<commit_message>
Final audit fixes: test windows, pool share ref, spare-slot wording, R13 pacing floor, labels
Co-Authored-By: Claude Opus 5.5 <noreply@anthropic.com>
Claude-Session: https://claude.ai/code/session_01V2NJtrYy3bzNxqKeiRXJfY
</commit_message>
<xml_diff>
--- a/operation_uptime/Operation_Uptime_Deck.pptx
+++ b/operation_uptime/Operation_Uptime_Deck.pptx
@@ -114,30 +114,30 @@
   <p:extLst>
     <p:ext uri="{521415D9-36F7-43E2-AB2F-B90AF26B5E84}">
       <p14:sectionLst xmlns:p14="http://schemas.microsoft.com/office/powerpoint/2010/main">
-        <p14:section name="Summary" id="{721e932a-412a-64ed-e806-259a84ca346e}">
+        <p14:section name="Summary" id="{c1fe148d-18b6-2f7d-bae4-0dce805ea791}">
           <p14:sldIdLst>
             <p14:sldId id="256"/>
           </p14:sldIdLst>
         </p14:section>
-        <p14:section name="Part 1 Funnel" id="{16fd1b44-ffb8-f6b3-3c98-7ffe0ecf6f9a}">
+        <p14:section name="Part 1 Funnel" id="{e92b1702-e93c-7d9f-8821-f7f96dca919c}">
           <p14:sldIdLst>
             <p14:sldId id="257"/>
             <p14:sldId id="258"/>
           </p14:sldIdLst>
         </p14:section>
-        <p14:section name="Part 2 Channels &amp; budget" id="{140cfb64-67fc-6076-8995-23a21a488071}">
+        <p14:section name="Part 2 Channels &amp; budget" id="{08e4786c-2b45-e9e1-850e-6d53c82bd042}">
           <p14:sldIdLst>
             <p14:sldId id="259"/>
             <p14:sldId id="260"/>
             <p14:sldId id="261"/>
           </p14:sldIdLst>
         </p14:section>
-        <p14:section name="Part 3 New sources" id="{0c29ad4d-a1b7-52ca-a0d6-08cfc4ba8f23}">
+        <p14:section name="Part 3 New sources" id="{fcd9d371-a1f4-59f0-3eef-8b662a338126}">
           <p14:sldIdLst>
             <p14:sldId id="262"/>
           </p14:sldIdLst>
         </p14:section>
-        <p14:section name="Part 4 Run it" id="{c0fb1c71-4454-d0e3-25b0-a9c616b3304f}">
+        <p14:section name="Part 4 Run it" id="{57ad5b5d-7d1c-a627-3a96-75002f169876}">
           <p14:sldIdLst>
             <p14:sldId id="263"/>
           </p14:sldIdLst>
@@ -2485,7 +2485,7 @@
           <a:p>
             <a:r>
               <a:rPr lang="en-US" dirty="0"/>
-              <a:t>Part 5 one-page summary. All figures are live from the model's Summary/Budget/Funnel tabs.</a:t>
+              <a:t>Part 5 one-page summary. All figures were generated from the model's Summary, Budget and Funnel tabs; re-run the deck build after changing the model.</a:t>
             </a:r>
             <a:endParaRPr lang="en-US" dirty="0"/>
           </a:p>
@@ -6282,7 +6282,7 @@
                   <a:schemeClr val="tx1"/>
                 </a:solidFill>
               </a:rPr>
-              <a:t>€750 test in every paid channel in weeks 1–2, then buy hires cheapest-first: free channels → ATS rediscovery (~€20/hire) → Polish corridor (≤40% of mechatronics) → construction-electrician campaign → LinkedIn, Search, referrals, 1 StepStone ad. Pace ≤55 qualified a week; paid spend stops 27 Nov.</a:t>
+              <a:t>€750 test in every paid CPC/CPA cell in weeks 1–2, then buy hires cheapest-first: free channels → ATS rediscovery (~€20/hire) → Polish corridor (≤40% of mechatronics) → construction-electrician campaign → LinkedIn, Search, referrals, 1 StepStone ad. Pace ≤55 qualified a week; paid spend stops 27 Nov.</a:t>
             </a:r>
             <a:endParaRPr lang="en-US" sz="1100" dirty="0"/>
           </a:p>
@@ -10125,7 +10125,7 @@
                   <a:schemeClr val="tx1"/>
                 </a:solidFill>
               </a:rPr>
-              <a:t>Assessment → interview 7 days, → offer 3, → signature 7; supervisors +7. Last realistic signature Fri 18 Dec, so applications must arrive by Fri 27 Nov (E/M/A) and Fri 20 Nov (supervisors). Slots = 55 × 41 days ÷ 7 = 322.</a:t>
+              <a:t>Application → assessment 4 days, → interview 7, → offer 3, → signature 7; supervisors +7. Last realistic signature Fri 18 Dec, so applications must arrive by Fri 27 Nov (E/M/A) and Fri 20 Nov (supervisors). Slots = 55 × 41 days ÷ 7 = 322.</a:t>
             </a:r>
             <a:endParaRPr lang="en-US" sz="1200" dirty="0"/>
           </a:p>
@@ -12223,7 +12223,7 @@
                   <a:schemeClr val="tx1"/>
                 </a:solidFill>
               </a:rPr>
-              <a:t>30% worse pass or acceptance rates need 415 qualified for 322 slots (129%), capping hires at ~78 and lifting media 43%. Upstream misses (share qualified, cost per application) only cost money.</a:t>
+              <a:t>30% worse pass or acceptance rates need 415 qualified for 322 slots (129%). The 43% more media that would need can't help: slots cap hires at ~78. Upstream misses (share qualified, cost per application) only cost money.</a:t>
             </a:r>
             <a:endParaRPr lang="en-US" sz="1200" dirty="0"/>
           </a:p>
@@ -17090,7 +17090,7 @@
                   <a:schemeClr val="accent4"/>
                 </a:solidFill>
               </a:rPr>
-              <a:t>Researched: StepStone €1,449/30-day ad (instaffo.com) · Pracuj.pl ~1,499 PLN/ad, indicative (dlafirm.pracuj.pl) · Indeed CPC $0.10–5+ (pin.com) · LinkedIn CPC $4–8 (peoplebox.ai) · Appcast apply rate 6.1% (2025 benchmark). Everything else: own estimates, labelled on the Assumptions tab.</a:t>
+              <a:t>Researched: StepStone €1,449/30-day ad (instaffo.com) · Pracuj.pl ~1,499 PLN/ad, indicative (dlafirm.pracuj.pl) · Indeed CPC $0.10–5+ (pin.com) · LinkedIn CPC $4–8 (peoplebox.ai) · Appcast apply rate 6.1% (2025 benchmark). Other sources (§6 BQFG, BA Engpassanalyse, WSI, plant headcount) and every own estimate are labelled on the Assumptions tab.</a:t>
             </a:r>
             <a:endParaRPr lang="en-US" sz="1000" dirty="0"/>
           </a:p>
@@ -22952,7 +22952,7 @@
                   <a:schemeClr val="tx1"/>
                 </a:solidFill>
               </a:rPr>
-              <a:t>electricians (23 of 30 at −30%), then supervisors (8 of 10). Mechatronics never falls short.</a:t>
+              <a:t>electricians (23 of 30 at −30%), then supervisors (8 of 10); automation slips to 14 of 15. Mechatronics never falls short.</a:t>
             </a:r>
             <a:endParaRPr lang="en-US" sz="1200" dirty="0"/>
           </a:p>
@@ -22983,7 +22983,7 @@
                   <a:schemeClr val="tx1"/>
                 </a:solidFill>
               </a:rPr>
-              <a:t>the last €14.25k buys ~9 hires at ~€1,550 each, mostly electricians, the role that keeps lines running. Keep it. If you must cut, cover supervisors through internal promotion and protect electricians. Above €47.5k, money buys almost nothing before 31 Dec: the 55/week limit binds.</a:t>
+              <a:t>the last €14.25k buys ~9 hires at ~€1,530 each, mostly electricians, the role that keeps lines running. Keep it. If you must cut, cover supervisors through internal promotion and protect electricians. Above €47.5k, extra money buys at most ~11 more hires (the 31 spare slots); then the 55/week limit binds.</a:t>
             </a:r>
             <a:endParaRPr lang="en-US" sz="1200" dirty="0"/>
           </a:p>
@@ -23397,7 +23397,7 @@
                   <a:schemeClr val="tx1"/>
                 </a:solidFill>
               </a:rPr>
-              <a:t>Wed 21 Oct – Tue 3 Nov (waves 1–2): €350. Pass: ≥19 qualified (≥⅓ electricians). Kill: &lt;10 → stop the waves</a:t>
+              <a:t>Wed 21 Oct – Tue 3 Nov (waves 1–3): €350. Pass: ≥19 qualified (≥⅓ electricians). Kill: &lt;10 → no further re-contacts; bonus stays live</a:t>
             </a:r>
             <a:endParaRPr lang="en-US" sz="1200" dirty="0"/>
           </a:p>
@@ -23428,7 +23428,7 @@
                   <a:schemeClr val="tx1"/>
                 </a:solidFill>
               </a:rPr>
-              <a:t>Me: wave 1 on day 2, set-up in 3 days. Client: ATS export + consent check, bonus approval, one staff message</a:t>
+              <a:t>Me: copy, segments and tracked links ready before 20 Oct; wave 1 on day 2 once the GDPR-checked export arrives. Client: ATS export + consent check, bonus approval, one staff message</a:t>
             </a:r>
             <a:endParaRPr lang="en-US" sz="1200" dirty="0"/>
           </a:p>
@@ -23692,7 +23692,7 @@
                   <a:schemeClr val="tx1"/>
                 </a:solidFill>
               </a:rPr>
-              <a:t>Fri 23 Oct – Fri 6 Nov (read Mon 9 Nov): €3.7k. Pass: ≥7 qualified at ≤€250. Kill: &lt;4, &gt;€300 per qualified, or profile rejected; week 4: &lt;40% interview pass</a:t>
+              <a:t>Fri 23 Oct – Fri 6 Nov (read Mon 9 Nov): €2.8k. Pass: ≥4 qualified at ≤€250. Kill: &lt;3, &gt;€300 per qualified, or profile rejected; week 4: &lt;40% interview pass</a:t>
             </a:r>
             <a:endParaRPr lang="en-US" sz="1200" dirty="0"/>
           </a:p>
@@ -23987,7 +23987,7 @@
                   <a:schemeClr val="tx1"/>
                 </a:solidFill>
               </a:rPr>
-              <a:t>Tue 27 Oct – Mon 9 Nov (freelancer starts 27 Oct): €1.2k. Pass: ≥5 qualified at ≤€110. Kill: &lt;3, &gt;€130 per qualified, or &lt;30% pass the language check</a:t>
+              <a:t>Tue 27 Oct – Mon 9 Nov (freelancer starts 27 Oct): €1.1k. Pass: ≥4 qualified at ≤€110. Kill: &lt;3, &gt;€130 per qualified, or &lt;30% pass the language check</a:t>
             </a:r>
             <a:endParaRPr lang="en-US" sz="1200" dirty="0"/>
           </a:p>

</xml_diff>

<commit_message>
Add model test suite (93 scenarios, oracle, edge cases, deck check) and fix bugs it found
Co-Authored-By: Claude Opus 5.5 <noreply@anthropic.com>
Claude-Session: https://claude.ai/code/session_01V2NJtrYy3bzNxqKeiRXJfY
</commit_message>
<xml_diff>
--- a/operation_uptime/Operation_Uptime_Deck.pptx
+++ b/operation_uptime/Operation_Uptime_Deck.pptx
@@ -114,30 +114,30 @@
   <p:extLst>
     <p:ext uri="{521415D9-36F7-43E2-AB2F-B90AF26B5E84}">
       <p14:sectionLst xmlns:p14="http://schemas.microsoft.com/office/powerpoint/2010/main">
-        <p14:section name="Summary" id="{c1fe148d-18b6-2f7d-bae4-0dce805ea791}">
+        <p14:section name="Summary" id="{bd00b158-f32d-5cff-3c29-40a10ed8ded9}">
           <p14:sldIdLst>
             <p14:sldId id="256"/>
           </p14:sldIdLst>
         </p14:section>
-        <p14:section name="Part 1 Funnel" id="{e92b1702-e93c-7d9f-8821-f7f96dca919c}">
+        <p14:section name="Part 1 Funnel" id="{2bab0a75-f0a9-6472-174e-2854a9482c97}">
           <p14:sldIdLst>
             <p14:sldId id="257"/>
             <p14:sldId id="258"/>
           </p14:sldIdLst>
         </p14:section>
-        <p14:section name="Part 2 Channels &amp; budget" id="{08e4786c-2b45-e9e1-850e-6d53c82bd042}">
+        <p14:section name="Part 2 Channels &amp; budget" id="{cfd8344b-ca2b-91c6-2b42-5eb2f5e79824}">
           <p14:sldIdLst>
             <p14:sldId id="259"/>
             <p14:sldId id="260"/>
             <p14:sldId id="261"/>
           </p14:sldIdLst>
         </p14:section>
-        <p14:section name="Part 3 New sources" id="{fcd9d371-a1f4-59f0-3eef-8b662a338126}">
+        <p14:section name="Part 3 New sources" id="{b2c6ce35-cab7-003a-3190-a85bb7911ea0}">
           <p14:sldIdLst>
             <p14:sldId id="262"/>
           </p14:sldIdLst>
         </p14:section>
-        <p14:section name="Part 4 Run it" id="{57ad5b5d-7d1c-a627-3a96-75002f169876}">
+        <p14:section name="Part 4 Run it" id="{92515731-63e2-e902-5cd0-1b77c60b9b14}">
           <p14:sldIdLst>
             <p14:sldId id="263"/>
           </p14:sldIdLst>
@@ -20897,7 +20897,7 @@
                             <a:schemeClr val="tx1"/>
                           </a:solidFill>
                         </a:rPr>
-                        <a:t>€0.3k</a:t>
+                        <a:t>€350</a:t>
                       </a:r>
                       <a:endParaRPr lang="en-US" sz="1000" dirty="0"/>
                     </a:p>
@@ -23692,7 +23692,7 @@
                   <a:schemeClr val="tx1"/>
                 </a:solidFill>
               </a:rPr>
-              <a:t>Fri 23 Oct – Fri 6 Nov (read Mon 9 Nov): €2.8k. Pass: ≥4 qualified at ≤€250. Kill: &lt;3, &gt;€300 per qualified, or profile rejected; week 4: &lt;40% interview pass</a:t>
+              <a:t>Fri 23 Oct – Thu 5 Nov (read Mon 9 Nov): €2.6k. Pass: ≥4 qualified at ≤€250. Kill: &lt;3, &gt;€300 per qualified, or profile rejected; week 4: &lt;40% interview pass</a:t>
             </a:r>
             <a:endParaRPr lang="en-US" sz="1200" dirty="0"/>
           </a:p>

</xml_diff>

<commit_message>
Cap budget scenarios by assessment capacity, flag invalid reserve, add 14 edge cases (107/107 pass), deck tweaks
Co-Authored-By: Claude Opus 5.5 <noreply@anthropic.com>
Claude-Session: https://claude.ai/code/session_01V2NJtrYy3bzNxqKeiRXJfY
</commit_message>
<xml_diff>
--- a/operation_uptime/Operation_Uptime_Deck.pptx
+++ b/operation_uptime/Operation_Uptime_Deck.pptx
@@ -114,30 +114,30 @@
   <p:extLst>
     <p:ext uri="{521415D9-36F7-43E2-AB2F-B90AF26B5E84}">
       <p14:sectionLst xmlns:p14="http://schemas.microsoft.com/office/powerpoint/2010/main">
-        <p14:section name="Summary" id="{bd00b158-f32d-5cff-3c29-40a10ed8ded9}">
+        <p14:section name="Summary" id="{8d100aba-e385-f549-818e-6e2d0299c9af}">
           <p14:sldIdLst>
             <p14:sldId id="256"/>
           </p14:sldIdLst>
         </p14:section>
-        <p14:section name="Part 1 Funnel" id="{2bab0a75-f0a9-6472-174e-2854a9482c97}">
+        <p14:section name="Part 1 Funnel" id="{87c93c7d-7386-c193-7162-9c14a107c7ab}">
           <p14:sldIdLst>
             <p14:sldId id="257"/>
             <p14:sldId id="258"/>
           </p14:sldIdLst>
         </p14:section>
-        <p14:section name="Part 2 Channels &amp; budget" id="{cfd8344b-ca2b-91c6-2b42-5eb2f5e79824}">
+        <p14:section name="Part 2 Channels &amp; budget" id="{44577dcc-176e-a789-dcd5-569f81d93bdd}">
           <p14:sldIdLst>
             <p14:sldId id="259"/>
             <p14:sldId id="260"/>
             <p14:sldId id="261"/>
           </p14:sldIdLst>
         </p14:section>
-        <p14:section name="Part 3 New sources" id="{b2c6ce35-cab7-003a-3190-a85bb7911ea0}">
+        <p14:section name="Part 3 New sources" id="{0c52266a-6c87-43fb-af32-2559c2b90b6e}">
           <p14:sldIdLst>
             <p14:sldId id="262"/>
           </p14:sldIdLst>
         </p14:section>
-        <p14:section name="Part 4 Run it" id="{92515731-63e2-e902-5cd0-1b77c60b9b14}">
+        <p14:section name="Part 4 Run it" id="{a4ee0300-3ae6-7b6d-70dc-10f406e70e63}">
           <p14:sldIdLst>
             <p14:sldId id="263"/>
           </p14:sldIdLst>
@@ -239,9 +239,9 @@
           </c:dLbls>
           <c:cat>
             <c:multiLvlStrRef>
-              <c:f>Sheet1!$A$2:$A$7</c:f>
+              <c:f>Sheet1!$A$2:$A$8</c:f>
               <c:multiLvlStrCache>
-                <c:ptCount val="6"/>
+                <c:ptCount val="7"/>
                 <c:lvl>
                   <c:pt idx="0">
                     <c:v>Wk 1</c:v>
@@ -261,16 +261,19 @@
                   <c:pt idx="5">
                     <c:v>Wk 6</c:v>
                   </c:pt>
+                  <c:pt idx="6">
+                    <c:v>Wk 7</c:v>
+                  </c:pt>
                 </c:lvl>
               </c:multiLvlStrCache>
             </c:multiLvlStrRef>
           </c:cat>
           <c:val>
             <c:numRef>
-              <c:f>Sheet1!$B$2:$B$7</c:f>
+              <c:f>Sheet1!$B$2:$B$8</c:f>
               <c:numCache>
                 <c:formatCode>General</c:formatCode>
-                <c:ptCount val="6"/>
+                <c:ptCount val="7"/>
                 <c:pt idx="0">
                   <c:v>39</c:v>
                 </c:pt>
@@ -288,6 +291,9 @@
                 </c:pt>
                 <c:pt idx="5">
                   <c:v>43</c:v>
+                </c:pt>
+                <c:pt idx="6">
+                  <c:v>0</c:v>
                 </c:pt>
               </c:numCache>
             </c:numRef>
@@ -340,9 +346,9 @@
           </c:dLbls>
           <c:cat>
             <c:multiLvlStrRef>
-              <c:f>Sheet1!$A$2:$A$7</c:f>
+              <c:f>Sheet1!$A$2:$A$8</c:f>
               <c:multiLvlStrCache>
-                <c:ptCount val="6"/>
+                <c:ptCount val="7"/>
                 <c:lvl>
                   <c:pt idx="0">
                     <c:v>Wk 1</c:v>
@@ -362,16 +368,19 @@
                   <c:pt idx="5">
                     <c:v>Wk 6</c:v>
                   </c:pt>
+                  <c:pt idx="6">
+                    <c:v>Wk 7</c:v>
+                  </c:pt>
                 </c:lvl>
               </c:multiLvlStrCache>
             </c:multiLvlStrRef>
           </c:cat>
           <c:val>
             <c:numRef>
-              <c:f>Sheet1!$C$2:$C$7</c:f>
+              <c:f>Sheet1!$C$2:$C$8</c:f>
               <c:numCache>
                 <c:formatCode>General</c:formatCode>
-                <c:ptCount val="6"/>
+                <c:ptCount val="7"/>
                 <c:pt idx="0">
                   <c:v>39</c:v>
                 </c:pt>
@@ -389,6 +398,9 @@
                 </c:pt>
                 <c:pt idx="5">
                   <c:v>55</c:v>
+                </c:pt>
+                <c:pt idx="6">
+                  <c:v>8</c:v>
                 </c:pt>
               </c:numCache>
             </c:numRef>
@@ -10177,7 +10189,7 @@
                   <a:schemeClr val="tx2"/>
                 </a:solidFill>
               </a:rPr>
-              <a:t>Week 1: 39 of 39 slots; weeks 2–5: 51–55 of 55; week 6: 43. Rediscovery re-applicants (waves 21 and 26 Oct) and the €750 tests fill weeks 1–2, so regular spend starts at 3% and 5%, then 20–24% a week.</a:t>
+              <a:t>Week 1: 39 of 39 slots; weeks 2–5: 51–55 of 55; week 6: 43; week 7 is Tue 1 Dec only (last assessment day, 8 slots). Rediscovery re-applicants (waves 21 Oct, 26 Oct and 2 Nov) and the €750 tests fill weeks 1–2, so regular spend starts at 3% and 5%, then 20–24% a week.</a:t>
             </a:r>
             <a:endParaRPr lang="en-US" sz="1100" dirty="0"/>
           </a:p>
@@ -24584,7 +24596,7 @@
                   <a:schemeClr val="tx1"/>
                 </a:solidFill>
               </a:rPr>
-              <a:t>1) Pass rate on the week-1 cohort (interviews 29 Oct–2 Nov), the most sensitive input: if &lt;45% → tighter knock-outs, pre-screen calls, ask +10 slots, re-run the model. 2) Electrician supply: profile decision + I2's two-week read on 9 Nov; if killed → Meta, StepStone (up to 2 more ads), programmatic; expect ~25–27 electricians. 3) The 12 tests' cost per application and share qualified → re-rank on Assumptions §7. Week 4 (16 Nov): acceptance &lt;55% → earlier cut-off + signing bonus.</a:t>
+              <a:t>1) Pass rate on the week-1 cohort (interviews 29 Oct–2 Nov), the most sensitive input: if &lt;45% → tighter knock-outs, pre-screen calls, ask +10 slots, re-run the model. 2) Electrician supply: profile decision + I2's two-week read on 9 Nov; if killed → Meta, StepStone (up to 2 more ads), programmatic; expect ~25–27 electricians (my judgement: capacity allows 30, but slower and at €1,000–1,500 per hire). 3) The 12 tests' cost per application and share qualified → re-rank on Assumptions §7. Week 4 (16 Nov): acceptance &lt;55% → earlier cut-off + signing bonus.</a:t>
             </a:r>
             <a:endParaRPr lang="en-US" sz="1250" dirty="0"/>
           </a:p>

</xml_diff>

<commit_message>
Skip tests for roles with no openings, explicit week-6 flag, guard edge divisions; 120/120 tests pass
Co-Authored-By: Claude Opus 5.5 <noreply@anthropic.com>
Claude-Session: https://claude.ai/code/session_01V2NJtrYy3bzNxqKeiRXJfY
</commit_message>
<xml_diff>
--- a/operation_uptime/Operation_Uptime_Deck.pptx
+++ b/operation_uptime/Operation_Uptime_Deck.pptx
@@ -114,30 +114,30 @@
   <p:extLst>
     <p:ext uri="{521415D9-36F7-43E2-AB2F-B90AF26B5E84}">
       <p14:sectionLst xmlns:p14="http://schemas.microsoft.com/office/powerpoint/2010/main">
-        <p14:section name="Summary" id="{8d100aba-e385-f549-818e-6e2d0299c9af}">
+        <p14:section name="Summary" id="{7945eef3-b949-c68e-8198-e1b04d6400ae}">
           <p14:sldIdLst>
             <p14:sldId id="256"/>
           </p14:sldIdLst>
         </p14:section>
-        <p14:section name="Part 1 Funnel" id="{87c93c7d-7386-c193-7162-9c14a107c7ab}">
+        <p14:section name="Part 1 Funnel" id="{f4f7ecf5-d61e-ef9f-6fda-904ed589cde3}">
           <p14:sldIdLst>
             <p14:sldId id="257"/>
             <p14:sldId id="258"/>
           </p14:sldIdLst>
         </p14:section>
-        <p14:section name="Part 2 Channels &amp; budget" id="{44577dcc-176e-a789-dcd5-569f81d93bdd}">
+        <p14:section name="Part 2 Channels &amp; budget" id="{7743f578-a711-e64b-0a97-5fbace36e591}">
           <p14:sldIdLst>
             <p14:sldId id="259"/>
             <p14:sldId id="260"/>
             <p14:sldId id="261"/>
           </p14:sldIdLst>
         </p14:section>
-        <p14:section name="Part 3 New sources" id="{0c52266a-6c87-43fb-af32-2559c2b90b6e}">
+        <p14:section name="Part 3 New sources" id="{a314cee0-95e9-8b70-892f-6bfc26610c85}">
           <p14:sldIdLst>
             <p14:sldId id="262"/>
           </p14:sldIdLst>
         </p14:section>
-        <p14:section name="Part 4 Run it" id="{a4ee0300-3ae6-7b6d-70dc-10f406e70e63}">
+        <p14:section name="Part 4 Run it" id="{1bf77cf0-48c7-6e52-58eb-b2c669fd35b4}">
           <p14:sldIdLst>
             <p14:sldId id="263"/>
           </p14:sldIdLst>

</xml_diff>

<commit_message>
Robustness: input validation (data validation + formula check), test hires capped at openings, cost clamp, live summary labels; 141/141 tests pass
Co-Authored-By: Claude Opus 5.5 <noreply@anthropic.com>
Claude-Session: https://claude.ai/code/session_01V2NJtrYy3bzNxqKeiRXJfY
</commit_message>
<xml_diff>
--- a/operation_uptime/Operation_Uptime_Deck.pptx
+++ b/operation_uptime/Operation_Uptime_Deck.pptx
@@ -114,30 +114,30 @@
   <p:extLst>
     <p:ext uri="{521415D9-36F7-43E2-AB2F-B90AF26B5E84}">
       <p14:sectionLst xmlns:p14="http://schemas.microsoft.com/office/powerpoint/2010/main">
-        <p14:section name="Summary" id="{7945eef3-b949-c68e-8198-e1b04d6400ae}">
+        <p14:section name="Summary" id="{edff4e24-d042-2c14-e6ed-45bf5de85241}">
           <p14:sldIdLst>
             <p14:sldId id="256"/>
           </p14:sldIdLst>
         </p14:section>
-        <p14:section name="Part 1 Funnel" id="{f4f7ecf5-d61e-ef9f-6fda-904ed589cde3}">
+        <p14:section name="Part 1 Funnel" id="{6e51d43d-a8d6-b352-6a08-0526c4eba922}">
           <p14:sldIdLst>
             <p14:sldId id="257"/>
             <p14:sldId id="258"/>
           </p14:sldIdLst>
         </p14:section>
-        <p14:section name="Part 2 Channels &amp; budget" id="{7743f578-a711-e64b-0a97-5fbace36e591}">
+        <p14:section name="Part 2 Channels &amp; budget" id="{3326d6cd-e9a4-d31b-23f2-96794002a429}">
           <p14:sldIdLst>
             <p14:sldId id="259"/>
             <p14:sldId id="260"/>
             <p14:sldId id="261"/>
           </p14:sldIdLst>
         </p14:section>
-        <p14:section name="Part 3 New sources" id="{a314cee0-95e9-8b70-892f-6bfc26610c85}">
+        <p14:section name="Part 3 New sources" id="{094779ac-35d8-8611-4551-8ebd1544b707}">
           <p14:sldIdLst>
             <p14:sldId id="262"/>
           </p14:sldIdLst>
         </p14:section>
-        <p14:section name="Part 4 Run it" id="{1bf77cf0-48c7-6e52-58eb-b2c669fd35b4}">
+        <p14:section name="Part 4 Run it" id="{8b66d83d-d770-5d8f-d15e-02ff52301a85}">
           <p14:sldIdLst>
             <p14:sldId id="263"/>
           </p14:sldIdLst>

</xml_diff>

<commit_message>
Input check covers every numeric input; flags for spend after cut-off and late assessment start; tracker label fix; 148/148 tests pass
Co-Authored-By: Claude Opus 5.5 <noreply@anthropic.com>
Claude-Session: https://claude.ai/code/session_01V2NJtrYy3bzNxqKeiRXJfY
</commit_message>
<xml_diff>
--- a/operation_uptime/Operation_Uptime_Deck.pptx
+++ b/operation_uptime/Operation_Uptime_Deck.pptx
@@ -114,30 +114,30 @@
   <p:extLst>
     <p:ext uri="{521415D9-36F7-43E2-AB2F-B90AF26B5E84}">
       <p14:sectionLst xmlns:p14="http://schemas.microsoft.com/office/powerpoint/2010/main">
-        <p14:section name="Summary" id="{edff4e24-d042-2c14-e6ed-45bf5de85241}">
+        <p14:section name="Summary" id="{4d4e0ca9-6e03-eb3a-09fb-397efe5e6133}">
           <p14:sldIdLst>
             <p14:sldId id="256"/>
           </p14:sldIdLst>
         </p14:section>
-        <p14:section name="Part 1 Funnel" id="{6e51d43d-a8d6-b352-6a08-0526c4eba922}">
+        <p14:section name="Part 1 Funnel" id="{118194ef-3e25-4e11-3b4c-348f5948c35c}">
           <p14:sldIdLst>
             <p14:sldId id="257"/>
             <p14:sldId id="258"/>
           </p14:sldIdLst>
         </p14:section>
-        <p14:section name="Part 2 Channels &amp; budget" id="{3326d6cd-e9a4-d31b-23f2-96794002a429}">
+        <p14:section name="Part 2 Channels &amp; budget" id="{80225c14-75c9-c49d-65c8-cd9081514d2d}">
           <p14:sldIdLst>
             <p14:sldId id="259"/>
             <p14:sldId id="260"/>
             <p14:sldId id="261"/>
           </p14:sldIdLst>
         </p14:section>
-        <p14:section name="Part 3 New sources" id="{094779ac-35d8-8611-4551-8ebd1544b707}">
+        <p14:section name="Part 3 New sources" id="{a64351ae-a56a-d12b-8f43-29c15d5bf572}">
           <p14:sldIdLst>
             <p14:sldId id="262"/>
           </p14:sldIdLst>
         </p14:section>
-        <p14:section name="Part 4 Run it" id="{8b66d83d-d770-5d8f-d15e-02ff52301a85}">
+        <p14:section name="Part 4 Run it" id="{62f40b79-b081-756b-6155-396156db0b36}">
           <p14:sldIdLst>
             <p14:sldId id="263"/>
           </p14:sldIdLst>

</xml_diff>

<commit_message>
Initiative pass/kill bars can't overlap; threshold input check; schedule check on Summary; 150/150 tests pass
Co-Authored-By: Claude Opus 5.5 <noreply@anthropic.com>
Claude-Session: https://claude.ai/code/session_01V2NJtrYy3bzNxqKeiRXJfY
</commit_message>
<xml_diff>
--- a/operation_uptime/Operation_Uptime_Deck.pptx
+++ b/operation_uptime/Operation_Uptime_Deck.pptx
@@ -114,30 +114,30 @@
   <p:extLst>
     <p:ext uri="{521415D9-36F7-43E2-AB2F-B90AF26B5E84}">
       <p14:sectionLst xmlns:p14="http://schemas.microsoft.com/office/powerpoint/2010/main">
-        <p14:section name="Summary" id="{4d4e0ca9-6e03-eb3a-09fb-397efe5e6133}">
+        <p14:section name="Summary" id="{831b61c7-dba6-d64e-c74b-6a1bb76c74a4}">
           <p14:sldIdLst>
             <p14:sldId id="256"/>
           </p14:sldIdLst>
         </p14:section>
-        <p14:section name="Part 1 Funnel" id="{118194ef-3e25-4e11-3b4c-348f5948c35c}">
+        <p14:section name="Part 1 Funnel" id="{ec10d330-e7d7-effc-9e6f-32d7e574c06d}">
           <p14:sldIdLst>
             <p14:sldId id="257"/>
             <p14:sldId id="258"/>
           </p14:sldIdLst>
         </p14:section>
-        <p14:section name="Part 2 Channels &amp; budget" id="{80225c14-75c9-c49d-65c8-cd9081514d2d}">
+        <p14:section name="Part 2 Channels &amp; budget" id="{20f2e94a-e6ab-11c5-b796-36005b2b9247}">
           <p14:sldIdLst>
             <p14:sldId id="259"/>
             <p14:sldId id="260"/>
             <p14:sldId id="261"/>
           </p14:sldIdLst>
         </p14:section>
-        <p14:section name="Part 3 New sources" id="{a64351ae-a56a-d12b-8f43-29c15d5bf572}">
+        <p14:section name="Part 3 New sources" id="{c034f7d4-e8e8-9271-28e1-ba9d2f199904}">
           <p14:sldIdLst>
             <p14:sldId id="262"/>
           </p14:sldIdLst>
         </p14:section>
-        <p14:section name="Part 4 Run it" id="{62f40b79-b081-756b-6155-396156db0b36}">
+        <p14:section name="Part 4 Run it" id="{8507f958-5496-c550-8c85-2680cbc26c75}">
           <p14:sldIdLst>
             <p14:sldId id="263"/>
           </p14:sldIdLst>

</xml_diff>

<commit_message>
Source model estimates: researched CPA, funnel rates, pools and lags
Replace own estimates with cited benchmarks where data exists (TalentBait
DACH cost per application, IAB share suitable, Gem pass rates, Koenigsteiner/
StepStone acceptance, BA KldB pools, SmartRecruiters lags). Retune weekly
pacing to stay under the 55/week limit, make verdict text live, refresh deck
narrative from the model, and add SOURCES.md.

Co-Authored-By: Claude Opus 5.5 <noreply@anthropic.com>
Claude-Session: https://claude.ai/code/session_01V2NJtrYy3bzNxqKeiRXJfY
</commit_message>
<xml_diff>
--- a/operation_uptime/Operation_Uptime_Deck.pptx
+++ b/operation_uptime/Operation_Uptime_Deck.pptx
@@ -114,30 +114,30 @@
   <p:extLst>
     <p:ext uri="{521415D9-36F7-43E2-AB2F-B90AF26B5E84}">
       <p14:sectionLst xmlns:p14="http://schemas.microsoft.com/office/powerpoint/2010/main">
-        <p14:section name="Summary" id="{831b61c7-dba6-d64e-c74b-6a1bb76c74a4}">
+        <p14:section name="Summary" id="{f8a88073-1330-45f4-e01b-74e6f738fc02}">
           <p14:sldIdLst>
             <p14:sldId id="256"/>
           </p14:sldIdLst>
         </p14:section>
-        <p14:section name="Part 1 Funnel" id="{ec10d330-e7d7-effc-9e6f-32d7e574c06d}">
+        <p14:section name="Part 1 Funnel" id="{08f63a34-2e00-4d71-998a-54ca1fa06ea6}">
           <p14:sldIdLst>
             <p14:sldId id="257"/>
             <p14:sldId id="258"/>
           </p14:sldIdLst>
         </p14:section>
-        <p14:section name="Part 2 Channels &amp; budget" id="{20f2e94a-e6ab-11c5-b796-36005b2b9247}">
+        <p14:section name="Part 2 Channels &amp; budget" id="{4ac4808e-65dd-04a2-3d11-db03ca21dcf1}">
           <p14:sldIdLst>
             <p14:sldId id="259"/>
             <p14:sldId id="260"/>
             <p14:sldId id="261"/>
           </p14:sldIdLst>
         </p14:section>
-        <p14:section name="Part 3 New sources" id="{c034f7d4-e8e8-9271-28e1-ba9d2f199904}">
+        <p14:section name="Part 3 New sources" id="{7588a314-d594-f44b-138b-d79c8ec2f33c}">
           <p14:sldIdLst>
             <p14:sldId id="262"/>
           </p14:sldIdLst>
         </p14:section>
-        <p14:section name="Part 4 Run it" id="{8507f958-5496-c550-8c85-2680cbc26c75}">
+        <p14:section name="Part 4 Run it" id="{0199cb29-7037-d626-ce5e-195b1b3658bf}">
           <p14:sldIdLst>
             <p14:sldId id="263"/>
           </p14:sldIdLst>
@@ -275,22 +275,22 @@
                 <c:formatCode>General</c:formatCode>
                 <c:ptCount val="7"/>
                 <c:pt idx="0">
-                  <c:v>39</c:v>
+                  <c:v>37</c:v>
                 </c:pt>
                 <c:pt idx="1">
-                  <c:v>55</c:v>
+                  <c:v>52</c:v>
                 </c:pt>
                 <c:pt idx="2">
                   <c:v>53</c:v>
                 </c:pt>
                 <c:pt idx="3">
-                  <c:v>51</c:v>
+                  <c:v>54</c:v>
                 </c:pt>
                 <c:pt idx="4">
-                  <c:v>51</c:v>
+                  <c:v>54</c:v>
                 </c:pt>
                 <c:pt idx="5">
-                  <c:v>43</c:v>
+                  <c:v>55</c:v>
                 </c:pt>
                 <c:pt idx="6">
                   <c:v>0</c:v>
@@ -400,7 +400,7 @@
                   <c:v>55</c:v>
                 </c:pt>
                 <c:pt idx="6">
-                  <c:v>8</c:v>
+                  <c:v>0</c:v>
                 </c:pt>
               </c:numCache>
             </c:numRef>
@@ -693,10 +693,10 @@
                   <c:v>100</c:v>
                 </c:pt>
                 <c:pt idx="1">
-                  <c:v>78</c:v>
+                  <c:v>72</c:v>
                 </c:pt>
                 <c:pt idx="2">
-                  <c:v>78</c:v>
+                  <c:v>72</c:v>
                 </c:pt>
                 <c:pt idx="3">
                   <c:v>100</c:v>
@@ -705,7 +705,7 @@
                   <c:v>100</c:v>
                 </c:pt>
                 <c:pt idx="5">
-                  <c:v>78</c:v>
+                  <c:v>72</c:v>
                 </c:pt>
               </c:numCache>
             </c:numRef>
@@ -1107,22 +1107,22 @@
                 <c:formatCode>General</c:formatCode>
                 <c:ptCount val="9"/>
                 <c:pt idx="0">
-                  <c:v>810</c:v>
+                  <c:v>4323</c:v>
                 </c:pt>
                 <c:pt idx="1">
-                  <c:v>1287</c:v>
+                  <c:v>6762</c:v>
                 </c:pt>
                 <c:pt idx="2">
-                  <c:v>4674</c:v>
+                  <c:v>9766</c:v>
                 </c:pt>
                 <c:pt idx="3">
-                  <c:v>5504</c:v>
+                  <c:v>12446</c:v>
                 </c:pt>
                 <c:pt idx="4">
-                  <c:v>5504</c:v>
+                  <c:v>12446</c:v>
                 </c:pt>
                 <c:pt idx="5">
-                  <c:v>4298</c:v>
+                  <c:v>12374</c:v>
                 </c:pt>
                 <c:pt idx="6">
                   <c:v>0</c:v>
@@ -1226,7 +1226,7 @@
                 <c:formatCode>General</c:formatCode>
                 <c:ptCount val="9"/>
                 <c:pt idx="0">
-                  <c:v>3049</c:v>
+                  <c:v>11743</c:v>
                 </c:pt>
                 <c:pt idx="1">
                   <c:v>0</c:v>
@@ -1354,22 +1354,22 @@
                   <c:v>0</c:v>
                 </c:pt>
                 <c:pt idx="3">
-                  <c:v>125</c:v>
+                  <c:v>388</c:v>
                 </c:pt>
                 <c:pt idx="4">
-                  <c:v>226</c:v>
+                  <c:v>702</c:v>
                 </c:pt>
                 <c:pt idx="5">
-                  <c:v>862</c:v>
+                  <c:v>1031</c:v>
                 </c:pt>
                 <c:pt idx="6">
-                  <c:v>1116</c:v>
+                  <c:v>1346</c:v>
                 </c:pt>
                 <c:pt idx="7">
-                  <c:v>1140</c:v>
+                  <c:v>1406</c:v>
                 </c:pt>
                 <c:pt idx="8">
-                  <c:v>1140</c:v>
+                  <c:v>1655</c:v>
                 </c:pt>
               </c:numCache>
             </c:numRef>
@@ -1631,16 +1631,16 @@
                 <c:ptCount val="4"/>
                 <c:lvl>
                   <c:pt idx="0">
-                    <c:v>100% · €47.50k</c:v>
+                    <c:v>100% · €102.50k</c:v>
                   </c:pt>
                   <c:pt idx="1">
-                    <c:v>85% · €40.38k</c:v>
+                    <c:v>85% · €87.13k</c:v>
                   </c:pt>
                   <c:pt idx="2">
-                    <c:v>70% · €33.25k</c:v>
+                    <c:v>70% · €71.75k</c:v>
                   </c:pt>
                   <c:pt idx="3">
-                    <c:v>50% · €23.75k</c:v>
+                    <c:v>50% · €51.25k</c:v>
                   </c:pt>
                 </c:lvl>
               </c:multiLvlStrCache>
@@ -1659,10 +1659,10 @@
                   <c:v>27.9</c:v>
                 </c:pt>
                 <c:pt idx="2">
-                  <c:v>23.1</c:v>
+                  <c:v>23.4</c:v>
                 </c:pt>
                 <c:pt idx="3">
-                  <c:v>12.7</c:v>
+                  <c:v>16.5</c:v>
                 </c:pt>
               </c:numCache>
             </c:numRef>
@@ -1721,16 +1721,16 @@
                 <c:ptCount val="4"/>
                 <c:lvl>
                   <c:pt idx="0">
-                    <c:v>100% · €47.50k</c:v>
+                    <c:v>100% · €102.50k</c:v>
                   </c:pt>
                   <c:pt idx="1">
-                    <c:v>85% · €40.38k</c:v>
+                    <c:v>85% · €87.13k</c:v>
                   </c:pt>
                   <c:pt idx="2">
-                    <c:v>70% · €33.25k</c:v>
+                    <c:v>70% · €71.75k</c:v>
                   </c:pt>
                   <c:pt idx="3">
-                    <c:v>50% · €23.75k</c:v>
+                    <c:v>50% · €51.25k</c:v>
                   </c:pt>
                 </c:lvl>
               </c:multiLvlStrCache>
@@ -1811,16 +1811,16 @@
                 <c:ptCount val="4"/>
                 <c:lvl>
                   <c:pt idx="0">
-                    <c:v>100% · €47.50k</c:v>
+                    <c:v>100% · €102.50k</c:v>
                   </c:pt>
                   <c:pt idx="1">
-                    <c:v>85% · €40.38k</c:v>
+                    <c:v>85% · €87.13k</c:v>
                   </c:pt>
                   <c:pt idx="2">
-                    <c:v>70% · €33.25k</c:v>
+                    <c:v>70% · €71.75k</c:v>
                   </c:pt>
                   <c:pt idx="3">
-                    <c:v>50% · €23.75k</c:v>
+                    <c:v>50% · €51.25k</c:v>
                   </c:pt>
                 </c:lvl>
               </c:multiLvlStrCache>
@@ -1836,13 +1836,13 @@
                   <c:v>15</c:v>
                 </c:pt>
                 <c:pt idx="1">
-                  <c:v>14.4</c:v>
+                  <c:v>14.7</c:v>
                 </c:pt>
                 <c:pt idx="2">
-                  <c:v>14.4</c:v>
+                  <c:v>14.7</c:v>
                 </c:pt>
                 <c:pt idx="3">
-                  <c:v>14.4</c:v>
+                  <c:v>14.7</c:v>
                 </c:pt>
               </c:numCache>
             </c:numRef>
@@ -1901,16 +1901,16 @@
                 <c:ptCount val="4"/>
                 <c:lvl>
                   <c:pt idx="0">
-                    <c:v>100% · €47.50k</c:v>
+                    <c:v>100% · €102.50k</c:v>
                   </c:pt>
                   <c:pt idx="1">
-                    <c:v>85% · €40.38k</c:v>
+                    <c:v>85% · €87.13k</c:v>
                   </c:pt>
                   <c:pt idx="2">
-                    <c:v>70% · €33.25k</c:v>
+                    <c:v>70% · €71.75k</c:v>
                   </c:pt>
                   <c:pt idx="3">
-                    <c:v>50% · €23.75k</c:v>
+                    <c:v>50% · €51.25k</c:v>
                   </c:pt>
                 </c:lvl>
               </c:multiLvlStrCache>
@@ -1926,13 +1926,13 @@
                   <c:v>10</c:v>
                 </c:pt>
                 <c:pt idx="1">
-                  <c:v>9.5</c:v>
+                  <c:v>9.8</c:v>
                 </c:pt>
                 <c:pt idx="2">
-                  <c:v>8.1</c:v>
+                  <c:v>9.8</c:v>
                 </c:pt>
                 <c:pt idx="3">
-                  <c:v>8.1</c:v>
+                  <c:v>9.4</c:v>
                 </c:pt>
               </c:numCache>
             </c:numRef>
@@ -3760,7 +3760,7 @@
                 <a:ea typeface="Cambria" pitchFamily="34" charset="-122"/>
                 <a:cs typeface="Cambria" pitchFamily="34" charset="-120"/>
               </a:rPr>
-              <a:t>€47.5k signs 100 maintenance hires by 31 Dec if the 55 weekly assessments hold</a:t>
+              <a:t>€102.5k signs 100 maintenance hires by 31 Dec if the 55 weekly assessments hold</a:t>
             </a:r>
             <a:endParaRPr lang="en-US" sz="2200" dirty="0"/>
           </a:p>
@@ -3826,7 +3826,7 @@
                 <a:ea typeface="Cambria" pitchFamily="34" charset="-122"/>
                 <a:cs typeface="Cambria" pitchFamily="34" charset="-120"/>
               </a:rPr>
-              <a:t>€47.5k</a:t>
+              <a:t>€102.5k</a:t>
             </a:r>
             <a:endParaRPr lang="en-US" sz="2600" dirty="0"/>
           </a:p>
@@ -3862,7 +3862,7 @@
                   <a:schemeClr val="tx2"/>
                 </a:solidFill>
               </a:rPr>
-              <a:t>recommended budget: €38.7k planned + €8.8k reserve released only on results</a:t>
+              <a:t>recommended budget: €85.4k planned + €17.1k reserve released only on results</a:t>
             </a:r>
             <a:endParaRPr lang="en-US" sz="1000" dirty="0"/>
           </a:p>
@@ -3928,7 +3928,7 @@
                 <a:ea typeface="Cambria" pitchFamily="34" charset="-122"/>
                 <a:cs typeface="Cambria" pitchFamily="34" charset="-120"/>
               </a:rPr>
-              <a:t>€387</a:t>
+              <a:t>€854</a:t>
             </a:r>
             <a:endParaRPr lang="en-US" sz="2600" dirty="0"/>
           </a:p>
@@ -3964,7 +3964,7 @@
                   <a:schemeClr val="tx2"/>
                 </a:solidFill>
               </a:rPr>
-              <a:t>media cost per hire (≤€475 if the reserve is spent); excludes Joveo fees</a:t>
+              <a:t>media cost per hire (≤€1,025 if the reserve is spent); excludes Joveo fees</a:t>
             </a:r>
             <a:endParaRPr lang="en-US" sz="1000" dirty="0"/>
           </a:p>
@@ -4030,7 +4030,7 @@
                 <a:ea typeface="Cambria" pitchFamily="34" charset="-122"/>
                 <a:cs typeface="Cambria" pitchFamily="34" charset="-120"/>
               </a:rPr>
-              <a:t>90%</a:t>
+              <a:t>97%</a:t>
             </a:r>
             <a:endParaRPr lang="en-US" sz="2600" dirty="0"/>
           </a:p>
@@ -4066,7 +4066,7 @@
                   <a:schemeClr val="tx2"/>
                 </a:solidFill>
               </a:rPr>
-              <a:t>of 322 assessment slots used (291 qualified). Capacity, not money, is the limit</a:t>
+              <a:t>of 314 assessment slots used (305 qualified). Capacity, not money, is the limit</a:t>
             </a:r>
             <a:endParaRPr lang="en-US" sz="1000" dirty="0"/>
           </a:p>
@@ -4132,7 +4132,7 @@
                 <a:ea typeface="Cambria" pitchFamily="34" charset="-122"/>
                 <a:cs typeface="Cambria" pitchFamily="34" charset="-120"/>
               </a:rPr>
-              <a:t>27 Nov</a:t>
+              <a:t>24 Nov</a:t>
             </a:r>
             <a:endParaRPr lang="en-US" sz="2600" dirty="0"/>
           </a:p>
@@ -4168,7 +4168,7 @@
                   <a:schemeClr val="tx2"/>
                 </a:solidFill>
               </a:rPr>
-              <a:t>last useful application (20 Nov for supervisors): signatures by Fri 18 Dec</a:t>
+              <a:t>last useful application (17 Nov for supervisors): signatures by Fri 18 Dec</a:t>
             </a:r>
             <a:endParaRPr lang="en-US" sz="1000" dirty="0"/>
           </a:p>
@@ -4215,7 +4215,7 @@
                   <a:schemeClr val="tx1"/>
                 </a:solidFill>
               </a:rPr>
-              <a:t>~60% we sign all 100, ~85% at least 90 (my judgement). If pass or acceptance rates are 30% worse, ~78. </a:t>
+              <a:t>~50% we sign all 100, ~80% at least 90 (my judgement; slots are 97% used). If pass or acceptance rates are 30% worse, ~72. </a:t>
             </a:r>
             <a:pPr indent="0" marL="0">
               <a:buNone/>
@@ -4237,7 +4237,7 @@
                   <a:schemeClr val="tx1"/>
                 </a:solidFill>
               </a:rPr>
-              <a:t>(€33.25k): ~91 hires; electricians fall short first (23 of 30).</a:t>
+              <a:t>(€71.75k): ~93 hires; electricians fall short first (23 of 30).</a:t>
             </a:r>
             <a:endParaRPr lang="en-US" sz="1100" dirty="0"/>
           </a:p>
@@ -4266,10 +4266,10 @@
             <a:tbl>
               <a:tblPr/>
               <a:tblGrid>
-                <a:gridCol w="1024128"/>
-                <a:gridCol w="457200"/>
-                <a:gridCol w="566928"/>
-                <a:gridCol w="530352"/>
+                <a:gridCol w="914400"/>
+                <a:gridCol w="475488"/>
+                <a:gridCol w="548640"/>
+                <a:gridCol w="640080"/>
                 <a:gridCol w="1536192"/>
               </a:tblGrid>
               <a:tr h="411480">
@@ -4762,7 +4762,7 @@
                           <a:ea typeface="Calibri" pitchFamily="34" charset="-122"/>
                           <a:cs typeface="Calibri" pitchFamily="34" charset="-120"/>
                         </a:rPr>
-                        <a:t>€19.9k</a:t>
+                        <a:t>€46.5k</a:t>
                       </a:r>
                       <a:endParaRPr lang="en-US" sz="1000" dirty="0">
                         <a:latin typeface="Calibri" charset="0"/>
@@ -4827,7 +4827,7 @@
                           <a:ea typeface="Calibri" pitchFamily="34" charset="-122"/>
                           <a:cs typeface="Calibri" pitchFamily="34" charset="-120"/>
                         </a:rPr>
-                        <a:t>€664</a:t>
+                        <a:t>€1,550</a:t>
                       </a:r>
                       <a:endParaRPr lang="en-US" sz="1000" dirty="0">
                         <a:latin typeface="Calibri" charset="0"/>
@@ -4892,7 +4892,7 @@
                           <a:ea typeface="Calibri" pitchFamily="34" charset="-122"/>
                           <a:cs typeface="Calibri" pitchFamily="34" charset="-120"/>
                         </a:rPr>
-                        <a:t>Handwerk→Industrie 11.6 · rediscovery 4.4 · referrals 4.2 · organic 3.9 · Google Search 3.9 · other 2.1</a:t>
+                        <a:t>Handwerk→Industrie 9.5 · rediscovery 4.3 · StepStone 4.3 · referrals 4.1 · organic 3.8 · other 4.1</a:t>
                       </a:r>
                       <a:endParaRPr lang="en-US" sz="900" dirty="0">
                         <a:latin typeface="Calibri" charset="0"/>
@@ -5089,7 +5089,7 @@
                           <a:ea typeface="Calibri" pitchFamily="34" charset="-122"/>
                           <a:cs typeface="Calibri" pitchFamily="34" charset="-120"/>
                         </a:rPr>
-                        <a:t>€5.5k</a:t>
+                        <a:t>€9.7k</a:t>
                       </a:r>
                       <a:endParaRPr lang="en-US" sz="1000" dirty="0">
                         <a:latin typeface="Calibri" charset="0"/>
@@ -5154,7 +5154,7 @@
                           <a:ea typeface="Calibri" pitchFamily="34" charset="-122"/>
                           <a:cs typeface="Calibri" pitchFamily="34" charset="-120"/>
                         </a:rPr>
-                        <a:t>€123</a:t>
+                        <a:t>€215</a:t>
                       </a:r>
                       <a:endParaRPr lang="en-US" sz="1000" dirty="0">
                         <a:latin typeface="Calibri" charset="0"/>
@@ -5219,7 +5219,7 @@
                           <a:ea typeface="Calibri" pitchFamily="34" charset="-122"/>
                           <a:cs typeface="Calibri" pitchFamily="34" charset="-120"/>
                         </a:rPr>
-                        <a:t>organic 14.6 · Polish corridor 13.8 · rediscovery 8.4 · tests 8.2</a:t>
+                        <a:t>Polish corridor 18.0 · organic 13.4 · rediscovery 7.7 · StepStone 4.8 · tests 1.2</a:t>
                       </a:r>
                       <a:endParaRPr lang="en-US" sz="900" dirty="0">
                         <a:latin typeface="Calibri" charset="0"/>
@@ -5416,7 +5416,7 @@
                           <a:ea typeface="Calibri" pitchFamily="34" charset="-122"/>
                           <a:cs typeface="Calibri" pitchFamily="34" charset="-120"/>
                         </a:rPr>
-                        <a:t>€6.7k</a:t>
+                        <a:t>€14.6k</a:t>
                       </a:r>
                       <a:endParaRPr lang="en-US" sz="1000" dirty="0">
                         <a:latin typeface="Calibri" charset="0"/>
@@ -5481,7 +5481,7 @@
                           <a:ea typeface="Calibri" pitchFamily="34" charset="-122"/>
                           <a:cs typeface="Calibri" pitchFamily="34" charset="-120"/>
                         </a:rPr>
-                        <a:t>€447</a:t>
+                        <a:t>€975</a:t>
                       </a:r>
                       <a:endParaRPr lang="en-US" sz="1000" dirty="0">
                         <a:latin typeface="Calibri" charset="0"/>
@@ -5546,7 +5546,7 @@
                           <a:ea typeface="Calibri" pitchFamily="34" charset="-122"/>
                           <a:cs typeface="Calibri" pitchFamily="34" charset="-120"/>
                         </a:rPr>
-                        <a:t>LinkedIn 8.6 · rediscovery 2.4 · organic 2.3 · tests 1.6</a:t>
+                        <a:t>LinkedIn 8.6 · rediscovery 2.3 · organic 2.3 · referrals 1.5 · tests 0.3</a:t>
                       </a:r>
                       <a:endParaRPr lang="en-US" sz="900" dirty="0">
                         <a:latin typeface="Calibri" charset="0"/>
@@ -5743,7 +5743,7 @@
                           <a:ea typeface="Calibri" pitchFamily="34" charset="-122"/>
                           <a:cs typeface="Calibri" pitchFamily="34" charset="-120"/>
                         </a:rPr>
-                        <a:t>€6.6k</a:t>
+                        <a:t>€14.6k</a:t>
                       </a:r>
                       <a:endParaRPr lang="en-US" sz="1000" dirty="0">
                         <a:latin typeface="Calibri" charset="0"/>
@@ -5808,7 +5808,7 @@
                           <a:ea typeface="Calibri" pitchFamily="34" charset="-122"/>
                           <a:cs typeface="Calibri" pitchFamily="34" charset="-120"/>
                         </a:rPr>
-                        <a:t>€655</a:t>
+                        <a:t>€1,457</a:t>
                       </a:r>
                       <a:endParaRPr lang="en-US" sz="1000" dirty="0">
                         <a:latin typeface="Calibri" charset="0"/>
@@ -5873,7 +5873,7 @@
                           <a:ea typeface="Calibri" pitchFamily="34" charset="-122"/>
                           <a:cs typeface="Calibri" pitchFamily="34" charset="-120"/>
                         </a:rPr>
-                        <a:t>LinkedIn 5.4 · rediscovery 1.5 · organic 1.3 · Google Search 1.0 · tests 0.5 · other 0.4</a:t>
+                        <a:t>LinkedIn 4.5 · StepStone 1.8 · rediscovery 1.3 · organic 1.1 · referrals 1.0 · other 0.2</a:t>
                       </a:r>
                       <a:endParaRPr lang="en-US" sz="900" dirty="0">
                         <a:latin typeface="Calibri" charset="0"/>
@@ -6070,7 +6070,7 @@
                           <a:ea typeface="Calibri" pitchFamily="34" charset="-122"/>
                           <a:cs typeface="Calibri" pitchFamily="34" charset="-120"/>
                         </a:rPr>
-                        <a:t>€38.7k</a:t>
+                        <a:t>€85.4k</a:t>
                       </a:r>
                       <a:endParaRPr lang="en-US" sz="1000" dirty="0">
                         <a:latin typeface="Calibri" charset="0"/>
@@ -6135,7 +6135,7 @@
                           <a:ea typeface="Calibri" pitchFamily="34" charset="-122"/>
                           <a:cs typeface="Calibri" pitchFamily="34" charset="-120"/>
                         </a:rPr>
-                        <a:t>€387</a:t>
+                        <a:t>€854</a:t>
                       </a:r>
                       <a:endParaRPr lang="en-US" sz="1000" dirty="0">
                         <a:latin typeface="Calibri" charset="0"/>
@@ -6200,7 +6200,7 @@
                           <a:ea typeface="Calibri" pitchFamily="34" charset="-122"/>
                           <a:cs typeface="Calibri" pitchFamily="34" charset="-120"/>
                         </a:rPr>
-                        <a:t>+ €8.8k reserve = €47.5k</a:t>
+                        <a:t>+ €17.1k reserve = €102.5k</a:t>
                       </a:r>
                       <a:endParaRPr lang="en-US" sz="900" dirty="0">
                         <a:latin typeface="Calibri" charset="0"/>
@@ -6294,7 +6294,7 @@
                   <a:schemeClr val="tx1"/>
                 </a:solidFill>
               </a:rPr>
-              <a:t>€750 test in every paid CPC/CPA cell in weeks 1–2, then buy hires cheapest-first: free channels → ATS rediscovery (~€20/hire) → Polish corridor (≤40% of mechatronics) → construction-electrician campaign → LinkedIn, Search, referrals, 1 StepStone ad. Pace ≤55 qualified a week; paid spend stops 27 Nov.</a:t>
+              <a:t>€750 test in every paid CPC/CPA cell in weeks 1–2, then buy hires cheapest-first: free channels → ATS rediscovery (~€13/hire) → Polish corridor (≤40% of mechatronics) → StepStone (7 ads) → referrals, LinkedIn → construction-electrician campaign, Search. Pace ≤55 qualified a week; paid spend stops Tue 24 Nov.</a:t>
             </a:r>
             <a:endParaRPr lang="en-US" sz="1100" dirty="0"/>
           </a:p>
@@ -6434,7 +6434,7 @@
                   <a:schemeClr val="tx1"/>
                 </a:solidFill>
               </a:rPr>
-              <a:t>90% used. Pre-screened sources first, pace ≤55/wk, ask +10–15 slots (65/wk → 76% use).</a:t>
+              <a:t>97% used. Pre-screened sources first, pace ≤55/wk, ask +10–15 slots (65/wk → 80% use).</a:t>
             </a:r>
             <a:endParaRPr lang="en-US" sz="1100" dirty="0"/>
           </a:p>
@@ -6465,7 +6465,7 @@
                   <a:schemeClr val="tx1"/>
                 </a:solidFill>
               </a:rPr>
-              <a:t>~12 of 30 need your OK on construction electricians by 23 Oct; else Meta, StepStone, programmatic at €1,000–1,500/hire.</a:t>
+              <a:t>~9 of 30 need your OK on construction electricians by 23 Oct; else more StepStone (~€1,022/hire), then Search and programmatic at €3.8k–€4.3k/hire.</a:t>
             </a:r>
             <a:endParaRPr lang="en-US" sz="1100" dirty="0"/>
           </a:p>
@@ -6496,7 +6496,7 @@
                   <a:schemeClr val="tx1"/>
                 </a:solidFill>
               </a:rPr>
-              <a:t>3-day offers, e-signature, 7-day offer validity, stop spend 27 Nov.</a:t>
+              <a:t>3-day offers, e-signature, 7-day offer validity, stop spend Tue 24 Nov.</a:t>
             </a:r>
             <a:endParaRPr lang="en-US" sz="1100" dirty="0"/>
           </a:p>
@@ -6695,7 +6695,7 @@
                   <a:schemeClr val="tx1"/>
                 </a:solidFill>
               </a:rPr>
-              <a:t>3-day offers, e-signature to 18 Dec; approve €47.5k</a:t>
+              <a:t>3-day offers, e-signature to 18 Dec; approve €102.5k</a:t>
             </a:r>
             <a:endParaRPr lang="en-US" sz="1100" dirty="0"/>
           </a:p>
@@ -6845,7 +6845,7 @@
                 <a:ea typeface="Cambria" pitchFamily="34" charset="-122"/>
                 <a:cs typeface="Cambria" pitchFamily="34" charset="-120"/>
               </a:rPr>
-              <a:t>Working back from 100 hires: ~291 qualified applicants for 322 assessment slots</a:t>
+              <a:t>Working back from 100 hires: ~305 qualified applicants for 314 assessment slots</a:t>
             </a:r>
             <a:endParaRPr lang="en-US" sz="2200" dirty="0"/>
           </a:p>
@@ -7624,7 +7624,7 @@
                             <a:schemeClr val="tx1"/>
                           </a:solidFill>
                         </a:rPr>
-                        <a:t>55%</a:t>
+                        <a:t>50%</a:t>
                       </a:r>
                       <a:endParaRPr lang="en-US" sz="1100" dirty="0"/>
                     </a:p>
@@ -7740,7 +7740,7 @@
                             <a:schemeClr val="tx1"/>
                           </a:solidFill>
                         </a:rPr>
-                        <a:t>65%</a:t>
+                        <a:t>70%</a:t>
                       </a:r>
                       <a:endParaRPr lang="en-US" sz="1100" dirty="0"/>
                     </a:p>
@@ -7856,7 +7856,7 @@
                             <a:schemeClr val="tx1"/>
                           </a:solidFill>
                         </a:rPr>
-                        <a:t>93</a:t>
+                        <a:t>95</a:t>
                       </a:r>
                       <a:endParaRPr lang="en-US" sz="1100" dirty="0"/>
                     </a:p>
@@ -7914,7 +7914,7 @@
                             <a:schemeClr val="tx1"/>
                           </a:solidFill>
                         </a:rPr>
-                        <a:t>622</a:t>
+                        <a:t>635</a:t>
                       </a:r>
                       <a:endParaRPr lang="en-US" sz="1100" dirty="0"/>
                     </a:p>
@@ -8148,7 +8148,7 @@
                             <a:schemeClr val="tx1"/>
                           </a:solidFill>
                         </a:rPr>
-                        <a:t>60%</a:t>
+                        <a:t>55%</a:t>
                       </a:r>
                       <a:endParaRPr lang="en-US" sz="1100" dirty="0"/>
                     </a:p>
@@ -8322,7 +8322,7 @@
                             <a:schemeClr val="tx1"/>
                           </a:solidFill>
                         </a:rPr>
-                        <a:t>41%</a:t>
+                        <a:t>37%</a:t>
                       </a:r>
                       <a:endParaRPr lang="en-US" sz="1100" dirty="0"/>
                     </a:p>
@@ -8380,7 +8380,7 @@
                             <a:schemeClr val="tx1"/>
                           </a:solidFill>
                         </a:rPr>
-                        <a:t>111</a:t>
+                        <a:t>121</a:t>
                       </a:r>
                       <a:endParaRPr lang="en-US" sz="1100" dirty="0"/>
                     </a:p>
@@ -8438,7 +8438,7 @@
                             <a:schemeClr val="tx1"/>
                           </a:solidFill>
                         </a:rPr>
-                        <a:t>505</a:t>
+                        <a:t>551</a:t>
                       </a:r>
                       <a:endParaRPr lang="en-US" sz="1100" dirty="0"/>
                     </a:p>
@@ -8672,7 +8672,7 @@
                             <a:schemeClr val="tx1"/>
                           </a:solidFill>
                         </a:rPr>
-                        <a:t>50%</a:t>
+                        <a:t>45%</a:t>
                       </a:r>
                       <a:endParaRPr lang="en-US" sz="1100" dirty="0"/>
                     </a:p>
@@ -8788,7 +8788,7 @@
                             <a:schemeClr val="tx1"/>
                           </a:solidFill>
                         </a:rPr>
-                        <a:t>65%</a:t>
+                        <a:t>70%</a:t>
                       </a:r>
                       <a:endParaRPr lang="en-US" sz="1100" dirty="0"/>
                     </a:p>
@@ -8846,7 +8846,7 @@
                             <a:schemeClr val="tx1"/>
                           </a:solidFill>
                         </a:rPr>
-                        <a:t>29%</a:t>
+                        <a:t>28%</a:t>
                       </a:r>
                       <a:endParaRPr lang="en-US" sz="1100" dirty="0"/>
                     </a:p>
@@ -8904,7 +8904,7 @@
                             <a:schemeClr val="tx1"/>
                           </a:solidFill>
                         </a:rPr>
-                        <a:t>51</a:t>
+                        <a:t>53</a:t>
                       </a:r>
                       <a:endParaRPr lang="en-US" sz="1100" dirty="0"/>
                     </a:p>
@@ -8962,7 +8962,7 @@
                             <a:schemeClr val="tx1"/>
                           </a:solidFill>
                         </a:rPr>
-                        <a:t>427</a:t>
+                        <a:t>441</a:t>
                       </a:r>
                       <a:endParaRPr lang="en-US" sz="1100" dirty="0"/>
                     </a:p>
@@ -9196,7 +9196,7 @@
                             <a:schemeClr val="tx1"/>
                           </a:solidFill>
                         </a:rPr>
-                        <a:t>45%</a:t>
+                        <a:t>40%</a:t>
                       </a:r>
                       <a:endParaRPr lang="en-US" sz="1100" dirty="0"/>
                     </a:p>
@@ -9370,7 +9370,7 @@
                             <a:schemeClr val="tx1"/>
                           </a:solidFill>
                         </a:rPr>
-                        <a:t>27%</a:t>
+                        <a:t>24%</a:t>
                       </a:r>
                       <a:endParaRPr lang="en-US" sz="1100" dirty="0"/>
                     </a:p>
@@ -9428,7 +9428,7 @@
                             <a:schemeClr val="tx1"/>
                           </a:solidFill>
                         </a:rPr>
-                        <a:t>37</a:t>
+                        <a:t>42</a:t>
                       </a:r>
                       <a:endParaRPr lang="en-US" sz="1100" dirty="0"/>
                     </a:p>
@@ -9486,7 +9486,7 @@
                             <a:schemeClr val="tx1"/>
                           </a:solidFill>
                         </a:rPr>
-                        <a:t>373</a:t>
+                        <a:t>420</a:t>
                       </a:r>
                       <a:endParaRPr lang="en-US" sz="1100" dirty="0"/>
                     </a:p>
@@ -9862,7 +9862,7 @@
                             <a:schemeClr val="tx1"/>
                           </a:solidFill>
                         </a:rPr>
-                        <a:t>34%</a:t>
+                        <a:t>32%</a:t>
                       </a:r>
                       <a:endParaRPr lang="en-US" sz="1100" dirty="0"/>
                     </a:p>
@@ -9920,7 +9920,7 @@
                             <a:schemeClr val="tx1"/>
                           </a:solidFill>
                         </a:rPr>
-                        <a:t>293</a:t>
+                        <a:t>311</a:t>
                       </a:r>
                       <a:endParaRPr lang="en-US" sz="1100" dirty="0"/>
                     </a:p>
@@ -9978,7 +9978,7 @@
                             <a:schemeClr val="tx1"/>
                           </a:solidFill>
                         </a:rPr>
-                        <a:t>1,927</a:t>
+                        <a:t>2,047</a:t>
                       </a:r>
                       <a:endParaRPr lang="en-US" sz="1100" dirty="0"/>
                     </a:p>
@@ -10068,7 +10068,7 @@
                   <a:schemeClr val="tx1"/>
                 </a:solidFill>
               </a:rPr>
-              <a:t>All own estimates, each reasoned on the Assumptions tab. Few applicants qualify (brief), and foreign-trained electricians can't be recognised in time (2–4 months, §6 BQFG). About half fail a practical test. Acceptance reflects counter-offers in Engpass trades. With the channel mix, the plan needs </a:t>
+              <a:t>Sourced where data exists (IAB: 28% of applications suitable; Gem interview-pass and Königsteiner/StepStone offer-acceptance data), own estimates otherwise; each labelled on the Assumptions tab. Few applicants qualify (brief), and foreign-trained electricians can't be recognised in time (2–4 months, §6 BQFG). Acceptance reflects counter-offers in Engpass trades. With the channel mix, the plan needs </a:t>
             </a:r>
             <a:pPr indent="0" marL="0">
               <a:buNone/>
@@ -10079,7 +10079,7 @@
                   <a:schemeClr val="tx1"/>
                 </a:solidFill>
               </a:rPr>
-              <a:t>291 qualified / 1,611 applications</a:t>
+              <a:t>305 qualified / 1,525 applications</a:t>
             </a:r>
             <a:pPr indent="0" marL="0">
               <a:buNone/>
@@ -10137,7 +10137,7 @@
                   <a:schemeClr val="tx1"/>
                 </a:solidFill>
               </a:rPr>
-              <a:t>Application → assessment 4 days, → interview 7, → offer 3, → signature 7; supervisors +7. Last realistic signature Fri 18 Dec, so applications must arrive by Fri 27 Nov (E/M/A) and Fri 20 Nov (supervisors). Slots = 55 × 41 days ÷ 7 = 322.</a:t>
+              <a:t>Application → assessment 6 days, → interview 8, → offer 3, → signature 7 (first two: SmartRecruiters DE benchmark); supervisors +7. Last realistic signature Fri 18 Dec, so applications must arrive by Tue 24 Nov (E/M/A) and Tue 17 Nov (supervisors). Slots = 55 × 40 days ÷ 7 = 314.</a:t>
             </a:r>
             <a:endParaRPr lang="en-US" sz="1200" dirty="0"/>
           </a:p>
@@ -10189,7 +10189,7 @@
                   <a:schemeClr val="tx2"/>
                 </a:solidFill>
               </a:rPr>
-              <a:t>Week 1: 39 of 39 slots; weeks 2–5: 51–55 of 55; week 6: 43; week 7 is Tue 1 Dec only (last assessment day, 8 slots). Rediscovery re-applicants (waves 21 Oct, 26 Oct and 2 Nov) and the €750 tests fill weeks 1–2, so regular spend starts at 3% and 5%, then 20–24% a week.</a:t>
+              <a:t>Week 1: 37 of 39 slots; weeks 2–5: 52–54 of 55; week 6: 55; assessments end Mon 30 Nov. Rediscovery re-applicants (waves 21 Oct, 26 Oct and 2 Nov) and the €750 tests fill weeks 1–2, so regular spend ramps 7%, 11%, 16%, then 21–25% a week.</a:t>
             </a:r>
             <a:endParaRPr lang="en-US" sz="1100" dirty="0"/>
           </a:p>
@@ -10339,7 +10339,7 @@
                 <a:ea typeface="Cambria" pitchFamily="34" charset="-122"/>
                 <a:cs typeface="Cambria" pitchFamily="34" charset="-120"/>
               </a:rPr>
-              <a:t>Electricians are hardest; a 30% worse pass rate costs ~22 hires that money can't buy back</a:t>
+              <a:t>Electricians are hardest; a 30% worse pass rate costs ~28 hires that money can't buy back</a:t>
             </a:r>
             <a:endParaRPr lang="en-US" sz="2200" dirty="0"/>
           </a:p>
@@ -10816,7 +10816,7 @@
                             <a:schemeClr val="tx1"/>
                           </a:solidFill>
                         </a:rPr>
-                        <a:t>1.9×</a:t>
+                        <a:t>1.8×</a:t>
                       </a:r>
                       <a:endParaRPr lang="en-US" sz="1100" dirty="0"/>
                     </a:p>
@@ -10932,7 +10932,7 @@
                             <a:schemeClr val="tx1"/>
                           </a:solidFill>
                         </a:rPr>
-                        <a:t>9%</a:t>
+                        <a:t>14%</a:t>
                       </a:r>
                       <a:endParaRPr lang="en-US" sz="1100" dirty="0"/>
                     </a:p>
@@ -11166,7 +11166,7 @@
                             <a:schemeClr val="tx1"/>
                           </a:solidFill>
                         </a:rPr>
-                        <a:t>3.2×</a:t>
+                        <a:t>3.0×</a:t>
                       </a:r>
                       <a:endParaRPr lang="en-US" sz="1100" dirty="0"/>
                     </a:p>
@@ -11224,7 +11224,7 @@
                             <a:schemeClr val="tx1"/>
                           </a:solidFill>
                         </a:rPr>
-                        <a:t>3.2×</a:t>
+                        <a:t>3.0×</a:t>
                       </a:r>
                       <a:endParaRPr lang="en-US" sz="1100" dirty="0"/>
                     </a:p>
@@ -11282,7 +11282,7 @@
                             <a:schemeClr val="tx1"/>
                           </a:solidFill>
                         </a:rPr>
-                        <a:t>5%</a:t>
+                        <a:t>7%</a:t>
                       </a:r>
                       <a:endParaRPr lang="en-US" sz="1100" dirty="0"/>
                     </a:p>
@@ -11516,7 +11516,7 @@
                             <a:schemeClr val="tx1"/>
                           </a:solidFill>
                         </a:rPr>
-                        <a:t>2.0×</a:t>
+                        <a:t>1.9×</a:t>
                       </a:r>
                       <a:endParaRPr lang="en-US" sz="1100" dirty="0"/>
                     </a:p>
@@ -11574,7 +11574,7 @@
                             <a:schemeClr val="tx1"/>
                           </a:solidFill>
                         </a:rPr>
-                        <a:t>2.0×</a:t>
+                        <a:t>1.9×</a:t>
                       </a:r>
                       <a:endParaRPr lang="en-US" sz="1100" dirty="0"/>
                     </a:p>
@@ -11632,7 +11632,7 @@
                             <a:schemeClr val="tx1"/>
                           </a:solidFill>
                         </a:rPr>
-                        <a:t>9%</a:t>
+                        <a:t>10%</a:t>
                       </a:r>
                       <a:endParaRPr lang="en-US" sz="1100" dirty="0"/>
                     </a:p>
@@ -11866,7 +11866,7 @@
                             <a:schemeClr val="tx1"/>
                           </a:solidFill>
                         </a:rPr>
-                        <a:t>1.8×</a:t>
+                        <a:t>1.6×</a:t>
                       </a:r>
                       <a:endParaRPr lang="en-US" sz="1100" dirty="0"/>
                     </a:p>
@@ -11924,7 +11924,7 @@
                             <a:schemeClr val="tx1"/>
                           </a:solidFill>
                         </a:rPr>
-                        <a:t>1.8×</a:t>
+                        <a:t>1.6×</a:t>
                       </a:r>
                       <a:endParaRPr lang="en-US" sz="1100" dirty="0"/>
                     </a:p>
@@ -11982,7 +11982,7 @@
                             <a:schemeClr val="tx1"/>
                           </a:solidFill>
                         </a:rPr>
-                        <a:t>17%</a:t>
+                        <a:t>19%</a:t>
                       </a:r>
                       <a:endParaRPr lang="en-US" sz="1100" dirty="0"/>
                     </a:p>
@@ -12235,7 +12235,7 @@
                   <a:schemeClr val="tx1"/>
                 </a:solidFill>
               </a:rPr>
-              <a:t>30% worse pass or acceptance rates need 415 qualified for 322 slots (129%). The 43% more media that would need can't help: slots cap hires at ~78. Upstream misses (share qualified, cost per application) only cost money.</a:t>
+              <a:t>30% worse pass or acceptance rates need 436 qualified for 314 slots (139%). The 43% more media that would need can't help: slots cap hires at ~72. Upstream misses (share qualified, cost per application) only cost money.</a:t>
             </a:r>
             <a:endParaRPr lang="en-US" sz="1200" dirty="0"/>
           </a:p>
@@ -12542,7 +12542,7 @@
                             <a:schemeClr val="tx1"/>
                           </a:solidFill>
                         </a:rPr>
-                        <a:t>415</a:t>
+                        <a:t>436</a:t>
                       </a:r>
                       <a:endParaRPr lang="en-US" sz="1000" dirty="0"/>
                     </a:p>
@@ -12718,7 +12718,7 @@
                             <a:schemeClr val="tx1"/>
                           </a:solidFill>
                         </a:rPr>
-                        <a:t>415</a:t>
+                        <a:t>436</a:t>
                       </a:r>
                       <a:endParaRPr lang="en-US" sz="1000" dirty="0"/>
                     </a:p>
@@ -12894,7 +12894,7 @@
                             <a:schemeClr val="tx1"/>
                           </a:solidFill>
                         </a:rPr>
-                        <a:t>291</a:t>
+                        <a:t>305</a:t>
                       </a:r>
                       <a:endParaRPr lang="en-US" sz="1000" dirty="0"/>
                     </a:p>
@@ -13070,7 +13070,7 @@
                             <a:schemeClr val="tx1"/>
                           </a:solidFill>
                         </a:rPr>
-                        <a:t>291</a:t>
+                        <a:t>305</a:t>
                       </a:r>
                       <a:endParaRPr lang="en-US" sz="1000" dirty="0"/>
                     </a:p>
@@ -13246,7 +13246,7 @@
                             <a:schemeClr val="tx1"/>
                           </a:solidFill>
                         </a:rPr>
-                        <a:t>291</a:t>
+                        <a:t>305</a:t>
                       </a:r>
                       <a:endParaRPr lang="en-US" sz="1000" dirty="0"/>
                     </a:p>
@@ -13912,7 +13912,7 @@
                             <a:schemeClr val="tx1"/>
                           </a:solidFill>
                         </a:rPr>
-                        <a:t>€0 / €0 · 3.9</a:t>
+                        <a:t>€0 / €0 · 3.8</a:t>
                       </a:r>
                       <a:endParaRPr lang="en-US" sz="1000" dirty="0"/>
                     </a:p>
@@ -13973,7 +13973,7 @@
                             <a:schemeClr val="tx1"/>
                           </a:solidFill>
                         </a:rPr>
-                        <a:t>€0 / €0 · 14.6</a:t>
+                        <a:t>€0 / €0 · 13.4</a:t>
                       </a:r>
                       <a:endParaRPr lang="en-US" sz="1000" dirty="0"/>
                     </a:p>
@@ -14095,7 +14095,7 @@
                             <a:schemeClr val="tx1"/>
                           </a:solidFill>
                         </a:rPr>
-                        <a:t>€0 / €0 · 1.3</a:t>
+                        <a:t>€0 / €0 · 1.1</a:t>
                       </a:r>
                       <a:endParaRPr lang="en-US" sz="1000" dirty="0"/>
                     </a:p>
@@ -14216,7 +14216,7 @@
                             <a:schemeClr val="tx1"/>
                           </a:solidFill>
                         </a:rPr>
-                        <a:t>€8 / €23 · 4.4</a:t>
+                        <a:t>€5 / €14 · 4.3</a:t>
                       </a:r>
                       <a:endParaRPr lang="en-US" sz="1000" dirty="0"/>
                     </a:p>
@@ -14277,7 +14277,7 @@
                             <a:schemeClr val="tx1"/>
                           </a:solidFill>
                         </a:rPr>
-                        <a:t>€8 / €18 · 8.4</a:t>
+                        <a:t>€5 / €12 · 7.7</a:t>
                       </a:r>
                       <a:endParaRPr lang="en-US" sz="1000" dirty="0"/>
                     </a:p>
@@ -14338,7 +14338,7 @@
                             <a:schemeClr val="tx1"/>
                           </a:solidFill>
                         </a:rPr>
-                        <a:t>€8 / €25 · 2.4</a:t>
+                        <a:t>€5 / €15 · 2.3</a:t>
                       </a:r>
                       <a:endParaRPr lang="en-US" sz="1000" dirty="0"/>
                     </a:p>
@@ -14399,7 +14399,7 @@
                             <a:schemeClr val="tx1"/>
                           </a:solidFill>
                         </a:rPr>
-                        <a:t>€8 / €27 · 1.5</a:t>
+                        <a:t>€5 / €18 · 1.3</a:t>
                       </a:r>
                       <a:endParaRPr lang="en-US" sz="1000" dirty="0"/>
                     </a:p>
@@ -14578,7 +14578,7 @@
                             <a:schemeClr val="tx1"/>
                           </a:solidFill>
                         </a:rPr>
-                        <a:t>€89 / €221 · 13.8</a:t>
+                        <a:t>€92 / €248 · 18.0</a:t>
                       </a:r>
                       <a:endParaRPr lang="en-US" sz="1000" dirty="0"/>
                     </a:p>
@@ -14757,6 +14757,912 @@
                             <a:schemeClr val="tx1"/>
                           </a:solidFill>
                         </a:rPr>
+                        <a:t>StepStone (German, CV-based, €1,449/ad)</a:t>
+                      </a:r>
+                      <a:endParaRPr lang="en-US" sz="1000" dirty="0"/>
+                    </a:p>
+                  </a:txBody>
+                  <a:tcPr marL="91440" marR="91440" marT="45720" marB="45720" anchor="ctr">
+                    <a:lnL w="6350" cap="flat" cmpd="sng" algn="ctr">
+                      <a:solidFill>
+                        <a:srgbClr val="D6DEE5"/>
+                      </a:solidFill>
+                      <a:prstDash val="solid"/>
+                      <a:round/>
+                      <a:headEnd type="none" w="med" len="med"/>
+                      <a:tailEnd type="none" w="med" len="med"/>
+                    </a:lnL>
+                    <a:lnR w="6350" cap="flat" cmpd="sng" algn="ctr">
+                      <a:solidFill>
+                        <a:srgbClr val="D6DEE5"/>
+                      </a:solidFill>
+                      <a:prstDash val="solid"/>
+                      <a:round/>
+                      <a:headEnd type="none" w="med" len="med"/>
+                      <a:tailEnd type="none" w="med" len="med"/>
+                    </a:lnR>
+                    <a:lnT w="6350" cap="flat" cmpd="sng" algn="ctr">
+                      <a:solidFill>
+                        <a:srgbClr val="D6DEE5"/>
+                      </a:solidFill>
+                      <a:prstDash val="solid"/>
+                      <a:round/>
+                      <a:headEnd type="none" w="med" len="med"/>
+                      <a:tailEnd type="none" w="med" len="med"/>
+                    </a:lnT>
+                    <a:lnB w="6350" cap="flat" cmpd="sng" algn="ctr">
+                      <a:solidFill>
+                        <a:srgbClr val="D6DEE5"/>
+                      </a:solidFill>
+                      <a:prstDash val="solid"/>
+                      <a:round/>
+                      <a:headEnd type="none" w="med" len="med"/>
+                      <a:tailEnd type="none" w="med" len="med"/>
+                    </a:lnB>
+                  </a:tcPr>
+                </a:tc>
+                <a:tc>
+                  <a:txBody>
+                    <a:bodyPr/>
+                    <a:lstStyle/>
+                    <a:p>
+                      <a:pPr algn="ctr" indent="0" marL="0">
+                        <a:buNone/>
+                      </a:pPr>
+                      <a:r>
+                        <a:rPr lang="en-US" sz="1000" dirty="0">
+                          <a:solidFill>
+                            <a:schemeClr val="tx1"/>
+                          </a:solidFill>
+                        </a:rPr>
+                        <a:t>€322 / €1,022 · 4.3</a:t>
+                      </a:r>
+                      <a:endParaRPr lang="en-US" sz="1000" dirty="0"/>
+                    </a:p>
+                  </a:txBody>
+                  <a:tcPr marL="91440" marR="91440" marT="45720" marB="45720" anchor="ctr">
+                    <a:lnL w="6350" cap="flat" cmpd="sng" algn="ctr">
+                      <a:solidFill>
+                        <a:srgbClr val="D6DEE5"/>
+                      </a:solidFill>
+                      <a:prstDash val="solid"/>
+                      <a:round/>
+                      <a:headEnd type="none" w="med" len="med"/>
+                      <a:tailEnd type="none" w="med" len="med"/>
+                    </a:lnL>
+                    <a:lnR w="6350" cap="flat" cmpd="sng" algn="ctr">
+                      <a:solidFill>
+                        <a:srgbClr val="D6DEE5"/>
+                      </a:solidFill>
+                      <a:prstDash val="solid"/>
+                      <a:round/>
+                      <a:headEnd type="none" w="med" len="med"/>
+                      <a:tailEnd type="none" w="med" len="med"/>
+                    </a:lnR>
+                    <a:lnT w="6350" cap="flat" cmpd="sng" algn="ctr">
+                      <a:solidFill>
+                        <a:srgbClr val="D6DEE5"/>
+                      </a:solidFill>
+                      <a:prstDash val="solid"/>
+                      <a:round/>
+                      <a:headEnd type="none" w="med" len="med"/>
+                      <a:tailEnd type="none" w="med" len="med"/>
+                    </a:lnT>
+                    <a:lnB w="6350" cap="flat" cmpd="sng" algn="ctr">
+                      <a:solidFill>
+                        <a:srgbClr val="D6DEE5"/>
+                      </a:solidFill>
+                      <a:prstDash val="solid"/>
+                      <a:round/>
+                      <a:headEnd type="none" w="med" len="med"/>
+                      <a:tailEnd type="none" w="med" len="med"/>
+                    </a:lnB>
+                    <a:solidFill>
+                      <a:srgbClr val="DCEFE8"/>
+                    </a:solidFill>
+                  </a:tcPr>
+                </a:tc>
+                <a:tc>
+                  <a:txBody>
+                    <a:bodyPr/>
+                    <a:lstStyle/>
+                    <a:p>
+                      <a:pPr algn="ctr" indent="0" marL="0">
+                        <a:buNone/>
+                      </a:pPr>
+                      <a:r>
+                        <a:rPr lang="en-US" sz="1000" dirty="0">
+                          <a:solidFill>
+                            <a:schemeClr val="tx1"/>
+                          </a:solidFill>
+                        </a:rPr>
+                        <a:t>€166 / €446 · 4.8</a:t>
+                      </a:r>
+                      <a:endParaRPr lang="en-US" sz="1000" dirty="0"/>
+                    </a:p>
+                  </a:txBody>
+                  <a:tcPr marL="91440" marR="91440" marT="45720" marB="45720" anchor="ctr">
+                    <a:lnL w="6350" cap="flat" cmpd="sng" algn="ctr">
+                      <a:solidFill>
+                        <a:srgbClr val="D6DEE5"/>
+                      </a:solidFill>
+                      <a:prstDash val="solid"/>
+                      <a:round/>
+                      <a:headEnd type="none" w="med" len="med"/>
+                      <a:tailEnd type="none" w="med" len="med"/>
+                    </a:lnL>
+                    <a:lnR w="6350" cap="flat" cmpd="sng" algn="ctr">
+                      <a:solidFill>
+                        <a:srgbClr val="D6DEE5"/>
+                      </a:solidFill>
+                      <a:prstDash val="solid"/>
+                      <a:round/>
+                      <a:headEnd type="none" w="med" len="med"/>
+                      <a:tailEnd type="none" w="med" len="med"/>
+                    </a:lnR>
+                    <a:lnT w="6350" cap="flat" cmpd="sng" algn="ctr">
+                      <a:solidFill>
+                        <a:srgbClr val="D6DEE5"/>
+                      </a:solidFill>
+                      <a:prstDash val="solid"/>
+                      <a:round/>
+                      <a:headEnd type="none" w="med" len="med"/>
+                      <a:tailEnd type="none" w="med" len="med"/>
+                    </a:lnT>
+                    <a:lnB w="6350" cap="flat" cmpd="sng" algn="ctr">
+                      <a:solidFill>
+                        <a:srgbClr val="D6DEE5"/>
+                      </a:solidFill>
+                      <a:prstDash val="solid"/>
+                      <a:round/>
+                      <a:headEnd type="none" w="med" len="med"/>
+                      <a:tailEnd type="none" w="med" len="med"/>
+                    </a:lnB>
+                    <a:solidFill>
+                      <a:srgbClr val="DCEFE8"/>
+                    </a:solidFill>
+                  </a:tcPr>
+                </a:tc>
+                <a:tc>
+                  <a:txBody>
+                    <a:bodyPr/>
+                    <a:lstStyle/>
+                    <a:p>
+                      <a:pPr algn="ctr" indent="0" marL="0">
+                        <a:buNone/>
+                      </a:pPr>
+                      <a:r>
+                        <a:rPr lang="en-US" sz="1000" dirty="0">
+                          <a:solidFill>
+                            <a:schemeClr val="tx1"/>
+                          </a:solidFill>
+                        </a:rPr>
+                        <a:t>€386 / €1,363 · –</a:t>
+                      </a:r>
+                      <a:endParaRPr lang="en-US" sz="1000" dirty="0"/>
+                    </a:p>
+                  </a:txBody>
+                  <a:tcPr marL="91440" marR="91440" marT="45720" marB="45720" anchor="ctr">
+                    <a:lnL w="6350" cap="flat" cmpd="sng" algn="ctr">
+                      <a:solidFill>
+                        <a:srgbClr val="D6DEE5"/>
+                      </a:solidFill>
+                      <a:prstDash val="solid"/>
+                      <a:round/>
+                      <a:headEnd type="none" w="med" len="med"/>
+                      <a:tailEnd type="none" w="med" len="med"/>
+                    </a:lnL>
+                    <a:lnR w="6350" cap="flat" cmpd="sng" algn="ctr">
+                      <a:solidFill>
+                        <a:srgbClr val="D6DEE5"/>
+                      </a:solidFill>
+                      <a:prstDash val="solid"/>
+                      <a:round/>
+                      <a:headEnd type="none" w="med" len="med"/>
+                      <a:tailEnd type="none" w="med" len="med"/>
+                    </a:lnR>
+                    <a:lnT w="6350" cap="flat" cmpd="sng" algn="ctr">
+                      <a:solidFill>
+                        <a:srgbClr val="D6DEE5"/>
+                      </a:solidFill>
+                      <a:prstDash val="solid"/>
+                      <a:round/>
+                      <a:headEnd type="none" w="med" len="med"/>
+                      <a:tailEnd type="none" w="med" len="med"/>
+                    </a:lnT>
+                    <a:lnB w="6350" cap="flat" cmpd="sng" algn="ctr">
+                      <a:solidFill>
+                        <a:srgbClr val="D6DEE5"/>
+                      </a:solidFill>
+                      <a:prstDash val="solid"/>
+                      <a:round/>
+                      <a:headEnd type="none" w="med" len="med"/>
+                      <a:tailEnd type="none" w="med" len="med"/>
+                    </a:lnB>
+                    <a:solidFill>
+                      <a:srgbClr val="F2F4F6"/>
+                    </a:solidFill>
+                  </a:tcPr>
+                </a:tc>
+                <a:tc>
+                  <a:txBody>
+                    <a:bodyPr/>
+                    <a:lstStyle/>
+                    <a:p>
+                      <a:pPr algn="ctr" indent="0" marL="0">
+                        <a:buNone/>
+                      </a:pPr>
+                      <a:r>
+                        <a:rPr lang="en-US" sz="1000" dirty="0">
+                          <a:solidFill>
+                            <a:schemeClr val="tx1"/>
+                          </a:solidFill>
+                        </a:rPr>
+                        <a:t>€386 / €1,624 · 1.8</a:t>
+                      </a:r>
+                      <a:endParaRPr lang="en-US" sz="1000" dirty="0"/>
+                    </a:p>
+                  </a:txBody>
+                  <a:tcPr marL="91440" marR="91440" marT="45720" marB="45720" anchor="ctr">
+                    <a:lnL w="6350" cap="flat" cmpd="sng" algn="ctr">
+                      <a:solidFill>
+                        <a:srgbClr val="D6DEE5"/>
+                      </a:solidFill>
+                      <a:prstDash val="solid"/>
+                      <a:round/>
+                      <a:headEnd type="none" w="med" len="med"/>
+                      <a:tailEnd type="none" w="med" len="med"/>
+                    </a:lnL>
+                    <a:lnR w="6350" cap="flat" cmpd="sng" algn="ctr">
+                      <a:solidFill>
+                        <a:srgbClr val="D6DEE5"/>
+                      </a:solidFill>
+                      <a:prstDash val="solid"/>
+                      <a:round/>
+                      <a:headEnd type="none" w="med" len="med"/>
+                      <a:tailEnd type="none" w="med" len="med"/>
+                    </a:lnR>
+                    <a:lnT w="6350" cap="flat" cmpd="sng" algn="ctr">
+                      <a:solidFill>
+                        <a:srgbClr val="D6DEE5"/>
+                      </a:solidFill>
+                      <a:prstDash val="solid"/>
+                      <a:round/>
+                      <a:headEnd type="none" w="med" len="med"/>
+                      <a:tailEnd type="none" w="med" len="med"/>
+                    </a:lnT>
+                    <a:lnB w="6350" cap="flat" cmpd="sng" algn="ctr">
+                      <a:solidFill>
+                        <a:srgbClr val="D6DEE5"/>
+                      </a:solidFill>
+                      <a:prstDash val="solid"/>
+                      <a:round/>
+                      <a:headEnd type="none" w="med" len="med"/>
+                      <a:tailEnd type="none" w="med" len="med"/>
+                    </a:lnB>
+                    <a:solidFill>
+                      <a:srgbClr val="DCEFE8"/>
+                    </a:solidFill>
+                  </a:tcPr>
+                </a:tc>
+              </a:tr>
+              <a:tr h="329184">
+                <a:tc>
+                  <a:txBody>
+                    <a:bodyPr/>
+                    <a:lstStyle/>
+                    <a:p>
+                      <a:pPr indent="0" marL="0">
+                        <a:buNone/>
+                      </a:pPr>
+                      <a:r>
+                        <a:rPr lang="en-US" sz="1000" dirty="0">
+                          <a:solidFill>
+                            <a:schemeClr val="tx1"/>
+                          </a:solidFill>
+                        </a:rPr>
+                        <a:t>I1b Referrals (€1,000 bonus on hire)</a:t>
+                      </a:r>
+                      <a:endParaRPr lang="en-US" sz="1000" dirty="0"/>
+                    </a:p>
+                  </a:txBody>
+                  <a:tcPr marL="91440" marR="91440" marT="45720" marB="45720" anchor="ctr">
+                    <a:lnL w="6350" cap="flat" cmpd="sng" algn="ctr">
+                      <a:solidFill>
+                        <a:srgbClr val="D6DEE5"/>
+                      </a:solidFill>
+                      <a:prstDash val="solid"/>
+                      <a:round/>
+                      <a:headEnd type="none" w="med" len="med"/>
+                      <a:tailEnd type="none" w="med" len="med"/>
+                    </a:lnL>
+                    <a:lnR w="6350" cap="flat" cmpd="sng" algn="ctr">
+                      <a:solidFill>
+                        <a:srgbClr val="D6DEE5"/>
+                      </a:solidFill>
+                      <a:prstDash val="solid"/>
+                      <a:round/>
+                      <a:headEnd type="none" w="med" len="med"/>
+                      <a:tailEnd type="none" w="med" len="med"/>
+                    </a:lnR>
+                    <a:lnT w="6350" cap="flat" cmpd="sng" algn="ctr">
+                      <a:solidFill>
+                        <a:srgbClr val="D6DEE5"/>
+                      </a:solidFill>
+                      <a:prstDash val="solid"/>
+                      <a:round/>
+                      <a:headEnd type="none" w="med" len="med"/>
+                      <a:tailEnd type="none" w="med" len="med"/>
+                    </a:lnT>
+                    <a:lnB w="6350" cap="flat" cmpd="sng" algn="ctr">
+                      <a:solidFill>
+                        <a:srgbClr val="D6DEE5"/>
+                      </a:solidFill>
+                      <a:prstDash val="solid"/>
+                      <a:round/>
+                      <a:headEnd type="none" w="med" len="med"/>
+                      <a:tailEnd type="none" w="med" len="med"/>
+                    </a:lnB>
+                  </a:tcPr>
+                </a:tc>
+                <a:tc>
+                  <a:txBody>
+                    <a:bodyPr/>
+                    <a:lstStyle/>
+                    <a:p>
+                      <a:pPr algn="ctr" indent="0" marL="0">
+                        <a:buNone/>
+                      </a:pPr>
+                      <a:r>
+                        <a:rPr lang="en-US" sz="1000" dirty="0">
+                          <a:solidFill>
+                            <a:schemeClr val="tx1"/>
+                          </a:solidFill>
+                        </a:rPr>
+                        <a:t>€362 / €1,000 · 4.1</a:t>
+                      </a:r>
+                      <a:endParaRPr lang="en-US" sz="1000" dirty="0"/>
+                    </a:p>
+                  </a:txBody>
+                  <a:tcPr marL="91440" marR="91440" marT="45720" marB="45720" anchor="ctr">
+                    <a:lnL w="6350" cap="flat" cmpd="sng" algn="ctr">
+                      <a:solidFill>
+                        <a:srgbClr val="D6DEE5"/>
+                      </a:solidFill>
+                      <a:prstDash val="solid"/>
+                      <a:round/>
+                      <a:headEnd type="none" w="med" len="med"/>
+                      <a:tailEnd type="none" w="med" len="med"/>
+                    </a:lnL>
+                    <a:lnR w="6350" cap="flat" cmpd="sng" algn="ctr">
+                      <a:solidFill>
+                        <a:srgbClr val="D6DEE5"/>
+                      </a:solidFill>
+                      <a:prstDash val="solid"/>
+                      <a:round/>
+                      <a:headEnd type="none" w="med" len="med"/>
+                      <a:tailEnd type="none" w="med" len="med"/>
+                    </a:lnR>
+                    <a:lnT w="6350" cap="flat" cmpd="sng" algn="ctr">
+                      <a:solidFill>
+                        <a:srgbClr val="D6DEE5"/>
+                      </a:solidFill>
+                      <a:prstDash val="solid"/>
+                      <a:round/>
+                      <a:headEnd type="none" w="med" len="med"/>
+                      <a:tailEnd type="none" w="med" len="med"/>
+                    </a:lnT>
+                    <a:lnB w="6350" cap="flat" cmpd="sng" algn="ctr">
+                      <a:solidFill>
+                        <a:srgbClr val="D6DEE5"/>
+                      </a:solidFill>
+                      <a:prstDash val="solid"/>
+                      <a:round/>
+                      <a:headEnd type="none" w="med" len="med"/>
+                      <a:tailEnd type="none" w="med" len="med"/>
+                    </a:lnB>
+                    <a:solidFill>
+                      <a:srgbClr val="DCEFE8"/>
+                    </a:solidFill>
+                  </a:tcPr>
+                </a:tc>
+                <a:tc>
+                  <a:txBody>
+                    <a:bodyPr/>
+                    <a:lstStyle/>
+                    <a:p>
+                      <a:pPr algn="ctr" indent="0" marL="0">
+                        <a:buNone/>
+                      </a:pPr>
+                      <a:r>
+                        <a:rPr lang="en-US" sz="1000" dirty="0">
+                          <a:solidFill>
+                            <a:schemeClr val="tx1"/>
+                          </a:solidFill>
+                        </a:rPr>
+                        <a:t>€427 / €1,000 · –</a:t>
+                      </a:r>
+                      <a:endParaRPr lang="en-US" sz="1000" dirty="0"/>
+                    </a:p>
+                  </a:txBody>
+                  <a:tcPr marL="91440" marR="91440" marT="45720" marB="45720" anchor="ctr">
+                    <a:lnL w="6350" cap="flat" cmpd="sng" algn="ctr">
+                      <a:solidFill>
+                        <a:srgbClr val="D6DEE5"/>
+                      </a:solidFill>
+                      <a:prstDash val="solid"/>
+                      <a:round/>
+                      <a:headEnd type="none" w="med" len="med"/>
+                      <a:tailEnd type="none" w="med" len="med"/>
+                    </a:lnL>
+                    <a:lnR w="6350" cap="flat" cmpd="sng" algn="ctr">
+                      <a:solidFill>
+                        <a:srgbClr val="D6DEE5"/>
+                      </a:solidFill>
+                      <a:prstDash val="solid"/>
+                      <a:round/>
+                      <a:headEnd type="none" w="med" len="med"/>
+                      <a:tailEnd type="none" w="med" len="med"/>
+                    </a:lnR>
+                    <a:lnT w="6350" cap="flat" cmpd="sng" algn="ctr">
+                      <a:solidFill>
+                        <a:srgbClr val="D6DEE5"/>
+                      </a:solidFill>
+                      <a:prstDash val="solid"/>
+                      <a:round/>
+                      <a:headEnd type="none" w="med" len="med"/>
+                      <a:tailEnd type="none" w="med" len="med"/>
+                    </a:lnT>
+                    <a:lnB w="6350" cap="flat" cmpd="sng" algn="ctr">
+                      <a:solidFill>
+                        <a:srgbClr val="D6DEE5"/>
+                      </a:solidFill>
+                      <a:prstDash val="solid"/>
+                      <a:round/>
+                      <a:headEnd type="none" w="med" len="med"/>
+                      <a:tailEnd type="none" w="med" len="med"/>
+                    </a:lnB>
+                    <a:solidFill>
+                      <a:srgbClr val="F2F4F6"/>
+                    </a:solidFill>
+                  </a:tcPr>
+                </a:tc>
+                <a:tc>
+                  <a:txBody>
+                    <a:bodyPr/>
+                    <a:lstStyle/>
+                    <a:p>
+                      <a:pPr algn="ctr" indent="0" marL="0">
+                        <a:buNone/>
+                      </a:pPr>
+                      <a:r>
+                        <a:rPr lang="en-US" sz="1000" dirty="0">
+                          <a:solidFill>
+                            <a:schemeClr val="tx1"/>
+                          </a:solidFill>
+                        </a:rPr>
+                        <a:t>€326 / €1,000 · 1.5</a:t>
+                      </a:r>
+                      <a:endParaRPr lang="en-US" sz="1000" dirty="0"/>
+                    </a:p>
+                  </a:txBody>
+                  <a:tcPr marL="91440" marR="91440" marT="45720" marB="45720" anchor="ctr">
+                    <a:lnL w="6350" cap="flat" cmpd="sng" algn="ctr">
+                      <a:solidFill>
+                        <a:srgbClr val="D6DEE5"/>
+                      </a:solidFill>
+                      <a:prstDash val="solid"/>
+                      <a:round/>
+                      <a:headEnd type="none" w="med" len="med"/>
+                      <a:tailEnd type="none" w="med" len="med"/>
+                    </a:lnL>
+                    <a:lnR w="6350" cap="flat" cmpd="sng" algn="ctr">
+                      <a:solidFill>
+                        <a:srgbClr val="D6DEE5"/>
+                      </a:solidFill>
+                      <a:prstDash val="solid"/>
+                      <a:round/>
+                      <a:headEnd type="none" w="med" len="med"/>
+                      <a:tailEnd type="none" w="med" len="med"/>
+                    </a:lnR>
+                    <a:lnT w="6350" cap="flat" cmpd="sng" algn="ctr">
+                      <a:solidFill>
+                        <a:srgbClr val="D6DEE5"/>
+                      </a:solidFill>
+                      <a:prstDash val="solid"/>
+                      <a:round/>
+                      <a:headEnd type="none" w="med" len="med"/>
+                      <a:tailEnd type="none" w="med" len="med"/>
+                    </a:lnT>
+                    <a:lnB w="6350" cap="flat" cmpd="sng" algn="ctr">
+                      <a:solidFill>
+                        <a:srgbClr val="D6DEE5"/>
+                      </a:solidFill>
+                      <a:prstDash val="solid"/>
+                      <a:round/>
+                      <a:headEnd type="none" w="med" len="med"/>
+                      <a:tailEnd type="none" w="med" len="med"/>
+                    </a:lnB>
+                    <a:solidFill>
+                      <a:srgbClr val="DCEFE8"/>
+                    </a:solidFill>
+                  </a:tcPr>
+                </a:tc>
+                <a:tc>
+                  <a:txBody>
+                    <a:bodyPr/>
+                    <a:lstStyle/>
+                    <a:p>
+                      <a:pPr algn="ctr" indent="0" marL="0">
+                        <a:buNone/>
+                      </a:pPr>
+                      <a:r>
+                        <a:rPr lang="en-US" sz="1000" dirty="0">
+                          <a:solidFill>
+                            <a:schemeClr val="tx1"/>
+                          </a:solidFill>
+                        </a:rPr>
+                        <a:t>€274 / €1,000 · 1.0</a:t>
+                      </a:r>
+                      <a:endParaRPr lang="en-US" sz="1000" dirty="0"/>
+                    </a:p>
+                  </a:txBody>
+                  <a:tcPr marL="91440" marR="91440" marT="45720" marB="45720" anchor="ctr">
+                    <a:lnL w="6350" cap="flat" cmpd="sng" algn="ctr">
+                      <a:solidFill>
+                        <a:srgbClr val="D6DEE5"/>
+                      </a:solidFill>
+                      <a:prstDash val="solid"/>
+                      <a:round/>
+                      <a:headEnd type="none" w="med" len="med"/>
+                      <a:tailEnd type="none" w="med" len="med"/>
+                    </a:lnL>
+                    <a:lnR w="6350" cap="flat" cmpd="sng" algn="ctr">
+                      <a:solidFill>
+                        <a:srgbClr val="D6DEE5"/>
+                      </a:solidFill>
+                      <a:prstDash val="solid"/>
+                      <a:round/>
+                      <a:headEnd type="none" w="med" len="med"/>
+                      <a:tailEnd type="none" w="med" len="med"/>
+                    </a:lnR>
+                    <a:lnT w="6350" cap="flat" cmpd="sng" algn="ctr">
+                      <a:solidFill>
+                        <a:srgbClr val="D6DEE5"/>
+                      </a:solidFill>
+                      <a:prstDash val="solid"/>
+                      <a:round/>
+                      <a:headEnd type="none" w="med" len="med"/>
+                      <a:tailEnd type="none" w="med" len="med"/>
+                    </a:lnT>
+                    <a:lnB w="6350" cap="flat" cmpd="sng" algn="ctr">
+                      <a:solidFill>
+                        <a:srgbClr val="D6DEE5"/>
+                      </a:solidFill>
+                      <a:prstDash val="solid"/>
+                      <a:round/>
+                      <a:headEnd type="none" w="med" len="med"/>
+                      <a:tailEnd type="none" w="med" len="med"/>
+                    </a:lnB>
+                    <a:solidFill>
+                      <a:srgbClr val="DCEFE8"/>
+                    </a:solidFill>
+                  </a:tcPr>
+                </a:tc>
+              </a:tr>
+              <a:tr h="329184">
+                <a:tc>
+                  <a:txBody>
+                    <a:bodyPr/>
+                    <a:lstStyle/>
+                    <a:p>
+                      <a:pPr indent="0" marL="0">
+                        <a:buNone/>
+                      </a:pPr>
+                      <a:r>
+                        <a:rPr lang="en-US" sz="1000" dirty="0">
+                          <a:solidFill>
+                            <a:schemeClr val="tx1"/>
+                          </a:solidFill>
+                        </a:rPr>
+                        <a:t>LinkedIn (PLC/TIA and Meister profiles)</a:t>
+                      </a:r>
+                      <a:endParaRPr lang="en-US" sz="1000" dirty="0"/>
+                    </a:p>
+                  </a:txBody>
+                  <a:tcPr marL="91440" marR="91440" marT="45720" marB="45720" anchor="ctr">
+                    <a:lnL w="6350" cap="flat" cmpd="sng" algn="ctr">
+                      <a:solidFill>
+                        <a:srgbClr val="D6DEE5"/>
+                      </a:solidFill>
+                      <a:prstDash val="solid"/>
+                      <a:round/>
+                      <a:headEnd type="none" w="med" len="med"/>
+                      <a:tailEnd type="none" w="med" len="med"/>
+                    </a:lnL>
+                    <a:lnR w="6350" cap="flat" cmpd="sng" algn="ctr">
+                      <a:solidFill>
+                        <a:srgbClr val="D6DEE5"/>
+                      </a:solidFill>
+                      <a:prstDash val="solid"/>
+                      <a:round/>
+                      <a:headEnd type="none" w="med" len="med"/>
+                      <a:tailEnd type="none" w="med" len="med"/>
+                    </a:lnR>
+                    <a:lnT w="6350" cap="flat" cmpd="sng" algn="ctr">
+                      <a:solidFill>
+                        <a:srgbClr val="D6DEE5"/>
+                      </a:solidFill>
+                      <a:prstDash val="solid"/>
+                      <a:round/>
+                      <a:headEnd type="none" w="med" len="med"/>
+                      <a:tailEnd type="none" w="med" len="med"/>
+                    </a:lnT>
+                    <a:lnB w="6350" cap="flat" cmpd="sng" algn="ctr">
+                      <a:solidFill>
+                        <a:srgbClr val="D6DEE5"/>
+                      </a:solidFill>
+                      <a:prstDash val="solid"/>
+                      <a:round/>
+                      <a:headEnd type="none" w="med" len="med"/>
+                      <a:tailEnd type="none" w="med" len="med"/>
+                    </a:lnB>
+                  </a:tcPr>
+                </a:tc>
+                <a:tc>
+                  <a:txBody>
+                    <a:bodyPr/>
+                    <a:lstStyle/>
+                    <a:p>
+                      <a:pPr algn="ctr" indent="0" marL="0">
+                        <a:buNone/>
+                      </a:pPr>
+                      <a:r>
+                        <a:rPr lang="en-US" sz="1000" dirty="0">
+                          <a:solidFill>
+                            <a:schemeClr val="accent4"/>
+                          </a:solidFill>
+                        </a:rPr>
+                        <a:t>–</a:t>
+                      </a:r>
+                      <a:endParaRPr lang="en-US" sz="1000" dirty="0"/>
+                    </a:p>
+                  </a:txBody>
+                  <a:tcPr marL="91440" marR="91440" marT="45720" marB="45720" anchor="ctr">
+                    <a:lnL w="6350" cap="flat" cmpd="sng" algn="ctr">
+                      <a:solidFill>
+                        <a:srgbClr val="D6DEE5"/>
+                      </a:solidFill>
+                      <a:prstDash val="solid"/>
+                      <a:round/>
+                      <a:headEnd type="none" w="med" len="med"/>
+                      <a:tailEnd type="none" w="med" len="med"/>
+                    </a:lnL>
+                    <a:lnR w="6350" cap="flat" cmpd="sng" algn="ctr">
+                      <a:solidFill>
+                        <a:srgbClr val="D6DEE5"/>
+                      </a:solidFill>
+                      <a:prstDash val="solid"/>
+                      <a:round/>
+                      <a:headEnd type="none" w="med" len="med"/>
+                      <a:tailEnd type="none" w="med" len="med"/>
+                    </a:lnR>
+                    <a:lnT w="6350" cap="flat" cmpd="sng" algn="ctr">
+                      <a:solidFill>
+                        <a:srgbClr val="D6DEE5"/>
+                      </a:solidFill>
+                      <a:prstDash val="solid"/>
+                      <a:round/>
+                      <a:headEnd type="none" w="med" len="med"/>
+                      <a:tailEnd type="none" w="med" len="med"/>
+                    </a:lnT>
+                    <a:lnB w="6350" cap="flat" cmpd="sng" algn="ctr">
+                      <a:solidFill>
+                        <a:srgbClr val="D6DEE5"/>
+                      </a:solidFill>
+                      <a:prstDash val="solid"/>
+                      <a:round/>
+                      <a:headEnd type="none" w="med" len="med"/>
+                      <a:tailEnd type="none" w="med" len="med"/>
+                    </a:lnB>
+                  </a:tcPr>
+                </a:tc>
+                <a:tc>
+                  <a:txBody>
+                    <a:bodyPr/>
+                    <a:lstStyle/>
+                    <a:p>
+                      <a:pPr algn="ctr" indent="0" marL="0">
+                        <a:buNone/>
+                      </a:pPr>
+                      <a:r>
+                        <a:rPr lang="en-US" sz="1000" dirty="0">
+                          <a:solidFill>
+                            <a:schemeClr val="accent4"/>
+                          </a:solidFill>
+                        </a:rPr>
+                        <a:t>–</a:t>
+                      </a:r>
+                      <a:endParaRPr lang="en-US" sz="1000" dirty="0"/>
+                    </a:p>
+                  </a:txBody>
+                  <a:tcPr marL="91440" marR="91440" marT="45720" marB="45720" anchor="ctr">
+                    <a:lnL w="6350" cap="flat" cmpd="sng" algn="ctr">
+                      <a:solidFill>
+                        <a:srgbClr val="D6DEE5"/>
+                      </a:solidFill>
+                      <a:prstDash val="solid"/>
+                      <a:round/>
+                      <a:headEnd type="none" w="med" len="med"/>
+                      <a:tailEnd type="none" w="med" len="med"/>
+                    </a:lnL>
+                    <a:lnR w="6350" cap="flat" cmpd="sng" algn="ctr">
+                      <a:solidFill>
+                        <a:srgbClr val="D6DEE5"/>
+                      </a:solidFill>
+                      <a:prstDash val="solid"/>
+                      <a:round/>
+                      <a:headEnd type="none" w="med" len="med"/>
+                      <a:tailEnd type="none" w="med" len="med"/>
+                    </a:lnR>
+                    <a:lnT w="6350" cap="flat" cmpd="sng" algn="ctr">
+                      <a:solidFill>
+                        <a:srgbClr val="D6DEE5"/>
+                      </a:solidFill>
+                      <a:prstDash val="solid"/>
+                      <a:round/>
+                      <a:headEnd type="none" w="med" len="med"/>
+                      <a:tailEnd type="none" w="med" len="med"/>
+                    </a:lnT>
+                    <a:lnB w="6350" cap="flat" cmpd="sng" algn="ctr">
+                      <a:solidFill>
+                        <a:srgbClr val="D6DEE5"/>
+                      </a:solidFill>
+                      <a:prstDash val="solid"/>
+                      <a:round/>
+                      <a:headEnd type="none" w="med" len="med"/>
+                      <a:tailEnd type="none" w="med" len="med"/>
+                    </a:lnB>
+                  </a:tcPr>
+                </a:tc>
+                <a:tc>
+                  <a:txBody>
+                    <a:bodyPr/>
+                    <a:lstStyle/>
+                    <a:p>
+                      <a:pPr algn="ctr" indent="0" marL="0">
+                        <a:buNone/>
+                      </a:pPr>
+                      <a:r>
+                        <a:rPr lang="en-US" sz="1000" dirty="0">
+                          <a:solidFill>
+                            <a:schemeClr val="tx1"/>
+                          </a:solidFill>
+                        </a:rPr>
+                        <a:t>€384 / €1,354 · 8.6</a:t>
+                      </a:r>
+                      <a:endParaRPr lang="en-US" sz="1000" dirty="0"/>
+                    </a:p>
+                  </a:txBody>
+                  <a:tcPr marL="91440" marR="91440" marT="45720" marB="45720" anchor="ctr">
+                    <a:lnL w="6350" cap="flat" cmpd="sng" algn="ctr">
+                      <a:solidFill>
+                        <a:srgbClr val="D6DEE5"/>
+                      </a:solidFill>
+                      <a:prstDash val="solid"/>
+                      <a:round/>
+                      <a:headEnd type="none" w="med" len="med"/>
+                      <a:tailEnd type="none" w="med" len="med"/>
+                    </a:lnL>
+                    <a:lnR w="6350" cap="flat" cmpd="sng" algn="ctr">
+                      <a:solidFill>
+                        <a:srgbClr val="D6DEE5"/>
+                      </a:solidFill>
+                      <a:prstDash val="solid"/>
+                      <a:round/>
+                      <a:headEnd type="none" w="med" len="med"/>
+                      <a:tailEnd type="none" w="med" len="med"/>
+                    </a:lnR>
+                    <a:lnT w="6350" cap="flat" cmpd="sng" algn="ctr">
+                      <a:solidFill>
+                        <a:srgbClr val="D6DEE5"/>
+                      </a:solidFill>
+                      <a:prstDash val="solid"/>
+                      <a:round/>
+                      <a:headEnd type="none" w="med" len="med"/>
+                      <a:tailEnd type="none" w="med" len="med"/>
+                    </a:lnT>
+                    <a:lnB w="6350" cap="flat" cmpd="sng" algn="ctr">
+                      <a:solidFill>
+                        <a:srgbClr val="D6DEE5"/>
+                      </a:solidFill>
+                      <a:prstDash val="solid"/>
+                      <a:round/>
+                      <a:headEnd type="none" w="med" len="med"/>
+                      <a:tailEnd type="none" w="med" len="med"/>
+                    </a:lnB>
+                    <a:solidFill>
+                      <a:srgbClr val="DCEFE8"/>
+                    </a:solidFill>
+                  </a:tcPr>
+                </a:tc>
+                <a:tc>
+                  <a:txBody>
+                    <a:bodyPr/>
+                    <a:lstStyle/>
+                    <a:p>
+                      <a:pPr algn="ctr" indent="0" marL="0">
+                        <a:buNone/>
+                      </a:pPr>
+                      <a:r>
+                        <a:rPr lang="en-US" sz="1000" dirty="0">
+                          <a:solidFill>
+                            <a:schemeClr val="tx1"/>
+                          </a:solidFill>
+                        </a:rPr>
+                        <a:t>€480 / €2,017 · 4.5</a:t>
+                      </a:r>
+                      <a:endParaRPr lang="en-US" sz="1000" dirty="0"/>
+                    </a:p>
+                  </a:txBody>
+                  <a:tcPr marL="91440" marR="91440" marT="45720" marB="45720" anchor="ctr">
+                    <a:lnL w="6350" cap="flat" cmpd="sng" algn="ctr">
+                      <a:solidFill>
+                        <a:srgbClr val="D6DEE5"/>
+                      </a:solidFill>
+                      <a:prstDash val="solid"/>
+                      <a:round/>
+                      <a:headEnd type="none" w="med" len="med"/>
+                      <a:tailEnd type="none" w="med" len="med"/>
+                    </a:lnL>
+                    <a:lnR w="6350" cap="flat" cmpd="sng" algn="ctr">
+                      <a:solidFill>
+                        <a:srgbClr val="D6DEE5"/>
+                      </a:solidFill>
+                      <a:prstDash val="solid"/>
+                      <a:round/>
+                      <a:headEnd type="none" w="med" len="med"/>
+                      <a:tailEnd type="none" w="med" len="med"/>
+                    </a:lnR>
+                    <a:lnT w="6350" cap="flat" cmpd="sng" algn="ctr">
+                      <a:solidFill>
+                        <a:srgbClr val="D6DEE5"/>
+                      </a:solidFill>
+                      <a:prstDash val="solid"/>
+                      <a:round/>
+                      <a:headEnd type="none" w="med" len="med"/>
+                      <a:tailEnd type="none" w="med" len="med"/>
+                    </a:lnT>
+                    <a:lnB w="6350" cap="flat" cmpd="sng" algn="ctr">
+                      <a:solidFill>
+                        <a:srgbClr val="D6DEE5"/>
+                      </a:solidFill>
+                      <a:prstDash val="solid"/>
+                      <a:round/>
+                      <a:headEnd type="none" w="med" len="med"/>
+                      <a:tailEnd type="none" w="med" len="med"/>
+                    </a:lnB>
+                    <a:solidFill>
+                      <a:srgbClr val="DCEFE8"/>
+                    </a:solidFill>
+                  </a:tcPr>
+                </a:tc>
+              </a:tr>
+              <a:tr h="329184">
+                <a:tc>
+                  <a:txBody>
+                    <a:bodyPr/>
+                    <a:lstStyle/>
+                    <a:p>
+                      <a:pPr indent="0" marL="0">
+                        <a:buNone/>
+                      </a:pPr>
+                      <a:r>
+                        <a:rPr lang="en-US" sz="1000" dirty="0">
+                          <a:solidFill>
+                            <a:schemeClr val="tx1"/>
+                          </a:solidFill>
+                        </a:rPr>
                         <a:t>Meta lead ads (passive blue-collar reach)</a:t>
                       </a:r>
                       <a:endParaRPr lang="en-US" sz="1000" dirty="0"/>
@@ -14815,7 +15721,7 @@
                             <a:schemeClr val="tx1"/>
                           </a:solidFill>
                         </a:rPr>
-                        <a:t>€360 / €1,119 · 0.7 T</a:t>
+                        <a:t>€1,680 / €5,333 · 0.1 T</a:t>
                       </a:r>
                       <a:endParaRPr lang="en-US" sz="1000" dirty="0"/>
                     </a:p>
@@ -14876,7 +15782,7 @@
                             <a:schemeClr val="tx1"/>
                           </a:solidFill>
                         </a:rPr>
-                        <a:t>€100 / €247 · 3.0 T</a:t>
+                        <a:t>€700 / €1,886 · 0.4 T</a:t>
                       </a:r>
                       <a:endParaRPr lang="en-US" sz="1000" dirty="0"/>
                     </a:p>
@@ -15055,7 +15961,7 @@
                             <a:schemeClr val="tx1"/>
                           </a:solidFill>
                         </a:rPr>
-                        <a:t>Programmatic (Indeed, Jooble, Talent.com…)</a:t>
+                        <a:t>Google Search (high intent, low volume)</a:t>
                       </a:r>
                       <a:endParaRPr lang="en-US" sz="1000" dirty="0"/>
                     </a:p>
@@ -15113,7 +16019,68 @@
                             <a:schemeClr val="tx1"/>
                           </a:solidFill>
                         </a:rPr>
-                        <a:t>€476 / €1,480 · 0.5 T</a:t>
+                        <a:t>€1,193 / €3,788 · 3.8</a:t>
+                      </a:r>
+                      <a:endParaRPr lang="en-US" sz="1000" dirty="0"/>
+                    </a:p>
+                  </a:txBody>
+                  <a:tcPr marL="91440" marR="91440" marT="45720" marB="45720" anchor="ctr">
+                    <a:lnL w="6350" cap="flat" cmpd="sng" algn="ctr">
+                      <a:solidFill>
+                        <a:srgbClr val="D6DEE5"/>
+                      </a:solidFill>
+                      <a:prstDash val="solid"/>
+                      <a:round/>
+                      <a:headEnd type="none" w="med" len="med"/>
+                      <a:tailEnd type="none" w="med" len="med"/>
+                    </a:lnL>
+                    <a:lnR w="6350" cap="flat" cmpd="sng" algn="ctr">
+                      <a:solidFill>
+                        <a:srgbClr val="D6DEE5"/>
+                      </a:solidFill>
+                      <a:prstDash val="solid"/>
+                      <a:round/>
+                      <a:headEnd type="none" w="med" len="med"/>
+                      <a:tailEnd type="none" w="med" len="med"/>
+                    </a:lnR>
+                    <a:lnT w="6350" cap="flat" cmpd="sng" algn="ctr">
+                      <a:solidFill>
+                        <a:srgbClr val="D6DEE5"/>
+                      </a:solidFill>
+                      <a:prstDash val="solid"/>
+                      <a:round/>
+                      <a:headEnd type="none" w="med" len="med"/>
+                      <a:tailEnd type="none" w="med" len="med"/>
+                    </a:lnT>
+                    <a:lnB w="6350" cap="flat" cmpd="sng" algn="ctr">
+                      <a:solidFill>
+                        <a:srgbClr val="D6DEE5"/>
+                      </a:solidFill>
+                      <a:prstDash val="solid"/>
+                      <a:round/>
+                      <a:headEnd type="none" w="med" len="med"/>
+                      <a:tailEnd type="none" w="med" len="med"/>
+                    </a:lnB>
+                    <a:solidFill>
+                      <a:srgbClr val="DCEFE8"/>
+                    </a:solidFill>
+                  </a:tcPr>
+                </a:tc>
+                <a:tc>
+                  <a:txBody>
+                    <a:bodyPr/>
+                    <a:lstStyle/>
+                    <a:p>
+                      <a:pPr algn="ctr" indent="0" marL="0">
+                        <a:buNone/>
+                      </a:pPr>
+                      <a:r>
+                        <a:rPr lang="en-US" sz="1000" dirty="0">
+                          <a:solidFill>
+                            <a:schemeClr val="tx1"/>
+                          </a:solidFill>
+                        </a:rPr>
+                        <a:t>€716 / €1,929 · 0.4 T</a:t>
                       </a:r>
                       <a:endParaRPr lang="en-US" sz="1000" dirty="0"/>
                     </a:p>
@@ -15174,7 +16141,7 @@
                             <a:schemeClr val="tx1"/>
                           </a:solidFill>
                         </a:rPr>
-                        <a:t>€109 / €269 · 2.8 T</a:t>
+                        <a:t>€1,193 / €4,209 · 0.2 T</a:t>
                       </a:r>
                       <a:endParaRPr lang="en-US" sz="1000" dirty="0"/>
                     </a:p>
@@ -15235,7 +16202,7 @@
                             <a:schemeClr val="tx1"/>
                           </a:solidFill>
                         </a:rPr>
-                        <a:t>€375 / €1,282 · 0.6 T</a:t>
+                        <a:t>€1,492 / €6,268 · 0.1 T</a:t>
                       </a:r>
                       <a:endParaRPr lang="en-US" sz="1000" dirty="0"/>
                     </a:p>
@@ -15282,6 +16249,66 @@
                     </a:solidFill>
                   </a:tcPr>
                 </a:tc>
+              </a:tr>
+              <a:tr h="329184">
+                <a:tc>
+                  <a:txBody>
+                    <a:bodyPr/>
+                    <a:lstStyle/>
+                    <a:p>
+                      <a:pPr indent="0" marL="0">
+                        <a:buNone/>
+                      </a:pPr>
+                      <a:r>
+                        <a:rPr lang="en-US" sz="1000" dirty="0">
+                          <a:solidFill>
+                            <a:schemeClr val="tx1"/>
+                          </a:solidFill>
+                        </a:rPr>
+                        <a:t>Programmatic (Indeed, Jooble, Talent.com…)</a:t>
+                      </a:r>
+                      <a:endParaRPr lang="en-US" sz="1000" dirty="0"/>
+                    </a:p>
+                  </a:txBody>
+                  <a:tcPr marL="91440" marR="91440" marT="45720" marB="45720" anchor="ctr">
+                    <a:lnL w="6350" cap="flat" cmpd="sng" algn="ctr">
+                      <a:solidFill>
+                        <a:srgbClr val="D6DEE5"/>
+                      </a:solidFill>
+                      <a:prstDash val="solid"/>
+                      <a:round/>
+                      <a:headEnd type="none" w="med" len="med"/>
+                      <a:tailEnd type="none" w="med" len="med"/>
+                    </a:lnL>
+                    <a:lnR w="6350" cap="flat" cmpd="sng" algn="ctr">
+                      <a:solidFill>
+                        <a:srgbClr val="D6DEE5"/>
+                      </a:solidFill>
+                      <a:prstDash val="solid"/>
+                      <a:round/>
+                      <a:headEnd type="none" w="med" len="med"/>
+                      <a:tailEnd type="none" w="med" len="med"/>
+                    </a:lnR>
+                    <a:lnT w="6350" cap="flat" cmpd="sng" algn="ctr">
+                      <a:solidFill>
+                        <a:srgbClr val="D6DEE5"/>
+                      </a:solidFill>
+                      <a:prstDash val="solid"/>
+                      <a:round/>
+                      <a:headEnd type="none" w="med" len="med"/>
+                      <a:tailEnd type="none" w="med" len="med"/>
+                    </a:lnT>
+                    <a:lnB w="6350" cap="flat" cmpd="sng" algn="ctr">
+                      <a:solidFill>
+                        <a:srgbClr val="D6DEE5"/>
+                      </a:solidFill>
+                      <a:prstDash val="solid"/>
+                      <a:round/>
+                      <a:headEnd type="none" w="med" len="med"/>
+                      <a:tailEnd type="none" w="med" len="med"/>
+                    </a:lnB>
+                  </a:tcPr>
+                </a:tc>
                 <a:tc>
                   <a:txBody>
                     <a:bodyPr/>
@@ -15296,7 +16323,7 @@
                             <a:schemeClr val="tx1"/>
                           </a:solidFill>
                         </a:rPr>
-                        <a:t>€425 / €1,587 · 0.5 T</a:t>
+                        <a:t>€1,342 / €4,259 · 0.2 T</a:t>
                       </a:r>
                       <a:endParaRPr lang="en-US" sz="1000" dirty="0"/>
                     </a:p>
@@ -15343,6 +16370,189 @@
                     </a:solidFill>
                   </a:tcPr>
                 </a:tc>
+                <a:tc>
+                  <a:txBody>
+                    <a:bodyPr/>
+                    <a:lstStyle/>
+                    <a:p>
+                      <a:pPr algn="ctr" indent="0" marL="0">
+                        <a:buNone/>
+                      </a:pPr>
+                      <a:r>
+                        <a:rPr lang="en-US" sz="1000" dirty="0">
+                          <a:solidFill>
+                            <a:schemeClr val="tx1"/>
+                          </a:solidFill>
+                        </a:rPr>
+                        <a:t>€732 / €1,971 · 0.4 T</a:t>
+                      </a:r>
+                      <a:endParaRPr lang="en-US" sz="1000" dirty="0"/>
+                    </a:p>
+                  </a:txBody>
+                  <a:tcPr marL="91440" marR="91440" marT="45720" marB="45720" anchor="ctr">
+                    <a:lnL w="6350" cap="flat" cmpd="sng" algn="ctr">
+                      <a:solidFill>
+                        <a:srgbClr val="D6DEE5"/>
+                      </a:solidFill>
+                      <a:prstDash val="solid"/>
+                      <a:round/>
+                      <a:headEnd type="none" w="med" len="med"/>
+                      <a:tailEnd type="none" w="med" len="med"/>
+                    </a:lnL>
+                    <a:lnR w="6350" cap="flat" cmpd="sng" algn="ctr">
+                      <a:solidFill>
+                        <a:srgbClr val="D6DEE5"/>
+                      </a:solidFill>
+                      <a:prstDash val="solid"/>
+                      <a:round/>
+                      <a:headEnd type="none" w="med" len="med"/>
+                      <a:tailEnd type="none" w="med" len="med"/>
+                    </a:lnR>
+                    <a:lnT w="6350" cap="flat" cmpd="sng" algn="ctr">
+                      <a:solidFill>
+                        <a:srgbClr val="D6DEE5"/>
+                      </a:solidFill>
+                      <a:prstDash val="solid"/>
+                      <a:round/>
+                      <a:headEnd type="none" w="med" len="med"/>
+                      <a:tailEnd type="none" w="med" len="med"/>
+                    </a:lnT>
+                    <a:lnB w="6350" cap="flat" cmpd="sng" algn="ctr">
+                      <a:solidFill>
+                        <a:srgbClr val="D6DEE5"/>
+                      </a:solidFill>
+                      <a:prstDash val="solid"/>
+                      <a:round/>
+                      <a:headEnd type="none" w="med" len="med"/>
+                      <a:tailEnd type="none" w="med" len="med"/>
+                    </a:lnB>
+                    <a:solidFill>
+                      <a:srgbClr val="FBEBC8"/>
+                    </a:solidFill>
+                  </a:tcPr>
+                </a:tc>
+                <a:tc>
+                  <a:txBody>
+                    <a:bodyPr/>
+                    <a:lstStyle/>
+                    <a:p>
+                      <a:pPr algn="ctr" indent="0" marL="0">
+                        <a:buNone/>
+                      </a:pPr>
+                      <a:r>
+                        <a:rPr lang="en-US" sz="1000" dirty="0">
+                          <a:solidFill>
+                            <a:schemeClr val="tx1"/>
+                          </a:solidFill>
+                        </a:rPr>
+                        <a:t>€1,342 / €4,733 · 0.2 T</a:t>
+                      </a:r>
+                      <a:endParaRPr lang="en-US" sz="1000" dirty="0"/>
+                    </a:p>
+                  </a:txBody>
+                  <a:tcPr marL="91440" marR="91440" marT="45720" marB="45720" anchor="ctr">
+                    <a:lnL w="6350" cap="flat" cmpd="sng" algn="ctr">
+                      <a:solidFill>
+                        <a:srgbClr val="D6DEE5"/>
+                      </a:solidFill>
+                      <a:prstDash val="solid"/>
+                      <a:round/>
+                      <a:headEnd type="none" w="med" len="med"/>
+                      <a:tailEnd type="none" w="med" len="med"/>
+                    </a:lnL>
+                    <a:lnR w="6350" cap="flat" cmpd="sng" algn="ctr">
+                      <a:solidFill>
+                        <a:srgbClr val="D6DEE5"/>
+                      </a:solidFill>
+                      <a:prstDash val="solid"/>
+                      <a:round/>
+                      <a:headEnd type="none" w="med" len="med"/>
+                      <a:tailEnd type="none" w="med" len="med"/>
+                    </a:lnR>
+                    <a:lnT w="6350" cap="flat" cmpd="sng" algn="ctr">
+                      <a:solidFill>
+                        <a:srgbClr val="D6DEE5"/>
+                      </a:solidFill>
+                      <a:prstDash val="solid"/>
+                      <a:round/>
+                      <a:headEnd type="none" w="med" len="med"/>
+                      <a:tailEnd type="none" w="med" len="med"/>
+                    </a:lnT>
+                    <a:lnB w="6350" cap="flat" cmpd="sng" algn="ctr">
+                      <a:solidFill>
+                        <a:srgbClr val="D6DEE5"/>
+                      </a:solidFill>
+                      <a:prstDash val="solid"/>
+                      <a:round/>
+                      <a:headEnd type="none" w="med" len="med"/>
+                      <a:tailEnd type="none" w="med" len="med"/>
+                    </a:lnB>
+                    <a:solidFill>
+                      <a:srgbClr val="FBEBC8"/>
+                    </a:solidFill>
+                  </a:tcPr>
+                </a:tc>
+                <a:tc>
+                  <a:txBody>
+                    <a:bodyPr/>
+                    <a:lstStyle/>
+                    <a:p>
+                      <a:pPr algn="ctr" indent="0" marL="0">
+                        <a:buNone/>
+                      </a:pPr>
+                      <a:r>
+                        <a:rPr lang="en-US" sz="1000" dirty="0">
+                          <a:solidFill>
+                            <a:schemeClr val="tx1"/>
+                          </a:solidFill>
+                        </a:rPr>
+                        <a:t>€1,610 / €6,765 · 0.1 T</a:t>
+                      </a:r>
+                      <a:endParaRPr lang="en-US" sz="1000" dirty="0"/>
+                    </a:p>
+                  </a:txBody>
+                  <a:tcPr marL="91440" marR="91440" marT="45720" marB="45720" anchor="ctr">
+                    <a:lnL w="6350" cap="flat" cmpd="sng" algn="ctr">
+                      <a:solidFill>
+                        <a:srgbClr val="D6DEE5"/>
+                      </a:solidFill>
+                      <a:prstDash val="solid"/>
+                      <a:round/>
+                      <a:headEnd type="none" w="med" len="med"/>
+                      <a:tailEnd type="none" w="med" len="med"/>
+                    </a:lnL>
+                    <a:lnR w="6350" cap="flat" cmpd="sng" algn="ctr">
+                      <a:solidFill>
+                        <a:srgbClr val="D6DEE5"/>
+                      </a:solidFill>
+                      <a:prstDash val="solid"/>
+                      <a:round/>
+                      <a:headEnd type="none" w="med" len="med"/>
+                      <a:tailEnd type="none" w="med" len="med"/>
+                    </a:lnR>
+                    <a:lnT w="6350" cap="flat" cmpd="sng" algn="ctr">
+                      <a:solidFill>
+                        <a:srgbClr val="D6DEE5"/>
+                      </a:solidFill>
+                      <a:prstDash val="solid"/>
+                      <a:round/>
+                      <a:headEnd type="none" w="med" len="med"/>
+                      <a:tailEnd type="none" w="med" len="med"/>
+                    </a:lnT>
+                    <a:lnB w="6350" cap="flat" cmpd="sng" algn="ctr">
+                      <a:solidFill>
+                        <a:srgbClr val="D6DEE5"/>
+                      </a:solidFill>
+                      <a:prstDash val="solid"/>
+                      <a:round/>
+                      <a:headEnd type="none" w="med" len="med"/>
+                      <a:tailEnd type="none" w="med" len="med"/>
+                    </a:lnB>
+                    <a:solidFill>
+                      <a:srgbClr val="FBEBC8"/>
+                    </a:solidFill>
+                  </a:tcPr>
+                </a:tc>
               </a:tr>
               <a:tr h="329184">
                 <a:tc>
@@ -15359,7 +16569,7 @@
                             <a:schemeClr val="tx1"/>
                           </a:solidFill>
                         </a:rPr>
-                        <a:t>Google Search (high intent, low volume)</a:t>
+                        <a:t>I2 Handwerk → Industrie (new pool)</a:t>
                       </a:r>
                       <a:endParaRPr lang="en-US" sz="1000" dirty="0"/>
                     </a:p>
@@ -15417,7 +16627,7 @@
                             <a:schemeClr val="tx1"/>
                           </a:solidFill>
                         </a:rPr>
-                        <a:t>€210 / €651 · 3.9</a:t>
+                        <a:t>€560 / €2,349 · 9.5</a:t>
                       </a:r>
                       <a:endParaRPr lang="en-US" sz="1000" dirty="0"/>
                     </a:p>
@@ -15475,10 +16685,10 @@
                       <a:r>
                         <a:rPr lang="en-US" sz="1000" dirty="0">
                           <a:solidFill>
-                            <a:schemeClr val="tx1"/>
-                          </a:solidFill>
-                        </a:rPr>
-                        <a:t>€126 / €310 · 2.4 T</a:t>
+                            <a:schemeClr val="accent4"/>
+                          </a:solidFill>
+                        </a:rPr>
+                        <a:t>–</a:t>
                       </a:r>
                       <a:endParaRPr lang="en-US" sz="1000" dirty="0"/>
                     </a:p>
@@ -15520,9 +16730,6 @@
                       <a:headEnd type="none" w="med" len="med"/>
                       <a:tailEnd type="none" w="med" len="med"/>
                     </a:lnB>
-                    <a:solidFill>
-                      <a:srgbClr val="FBEBC8"/>
-                    </a:solidFill>
                   </a:tcPr>
                 </a:tc>
                 <a:tc>
@@ -15536,10 +16743,10 @@
                       <a:r>
                         <a:rPr lang="en-US" sz="1000" dirty="0">
                           <a:solidFill>
-                            <a:schemeClr val="tx1"/>
-                          </a:solidFill>
-                        </a:rPr>
-                        <a:t>€210 / €716 · 1.0 T</a:t>
+                            <a:schemeClr val="accent4"/>
+                          </a:solidFill>
+                        </a:rPr>
+                        <a:t>–</a:t>
                       </a:r>
                       <a:endParaRPr lang="en-US" sz="1000" dirty="0"/>
                     </a:p>
@@ -15581,9 +16788,6 @@
                       <a:headEnd type="none" w="med" len="med"/>
                       <a:tailEnd type="none" w="med" len="med"/>
                     </a:lnB>
-                    <a:solidFill>
-                      <a:srgbClr val="FBEBC8"/>
-                    </a:solidFill>
                   </a:tcPr>
                 </a:tc>
                 <a:tc>
@@ -15597,10 +16801,10 @@
                       <a:r>
                         <a:rPr lang="en-US" sz="1000" dirty="0">
                           <a:solidFill>
-                            <a:schemeClr val="tx1"/>
-                          </a:solidFill>
-                        </a:rPr>
-                        <a:t>€262 / €978 · 1.0</a:t>
+                            <a:schemeClr val="accent4"/>
+                          </a:solidFill>
+                        </a:rPr>
+                        <a:t>–</a:t>
                       </a:r>
                       <a:endParaRPr lang="en-US" sz="1000" dirty="0"/>
                     </a:p>
@@ -15642,1210 +16846,6 @@
                       <a:headEnd type="none" w="med" len="med"/>
                       <a:tailEnd type="none" w="med" len="med"/>
                     </a:lnB>
-                    <a:solidFill>
-                      <a:srgbClr val="DCEFE8"/>
-                    </a:solidFill>
-                  </a:tcPr>
-                </a:tc>
-              </a:tr>
-              <a:tr h="329184">
-                <a:tc>
-                  <a:txBody>
-                    <a:bodyPr/>
-                    <a:lstStyle/>
-                    <a:p>
-                      <a:pPr indent="0" marL="0">
-                        <a:buNone/>
-                      </a:pPr>
-                      <a:r>
-                        <a:rPr lang="en-US" sz="1000" dirty="0">
-                          <a:solidFill>
-                            <a:schemeClr val="tx1"/>
-                          </a:solidFill>
-                        </a:rPr>
-                        <a:t>LinkedIn (PLC/TIA and Meister profiles)</a:t>
-                      </a:r>
-                      <a:endParaRPr lang="en-US" sz="1000" dirty="0"/>
-                    </a:p>
-                  </a:txBody>
-                  <a:tcPr marL="91440" marR="91440" marT="45720" marB="45720" anchor="ctr">
-                    <a:lnL w="6350" cap="flat" cmpd="sng" algn="ctr">
-                      <a:solidFill>
-                        <a:srgbClr val="D6DEE5"/>
-                      </a:solidFill>
-                      <a:prstDash val="solid"/>
-                      <a:round/>
-                      <a:headEnd type="none" w="med" len="med"/>
-                      <a:tailEnd type="none" w="med" len="med"/>
-                    </a:lnL>
-                    <a:lnR w="6350" cap="flat" cmpd="sng" algn="ctr">
-                      <a:solidFill>
-                        <a:srgbClr val="D6DEE5"/>
-                      </a:solidFill>
-                      <a:prstDash val="solid"/>
-                      <a:round/>
-                      <a:headEnd type="none" w="med" len="med"/>
-                      <a:tailEnd type="none" w="med" len="med"/>
-                    </a:lnR>
-                    <a:lnT w="6350" cap="flat" cmpd="sng" algn="ctr">
-                      <a:solidFill>
-                        <a:srgbClr val="D6DEE5"/>
-                      </a:solidFill>
-                      <a:prstDash val="solid"/>
-                      <a:round/>
-                      <a:headEnd type="none" w="med" len="med"/>
-                      <a:tailEnd type="none" w="med" len="med"/>
-                    </a:lnT>
-                    <a:lnB w="6350" cap="flat" cmpd="sng" algn="ctr">
-                      <a:solidFill>
-                        <a:srgbClr val="D6DEE5"/>
-                      </a:solidFill>
-                      <a:prstDash val="solid"/>
-                      <a:round/>
-                      <a:headEnd type="none" w="med" len="med"/>
-                      <a:tailEnd type="none" w="med" len="med"/>
-                    </a:lnB>
-                  </a:tcPr>
-                </a:tc>
-                <a:tc>
-                  <a:txBody>
-                    <a:bodyPr/>
-                    <a:lstStyle/>
-                    <a:p>
-                      <a:pPr algn="ctr" indent="0" marL="0">
-                        <a:buNone/>
-                      </a:pPr>
-                      <a:r>
-                        <a:rPr lang="en-US" sz="1000" dirty="0">
-                          <a:solidFill>
-                            <a:schemeClr val="accent4"/>
-                          </a:solidFill>
-                        </a:rPr>
-                        <a:t>–</a:t>
-                      </a:r>
-                      <a:endParaRPr lang="en-US" sz="1000" dirty="0"/>
-                    </a:p>
-                  </a:txBody>
-                  <a:tcPr marL="91440" marR="91440" marT="45720" marB="45720" anchor="ctr">
-                    <a:lnL w="6350" cap="flat" cmpd="sng" algn="ctr">
-                      <a:solidFill>
-                        <a:srgbClr val="D6DEE5"/>
-                      </a:solidFill>
-                      <a:prstDash val="solid"/>
-                      <a:round/>
-                      <a:headEnd type="none" w="med" len="med"/>
-                      <a:tailEnd type="none" w="med" len="med"/>
-                    </a:lnL>
-                    <a:lnR w="6350" cap="flat" cmpd="sng" algn="ctr">
-                      <a:solidFill>
-                        <a:srgbClr val="D6DEE5"/>
-                      </a:solidFill>
-                      <a:prstDash val="solid"/>
-                      <a:round/>
-                      <a:headEnd type="none" w="med" len="med"/>
-                      <a:tailEnd type="none" w="med" len="med"/>
-                    </a:lnR>
-                    <a:lnT w="6350" cap="flat" cmpd="sng" algn="ctr">
-                      <a:solidFill>
-                        <a:srgbClr val="D6DEE5"/>
-                      </a:solidFill>
-                      <a:prstDash val="solid"/>
-                      <a:round/>
-                      <a:headEnd type="none" w="med" len="med"/>
-                      <a:tailEnd type="none" w="med" len="med"/>
-                    </a:lnT>
-                    <a:lnB w="6350" cap="flat" cmpd="sng" algn="ctr">
-                      <a:solidFill>
-                        <a:srgbClr val="D6DEE5"/>
-                      </a:solidFill>
-                      <a:prstDash val="solid"/>
-                      <a:round/>
-                      <a:headEnd type="none" w="med" len="med"/>
-                      <a:tailEnd type="none" w="med" len="med"/>
-                    </a:lnB>
-                  </a:tcPr>
-                </a:tc>
-                <a:tc>
-                  <a:txBody>
-                    <a:bodyPr/>
-                    <a:lstStyle/>
-                    <a:p>
-                      <a:pPr algn="ctr" indent="0" marL="0">
-                        <a:buNone/>
-                      </a:pPr>
-                      <a:r>
-                        <a:rPr lang="en-US" sz="1000" dirty="0">
-                          <a:solidFill>
-                            <a:schemeClr val="accent4"/>
-                          </a:solidFill>
-                        </a:rPr>
-                        <a:t>–</a:t>
-                      </a:r>
-                      <a:endParaRPr lang="en-US" sz="1000" dirty="0"/>
-                    </a:p>
-                  </a:txBody>
-                  <a:tcPr marL="91440" marR="91440" marT="45720" marB="45720" anchor="ctr">
-                    <a:lnL w="6350" cap="flat" cmpd="sng" algn="ctr">
-                      <a:solidFill>
-                        <a:srgbClr val="D6DEE5"/>
-                      </a:solidFill>
-                      <a:prstDash val="solid"/>
-                      <a:round/>
-                      <a:headEnd type="none" w="med" len="med"/>
-                      <a:tailEnd type="none" w="med" len="med"/>
-                    </a:lnL>
-                    <a:lnR w="6350" cap="flat" cmpd="sng" algn="ctr">
-                      <a:solidFill>
-                        <a:srgbClr val="D6DEE5"/>
-                      </a:solidFill>
-                      <a:prstDash val="solid"/>
-                      <a:round/>
-                      <a:headEnd type="none" w="med" len="med"/>
-                      <a:tailEnd type="none" w="med" len="med"/>
-                    </a:lnR>
-                    <a:lnT w="6350" cap="flat" cmpd="sng" algn="ctr">
-                      <a:solidFill>
-                        <a:srgbClr val="D6DEE5"/>
-                      </a:solidFill>
-                      <a:prstDash val="solid"/>
-                      <a:round/>
-                      <a:headEnd type="none" w="med" len="med"/>
-                      <a:tailEnd type="none" w="med" len="med"/>
-                    </a:lnT>
-                    <a:lnB w="6350" cap="flat" cmpd="sng" algn="ctr">
-                      <a:solidFill>
-                        <a:srgbClr val="D6DEE5"/>
-                      </a:solidFill>
-                      <a:prstDash val="solid"/>
-                      <a:round/>
-                      <a:headEnd type="none" w="med" len="med"/>
-                      <a:tailEnd type="none" w="med" len="med"/>
-                    </a:lnB>
-                  </a:tcPr>
-                </a:tc>
-                <a:tc>
-                  <a:txBody>
-                    <a:bodyPr/>
-                    <a:lstStyle/>
-                    <a:p>
-                      <a:pPr algn="ctr" indent="0" marL="0">
-                        <a:buNone/>
-                      </a:pPr>
-                      <a:r>
-                        <a:rPr lang="en-US" sz="1000" dirty="0">
-                          <a:solidFill>
-                            <a:schemeClr val="tx1"/>
-                          </a:solidFill>
-                        </a:rPr>
-                        <a:t>€175 / €598 · 8.6</a:t>
-                      </a:r>
-                      <a:endParaRPr lang="en-US" sz="1000" dirty="0"/>
-                    </a:p>
-                  </a:txBody>
-                  <a:tcPr marL="91440" marR="91440" marT="45720" marB="45720" anchor="ctr">
-                    <a:lnL w="6350" cap="flat" cmpd="sng" algn="ctr">
-                      <a:solidFill>
-                        <a:srgbClr val="D6DEE5"/>
-                      </a:solidFill>
-                      <a:prstDash val="solid"/>
-                      <a:round/>
-                      <a:headEnd type="none" w="med" len="med"/>
-                      <a:tailEnd type="none" w="med" len="med"/>
-                    </a:lnL>
-                    <a:lnR w="6350" cap="flat" cmpd="sng" algn="ctr">
-                      <a:solidFill>
-                        <a:srgbClr val="D6DEE5"/>
-                      </a:solidFill>
-                      <a:prstDash val="solid"/>
-                      <a:round/>
-                      <a:headEnd type="none" w="med" len="med"/>
-                      <a:tailEnd type="none" w="med" len="med"/>
-                    </a:lnR>
-                    <a:lnT w="6350" cap="flat" cmpd="sng" algn="ctr">
-                      <a:solidFill>
-                        <a:srgbClr val="D6DEE5"/>
-                      </a:solidFill>
-                      <a:prstDash val="solid"/>
-                      <a:round/>
-                      <a:headEnd type="none" w="med" len="med"/>
-                      <a:tailEnd type="none" w="med" len="med"/>
-                    </a:lnT>
-                    <a:lnB w="6350" cap="flat" cmpd="sng" algn="ctr">
-                      <a:solidFill>
-                        <a:srgbClr val="D6DEE5"/>
-                      </a:solidFill>
-                      <a:prstDash val="solid"/>
-                      <a:round/>
-                      <a:headEnd type="none" w="med" len="med"/>
-                      <a:tailEnd type="none" w="med" len="med"/>
-                    </a:lnB>
-                    <a:solidFill>
-                      <a:srgbClr val="DCEFE8"/>
-                    </a:solidFill>
-                  </a:tcPr>
-                </a:tc>
-                <a:tc>
-                  <a:txBody>
-                    <a:bodyPr/>
-                    <a:lstStyle/>
-                    <a:p>
-                      <a:pPr algn="ctr" indent="0" marL="0">
-                        <a:buNone/>
-                      </a:pPr>
-                      <a:r>
-                        <a:rPr lang="en-US" sz="1000" dirty="0">
-                          <a:solidFill>
-                            <a:schemeClr val="tx1"/>
-                          </a:solidFill>
-                        </a:rPr>
-                        <a:t>€219 / €817 · 5.4</a:t>
-                      </a:r>
-                      <a:endParaRPr lang="en-US" sz="1000" dirty="0"/>
-                    </a:p>
-                  </a:txBody>
-                  <a:tcPr marL="91440" marR="91440" marT="45720" marB="45720" anchor="ctr">
-                    <a:lnL w="6350" cap="flat" cmpd="sng" algn="ctr">
-                      <a:solidFill>
-                        <a:srgbClr val="D6DEE5"/>
-                      </a:solidFill>
-                      <a:prstDash val="solid"/>
-                      <a:round/>
-                      <a:headEnd type="none" w="med" len="med"/>
-                      <a:tailEnd type="none" w="med" len="med"/>
-                    </a:lnL>
-                    <a:lnR w="6350" cap="flat" cmpd="sng" algn="ctr">
-                      <a:solidFill>
-                        <a:srgbClr val="D6DEE5"/>
-                      </a:solidFill>
-                      <a:prstDash val="solid"/>
-                      <a:round/>
-                      <a:headEnd type="none" w="med" len="med"/>
-                      <a:tailEnd type="none" w="med" len="med"/>
-                    </a:lnR>
-                    <a:lnT w="6350" cap="flat" cmpd="sng" algn="ctr">
-                      <a:solidFill>
-                        <a:srgbClr val="D6DEE5"/>
-                      </a:solidFill>
-                      <a:prstDash val="solid"/>
-                      <a:round/>
-                      <a:headEnd type="none" w="med" len="med"/>
-                      <a:tailEnd type="none" w="med" len="med"/>
-                    </a:lnT>
-                    <a:lnB w="6350" cap="flat" cmpd="sng" algn="ctr">
-                      <a:solidFill>
-                        <a:srgbClr val="D6DEE5"/>
-                      </a:solidFill>
-                      <a:prstDash val="solid"/>
-                      <a:round/>
-                      <a:headEnd type="none" w="med" len="med"/>
-                      <a:tailEnd type="none" w="med" len="med"/>
-                    </a:lnB>
-                    <a:solidFill>
-                      <a:srgbClr val="DCEFE8"/>
-                    </a:solidFill>
-                  </a:tcPr>
-                </a:tc>
-              </a:tr>
-              <a:tr h="329184">
-                <a:tc>
-                  <a:txBody>
-                    <a:bodyPr/>
-                    <a:lstStyle/>
-                    <a:p>
-                      <a:pPr indent="0" marL="0">
-                        <a:buNone/>
-                      </a:pPr>
-                      <a:r>
-                        <a:rPr lang="en-US" sz="1000" dirty="0">
-                          <a:solidFill>
-                            <a:schemeClr val="tx1"/>
-                          </a:solidFill>
-                        </a:rPr>
-                        <a:t>I2 Handwerk → Industrie (new pool)</a:t>
-                      </a:r>
-                      <a:endParaRPr lang="en-US" sz="1000" dirty="0"/>
-                    </a:p>
-                  </a:txBody>
-                  <a:tcPr marL="91440" marR="91440" marT="45720" marB="45720" anchor="ctr">
-                    <a:lnL w="6350" cap="flat" cmpd="sng" algn="ctr">
-                      <a:solidFill>
-                        <a:srgbClr val="D6DEE5"/>
-                      </a:solidFill>
-                      <a:prstDash val="solid"/>
-                      <a:round/>
-                      <a:headEnd type="none" w="med" len="med"/>
-                      <a:tailEnd type="none" w="med" len="med"/>
-                    </a:lnL>
-                    <a:lnR w="6350" cap="flat" cmpd="sng" algn="ctr">
-                      <a:solidFill>
-                        <a:srgbClr val="D6DEE5"/>
-                      </a:solidFill>
-                      <a:prstDash val="solid"/>
-                      <a:round/>
-                      <a:headEnd type="none" w="med" len="med"/>
-                      <a:tailEnd type="none" w="med" len="med"/>
-                    </a:lnR>
-                    <a:lnT w="6350" cap="flat" cmpd="sng" algn="ctr">
-                      <a:solidFill>
-                        <a:srgbClr val="D6DEE5"/>
-                      </a:solidFill>
-                      <a:prstDash val="solid"/>
-                      <a:round/>
-                      <a:headEnd type="none" w="med" len="med"/>
-                      <a:tailEnd type="none" w="med" len="med"/>
-                    </a:lnT>
-                    <a:lnB w="6350" cap="flat" cmpd="sng" algn="ctr">
-                      <a:solidFill>
-                        <a:srgbClr val="D6DEE5"/>
-                      </a:solidFill>
-                      <a:prstDash val="solid"/>
-                      <a:round/>
-                      <a:headEnd type="none" w="med" len="med"/>
-                      <a:tailEnd type="none" w="med" len="med"/>
-                    </a:lnB>
-                  </a:tcPr>
-                </a:tc>
-                <a:tc>
-                  <a:txBody>
-                    <a:bodyPr/>
-                    <a:lstStyle/>
-                    <a:p>
-                      <a:pPr algn="ctr" indent="0" marL="0">
-                        <a:buNone/>
-                      </a:pPr>
-                      <a:r>
-                        <a:rPr lang="en-US" sz="1000" dirty="0">
-                          <a:solidFill>
-                            <a:schemeClr val="tx1"/>
-                          </a:solidFill>
-                        </a:rPr>
-                        <a:t>€200 / €881 · 11.6</a:t>
-                      </a:r>
-                      <a:endParaRPr lang="en-US" sz="1000" dirty="0"/>
-                    </a:p>
-                  </a:txBody>
-                  <a:tcPr marL="91440" marR="91440" marT="45720" marB="45720" anchor="ctr">
-                    <a:lnL w="6350" cap="flat" cmpd="sng" algn="ctr">
-                      <a:solidFill>
-                        <a:srgbClr val="D6DEE5"/>
-                      </a:solidFill>
-                      <a:prstDash val="solid"/>
-                      <a:round/>
-                      <a:headEnd type="none" w="med" len="med"/>
-                      <a:tailEnd type="none" w="med" len="med"/>
-                    </a:lnL>
-                    <a:lnR w="6350" cap="flat" cmpd="sng" algn="ctr">
-                      <a:solidFill>
-                        <a:srgbClr val="D6DEE5"/>
-                      </a:solidFill>
-                      <a:prstDash val="solid"/>
-                      <a:round/>
-                      <a:headEnd type="none" w="med" len="med"/>
-                      <a:tailEnd type="none" w="med" len="med"/>
-                    </a:lnR>
-                    <a:lnT w="6350" cap="flat" cmpd="sng" algn="ctr">
-                      <a:solidFill>
-                        <a:srgbClr val="D6DEE5"/>
-                      </a:solidFill>
-                      <a:prstDash val="solid"/>
-                      <a:round/>
-                      <a:headEnd type="none" w="med" len="med"/>
-                      <a:tailEnd type="none" w="med" len="med"/>
-                    </a:lnT>
-                    <a:lnB w="6350" cap="flat" cmpd="sng" algn="ctr">
-                      <a:solidFill>
-                        <a:srgbClr val="D6DEE5"/>
-                      </a:solidFill>
-                      <a:prstDash val="solid"/>
-                      <a:round/>
-                      <a:headEnd type="none" w="med" len="med"/>
-                      <a:tailEnd type="none" w="med" len="med"/>
-                    </a:lnB>
-                    <a:solidFill>
-                      <a:srgbClr val="DCEFE8"/>
-                    </a:solidFill>
-                  </a:tcPr>
-                </a:tc>
-                <a:tc>
-                  <a:txBody>
-                    <a:bodyPr/>
-                    <a:lstStyle/>
-                    <a:p>
-                      <a:pPr algn="ctr" indent="0" marL="0">
-                        <a:buNone/>
-                      </a:pPr>
-                      <a:r>
-                        <a:rPr lang="en-US" sz="1000" dirty="0">
-                          <a:solidFill>
-                            <a:schemeClr val="accent4"/>
-                          </a:solidFill>
-                        </a:rPr>
-                        <a:t>–</a:t>
-                      </a:r>
-                      <a:endParaRPr lang="en-US" sz="1000" dirty="0"/>
-                    </a:p>
-                  </a:txBody>
-                  <a:tcPr marL="91440" marR="91440" marT="45720" marB="45720" anchor="ctr">
-                    <a:lnL w="6350" cap="flat" cmpd="sng" algn="ctr">
-                      <a:solidFill>
-                        <a:srgbClr val="D6DEE5"/>
-                      </a:solidFill>
-                      <a:prstDash val="solid"/>
-                      <a:round/>
-                      <a:headEnd type="none" w="med" len="med"/>
-                      <a:tailEnd type="none" w="med" len="med"/>
-                    </a:lnL>
-                    <a:lnR w="6350" cap="flat" cmpd="sng" algn="ctr">
-                      <a:solidFill>
-                        <a:srgbClr val="D6DEE5"/>
-                      </a:solidFill>
-                      <a:prstDash val="solid"/>
-                      <a:round/>
-                      <a:headEnd type="none" w="med" len="med"/>
-                      <a:tailEnd type="none" w="med" len="med"/>
-                    </a:lnR>
-                    <a:lnT w="6350" cap="flat" cmpd="sng" algn="ctr">
-                      <a:solidFill>
-                        <a:srgbClr val="D6DEE5"/>
-                      </a:solidFill>
-                      <a:prstDash val="solid"/>
-                      <a:round/>
-                      <a:headEnd type="none" w="med" len="med"/>
-                      <a:tailEnd type="none" w="med" len="med"/>
-                    </a:lnT>
-                    <a:lnB w="6350" cap="flat" cmpd="sng" algn="ctr">
-                      <a:solidFill>
-                        <a:srgbClr val="D6DEE5"/>
-                      </a:solidFill>
-                      <a:prstDash val="solid"/>
-                      <a:round/>
-                      <a:headEnd type="none" w="med" len="med"/>
-                      <a:tailEnd type="none" w="med" len="med"/>
-                    </a:lnB>
-                  </a:tcPr>
-                </a:tc>
-                <a:tc>
-                  <a:txBody>
-                    <a:bodyPr/>
-                    <a:lstStyle/>
-                    <a:p>
-                      <a:pPr algn="ctr" indent="0" marL="0">
-                        <a:buNone/>
-                      </a:pPr>
-                      <a:r>
-                        <a:rPr lang="en-US" sz="1000" dirty="0">
-                          <a:solidFill>
-                            <a:schemeClr val="accent4"/>
-                          </a:solidFill>
-                        </a:rPr>
-                        <a:t>–</a:t>
-                      </a:r>
-                      <a:endParaRPr lang="en-US" sz="1000" dirty="0"/>
-                    </a:p>
-                  </a:txBody>
-                  <a:tcPr marL="91440" marR="91440" marT="45720" marB="45720" anchor="ctr">
-                    <a:lnL w="6350" cap="flat" cmpd="sng" algn="ctr">
-                      <a:solidFill>
-                        <a:srgbClr val="D6DEE5"/>
-                      </a:solidFill>
-                      <a:prstDash val="solid"/>
-                      <a:round/>
-                      <a:headEnd type="none" w="med" len="med"/>
-                      <a:tailEnd type="none" w="med" len="med"/>
-                    </a:lnL>
-                    <a:lnR w="6350" cap="flat" cmpd="sng" algn="ctr">
-                      <a:solidFill>
-                        <a:srgbClr val="D6DEE5"/>
-                      </a:solidFill>
-                      <a:prstDash val="solid"/>
-                      <a:round/>
-                      <a:headEnd type="none" w="med" len="med"/>
-                      <a:tailEnd type="none" w="med" len="med"/>
-                    </a:lnR>
-                    <a:lnT w="6350" cap="flat" cmpd="sng" algn="ctr">
-                      <a:solidFill>
-                        <a:srgbClr val="D6DEE5"/>
-                      </a:solidFill>
-                      <a:prstDash val="solid"/>
-                      <a:round/>
-                      <a:headEnd type="none" w="med" len="med"/>
-                      <a:tailEnd type="none" w="med" len="med"/>
-                    </a:lnT>
-                    <a:lnB w="6350" cap="flat" cmpd="sng" algn="ctr">
-                      <a:solidFill>
-                        <a:srgbClr val="D6DEE5"/>
-                      </a:solidFill>
-                      <a:prstDash val="solid"/>
-                      <a:round/>
-                      <a:headEnd type="none" w="med" len="med"/>
-                      <a:tailEnd type="none" w="med" len="med"/>
-                    </a:lnB>
-                  </a:tcPr>
-                </a:tc>
-                <a:tc>
-                  <a:txBody>
-                    <a:bodyPr/>
-                    <a:lstStyle/>
-                    <a:p>
-                      <a:pPr algn="ctr" indent="0" marL="0">
-                        <a:buNone/>
-                      </a:pPr>
-                      <a:r>
-                        <a:rPr lang="en-US" sz="1000" dirty="0">
-                          <a:solidFill>
-                            <a:schemeClr val="accent4"/>
-                          </a:solidFill>
-                        </a:rPr>
-                        <a:t>–</a:t>
-                      </a:r>
-                      <a:endParaRPr lang="en-US" sz="1000" dirty="0"/>
-                    </a:p>
-                  </a:txBody>
-                  <a:tcPr marL="91440" marR="91440" marT="45720" marB="45720" anchor="ctr">
-                    <a:lnL w="6350" cap="flat" cmpd="sng" algn="ctr">
-                      <a:solidFill>
-                        <a:srgbClr val="D6DEE5"/>
-                      </a:solidFill>
-                      <a:prstDash val="solid"/>
-                      <a:round/>
-                      <a:headEnd type="none" w="med" len="med"/>
-                      <a:tailEnd type="none" w="med" len="med"/>
-                    </a:lnL>
-                    <a:lnR w="6350" cap="flat" cmpd="sng" algn="ctr">
-                      <a:solidFill>
-                        <a:srgbClr val="D6DEE5"/>
-                      </a:solidFill>
-                      <a:prstDash val="solid"/>
-                      <a:round/>
-                      <a:headEnd type="none" w="med" len="med"/>
-                      <a:tailEnd type="none" w="med" len="med"/>
-                    </a:lnR>
-                    <a:lnT w="6350" cap="flat" cmpd="sng" algn="ctr">
-                      <a:solidFill>
-                        <a:srgbClr val="D6DEE5"/>
-                      </a:solidFill>
-                      <a:prstDash val="solid"/>
-                      <a:round/>
-                      <a:headEnd type="none" w="med" len="med"/>
-                      <a:tailEnd type="none" w="med" len="med"/>
-                    </a:lnT>
-                    <a:lnB w="6350" cap="flat" cmpd="sng" algn="ctr">
-                      <a:solidFill>
-                        <a:srgbClr val="D6DEE5"/>
-                      </a:solidFill>
-                      <a:prstDash val="solid"/>
-                      <a:round/>
-                      <a:headEnd type="none" w="med" len="med"/>
-                      <a:tailEnd type="none" w="med" len="med"/>
-                    </a:lnB>
-                  </a:tcPr>
-                </a:tc>
-              </a:tr>
-              <a:tr h="329184">
-                <a:tc>
-                  <a:txBody>
-                    <a:bodyPr/>
-                    <a:lstStyle/>
-                    <a:p>
-                      <a:pPr indent="0" marL="0">
-                        <a:buNone/>
-                      </a:pPr>
-                      <a:r>
-                        <a:rPr lang="en-US" sz="1000" dirty="0">
-                          <a:solidFill>
-                            <a:schemeClr val="tx1"/>
-                          </a:solidFill>
-                        </a:rPr>
-                        <a:t>I1b Referrals (€1,000 bonus on hire)</a:t>
-                      </a:r>
-                      <a:endParaRPr lang="en-US" sz="1000" dirty="0"/>
-                    </a:p>
-                  </a:txBody>
-                  <a:tcPr marL="91440" marR="91440" marT="45720" marB="45720" anchor="ctr">
-                    <a:lnL w="6350" cap="flat" cmpd="sng" algn="ctr">
-                      <a:solidFill>
-                        <a:srgbClr val="D6DEE5"/>
-                      </a:solidFill>
-                      <a:prstDash val="solid"/>
-                      <a:round/>
-                      <a:headEnd type="none" w="med" len="med"/>
-                      <a:tailEnd type="none" w="med" len="med"/>
-                    </a:lnL>
-                    <a:lnR w="6350" cap="flat" cmpd="sng" algn="ctr">
-                      <a:solidFill>
-                        <a:srgbClr val="D6DEE5"/>
-                      </a:solidFill>
-                      <a:prstDash val="solid"/>
-                      <a:round/>
-                      <a:headEnd type="none" w="med" len="med"/>
-                      <a:tailEnd type="none" w="med" len="med"/>
-                    </a:lnR>
-                    <a:lnT w="6350" cap="flat" cmpd="sng" algn="ctr">
-                      <a:solidFill>
-                        <a:srgbClr val="D6DEE5"/>
-                      </a:solidFill>
-                      <a:prstDash val="solid"/>
-                      <a:round/>
-                      <a:headEnd type="none" w="med" len="med"/>
-                      <a:tailEnd type="none" w="med" len="med"/>
-                    </a:lnT>
-                    <a:lnB w="6350" cap="flat" cmpd="sng" algn="ctr">
-                      <a:solidFill>
-                        <a:srgbClr val="D6DEE5"/>
-                      </a:solidFill>
-                      <a:prstDash val="solid"/>
-                      <a:round/>
-                      <a:headEnd type="none" w="med" len="med"/>
-                      <a:tailEnd type="none" w="med" len="med"/>
-                    </a:lnB>
-                  </a:tcPr>
-                </a:tc>
-                <a:tc>
-                  <a:txBody>
-                    <a:bodyPr/>
-                    <a:lstStyle/>
-                    <a:p>
-                      <a:pPr algn="ctr" indent="0" marL="0">
-                        <a:buNone/>
-                      </a:pPr>
-                      <a:r>
-                        <a:rPr lang="en-US" sz="1000" dirty="0">
-                          <a:solidFill>
-                            <a:schemeClr val="tx1"/>
-                          </a:solidFill>
-                        </a:rPr>
-                        <a:t>€370 / €1,000 · 4.2</a:t>
-                      </a:r>
-                      <a:endParaRPr lang="en-US" sz="1000" dirty="0"/>
-                    </a:p>
-                  </a:txBody>
-                  <a:tcPr marL="91440" marR="91440" marT="45720" marB="45720" anchor="ctr">
-                    <a:lnL w="6350" cap="flat" cmpd="sng" algn="ctr">
-                      <a:solidFill>
-                        <a:srgbClr val="D6DEE5"/>
-                      </a:solidFill>
-                      <a:prstDash val="solid"/>
-                      <a:round/>
-                      <a:headEnd type="none" w="med" len="med"/>
-                      <a:tailEnd type="none" w="med" len="med"/>
-                    </a:lnL>
-                    <a:lnR w="6350" cap="flat" cmpd="sng" algn="ctr">
-                      <a:solidFill>
-                        <a:srgbClr val="D6DEE5"/>
-                      </a:solidFill>
-                      <a:prstDash val="solid"/>
-                      <a:round/>
-                      <a:headEnd type="none" w="med" len="med"/>
-                      <a:tailEnd type="none" w="med" len="med"/>
-                    </a:lnR>
-                    <a:lnT w="6350" cap="flat" cmpd="sng" algn="ctr">
-                      <a:solidFill>
-                        <a:srgbClr val="D6DEE5"/>
-                      </a:solidFill>
-                      <a:prstDash val="solid"/>
-                      <a:round/>
-                      <a:headEnd type="none" w="med" len="med"/>
-                      <a:tailEnd type="none" w="med" len="med"/>
-                    </a:lnT>
-                    <a:lnB w="6350" cap="flat" cmpd="sng" algn="ctr">
-                      <a:solidFill>
-                        <a:srgbClr val="D6DEE5"/>
-                      </a:solidFill>
-                      <a:prstDash val="solid"/>
-                      <a:round/>
-                      <a:headEnd type="none" w="med" len="med"/>
-                      <a:tailEnd type="none" w="med" len="med"/>
-                    </a:lnB>
-                    <a:solidFill>
-                      <a:srgbClr val="DCEFE8"/>
-                    </a:solidFill>
-                  </a:tcPr>
-                </a:tc>
-                <a:tc>
-                  <a:txBody>
-                    <a:bodyPr/>
-                    <a:lstStyle/>
-                    <a:p>
-                      <a:pPr algn="ctr" indent="0" marL="0">
-                        <a:buNone/>
-                      </a:pPr>
-                      <a:r>
-                        <a:rPr lang="en-US" sz="1000" dirty="0">
-                          <a:solidFill>
-                            <a:schemeClr val="tx1"/>
-                          </a:solidFill>
-                        </a:rPr>
-                        <a:t>€466 / €1,000 · –</a:t>
-                      </a:r>
-                      <a:endParaRPr lang="en-US" sz="1000" dirty="0"/>
-                    </a:p>
-                  </a:txBody>
-                  <a:tcPr marL="91440" marR="91440" marT="45720" marB="45720" anchor="ctr">
-                    <a:lnL w="6350" cap="flat" cmpd="sng" algn="ctr">
-                      <a:solidFill>
-                        <a:srgbClr val="D6DEE5"/>
-                      </a:solidFill>
-                      <a:prstDash val="solid"/>
-                      <a:round/>
-                      <a:headEnd type="none" w="med" len="med"/>
-                      <a:tailEnd type="none" w="med" len="med"/>
-                    </a:lnL>
-                    <a:lnR w="6350" cap="flat" cmpd="sng" algn="ctr">
-                      <a:solidFill>
-                        <a:srgbClr val="D6DEE5"/>
-                      </a:solidFill>
-                      <a:prstDash val="solid"/>
-                      <a:round/>
-                      <a:headEnd type="none" w="med" len="med"/>
-                      <a:tailEnd type="none" w="med" len="med"/>
-                    </a:lnR>
-                    <a:lnT w="6350" cap="flat" cmpd="sng" algn="ctr">
-                      <a:solidFill>
-                        <a:srgbClr val="D6DEE5"/>
-                      </a:solidFill>
-                      <a:prstDash val="solid"/>
-                      <a:round/>
-                      <a:headEnd type="none" w="med" len="med"/>
-                      <a:tailEnd type="none" w="med" len="med"/>
-                    </a:lnT>
-                    <a:lnB w="6350" cap="flat" cmpd="sng" algn="ctr">
-                      <a:solidFill>
-                        <a:srgbClr val="D6DEE5"/>
-                      </a:solidFill>
-                      <a:prstDash val="solid"/>
-                      <a:round/>
-                      <a:headEnd type="none" w="med" len="med"/>
-                      <a:tailEnd type="none" w="med" len="med"/>
-                    </a:lnB>
-                    <a:solidFill>
-                      <a:srgbClr val="F2F4F6"/>
-                    </a:solidFill>
-                  </a:tcPr>
-                </a:tc>
-                <a:tc>
-                  <a:txBody>
-                    <a:bodyPr/>
-                    <a:lstStyle/>
-                    <a:p>
-                      <a:pPr algn="ctr" indent="0" marL="0">
-                        <a:buNone/>
-                      </a:pPr>
-                      <a:r>
-                        <a:rPr lang="en-US" sz="1000" dirty="0">
-                          <a:solidFill>
-                            <a:schemeClr val="tx1"/>
-                          </a:solidFill>
-                        </a:rPr>
-                        <a:t>€336 / €1,000 · –</a:t>
-                      </a:r>
-                      <a:endParaRPr lang="en-US" sz="1000" dirty="0"/>
-                    </a:p>
-                  </a:txBody>
-                  <a:tcPr marL="91440" marR="91440" marT="45720" marB="45720" anchor="ctr">
-                    <a:lnL w="6350" cap="flat" cmpd="sng" algn="ctr">
-                      <a:solidFill>
-                        <a:srgbClr val="D6DEE5"/>
-                      </a:solidFill>
-                      <a:prstDash val="solid"/>
-                      <a:round/>
-                      <a:headEnd type="none" w="med" len="med"/>
-                      <a:tailEnd type="none" w="med" len="med"/>
-                    </a:lnL>
-                    <a:lnR w="6350" cap="flat" cmpd="sng" algn="ctr">
-                      <a:solidFill>
-                        <a:srgbClr val="D6DEE5"/>
-                      </a:solidFill>
-                      <a:prstDash val="solid"/>
-                      <a:round/>
-                      <a:headEnd type="none" w="med" len="med"/>
-                      <a:tailEnd type="none" w="med" len="med"/>
-                    </a:lnR>
-                    <a:lnT w="6350" cap="flat" cmpd="sng" algn="ctr">
-                      <a:solidFill>
-                        <a:srgbClr val="D6DEE5"/>
-                      </a:solidFill>
-                      <a:prstDash val="solid"/>
-                      <a:round/>
-                      <a:headEnd type="none" w="med" len="med"/>
-                      <a:tailEnd type="none" w="med" len="med"/>
-                    </a:lnT>
-                    <a:lnB w="6350" cap="flat" cmpd="sng" algn="ctr">
-                      <a:solidFill>
-                        <a:srgbClr val="D6DEE5"/>
-                      </a:solidFill>
-                      <a:prstDash val="solid"/>
-                      <a:round/>
-                      <a:headEnd type="none" w="med" len="med"/>
-                      <a:tailEnd type="none" w="med" len="med"/>
-                    </a:lnB>
-                    <a:solidFill>
-                      <a:srgbClr val="F2F4F6"/>
-                    </a:solidFill>
-                  </a:tcPr>
-                </a:tc>
-                <a:tc>
-                  <a:txBody>
-                    <a:bodyPr/>
-                    <a:lstStyle/>
-                    <a:p>
-                      <a:pPr algn="ctr" indent="0" marL="0">
-                        <a:buNone/>
-                      </a:pPr>
-                      <a:r>
-                        <a:rPr lang="en-US" sz="1000" dirty="0">
-                          <a:solidFill>
-                            <a:schemeClr val="tx1"/>
-                          </a:solidFill>
-                        </a:rPr>
-                        <a:t>€308 / €1,000 · 0.4</a:t>
-                      </a:r>
-                      <a:endParaRPr lang="en-US" sz="1000" dirty="0"/>
-                    </a:p>
-                  </a:txBody>
-                  <a:tcPr marL="91440" marR="91440" marT="45720" marB="45720" anchor="ctr">
-                    <a:lnL w="6350" cap="flat" cmpd="sng" algn="ctr">
-                      <a:solidFill>
-                        <a:srgbClr val="D6DEE5"/>
-                      </a:solidFill>
-                      <a:prstDash val="solid"/>
-                      <a:round/>
-                      <a:headEnd type="none" w="med" len="med"/>
-                      <a:tailEnd type="none" w="med" len="med"/>
-                    </a:lnL>
-                    <a:lnR w="6350" cap="flat" cmpd="sng" algn="ctr">
-                      <a:solidFill>
-                        <a:srgbClr val="D6DEE5"/>
-                      </a:solidFill>
-                      <a:prstDash val="solid"/>
-                      <a:round/>
-                      <a:headEnd type="none" w="med" len="med"/>
-                      <a:tailEnd type="none" w="med" len="med"/>
-                    </a:lnR>
-                    <a:lnT w="6350" cap="flat" cmpd="sng" algn="ctr">
-                      <a:solidFill>
-                        <a:srgbClr val="D6DEE5"/>
-                      </a:solidFill>
-                      <a:prstDash val="solid"/>
-                      <a:round/>
-                      <a:headEnd type="none" w="med" len="med"/>
-                      <a:tailEnd type="none" w="med" len="med"/>
-                    </a:lnT>
-                    <a:lnB w="6350" cap="flat" cmpd="sng" algn="ctr">
-                      <a:solidFill>
-                        <a:srgbClr val="D6DEE5"/>
-                      </a:solidFill>
-                      <a:prstDash val="solid"/>
-                      <a:round/>
-                      <a:headEnd type="none" w="med" len="med"/>
-                      <a:tailEnd type="none" w="med" len="med"/>
-                    </a:lnB>
-                    <a:solidFill>
-                      <a:srgbClr val="DCEFE8"/>
-                    </a:solidFill>
-                  </a:tcPr>
-                </a:tc>
-              </a:tr>
-              <a:tr h="329184">
-                <a:tc>
-                  <a:txBody>
-                    <a:bodyPr/>
-                    <a:lstStyle/>
-                    <a:p>
-                      <a:pPr indent="0" marL="0">
-                        <a:buNone/>
-                      </a:pPr>
-                      <a:r>
-                        <a:rPr lang="en-US" sz="1000" dirty="0">
-                          <a:solidFill>
-                            <a:schemeClr val="tx1"/>
-                          </a:solidFill>
-                        </a:rPr>
-                        <a:t>StepStone (German, CV-based, €1,449/ad)</a:t>
-                      </a:r>
-                      <a:endParaRPr lang="en-US" sz="1000" dirty="0"/>
-                    </a:p>
-                  </a:txBody>
-                  <a:tcPr marL="91440" marR="91440" marT="45720" marB="45720" anchor="ctr">
-                    <a:lnL w="6350" cap="flat" cmpd="sng" algn="ctr">
-                      <a:solidFill>
-                        <a:srgbClr val="D6DEE5"/>
-                      </a:solidFill>
-                      <a:prstDash val="solid"/>
-                      <a:round/>
-                      <a:headEnd type="none" w="med" len="med"/>
-                      <a:tailEnd type="none" w="med" len="med"/>
-                    </a:lnL>
-                    <a:lnR w="6350" cap="flat" cmpd="sng" algn="ctr">
-                      <a:solidFill>
-                        <a:srgbClr val="D6DEE5"/>
-                      </a:solidFill>
-                      <a:prstDash val="solid"/>
-                      <a:round/>
-                      <a:headEnd type="none" w="med" len="med"/>
-                      <a:tailEnd type="none" w="med" len="med"/>
-                    </a:lnR>
-                    <a:lnT w="6350" cap="flat" cmpd="sng" algn="ctr">
-                      <a:solidFill>
-                        <a:srgbClr val="D6DEE5"/>
-                      </a:solidFill>
-                      <a:prstDash val="solid"/>
-                      <a:round/>
-                      <a:headEnd type="none" w="med" len="med"/>
-                      <a:tailEnd type="none" w="med" len="med"/>
-                    </a:lnT>
-                    <a:lnB w="6350" cap="flat" cmpd="sng" algn="ctr">
-                      <a:solidFill>
-                        <a:srgbClr val="D6DEE5"/>
-                      </a:solidFill>
-                      <a:prstDash val="solid"/>
-                      <a:round/>
-                      <a:headEnd type="none" w="med" len="med"/>
-                      <a:tailEnd type="none" w="med" len="med"/>
-                    </a:lnB>
-                  </a:tcPr>
-                </a:tc>
-                <a:tc>
-                  <a:txBody>
-                    <a:bodyPr/>
-                    <a:lstStyle/>
-                    <a:p>
-                      <a:pPr algn="ctr" indent="0" marL="0">
-                        <a:buNone/>
-                      </a:pPr>
-                      <a:r>
-                        <a:rPr lang="en-US" sz="1000" dirty="0">
-                          <a:solidFill>
-                            <a:schemeClr val="tx1"/>
-                          </a:solidFill>
-                        </a:rPr>
-                        <a:t>€322 / €1,001 · 0.9</a:t>
-                      </a:r>
-                      <a:endParaRPr lang="en-US" sz="1000" dirty="0"/>
-                    </a:p>
-                  </a:txBody>
-                  <a:tcPr marL="91440" marR="91440" marT="45720" marB="45720" anchor="ctr">
-                    <a:lnL w="6350" cap="flat" cmpd="sng" algn="ctr">
-                      <a:solidFill>
-                        <a:srgbClr val="D6DEE5"/>
-                      </a:solidFill>
-                      <a:prstDash val="solid"/>
-                      <a:round/>
-                      <a:headEnd type="none" w="med" len="med"/>
-                      <a:tailEnd type="none" w="med" len="med"/>
-                    </a:lnL>
-                    <a:lnR w="6350" cap="flat" cmpd="sng" algn="ctr">
-                      <a:solidFill>
-                        <a:srgbClr val="D6DEE5"/>
-                      </a:solidFill>
-                      <a:prstDash val="solid"/>
-                      <a:round/>
-                      <a:headEnd type="none" w="med" len="med"/>
-                      <a:tailEnd type="none" w="med" len="med"/>
-                    </a:lnR>
-                    <a:lnT w="6350" cap="flat" cmpd="sng" algn="ctr">
-                      <a:solidFill>
-                        <a:srgbClr val="D6DEE5"/>
-                      </a:solidFill>
-                      <a:prstDash val="solid"/>
-                      <a:round/>
-                      <a:headEnd type="none" w="med" len="med"/>
-                      <a:tailEnd type="none" w="med" len="med"/>
-                    </a:lnT>
-                    <a:lnB w="6350" cap="flat" cmpd="sng" algn="ctr">
-                      <a:solidFill>
-                        <a:srgbClr val="D6DEE5"/>
-                      </a:solidFill>
-                      <a:prstDash val="solid"/>
-                      <a:round/>
-                      <a:headEnd type="none" w="med" len="med"/>
-                      <a:tailEnd type="none" w="med" len="med"/>
-                    </a:lnB>
-                    <a:solidFill>
-                      <a:srgbClr val="DCEFE8"/>
-                    </a:solidFill>
-                  </a:tcPr>
-                </a:tc>
-                <a:tc>
-                  <a:txBody>
-                    <a:bodyPr/>
-                    <a:lstStyle/>
-                    <a:p>
-                      <a:pPr algn="ctr" indent="0" marL="0">
-                        <a:buNone/>
-                      </a:pPr>
-                      <a:r>
-                        <a:rPr lang="en-US" sz="1000" dirty="0">
-                          <a:solidFill>
-                            <a:schemeClr val="tx1"/>
-                          </a:solidFill>
-                        </a:rPr>
-                        <a:t>€166 / €409 · –</a:t>
-                      </a:r>
-                      <a:endParaRPr lang="en-US" sz="1000" dirty="0"/>
-                    </a:p>
-                  </a:txBody>
-                  <a:tcPr marL="91440" marR="91440" marT="45720" marB="45720" anchor="ctr">
-                    <a:lnL w="6350" cap="flat" cmpd="sng" algn="ctr">
-                      <a:solidFill>
-                        <a:srgbClr val="D6DEE5"/>
-                      </a:solidFill>
-                      <a:prstDash val="solid"/>
-                      <a:round/>
-                      <a:headEnd type="none" w="med" len="med"/>
-                      <a:tailEnd type="none" w="med" len="med"/>
-                    </a:lnL>
-                    <a:lnR w="6350" cap="flat" cmpd="sng" algn="ctr">
-                      <a:solidFill>
-                        <a:srgbClr val="D6DEE5"/>
-                      </a:solidFill>
-                      <a:prstDash val="solid"/>
-                      <a:round/>
-                      <a:headEnd type="none" w="med" len="med"/>
-                      <a:tailEnd type="none" w="med" len="med"/>
-                    </a:lnR>
-                    <a:lnT w="6350" cap="flat" cmpd="sng" algn="ctr">
-                      <a:solidFill>
-                        <a:srgbClr val="D6DEE5"/>
-                      </a:solidFill>
-                      <a:prstDash val="solid"/>
-                      <a:round/>
-                      <a:headEnd type="none" w="med" len="med"/>
-                      <a:tailEnd type="none" w="med" len="med"/>
-                    </a:lnT>
-                    <a:lnB w="6350" cap="flat" cmpd="sng" algn="ctr">
-                      <a:solidFill>
-                        <a:srgbClr val="D6DEE5"/>
-                      </a:solidFill>
-                      <a:prstDash val="solid"/>
-                      <a:round/>
-                      <a:headEnd type="none" w="med" len="med"/>
-                      <a:tailEnd type="none" w="med" len="med"/>
-                    </a:lnB>
-                    <a:solidFill>
-                      <a:srgbClr val="F2F4F6"/>
-                    </a:solidFill>
-                  </a:tcPr>
-                </a:tc>
-                <a:tc>
-                  <a:txBody>
-                    <a:bodyPr/>
-                    <a:lstStyle/>
-                    <a:p>
-                      <a:pPr algn="ctr" indent="0" marL="0">
-                        <a:buNone/>
-                      </a:pPr>
-                      <a:r>
-                        <a:rPr lang="en-US" sz="1000" dirty="0">
-                          <a:solidFill>
-                            <a:schemeClr val="tx1"/>
-                          </a:solidFill>
-                        </a:rPr>
-                        <a:t>€386 / €1,321 · –</a:t>
-                      </a:r>
-                      <a:endParaRPr lang="en-US" sz="1000" dirty="0"/>
-                    </a:p>
-                  </a:txBody>
-                  <a:tcPr marL="91440" marR="91440" marT="45720" marB="45720" anchor="ctr">
-                    <a:lnL w="6350" cap="flat" cmpd="sng" algn="ctr">
-                      <a:solidFill>
-                        <a:srgbClr val="D6DEE5"/>
-                      </a:solidFill>
-                      <a:prstDash val="solid"/>
-                      <a:round/>
-                      <a:headEnd type="none" w="med" len="med"/>
-                      <a:tailEnd type="none" w="med" len="med"/>
-                    </a:lnL>
-                    <a:lnR w="6350" cap="flat" cmpd="sng" algn="ctr">
-                      <a:solidFill>
-                        <a:srgbClr val="D6DEE5"/>
-                      </a:solidFill>
-                      <a:prstDash val="solid"/>
-                      <a:round/>
-                      <a:headEnd type="none" w="med" len="med"/>
-                      <a:tailEnd type="none" w="med" len="med"/>
-                    </a:lnR>
-                    <a:lnT w="6350" cap="flat" cmpd="sng" algn="ctr">
-                      <a:solidFill>
-                        <a:srgbClr val="D6DEE5"/>
-                      </a:solidFill>
-                      <a:prstDash val="solid"/>
-                      <a:round/>
-                      <a:headEnd type="none" w="med" len="med"/>
-                      <a:tailEnd type="none" w="med" len="med"/>
-                    </a:lnT>
-                    <a:lnB w="6350" cap="flat" cmpd="sng" algn="ctr">
-                      <a:solidFill>
-                        <a:srgbClr val="D6DEE5"/>
-                      </a:solidFill>
-                      <a:prstDash val="solid"/>
-                      <a:round/>
-                      <a:headEnd type="none" w="med" len="med"/>
-                      <a:tailEnd type="none" w="med" len="med"/>
-                    </a:lnB>
-                    <a:solidFill>
-                      <a:srgbClr val="F2F4F6"/>
-                    </a:solidFill>
-                  </a:tcPr>
-                </a:tc>
-                <a:tc>
-                  <a:txBody>
-                    <a:bodyPr/>
-                    <a:lstStyle/>
-                    <a:p>
-                      <a:pPr algn="ctr" indent="0" marL="0">
-                        <a:buNone/>
-                      </a:pPr>
-                      <a:r>
-                        <a:rPr lang="en-US" sz="1000" dirty="0">
-                          <a:solidFill>
-                            <a:schemeClr val="tx1"/>
-                          </a:solidFill>
-                        </a:rPr>
-                        <a:t>€386 / €1,443 · –</a:t>
-                      </a:r>
-                      <a:endParaRPr lang="en-US" sz="1000" dirty="0"/>
-                    </a:p>
-                  </a:txBody>
-                  <a:tcPr marL="91440" marR="91440" marT="45720" marB="45720" anchor="ctr">
-                    <a:lnL w="6350" cap="flat" cmpd="sng" algn="ctr">
-                      <a:solidFill>
-                        <a:srgbClr val="D6DEE5"/>
-                      </a:solidFill>
-                      <a:prstDash val="solid"/>
-                      <a:round/>
-                      <a:headEnd type="none" w="med" len="med"/>
-                      <a:tailEnd type="none" w="med" len="med"/>
-                    </a:lnL>
-                    <a:lnR w="6350" cap="flat" cmpd="sng" algn="ctr">
-                      <a:solidFill>
-                        <a:srgbClr val="D6DEE5"/>
-                      </a:solidFill>
-                      <a:prstDash val="solid"/>
-                      <a:round/>
-                      <a:headEnd type="none" w="med" len="med"/>
-                      <a:tailEnd type="none" w="med" len="med"/>
-                    </a:lnR>
-                    <a:lnT w="6350" cap="flat" cmpd="sng" algn="ctr">
-                      <a:solidFill>
-                        <a:srgbClr val="D6DEE5"/>
-                      </a:solidFill>
-                      <a:prstDash val="solid"/>
-                      <a:round/>
-                      <a:headEnd type="none" w="med" len="med"/>
-                      <a:tailEnd type="none" w="med" len="med"/>
-                    </a:lnT>
-                    <a:lnB w="6350" cap="flat" cmpd="sng" algn="ctr">
-                      <a:solidFill>
-                        <a:srgbClr val="D6DEE5"/>
-                      </a:solidFill>
-                      <a:prstDash val="solid"/>
-                      <a:round/>
-                      <a:headEnd type="none" w="med" len="med"/>
-                      <a:tailEnd type="none" w="med" len="med"/>
-                    </a:lnB>
-                    <a:solidFill>
-                      <a:srgbClr val="F2F4F6"/>
-                    </a:solidFill>
                   </a:tcPr>
                 </a:tc>
               </a:tr>
@@ -17066,7 +17066,7 @@
                   <a:schemeClr val="tx2"/>
                 </a:solidFill>
               </a:rPr>
-              <a:t>Cells: cost per qualified / cost per hire · hires planned. Cost per hire = (cost per application × applications + set-up) ÷ hires at full capacity; I2 includes €1,200 set-up, I3 €400 translation. StepStone's single ad works out at €1,583 per hire: costed whole, credited only the applications the plan needs (conservative).</a:t>
+              <a:t>Cells: cost per qualified / cost per hire · hires planned. Cost per hire = (cost per application × applications + set-up) ÷ hires at full capacity; I2 includes €1,200 set-up, I3 €400 translation. StepStone ads (7 × €1,449) are costed whole and credited only the applications the plan needs (conservative).</a:t>
             </a:r>
             <a:endParaRPr lang="en-US" sz="1000" dirty="0"/>
           </a:p>
@@ -17102,7 +17102,7 @@
                   <a:schemeClr val="accent4"/>
                 </a:solidFill>
               </a:rPr>
-              <a:t>Researched: StepStone €1,449/30-day ad (instaffo.com) · Pracuj.pl ~1,499 PLN/ad, indicative (dlafirm.pracuj.pl) · Indeed CPC $0.10–5+ (pin.com) · LinkedIn CPC $4–8 (peoplebox.ai) · Appcast apply rate 6.1% (2025 benchmark). Other sources (§6 BQFG, BA Engpassanalyse, WSI, plant headcount) and every own estimate are labelled on the Assumptions tab.</a:t>
+              <a:t>Sourced: StepStone €1,449/30-day ad (stepstone.de price list) · cost per application, DACH medians: Indeed €161, Google €179, LinkedIn €96, Meta €84 (TalentBait, 2,549 campaigns, 2024–26) · share qualified: 28% of applications suitable (IAB-Stellenerhebung 2026) · pools: BA employment statistics by KldB code (Dec 2025) · time-to-offer: SmartRecruiters Germany benchmark. Every source and every remaining own estimate is labelled with its URL on the Assumptions tab.</a:t>
             </a:r>
             <a:endParaRPr lang="en-US" sz="1000" dirty="0"/>
           </a:p>
@@ -17252,7 +17252,7 @@
                 <a:ea typeface="Cambria" pitchFamily="34" charset="-122"/>
                 <a:cs typeface="Cambria" pitchFamily="34" charset="-120"/>
               </a:rPr>
-              <a:t>€38.7k planned across roles and weeks, plus €8.8k reserve released on results</a:t>
+              <a:t>€85.4k planned across roles and weeks, plus €17.1k reserve released on results</a:t>
             </a:r>
             <a:endParaRPr lang="en-US" sz="2200" dirty="0"/>
           </a:p>
@@ -17321,7 +17321,7 @@
                   <a:schemeClr val="tx1"/>
                 </a:solidFill>
               </a:rPr>
-              <a:t>€20.4k paid channels (incl. €9.0k tests) + €16.7k initiative media, pre-screen calls and bonuses + €1.6k set-up = €38.7k. Reserve: 15% of €45.6k plus rounding = €8.8k.</a:t>
+              <a:t>€52.0k paid channels (incl. €9.0k tests) + €31.8k initiative media, pre-screen calls and bonuses + €1.6k set-up = €85.4k. Reserve: 15% of €100.5k plus rounding = €17.1k.</a:t>
             </a:r>
             <a:endParaRPr lang="en-US" sz="1100" dirty="0"/>
           </a:p>
@@ -17352,7 +17352,7 @@
                   <a:schemeClr val="tx1"/>
                 </a:solidFill>
               </a:rPr>
-              <a:t>weeks 1–2 cost €14.1k (30%), mostly tests. Duds are cut from Mon 2 Nov (after €500 / 30 apps); tests and the full re-allocation are judged by Mon 9 Nov; the reserve moves only from week 3. Paid media stops after 27 Nov.</a:t>
+              <a:t>weeks 1–2 cost €31.8k (31%), mostly tests. Duds are cut from Mon 2 Nov (after €500 / 30 apps); tests and the full re-allocation are judged by Mon 9 Nov; the reserve moves only from week 3. Paid media stops after Tue 24 Nov.</a:t>
             </a:r>
             <a:endParaRPr lang="en-US" sz="1100" dirty="0"/>
           </a:p>
@@ -17767,7 +17767,7 @@
                             <a:schemeClr val="tx1"/>
                           </a:solidFill>
                         </a:rPr>
-                        <a:t>€19.9k</a:t>
+                        <a:t>€46.5k</a:t>
                       </a:r>
                       <a:endParaRPr lang="en-US" sz="1100" dirty="0"/>
                     </a:p>
@@ -17941,7 +17941,7 @@
                             <a:schemeClr val="tx1"/>
                           </a:solidFill>
                         </a:rPr>
-                        <a:t>€664</a:t>
+                        <a:t>€1,550</a:t>
                       </a:r>
                       <a:endParaRPr lang="en-US" sz="1100" dirty="0"/>
                     </a:p>
@@ -18059,7 +18059,7 @@
                             <a:schemeClr val="tx1"/>
                           </a:solidFill>
                         </a:rPr>
-                        <a:t>€5.5k</a:t>
+                        <a:t>€9.7k</a:t>
                       </a:r>
                       <a:endParaRPr lang="en-US" sz="1100" dirty="0"/>
                     </a:p>
@@ -18233,7 +18233,7 @@
                             <a:schemeClr val="tx1"/>
                           </a:solidFill>
                         </a:rPr>
-                        <a:t>€123</a:t>
+                        <a:t>€215</a:t>
                       </a:r>
                       <a:endParaRPr lang="en-US" sz="1100" dirty="0"/>
                     </a:p>
@@ -18351,7 +18351,7 @@
                             <a:schemeClr val="tx1"/>
                           </a:solidFill>
                         </a:rPr>
-                        <a:t>€6.7k</a:t>
+                        <a:t>€14.6k</a:t>
                       </a:r>
                       <a:endParaRPr lang="en-US" sz="1100" dirty="0"/>
                     </a:p>
@@ -18525,7 +18525,7 @@
                             <a:schemeClr val="tx1"/>
                           </a:solidFill>
                         </a:rPr>
-                        <a:t>€447</a:t>
+                        <a:t>€975</a:t>
                       </a:r>
                       <a:endParaRPr lang="en-US" sz="1100" dirty="0"/>
                     </a:p>
@@ -18643,7 +18643,7 @@
                             <a:schemeClr val="tx1"/>
                           </a:solidFill>
                         </a:rPr>
-                        <a:t>€6.6k</a:t>
+                        <a:t>€14.6k</a:t>
                       </a:r>
                       <a:endParaRPr lang="en-US" sz="1100" dirty="0"/>
                     </a:p>
@@ -18817,7 +18817,7 @@
                             <a:schemeClr val="tx1"/>
                           </a:solidFill>
                         </a:rPr>
-                        <a:t>€655</a:t>
+                        <a:t>€1,457</a:t>
                       </a:r>
                       <a:endParaRPr lang="en-US" sz="1100" dirty="0"/>
                     </a:p>
@@ -18935,7 +18935,7 @@
                             <a:schemeClr val="tx1"/>
                           </a:solidFill>
                         </a:rPr>
-                        <a:t>€38.7k</a:t>
+                        <a:t>€85.4k</a:t>
                       </a:r>
                       <a:endParaRPr lang="en-US" sz="1100" dirty="0"/>
                     </a:p>
@@ -19109,7 +19109,7 @@
                             <a:schemeClr val="tx1"/>
                           </a:solidFill>
                         </a:rPr>
-                        <a:t>€387</a:t>
+                        <a:t>€854</a:t>
                       </a:r>
                       <a:endParaRPr lang="en-US" sz="1100" dirty="0"/>
                     </a:p>
@@ -19563,7 +19563,7 @@
                             <a:schemeClr val="tx1"/>
                           </a:solidFill>
                         </a:rPr>
-                        <a:t>22.1</a:t>
+                        <a:t>20.6</a:t>
                       </a:r>
                       <a:endParaRPr lang="en-US" sz="1000" dirty="0"/>
                     </a:p>
@@ -19797,7 +19797,7 @@
                             <a:schemeClr val="tx1"/>
                           </a:solidFill>
                         </a:rPr>
-                        <a:t>4.3</a:t>
+                        <a:t>0.8</a:t>
                       </a:r>
                       <a:endParaRPr lang="en-US" sz="1000" dirty="0"/>
                     </a:p>
@@ -19855,7 +19855,7 @@
                             <a:schemeClr val="tx1"/>
                           </a:solidFill>
                         </a:rPr>
-                        <a:t>€690</a:t>
+                        <a:t>€3,632</a:t>
                       </a:r>
                       <a:endParaRPr lang="en-US" sz="1000" dirty="0"/>
                     </a:p>
@@ -19973,7 +19973,7 @@
                             <a:schemeClr val="tx1"/>
                           </a:solidFill>
                         </a:rPr>
-                        <a:t>€1.4k</a:t>
+                        <a:t>€10.1k</a:t>
                       </a:r>
                       <a:endParaRPr lang="en-US" sz="1000" dirty="0"/>
                     </a:p>
@@ -20031,7 +20031,7 @@
                             <a:schemeClr val="tx1"/>
                           </a:solidFill>
                         </a:rPr>
-                        <a:t>0.9</a:t>
+                        <a:t>10.8</a:t>
                       </a:r>
                       <a:endParaRPr lang="en-US" sz="1000" dirty="0"/>
                     </a:p>
@@ -20089,7 +20089,7 @@
                             <a:schemeClr val="tx1"/>
                           </a:solidFill>
                         </a:rPr>
-                        <a:t>€1,583</a:t>
+                        <a:t>€937</a:t>
                       </a:r>
                       <a:endParaRPr lang="en-US" sz="1000" dirty="0"/>
                     </a:p>
@@ -20207,7 +20207,7 @@
                             <a:schemeClr val="tx1"/>
                           </a:solidFill>
                         </a:rPr>
-                        <a:t>€9.5k</a:t>
+                        <a:t>€20.8k</a:t>
                       </a:r>
                       <a:endParaRPr lang="en-US" sz="1000" dirty="0"/>
                     </a:p>
@@ -20265,7 +20265,7 @@
                             <a:schemeClr val="tx1"/>
                           </a:solidFill>
                         </a:rPr>
-                        <a:t>14.0</a:t>
+                        <a:t>13.1</a:t>
                       </a:r>
                       <a:endParaRPr lang="en-US" sz="1000" dirty="0"/>
                     </a:p>
@@ -20323,7 +20323,7 @@
                             <a:schemeClr val="tx1"/>
                           </a:solidFill>
                         </a:rPr>
-                        <a:t>€682</a:t>
+                        <a:t>€1,584</a:t>
                       </a:r>
                       <a:endParaRPr lang="en-US" sz="1000" dirty="0"/>
                     </a:p>
@@ -20499,7 +20499,7 @@
                             <a:schemeClr val="tx1"/>
                           </a:solidFill>
                         </a:rPr>
-                        <a:t>3.7</a:t>
+                        <a:t>0.5</a:t>
                       </a:r>
                       <a:endParaRPr lang="en-US" sz="1000" dirty="0"/>
                     </a:p>
@@ -20557,7 +20557,7 @@
                             <a:schemeClr val="tx1"/>
                           </a:solidFill>
                         </a:rPr>
-                        <a:t>€405</a:t>
+                        <a:t>€2,786</a:t>
                       </a:r>
                       <a:endParaRPr lang="en-US" sz="1000" dirty="0"/>
                     </a:p>
@@ -20675,7 +20675,7 @@
                             <a:schemeClr val="tx1"/>
                           </a:solidFill>
                         </a:rPr>
-                        <a:t>€5.0k</a:t>
+                        <a:t>€16.6k</a:t>
                       </a:r>
                       <a:endParaRPr lang="en-US" sz="1000" dirty="0"/>
                     </a:p>
@@ -20733,7 +20733,7 @@
                             <a:schemeClr val="tx1"/>
                           </a:solidFill>
                         </a:rPr>
-                        <a:t>8.3</a:t>
+                        <a:t>4.5</a:t>
                       </a:r>
                       <a:endParaRPr lang="en-US" sz="1000" dirty="0"/>
                     </a:p>
@@ -20791,7 +20791,7 @@
                             <a:schemeClr val="tx1"/>
                           </a:solidFill>
                         </a:rPr>
-                        <a:t>€598</a:t>
+                        <a:t>€3,710</a:t>
                       </a:r>
                       <a:endParaRPr lang="en-US" sz="1000" dirty="0"/>
                     </a:p>
@@ -20909,7 +20909,7 @@
                             <a:schemeClr val="tx1"/>
                           </a:solidFill>
                         </a:rPr>
-                        <a:t>€350</a:t>
+                        <a:t>€210</a:t>
                       </a:r>
                       <a:endParaRPr lang="en-US" sz="1000" dirty="0"/>
                     </a:p>
@@ -20967,7 +20967,7 @@
                             <a:schemeClr val="tx1"/>
                           </a:solidFill>
                         </a:rPr>
-                        <a:t>16.7</a:t>
+                        <a:t>15.7</a:t>
                       </a:r>
                       <a:endParaRPr lang="en-US" sz="1000" dirty="0"/>
                     </a:p>
@@ -21025,7 +21025,7 @@
                             <a:schemeClr val="tx1"/>
                           </a:solidFill>
                         </a:rPr>
-                        <a:t>€21</a:t>
+                        <a:t>€13</a:t>
                       </a:r>
                       <a:endParaRPr lang="en-US" sz="1000" dirty="0"/>
                     </a:p>
@@ -21143,7 +21143,7 @@
                             <a:schemeClr val="tx1"/>
                           </a:solidFill>
                         </a:rPr>
-                        <a:t>€4.6k</a:t>
+                        <a:t>€6.5k</a:t>
                       </a:r>
                       <a:endParaRPr lang="en-US" sz="1000" dirty="0"/>
                     </a:p>
@@ -21201,7 +21201,7 @@
                             <a:schemeClr val="tx1"/>
                           </a:solidFill>
                         </a:rPr>
-                        <a:t>4.6</a:t>
+                        <a:t>6.5</a:t>
                       </a:r>
                       <a:endParaRPr lang="en-US" sz="1000" dirty="0"/>
                     </a:p>
@@ -21377,7 +21377,7 @@
                             <a:schemeClr val="tx1"/>
                           </a:solidFill>
                         </a:rPr>
-                        <a:t>€10.2k</a:t>
+                        <a:t>€22.2k</a:t>
                       </a:r>
                       <a:endParaRPr lang="en-US" sz="1000" dirty="0"/>
                     </a:p>
@@ -21435,7 +21435,7 @@
                             <a:schemeClr val="tx1"/>
                           </a:solidFill>
                         </a:rPr>
-                        <a:t>11.6</a:t>
+                        <a:t>9.5</a:t>
                       </a:r>
                       <a:endParaRPr lang="en-US" sz="1000" dirty="0"/>
                     </a:p>
@@ -21493,7 +21493,7 @@
                             <a:schemeClr val="tx1"/>
                           </a:solidFill>
                         </a:rPr>
-                        <a:t>€881</a:t>
+                        <a:t>€2,349</a:t>
                       </a:r>
                       <a:endParaRPr lang="en-US" sz="1000" dirty="0"/>
                     </a:p>
@@ -21611,7 +21611,7 @@
                             <a:schemeClr val="tx1"/>
                           </a:solidFill>
                         </a:rPr>
-                        <a:t>€3.1k</a:t>
+                        <a:t>€4.5k</a:t>
                       </a:r>
                       <a:endParaRPr lang="en-US" sz="1000" dirty="0"/>
                     </a:p>
@@ -21669,7 +21669,7 @@
                             <a:schemeClr val="tx1"/>
                           </a:solidFill>
                         </a:rPr>
-                        <a:t>13.8</a:t>
+                        <a:t>18.0</a:t>
                       </a:r>
                       <a:endParaRPr lang="en-US" sz="1000" dirty="0"/>
                     </a:p>
@@ -21727,7 +21727,7 @@
                             <a:schemeClr val="tx1"/>
                           </a:solidFill>
                         </a:rPr>
-                        <a:t>€228</a:t>
+                        <a:t>€248</a:t>
                       </a:r>
                       <a:endParaRPr lang="en-US" sz="1000" dirty="0"/>
                     </a:p>
@@ -21920,7 +21920,7 @@
                 <a:ea typeface="Cambria" pitchFamily="34" charset="-122"/>
                 <a:cs typeface="Cambria" pitchFamily="34" charset="-120"/>
               </a:rPr>
-              <a:t>30% less (€33.25k) still signs ~91, but electricians take most of the loss</a:t>
+              <a:t>30% less (€71.75k) still signs ~93, but electricians take most of the loss</a:t>
             </a:r>
             <a:endParaRPr lang="en-US" sz="2200" dirty="0"/>
           </a:p>
@@ -22169,7 +22169,7 @@
                             <a:schemeClr val="tx1"/>
                           </a:solidFill>
                         </a:rPr>
-                        <a:t>100% · €47.50k</a:t>
+                        <a:t>100% · €102.50k</a:t>
                       </a:r>
                       <a:endParaRPr lang="en-US" sz="1100" dirty="0"/>
                     </a:p>
@@ -22285,7 +22285,7 @@
                             <a:schemeClr val="tx1"/>
                           </a:solidFill>
                         </a:rPr>
-                        <a:t>€475</a:t>
+                        <a:t>€1,025</a:t>
                       </a:r>
                       <a:endParaRPr lang="en-US" sz="1100" dirty="0"/>
                     </a:p>
@@ -22345,7 +22345,7 @@
                             <a:schemeClr val="tx1"/>
                           </a:solidFill>
                         </a:rPr>
-                        <a:t>85% · €40.38k</a:t>
+                        <a:t>85% · €87.13k</a:t>
                       </a:r>
                       <a:endParaRPr lang="en-US" sz="1100" dirty="0"/>
                     </a:p>
@@ -22461,7 +22461,7 @@
                             <a:schemeClr val="tx1"/>
                           </a:solidFill>
                         </a:rPr>
-                        <a:t>€417</a:t>
+                        <a:t>€895</a:t>
                       </a:r>
                       <a:endParaRPr lang="en-US" sz="1100" dirty="0"/>
                     </a:p>
@@ -22521,7 +22521,7 @@
                             <a:schemeClr val="tx1"/>
                           </a:solidFill>
                         </a:rPr>
-                        <a:t>70% · €33.25k</a:t>
+                        <a:t>70% · €71.75k</a:t>
                       </a:r>
                       <a:endParaRPr lang="en-US" sz="1100" dirty="0"/>
                     </a:p>
@@ -22579,7 +22579,7 @@
                             <a:schemeClr val="tx1"/>
                           </a:solidFill>
                         </a:rPr>
-                        <a:t>91</a:t>
+                        <a:t>93</a:t>
                       </a:r>
                       <a:endParaRPr lang="en-US" sz="1100" dirty="0"/>
                     </a:p>
@@ -22637,7 +22637,7 @@
                             <a:schemeClr val="tx1"/>
                           </a:solidFill>
                         </a:rPr>
-                        <a:t>€367</a:t>
+                        <a:t>€773</a:t>
                       </a:r>
                       <a:endParaRPr lang="en-US" sz="1100" dirty="0"/>
                     </a:p>
@@ -22697,7 +22697,7 @@
                             <a:schemeClr val="tx1"/>
                           </a:solidFill>
                         </a:rPr>
-                        <a:t>50% · €23.75k</a:t>
+                        <a:t>50% · €51.25k</a:t>
                       </a:r>
                       <a:endParaRPr lang="en-US" sz="1100" dirty="0"/>
                     </a:p>
@@ -22755,7 +22755,7 @@
                             <a:schemeClr val="tx1"/>
                           </a:solidFill>
                         </a:rPr>
-                        <a:t>80</a:t>
+                        <a:t>85</a:t>
                       </a:r>
                       <a:endParaRPr lang="en-US" sz="1100" dirty="0"/>
                     </a:p>
@@ -22813,7 +22813,7 @@
                             <a:schemeClr val="tx1"/>
                           </a:solidFill>
                         </a:rPr>
-                        <a:t>€296</a:t>
+                        <a:t>€600</a:t>
                       </a:r>
                       <a:endParaRPr lang="en-US" sz="1100" dirty="0"/>
                     </a:p>
@@ -22964,7 +22964,7 @@
                   <a:schemeClr val="tx1"/>
                 </a:solidFill>
               </a:rPr>
-              <a:t>electricians (23 of 30 at −30%), then supervisors (8 of 10); automation slips to 14 of 15. Mechatronics never falls short.</a:t>
+              <a:t>electricians (23 of 30 at −30%); automation and supervisors lose under 1 hire each (14.7 of 15, 9.8 of 10). Mechatronics never falls short.</a:t>
             </a:r>
             <a:endParaRPr lang="en-US" sz="1200" dirty="0"/>
           </a:p>
@@ -22995,7 +22995,7 @@
                   <a:schemeClr val="tx1"/>
                 </a:solidFill>
               </a:rPr>
-              <a:t>the last €14.25k buys ~9 hires at ~€1,530 each, mostly electricians, the role that keeps lines running. Keep it. If you must cut, cover supervisors through internal promotion and protect electricians. Above €47.5k, extra money buys at most ~11 more hires (the 31 spare slots); then the 55/week limit binds.</a:t>
+              <a:t>the last €30.75k buys ~7 hires at ~€4,290 each, mostly electricians, the role that keeps lines running. Keep it. If you must cut, cover supervisors through internal promotion and protect electricians. Above €102.5k, extra money buys at most ~3 more hires (the 9 spare slots); then the 55/week limit binds.</a:t>
             </a:r>
             <a:endParaRPr lang="en-US" sz="1200" dirty="0"/>
           </a:p>
@@ -23145,7 +23145,7 @@
                 <a:ea typeface="Cambria" pitchFamily="34" charset="-122"/>
                 <a:cs typeface="Cambria" pitchFamily="34" charset="-120"/>
               </a:rPr>
-              <a:t>Three new sources supply ~47 of the 100 hires, one built for electricians</a:t>
+              <a:t>Three new sources supply ~50 of the 100 hires, one built for electricians</a:t>
             </a:r>
             <a:endParaRPr lang="en-US" sz="2200" dirty="0"/>
           </a:p>
@@ -23347,7 +23347,7 @@
                   <a:schemeClr val="tx1"/>
                 </a:solidFill>
               </a:rPr>
-              <a:t>Already screened (50% qualified), already wanted Tesla, €4 per application</a:t>
+              <a:t>Already screened (50% qualified, my estimate), already wanted Tesla, ~€3 per application</a:t>
             </a:r>
             <a:endParaRPr lang="en-US" sz="1200" dirty="0"/>
           </a:p>
@@ -23378,7 +23378,7 @@
                   <a:schemeClr val="tx1"/>
                 </a:solidFill>
               </a:rPr>
-              <a:t>€350 + €4.6k bonuses → 84 re-apps + 28 referrals → ~55 qualified → ~21 hires</a:t>
+              <a:t>€210 + €6.5k bonuses → 84 re-apps + 43 referrals → ~61 qualified → ~22 hires</a:t>
             </a:r>
             <a:endParaRPr lang="en-US" sz="1200" dirty="0"/>
           </a:p>
@@ -23409,7 +23409,7 @@
                   <a:schemeClr val="tx1"/>
                 </a:solidFill>
               </a:rPr>
-              <a:t>Wed 21 Oct – Tue 3 Nov (waves 1–3): €350. Pass: ≥19 qualified (≥⅓ electricians). Kill: &lt;10 → no further re-contacts; bonus stays live</a:t>
+              <a:t>Wed 21 Oct – Tue 3 Nov (waves 1–3): €210. Pass: ≥20 qualified (≥⅓ electricians). Kill: &lt;11 → no further re-contacts; bonus stays live</a:t>
             </a:r>
             <a:endParaRPr lang="en-US" sz="1200" dirty="0"/>
           </a:p>
@@ -23580,7 +23580,7 @@
                   <a:schemeClr val="tx1"/>
                 </a:solidFill>
               </a:rPr>
-              <a:t>~12,000 construction electricians (Elektroniker EGT) within 75 km</a:t>
+              <a:t>~10,000 construction electricians (Elektroniker EGT, BA KldB 2621) within 75 km</a:t>
             </a:r>
             <a:endParaRPr lang="en-US" sz="1200" dirty="0"/>
           </a:p>
@@ -23673,7 +23673,7 @@
                   <a:schemeClr val="tx1"/>
                 </a:solidFill>
               </a:rPr>
-              <a:t>300 apps × €30 = €9.0k + €1.2k set-up → 45 qualified × 26% = 11.6 hires (€881/hire)</a:t>
+              <a:t>250 apps × €84 = €21.0k + €1.2k set-up → 38 qualified × 25% = 9.5 hires (€2,349/hire)</a:t>
             </a:r>
             <a:endParaRPr lang="en-US" sz="1200" dirty="0"/>
           </a:p>
@@ -23704,7 +23704,7 @@
                   <a:schemeClr val="tx1"/>
                 </a:solidFill>
               </a:rPr>
-              <a:t>Fri 23 Oct – Thu 5 Nov (read Mon 9 Nov): €2.6k. Pass: ≥4 qualified at ≤€250. Kill: &lt;3, &gt;€300 per qualified, or profile rejected; week 4: &lt;40% interview pass</a:t>
+              <a:t>Fri 23 Oct – Thu 5 Nov (read Mon 9 Nov): €5.8k. Pass: ≥4 qualified at ≤€700. Kill: &lt;3, &gt;€840 per qualified, or profile rejected; week 4: &lt;40% interview pass</a:t>
             </a:r>
             <a:endParaRPr lang="en-US" sz="1200" dirty="0"/>
           </a:p>
@@ -23968,7 +23968,7 @@
                   <a:schemeClr val="tx1"/>
                 </a:solidFill>
               </a:rPr>
-              <a:t>141 apps × €19.50 + €400 → 31 qualified × 45% = 13.8 hires (31% of mech, cap 40%)</a:t>
+              <a:t>200 apps × €20.25 + €400 → 44 qualified × 41% = 18.0 hires (40% of mech, cap 40%)</a:t>
             </a:r>
             <a:endParaRPr lang="en-US" sz="1200" dirty="0"/>
           </a:p>
@@ -23999,7 +23999,7 @@
                   <a:schemeClr val="tx1"/>
                 </a:solidFill>
               </a:rPr>
-              <a:t>Tue 27 Oct – Mon 9 Nov (freelancer starts 27 Oct): €1.1k. Pass: ≥4 qualified at ≤€110. Kill: &lt;3, &gt;€130 per qualified, or &lt;30% pass the language check</a:t>
+              <a:t>Tue 27 Oct – Mon 9 Nov (freelancer starts 27 Oct): €1.5k. Pass: ≥7 qualified at ≤€120. Kill: &lt;4, &gt;€140 per qualified, or &lt;30% pass the language check</a:t>
             </a:r>
             <a:endParaRPr lang="en-US" sz="1200" dirty="0"/>
           </a:p>
@@ -24077,7 +24077,7 @@
                   <a:schemeClr val="tx1"/>
                 </a:solidFill>
               </a:rPr>
-              <a:t>Every large employer holds thousands of previously screened candidates who are rarely re-marketed to. Here they cost ~€20 per hire and fill week-1 slots before paid channels warm up. Joveo already matches jobs to supply programmatically. Adding a consented rediscovery source, tracked to hire with the same source tags, is repeatable in any market without local staff.</a:t>
+              <a:t>Every large employer holds thousands of previously screened candidates who are rarely re-marketed to. Here they cost ~€13 per hire and fill week-1 slots before paid channels warm up. Joveo already matches jobs to supply programmatically. Adding a consented rediscovery source, tracked to hire with the same source tags, is repeatable in any market without local staff.</a:t>
             </a:r>
             <a:endParaRPr lang="en-US" sz="1200" dirty="0"/>
           </a:p>
@@ -24596,7 +24596,7 @@
                   <a:schemeClr val="tx1"/>
                 </a:solidFill>
               </a:rPr>
-              <a:t>1) Pass rate on the week-1 cohort (interviews 29 Oct–2 Nov), the most sensitive input: if &lt;45% → tighter knock-outs, pre-screen calls, ask +10 slots, re-run the model. 2) Electrician supply: profile decision + I2's two-week read on 9 Nov; if killed → Meta, StepStone (up to 2 more ads), programmatic; expect ~25–27 electricians (my judgement: capacity allows 30, but slower and at €1,000–1,500 per hire). 3) The 12 tests' cost per application and share qualified → re-rank on Assumptions §7. Week 4 (16 Nov): acceptance &lt;55% → earlier cut-off + signing bonus.</a:t>
+              <a:t>1) Pass rate on the week-1 cohort (interviews 29 Oct–2 Nov), the most sensitive input: if &lt;45% → tighter knock-outs, pre-screen calls, ask +10 slots, re-run the model. 2) Electrician supply: profile decision + I2's two-week read on 9 Nov; if killed → more StepStone ads, then Search and programmatic; expect ~25–27 electricians (my judgement: capacity allows 30, but slower and at €1,022–€3,788 per hire). 3) The 12 tests' cost per application and share qualified → re-rank on Assumptions §7. Week 4 (16 Nov): acceptance &lt;55% → earlier cut-off + signing bonus.</a:t>
             </a:r>
             <a:endParaRPr lang="en-US" sz="1250" dirty="0"/>
           </a:p>

</xml_diff>

<commit_message>
Move sources into the model: new live Sources tab
Sources tab links every input to Assumptions (value, label, reasoning),
adds clickable source links, splits own estimates into unsourced facts vs
policy choices, and lists every distinct reference. Drops SOURCES.md.

Co-Authored-By: Claude Opus 5.5 <noreply@anthropic.com>
Claude-Session: https://claude.ai/code/session_01V2NJtrYy3bzNxqKeiRXJfY
</commit_message>
<xml_diff>
--- a/operation_uptime/Operation_Uptime_Deck.pptx
+++ b/operation_uptime/Operation_Uptime_Deck.pptx
@@ -114,30 +114,30 @@
   <p:extLst>
     <p:ext uri="{521415D9-36F7-43E2-AB2F-B90AF26B5E84}">
       <p14:sectionLst xmlns:p14="http://schemas.microsoft.com/office/powerpoint/2010/main">
-        <p14:section name="Summary" id="{f8a88073-1330-45f4-e01b-74e6f738fc02}">
+        <p14:section name="Summary" id="{2596f74d-fb4a-fbb1-4ee1-31559558fa9d}">
           <p14:sldIdLst>
             <p14:sldId id="256"/>
           </p14:sldIdLst>
         </p14:section>
-        <p14:section name="Part 1 Funnel" id="{08f63a34-2e00-4d71-998a-54ca1fa06ea6}">
+        <p14:section name="Part 1 Funnel" id="{7f6cca6b-0890-571c-905b-7a9036c35073}">
           <p14:sldIdLst>
             <p14:sldId id="257"/>
             <p14:sldId id="258"/>
           </p14:sldIdLst>
         </p14:section>
-        <p14:section name="Part 2 Channels &amp; budget" id="{4ac4808e-65dd-04a2-3d11-db03ca21dcf1}">
+        <p14:section name="Part 2 Channels &amp; budget" id="{ad70c299-6e32-ef82-7795-d4fdae8eeebd}">
           <p14:sldIdLst>
             <p14:sldId id="259"/>
             <p14:sldId id="260"/>
             <p14:sldId id="261"/>
           </p14:sldIdLst>
         </p14:section>
-        <p14:section name="Part 3 New sources" id="{7588a314-d594-f44b-138b-d79c8ec2f33c}">
+        <p14:section name="Part 3 New sources" id="{59267c12-3ec3-6482-b322-98211a9a097a}">
           <p14:sldIdLst>
             <p14:sldId id="262"/>
           </p14:sldIdLst>
         </p14:section>
-        <p14:section name="Part 4 Run it" id="{0199cb29-7037-d626-ce5e-195b1b3658bf}">
+        <p14:section name="Part 4 Run it" id="{b0558b36-5242-87bf-2094-1c36c8756a8f}">
           <p14:sldIdLst>
             <p14:sldId id="263"/>
           </p14:sldIdLst>
@@ -17102,7 +17102,7 @@
                   <a:schemeClr val="accent4"/>
                 </a:solidFill>
               </a:rPr>
-              <a:t>Sourced: StepStone €1,449/30-day ad (stepstone.de price list) · cost per application, DACH medians: Indeed €161, Google €179, LinkedIn €96, Meta €84 (TalentBait, 2,549 campaigns, 2024–26) · share qualified: 28% of applications suitable (IAB-Stellenerhebung 2026) · pools: BA employment statistics by KldB code (Dec 2025) · time-to-offer: SmartRecruiters Germany benchmark. Every source and every remaining own estimate is labelled with its URL on the Assumptions tab.</a:t>
+              <a:t>Sourced: StepStone €1,449/30-day ad (stepstone.de price list) · cost per application, DACH medians: Indeed €161, Google €179, LinkedIn €96, Meta €84 (TalentBait, 2,549 campaigns, 2024–26) · share qualified: 28% of applications suitable (IAB-Stellenerhebung 2026) · pools: BA employment statistics by KldB code (Dec 2025) · time-to-offer: SmartRecruiters Germany benchmark. Every source, its link and every remaining own estimate are on the Sources tab of the model.</a:t>
             </a:r>
             <a:endParaRPr lang="en-US" sz="1000" dirty="0"/>
           </a:p>

</xml_diff>

<commit_message>
Trim workbook to 8 tabs and harden it against single-input changes
Fold the pool check into Funnel and the scenario engine into Budget (all
references rewritten, outputs identical); drop the Guide and Sources tabs and
make each source on Assumptions clickable. Re-spread weekly shares that fall
after the cut-off so date/lag changes never strand spend; whole-day lag inputs.
Add a one-at-a-time sweep over all 218 inputs and a live-round Tracker rules test.

Co-Authored-By: Claude Opus 5.5 <noreply@anthropic.com>
Claude-Session: https://claude.ai/code/session_01V2NJtrYy3bzNxqKeiRXJfY
</commit_message>
<xml_diff>
--- a/operation_uptime/Operation_Uptime_Deck.pptx
+++ b/operation_uptime/Operation_Uptime_Deck.pptx
@@ -114,30 +114,30 @@
   <p:extLst>
     <p:ext uri="{521415D9-36F7-43E2-AB2F-B90AF26B5E84}">
       <p14:sectionLst xmlns:p14="http://schemas.microsoft.com/office/powerpoint/2010/main">
-        <p14:section name="Summary" id="{2596f74d-fb4a-fbb1-4ee1-31559558fa9d}">
+        <p14:section name="Summary" id="{36be1f79-3887-4443-4e24-5ec4a885815c}">
           <p14:sldIdLst>
             <p14:sldId id="256"/>
           </p14:sldIdLst>
         </p14:section>
-        <p14:section name="Part 1 Funnel" id="{7f6cca6b-0890-571c-905b-7a9036c35073}">
+        <p14:section name="Part 1 Funnel" id="{3e782c79-f585-9966-c89a-b790f94f19ad}">
           <p14:sldIdLst>
             <p14:sldId id="257"/>
             <p14:sldId id="258"/>
           </p14:sldIdLst>
         </p14:section>
-        <p14:section name="Part 2 Channels &amp; budget" id="{ad70c299-6e32-ef82-7795-d4fdae8eeebd}">
+        <p14:section name="Part 2 Channels &amp; budget" id="{17c6439d-bb3d-a118-0356-cc571bfcb041}">
           <p14:sldIdLst>
             <p14:sldId id="259"/>
             <p14:sldId id="260"/>
             <p14:sldId id="261"/>
           </p14:sldIdLst>
         </p14:section>
-        <p14:section name="Part 3 New sources" id="{59267c12-3ec3-6482-b322-98211a9a097a}">
+        <p14:section name="Part 3 New sources" id="{3edde6c8-9290-d423-84e2-c2d6a89dc256}">
           <p14:sldIdLst>
             <p14:sldId id="262"/>
           </p14:sldIdLst>
         </p14:section>
-        <p14:section name="Part 4 Run it" id="{b0558b36-5242-87bf-2094-1c36c8756a8f}">
+        <p14:section name="Part 4 Run it" id="{95904679-1b3f-005d-d1d4-36a78d0d1e40}">
           <p14:sldIdLst>
             <p14:sldId id="263"/>
           </p14:sldIdLst>
@@ -17102,7 +17102,7 @@
                   <a:schemeClr val="accent4"/>
                 </a:solidFill>
               </a:rPr>
-              <a:t>Sourced: StepStone €1,449/30-day ad (stepstone.de price list) · cost per application, DACH medians: Indeed €161, Google €179, LinkedIn €96, Meta €84 (TalentBait, 2,549 campaigns, 2024–26) · share qualified: 28% of applications suitable (IAB-Stellenerhebung 2026) · pools: BA employment statistics by KldB code (Dec 2025) · time-to-offer: SmartRecruiters Germany benchmark. Every source, its link and every remaining own estimate are on the Sources tab of the model.</a:t>
+              <a:t>Sourced: StepStone €1,449/30-day ad (stepstone.de price list) · cost per application, DACH medians: Indeed €161, Google €179, LinkedIn €96, Meta €84 (TalentBait, 2,549 campaigns, 2024–26) · share qualified: 28% of applications suitable (IAB-Stellenerhebung 2026) · pools: BA employment statistics by KldB code (Dec 2025) · time-to-offer: SmartRecruiters Germany benchmark. Every source (with its link) and every remaining own estimate is labelled on the Assumptions tab.</a:t>
             </a:r>
             <a:endParaRPr lang="en-US" sz="1000" dirty="0"/>
           </a:p>

</xml_diff>

<commit_message>
Source or derive every input; evidence-based channel quality, caps and pacing; data-driven deck text
Co-Authored-By: Claude Opus 5.5 <noreply@anthropic.com>
Claude-Session: https://claude.ai/code/session_01V2NJtrYy3bzNxqKeiRXJfY
</commit_message>
<xml_diff>
--- a/operation_uptime/Operation_Uptime_Deck.pptx
+++ b/operation_uptime/Operation_Uptime_Deck.pptx
@@ -114,30 +114,30 @@
   <p:extLst>
     <p:ext uri="{521415D9-36F7-43E2-AB2F-B90AF26B5E84}">
       <p14:sectionLst xmlns:p14="http://schemas.microsoft.com/office/powerpoint/2010/main">
-        <p14:section name="Summary" id="{36be1f79-3887-4443-4e24-5ec4a885815c}">
+        <p14:section name="Summary" id="{2bdee562-aee5-03b5-c7ad-e010321f31a4}">
           <p14:sldIdLst>
             <p14:sldId id="256"/>
           </p14:sldIdLst>
         </p14:section>
-        <p14:section name="Part 1 Funnel" id="{3e782c79-f585-9966-c89a-b790f94f19ad}">
+        <p14:section name="Part 1 Funnel" id="{b035a81c-5815-6f5a-0b24-58eb45efaff1}">
           <p14:sldIdLst>
             <p14:sldId id="257"/>
             <p14:sldId id="258"/>
           </p14:sldIdLst>
         </p14:section>
-        <p14:section name="Part 2 Channels &amp; budget" id="{17c6439d-bb3d-a118-0356-cc571bfcb041}">
+        <p14:section name="Part 2 Channels &amp; budget" id="{5f707b24-326e-ad07-33c7-7985bb7b13ec}">
           <p14:sldIdLst>
             <p14:sldId id="259"/>
             <p14:sldId id="260"/>
             <p14:sldId id="261"/>
           </p14:sldIdLst>
         </p14:section>
-        <p14:section name="Part 3 New sources" id="{3edde6c8-9290-d423-84e2-c2d6a89dc256}">
+        <p14:section name="Part 3 New sources" id="{8711c40d-43b5-81fe-9f67-08f022f71fc8}">
           <p14:sldIdLst>
             <p14:sldId id="262"/>
           </p14:sldIdLst>
         </p14:section>
-        <p14:section name="Part 4 Run it" id="{95904679-1b3f-005d-d1d4-36a78d0d1e40}">
+        <p14:section name="Part 4 Run it" id="{e0a91142-f22a-f722-a4c5-f92bd1ad51fd}">
           <p14:sldIdLst>
             <p14:sldId id="263"/>
           </p14:sldIdLst>
@@ -275,22 +275,22 @@
                 <c:formatCode>General</c:formatCode>
                 <c:ptCount val="7"/>
                 <c:pt idx="0">
-                  <c:v>37</c:v>
+                  <c:v>38</c:v>
                 </c:pt>
                 <c:pt idx="1">
-                  <c:v>52</c:v>
+                  <c:v>54</c:v>
                 </c:pt>
                 <c:pt idx="2">
-                  <c:v>53</c:v>
+                  <c:v>54</c:v>
                 </c:pt>
                 <c:pt idx="3">
-                  <c:v>54</c:v>
+                  <c:v>55</c:v>
                 </c:pt>
                 <c:pt idx="4">
-                  <c:v>54</c:v>
+                  <c:v>55</c:v>
                 </c:pt>
                 <c:pt idx="5">
-                  <c:v>55</c:v>
+                  <c:v>53</c:v>
                 </c:pt>
                 <c:pt idx="6">
                   <c:v>0</c:v>
@@ -693,10 +693,10 @@
                   <c:v>100</c:v>
                 </c:pt>
                 <c:pt idx="1">
-                  <c:v>72</c:v>
+                  <c:v>71</c:v>
                 </c:pt>
                 <c:pt idx="2">
-                  <c:v>72</c:v>
+                  <c:v>71</c:v>
                 </c:pt>
                 <c:pt idx="3">
                   <c:v>100</c:v>
@@ -705,7 +705,7 @@
                   <c:v>100</c:v>
                 </c:pt>
                 <c:pt idx="5">
-                  <c:v>72</c:v>
+                  <c:v>71</c:v>
                 </c:pt>
               </c:numCache>
             </c:numRef>
@@ -1107,22 +1107,22 @@
                 <c:formatCode>General</c:formatCode>
                 <c:ptCount val="9"/>
                 <c:pt idx="0">
-                  <c:v>4323</c:v>
+                  <c:v>15555</c:v>
                 </c:pt>
                 <c:pt idx="1">
-                  <c:v>6762</c:v>
+                  <c:v>24084</c:v>
                 </c:pt>
                 <c:pt idx="2">
-                  <c:v>9766</c:v>
+                  <c:v>27182</c:v>
                 </c:pt>
                 <c:pt idx="3">
-                  <c:v>12446</c:v>
+                  <c:v>27954</c:v>
                 </c:pt>
                 <c:pt idx="4">
-                  <c:v>12446</c:v>
+                  <c:v>27954</c:v>
                 </c:pt>
                 <c:pt idx="5">
-                  <c:v>12374</c:v>
+                  <c:v>22961</c:v>
                 </c:pt>
                 <c:pt idx="6">
                   <c:v>0</c:v>
@@ -1226,7 +1226,7 @@
                 <c:formatCode>General</c:formatCode>
                 <c:ptCount val="9"/>
                 <c:pt idx="0">
-                  <c:v>11743</c:v>
+                  <c:v>10294</c:v>
                 </c:pt>
                 <c:pt idx="1">
                   <c:v>0</c:v>
@@ -1354,22 +1354,22 @@
                   <c:v>0</c:v>
                 </c:pt>
                 <c:pt idx="3">
-                  <c:v>388</c:v>
+                  <c:v>1049</c:v>
                 </c:pt>
                 <c:pt idx="4">
-                  <c:v>702</c:v>
+                  <c:v>1720</c:v>
                 </c:pt>
                 <c:pt idx="5">
-                  <c:v>1031</c:v>
+                  <c:v>1981</c:v>
                 </c:pt>
                 <c:pt idx="6">
-                  <c:v>1346</c:v>
+                  <c:v>2052</c:v>
                 </c:pt>
                 <c:pt idx="7">
-                  <c:v>1406</c:v>
+                  <c:v>2057</c:v>
                 </c:pt>
                 <c:pt idx="8">
-                  <c:v>1655</c:v>
+                  <c:v>2371</c:v>
                 </c:pt>
               </c:numCache>
             </c:numRef>
@@ -1631,16 +1631,16 @@
                 <c:ptCount val="4"/>
                 <c:lvl>
                   <c:pt idx="0">
-                    <c:v>100% · €102.50k</c:v>
+                    <c:v>100% · €207.50k</c:v>
                   </c:pt>
                   <c:pt idx="1">
-                    <c:v>85% · €87.13k</c:v>
+                    <c:v>85% · €176.38k</c:v>
                   </c:pt>
                   <c:pt idx="2">
-                    <c:v>70% · €71.75k</c:v>
+                    <c:v>70% · €145.25k</c:v>
                   </c:pt>
                   <c:pt idx="3">
-                    <c:v>50% · €51.25k</c:v>
+                    <c:v>50% · €103.75k</c:v>
                   </c:pt>
                 </c:lvl>
               </c:multiLvlStrCache>
@@ -1656,13 +1656,13 @@
                   <c:v>30</c:v>
                 </c:pt>
                 <c:pt idx="1">
-                  <c:v>27.9</c:v>
+                  <c:v>29.9</c:v>
                 </c:pt>
                 <c:pt idx="2">
-                  <c:v>23.4</c:v>
+                  <c:v>27.1</c:v>
                 </c:pt>
                 <c:pt idx="3">
-                  <c:v>16.5</c:v>
+                  <c:v>17.2</c:v>
                 </c:pt>
               </c:numCache>
             </c:numRef>
@@ -1721,16 +1721,16 @@
                 <c:ptCount val="4"/>
                 <c:lvl>
                   <c:pt idx="0">
-                    <c:v>100% · €102.50k</c:v>
+                    <c:v>100% · €207.50k</c:v>
                   </c:pt>
                   <c:pt idx="1">
-                    <c:v>85% · €87.13k</c:v>
+                    <c:v>85% · €176.38k</c:v>
                   </c:pt>
                   <c:pt idx="2">
-                    <c:v>70% · €71.75k</c:v>
+                    <c:v>70% · €145.25k</c:v>
                   </c:pt>
                   <c:pt idx="3">
-                    <c:v>50% · €51.25k</c:v>
+                    <c:v>50% · €103.75k</c:v>
                   </c:pt>
                 </c:lvl>
               </c:multiLvlStrCache>
@@ -1811,16 +1811,16 @@
                 <c:ptCount val="4"/>
                 <c:lvl>
                   <c:pt idx="0">
-                    <c:v>100% · €102.50k</c:v>
+                    <c:v>100% · €207.50k</c:v>
                   </c:pt>
                   <c:pt idx="1">
-                    <c:v>85% · €87.13k</c:v>
+                    <c:v>85% · €176.38k</c:v>
                   </c:pt>
                   <c:pt idx="2">
-                    <c:v>70% · €71.75k</c:v>
+                    <c:v>70% · €145.25k</c:v>
                   </c:pt>
                   <c:pt idx="3">
-                    <c:v>50% · €51.25k</c:v>
+                    <c:v>50% · €103.75k</c:v>
                   </c:pt>
                 </c:lvl>
               </c:multiLvlStrCache>
@@ -1836,13 +1836,13 @@
                   <c:v>15</c:v>
                 </c:pt>
                 <c:pt idx="1">
-                  <c:v>14.7</c:v>
+                  <c:v>14.9</c:v>
                 </c:pt>
                 <c:pt idx="2">
-                  <c:v>14.7</c:v>
+                  <c:v>14.3</c:v>
                 </c:pt>
                 <c:pt idx="3">
-                  <c:v>14.7</c:v>
+                  <c:v>14.3</c:v>
                 </c:pt>
               </c:numCache>
             </c:numRef>
@@ -1901,16 +1901,16 @@
                 <c:ptCount val="4"/>
                 <c:lvl>
                   <c:pt idx="0">
-                    <c:v>100% · €102.50k</c:v>
+                    <c:v>100% · €207.50k</c:v>
                   </c:pt>
                   <c:pt idx="1">
-                    <c:v>85% · €87.13k</c:v>
+                    <c:v>85% · €176.38k</c:v>
                   </c:pt>
                   <c:pt idx="2">
-                    <c:v>70% · €71.75k</c:v>
+                    <c:v>70% · €145.25k</c:v>
                   </c:pt>
                   <c:pt idx="3">
-                    <c:v>50% · €51.25k</c:v>
+                    <c:v>50% · €103.75k</c:v>
                   </c:pt>
                 </c:lvl>
               </c:multiLvlStrCache>
@@ -1926,13 +1926,13 @@
                   <c:v>10</c:v>
                 </c:pt>
                 <c:pt idx="1">
-                  <c:v>9.8</c:v>
+                  <c:v>4.6</c:v>
                 </c:pt>
                 <c:pt idx="2">
-                  <c:v>9.8</c:v>
+                  <c:v>1.6</c:v>
                 </c:pt>
                 <c:pt idx="3">
-                  <c:v>9.4</c:v>
+                  <c:v>1.6</c:v>
                 </c:pt>
               </c:numCache>
             </c:numRef>
@@ -3760,7 +3760,7 @@
                 <a:ea typeface="Cambria" pitchFamily="34" charset="-122"/>
                 <a:cs typeface="Cambria" pitchFamily="34" charset="-120"/>
               </a:rPr>
-              <a:t>€102.5k signs 100 maintenance hires by 31 Dec if the 55 weekly assessments hold</a:t>
+              <a:t>€207.5k signs 100 maintenance hires by 31 Dec if the 55 weekly assessments hold</a:t>
             </a:r>
             <a:endParaRPr lang="en-US" sz="2200" dirty="0"/>
           </a:p>
@@ -3826,7 +3826,7 @@
                 <a:ea typeface="Cambria" pitchFamily="34" charset="-122"/>
                 <a:cs typeface="Cambria" pitchFamily="34" charset="-120"/>
               </a:rPr>
-              <a:t>€102.5k</a:t>
+              <a:t>€207.5k</a:t>
             </a:r>
             <a:endParaRPr lang="en-US" sz="2600" dirty="0"/>
           </a:p>
@@ -3862,7 +3862,7 @@
                   <a:schemeClr val="tx2"/>
                 </a:solidFill>
               </a:rPr>
-              <a:t>recommended budget: €85.4k planned + €17.1k reserve released only on results</a:t>
+              <a:t>recommended budget: €176.2k planned + €31.3k reserve released only on results</a:t>
             </a:r>
             <a:endParaRPr lang="en-US" sz="1000" dirty="0"/>
           </a:p>
@@ -3928,7 +3928,7 @@
                 <a:ea typeface="Cambria" pitchFamily="34" charset="-122"/>
                 <a:cs typeface="Cambria" pitchFamily="34" charset="-120"/>
               </a:rPr>
-              <a:t>€854</a:t>
+              <a:t>€1,762</a:t>
             </a:r>
             <a:endParaRPr lang="en-US" sz="2600" dirty="0"/>
           </a:p>
@@ -3964,7 +3964,7 @@
                   <a:schemeClr val="tx2"/>
                 </a:solidFill>
               </a:rPr>
-              <a:t>media cost per hire (≤€1,025 if the reserve is spent); excludes Joveo fees</a:t>
+              <a:t>media cost per hire (≤€2,075 if the reserve is spent); excludes Joveo fees</a:t>
             </a:r>
             <a:endParaRPr lang="en-US" sz="1000" dirty="0"/>
           </a:p>
@@ -4030,7 +4030,7 @@
                 <a:ea typeface="Cambria" pitchFamily="34" charset="-122"/>
                 <a:cs typeface="Cambria" pitchFamily="34" charset="-120"/>
               </a:rPr>
-              <a:t>97%</a:t>
+              <a:t>98%</a:t>
             </a:r>
             <a:endParaRPr lang="en-US" sz="2600" dirty="0"/>
           </a:p>
@@ -4066,7 +4066,7 @@
                   <a:schemeClr val="tx2"/>
                 </a:solidFill>
               </a:rPr>
-              <a:t>of 314 assessment slots used (305 qualified). Capacity, not money, is the limit</a:t>
+              <a:t>of 314 assessment slots used (309 qualified). Capacity, not money, is the limit</a:t>
             </a:r>
             <a:endParaRPr lang="en-US" sz="1000" dirty="0"/>
           </a:p>
@@ -4215,7 +4215,7 @@
                   <a:schemeClr val="tx1"/>
                 </a:solidFill>
               </a:rPr>
-              <a:t>~50% we sign all 100, ~80% at least 90 (my judgement; slots are 97% used). If pass or acceptance rates are 30% worse, ~72. </a:t>
+              <a:t>100 if the funnel rates hold, with slots 98% used. Pass rates 10% worse: ~92 hires (slots run out); 30% worse: ~71. </a:t>
             </a:r>
             <a:pPr indent="0" marL="0">
               <a:buNone/>
@@ -4237,7 +4237,7 @@
                   <a:schemeClr val="tx1"/>
                 </a:solidFill>
               </a:rPr>
-              <a:t>(€71.75k): ~93 hires; electricians fall short first (23 of 30).</a:t>
+              <a:t>(€145.25k): ~88 hires; supervisors fall short first (1.6 of 10).</a:t>
             </a:r>
             <a:endParaRPr lang="en-US" sz="1100" dirty="0"/>
           </a:p>
@@ -4266,11 +4266,11 @@
             <a:tbl>
               <a:tblPr/>
               <a:tblGrid>
-                <a:gridCol w="914400"/>
-                <a:gridCol w="475488"/>
-                <a:gridCol w="548640"/>
+                <a:gridCol w="896112"/>
+                <a:gridCol w="457200"/>
                 <a:gridCol w="640080"/>
-                <a:gridCol w="1536192"/>
+                <a:gridCol w="603504"/>
+                <a:gridCol w="1517904"/>
               </a:tblGrid>
               <a:tr h="411480">
                 <a:tc>
@@ -4762,7 +4762,7 @@
                           <a:ea typeface="Calibri" pitchFamily="34" charset="-122"/>
                           <a:cs typeface="Calibri" pitchFamily="34" charset="-120"/>
                         </a:rPr>
-                        <a:t>€46.5k</a:t>
+                        <a:t>€70.7k</a:t>
                       </a:r>
                       <a:endParaRPr lang="en-US" sz="1000" dirty="0">
                         <a:latin typeface="Calibri" charset="0"/>
@@ -4827,7 +4827,7 @@
                           <a:ea typeface="Calibri" pitchFamily="34" charset="-122"/>
                           <a:cs typeface="Calibri" pitchFamily="34" charset="-120"/>
                         </a:rPr>
-                        <a:t>€1,550</a:t>
+                        <a:t>€2,356</a:t>
                       </a:r>
                       <a:endParaRPr lang="en-US" sz="1000" dirty="0">
                         <a:latin typeface="Calibri" charset="0"/>
@@ -4892,7 +4892,7 @@
                           <a:ea typeface="Calibri" pitchFamily="34" charset="-122"/>
                           <a:cs typeface="Calibri" pitchFamily="34" charset="-120"/>
                         </a:rPr>
-                        <a:t>Handwerk→Industrie 9.5 · rediscovery 4.3 · StepStone 4.3 · referrals 4.1 · organic 3.8 · other 4.1</a:t>
+                        <a:t>Meta 9.5 · Handwerk→Industrie 8.5 · organic 3.5 · referrals 3.3 · programmatic 3.2 · other 2.1</a:t>
                       </a:r>
                       <a:endParaRPr lang="en-US" sz="900" dirty="0">
                         <a:latin typeface="Calibri" charset="0"/>
@@ -5089,7 +5089,7 @@
                           <a:ea typeface="Calibri" pitchFamily="34" charset="-122"/>
                           <a:cs typeface="Calibri" pitchFamily="34" charset="-120"/>
                         </a:rPr>
-                        <a:t>€9.7k</a:t>
+                        <a:t>€33.9k</a:t>
                       </a:r>
                       <a:endParaRPr lang="en-US" sz="1000" dirty="0">
                         <a:latin typeface="Calibri" charset="0"/>
@@ -5154,7 +5154,7 @@
                           <a:ea typeface="Calibri" pitchFamily="34" charset="-122"/>
                           <a:cs typeface="Calibri" pitchFamily="34" charset="-120"/>
                         </a:rPr>
-                        <a:t>€215</a:t>
+                        <a:t>€752</a:t>
                       </a:r>
                       <a:endParaRPr lang="en-US" sz="1000" dirty="0">
                         <a:latin typeface="Calibri" charset="0"/>
@@ -5219,7 +5219,7 @@
                           <a:ea typeface="Calibri" pitchFamily="34" charset="-122"/>
                           <a:cs typeface="Calibri" pitchFamily="34" charset="-120"/>
                         </a:rPr>
-                        <a:t>Polish corridor 18.0 · organic 13.4 · rediscovery 7.7 · StepStone 4.8 · tests 1.2</a:t>
+                        <a:t>Polish corridor 18.0 · organic 9.2 · Meta 8.2 · referrals 5.8 · StepStone 1.8 · other 2.1</a:t>
                       </a:r>
                       <a:endParaRPr lang="en-US" sz="900" dirty="0">
                         <a:latin typeface="Calibri" charset="0"/>
@@ -5416,7 +5416,7 @@
                           <a:ea typeface="Calibri" pitchFamily="34" charset="-122"/>
                           <a:cs typeface="Calibri" pitchFamily="34" charset="-120"/>
                         </a:rPr>
-                        <a:t>€14.6k</a:t>
+                        <a:t>€32.4k</a:t>
                       </a:r>
                       <a:endParaRPr lang="en-US" sz="1000" dirty="0">
                         <a:latin typeface="Calibri" charset="0"/>
@@ -5481,7 +5481,7 @@
                           <a:ea typeface="Calibri" pitchFamily="34" charset="-122"/>
                           <a:cs typeface="Calibri" pitchFamily="34" charset="-120"/>
                         </a:rPr>
-                        <a:t>€975</a:t>
+                        <a:t>€2,158</a:t>
                       </a:r>
                       <a:endParaRPr lang="en-US" sz="1000" dirty="0">
                         <a:latin typeface="Calibri" charset="0"/>
@@ -5546,7 +5546,7 @@
                           <a:ea typeface="Calibri" pitchFamily="34" charset="-122"/>
                           <a:cs typeface="Calibri" pitchFamily="34" charset="-120"/>
                         </a:rPr>
-                        <a:t>LinkedIn 8.6 · rediscovery 2.3 · organic 2.3 · referrals 1.5 · tests 0.3</a:t>
+                        <a:t>LinkedIn 10.0 · organic 1.6 · referrals 1.5 · StepStone 0.9 · programmatic 0.5 · other 0.5</a:t>
                       </a:r>
                       <a:endParaRPr lang="en-US" sz="900" dirty="0">
                         <a:latin typeface="Calibri" charset="0"/>
@@ -5743,7 +5743,7 @@
                           <a:ea typeface="Calibri" pitchFamily="34" charset="-122"/>
                           <a:cs typeface="Calibri" pitchFamily="34" charset="-120"/>
                         </a:rPr>
-                        <a:t>€14.6k</a:t>
+                        <a:t>€39.3k</a:t>
                       </a:r>
                       <a:endParaRPr lang="en-US" sz="1000" dirty="0">
                         <a:latin typeface="Calibri" charset="0"/>
@@ -5808,7 +5808,7 @@
                           <a:ea typeface="Calibri" pitchFamily="34" charset="-122"/>
                           <a:cs typeface="Calibri" pitchFamily="34" charset="-120"/>
                         </a:rPr>
-                        <a:t>€1,457</a:t>
+                        <a:t>€3,930</a:t>
                       </a:r>
                       <a:endParaRPr lang="en-US" sz="1000" dirty="0">
                         <a:latin typeface="Calibri" charset="0"/>
@@ -5873,7 +5873,7 @@
                           <a:ea typeface="Calibri" pitchFamily="34" charset="-122"/>
                           <a:cs typeface="Calibri" pitchFamily="34" charset="-120"/>
                         </a:rPr>
-                        <a:t>LinkedIn 4.5 · StepStone 1.8 · rediscovery 1.3 · organic 1.1 · referrals 1.0 · other 0.2</a:t>
+                        <a:t>LinkedIn 8.3 · referrals 0.7 · organic 0.6 · rediscovery 0.2 · tests 0.2</a:t>
                       </a:r>
                       <a:endParaRPr lang="en-US" sz="900" dirty="0">
                         <a:latin typeface="Calibri" charset="0"/>
@@ -6070,7 +6070,7 @@
                           <a:ea typeface="Calibri" pitchFamily="34" charset="-122"/>
                           <a:cs typeface="Calibri" pitchFamily="34" charset="-120"/>
                         </a:rPr>
-                        <a:t>€85.4k</a:t>
+                        <a:t>€176.2k</a:t>
                       </a:r>
                       <a:endParaRPr lang="en-US" sz="1000" dirty="0">
                         <a:latin typeface="Calibri" charset="0"/>
@@ -6135,7 +6135,7 @@
                           <a:ea typeface="Calibri" pitchFamily="34" charset="-122"/>
                           <a:cs typeface="Calibri" pitchFamily="34" charset="-120"/>
                         </a:rPr>
-                        <a:t>€854</a:t>
+                        <a:t>€1,762</a:t>
                       </a:r>
                       <a:endParaRPr lang="en-US" sz="1000" dirty="0">
                         <a:latin typeface="Calibri" charset="0"/>
@@ -6200,7 +6200,7 @@
                           <a:ea typeface="Calibri" pitchFamily="34" charset="-122"/>
                           <a:cs typeface="Calibri" pitchFamily="34" charset="-120"/>
                         </a:rPr>
-                        <a:t>+ €17.1k reserve = €102.5k</a:t>
+                        <a:t>+ €31.3k reserve = €207.5k</a:t>
                       </a:r>
                       <a:endParaRPr lang="en-US" sz="900" dirty="0">
                         <a:latin typeface="Calibri" charset="0"/>
@@ -6294,7 +6294,7 @@
                   <a:schemeClr val="tx1"/>
                 </a:solidFill>
               </a:rPr>
-              <a:t>€750 test in every paid CPC/CPA cell in weeks 1–2, then buy hires cheapest-first: free channels → ATS rediscovery (~€13/hire) → Polish corridor (≤40% of mechatronics) → StepStone (7 ads) → referrals, LinkedIn → construction-electrician campaign, Search. Pace ≤55 qualified a week; paid spend stops Tue 24 Nov.</a:t>
+              <a:t>€750 test in every paid CPC/CPA cell in weeks 1–2, then buy hires cheapest-first: free channels → ATS rediscovery → Polish corridor (≤40% of mechatronics) → referrals → construction-electrician campaign → StepStone → Meta → LinkedIn → programmatic. Pace ≤55 qualified a week; paid spend stops Tue 24 Nov.</a:t>
             </a:r>
             <a:endParaRPr lang="en-US" sz="1100" dirty="0"/>
           </a:p>
@@ -6434,7 +6434,7 @@
                   <a:schemeClr val="tx1"/>
                 </a:solidFill>
               </a:rPr>
-              <a:t>97% used. Pre-screened sources first, pace ≤55/wk, ask +10–15 slots (65/wk → 80% use).</a:t>
+              <a:t>98% used. Pre-screened sources first, pace ≤55/wk, ask +10–15 slots (65/wk → 81% use).</a:t>
             </a:r>
             <a:endParaRPr lang="en-US" sz="1100" dirty="0"/>
           </a:p>
@@ -6465,7 +6465,7 @@
                   <a:schemeClr val="tx1"/>
                 </a:solidFill>
               </a:rPr>
-              <a:t>~9 of 30 need your OK on construction electricians by 23 Oct; else more StepStone (~€1,022/hire), then Search and programmatic at €3.8k–€4.3k/hire.</a:t>
+              <a:t>~9 of 30 need your OK on construction electricians by 23 Oct; without them programmatic ads fill the gap and the budget rises to €225.0k.</a:t>
             </a:r>
             <a:endParaRPr lang="en-US" sz="1100" dirty="0"/>
           </a:p>
@@ -6695,7 +6695,7 @@
                   <a:schemeClr val="tx1"/>
                 </a:solidFill>
               </a:rPr>
-              <a:t>3-day offers, e-signature to 18 Dec; approve €102.5k</a:t>
+              <a:t>3-day offers, e-signature to 18 Dec; approve €207.5k</a:t>
             </a:r>
             <a:endParaRPr lang="en-US" sz="1100" dirty="0"/>
           </a:p>
@@ -6845,7 +6845,7 @@
                 <a:ea typeface="Cambria" pitchFamily="34" charset="-122"/>
                 <a:cs typeface="Cambria" pitchFamily="34" charset="-120"/>
               </a:rPr>
-              <a:t>Working back from 100 hires: ~305 qualified applicants for 314 assessment slots</a:t>
+              <a:t>Working back from 100 hires: ~309 qualified applicants for 314 assessment slots</a:t>
             </a:r>
             <a:endParaRPr lang="en-US" sz="2200" dirty="0"/>
           </a:p>
@@ -8614,7 +8614,7 @@
                             <a:schemeClr val="tx1"/>
                           </a:solidFill>
                         </a:rPr>
-                        <a:t>12%</a:t>
+                        <a:t>15%</a:t>
                       </a:r>
                       <a:endParaRPr lang="en-US" sz="1100" dirty="0"/>
                     </a:p>
@@ -8962,7 +8962,7 @@
                             <a:schemeClr val="tx1"/>
                           </a:solidFill>
                         </a:rPr>
-                        <a:t>441</a:t>
+                        <a:t>353</a:t>
                       </a:r>
                       <a:endParaRPr lang="en-US" sz="1100" dirty="0"/>
                     </a:p>
@@ -9978,7 +9978,7 @@
                             <a:schemeClr val="tx1"/>
                           </a:solidFill>
                         </a:rPr>
-                        <a:t>2,047</a:t>
+                        <a:t>1,959</a:t>
                       </a:r>
                       <a:endParaRPr lang="en-US" sz="1100" dirty="0"/>
                     </a:p>
@@ -10079,7 +10079,7 @@
                   <a:schemeClr val="tx1"/>
                 </a:solidFill>
               </a:rPr>
-              <a:t>305 qualified / 1,525 applications</a:t>
+              <a:t>309 qualified / 2,413 applications</a:t>
             </a:r>
             <a:pPr indent="0" marL="0">
               <a:buNone/>
@@ -10189,7 +10189,7 @@
                   <a:schemeClr val="tx2"/>
                 </a:solidFill>
               </a:rPr>
-              <a:t>Week 1: 37 of 39 slots; weeks 2–5: 52–54 of 55; week 6: 55; assessments end Mon 30 Nov. Rediscovery re-applicants (waves 21 Oct, 26 Oct and 2 Nov) and the €750 tests fill weeks 1–2, so regular spend ramps 7%, 11%, 16%, then 21–25% a week.</a:t>
+              <a:t>Week 1: 38 of 39 slots; weeks 2–5: 54–55 of 55; week 6: 53; assessments end Mon 30 Nov. Rediscovery re-applicants (waves 21 Oct, 26 Oct and 2 Nov) and the €750 tests fill weeks 1–2, so regular spend ramps 10%, 16%, 18%, then 18–21% a week.</a:t>
             </a:r>
             <a:endParaRPr lang="en-US" sz="1100" dirty="0"/>
           </a:p>
@@ -10339,7 +10339,7 @@
                 <a:ea typeface="Cambria" pitchFamily="34" charset="-122"/>
                 <a:cs typeface="Cambria" pitchFamily="34" charset="-120"/>
               </a:rPr>
-              <a:t>Electricians are hardest; a 30% worse pass rate costs ~28 hires that money can't buy back</a:t>
+              <a:t>Electricians are hardest; a 30% worse pass rate costs ~29 hires that money can't buy back</a:t>
             </a:r>
             <a:endParaRPr lang="en-US" sz="2200" dirty="0"/>
           </a:p>
@@ -10816,7 +10816,7 @@
                             <a:schemeClr val="tx1"/>
                           </a:solidFill>
                         </a:rPr>
-                        <a:t>1.8×</a:t>
+                        <a:t>3.7×</a:t>
                       </a:r>
                       <a:endParaRPr lang="en-US" sz="1100" dirty="0"/>
                     </a:p>
@@ -10874,7 +10874,7 @@
                             <a:schemeClr val="accent3"/>
                           </a:solidFill>
                         </a:rPr>
-                        <a:t>1.5×</a:t>
+                        <a:t>3.4×</a:t>
                       </a:r>
                       <a:endParaRPr lang="en-US" sz="1100" dirty="0"/>
                     </a:p>
@@ -10932,7 +10932,7 @@
                             <a:schemeClr val="tx1"/>
                           </a:solidFill>
                         </a:rPr>
-                        <a:t>14%</a:t>
+                        <a:t>12%</a:t>
                       </a:r>
                       <a:endParaRPr lang="en-US" sz="1100" dirty="0"/>
                     </a:p>
@@ -11166,7 +11166,7 @@
                             <a:schemeClr val="tx1"/>
                           </a:solidFill>
                         </a:rPr>
-                        <a:t>3.0×</a:t>
+                        <a:t>12.2×</a:t>
                       </a:r>
                       <a:endParaRPr lang="en-US" sz="1100" dirty="0"/>
                     </a:p>
@@ -11224,7 +11224,7 @@
                             <a:schemeClr val="tx1"/>
                           </a:solidFill>
                         </a:rPr>
-                        <a:t>3.0×</a:t>
+                        <a:t>12.2×</a:t>
                       </a:r>
                       <a:endParaRPr lang="en-US" sz="1100" dirty="0"/>
                     </a:p>
@@ -11282,7 +11282,7 @@
                             <a:schemeClr val="tx1"/>
                           </a:solidFill>
                         </a:rPr>
-                        <a:t>7%</a:t>
+                        <a:t>4%</a:t>
                       </a:r>
                       <a:endParaRPr lang="en-US" sz="1100" dirty="0"/>
                     </a:p>
@@ -11516,7 +11516,7 @@
                             <a:schemeClr val="tx1"/>
                           </a:solidFill>
                         </a:rPr>
-                        <a:t>1.9×</a:t>
+                        <a:t>3.0×</a:t>
                       </a:r>
                       <a:endParaRPr lang="en-US" sz="1100" dirty="0"/>
                     </a:p>
@@ -11574,7 +11574,7 @@
                             <a:schemeClr val="tx1"/>
                           </a:solidFill>
                         </a:rPr>
-                        <a:t>1.9×</a:t>
+                        <a:t>3.0×</a:t>
                       </a:r>
                       <a:endParaRPr lang="en-US" sz="1100" dirty="0"/>
                     </a:p>
@@ -11632,7 +11632,7 @@
                             <a:schemeClr val="tx1"/>
                           </a:solidFill>
                         </a:rPr>
-                        <a:t>10%</a:t>
+                        <a:t>22%</a:t>
                       </a:r>
                       <a:endParaRPr lang="en-US" sz="1100" dirty="0"/>
                     </a:p>
@@ -11866,7 +11866,7 @@
                             <a:schemeClr val="tx1"/>
                           </a:solidFill>
                         </a:rPr>
-                        <a:t>1.6×</a:t>
+                        <a:t>3.8×</a:t>
                       </a:r>
                       <a:endParaRPr lang="en-US" sz="1100" dirty="0"/>
                     </a:p>
@@ -11924,7 +11924,7 @@
                             <a:schemeClr val="tx1"/>
                           </a:solidFill>
                         </a:rPr>
-                        <a:t>1.6×</a:t>
+                        <a:t>3.8×</a:t>
                       </a:r>
                       <a:endParaRPr lang="en-US" sz="1100" dirty="0"/>
                     </a:p>
@@ -11982,7 +11982,7 @@
                             <a:schemeClr val="tx1"/>
                           </a:solidFill>
                         </a:rPr>
-                        <a:t>19%</a:t>
+                        <a:t>17%</a:t>
                       </a:r>
                       <a:endParaRPr lang="en-US" sz="1100" dirty="0"/>
                     </a:p>
@@ -12188,7 +12188,7 @@
                   <a:schemeClr val="tx1"/>
                 </a:solidFill>
               </a:rPr>
-              <a:t>the largest scarce block (30), and the lowest coverage once the unproven construction-electrician campaign (I2) is removed. There is no Polish route and no foreign-trained route by 31 Dec, and energy/grid, rail, aerospace and agencies all chase the same certificate. Supervisors need a bigger share of a smaller pool, but they're only 10 hires with an internal-promotion fallback.</a:t>
+              <a:t>the scarcest trade in Brandenburg (KOFA 2026: 85.7% of vacancies have no suitable unemployed candidate, vs 41.4% across all occupations) and the largest scarce block (30), so they take 40% of the money. No Polish route and no foreign-trained route by 31 Dec. Supervisors cost more per hire and automation has thinner coverage, but they are 10 and 15 hires with fallbacks (internal promotion, foreign-trained).</a:t>
             </a:r>
             <a:endParaRPr lang="en-US" sz="1200" dirty="0"/>
           </a:p>
@@ -12235,7 +12235,7 @@
                   <a:schemeClr val="tx1"/>
                 </a:solidFill>
               </a:rPr>
-              <a:t>30% worse pass or acceptance rates need 436 qualified for 314 slots (139%). The 43% more media that would need can't help: slots cap hires at ~72. Upstream misses (share qualified, cost per application) only cost money.</a:t>
+              <a:t>30% worse pass or acceptance rates need 441 qualified for 314 slots (140%). The 43% more media that would need can't help: slots cap hires at ~71. Upstream misses (share qualified, cost per application) only cost money.</a:t>
             </a:r>
             <a:endParaRPr lang="en-US" sz="1200" dirty="0"/>
           </a:p>
@@ -12542,7 +12542,7 @@
                             <a:schemeClr val="tx1"/>
                           </a:solidFill>
                         </a:rPr>
-                        <a:t>436</a:t>
+                        <a:t>441</a:t>
                       </a:r>
                       <a:endParaRPr lang="en-US" sz="1000" dirty="0"/>
                     </a:p>
@@ -12718,7 +12718,7 @@
                             <a:schemeClr val="tx1"/>
                           </a:solidFill>
                         </a:rPr>
-                        <a:t>436</a:t>
+                        <a:t>441</a:t>
                       </a:r>
                       <a:endParaRPr lang="en-US" sz="1000" dirty="0"/>
                     </a:p>
@@ -12894,7 +12894,7 @@
                             <a:schemeClr val="tx1"/>
                           </a:solidFill>
                         </a:rPr>
-                        <a:t>305</a:t>
+                        <a:t>309</a:t>
                       </a:r>
                       <a:endParaRPr lang="en-US" sz="1000" dirty="0"/>
                     </a:p>
@@ -13070,7 +13070,7 @@
                             <a:schemeClr val="tx1"/>
                           </a:solidFill>
                         </a:rPr>
-                        <a:t>305</a:t>
+                        <a:t>309</a:t>
                       </a:r>
                       <a:endParaRPr lang="en-US" sz="1000" dirty="0"/>
                     </a:p>
@@ -13246,7 +13246,7 @@
                             <a:schemeClr val="tx1"/>
                           </a:solidFill>
                         </a:rPr>
-                        <a:t>305</a:t>
+                        <a:t>309</a:t>
                       </a:r>
                       <a:endParaRPr lang="en-US" sz="1000" dirty="0"/>
                     </a:p>
@@ -13497,7 +13497,7 @@
                 <a:ea typeface="Cambria" pitchFamily="34" charset="-122"/>
                 <a:cs typeface="Cambria" pitchFamily="34" charset="-120"/>
               </a:rPr>
-              <a:t>Each role buys hires cheapest-first; electricians run out of cheap sources after ~8</a:t>
+              <a:t>Each role buys hires cheapest-first; electricians run out of cheap sources after ~4</a:t>
             </a:r>
             <a:endParaRPr lang="en-US" sz="2200" dirty="0"/>
           </a:p>
@@ -13912,7 +13912,7 @@
                             <a:schemeClr val="tx1"/>
                           </a:solidFill>
                         </a:rPr>
-                        <a:t>€0 / €0 · 3.8</a:t>
+                        <a:t>€0 / €0 · 3.5</a:t>
                       </a:r>
                       <a:endParaRPr lang="en-US" sz="1000" dirty="0"/>
                     </a:p>
@@ -13973,7 +13973,7 @@
                             <a:schemeClr val="tx1"/>
                           </a:solidFill>
                         </a:rPr>
-                        <a:t>€0 / €0 · 13.4</a:t>
+                        <a:t>€0 / €0 · 9.2</a:t>
                       </a:r>
                       <a:endParaRPr lang="en-US" sz="1000" dirty="0"/>
                     </a:p>
@@ -14034,7 +14034,7 @@
                             <a:schemeClr val="tx1"/>
                           </a:solidFill>
                         </a:rPr>
-                        <a:t>€0 / €0 · 2.3</a:t>
+                        <a:t>€0 / €0 · 1.6</a:t>
                       </a:r>
                       <a:endParaRPr lang="en-US" sz="1000" dirty="0"/>
                     </a:p>
@@ -14095,7 +14095,7 @@
                             <a:schemeClr val="tx1"/>
                           </a:solidFill>
                         </a:rPr>
-                        <a:t>€0 / €0 · 1.1</a:t>
+                        <a:t>€0 / €0 · 0.6</a:t>
                       </a:r>
                       <a:endParaRPr lang="en-US" sz="1000" dirty="0"/>
                     </a:p>
@@ -14216,7 +14216,7 @@
                             <a:schemeClr val="tx1"/>
                           </a:solidFill>
                         </a:rPr>
-                        <a:t>€5 / €14 · 4.3</a:t>
+                        <a:t>€5 / €14 · 0.9</a:t>
                       </a:r>
                       <a:endParaRPr lang="en-US" sz="1000" dirty="0"/>
                     </a:p>
@@ -14277,7 +14277,7 @@
                             <a:schemeClr val="tx1"/>
                           </a:solidFill>
                         </a:rPr>
-                        <a:t>€5 / €12 · 7.7</a:t>
+                        <a:t>€5 / €12 · 1.6</a:t>
                       </a:r>
                       <a:endParaRPr lang="en-US" sz="1000" dirty="0"/>
                     </a:p>
@@ -14338,7 +14338,7 @@
                             <a:schemeClr val="tx1"/>
                           </a:solidFill>
                         </a:rPr>
-                        <a:t>€5 / €15 · 2.3</a:t>
+                        <a:t>€5 / €15 · 0.4</a:t>
                       </a:r>
                       <a:endParaRPr lang="en-US" sz="1000" dirty="0"/>
                     </a:p>
@@ -14399,7 +14399,7 @@
                             <a:schemeClr val="tx1"/>
                           </a:solidFill>
                         </a:rPr>
-                        <a:t>€5 / €18 · 1.3</a:t>
+                        <a:t>€5 / €18 · 0.2</a:t>
                       </a:r>
                       <a:endParaRPr lang="en-US" sz="1000" dirty="0"/>
                     </a:p>
@@ -14578,7 +14578,7 @@
                             <a:schemeClr val="tx1"/>
                           </a:solidFill>
                         </a:rPr>
-                        <a:t>€92 / €248 · 18.0</a:t>
+                        <a:t>€134 / €383 · 18.0</a:t>
                       </a:r>
                       <a:endParaRPr lang="en-US" sz="1000" dirty="0"/>
                     </a:p>
@@ -14757,7 +14757,7 @@
                             <a:schemeClr val="tx1"/>
                           </a:solidFill>
                         </a:rPr>
-                        <a:t>StepStone (German, CV-based, €1,449/ad)</a:t>
+                        <a:t>I1b Referrals (€1,000 bonus on hire)</a:t>
                       </a:r>
                       <a:endParaRPr lang="en-US" sz="1000" dirty="0"/>
                     </a:p>
@@ -14815,7 +14815,7 @@
                             <a:schemeClr val="tx1"/>
                           </a:solidFill>
                         </a:rPr>
-                        <a:t>€322 / €1,022 · 4.3</a:t>
+                        <a:t>€362 / €1,000 · 3.3</a:t>
                       </a:r>
                       <a:endParaRPr lang="en-US" sz="1000" dirty="0"/>
                     </a:p>
@@ -14876,7 +14876,7 @@
                             <a:schemeClr val="tx1"/>
                           </a:solidFill>
                         </a:rPr>
-                        <a:t>€166 / €446 · 4.8</a:t>
+                        <a:t>€427 / €1,000 · 5.8</a:t>
                       </a:r>
                       <a:endParaRPr lang="en-US" sz="1000" dirty="0"/>
                     </a:p>
@@ -14937,7 +14937,372 @@
                             <a:schemeClr val="tx1"/>
                           </a:solidFill>
                         </a:rPr>
-                        <a:t>€386 / €1,363 · –</a:t>
+                        <a:t>€326 / €1,000 · 1.5</a:t>
+                      </a:r>
+                      <a:endParaRPr lang="en-US" sz="1000" dirty="0"/>
+                    </a:p>
+                  </a:txBody>
+                  <a:tcPr marL="91440" marR="91440" marT="45720" marB="45720" anchor="ctr">
+                    <a:lnL w="6350" cap="flat" cmpd="sng" algn="ctr">
+                      <a:solidFill>
+                        <a:srgbClr val="D6DEE5"/>
+                      </a:solidFill>
+                      <a:prstDash val="solid"/>
+                      <a:round/>
+                      <a:headEnd type="none" w="med" len="med"/>
+                      <a:tailEnd type="none" w="med" len="med"/>
+                    </a:lnL>
+                    <a:lnR w="6350" cap="flat" cmpd="sng" algn="ctr">
+                      <a:solidFill>
+                        <a:srgbClr val="D6DEE5"/>
+                      </a:solidFill>
+                      <a:prstDash val="solid"/>
+                      <a:round/>
+                      <a:headEnd type="none" w="med" len="med"/>
+                      <a:tailEnd type="none" w="med" len="med"/>
+                    </a:lnR>
+                    <a:lnT w="6350" cap="flat" cmpd="sng" algn="ctr">
+                      <a:solidFill>
+                        <a:srgbClr val="D6DEE5"/>
+                      </a:solidFill>
+                      <a:prstDash val="solid"/>
+                      <a:round/>
+                      <a:headEnd type="none" w="med" len="med"/>
+                      <a:tailEnd type="none" w="med" len="med"/>
+                    </a:lnT>
+                    <a:lnB w="6350" cap="flat" cmpd="sng" algn="ctr">
+                      <a:solidFill>
+                        <a:srgbClr val="D6DEE5"/>
+                      </a:solidFill>
+                      <a:prstDash val="solid"/>
+                      <a:round/>
+                      <a:headEnd type="none" w="med" len="med"/>
+                      <a:tailEnd type="none" w="med" len="med"/>
+                    </a:lnB>
+                    <a:solidFill>
+                      <a:srgbClr val="DCEFE8"/>
+                    </a:solidFill>
+                  </a:tcPr>
+                </a:tc>
+                <a:tc>
+                  <a:txBody>
+                    <a:bodyPr/>
+                    <a:lstStyle/>
+                    <a:p>
+                      <a:pPr algn="ctr" indent="0" marL="0">
+                        <a:buNone/>
+                      </a:pPr>
+                      <a:r>
+                        <a:rPr lang="en-US" sz="1000" dirty="0">
+                          <a:solidFill>
+                            <a:schemeClr val="tx1"/>
+                          </a:solidFill>
+                        </a:rPr>
+                        <a:t>€274 / €1,000 · 0.7</a:t>
+                      </a:r>
+                      <a:endParaRPr lang="en-US" sz="1000" dirty="0"/>
+                    </a:p>
+                  </a:txBody>
+                  <a:tcPr marL="91440" marR="91440" marT="45720" marB="45720" anchor="ctr">
+                    <a:lnL w="6350" cap="flat" cmpd="sng" algn="ctr">
+                      <a:solidFill>
+                        <a:srgbClr val="D6DEE5"/>
+                      </a:solidFill>
+                      <a:prstDash val="solid"/>
+                      <a:round/>
+                      <a:headEnd type="none" w="med" len="med"/>
+                      <a:tailEnd type="none" w="med" len="med"/>
+                    </a:lnL>
+                    <a:lnR w="6350" cap="flat" cmpd="sng" algn="ctr">
+                      <a:solidFill>
+                        <a:srgbClr val="D6DEE5"/>
+                      </a:solidFill>
+                      <a:prstDash val="solid"/>
+                      <a:round/>
+                      <a:headEnd type="none" w="med" len="med"/>
+                      <a:tailEnd type="none" w="med" len="med"/>
+                    </a:lnR>
+                    <a:lnT w="6350" cap="flat" cmpd="sng" algn="ctr">
+                      <a:solidFill>
+                        <a:srgbClr val="D6DEE5"/>
+                      </a:solidFill>
+                      <a:prstDash val="solid"/>
+                      <a:round/>
+                      <a:headEnd type="none" w="med" len="med"/>
+                      <a:tailEnd type="none" w="med" len="med"/>
+                    </a:lnT>
+                    <a:lnB w="6350" cap="flat" cmpd="sng" algn="ctr">
+                      <a:solidFill>
+                        <a:srgbClr val="D6DEE5"/>
+                      </a:solidFill>
+                      <a:prstDash val="solid"/>
+                      <a:round/>
+                      <a:headEnd type="none" w="med" len="med"/>
+                      <a:tailEnd type="none" w="med" len="med"/>
+                    </a:lnB>
+                    <a:solidFill>
+                      <a:srgbClr val="DCEFE8"/>
+                    </a:solidFill>
+                  </a:tcPr>
+                </a:tc>
+              </a:tr>
+              <a:tr h="329184">
+                <a:tc>
+                  <a:txBody>
+                    <a:bodyPr/>
+                    <a:lstStyle/>
+                    <a:p>
+                      <a:pPr indent="0" marL="0">
+                        <a:buNone/>
+                      </a:pPr>
+                      <a:r>
+                        <a:rPr lang="en-US" sz="1000" dirty="0">
+                          <a:solidFill>
+                            <a:schemeClr val="tx1"/>
+                          </a:solidFill>
+                        </a:rPr>
+                        <a:t>StepStone (German, CV-based, €1,449/ad)</a:t>
+                      </a:r>
+                      <a:endParaRPr lang="en-US" sz="1000" dirty="0"/>
+                    </a:p>
+                  </a:txBody>
+                  <a:tcPr marL="91440" marR="91440" marT="45720" marB="45720" anchor="ctr">
+                    <a:lnL w="6350" cap="flat" cmpd="sng" algn="ctr">
+                      <a:solidFill>
+                        <a:srgbClr val="D6DEE5"/>
+                      </a:solidFill>
+                      <a:prstDash val="solid"/>
+                      <a:round/>
+                      <a:headEnd type="none" w="med" len="med"/>
+                      <a:tailEnd type="none" w="med" len="med"/>
+                    </a:lnL>
+                    <a:lnR w="6350" cap="flat" cmpd="sng" algn="ctr">
+                      <a:solidFill>
+                        <a:srgbClr val="D6DEE5"/>
+                      </a:solidFill>
+                      <a:prstDash val="solid"/>
+                      <a:round/>
+                      <a:headEnd type="none" w="med" len="med"/>
+                      <a:tailEnd type="none" w="med" len="med"/>
+                    </a:lnR>
+                    <a:lnT w="6350" cap="flat" cmpd="sng" algn="ctr">
+                      <a:solidFill>
+                        <a:srgbClr val="D6DEE5"/>
+                      </a:solidFill>
+                      <a:prstDash val="solid"/>
+                      <a:round/>
+                      <a:headEnd type="none" w="med" len="med"/>
+                      <a:tailEnd type="none" w="med" len="med"/>
+                    </a:lnT>
+                    <a:lnB w="6350" cap="flat" cmpd="sng" algn="ctr">
+                      <a:solidFill>
+                        <a:srgbClr val="D6DEE5"/>
+                      </a:solidFill>
+                      <a:prstDash val="solid"/>
+                      <a:round/>
+                      <a:headEnd type="none" w="med" len="med"/>
+                      <a:tailEnd type="none" w="med" len="med"/>
+                    </a:lnB>
+                  </a:tcPr>
+                </a:tc>
+                <a:tc>
+                  <a:txBody>
+                    <a:bodyPr/>
+                    <a:lstStyle/>
+                    <a:p>
+                      <a:pPr algn="ctr" indent="0" marL="0">
+                        <a:buNone/>
+                      </a:pPr>
+                      <a:r>
+                        <a:rPr lang="en-US" sz="1000" dirty="0">
+                          <a:solidFill>
+                            <a:schemeClr val="tx1"/>
+                          </a:solidFill>
+                        </a:rPr>
+                        <a:t>€894 / €2,840 · 1.0</a:t>
+                      </a:r>
+                      <a:endParaRPr lang="en-US" sz="1000" dirty="0"/>
+                    </a:p>
+                  </a:txBody>
+                  <a:tcPr marL="91440" marR="91440" marT="45720" marB="45720" anchor="ctr">
+                    <a:lnL w="6350" cap="flat" cmpd="sng" algn="ctr">
+                      <a:solidFill>
+                        <a:srgbClr val="D6DEE5"/>
+                      </a:solidFill>
+                      <a:prstDash val="solid"/>
+                      <a:round/>
+                      <a:headEnd type="none" w="med" len="med"/>
+                      <a:tailEnd type="none" w="med" len="med"/>
+                    </a:lnL>
+                    <a:lnR w="6350" cap="flat" cmpd="sng" algn="ctr">
+                      <a:solidFill>
+                        <a:srgbClr val="D6DEE5"/>
+                      </a:solidFill>
+                      <a:prstDash val="solid"/>
+                      <a:round/>
+                      <a:headEnd type="none" w="med" len="med"/>
+                      <a:tailEnd type="none" w="med" len="med"/>
+                    </a:lnR>
+                    <a:lnT w="6350" cap="flat" cmpd="sng" algn="ctr">
+                      <a:solidFill>
+                        <a:srgbClr val="D6DEE5"/>
+                      </a:solidFill>
+                      <a:prstDash val="solid"/>
+                      <a:round/>
+                      <a:headEnd type="none" w="med" len="med"/>
+                      <a:tailEnd type="none" w="med" len="med"/>
+                    </a:lnT>
+                    <a:lnB w="6350" cap="flat" cmpd="sng" algn="ctr">
+                      <a:solidFill>
+                        <a:srgbClr val="D6DEE5"/>
+                      </a:solidFill>
+                      <a:prstDash val="solid"/>
+                      <a:round/>
+                      <a:headEnd type="none" w="med" len="med"/>
+                      <a:tailEnd type="none" w="med" len="med"/>
+                    </a:lnB>
+                    <a:solidFill>
+                      <a:srgbClr val="DCEFE8"/>
+                    </a:solidFill>
+                  </a:tcPr>
+                </a:tc>
+                <a:tc>
+                  <a:txBody>
+                    <a:bodyPr/>
+                    <a:lstStyle/>
+                    <a:p>
+                      <a:pPr algn="ctr" indent="0" marL="0">
+                        <a:buNone/>
+                      </a:pPr>
+                      <a:r>
+                        <a:rPr lang="en-US" sz="1000" dirty="0">
+                          <a:solidFill>
+                            <a:schemeClr val="tx1"/>
+                          </a:solidFill>
+                        </a:rPr>
+                        <a:t>€610 / €1,643 · 1.8</a:t>
+                      </a:r>
+                      <a:endParaRPr lang="en-US" sz="1000" dirty="0"/>
+                    </a:p>
+                  </a:txBody>
+                  <a:tcPr marL="91440" marR="91440" marT="45720" marB="45720" anchor="ctr">
+                    <a:lnL w="6350" cap="flat" cmpd="sng" algn="ctr">
+                      <a:solidFill>
+                        <a:srgbClr val="D6DEE5"/>
+                      </a:solidFill>
+                      <a:prstDash val="solid"/>
+                      <a:round/>
+                      <a:headEnd type="none" w="med" len="med"/>
+                      <a:tailEnd type="none" w="med" len="med"/>
+                    </a:lnL>
+                    <a:lnR w="6350" cap="flat" cmpd="sng" algn="ctr">
+                      <a:solidFill>
+                        <a:srgbClr val="D6DEE5"/>
+                      </a:solidFill>
+                      <a:prstDash val="solid"/>
+                      <a:round/>
+                      <a:headEnd type="none" w="med" len="med"/>
+                      <a:tailEnd type="none" w="med" len="med"/>
+                    </a:lnR>
+                    <a:lnT w="6350" cap="flat" cmpd="sng" algn="ctr">
+                      <a:solidFill>
+                        <a:srgbClr val="D6DEE5"/>
+                      </a:solidFill>
+                      <a:prstDash val="solid"/>
+                      <a:round/>
+                      <a:headEnd type="none" w="med" len="med"/>
+                      <a:tailEnd type="none" w="med" len="med"/>
+                    </a:lnT>
+                    <a:lnB w="6350" cap="flat" cmpd="sng" algn="ctr">
+                      <a:solidFill>
+                        <a:srgbClr val="D6DEE5"/>
+                      </a:solidFill>
+                      <a:prstDash val="solid"/>
+                      <a:round/>
+                      <a:headEnd type="none" w="med" len="med"/>
+                      <a:tailEnd type="none" w="med" len="med"/>
+                    </a:lnB>
+                    <a:solidFill>
+                      <a:srgbClr val="DCEFE8"/>
+                    </a:solidFill>
+                  </a:tcPr>
+                </a:tc>
+                <a:tc>
+                  <a:txBody>
+                    <a:bodyPr/>
+                    <a:lstStyle/>
+                    <a:p>
+                      <a:pPr algn="ctr" indent="0" marL="0">
+                        <a:buNone/>
+                      </a:pPr>
+                      <a:r>
+                        <a:rPr lang="en-US" sz="1000" dirty="0">
+                          <a:solidFill>
+                            <a:schemeClr val="tx1"/>
+                          </a:solidFill>
+                        </a:rPr>
+                        <a:t>€894 / €3,155 · 0.9</a:t>
+                      </a:r>
+                      <a:endParaRPr lang="en-US" sz="1000" dirty="0"/>
+                    </a:p>
+                  </a:txBody>
+                  <a:tcPr marL="91440" marR="91440" marT="45720" marB="45720" anchor="ctr">
+                    <a:lnL w="6350" cap="flat" cmpd="sng" algn="ctr">
+                      <a:solidFill>
+                        <a:srgbClr val="D6DEE5"/>
+                      </a:solidFill>
+                      <a:prstDash val="solid"/>
+                      <a:round/>
+                      <a:headEnd type="none" w="med" len="med"/>
+                      <a:tailEnd type="none" w="med" len="med"/>
+                    </a:lnL>
+                    <a:lnR w="6350" cap="flat" cmpd="sng" algn="ctr">
+                      <a:solidFill>
+                        <a:srgbClr val="D6DEE5"/>
+                      </a:solidFill>
+                      <a:prstDash val="solid"/>
+                      <a:round/>
+                      <a:headEnd type="none" w="med" len="med"/>
+                      <a:tailEnd type="none" w="med" len="med"/>
+                    </a:lnR>
+                    <a:lnT w="6350" cap="flat" cmpd="sng" algn="ctr">
+                      <a:solidFill>
+                        <a:srgbClr val="D6DEE5"/>
+                      </a:solidFill>
+                      <a:prstDash val="solid"/>
+                      <a:round/>
+                      <a:headEnd type="none" w="med" len="med"/>
+                      <a:tailEnd type="none" w="med" len="med"/>
+                    </a:lnT>
+                    <a:lnB w="6350" cap="flat" cmpd="sng" algn="ctr">
+                      <a:solidFill>
+                        <a:srgbClr val="D6DEE5"/>
+                      </a:solidFill>
+                      <a:prstDash val="solid"/>
+                      <a:round/>
+                      <a:headEnd type="none" w="med" len="med"/>
+                      <a:tailEnd type="none" w="med" len="med"/>
+                    </a:lnB>
+                    <a:solidFill>
+                      <a:srgbClr val="DCEFE8"/>
+                    </a:solidFill>
+                  </a:tcPr>
+                </a:tc>
+                <a:tc>
+                  <a:txBody>
+                    <a:bodyPr/>
+                    <a:lstStyle/>
+                    <a:p>
+                      <a:pPr algn="ctr" indent="0" marL="0">
+                        <a:buNone/>
+                      </a:pPr>
+                      <a:r>
+                        <a:rPr lang="en-US" sz="1000" dirty="0">
+                          <a:solidFill>
+                            <a:schemeClr val="tx1"/>
+                          </a:solidFill>
+                        </a:rPr>
+                        <a:t>€1,342 / €5,637 · –</a:t>
                       </a:r>
                       <a:endParaRPr lang="en-US" sz="1000" dirty="0"/>
                     </a:p>
@@ -14984,6 +15349,66 @@
                     </a:solidFill>
                   </a:tcPr>
                 </a:tc>
+              </a:tr>
+              <a:tr h="329184">
+                <a:tc>
+                  <a:txBody>
+                    <a:bodyPr/>
+                    <a:lstStyle/>
+                    <a:p>
+                      <a:pPr indent="0" marL="0">
+                        <a:buNone/>
+                      </a:pPr>
+                      <a:r>
+                        <a:rPr lang="en-US" sz="1000" dirty="0">
+                          <a:solidFill>
+                            <a:schemeClr val="tx1"/>
+                          </a:solidFill>
+                        </a:rPr>
+                        <a:t>Meta lead ads (passive blue-collar reach)</a:t>
+                      </a:r>
+                      <a:endParaRPr lang="en-US" sz="1000" dirty="0"/>
+                    </a:p>
+                  </a:txBody>
+                  <a:tcPr marL="91440" marR="91440" marT="45720" marB="45720" anchor="ctr">
+                    <a:lnL w="6350" cap="flat" cmpd="sng" algn="ctr">
+                      <a:solidFill>
+                        <a:srgbClr val="D6DEE5"/>
+                      </a:solidFill>
+                      <a:prstDash val="solid"/>
+                      <a:round/>
+                      <a:headEnd type="none" w="med" len="med"/>
+                      <a:tailEnd type="none" w="med" len="med"/>
+                    </a:lnL>
+                    <a:lnR w="6350" cap="flat" cmpd="sng" algn="ctr">
+                      <a:solidFill>
+                        <a:srgbClr val="D6DEE5"/>
+                      </a:solidFill>
+                      <a:prstDash val="solid"/>
+                      <a:round/>
+                      <a:headEnd type="none" w="med" len="med"/>
+                      <a:tailEnd type="none" w="med" len="med"/>
+                    </a:lnR>
+                    <a:lnT w="6350" cap="flat" cmpd="sng" algn="ctr">
+                      <a:solidFill>
+                        <a:srgbClr val="D6DEE5"/>
+                      </a:solidFill>
+                      <a:prstDash val="solid"/>
+                      <a:round/>
+                      <a:headEnd type="none" w="med" len="med"/>
+                      <a:tailEnd type="none" w="med" len="med"/>
+                    </a:lnT>
+                    <a:lnB w="6350" cap="flat" cmpd="sng" algn="ctr">
+                      <a:solidFill>
+                        <a:srgbClr val="D6DEE5"/>
+                      </a:solidFill>
+                      <a:prstDash val="solid"/>
+                      <a:round/>
+                      <a:headEnd type="none" w="med" len="med"/>
+                      <a:tailEnd type="none" w="med" len="med"/>
+                    </a:lnB>
+                  </a:tcPr>
+                </a:tc>
                 <a:tc>
                   <a:txBody>
                     <a:bodyPr/>
@@ -14998,7 +15423,7 @@
                             <a:schemeClr val="tx1"/>
                           </a:solidFill>
                         </a:rPr>
-                        <a:t>€386 / €1,624 · 1.8</a:t>
+                        <a:t>€1,120 / €3,556 · 9.5</a:t>
                       </a:r>
                       <a:endParaRPr lang="en-US" sz="1000" dirty="0"/>
                     </a:p>
@@ -15045,14 +15470,12 @@
                     </a:solidFill>
                   </a:tcPr>
                 </a:tc>
-              </a:tr>
-              <a:tr h="329184">
-                <a:tc>
-                  <a:txBody>
-                    <a:bodyPr/>
-                    <a:lstStyle/>
-                    <a:p>
-                      <a:pPr indent="0" marL="0">
+                <a:tc>
+                  <a:txBody>
+                    <a:bodyPr/>
+                    <a:lstStyle/>
+                    <a:p>
+                      <a:pPr algn="ctr" indent="0" marL="0">
                         <a:buNone/>
                       </a:pPr>
                       <a:r>
@@ -15061,65 +15484,7 @@
                             <a:schemeClr val="tx1"/>
                           </a:solidFill>
                         </a:rPr>
-                        <a:t>I1b Referrals (€1,000 bonus on hire)</a:t>
-                      </a:r>
-                      <a:endParaRPr lang="en-US" sz="1000" dirty="0"/>
-                    </a:p>
-                  </a:txBody>
-                  <a:tcPr marL="91440" marR="91440" marT="45720" marB="45720" anchor="ctr">
-                    <a:lnL w="6350" cap="flat" cmpd="sng" algn="ctr">
-                      <a:solidFill>
-                        <a:srgbClr val="D6DEE5"/>
-                      </a:solidFill>
-                      <a:prstDash val="solid"/>
-                      <a:round/>
-                      <a:headEnd type="none" w="med" len="med"/>
-                      <a:tailEnd type="none" w="med" len="med"/>
-                    </a:lnL>
-                    <a:lnR w="6350" cap="flat" cmpd="sng" algn="ctr">
-                      <a:solidFill>
-                        <a:srgbClr val="D6DEE5"/>
-                      </a:solidFill>
-                      <a:prstDash val="solid"/>
-                      <a:round/>
-                      <a:headEnd type="none" w="med" len="med"/>
-                      <a:tailEnd type="none" w="med" len="med"/>
-                    </a:lnR>
-                    <a:lnT w="6350" cap="flat" cmpd="sng" algn="ctr">
-                      <a:solidFill>
-                        <a:srgbClr val="D6DEE5"/>
-                      </a:solidFill>
-                      <a:prstDash val="solid"/>
-                      <a:round/>
-                      <a:headEnd type="none" w="med" len="med"/>
-                      <a:tailEnd type="none" w="med" len="med"/>
-                    </a:lnT>
-                    <a:lnB w="6350" cap="flat" cmpd="sng" algn="ctr">
-                      <a:solidFill>
-                        <a:srgbClr val="D6DEE5"/>
-                      </a:solidFill>
-                      <a:prstDash val="solid"/>
-                      <a:round/>
-                      <a:headEnd type="none" w="med" len="med"/>
-                      <a:tailEnd type="none" w="med" len="med"/>
-                    </a:lnB>
-                  </a:tcPr>
-                </a:tc>
-                <a:tc>
-                  <a:txBody>
-                    <a:bodyPr/>
-                    <a:lstStyle/>
-                    <a:p>
-                      <a:pPr algn="ctr" indent="0" marL="0">
-                        <a:buNone/>
-                      </a:pPr>
-                      <a:r>
-                        <a:rPr lang="en-US" sz="1000" dirty="0">
-                          <a:solidFill>
-                            <a:schemeClr val="tx1"/>
-                          </a:solidFill>
-                        </a:rPr>
-                        <a:t>€362 / €1,000 · 4.1</a:t>
+                        <a:t>€764 / €2,057 · 8.2</a:t>
                       </a:r>
                       <a:endParaRPr lang="en-US" sz="1000" dirty="0"/>
                     </a:p>
@@ -15177,10 +15542,128 @@
                       <a:r>
                         <a:rPr lang="en-US" sz="1000" dirty="0">
                           <a:solidFill>
+                            <a:schemeClr val="accent4"/>
+                          </a:solidFill>
+                        </a:rPr>
+                        <a:t>–</a:t>
+                      </a:r>
+                      <a:endParaRPr lang="en-US" sz="1000" dirty="0"/>
+                    </a:p>
+                  </a:txBody>
+                  <a:tcPr marL="91440" marR="91440" marT="45720" marB="45720" anchor="ctr">
+                    <a:lnL w="6350" cap="flat" cmpd="sng" algn="ctr">
+                      <a:solidFill>
+                        <a:srgbClr val="D6DEE5"/>
+                      </a:solidFill>
+                      <a:prstDash val="solid"/>
+                      <a:round/>
+                      <a:headEnd type="none" w="med" len="med"/>
+                      <a:tailEnd type="none" w="med" len="med"/>
+                    </a:lnL>
+                    <a:lnR w="6350" cap="flat" cmpd="sng" algn="ctr">
+                      <a:solidFill>
+                        <a:srgbClr val="D6DEE5"/>
+                      </a:solidFill>
+                      <a:prstDash val="solid"/>
+                      <a:round/>
+                      <a:headEnd type="none" w="med" len="med"/>
+                      <a:tailEnd type="none" w="med" len="med"/>
+                    </a:lnR>
+                    <a:lnT w="6350" cap="flat" cmpd="sng" algn="ctr">
+                      <a:solidFill>
+                        <a:srgbClr val="D6DEE5"/>
+                      </a:solidFill>
+                      <a:prstDash val="solid"/>
+                      <a:round/>
+                      <a:headEnd type="none" w="med" len="med"/>
+                      <a:tailEnd type="none" w="med" len="med"/>
+                    </a:lnT>
+                    <a:lnB w="6350" cap="flat" cmpd="sng" algn="ctr">
+                      <a:solidFill>
+                        <a:srgbClr val="D6DEE5"/>
+                      </a:solidFill>
+                      <a:prstDash val="solid"/>
+                      <a:round/>
+                      <a:headEnd type="none" w="med" len="med"/>
+                      <a:tailEnd type="none" w="med" len="med"/>
+                    </a:lnB>
+                  </a:tcPr>
+                </a:tc>
+                <a:tc>
+                  <a:txBody>
+                    <a:bodyPr/>
+                    <a:lstStyle/>
+                    <a:p>
+                      <a:pPr algn="ctr" indent="0" marL="0">
+                        <a:buNone/>
+                      </a:pPr>
+                      <a:r>
+                        <a:rPr lang="en-US" sz="1000" dirty="0">
+                          <a:solidFill>
+                            <a:schemeClr val="accent4"/>
+                          </a:solidFill>
+                        </a:rPr>
+                        <a:t>–</a:t>
+                      </a:r>
+                      <a:endParaRPr lang="en-US" sz="1000" dirty="0"/>
+                    </a:p>
+                  </a:txBody>
+                  <a:tcPr marL="91440" marR="91440" marT="45720" marB="45720" anchor="ctr">
+                    <a:lnL w="6350" cap="flat" cmpd="sng" algn="ctr">
+                      <a:solidFill>
+                        <a:srgbClr val="D6DEE5"/>
+                      </a:solidFill>
+                      <a:prstDash val="solid"/>
+                      <a:round/>
+                      <a:headEnd type="none" w="med" len="med"/>
+                      <a:tailEnd type="none" w="med" len="med"/>
+                    </a:lnL>
+                    <a:lnR w="6350" cap="flat" cmpd="sng" algn="ctr">
+                      <a:solidFill>
+                        <a:srgbClr val="D6DEE5"/>
+                      </a:solidFill>
+                      <a:prstDash val="solid"/>
+                      <a:round/>
+                      <a:headEnd type="none" w="med" len="med"/>
+                      <a:tailEnd type="none" w="med" len="med"/>
+                    </a:lnR>
+                    <a:lnT w="6350" cap="flat" cmpd="sng" algn="ctr">
+                      <a:solidFill>
+                        <a:srgbClr val="D6DEE5"/>
+                      </a:solidFill>
+                      <a:prstDash val="solid"/>
+                      <a:round/>
+                      <a:headEnd type="none" w="med" len="med"/>
+                      <a:tailEnd type="none" w="med" len="med"/>
+                    </a:lnT>
+                    <a:lnB w="6350" cap="flat" cmpd="sng" algn="ctr">
+                      <a:solidFill>
+                        <a:srgbClr val="D6DEE5"/>
+                      </a:solidFill>
+                      <a:prstDash val="solid"/>
+                      <a:round/>
+                      <a:headEnd type="none" w="med" len="med"/>
+                      <a:tailEnd type="none" w="med" len="med"/>
+                    </a:lnB>
+                  </a:tcPr>
+                </a:tc>
+              </a:tr>
+              <a:tr h="329184">
+                <a:tc>
+                  <a:txBody>
+                    <a:bodyPr/>
+                    <a:lstStyle/>
+                    <a:p>
+                      <a:pPr indent="0" marL="0">
+                        <a:buNone/>
+                      </a:pPr>
+                      <a:r>
+                        <a:rPr lang="en-US" sz="1000" dirty="0">
+                          <a:solidFill>
                             <a:schemeClr val="tx1"/>
                           </a:solidFill>
                         </a:rPr>
-                        <a:t>€427 / €1,000 · –</a:t>
+                        <a:t>I2 Handwerk → Industrie (new pool)</a:t>
                       </a:r>
                       <a:endParaRPr lang="en-US" sz="1000" dirty="0"/>
                     </a:p>
@@ -15222,9 +15705,6 @@
                       <a:headEnd type="none" w="med" len="med"/>
                       <a:tailEnd type="none" w="med" len="med"/>
                     </a:lnB>
-                    <a:solidFill>
-                      <a:srgbClr val="F2F4F6"/>
-                    </a:solidFill>
                   </a:tcPr>
                 </a:tc>
                 <a:tc>
@@ -15241,7 +15721,7 @@
                             <a:schemeClr val="tx1"/>
                           </a:solidFill>
                         </a:rPr>
-                        <a:t>€326 / €1,000 · 1.5</a:t>
+                        <a:t>€560 / €2,116 · 8.5</a:t>
                       </a:r>
                       <a:endParaRPr lang="en-US" sz="1000" dirty="0"/>
                     </a:p>
@@ -15299,10 +15779,244 @@
                       <a:r>
                         <a:rPr lang="en-US" sz="1000" dirty="0">
                           <a:solidFill>
+                            <a:schemeClr val="accent4"/>
+                          </a:solidFill>
+                        </a:rPr>
+                        <a:t>–</a:t>
+                      </a:r>
+                      <a:endParaRPr lang="en-US" sz="1000" dirty="0"/>
+                    </a:p>
+                  </a:txBody>
+                  <a:tcPr marL="91440" marR="91440" marT="45720" marB="45720" anchor="ctr">
+                    <a:lnL w="6350" cap="flat" cmpd="sng" algn="ctr">
+                      <a:solidFill>
+                        <a:srgbClr val="D6DEE5"/>
+                      </a:solidFill>
+                      <a:prstDash val="solid"/>
+                      <a:round/>
+                      <a:headEnd type="none" w="med" len="med"/>
+                      <a:tailEnd type="none" w="med" len="med"/>
+                    </a:lnL>
+                    <a:lnR w="6350" cap="flat" cmpd="sng" algn="ctr">
+                      <a:solidFill>
+                        <a:srgbClr val="D6DEE5"/>
+                      </a:solidFill>
+                      <a:prstDash val="solid"/>
+                      <a:round/>
+                      <a:headEnd type="none" w="med" len="med"/>
+                      <a:tailEnd type="none" w="med" len="med"/>
+                    </a:lnR>
+                    <a:lnT w="6350" cap="flat" cmpd="sng" algn="ctr">
+                      <a:solidFill>
+                        <a:srgbClr val="D6DEE5"/>
+                      </a:solidFill>
+                      <a:prstDash val="solid"/>
+                      <a:round/>
+                      <a:headEnd type="none" w="med" len="med"/>
+                      <a:tailEnd type="none" w="med" len="med"/>
+                    </a:lnT>
+                    <a:lnB w="6350" cap="flat" cmpd="sng" algn="ctr">
+                      <a:solidFill>
+                        <a:srgbClr val="D6DEE5"/>
+                      </a:solidFill>
+                      <a:prstDash val="solid"/>
+                      <a:round/>
+                      <a:headEnd type="none" w="med" len="med"/>
+                      <a:tailEnd type="none" w="med" len="med"/>
+                    </a:lnB>
+                  </a:tcPr>
+                </a:tc>
+                <a:tc>
+                  <a:txBody>
+                    <a:bodyPr/>
+                    <a:lstStyle/>
+                    <a:p>
+                      <a:pPr algn="ctr" indent="0" marL="0">
+                        <a:buNone/>
+                      </a:pPr>
+                      <a:r>
+                        <a:rPr lang="en-US" sz="1000" dirty="0">
+                          <a:solidFill>
+                            <a:schemeClr val="accent4"/>
+                          </a:solidFill>
+                        </a:rPr>
+                        <a:t>–</a:t>
+                      </a:r>
+                      <a:endParaRPr lang="en-US" sz="1000" dirty="0"/>
+                    </a:p>
+                  </a:txBody>
+                  <a:tcPr marL="91440" marR="91440" marT="45720" marB="45720" anchor="ctr">
+                    <a:lnL w="6350" cap="flat" cmpd="sng" algn="ctr">
+                      <a:solidFill>
+                        <a:srgbClr val="D6DEE5"/>
+                      </a:solidFill>
+                      <a:prstDash val="solid"/>
+                      <a:round/>
+                      <a:headEnd type="none" w="med" len="med"/>
+                      <a:tailEnd type="none" w="med" len="med"/>
+                    </a:lnL>
+                    <a:lnR w="6350" cap="flat" cmpd="sng" algn="ctr">
+                      <a:solidFill>
+                        <a:srgbClr val="D6DEE5"/>
+                      </a:solidFill>
+                      <a:prstDash val="solid"/>
+                      <a:round/>
+                      <a:headEnd type="none" w="med" len="med"/>
+                      <a:tailEnd type="none" w="med" len="med"/>
+                    </a:lnR>
+                    <a:lnT w="6350" cap="flat" cmpd="sng" algn="ctr">
+                      <a:solidFill>
+                        <a:srgbClr val="D6DEE5"/>
+                      </a:solidFill>
+                      <a:prstDash val="solid"/>
+                      <a:round/>
+                      <a:headEnd type="none" w="med" len="med"/>
+                      <a:tailEnd type="none" w="med" len="med"/>
+                    </a:lnT>
+                    <a:lnB w="6350" cap="flat" cmpd="sng" algn="ctr">
+                      <a:solidFill>
+                        <a:srgbClr val="D6DEE5"/>
+                      </a:solidFill>
+                      <a:prstDash val="solid"/>
+                      <a:round/>
+                      <a:headEnd type="none" w="med" len="med"/>
+                      <a:tailEnd type="none" w="med" len="med"/>
+                    </a:lnB>
+                  </a:tcPr>
+                </a:tc>
+                <a:tc>
+                  <a:txBody>
+                    <a:bodyPr/>
+                    <a:lstStyle/>
+                    <a:p>
+                      <a:pPr algn="ctr" indent="0" marL="0">
+                        <a:buNone/>
+                      </a:pPr>
+                      <a:r>
+                        <a:rPr lang="en-US" sz="1000" dirty="0">
+                          <a:solidFill>
+                            <a:schemeClr val="accent4"/>
+                          </a:solidFill>
+                        </a:rPr>
+                        <a:t>–</a:t>
+                      </a:r>
+                      <a:endParaRPr lang="en-US" sz="1000" dirty="0"/>
+                    </a:p>
+                  </a:txBody>
+                  <a:tcPr marL="91440" marR="91440" marT="45720" marB="45720" anchor="ctr">
+                    <a:lnL w="6350" cap="flat" cmpd="sng" algn="ctr">
+                      <a:solidFill>
+                        <a:srgbClr val="D6DEE5"/>
+                      </a:solidFill>
+                      <a:prstDash val="solid"/>
+                      <a:round/>
+                      <a:headEnd type="none" w="med" len="med"/>
+                      <a:tailEnd type="none" w="med" len="med"/>
+                    </a:lnL>
+                    <a:lnR w="6350" cap="flat" cmpd="sng" algn="ctr">
+                      <a:solidFill>
+                        <a:srgbClr val="D6DEE5"/>
+                      </a:solidFill>
+                      <a:prstDash val="solid"/>
+                      <a:round/>
+                      <a:headEnd type="none" w="med" len="med"/>
+                      <a:tailEnd type="none" w="med" len="med"/>
+                    </a:lnR>
+                    <a:lnT w="6350" cap="flat" cmpd="sng" algn="ctr">
+                      <a:solidFill>
+                        <a:srgbClr val="D6DEE5"/>
+                      </a:solidFill>
+                      <a:prstDash val="solid"/>
+                      <a:round/>
+                      <a:headEnd type="none" w="med" len="med"/>
+                      <a:tailEnd type="none" w="med" len="med"/>
+                    </a:lnT>
+                    <a:lnB w="6350" cap="flat" cmpd="sng" algn="ctr">
+                      <a:solidFill>
+                        <a:srgbClr val="D6DEE5"/>
+                      </a:solidFill>
+                      <a:prstDash val="solid"/>
+                      <a:round/>
+                      <a:headEnd type="none" w="med" len="med"/>
+                      <a:tailEnd type="none" w="med" len="med"/>
+                    </a:lnB>
+                  </a:tcPr>
+                </a:tc>
+              </a:tr>
+              <a:tr h="329184">
+                <a:tc>
+                  <a:txBody>
+                    <a:bodyPr/>
+                    <a:lstStyle/>
+                    <a:p>
+                      <a:pPr indent="0" marL="0">
+                        <a:buNone/>
+                      </a:pPr>
+                      <a:r>
+                        <a:rPr lang="en-US" sz="1000" dirty="0">
+                          <a:solidFill>
                             <a:schemeClr val="tx1"/>
                           </a:solidFill>
                         </a:rPr>
-                        <a:t>€274 / €1,000 · 1.0</a:t>
+                        <a:t>Programmatic (Indeed, Jooble, Talent.com…)</a:t>
+                      </a:r>
+                      <a:endParaRPr lang="en-US" sz="1000" dirty="0"/>
+                    </a:p>
+                  </a:txBody>
+                  <a:tcPr marL="91440" marR="91440" marT="45720" marB="45720" anchor="ctr">
+                    <a:lnL w="6350" cap="flat" cmpd="sng" algn="ctr">
+                      <a:solidFill>
+                        <a:srgbClr val="D6DEE5"/>
+                      </a:solidFill>
+                      <a:prstDash val="solid"/>
+                      <a:round/>
+                      <a:headEnd type="none" w="med" len="med"/>
+                      <a:tailEnd type="none" w="med" len="med"/>
+                    </a:lnL>
+                    <a:lnR w="6350" cap="flat" cmpd="sng" algn="ctr">
+                      <a:solidFill>
+                        <a:srgbClr val="D6DEE5"/>
+                      </a:solidFill>
+                      <a:prstDash val="solid"/>
+                      <a:round/>
+                      <a:headEnd type="none" w="med" len="med"/>
+                      <a:tailEnd type="none" w="med" len="med"/>
+                    </a:lnR>
+                    <a:lnT w="6350" cap="flat" cmpd="sng" algn="ctr">
+                      <a:solidFill>
+                        <a:srgbClr val="D6DEE5"/>
+                      </a:solidFill>
+                      <a:prstDash val="solid"/>
+                      <a:round/>
+                      <a:headEnd type="none" w="med" len="med"/>
+                      <a:tailEnd type="none" w="med" len="med"/>
+                    </a:lnT>
+                    <a:lnB w="6350" cap="flat" cmpd="sng" algn="ctr">
+                      <a:solidFill>
+                        <a:srgbClr val="D6DEE5"/>
+                      </a:solidFill>
+                      <a:prstDash val="solid"/>
+                      <a:round/>
+                      <a:headEnd type="none" w="med" len="med"/>
+                      <a:tailEnd type="none" w="med" len="med"/>
+                    </a:lnB>
+                  </a:tcPr>
+                </a:tc>
+                <a:tc>
+                  <a:txBody>
+                    <a:bodyPr/>
+                    <a:lstStyle/>
+                    <a:p>
+                      <a:pPr algn="ctr" indent="0" marL="0">
+                        <a:buNone/>
+                      </a:pPr>
+                      <a:r>
+                        <a:rPr lang="en-US" sz="1000" dirty="0">
+                          <a:solidFill>
+                            <a:schemeClr val="tx1"/>
+                          </a:solidFill>
+                        </a:rPr>
+                        <a:t>€1,193 / €3,786 · 3.2</a:t>
                       </a:r>
                       <a:endParaRPr lang="en-US" sz="1000" dirty="0"/>
                     </a:p>
@@ -15349,14 +16063,12 @@
                     </a:solidFill>
                   </a:tcPr>
                 </a:tc>
-              </a:tr>
-              <a:tr h="329184">
-                <a:tc>
-                  <a:txBody>
-                    <a:bodyPr/>
-                    <a:lstStyle/>
-                    <a:p>
-                      <a:pPr indent="0" marL="0">
+                <a:tc>
+                  <a:txBody>
+                    <a:bodyPr/>
+                    <a:lstStyle/>
+                    <a:p>
+                      <a:pPr algn="ctr" indent="0" marL="0">
                         <a:buNone/>
                       </a:pPr>
                       <a:r>
@@ -15365,7 +16077,7 @@
                             <a:schemeClr val="tx1"/>
                           </a:solidFill>
                         </a:rPr>
-                        <a:t>LinkedIn (PLC/TIA and Meister profiles)</a:t>
+                        <a:t>€813 / €2,190 · 0.3 T</a:t>
                       </a:r>
                       <a:endParaRPr lang="en-US" sz="1000" dirty="0"/>
                     </a:p>
@@ -15407,6 +16119,9 @@
                       <a:headEnd type="none" w="med" len="med"/>
                       <a:tailEnd type="none" w="med" len="med"/>
                     </a:lnB>
+                    <a:solidFill>
+                      <a:srgbClr val="FBEBC8"/>
+                    </a:solidFill>
                   </a:tcPr>
                 </a:tc>
                 <a:tc>
@@ -15420,126 +16135,10 @@
                       <a:r>
                         <a:rPr lang="en-US" sz="1000" dirty="0">
                           <a:solidFill>
-                            <a:schemeClr val="accent4"/>
-                          </a:solidFill>
-                        </a:rPr>
-                        <a:t>–</a:t>
-                      </a:r>
-                      <a:endParaRPr lang="en-US" sz="1000" dirty="0"/>
-                    </a:p>
-                  </a:txBody>
-                  <a:tcPr marL="91440" marR="91440" marT="45720" marB="45720" anchor="ctr">
-                    <a:lnL w="6350" cap="flat" cmpd="sng" algn="ctr">
-                      <a:solidFill>
-                        <a:srgbClr val="D6DEE5"/>
-                      </a:solidFill>
-                      <a:prstDash val="solid"/>
-                      <a:round/>
-                      <a:headEnd type="none" w="med" len="med"/>
-                      <a:tailEnd type="none" w="med" len="med"/>
-                    </a:lnL>
-                    <a:lnR w="6350" cap="flat" cmpd="sng" algn="ctr">
-                      <a:solidFill>
-                        <a:srgbClr val="D6DEE5"/>
-                      </a:solidFill>
-                      <a:prstDash val="solid"/>
-                      <a:round/>
-                      <a:headEnd type="none" w="med" len="med"/>
-                      <a:tailEnd type="none" w="med" len="med"/>
-                    </a:lnR>
-                    <a:lnT w="6350" cap="flat" cmpd="sng" algn="ctr">
-                      <a:solidFill>
-                        <a:srgbClr val="D6DEE5"/>
-                      </a:solidFill>
-                      <a:prstDash val="solid"/>
-                      <a:round/>
-                      <a:headEnd type="none" w="med" len="med"/>
-                      <a:tailEnd type="none" w="med" len="med"/>
-                    </a:lnT>
-                    <a:lnB w="6350" cap="flat" cmpd="sng" algn="ctr">
-                      <a:solidFill>
-                        <a:srgbClr val="D6DEE5"/>
-                      </a:solidFill>
-                      <a:prstDash val="solid"/>
-                      <a:round/>
-                      <a:headEnd type="none" w="med" len="med"/>
-                      <a:tailEnd type="none" w="med" len="med"/>
-                    </a:lnB>
-                  </a:tcPr>
-                </a:tc>
-                <a:tc>
-                  <a:txBody>
-                    <a:bodyPr/>
-                    <a:lstStyle/>
-                    <a:p>
-                      <a:pPr algn="ctr" indent="0" marL="0">
-                        <a:buNone/>
-                      </a:pPr>
-                      <a:r>
-                        <a:rPr lang="en-US" sz="1000" dirty="0">
-                          <a:solidFill>
-                            <a:schemeClr val="accent4"/>
-                          </a:solidFill>
-                        </a:rPr>
-                        <a:t>–</a:t>
-                      </a:r>
-                      <a:endParaRPr lang="en-US" sz="1000" dirty="0"/>
-                    </a:p>
-                  </a:txBody>
-                  <a:tcPr marL="91440" marR="91440" marT="45720" marB="45720" anchor="ctr">
-                    <a:lnL w="6350" cap="flat" cmpd="sng" algn="ctr">
-                      <a:solidFill>
-                        <a:srgbClr val="D6DEE5"/>
-                      </a:solidFill>
-                      <a:prstDash val="solid"/>
-                      <a:round/>
-                      <a:headEnd type="none" w="med" len="med"/>
-                      <a:tailEnd type="none" w="med" len="med"/>
-                    </a:lnL>
-                    <a:lnR w="6350" cap="flat" cmpd="sng" algn="ctr">
-                      <a:solidFill>
-                        <a:srgbClr val="D6DEE5"/>
-                      </a:solidFill>
-                      <a:prstDash val="solid"/>
-                      <a:round/>
-                      <a:headEnd type="none" w="med" len="med"/>
-                      <a:tailEnd type="none" w="med" len="med"/>
-                    </a:lnR>
-                    <a:lnT w="6350" cap="flat" cmpd="sng" algn="ctr">
-                      <a:solidFill>
-                        <a:srgbClr val="D6DEE5"/>
-                      </a:solidFill>
-                      <a:prstDash val="solid"/>
-                      <a:round/>
-                      <a:headEnd type="none" w="med" len="med"/>
-                      <a:tailEnd type="none" w="med" len="med"/>
-                    </a:lnT>
-                    <a:lnB w="6350" cap="flat" cmpd="sng" algn="ctr">
-                      <a:solidFill>
-                        <a:srgbClr val="D6DEE5"/>
-                      </a:solidFill>
-                      <a:prstDash val="solid"/>
-                      <a:round/>
-                      <a:headEnd type="none" w="med" len="med"/>
-                      <a:tailEnd type="none" w="med" len="med"/>
-                    </a:lnB>
-                  </a:tcPr>
-                </a:tc>
-                <a:tc>
-                  <a:txBody>
-                    <a:bodyPr/>
-                    <a:lstStyle/>
-                    <a:p>
-                      <a:pPr algn="ctr" indent="0" marL="0">
-                        <a:buNone/>
-                      </a:pPr>
-                      <a:r>
-                        <a:rPr lang="en-US" sz="1000" dirty="0">
-                          <a:solidFill>
                             <a:schemeClr val="tx1"/>
                           </a:solidFill>
                         </a:rPr>
-                        <a:t>€384 / €1,354 · 8.6</a:t>
+                        <a:t>€1,193 / €4,207 · 0.5</a:t>
                       </a:r>
                       <a:endParaRPr lang="en-US" sz="1000" dirty="0"/>
                     </a:p>
@@ -15600,7 +16199,244 @@
                             <a:schemeClr val="tx1"/>
                           </a:solidFill>
                         </a:rPr>
-                        <a:t>€480 / €2,017 · 4.5</a:t>
+                        <a:t>€1,789 / €7,516 · 0.1 T</a:t>
+                      </a:r>
+                      <a:endParaRPr lang="en-US" sz="1000" dirty="0"/>
+                    </a:p>
+                  </a:txBody>
+                  <a:tcPr marL="91440" marR="91440" marT="45720" marB="45720" anchor="ctr">
+                    <a:lnL w="6350" cap="flat" cmpd="sng" algn="ctr">
+                      <a:solidFill>
+                        <a:srgbClr val="D6DEE5"/>
+                      </a:solidFill>
+                      <a:prstDash val="solid"/>
+                      <a:round/>
+                      <a:headEnd type="none" w="med" len="med"/>
+                      <a:tailEnd type="none" w="med" len="med"/>
+                    </a:lnL>
+                    <a:lnR w="6350" cap="flat" cmpd="sng" algn="ctr">
+                      <a:solidFill>
+                        <a:srgbClr val="D6DEE5"/>
+                      </a:solidFill>
+                      <a:prstDash val="solid"/>
+                      <a:round/>
+                      <a:headEnd type="none" w="med" len="med"/>
+                      <a:tailEnd type="none" w="med" len="med"/>
+                    </a:lnR>
+                    <a:lnT w="6350" cap="flat" cmpd="sng" algn="ctr">
+                      <a:solidFill>
+                        <a:srgbClr val="D6DEE5"/>
+                      </a:solidFill>
+                      <a:prstDash val="solid"/>
+                      <a:round/>
+                      <a:headEnd type="none" w="med" len="med"/>
+                      <a:tailEnd type="none" w="med" len="med"/>
+                    </a:lnT>
+                    <a:lnB w="6350" cap="flat" cmpd="sng" algn="ctr">
+                      <a:solidFill>
+                        <a:srgbClr val="D6DEE5"/>
+                      </a:solidFill>
+                      <a:prstDash val="solid"/>
+                      <a:round/>
+                      <a:headEnd type="none" w="med" len="med"/>
+                      <a:tailEnd type="none" w="med" len="med"/>
+                    </a:lnB>
+                    <a:solidFill>
+                      <a:srgbClr val="FBEBC8"/>
+                    </a:solidFill>
+                  </a:tcPr>
+                </a:tc>
+              </a:tr>
+              <a:tr h="329184">
+                <a:tc>
+                  <a:txBody>
+                    <a:bodyPr/>
+                    <a:lstStyle/>
+                    <a:p>
+                      <a:pPr indent="0" marL="0">
+                        <a:buNone/>
+                      </a:pPr>
+                      <a:r>
+                        <a:rPr lang="en-US" sz="1000" dirty="0">
+                          <a:solidFill>
+                            <a:schemeClr val="tx1"/>
+                          </a:solidFill>
+                        </a:rPr>
+                        <a:t>LinkedIn (PLC/TIA and Meister profiles)</a:t>
+                      </a:r>
+                      <a:endParaRPr lang="en-US" sz="1000" dirty="0"/>
+                    </a:p>
+                  </a:txBody>
+                  <a:tcPr marL="91440" marR="91440" marT="45720" marB="45720" anchor="ctr">
+                    <a:lnL w="6350" cap="flat" cmpd="sng" algn="ctr">
+                      <a:solidFill>
+                        <a:srgbClr val="D6DEE5"/>
+                      </a:solidFill>
+                      <a:prstDash val="solid"/>
+                      <a:round/>
+                      <a:headEnd type="none" w="med" len="med"/>
+                      <a:tailEnd type="none" w="med" len="med"/>
+                    </a:lnL>
+                    <a:lnR w="6350" cap="flat" cmpd="sng" algn="ctr">
+                      <a:solidFill>
+                        <a:srgbClr val="D6DEE5"/>
+                      </a:solidFill>
+                      <a:prstDash val="solid"/>
+                      <a:round/>
+                      <a:headEnd type="none" w="med" len="med"/>
+                      <a:tailEnd type="none" w="med" len="med"/>
+                    </a:lnR>
+                    <a:lnT w="6350" cap="flat" cmpd="sng" algn="ctr">
+                      <a:solidFill>
+                        <a:srgbClr val="D6DEE5"/>
+                      </a:solidFill>
+                      <a:prstDash val="solid"/>
+                      <a:round/>
+                      <a:headEnd type="none" w="med" len="med"/>
+                      <a:tailEnd type="none" w="med" len="med"/>
+                    </a:lnT>
+                    <a:lnB w="6350" cap="flat" cmpd="sng" algn="ctr">
+                      <a:solidFill>
+                        <a:srgbClr val="D6DEE5"/>
+                      </a:solidFill>
+                      <a:prstDash val="solid"/>
+                      <a:round/>
+                      <a:headEnd type="none" w="med" len="med"/>
+                      <a:tailEnd type="none" w="med" len="med"/>
+                    </a:lnB>
+                  </a:tcPr>
+                </a:tc>
+                <a:tc>
+                  <a:txBody>
+                    <a:bodyPr/>
+                    <a:lstStyle/>
+                    <a:p>
+                      <a:pPr algn="ctr" indent="0" marL="0">
+                        <a:buNone/>
+                      </a:pPr>
+                      <a:r>
+                        <a:rPr lang="en-US" sz="1000" dirty="0">
+                          <a:solidFill>
+                            <a:schemeClr val="accent4"/>
+                          </a:solidFill>
+                        </a:rPr>
+                        <a:t>–</a:t>
+                      </a:r>
+                      <a:endParaRPr lang="en-US" sz="1000" dirty="0"/>
+                    </a:p>
+                  </a:txBody>
+                  <a:tcPr marL="91440" marR="91440" marT="45720" marB="45720" anchor="ctr">
+                    <a:lnL w="6350" cap="flat" cmpd="sng" algn="ctr">
+                      <a:solidFill>
+                        <a:srgbClr val="D6DEE5"/>
+                      </a:solidFill>
+                      <a:prstDash val="solid"/>
+                      <a:round/>
+                      <a:headEnd type="none" w="med" len="med"/>
+                      <a:tailEnd type="none" w="med" len="med"/>
+                    </a:lnL>
+                    <a:lnR w="6350" cap="flat" cmpd="sng" algn="ctr">
+                      <a:solidFill>
+                        <a:srgbClr val="D6DEE5"/>
+                      </a:solidFill>
+                      <a:prstDash val="solid"/>
+                      <a:round/>
+                      <a:headEnd type="none" w="med" len="med"/>
+                      <a:tailEnd type="none" w="med" len="med"/>
+                    </a:lnR>
+                    <a:lnT w="6350" cap="flat" cmpd="sng" algn="ctr">
+                      <a:solidFill>
+                        <a:srgbClr val="D6DEE5"/>
+                      </a:solidFill>
+                      <a:prstDash val="solid"/>
+                      <a:round/>
+                      <a:headEnd type="none" w="med" len="med"/>
+                      <a:tailEnd type="none" w="med" len="med"/>
+                    </a:lnT>
+                    <a:lnB w="6350" cap="flat" cmpd="sng" algn="ctr">
+                      <a:solidFill>
+                        <a:srgbClr val="D6DEE5"/>
+                      </a:solidFill>
+                      <a:prstDash val="solid"/>
+                      <a:round/>
+                      <a:headEnd type="none" w="med" len="med"/>
+                      <a:tailEnd type="none" w="med" len="med"/>
+                    </a:lnB>
+                  </a:tcPr>
+                </a:tc>
+                <a:tc>
+                  <a:txBody>
+                    <a:bodyPr/>
+                    <a:lstStyle/>
+                    <a:p>
+                      <a:pPr algn="ctr" indent="0" marL="0">
+                        <a:buNone/>
+                      </a:pPr>
+                      <a:r>
+                        <a:rPr lang="en-US" sz="1000" dirty="0">
+                          <a:solidFill>
+                            <a:schemeClr val="accent4"/>
+                          </a:solidFill>
+                        </a:rPr>
+                        <a:t>–</a:t>
+                      </a:r>
+                      <a:endParaRPr lang="en-US" sz="1000" dirty="0"/>
+                    </a:p>
+                  </a:txBody>
+                  <a:tcPr marL="91440" marR="91440" marT="45720" marB="45720" anchor="ctr">
+                    <a:lnL w="6350" cap="flat" cmpd="sng" algn="ctr">
+                      <a:solidFill>
+                        <a:srgbClr val="D6DEE5"/>
+                      </a:solidFill>
+                      <a:prstDash val="solid"/>
+                      <a:round/>
+                      <a:headEnd type="none" w="med" len="med"/>
+                      <a:tailEnd type="none" w="med" len="med"/>
+                    </a:lnL>
+                    <a:lnR w="6350" cap="flat" cmpd="sng" algn="ctr">
+                      <a:solidFill>
+                        <a:srgbClr val="D6DEE5"/>
+                      </a:solidFill>
+                      <a:prstDash val="solid"/>
+                      <a:round/>
+                      <a:headEnd type="none" w="med" len="med"/>
+                      <a:tailEnd type="none" w="med" len="med"/>
+                    </a:lnR>
+                    <a:lnT w="6350" cap="flat" cmpd="sng" algn="ctr">
+                      <a:solidFill>
+                        <a:srgbClr val="D6DEE5"/>
+                      </a:solidFill>
+                      <a:prstDash val="solid"/>
+                      <a:round/>
+                      <a:headEnd type="none" w="med" len="med"/>
+                      <a:tailEnd type="none" w="med" len="med"/>
+                    </a:lnT>
+                    <a:lnB w="6350" cap="flat" cmpd="sng" algn="ctr">
+                      <a:solidFill>
+                        <a:srgbClr val="D6DEE5"/>
+                      </a:solidFill>
+                      <a:prstDash val="solid"/>
+                      <a:round/>
+                      <a:headEnd type="none" w="med" len="med"/>
+                      <a:tailEnd type="none" w="med" len="med"/>
+                    </a:lnB>
+                  </a:tcPr>
+                </a:tc>
+                <a:tc>
+                  <a:txBody>
+                    <a:bodyPr/>
+                    <a:lstStyle/>
+                    <a:p>
+                      <a:pPr algn="ctr" indent="0" marL="0">
+                        <a:buNone/>
+                      </a:pPr>
+                      <a:r>
+                        <a:rPr lang="en-US" sz="1000" dirty="0">
+                          <a:solidFill>
+                            <a:schemeClr val="tx1"/>
+                          </a:solidFill>
+                        </a:rPr>
+                        <a:t>€711 / €2,508 · 10.0</a:t>
                       </a:r>
                       <a:endParaRPr lang="en-US" sz="1000" dirty="0"/>
                     </a:p>
@@ -15647,6 +16483,67 @@
                     </a:solidFill>
                   </a:tcPr>
                 </a:tc>
+                <a:tc>
+                  <a:txBody>
+                    <a:bodyPr/>
+                    <a:lstStyle/>
+                    <a:p>
+                      <a:pPr algn="ctr" indent="0" marL="0">
+                        <a:buNone/>
+                      </a:pPr>
+                      <a:r>
+                        <a:rPr lang="en-US" sz="1000" dirty="0">
+                          <a:solidFill>
+                            <a:schemeClr val="tx1"/>
+                          </a:solidFill>
+                        </a:rPr>
+                        <a:t>€1,067 / €4,482 · 8.3</a:t>
+                      </a:r>
+                      <a:endParaRPr lang="en-US" sz="1000" dirty="0"/>
+                    </a:p>
+                  </a:txBody>
+                  <a:tcPr marL="91440" marR="91440" marT="45720" marB="45720" anchor="ctr">
+                    <a:lnL w="6350" cap="flat" cmpd="sng" algn="ctr">
+                      <a:solidFill>
+                        <a:srgbClr val="D6DEE5"/>
+                      </a:solidFill>
+                      <a:prstDash val="solid"/>
+                      <a:round/>
+                      <a:headEnd type="none" w="med" len="med"/>
+                      <a:tailEnd type="none" w="med" len="med"/>
+                    </a:lnL>
+                    <a:lnR w="6350" cap="flat" cmpd="sng" algn="ctr">
+                      <a:solidFill>
+                        <a:srgbClr val="D6DEE5"/>
+                      </a:solidFill>
+                      <a:prstDash val="solid"/>
+                      <a:round/>
+                      <a:headEnd type="none" w="med" len="med"/>
+                      <a:tailEnd type="none" w="med" len="med"/>
+                    </a:lnR>
+                    <a:lnT w="6350" cap="flat" cmpd="sng" algn="ctr">
+                      <a:solidFill>
+                        <a:srgbClr val="D6DEE5"/>
+                      </a:solidFill>
+                      <a:prstDash val="solid"/>
+                      <a:round/>
+                      <a:headEnd type="none" w="med" len="med"/>
+                      <a:tailEnd type="none" w="med" len="med"/>
+                    </a:lnT>
+                    <a:lnB w="6350" cap="flat" cmpd="sng" algn="ctr">
+                      <a:solidFill>
+                        <a:srgbClr val="D6DEE5"/>
+                      </a:solidFill>
+                      <a:prstDash val="solid"/>
+                      <a:round/>
+                      <a:headEnd type="none" w="med" len="med"/>
+                      <a:tailEnd type="none" w="med" len="med"/>
+                    </a:lnB>
+                    <a:solidFill>
+                      <a:srgbClr val="DCEFE8"/>
+                    </a:solidFill>
+                  </a:tcPr>
+                </a:tc>
               </a:tr>
               <a:tr h="329184">
                 <a:tc>
@@ -15663,7 +16560,7 @@
                             <a:schemeClr val="tx1"/>
                           </a:solidFill>
                         </a:rPr>
-                        <a:t>Meta lead ads (passive blue-collar reach)</a:t>
+                        <a:t>Google Search (high intent, low volume)</a:t>
                       </a:r>
                       <a:endParaRPr lang="en-US" sz="1000" dirty="0"/>
                     </a:p>
@@ -15721,7 +16618,7 @@
                             <a:schemeClr val="tx1"/>
                           </a:solidFill>
                         </a:rPr>
-                        <a:t>€1,680 / €5,333 · 0.1 T</a:t>
+                        <a:t>€1,681 / €5,336 · 0.1 T</a:t>
                       </a:r>
                       <a:endParaRPr lang="en-US" sz="1000" dirty="0"/>
                     </a:p>
@@ -15782,7 +16679,7 @@
                             <a:schemeClr val="tx1"/>
                           </a:solidFill>
                         </a:rPr>
-                        <a:t>€700 / €1,886 · 0.4 T</a:t>
+                        <a:t>€1,146 / €3,087 · 0.2 T</a:t>
                       </a:r>
                       <a:endParaRPr lang="en-US" sz="1000" dirty="0"/>
                     </a:p>
@@ -15840,247 +16737,10 @@
                       <a:r>
                         <a:rPr lang="en-US" sz="1000" dirty="0">
                           <a:solidFill>
-                            <a:schemeClr val="accent4"/>
-                          </a:solidFill>
-                        </a:rPr>
-                        <a:t>–</a:t>
-                      </a:r>
-                      <a:endParaRPr lang="en-US" sz="1000" dirty="0"/>
-                    </a:p>
-                  </a:txBody>
-                  <a:tcPr marL="91440" marR="91440" marT="45720" marB="45720" anchor="ctr">
-                    <a:lnL w="6350" cap="flat" cmpd="sng" algn="ctr">
-                      <a:solidFill>
-                        <a:srgbClr val="D6DEE5"/>
-                      </a:solidFill>
-                      <a:prstDash val="solid"/>
-                      <a:round/>
-                      <a:headEnd type="none" w="med" len="med"/>
-                      <a:tailEnd type="none" w="med" len="med"/>
-                    </a:lnL>
-                    <a:lnR w="6350" cap="flat" cmpd="sng" algn="ctr">
-                      <a:solidFill>
-                        <a:srgbClr val="D6DEE5"/>
-                      </a:solidFill>
-                      <a:prstDash val="solid"/>
-                      <a:round/>
-                      <a:headEnd type="none" w="med" len="med"/>
-                      <a:tailEnd type="none" w="med" len="med"/>
-                    </a:lnR>
-                    <a:lnT w="6350" cap="flat" cmpd="sng" algn="ctr">
-                      <a:solidFill>
-                        <a:srgbClr val="D6DEE5"/>
-                      </a:solidFill>
-                      <a:prstDash val="solid"/>
-                      <a:round/>
-                      <a:headEnd type="none" w="med" len="med"/>
-                      <a:tailEnd type="none" w="med" len="med"/>
-                    </a:lnT>
-                    <a:lnB w="6350" cap="flat" cmpd="sng" algn="ctr">
-                      <a:solidFill>
-                        <a:srgbClr val="D6DEE5"/>
-                      </a:solidFill>
-                      <a:prstDash val="solid"/>
-                      <a:round/>
-                      <a:headEnd type="none" w="med" len="med"/>
-                      <a:tailEnd type="none" w="med" len="med"/>
-                    </a:lnB>
-                  </a:tcPr>
-                </a:tc>
-                <a:tc>
-                  <a:txBody>
-                    <a:bodyPr/>
-                    <a:lstStyle/>
-                    <a:p>
-                      <a:pPr algn="ctr" indent="0" marL="0">
-                        <a:buNone/>
-                      </a:pPr>
-                      <a:r>
-                        <a:rPr lang="en-US" sz="1000" dirty="0">
-                          <a:solidFill>
-                            <a:schemeClr val="accent4"/>
-                          </a:solidFill>
-                        </a:rPr>
-                        <a:t>–</a:t>
-                      </a:r>
-                      <a:endParaRPr lang="en-US" sz="1000" dirty="0"/>
-                    </a:p>
-                  </a:txBody>
-                  <a:tcPr marL="91440" marR="91440" marT="45720" marB="45720" anchor="ctr">
-                    <a:lnL w="6350" cap="flat" cmpd="sng" algn="ctr">
-                      <a:solidFill>
-                        <a:srgbClr val="D6DEE5"/>
-                      </a:solidFill>
-                      <a:prstDash val="solid"/>
-                      <a:round/>
-                      <a:headEnd type="none" w="med" len="med"/>
-                      <a:tailEnd type="none" w="med" len="med"/>
-                    </a:lnL>
-                    <a:lnR w="6350" cap="flat" cmpd="sng" algn="ctr">
-                      <a:solidFill>
-                        <a:srgbClr val="D6DEE5"/>
-                      </a:solidFill>
-                      <a:prstDash val="solid"/>
-                      <a:round/>
-                      <a:headEnd type="none" w="med" len="med"/>
-                      <a:tailEnd type="none" w="med" len="med"/>
-                    </a:lnR>
-                    <a:lnT w="6350" cap="flat" cmpd="sng" algn="ctr">
-                      <a:solidFill>
-                        <a:srgbClr val="D6DEE5"/>
-                      </a:solidFill>
-                      <a:prstDash val="solid"/>
-                      <a:round/>
-                      <a:headEnd type="none" w="med" len="med"/>
-                      <a:tailEnd type="none" w="med" len="med"/>
-                    </a:lnT>
-                    <a:lnB w="6350" cap="flat" cmpd="sng" algn="ctr">
-                      <a:solidFill>
-                        <a:srgbClr val="D6DEE5"/>
-                      </a:solidFill>
-                      <a:prstDash val="solid"/>
-                      <a:round/>
-                      <a:headEnd type="none" w="med" len="med"/>
-                      <a:tailEnd type="none" w="med" len="med"/>
-                    </a:lnB>
-                  </a:tcPr>
-                </a:tc>
-              </a:tr>
-              <a:tr h="329184">
-                <a:tc>
-                  <a:txBody>
-                    <a:bodyPr/>
-                    <a:lstStyle/>
-                    <a:p>
-                      <a:pPr indent="0" marL="0">
-                        <a:buNone/>
-                      </a:pPr>
-                      <a:r>
-                        <a:rPr lang="en-US" sz="1000" dirty="0">
-                          <a:solidFill>
                             <a:schemeClr val="tx1"/>
                           </a:solidFill>
                         </a:rPr>
-                        <a:t>Google Search (high intent, low volume)</a:t>
-                      </a:r>
-                      <a:endParaRPr lang="en-US" sz="1000" dirty="0"/>
-                    </a:p>
-                  </a:txBody>
-                  <a:tcPr marL="91440" marR="91440" marT="45720" marB="45720" anchor="ctr">
-                    <a:lnL w="6350" cap="flat" cmpd="sng" algn="ctr">
-                      <a:solidFill>
-                        <a:srgbClr val="D6DEE5"/>
-                      </a:solidFill>
-                      <a:prstDash val="solid"/>
-                      <a:round/>
-                      <a:headEnd type="none" w="med" len="med"/>
-                      <a:tailEnd type="none" w="med" len="med"/>
-                    </a:lnL>
-                    <a:lnR w="6350" cap="flat" cmpd="sng" algn="ctr">
-                      <a:solidFill>
-                        <a:srgbClr val="D6DEE5"/>
-                      </a:solidFill>
-                      <a:prstDash val="solid"/>
-                      <a:round/>
-                      <a:headEnd type="none" w="med" len="med"/>
-                      <a:tailEnd type="none" w="med" len="med"/>
-                    </a:lnR>
-                    <a:lnT w="6350" cap="flat" cmpd="sng" algn="ctr">
-                      <a:solidFill>
-                        <a:srgbClr val="D6DEE5"/>
-                      </a:solidFill>
-                      <a:prstDash val="solid"/>
-                      <a:round/>
-                      <a:headEnd type="none" w="med" len="med"/>
-                      <a:tailEnd type="none" w="med" len="med"/>
-                    </a:lnT>
-                    <a:lnB w="6350" cap="flat" cmpd="sng" algn="ctr">
-                      <a:solidFill>
-                        <a:srgbClr val="D6DEE5"/>
-                      </a:solidFill>
-                      <a:prstDash val="solid"/>
-                      <a:round/>
-                      <a:headEnd type="none" w="med" len="med"/>
-                      <a:tailEnd type="none" w="med" len="med"/>
-                    </a:lnB>
-                  </a:tcPr>
-                </a:tc>
-                <a:tc>
-                  <a:txBody>
-                    <a:bodyPr/>
-                    <a:lstStyle/>
-                    <a:p>
-                      <a:pPr algn="ctr" indent="0" marL="0">
-                        <a:buNone/>
-                      </a:pPr>
-                      <a:r>
-                        <a:rPr lang="en-US" sz="1000" dirty="0">
-                          <a:solidFill>
-                            <a:schemeClr val="tx1"/>
-                          </a:solidFill>
-                        </a:rPr>
-                        <a:t>€1,193 / €3,788 · 3.8</a:t>
-                      </a:r>
-                      <a:endParaRPr lang="en-US" sz="1000" dirty="0"/>
-                    </a:p>
-                  </a:txBody>
-                  <a:tcPr marL="91440" marR="91440" marT="45720" marB="45720" anchor="ctr">
-                    <a:lnL w="6350" cap="flat" cmpd="sng" algn="ctr">
-                      <a:solidFill>
-                        <a:srgbClr val="D6DEE5"/>
-                      </a:solidFill>
-                      <a:prstDash val="solid"/>
-                      <a:round/>
-                      <a:headEnd type="none" w="med" len="med"/>
-                      <a:tailEnd type="none" w="med" len="med"/>
-                    </a:lnL>
-                    <a:lnR w="6350" cap="flat" cmpd="sng" algn="ctr">
-                      <a:solidFill>
-                        <a:srgbClr val="D6DEE5"/>
-                      </a:solidFill>
-                      <a:prstDash val="solid"/>
-                      <a:round/>
-                      <a:headEnd type="none" w="med" len="med"/>
-                      <a:tailEnd type="none" w="med" len="med"/>
-                    </a:lnR>
-                    <a:lnT w="6350" cap="flat" cmpd="sng" algn="ctr">
-                      <a:solidFill>
-                        <a:srgbClr val="D6DEE5"/>
-                      </a:solidFill>
-                      <a:prstDash val="solid"/>
-                      <a:round/>
-                      <a:headEnd type="none" w="med" len="med"/>
-                      <a:tailEnd type="none" w="med" len="med"/>
-                    </a:lnT>
-                    <a:lnB w="6350" cap="flat" cmpd="sng" algn="ctr">
-                      <a:solidFill>
-                        <a:srgbClr val="D6DEE5"/>
-                      </a:solidFill>
-                      <a:prstDash val="solid"/>
-                      <a:round/>
-                      <a:headEnd type="none" w="med" len="med"/>
-                      <a:tailEnd type="none" w="med" len="med"/>
-                    </a:lnB>
-                    <a:solidFill>
-                      <a:srgbClr val="DCEFE8"/>
-                    </a:solidFill>
-                  </a:tcPr>
-                </a:tc>
-                <a:tc>
-                  <a:txBody>
-                    <a:bodyPr/>
-                    <a:lstStyle/>
-                    <a:p>
-                      <a:pPr algn="ctr" indent="0" marL="0">
-                        <a:buNone/>
-                      </a:pPr>
-                      <a:r>
-                        <a:rPr lang="en-US" sz="1000" dirty="0">
-                          <a:solidFill>
-                            <a:schemeClr val="tx1"/>
-                          </a:solidFill>
-                        </a:rPr>
-                        <a:t>€716 / €1,929 · 0.4 T</a:t>
+                        <a:t>€1,681 / €5,929 · 0.1 T</a:t>
                       </a:r>
                       <a:endParaRPr lang="en-US" sz="1000" dirty="0"/>
                     </a:p>
@@ -16141,7 +16801,7 @@
                             <a:schemeClr val="tx1"/>
                           </a:solidFill>
                         </a:rPr>
-                        <a:t>€1,193 / €4,209 · 0.2 T</a:t>
+                        <a:t>€2,521 / €10,593 · 0.1 T</a:t>
                       </a:r>
                       <a:endParaRPr lang="en-US" sz="1000" dirty="0"/>
                     </a:p>
@@ -16186,666 +16846,6 @@
                     <a:solidFill>
                       <a:srgbClr val="FBEBC8"/>
                     </a:solidFill>
-                  </a:tcPr>
-                </a:tc>
-                <a:tc>
-                  <a:txBody>
-                    <a:bodyPr/>
-                    <a:lstStyle/>
-                    <a:p>
-                      <a:pPr algn="ctr" indent="0" marL="0">
-                        <a:buNone/>
-                      </a:pPr>
-                      <a:r>
-                        <a:rPr lang="en-US" sz="1000" dirty="0">
-                          <a:solidFill>
-                            <a:schemeClr val="tx1"/>
-                          </a:solidFill>
-                        </a:rPr>
-                        <a:t>€1,492 / €6,268 · 0.1 T</a:t>
-                      </a:r>
-                      <a:endParaRPr lang="en-US" sz="1000" dirty="0"/>
-                    </a:p>
-                  </a:txBody>
-                  <a:tcPr marL="91440" marR="91440" marT="45720" marB="45720" anchor="ctr">
-                    <a:lnL w="6350" cap="flat" cmpd="sng" algn="ctr">
-                      <a:solidFill>
-                        <a:srgbClr val="D6DEE5"/>
-                      </a:solidFill>
-                      <a:prstDash val="solid"/>
-                      <a:round/>
-                      <a:headEnd type="none" w="med" len="med"/>
-                      <a:tailEnd type="none" w="med" len="med"/>
-                    </a:lnL>
-                    <a:lnR w="6350" cap="flat" cmpd="sng" algn="ctr">
-                      <a:solidFill>
-                        <a:srgbClr val="D6DEE5"/>
-                      </a:solidFill>
-                      <a:prstDash val="solid"/>
-                      <a:round/>
-                      <a:headEnd type="none" w="med" len="med"/>
-                      <a:tailEnd type="none" w="med" len="med"/>
-                    </a:lnR>
-                    <a:lnT w="6350" cap="flat" cmpd="sng" algn="ctr">
-                      <a:solidFill>
-                        <a:srgbClr val="D6DEE5"/>
-                      </a:solidFill>
-                      <a:prstDash val="solid"/>
-                      <a:round/>
-                      <a:headEnd type="none" w="med" len="med"/>
-                      <a:tailEnd type="none" w="med" len="med"/>
-                    </a:lnT>
-                    <a:lnB w="6350" cap="flat" cmpd="sng" algn="ctr">
-                      <a:solidFill>
-                        <a:srgbClr val="D6DEE5"/>
-                      </a:solidFill>
-                      <a:prstDash val="solid"/>
-                      <a:round/>
-                      <a:headEnd type="none" w="med" len="med"/>
-                      <a:tailEnd type="none" w="med" len="med"/>
-                    </a:lnB>
-                    <a:solidFill>
-                      <a:srgbClr val="FBEBC8"/>
-                    </a:solidFill>
-                  </a:tcPr>
-                </a:tc>
-              </a:tr>
-              <a:tr h="329184">
-                <a:tc>
-                  <a:txBody>
-                    <a:bodyPr/>
-                    <a:lstStyle/>
-                    <a:p>
-                      <a:pPr indent="0" marL="0">
-                        <a:buNone/>
-                      </a:pPr>
-                      <a:r>
-                        <a:rPr lang="en-US" sz="1000" dirty="0">
-                          <a:solidFill>
-                            <a:schemeClr val="tx1"/>
-                          </a:solidFill>
-                        </a:rPr>
-                        <a:t>Programmatic (Indeed, Jooble, Talent.com…)</a:t>
-                      </a:r>
-                      <a:endParaRPr lang="en-US" sz="1000" dirty="0"/>
-                    </a:p>
-                  </a:txBody>
-                  <a:tcPr marL="91440" marR="91440" marT="45720" marB="45720" anchor="ctr">
-                    <a:lnL w="6350" cap="flat" cmpd="sng" algn="ctr">
-                      <a:solidFill>
-                        <a:srgbClr val="D6DEE5"/>
-                      </a:solidFill>
-                      <a:prstDash val="solid"/>
-                      <a:round/>
-                      <a:headEnd type="none" w="med" len="med"/>
-                      <a:tailEnd type="none" w="med" len="med"/>
-                    </a:lnL>
-                    <a:lnR w="6350" cap="flat" cmpd="sng" algn="ctr">
-                      <a:solidFill>
-                        <a:srgbClr val="D6DEE5"/>
-                      </a:solidFill>
-                      <a:prstDash val="solid"/>
-                      <a:round/>
-                      <a:headEnd type="none" w="med" len="med"/>
-                      <a:tailEnd type="none" w="med" len="med"/>
-                    </a:lnR>
-                    <a:lnT w="6350" cap="flat" cmpd="sng" algn="ctr">
-                      <a:solidFill>
-                        <a:srgbClr val="D6DEE5"/>
-                      </a:solidFill>
-                      <a:prstDash val="solid"/>
-                      <a:round/>
-                      <a:headEnd type="none" w="med" len="med"/>
-                      <a:tailEnd type="none" w="med" len="med"/>
-                    </a:lnT>
-                    <a:lnB w="6350" cap="flat" cmpd="sng" algn="ctr">
-                      <a:solidFill>
-                        <a:srgbClr val="D6DEE5"/>
-                      </a:solidFill>
-                      <a:prstDash val="solid"/>
-                      <a:round/>
-                      <a:headEnd type="none" w="med" len="med"/>
-                      <a:tailEnd type="none" w="med" len="med"/>
-                    </a:lnB>
-                  </a:tcPr>
-                </a:tc>
-                <a:tc>
-                  <a:txBody>
-                    <a:bodyPr/>
-                    <a:lstStyle/>
-                    <a:p>
-                      <a:pPr algn="ctr" indent="0" marL="0">
-                        <a:buNone/>
-                      </a:pPr>
-                      <a:r>
-                        <a:rPr lang="en-US" sz="1000" dirty="0">
-                          <a:solidFill>
-                            <a:schemeClr val="tx1"/>
-                          </a:solidFill>
-                        </a:rPr>
-                        <a:t>€1,342 / €4,259 · 0.2 T</a:t>
-                      </a:r>
-                      <a:endParaRPr lang="en-US" sz="1000" dirty="0"/>
-                    </a:p>
-                  </a:txBody>
-                  <a:tcPr marL="91440" marR="91440" marT="45720" marB="45720" anchor="ctr">
-                    <a:lnL w="6350" cap="flat" cmpd="sng" algn="ctr">
-                      <a:solidFill>
-                        <a:srgbClr val="D6DEE5"/>
-                      </a:solidFill>
-                      <a:prstDash val="solid"/>
-                      <a:round/>
-                      <a:headEnd type="none" w="med" len="med"/>
-                      <a:tailEnd type="none" w="med" len="med"/>
-                    </a:lnL>
-                    <a:lnR w="6350" cap="flat" cmpd="sng" algn="ctr">
-                      <a:solidFill>
-                        <a:srgbClr val="D6DEE5"/>
-                      </a:solidFill>
-                      <a:prstDash val="solid"/>
-                      <a:round/>
-                      <a:headEnd type="none" w="med" len="med"/>
-                      <a:tailEnd type="none" w="med" len="med"/>
-                    </a:lnR>
-                    <a:lnT w="6350" cap="flat" cmpd="sng" algn="ctr">
-                      <a:solidFill>
-                        <a:srgbClr val="D6DEE5"/>
-                      </a:solidFill>
-                      <a:prstDash val="solid"/>
-                      <a:round/>
-                      <a:headEnd type="none" w="med" len="med"/>
-                      <a:tailEnd type="none" w="med" len="med"/>
-                    </a:lnT>
-                    <a:lnB w="6350" cap="flat" cmpd="sng" algn="ctr">
-                      <a:solidFill>
-                        <a:srgbClr val="D6DEE5"/>
-                      </a:solidFill>
-                      <a:prstDash val="solid"/>
-                      <a:round/>
-                      <a:headEnd type="none" w="med" len="med"/>
-                      <a:tailEnd type="none" w="med" len="med"/>
-                    </a:lnB>
-                    <a:solidFill>
-                      <a:srgbClr val="FBEBC8"/>
-                    </a:solidFill>
-                  </a:tcPr>
-                </a:tc>
-                <a:tc>
-                  <a:txBody>
-                    <a:bodyPr/>
-                    <a:lstStyle/>
-                    <a:p>
-                      <a:pPr algn="ctr" indent="0" marL="0">
-                        <a:buNone/>
-                      </a:pPr>
-                      <a:r>
-                        <a:rPr lang="en-US" sz="1000" dirty="0">
-                          <a:solidFill>
-                            <a:schemeClr val="tx1"/>
-                          </a:solidFill>
-                        </a:rPr>
-                        <a:t>€732 / €1,971 · 0.4 T</a:t>
-                      </a:r>
-                      <a:endParaRPr lang="en-US" sz="1000" dirty="0"/>
-                    </a:p>
-                  </a:txBody>
-                  <a:tcPr marL="91440" marR="91440" marT="45720" marB="45720" anchor="ctr">
-                    <a:lnL w="6350" cap="flat" cmpd="sng" algn="ctr">
-                      <a:solidFill>
-                        <a:srgbClr val="D6DEE5"/>
-                      </a:solidFill>
-                      <a:prstDash val="solid"/>
-                      <a:round/>
-                      <a:headEnd type="none" w="med" len="med"/>
-                      <a:tailEnd type="none" w="med" len="med"/>
-                    </a:lnL>
-                    <a:lnR w="6350" cap="flat" cmpd="sng" algn="ctr">
-                      <a:solidFill>
-                        <a:srgbClr val="D6DEE5"/>
-                      </a:solidFill>
-                      <a:prstDash val="solid"/>
-                      <a:round/>
-                      <a:headEnd type="none" w="med" len="med"/>
-                      <a:tailEnd type="none" w="med" len="med"/>
-                    </a:lnR>
-                    <a:lnT w="6350" cap="flat" cmpd="sng" algn="ctr">
-                      <a:solidFill>
-                        <a:srgbClr val="D6DEE5"/>
-                      </a:solidFill>
-                      <a:prstDash val="solid"/>
-                      <a:round/>
-                      <a:headEnd type="none" w="med" len="med"/>
-                      <a:tailEnd type="none" w="med" len="med"/>
-                    </a:lnT>
-                    <a:lnB w="6350" cap="flat" cmpd="sng" algn="ctr">
-                      <a:solidFill>
-                        <a:srgbClr val="D6DEE5"/>
-                      </a:solidFill>
-                      <a:prstDash val="solid"/>
-                      <a:round/>
-                      <a:headEnd type="none" w="med" len="med"/>
-                      <a:tailEnd type="none" w="med" len="med"/>
-                    </a:lnB>
-                    <a:solidFill>
-                      <a:srgbClr val="FBEBC8"/>
-                    </a:solidFill>
-                  </a:tcPr>
-                </a:tc>
-                <a:tc>
-                  <a:txBody>
-                    <a:bodyPr/>
-                    <a:lstStyle/>
-                    <a:p>
-                      <a:pPr algn="ctr" indent="0" marL="0">
-                        <a:buNone/>
-                      </a:pPr>
-                      <a:r>
-                        <a:rPr lang="en-US" sz="1000" dirty="0">
-                          <a:solidFill>
-                            <a:schemeClr val="tx1"/>
-                          </a:solidFill>
-                        </a:rPr>
-                        <a:t>€1,342 / €4,733 · 0.2 T</a:t>
-                      </a:r>
-                      <a:endParaRPr lang="en-US" sz="1000" dirty="0"/>
-                    </a:p>
-                  </a:txBody>
-                  <a:tcPr marL="91440" marR="91440" marT="45720" marB="45720" anchor="ctr">
-                    <a:lnL w="6350" cap="flat" cmpd="sng" algn="ctr">
-                      <a:solidFill>
-                        <a:srgbClr val="D6DEE5"/>
-                      </a:solidFill>
-                      <a:prstDash val="solid"/>
-                      <a:round/>
-                      <a:headEnd type="none" w="med" len="med"/>
-                      <a:tailEnd type="none" w="med" len="med"/>
-                    </a:lnL>
-                    <a:lnR w="6350" cap="flat" cmpd="sng" algn="ctr">
-                      <a:solidFill>
-                        <a:srgbClr val="D6DEE5"/>
-                      </a:solidFill>
-                      <a:prstDash val="solid"/>
-                      <a:round/>
-                      <a:headEnd type="none" w="med" len="med"/>
-                      <a:tailEnd type="none" w="med" len="med"/>
-                    </a:lnR>
-                    <a:lnT w="6350" cap="flat" cmpd="sng" algn="ctr">
-                      <a:solidFill>
-                        <a:srgbClr val="D6DEE5"/>
-                      </a:solidFill>
-                      <a:prstDash val="solid"/>
-                      <a:round/>
-                      <a:headEnd type="none" w="med" len="med"/>
-                      <a:tailEnd type="none" w="med" len="med"/>
-                    </a:lnT>
-                    <a:lnB w="6350" cap="flat" cmpd="sng" algn="ctr">
-                      <a:solidFill>
-                        <a:srgbClr val="D6DEE5"/>
-                      </a:solidFill>
-                      <a:prstDash val="solid"/>
-                      <a:round/>
-                      <a:headEnd type="none" w="med" len="med"/>
-                      <a:tailEnd type="none" w="med" len="med"/>
-                    </a:lnB>
-                    <a:solidFill>
-                      <a:srgbClr val="FBEBC8"/>
-                    </a:solidFill>
-                  </a:tcPr>
-                </a:tc>
-                <a:tc>
-                  <a:txBody>
-                    <a:bodyPr/>
-                    <a:lstStyle/>
-                    <a:p>
-                      <a:pPr algn="ctr" indent="0" marL="0">
-                        <a:buNone/>
-                      </a:pPr>
-                      <a:r>
-                        <a:rPr lang="en-US" sz="1000" dirty="0">
-                          <a:solidFill>
-                            <a:schemeClr val="tx1"/>
-                          </a:solidFill>
-                        </a:rPr>
-                        <a:t>€1,610 / €6,765 · 0.1 T</a:t>
-                      </a:r>
-                      <a:endParaRPr lang="en-US" sz="1000" dirty="0"/>
-                    </a:p>
-                  </a:txBody>
-                  <a:tcPr marL="91440" marR="91440" marT="45720" marB="45720" anchor="ctr">
-                    <a:lnL w="6350" cap="flat" cmpd="sng" algn="ctr">
-                      <a:solidFill>
-                        <a:srgbClr val="D6DEE5"/>
-                      </a:solidFill>
-                      <a:prstDash val="solid"/>
-                      <a:round/>
-                      <a:headEnd type="none" w="med" len="med"/>
-                      <a:tailEnd type="none" w="med" len="med"/>
-                    </a:lnL>
-                    <a:lnR w="6350" cap="flat" cmpd="sng" algn="ctr">
-                      <a:solidFill>
-                        <a:srgbClr val="D6DEE5"/>
-                      </a:solidFill>
-                      <a:prstDash val="solid"/>
-                      <a:round/>
-                      <a:headEnd type="none" w="med" len="med"/>
-                      <a:tailEnd type="none" w="med" len="med"/>
-                    </a:lnR>
-                    <a:lnT w="6350" cap="flat" cmpd="sng" algn="ctr">
-                      <a:solidFill>
-                        <a:srgbClr val="D6DEE5"/>
-                      </a:solidFill>
-                      <a:prstDash val="solid"/>
-                      <a:round/>
-                      <a:headEnd type="none" w="med" len="med"/>
-                      <a:tailEnd type="none" w="med" len="med"/>
-                    </a:lnT>
-                    <a:lnB w="6350" cap="flat" cmpd="sng" algn="ctr">
-                      <a:solidFill>
-                        <a:srgbClr val="D6DEE5"/>
-                      </a:solidFill>
-                      <a:prstDash val="solid"/>
-                      <a:round/>
-                      <a:headEnd type="none" w="med" len="med"/>
-                      <a:tailEnd type="none" w="med" len="med"/>
-                    </a:lnB>
-                    <a:solidFill>
-                      <a:srgbClr val="FBEBC8"/>
-                    </a:solidFill>
-                  </a:tcPr>
-                </a:tc>
-              </a:tr>
-              <a:tr h="329184">
-                <a:tc>
-                  <a:txBody>
-                    <a:bodyPr/>
-                    <a:lstStyle/>
-                    <a:p>
-                      <a:pPr indent="0" marL="0">
-                        <a:buNone/>
-                      </a:pPr>
-                      <a:r>
-                        <a:rPr lang="en-US" sz="1000" dirty="0">
-                          <a:solidFill>
-                            <a:schemeClr val="tx1"/>
-                          </a:solidFill>
-                        </a:rPr>
-                        <a:t>I2 Handwerk → Industrie (new pool)</a:t>
-                      </a:r>
-                      <a:endParaRPr lang="en-US" sz="1000" dirty="0"/>
-                    </a:p>
-                  </a:txBody>
-                  <a:tcPr marL="91440" marR="91440" marT="45720" marB="45720" anchor="ctr">
-                    <a:lnL w="6350" cap="flat" cmpd="sng" algn="ctr">
-                      <a:solidFill>
-                        <a:srgbClr val="D6DEE5"/>
-                      </a:solidFill>
-                      <a:prstDash val="solid"/>
-                      <a:round/>
-                      <a:headEnd type="none" w="med" len="med"/>
-                      <a:tailEnd type="none" w="med" len="med"/>
-                    </a:lnL>
-                    <a:lnR w="6350" cap="flat" cmpd="sng" algn="ctr">
-                      <a:solidFill>
-                        <a:srgbClr val="D6DEE5"/>
-                      </a:solidFill>
-                      <a:prstDash val="solid"/>
-                      <a:round/>
-                      <a:headEnd type="none" w="med" len="med"/>
-                      <a:tailEnd type="none" w="med" len="med"/>
-                    </a:lnR>
-                    <a:lnT w="6350" cap="flat" cmpd="sng" algn="ctr">
-                      <a:solidFill>
-                        <a:srgbClr val="D6DEE5"/>
-                      </a:solidFill>
-                      <a:prstDash val="solid"/>
-                      <a:round/>
-                      <a:headEnd type="none" w="med" len="med"/>
-                      <a:tailEnd type="none" w="med" len="med"/>
-                    </a:lnT>
-                    <a:lnB w="6350" cap="flat" cmpd="sng" algn="ctr">
-                      <a:solidFill>
-                        <a:srgbClr val="D6DEE5"/>
-                      </a:solidFill>
-                      <a:prstDash val="solid"/>
-                      <a:round/>
-                      <a:headEnd type="none" w="med" len="med"/>
-                      <a:tailEnd type="none" w="med" len="med"/>
-                    </a:lnB>
-                  </a:tcPr>
-                </a:tc>
-                <a:tc>
-                  <a:txBody>
-                    <a:bodyPr/>
-                    <a:lstStyle/>
-                    <a:p>
-                      <a:pPr algn="ctr" indent="0" marL="0">
-                        <a:buNone/>
-                      </a:pPr>
-                      <a:r>
-                        <a:rPr lang="en-US" sz="1000" dirty="0">
-                          <a:solidFill>
-                            <a:schemeClr val="tx1"/>
-                          </a:solidFill>
-                        </a:rPr>
-                        <a:t>€560 / €2,349 · 9.5</a:t>
-                      </a:r>
-                      <a:endParaRPr lang="en-US" sz="1000" dirty="0"/>
-                    </a:p>
-                  </a:txBody>
-                  <a:tcPr marL="91440" marR="91440" marT="45720" marB="45720" anchor="ctr">
-                    <a:lnL w="6350" cap="flat" cmpd="sng" algn="ctr">
-                      <a:solidFill>
-                        <a:srgbClr val="D6DEE5"/>
-                      </a:solidFill>
-                      <a:prstDash val="solid"/>
-                      <a:round/>
-                      <a:headEnd type="none" w="med" len="med"/>
-                      <a:tailEnd type="none" w="med" len="med"/>
-                    </a:lnL>
-                    <a:lnR w="6350" cap="flat" cmpd="sng" algn="ctr">
-                      <a:solidFill>
-                        <a:srgbClr val="D6DEE5"/>
-                      </a:solidFill>
-                      <a:prstDash val="solid"/>
-                      <a:round/>
-                      <a:headEnd type="none" w="med" len="med"/>
-                      <a:tailEnd type="none" w="med" len="med"/>
-                    </a:lnR>
-                    <a:lnT w="6350" cap="flat" cmpd="sng" algn="ctr">
-                      <a:solidFill>
-                        <a:srgbClr val="D6DEE5"/>
-                      </a:solidFill>
-                      <a:prstDash val="solid"/>
-                      <a:round/>
-                      <a:headEnd type="none" w="med" len="med"/>
-                      <a:tailEnd type="none" w="med" len="med"/>
-                    </a:lnT>
-                    <a:lnB w="6350" cap="flat" cmpd="sng" algn="ctr">
-                      <a:solidFill>
-                        <a:srgbClr val="D6DEE5"/>
-                      </a:solidFill>
-                      <a:prstDash val="solid"/>
-                      <a:round/>
-                      <a:headEnd type="none" w="med" len="med"/>
-                      <a:tailEnd type="none" w="med" len="med"/>
-                    </a:lnB>
-                    <a:solidFill>
-                      <a:srgbClr val="DCEFE8"/>
-                    </a:solidFill>
-                  </a:tcPr>
-                </a:tc>
-                <a:tc>
-                  <a:txBody>
-                    <a:bodyPr/>
-                    <a:lstStyle/>
-                    <a:p>
-                      <a:pPr algn="ctr" indent="0" marL="0">
-                        <a:buNone/>
-                      </a:pPr>
-                      <a:r>
-                        <a:rPr lang="en-US" sz="1000" dirty="0">
-                          <a:solidFill>
-                            <a:schemeClr val="accent4"/>
-                          </a:solidFill>
-                        </a:rPr>
-                        <a:t>–</a:t>
-                      </a:r>
-                      <a:endParaRPr lang="en-US" sz="1000" dirty="0"/>
-                    </a:p>
-                  </a:txBody>
-                  <a:tcPr marL="91440" marR="91440" marT="45720" marB="45720" anchor="ctr">
-                    <a:lnL w="6350" cap="flat" cmpd="sng" algn="ctr">
-                      <a:solidFill>
-                        <a:srgbClr val="D6DEE5"/>
-                      </a:solidFill>
-                      <a:prstDash val="solid"/>
-                      <a:round/>
-                      <a:headEnd type="none" w="med" len="med"/>
-                      <a:tailEnd type="none" w="med" len="med"/>
-                    </a:lnL>
-                    <a:lnR w="6350" cap="flat" cmpd="sng" algn="ctr">
-                      <a:solidFill>
-                        <a:srgbClr val="D6DEE5"/>
-                      </a:solidFill>
-                      <a:prstDash val="solid"/>
-                      <a:round/>
-                      <a:headEnd type="none" w="med" len="med"/>
-                      <a:tailEnd type="none" w="med" len="med"/>
-                    </a:lnR>
-                    <a:lnT w="6350" cap="flat" cmpd="sng" algn="ctr">
-                      <a:solidFill>
-                        <a:srgbClr val="D6DEE5"/>
-                      </a:solidFill>
-                      <a:prstDash val="solid"/>
-                      <a:round/>
-                      <a:headEnd type="none" w="med" len="med"/>
-                      <a:tailEnd type="none" w="med" len="med"/>
-                    </a:lnT>
-                    <a:lnB w="6350" cap="flat" cmpd="sng" algn="ctr">
-                      <a:solidFill>
-                        <a:srgbClr val="D6DEE5"/>
-                      </a:solidFill>
-                      <a:prstDash val="solid"/>
-                      <a:round/>
-                      <a:headEnd type="none" w="med" len="med"/>
-                      <a:tailEnd type="none" w="med" len="med"/>
-                    </a:lnB>
-                  </a:tcPr>
-                </a:tc>
-                <a:tc>
-                  <a:txBody>
-                    <a:bodyPr/>
-                    <a:lstStyle/>
-                    <a:p>
-                      <a:pPr algn="ctr" indent="0" marL="0">
-                        <a:buNone/>
-                      </a:pPr>
-                      <a:r>
-                        <a:rPr lang="en-US" sz="1000" dirty="0">
-                          <a:solidFill>
-                            <a:schemeClr val="accent4"/>
-                          </a:solidFill>
-                        </a:rPr>
-                        <a:t>–</a:t>
-                      </a:r>
-                      <a:endParaRPr lang="en-US" sz="1000" dirty="0"/>
-                    </a:p>
-                  </a:txBody>
-                  <a:tcPr marL="91440" marR="91440" marT="45720" marB="45720" anchor="ctr">
-                    <a:lnL w="6350" cap="flat" cmpd="sng" algn="ctr">
-                      <a:solidFill>
-                        <a:srgbClr val="D6DEE5"/>
-                      </a:solidFill>
-                      <a:prstDash val="solid"/>
-                      <a:round/>
-                      <a:headEnd type="none" w="med" len="med"/>
-                      <a:tailEnd type="none" w="med" len="med"/>
-                    </a:lnL>
-                    <a:lnR w="6350" cap="flat" cmpd="sng" algn="ctr">
-                      <a:solidFill>
-                        <a:srgbClr val="D6DEE5"/>
-                      </a:solidFill>
-                      <a:prstDash val="solid"/>
-                      <a:round/>
-                      <a:headEnd type="none" w="med" len="med"/>
-                      <a:tailEnd type="none" w="med" len="med"/>
-                    </a:lnR>
-                    <a:lnT w="6350" cap="flat" cmpd="sng" algn="ctr">
-                      <a:solidFill>
-                        <a:srgbClr val="D6DEE5"/>
-                      </a:solidFill>
-                      <a:prstDash val="solid"/>
-                      <a:round/>
-                      <a:headEnd type="none" w="med" len="med"/>
-                      <a:tailEnd type="none" w="med" len="med"/>
-                    </a:lnT>
-                    <a:lnB w="6350" cap="flat" cmpd="sng" algn="ctr">
-                      <a:solidFill>
-                        <a:srgbClr val="D6DEE5"/>
-                      </a:solidFill>
-                      <a:prstDash val="solid"/>
-                      <a:round/>
-                      <a:headEnd type="none" w="med" len="med"/>
-                      <a:tailEnd type="none" w="med" len="med"/>
-                    </a:lnB>
-                  </a:tcPr>
-                </a:tc>
-                <a:tc>
-                  <a:txBody>
-                    <a:bodyPr/>
-                    <a:lstStyle/>
-                    <a:p>
-                      <a:pPr algn="ctr" indent="0" marL="0">
-                        <a:buNone/>
-                      </a:pPr>
-                      <a:r>
-                        <a:rPr lang="en-US" sz="1000" dirty="0">
-                          <a:solidFill>
-                            <a:schemeClr val="accent4"/>
-                          </a:solidFill>
-                        </a:rPr>
-                        <a:t>–</a:t>
-                      </a:r>
-                      <a:endParaRPr lang="en-US" sz="1000" dirty="0"/>
-                    </a:p>
-                  </a:txBody>
-                  <a:tcPr marL="91440" marR="91440" marT="45720" marB="45720" anchor="ctr">
-                    <a:lnL w="6350" cap="flat" cmpd="sng" algn="ctr">
-                      <a:solidFill>
-                        <a:srgbClr val="D6DEE5"/>
-                      </a:solidFill>
-                      <a:prstDash val="solid"/>
-                      <a:round/>
-                      <a:headEnd type="none" w="med" len="med"/>
-                      <a:tailEnd type="none" w="med" len="med"/>
-                    </a:lnL>
-                    <a:lnR w="6350" cap="flat" cmpd="sng" algn="ctr">
-                      <a:solidFill>
-                        <a:srgbClr val="D6DEE5"/>
-                      </a:solidFill>
-                      <a:prstDash val="solid"/>
-                      <a:round/>
-                      <a:headEnd type="none" w="med" len="med"/>
-                      <a:tailEnd type="none" w="med" len="med"/>
-                    </a:lnR>
-                    <a:lnT w="6350" cap="flat" cmpd="sng" algn="ctr">
-                      <a:solidFill>
-                        <a:srgbClr val="D6DEE5"/>
-                      </a:solidFill>
-                      <a:prstDash val="solid"/>
-                      <a:round/>
-                      <a:headEnd type="none" w="med" len="med"/>
-                      <a:tailEnd type="none" w="med" len="med"/>
-                    </a:lnT>
-                    <a:lnB w="6350" cap="flat" cmpd="sng" algn="ctr">
-                      <a:solidFill>
-                        <a:srgbClr val="D6DEE5"/>
-                      </a:solidFill>
-                      <a:prstDash val="solid"/>
-                      <a:round/>
-                      <a:headEnd type="none" w="med" len="med"/>
-                      <a:tailEnd type="none" w="med" len="med"/>
-                    </a:lnB>
                   </a:tcPr>
                 </a:tc>
               </a:tr>
@@ -17066,7 +17066,7 @@
                   <a:schemeClr val="tx2"/>
                 </a:solidFill>
               </a:rPr>
-              <a:t>Cells: cost per qualified / cost per hire · hires planned. Cost per hire = (cost per application × applications + set-up) ÷ hires at full capacity; I2 includes €1,200 set-up, I3 €400 translation. StepStone ads (7 × €1,449) are costed whole and credited only the applications the plan needs (conservative).</a:t>
+              <a:t>Cells: cost per qualified / cost per hire · hires planned. Cost per hire = (cost per application × applications + set-up) ÷ hires at full capacity; I2 includes €1,200 set-up, I3 €400 translation. StepStone ads (6 × €1,449) are costed whole and credited only the applications the plan needs (conservative).</a:t>
             </a:r>
             <a:endParaRPr lang="en-US" sz="1000" dirty="0"/>
           </a:p>
@@ -17102,7 +17102,7 @@
                   <a:schemeClr val="accent4"/>
                 </a:solidFill>
               </a:rPr>
-              <a:t>Sourced: StepStone €1,449/30-day ad (stepstone.de price list) · cost per application, DACH medians: Indeed €161, Google €179, LinkedIn €96, Meta €84 (TalentBait, 2,549 campaigns, 2024–26) · share qualified: 28% of applications suitable (IAB-Stellenerhebung 2026) · pools: BA employment statistics by KldB code (Dec 2025) · time-to-offer: SmartRecruiters Germany benchmark. Every source (with its link) and every remaining own estimate is labelled on the Assumptions tab.</a:t>
+              <a:t>Sourced: cost per application, DACH medians: Indeed €161, Google €179, LinkedIn €96, Meta €84 (TalentBait 2024–26) · StepStone €1,449/ad, 12 applications per ad · share qualified: IAB 2026 (28%), channel index from IAB 2025 (job boards 0.90, careers page 0.71, social 0.50) · volume caps: channel reach (Trendence 2023: Indeed 36%, LinkedIn 15%) × in-market pool (BA 2025, Gallup 11%) · Meta volumes: Redline 2024–26. Every input's source or derivation is on the Assumptions tab.</a:t>
             </a:r>
             <a:endParaRPr lang="en-US" sz="1000" dirty="0"/>
           </a:p>
@@ -17252,7 +17252,7 @@
                 <a:ea typeface="Cambria" pitchFamily="34" charset="-122"/>
                 <a:cs typeface="Cambria" pitchFamily="34" charset="-120"/>
               </a:rPr>
-              <a:t>€85.4k planned across roles and weeks, plus €17.1k reserve released on results</a:t>
+              <a:t>€176.2k planned across roles and weeks, plus €31.3k reserve released on results</a:t>
             </a:r>
             <a:endParaRPr lang="en-US" sz="2200" dirty="0"/>
           </a:p>
@@ -17321,7 +17321,7 @@
                   <a:schemeClr val="tx1"/>
                 </a:solidFill>
               </a:rPr>
-              <a:t>€52.0k paid channels (incl. €9.0k tests) + €31.8k initiative media, pre-screen calls and bonuses + €1.6k set-up = €85.4k. Reserve: 15% of €100.5k plus rounding = €17.1k.</a:t>
+              <a:t>€140.1k paid channels (incl. €9.0k tests) + €34.6k initiative media, pre-screen calls and bonuses + €1.6k set-up = €176.2k. Reserve: 15% of €207.3k plus rounding = €31.3k.</a:t>
             </a:r>
             <a:endParaRPr lang="en-US" sz="1100" dirty="0"/>
           </a:p>
@@ -17352,7 +17352,7 @@
                   <a:schemeClr val="tx1"/>
                 </a:solidFill>
               </a:rPr>
-              <a:t>weeks 1–2 cost €31.8k (31%), mostly tests. Duds are cut from Mon 2 Nov (after €500 / 30 apps); tests and the full re-allocation are judged by Mon 9 Nov; the reserve moves only from week 3. Paid media stops after Tue 24 Nov.</a:t>
+              <a:t>weeks 1–2 cost €58.9k (28%), mostly tests. Duds are cut from Mon 2 Nov (after €500 / 30 apps); tests and the full re-allocation are judged by Mon 9 Nov; the reserve moves only from week 3. Paid media stops after Tue 24 Nov.</a:t>
             </a:r>
             <a:endParaRPr lang="en-US" sz="1100" dirty="0"/>
           </a:p>
@@ -17767,7 +17767,7 @@
                             <a:schemeClr val="tx1"/>
                           </a:solidFill>
                         </a:rPr>
-                        <a:t>€46.5k</a:t>
+                        <a:t>€70.7k</a:t>
                       </a:r>
                       <a:endParaRPr lang="en-US" sz="1100" dirty="0"/>
                     </a:p>
@@ -17941,7 +17941,7 @@
                             <a:schemeClr val="tx1"/>
                           </a:solidFill>
                         </a:rPr>
-                        <a:t>€1,550</a:t>
+                        <a:t>€2,356</a:t>
                       </a:r>
                       <a:endParaRPr lang="en-US" sz="1100" dirty="0"/>
                     </a:p>
@@ -18059,7 +18059,7 @@
                             <a:schemeClr val="tx1"/>
                           </a:solidFill>
                         </a:rPr>
-                        <a:t>€9.7k</a:t>
+                        <a:t>€33.9k</a:t>
                       </a:r>
                       <a:endParaRPr lang="en-US" sz="1100" dirty="0"/>
                     </a:p>
@@ -18233,7 +18233,7 @@
                             <a:schemeClr val="tx1"/>
                           </a:solidFill>
                         </a:rPr>
-                        <a:t>€215</a:t>
+                        <a:t>€752</a:t>
                       </a:r>
                       <a:endParaRPr lang="en-US" sz="1100" dirty="0"/>
                     </a:p>
@@ -18351,7 +18351,7 @@
                             <a:schemeClr val="tx1"/>
                           </a:solidFill>
                         </a:rPr>
-                        <a:t>€14.6k</a:t>
+                        <a:t>€32.4k</a:t>
                       </a:r>
                       <a:endParaRPr lang="en-US" sz="1100" dirty="0"/>
                     </a:p>
@@ -18525,7 +18525,7 @@
                             <a:schemeClr val="tx1"/>
                           </a:solidFill>
                         </a:rPr>
-                        <a:t>€975</a:t>
+                        <a:t>€2,158</a:t>
                       </a:r>
                       <a:endParaRPr lang="en-US" sz="1100" dirty="0"/>
                     </a:p>
@@ -18643,7 +18643,7 @@
                             <a:schemeClr val="tx1"/>
                           </a:solidFill>
                         </a:rPr>
-                        <a:t>€14.6k</a:t>
+                        <a:t>€39.3k</a:t>
                       </a:r>
                       <a:endParaRPr lang="en-US" sz="1100" dirty="0"/>
                     </a:p>
@@ -18817,7 +18817,7 @@
                             <a:schemeClr val="tx1"/>
                           </a:solidFill>
                         </a:rPr>
-                        <a:t>€1,457</a:t>
+                        <a:t>€3,930</a:t>
                       </a:r>
                       <a:endParaRPr lang="en-US" sz="1100" dirty="0"/>
                     </a:p>
@@ -18935,7 +18935,7 @@
                             <a:schemeClr val="tx1"/>
                           </a:solidFill>
                         </a:rPr>
-                        <a:t>€85.4k</a:t>
+                        <a:t>€176.2k</a:t>
                       </a:r>
                       <a:endParaRPr lang="en-US" sz="1100" dirty="0"/>
                     </a:p>
@@ -19109,7 +19109,7 @@
                             <a:schemeClr val="tx1"/>
                           </a:solidFill>
                         </a:rPr>
-                        <a:t>€854</a:t>
+                        <a:t>€1,762</a:t>
                       </a:r>
                       <a:endParaRPr lang="en-US" sz="1100" dirty="0"/>
                     </a:p>
@@ -19563,7 +19563,7 @@
                             <a:schemeClr val="tx1"/>
                           </a:solidFill>
                         </a:rPr>
-                        <a:t>20.6</a:t>
+                        <a:t>14.9</a:t>
                       </a:r>
                       <a:endParaRPr lang="en-US" sz="1000" dirty="0"/>
                     </a:p>
@@ -19739,7 +19739,7 @@
                             <a:schemeClr val="tx1"/>
                           </a:solidFill>
                         </a:rPr>
-                        <a:t>€3.0k</a:t>
+                        <a:t>€15.9k</a:t>
                       </a:r>
                       <a:endParaRPr lang="en-US" sz="1000" dirty="0"/>
                     </a:p>
@@ -19797,7 +19797,7 @@
                             <a:schemeClr val="tx1"/>
                           </a:solidFill>
                         </a:rPr>
-                        <a:t>0.8</a:t>
+                        <a:t>4.2</a:t>
                       </a:r>
                       <a:endParaRPr lang="en-US" sz="1000" dirty="0"/>
                     </a:p>
@@ -19855,7 +19855,7 @@
                             <a:schemeClr val="tx1"/>
                           </a:solidFill>
                         </a:rPr>
-                        <a:t>€3,632</a:t>
+                        <a:t>€3,799</a:t>
                       </a:r>
                       <a:endParaRPr lang="en-US" sz="1000" dirty="0"/>
                     </a:p>
@@ -19973,7 +19973,7 @@
                             <a:schemeClr val="tx1"/>
                           </a:solidFill>
                         </a:rPr>
-                        <a:t>€10.1k</a:t>
+                        <a:t>€8.7k</a:t>
                       </a:r>
                       <a:endParaRPr lang="en-US" sz="1000" dirty="0"/>
                     </a:p>
@@ -20031,7 +20031,7 @@
                             <a:schemeClr val="tx1"/>
                           </a:solidFill>
                         </a:rPr>
-                        <a:t>10.8</a:t>
+                        <a:t>3.7</a:t>
                       </a:r>
                       <a:endParaRPr lang="en-US" sz="1000" dirty="0"/>
                     </a:p>
@@ -20089,7 +20089,7 @@
                             <a:schemeClr val="tx1"/>
                           </a:solidFill>
                         </a:rPr>
-                        <a:t>€937</a:t>
+                        <a:t>€2,348</a:t>
                       </a:r>
                       <a:endParaRPr lang="en-US" sz="1000" dirty="0"/>
                     </a:p>
@@ -20207,7 +20207,7 @@
                             <a:schemeClr val="tx1"/>
                           </a:solidFill>
                         </a:rPr>
-                        <a:t>€20.8k</a:t>
+                        <a:t>€62.0k</a:t>
                       </a:r>
                       <a:endParaRPr lang="en-US" sz="1000" dirty="0"/>
                     </a:p>
@@ -20265,7 +20265,7 @@
                             <a:schemeClr val="tx1"/>
                           </a:solidFill>
                         </a:rPr>
-                        <a:t>13.1</a:t>
+                        <a:t>18.2</a:t>
                       </a:r>
                       <a:endParaRPr lang="en-US" sz="1000" dirty="0"/>
                     </a:p>
@@ -20323,7 +20323,7 @@
                             <a:schemeClr val="tx1"/>
                           </a:solidFill>
                         </a:rPr>
-                        <a:t>€1,584</a:t>
+                        <a:t>€3,404</a:t>
                       </a:r>
                       <a:endParaRPr lang="en-US" sz="1000" dirty="0"/>
                     </a:p>
@@ -20441,7 +20441,7 @@
                             <a:schemeClr val="tx1"/>
                           </a:solidFill>
                         </a:rPr>
-                        <a:t>€1.5k</a:t>
+                        <a:t>€50.4k</a:t>
                       </a:r>
                       <a:endParaRPr lang="en-US" sz="1000" dirty="0"/>
                     </a:p>
@@ -20499,7 +20499,7 @@
                             <a:schemeClr val="tx1"/>
                           </a:solidFill>
                         </a:rPr>
-                        <a:t>0.5</a:t>
+                        <a:t>17.6</a:t>
                       </a:r>
                       <a:endParaRPr lang="en-US" sz="1000" dirty="0"/>
                     </a:p>
@@ -20557,7 +20557,7 @@
                             <a:schemeClr val="tx1"/>
                           </a:solidFill>
                         </a:rPr>
-                        <a:t>€2,786</a:t>
+                        <a:t>€2,861</a:t>
                       </a:r>
                       <a:endParaRPr lang="en-US" sz="1000" dirty="0"/>
                     </a:p>
@@ -20675,7 +20675,7 @@
                             <a:schemeClr val="tx1"/>
                           </a:solidFill>
                         </a:rPr>
-                        <a:t>€16.6k</a:t>
+                        <a:t>€3.0k</a:t>
                       </a:r>
                       <a:endParaRPr lang="en-US" sz="1000" dirty="0"/>
                     </a:p>
@@ -20733,7 +20733,7 @@
                             <a:schemeClr val="tx1"/>
                           </a:solidFill>
                         </a:rPr>
-                        <a:t>4.5</a:t>
+                        <a:t>0.6</a:t>
                       </a:r>
                       <a:endParaRPr lang="en-US" sz="1000" dirty="0"/>
                     </a:p>
@@ -20791,7 +20791,7 @@
                             <a:schemeClr val="tx1"/>
                           </a:solidFill>
                         </a:rPr>
-                        <a:t>€3,710</a:t>
+                        <a:t>€5,165</a:t>
                       </a:r>
                       <a:endParaRPr lang="en-US" sz="1000" dirty="0"/>
                     </a:p>
@@ -20909,7 +20909,7 @@
                             <a:schemeClr val="tx1"/>
                           </a:solidFill>
                         </a:rPr>
-                        <a:t>€210</a:t>
+                        <a:t>€41</a:t>
                       </a:r>
                       <a:endParaRPr lang="en-US" sz="1000" dirty="0"/>
                     </a:p>
@@ -20967,7 +20967,7 @@
                             <a:schemeClr val="tx1"/>
                           </a:solidFill>
                         </a:rPr>
-                        <a:t>15.7</a:t>
+                        <a:t>3.1</a:t>
                       </a:r>
                       <a:endParaRPr lang="en-US" sz="1000" dirty="0"/>
                     </a:p>
@@ -21143,7 +21143,7 @@
                             <a:schemeClr val="tx1"/>
                           </a:solidFill>
                         </a:rPr>
-                        <a:t>€6.5k</a:t>
+                        <a:t>€11.2k</a:t>
                       </a:r>
                       <a:endParaRPr lang="en-US" sz="1000" dirty="0"/>
                     </a:p>
@@ -21201,7 +21201,7 @@
                             <a:schemeClr val="tx1"/>
                           </a:solidFill>
                         </a:rPr>
-                        <a:t>6.5</a:t>
+                        <a:t>11.2</a:t>
                       </a:r>
                       <a:endParaRPr lang="en-US" sz="1000" dirty="0"/>
                     </a:p>
@@ -21377,7 +21377,7 @@
                             <a:schemeClr val="tx1"/>
                           </a:solidFill>
                         </a:rPr>
-                        <a:t>€22.2k</a:t>
+                        <a:t>€18.0k</a:t>
                       </a:r>
                       <a:endParaRPr lang="en-US" sz="1000" dirty="0"/>
                     </a:p>
@@ -21435,7 +21435,7 @@
                             <a:schemeClr val="tx1"/>
                           </a:solidFill>
                         </a:rPr>
-                        <a:t>9.5</a:t>
+                        <a:t>8.5</a:t>
                       </a:r>
                       <a:endParaRPr lang="en-US" sz="1000" dirty="0"/>
                     </a:p>
@@ -21493,7 +21493,7 @@
                             <a:schemeClr val="tx1"/>
                           </a:solidFill>
                         </a:rPr>
-                        <a:t>€2,349</a:t>
+                        <a:t>€2,116</a:t>
                       </a:r>
                       <a:endParaRPr lang="en-US" sz="1000" dirty="0"/>
                     </a:p>
@@ -21611,7 +21611,7 @@
                             <a:schemeClr val="tx1"/>
                           </a:solidFill>
                         </a:rPr>
-                        <a:t>€4.5k</a:t>
+                        <a:t>€6.9k</a:t>
                       </a:r>
                       <a:endParaRPr lang="en-US" sz="1000" dirty="0"/>
                     </a:p>
@@ -21727,7 +21727,7 @@
                             <a:schemeClr val="tx1"/>
                           </a:solidFill>
                         </a:rPr>
-                        <a:t>€248</a:t>
+                        <a:t>€383</a:t>
                       </a:r>
                       <a:endParaRPr lang="en-US" sz="1000" dirty="0"/>
                     </a:p>
@@ -21920,7 +21920,7 @@
                 <a:ea typeface="Cambria" pitchFamily="34" charset="-122"/>
                 <a:cs typeface="Cambria" pitchFamily="34" charset="-120"/>
               </a:rPr>
-              <a:t>30% less (€71.75k) still signs ~93, but electricians take most of the loss</a:t>
+              <a:t>30% less (€145.25k) still signs ~88; supervisors take most of the loss</a:t>
             </a:r>
             <a:endParaRPr lang="en-US" sz="2200" dirty="0"/>
           </a:p>
@@ -22169,7 +22169,7 @@
                             <a:schemeClr val="tx1"/>
                           </a:solidFill>
                         </a:rPr>
-                        <a:t>100% · €102.50k</a:t>
+                        <a:t>100% · €207.50k</a:t>
                       </a:r>
                       <a:endParaRPr lang="en-US" sz="1100" dirty="0"/>
                     </a:p>
@@ -22285,7 +22285,7 @@
                             <a:schemeClr val="tx1"/>
                           </a:solidFill>
                         </a:rPr>
-                        <a:t>€1,025</a:t>
+                        <a:t>€2,075</a:t>
                       </a:r>
                       <a:endParaRPr lang="en-US" sz="1100" dirty="0"/>
                     </a:p>
@@ -22345,7 +22345,7 @@
                             <a:schemeClr val="tx1"/>
                           </a:solidFill>
                         </a:rPr>
-                        <a:t>85% · €87.13k</a:t>
+                        <a:t>85% · €176.38k</a:t>
                       </a:r>
                       <a:endParaRPr lang="en-US" sz="1100" dirty="0"/>
                     </a:p>
@@ -22403,7 +22403,7 @@
                             <a:schemeClr val="tx1"/>
                           </a:solidFill>
                         </a:rPr>
-                        <a:t>97</a:t>
+                        <a:t>94</a:t>
                       </a:r>
                       <a:endParaRPr lang="en-US" sz="1100" dirty="0"/>
                     </a:p>
@@ -22461,7 +22461,7 @@
                             <a:schemeClr val="tx1"/>
                           </a:solidFill>
                         </a:rPr>
-                        <a:t>€895</a:t>
+                        <a:t>€1,869</a:t>
                       </a:r>
                       <a:endParaRPr lang="en-US" sz="1100" dirty="0"/>
                     </a:p>
@@ -22521,7 +22521,7 @@
                             <a:schemeClr val="tx1"/>
                           </a:solidFill>
                         </a:rPr>
-                        <a:t>70% · €71.75k</a:t>
+                        <a:t>70% · €145.25k</a:t>
                       </a:r>
                       <a:endParaRPr lang="en-US" sz="1100" dirty="0"/>
                     </a:p>
@@ -22579,7 +22579,7 @@
                             <a:schemeClr val="tx1"/>
                           </a:solidFill>
                         </a:rPr>
-                        <a:t>93</a:t>
+                        <a:t>88</a:t>
                       </a:r>
                       <a:endParaRPr lang="en-US" sz="1100" dirty="0"/>
                     </a:p>
@@ -22637,7 +22637,7 @@
                             <a:schemeClr val="tx1"/>
                           </a:solidFill>
                         </a:rPr>
-                        <a:t>€773</a:t>
+                        <a:t>€1,651</a:t>
                       </a:r>
                       <a:endParaRPr lang="en-US" sz="1100" dirty="0"/>
                     </a:p>
@@ -22697,7 +22697,7 @@
                             <a:schemeClr val="tx1"/>
                           </a:solidFill>
                         </a:rPr>
-                        <a:t>50% · €51.25k</a:t>
+                        <a:t>50% · €103.75k</a:t>
                       </a:r>
                       <a:endParaRPr lang="en-US" sz="1100" dirty="0"/>
                     </a:p>
@@ -22755,7 +22755,7 @@
                             <a:schemeClr val="tx1"/>
                           </a:solidFill>
                         </a:rPr>
-                        <a:t>85</a:t>
+                        <a:t>78</a:t>
                       </a:r>
                       <a:endParaRPr lang="en-US" sz="1100" dirty="0"/>
                     </a:p>
@@ -22813,7 +22813,7 @@
                             <a:schemeClr val="tx1"/>
                           </a:solidFill>
                         </a:rPr>
-                        <a:t>€600</a:t>
+                        <a:t>€1,328</a:t>
                       </a:r>
                       <a:endParaRPr lang="en-US" sz="1100" dirty="0"/>
                     </a:p>
@@ -22964,7 +22964,7 @@
                   <a:schemeClr val="tx1"/>
                 </a:solidFill>
               </a:rPr>
-              <a:t>electricians (23 of 30 at −30%); automation and supervisors lose under 1 hire each (14.7 of 15, 9.8 of 10). Mechatronics never falls short.</a:t>
+              <a:t>at −30%: supervisors 1.6 of 10, electricians 27.1 of 30, automation 14.3 of 15. Mechatronics never falls short.</a:t>
             </a:r>
             <a:endParaRPr lang="en-US" sz="1200" dirty="0"/>
           </a:p>
@@ -22995,7 +22995,7 @@
                   <a:schemeClr val="tx1"/>
                 </a:solidFill>
               </a:rPr>
-              <a:t>the last €30.75k buys ~7 hires at ~€4,290 each, mostly electricians, the role that keeps lines running. Keep it. If you must cut, cover supervisors through internal promotion and protect electricians. Above €102.5k, extra money buys at most ~3 more hires (the 9 spare slots); then the 55/week limit binds.</a:t>
+              <a:t>the last €62.25k buys ~12 hires at ~€5,190 each, mostly supervisors. If you must cut, cover supervisors through internal promotion and protect electricians, the role that keeps lines running. Above €207.5k, extra money buys at most ~2 more hires (the 6 spare slots); then the 55/week limit binds.</a:t>
             </a:r>
             <a:endParaRPr lang="en-US" sz="1200" dirty="0"/>
           </a:p>
@@ -23145,7 +23145,7 @@
                 <a:ea typeface="Cambria" pitchFamily="34" charset="-122"/>
                 <a:cs typeface="Cambria" pitchFamily="34" charset="-120"/>
               </a:rPr>
-              <a:t>Three new sources supply ~50 of the 100 hires, one built for electricians</a:t>
+              <a:t>Three new sources supply ~41 of the 100 hires, one built for electricians</a:t>
             </a:r>
             <a:endParaRPr lang="en-US" sz="2200" dirty="0"/>
           </a:p>
@@ -23285,7 +23285,7 @@
                   <a:schemeClr val="tx1"/>
                 </a:solidFill>
               </a:rPr>
-              <a:t>~700 past applicants qualified but not hired; ~1,000 plant technicians as referrers</a:t>
+              <a:t>136 runners-up from the last year (consented talent pool); the plant's 10,703 staff as referrers</a:t>
             </a:r>
             <a:endParaRPr lang="en-US" sz="1200" dirty="0"/>
           </a:p>
@@ -23347,7 +23347,7 @@
                   <a:schemeClr val="tx1"/>
                 </a:solidFill>
               </a:rPr>
-              <a:t>Already screened (50% qualified, my estimate), already wanted Tesla, ~€3 per application</a:t>
+              <a:t>Already screened (50% still qualified, below the 70% skills match Forrester reports), already wanted Tesla, ~€3 per application</a:t>
             </a:r>
             <a:endParaRPr lang="en-US" sz="1200" dirty="0"/>
           </a:p>
@@ -23378,7 +23378,7 @@
                   <a:schemeClr val="tx1"/>
                 </a:solidFill>
               </a:rPr>
-              <a:t>€210 + €6.5k bonuses → 84 re-apps + 43 referrals → ~61 qualified → ~22 hires</a:t>
+              <a:t>€41 + €11.2k bonuses → 16 re-apps + 66 referrals → ~38 qualified → ~14 hires</a:t>
             </a:r>
             <a:endParaRPr lang="en-US" sz="1200" dirty="0"/>
           </a:p>
@@ -23409,7 +23409,7 @@
                   <a:schemeClr val="tx1"/>
                 </a:solidFill>
               </a:rPr>
-              <a:t>Wed 21 Oct – Tue 3 Nov (waves 1–3): €210. Pass: ≥20 qualified (≥⅓ electricians). Kill: &lt;11 → no further re-contacts; bonus stays live</a:t>
+              <a:t>Wed 21 Oct – Tue 3 Nov (waves 1–3): €41. Pass: ≥8 qualified (≥⅓ electricians). Kill: &lt;5 → no further re-contacts; bonus stays live</a:t>
             </a:r>
             <a:endParaRPr lang="en-US" sz="1200" dirty="0"/>
           </a:p>
@@ -23673,7 +23673,7 @@
                   <a:schemeClr val="tx1"/>
                 </a:solidFill>
               </a:rPr>
-              <a:t>250 apps × €84 = €21.0k + €1.2k set-up → 38 qualified × 25% = 9.5 hires (€2,349/hire)</a:t>
+              <a:t>200 apps × €84 = €16.8k + €1.2k set-up → 30 qualified × 28% = 8.5 hires (€2,116/hire)</a:t>
             </a:r>
             <a:endParaRPr lang="en-US" sz="1200" dirty="0"/>
           </a:p>
@@ -23704,7 +23704,7 @@
                   <a:schemeClr val="tx1"/>
                 </a:solidFill>
               </a:rPr>
-              <a:t>Fri 23 Oct – Thu 5 Nov (read Mon 9 Nov): €5.8k. Pass: ≥4 qualified at ≤€700. Kill: &lt;3, &gt;€840 per qualified, or profile rejected; week 4: &lt;40% interview pass</a:t>
+              <a:t>Fri 23 Oct – Thu 5 Nov (read Mon 9 Nov): €6.0k. Pass: ≥5 qualified at ≤€700. Kill: &lt;3, &gt;€840 per qualified, or profile rejected; week 4: &lt;40% interview pass</a:t>
             </a:r>
             <a:endParaRPr lang="en-US" sz="1200" dirty="0"/>
           </a:p>
@@ -23906,7 +23906,7 @@
                   <a:schemeClr val="tx1"/>
                 </a:solidFill>
               </a:rPr>
-              <a:t>Pracuj.pl, OLX Praca and Polish-geo Meta; a remote Polish-speaking freelancer phones each applicant (~15 min, paid hourly)</a:t>
+              <a:t>Pracuj.pl, OLX Praca and Polish-geo Meta; a remote Polish-speaking freelancer phones each applicant (15 min, low end of Indeed’s 15–30 min range)</a:t>
             </a:r>
             <a:endParaRPr lang="en-US" sz="1200" dirty="0"/>
           </a:p>
@@ -23937,7 +23937,7 @@
                   <a:schemeClr val="tx1"/>
                 </a:solidFill>
               </a:rPr>
-              <a:t>Polish job seekers mostly use Polish boards (my estimate); the pre-screen saves your 55 slots</a:t>
+              <a:t>Pracuj.pl is Poland's largest job board (762,827 offers in 2025); ~2,000 Polish trade workers already commute to Brandenburg</a:t>
             </a:r>
             <a:endParaRPr lang="en-US" sz="1200" dirty="0"/>
           </a:p>
@@ -23968,7 +23968,7 @@
                   <a:schemeClr val="tx1"/>
                 </a:solidFill>
               </a:rPr>
-              <a:t>200 apps × €20.25 + €400 → 44 qualified × 41% = 18.0 hires (40% of mech, cap 40%)</a:t>
+              <a:t>346 apps × €18.75 + €400 → 48 qualified × 37% = 18.0 hires (40% of mech, cap 40%)</a:t>
             </a:r>
             <a:endParaRPr lang="en-US" sz="1200" dirty="0"/>
           </a:p>
@@ -23999,7 +23999,7 @@
                   <a:schemeClr val="tx1"/>
                 </a:solidFill>
               </a:rPr>
-              <a:t>Tue 27 Oct – Mon 9 Nov (freelancer starts 27 Oct): €1.5k. Pass: ≥7 qualified at ≤€120. Kill: &lt;4, &gt;€140 per qualified, or &lt;30% pass the language check</a:t>
+              <a:t>Tue 27 Oct – Mon 9 Nov (freelancer starts 27 Oct): €2.5k. Pass: ≥9 qualified at ≤€170. Kill: &lt;5, &gt;€200 per qualified, or &lt;30% pass the language check</a:t>
             </a:r>
             <a:endParaRPr lang="en-US" sz="1200" dirty="0"/>
           </a:p>
@@ -24030,7 +24030,7 @@
                   <a:schemeClr val="tx1"/>
                 </a:solidFill>
               </a:rPr>
-              <a:t>Me: ads on day 3, contract the freelancer (live 27 Oct), script and scorecard, daily call 09:00 German time. Client: approve PL ads</a:t>
+              <a:t>Me: ads on day 3, contract the freelancer (live 27 Oct), script and scorecard. Client: approve PL ads</a:t>
             </a:r>
             <a:endParaRPr lang="en-US" sz="1200" dirty="0"/>
           </a:p>
@@ -24077,7 +24077,7 @@
                   <a:schemeClr val="tx1"/>
                 </a:solidFill>
               </a:rPr>
-              <a:t>Every large employer holds thousands of previously screened candidates who are rarely re-marketed to. Here they cost ~€13 per hire and fill week-1 slots before paid channels warm up. Joveo already matches jobs to supply programmatically. Adding a consented rediscovery source, tracked to hire with the same source tags, is repeatable in any market without local staff.</a:t>
+              <a:t>Every employer may keep consenting runners-up for up to a year, and they are rarely re-marketed to. Here 136 records cost ~€13 per hire and fill week-1 slots before paid channels warm up. Joveo already matches jobs to supply programmatically. Adding a consented rediscovery source, tracked to hire with the same source tags, is repeatable in any market without local staff.</a:t>
             </a:r>
             <a:endParaRPr lang="en-US" sz="1200" dirty="0"/>
           </a:p>
@@ -24473,7 +24473,7 @@
                   <a:schemeClr val="tx1"/>
                 </a:solidFill>
               </a:rPr>
-              <a:t>No judgement before €500 / 30 apps (tests run to €750). Updated Q = (qual + 30 × plan) ÷ (apps + 30). Cost per qualified ≤0.8× plan with free slots → +25%/wk from reserve; ≥1.5× → cut 50%; ≥2× → off. Zero qualified at €750 → off where ≥2 were expected; low-yield cells → off if applications are &lt;50% of plan. Next week forecast &gt;55 qualified → pause the costliest cells; &lt;45 → release reserve.</a:t>
+              <a:t>No judgement before €500 / 30 apps (tests run to €750). Updated Q = (qual + 30 × plan) ÷ (apps + 30). Cost per qualified ≤0.8× plan with free slots → +25%/wk from reserve; ≥1.5× → cut 50%; ≥2× → off. Zero qualified at €750 → off where ≥3 were expected; low-yield cells → off if applications are &lt;50% of plan. Next week forecast &gt;55 qualified → pause the costliest cells; &lt;45 → release reserve.</a:t>
             </a:r>
             <a:endParaRPr lang="en-US" sz="1250" dirty="0"/>
           </a:p>
@@ -24596,7 +24596,7 @@
                   <a:schemeClr val="tx1"/>
                 </a:solidFill>
               </a:rPr>
-              <a:t>1) Pass rate on the week-1 cohort (interviews 29 Oct–2 Nov), the most sensitive input: if &lt;45% → tighter knock-outs, pre-screen calls, ask +10 slots, re-run the model. 2) Electrician supply: profile decision + I2's two-week read on 9 Nov; if killed → more StepStone ads, then Search and programmatic; expect ~25–27 electricians (my judgement: capacity allows 30, but slower and at €1,022–€3,788 per hire). 3) The 12 tests' cost per application and share qualified → re-rank on Assumptions §7. Week 4 (16 Nov): acceptance &lt;55% → earlier cut-off + signing bonus.</a:t>
+              <a:t>1) Pass rate on the week-1 cohort (interviews 29 Oct–2 Nov), the most sensitive input: if &lt;45% → tighter knock-outs, pre-screen calls, ask +10 slots, re-run the model. 2) Electrician supply: profile decision + I2's two-week read on 9 Nov; if killed → programmatic picks up the gap: all 30 still possible (model run with I2 off), budget €225.0k, electricians at €2,829 per hire. 3) The 12 tests' cost per application and share qualified → re-rank on Assumptions §7. Week 4 (16 Nov): acceptance &lt;55% → earlier cut-off + signing bonus.</a:t>
             </a:r>
             <a:endParaRPr lang="en-US" sz="1250" dirty="0"/>
           </a:p>

</xml_diff>

<commit_message>
All inputs sourced or derived; Tracker rule test covers R6 again; refresh report, note and preview
Co-Authored-By: Claude Opus 5.5 <noreply@anthropic.com>
Claude-Session: https://claude.ai/code/session_01V2NJtrYy3bzNxqKeiRXJfY
</commit_message>
<xml_diff>
--- a/operation_uptime/Operation_Uptime_Deck.pptx
+++ b/operation_uptime/Operation_Uptime_Deck.pptx
@@ -114,30 +114,30 @@
   <p:extLst>
     <p:ext uri="{521415D9-36F7-43E2-AB2F-B90AF26B5E84}">
       <p14:sectionLst xmlns:p14="http://schemas.microsoft.com/office/powerpoint/2010/main">
-        <p14:section name="Summary" id="{2bdee562-aee5-03b5-c7ad-e010321f31a4}">
+        <p14:section name="Summary" id="{8220110d-32ec-b84c-cba0-908a4f820703}">
           <p14:sldIdLst>
             <p14:sldId id="256"/>
           </p14:sldIdLst>
         </p14:section>
-        <p14:section name="Part 1 Funnel" id="{b035a81c-5815-6f5a-0b24-58eb45efaff1}">
+        <p14:section name="Part 1 Funnel" id="{4dde818f-132d-0663-5b7d-64d89c0a4d38}">
           <p14:sldIdLst>
             <p14:sldId id="257"/>
             <p14:sldId id="258"/>
           </p14:sldIdLst>
         </p14:section>
-        <p14:section name="Part 2 Channels &amp; budget" id="{5f707b24-326e-ad07-33c7-7985bb7b13ec}">
+        <p14:section name="Part 2 Channels &amp; budget" id="{e8d3f9ae-05c4-e12a-ed89-545b34f8f75b}">
           <p14:sldIdLst>
             <p14:sldId id="259"/>
             <p14:sldId id="260"/>
             <p14:sldId id="261"/>
           </p14:sldIdLst>
         </p14:section>
-        <p14:section name="Part 3 New sources" id="{8711c40d-43b5-81fe-9f67-08f022f71fc8}">
+        <p14:section name="Part 3 New sources" id="{b9cdde3d-29ad-e4a0-8940-38ff90eaded4}">
           <p14:sldIdLst>
             <p14:sldId id="262"/>
           </p14:sldIdLst>
         </p14:section>
-        <p14:section name="Part 4 Run it" id="{e0a91142-f22a-f722-a4c5-f92bd1ad51fd}">
+        <p14:section name="Part 4 Run it" id="{b920e9c4-881e-161d-28d5-ca630ef72700}">
           <p14:sldIdLst>
             <p14:sldId id="263"/>
           </p14:sldIdLst>

</xml_diff>

<commit_message>
Replace remaining chosen thresholds with conventions and data; IAB role shares; BA-based rediscovery pool; full test rerun
Co-Authored-By: Claude Opus 5.5 <noreply@anthropic.com>
Claude-Session: https://claude.ai/code/session_01V2NJtrYy3bzNxqKeiRXJfY
</commit_message>
<xml_diff>
--- a/operation_uptime/Operation_Uptime_Deck.pptx
+++ b/operation_uptime/Operation_Uptime_Deck.pptx
@@ -114,30 +114,30 @@
   <p:extLst>
     <p:ext uri="{521415D9-36F7-43E2-AB2F-B90AF26B5E84}">
       <p14:sectionLst xmlns:p14="http://schemas.microsoft.com/office/powerpoint/2010/main">
-        <p14:section name="Summary" id="{8220110d-32ec-b84c-cba0-908a4f820703}">
+        <p14:section name="Summary" id="{b5206f16-7ef7-5e8f-5b97-a2281e36dda5}">
           <p14:sldIdLst>
             <p14:sldId id="256"/>
           </p14:sldIdLst>
         </p14:section>
-        <p14:section name="Part 1 Funnel" id="{4dde818f-132d-0663-5b7d-64d89c0a4d38}">
+        <p14:section name="Part 1 Funnel" id="{a4a93b05-1ac7-e866-a8e2-08c32e5adc77}">
           <p14:sldIdLst>
             <p14:sldId id="257"/>
             <p14:sldId id="258"/>
           </p14:sldIdLst>
         </p14:section>
-        <p14:section name="Part 2 Channels &amp; budget" id="{e8d3f9ae-05c4-e12a-ed89-545b34f8f75b}">
+        <p14:section name="Part 2 Channels &amp; budget" id="{b95f9b78-760f-da98-8859-d4736eebed2d}">
           <p14:sldIdLst>
             <p14:sldId id="259"/>
             <p14:sldId id="260"/>
             <p14:sldId id="261"/>
           </p14:sldIdLst>
         </p14:section>
-        <p14:section name="Part 3 New sources" id="{b9cdde3d-29ad-e4a0-8940-38ff90eaded4}">
+        <p14:section name="Part 3 New sources" id="{00b2a2b2-5d6b-340f-c280-4390cbd11ada}">
           <p14:sldIdLst>
             <p14:sldId id="262"/>
           </p14:sldIdLst>
         </p14:section>
-        <p14:section name="Part 4 Run it" id="{b920e9c4-881e-161d-28d5-ca630ef72700}">
+        <p14:section name="Part 4 Run it" id="{7779d167-52e6-e63b-e9ed-2e16521153a4}">
           <p14:sldIdLst>
             <p14:sldId id="263"/>
           </p14:sldIdLst>
@@ -275,7 +275,7 @@
                 <c:formatCode>General</c:formatCode>
                 <c:ptCount val="7"/>
                 <c:pt idx="0">
-                  <c:v>38</c:v>
+                  <c:v>39</c:v>
                 </c:pt>
                 <c:pt idx="1">
                   <c:v>54</c:v>
@@ -284,13 +284,13 @@
                   <c:v>54</c:v>
                 </c:pt>
                 <c:pt idx="3">
-                  <c:v>55</c:v>
+                  <c:v>53</c:v>
                 </c:pt>
                 <c:pt idx="4">
-                  <c:v>55</c:v>
+                  <c:v>54</c:v>
                 </c:pt>
                 <c:pt idx="5">
-                  <c:v>53</c:v>
+                  <c:v>54</c:v>
                 </c:pt>
                 <c:pt idx="6">
                   <c:v>0</c:v>
@@ -1107,22 +1107,22 @@
                 <c:formatCode>General</c:formatCode>
                 <c:ptCount val="9"/>
                 <c:pt idx="0">
-                  <c:v>15555</c:v>
+                  <c:v>6808</c:v>
                 </c:pt>
                 <c:pt idx="1">
-                  <c:v>24084</c:v>
+                  <c:v>10925</c:v>
                 </c:pt>
                 <c:pt idx="2">
-                  <c:v>27182</c:v>
+                  <c:v>13546</c:v>
                 </c:pt>
                 <c:pt idx="3">
-                  <c:v>27954</c:v>
+                  <c:v>13539</c:v>
                 </c:pt>
                 <c:pt idx="4">
-                  <c:v>27954</c:v>
+                  <c:v>13915</c:v>
                 </c:pt>
                 <c:pt idx="5">
-                  <c:v>22961</c:v>
+                  <c:v>12822</c:v>
                 </c:pt>
                 <c:pt idx="6">
                   <c:v>0</c:v>
@@ -1226,7 +1226,7 @@
                 <c:formatCode>General</c:formatCode>
                 <c:ptCount val="9"/>
                 <c:pt idx="0">
-                  <c:v>10294</c:v>
+                  <c:v>7396</c:v>
                 </c:pt>
                 <c:pt idx="1">
                   <c:v>0</c:v>
@@ -1354,22 +1354,22 @@
                   <c:v>0</c:v>
                 </c:pt>
                 <c:pt idx="3">
-                  <c:v>1049</c:v>
+                  <c:v>944</c:v>
                 </c:pt>
                 <c:pt idx="4">
-                  <c:v>1720</c:v>
+                  <c:v>1606</c:v>
                 </c:pt>
                 <c:pt idx="5">
-                  <c:v>1981</c:v>
+                  <c:v>2026</c:v>
                 </c:pt>
                 <c:pt idx="6">
-                  <c:v>2052</c:v>
+                  <c:v>2059</c:v>
                 </c:pt>
                 <c:pt idx="7">
-                  <c:v>2057</c:v>
+                  <c:v>2111</c:v>
                 </c:pt>
                 <c:pt idx="8">
-                  <c:v>2371</c:v>
+                  <c:v>2483</c:v>
                 </c:pt>
               </c:numCache>
             </c:numRef>
@@ -1631,16 +1631,16 @@
                 <c:ptCount val="4"/>
                 <c:lvl>
                   <c:pt idx="0">
-                    <c:v>100% · €207.50k</c:v>
+                    <c:v>100% · €117.50k</c:v>
                   </c:pt>
                   <c:pt idx="1">
-                    <c:v>85% · €176.38k</c:v>
+                    <c:v>85% · €99.88k</c:v>
                   </c:pt>
                   <c:pt idx="2">
-                    <c:v>70% · €145.25k</c:v>
+                    <c:v>70% · €82.25k</c:v>
                   </c:pt>
                   <c:pt idx="3">
-                    <c:v>50% · €103.75k</c:v>
+                    <c:v>50% · €58.75k</c:v>
                   </c:pt>
                 </c:lvl>
               </c:multiLvlStrCache>
@@ -1656,13 +1656,13 @@
                   <c:v>30</c:v>
                 </c:pt>
                 <c:pt idx="1">
-                  <c:v>29.9</c:v>
+                  <c:v>25.4</c:v>
                 </c:pt>
                 <c:pt idx="2">
-                  <c:v>27.1</c:v>
+                  <c:v>20.7</c:v>
                 </c:pt>
                 <c:pt idx="3">
-                  <c:v>17.2</c:v>
+                  <c:v>20.7</c:v>
                 </c:pt>
               </c:numCache>
             </c:numRef>
@@ -1721,16 +1721,16 @@
                 <c:ptCount val="4"/>
                 <c:lvl>
                   <c:pt idx="0">
-                    <c:v>100% · €207.50k</c:v>
+                    <c:v>100% · €117.50k</c:v>
                   </c:pt>
                   <c:pt idx="1">
-                    <c:v>85% · €176.38k</c:v>
+                    <c:v>85% · €99.88k</c:v>
                   </c:pt>
                   <c:pt idx="2">
-                    <c:v>70% · €145.25k</c:v>
+                    <c:v>70% · €82.25k</c:v>
                   </c:pt>
                   <c:pt idx="3">
-                    <c:v>50% · €103.75k</c:v>
+                    <c:v>50% · €58.75k</c:v>
                   </c:pt>
                 </c:lvl>
               </c:multiLvlStrCache>
@@ -1746,13 +1746,13 @@
                   <c:v>45</c:v>
                 </c:pt>
                 <c:pt idx="1">
-                  <c:v>45</c:v>
+                  <c:v>44.7</c:v>
                 </c:pt>
                 <c:pt idx="2">
-                  <c:v>45</c:v>
+                  <c:v>44.7</c:v>
                 </c:pt>
                 <c:pt idx="3">
-                  <c:v>45</c:v>
+                  <c:v>38.6</c:v>
                 </c:pt>
               </c:numCache>
             </c:numRef>
@@ -1811,16 +1811,16 @@
                 <c:ptCount val="4"/>
                 <c:lvl>
                   <c:pt idx="0">
-                    <c:v>100% · €207.50k</c:v>
+                    <c:v>100% · €117.50k</c:v>
                   </c:pt>
                   <c:pt idx="1">
-                    <c:v>85% · €176.38k</c:v>
+                    <c:v>85% · €99.88k</c:v>
                   </c:pt>
                   <c:pt idx="2">
-                    <c:v>70% · €145.25k</c:v>
+                    <c:v>70% · €82.25k</c:v>
                   </c:pt>
                   <c:pt idx="3">
-                    <c:v>50% · €103.75k</c:v>
+                    <c:v>50% · €58.75k</c:v>
                   </c:pt>
                 </c:lvl>
               </c:multiLvlStrCache>
@@ -1836,13 +1836,13 @@
                   <c:v>15</c:v>
                 </c:pt>
                 <c:pt idx="1">
-                  <c:v>14.9</c:v>
+                  <c:v>14.5</c:v>
                 </c:pt>
                 <c:pt idx="2">
-                  <c:v>14.3</c:v>
+                  <c:v>14.5</c:v>
                 </c:pt>
                 <c:pt idx="3">
-                  <c:v>14.3</c:v>
+                  <c:v>14.5</c:v>
                 </c:pt>
               </c:numCache>
             </c:numRef>
@@ -1901,16 +1901,16 @@
                 <c:ptCount val="4"/>
                 <c:lvl>
                   <c:pt idx="0">
-                    <c:v>100% · €207.50k</c:v>
+                    <c:v>100% · €117.50k</c:v>
                   </c:pt>
                   <c:pt idx="1">
-                    <c:v>85% · €176.38k</c:v>
+                    <c:v>85% · €99.88k</c:v>
                   </c:pt>
                   <c:pt idx="2">
-                    <c:v>70% · €145.25k</c:v>
+                    <c:v>70% · €82.25k</c:v>
                   </c:pt>
                   <c:pt idx="3">
-                    <c:v>50% · €103.75k</c:v>
+                    <c:v>50% · €58.75k</c:v>
                   </c:pt>
                 </c:lvl>
               </c:multiLvlStrCache>
@@ -1926,13 +1926,13 @@
                   <c:v>10</c:v>
                 </c:pt>
                 <c:pt idx="1">
-                  <c:v>4.6</c:v>
+                  <c:v>9.6</c:v>
                 </c:pt>
                 <c:pt idx="2">
-                  <c:v>1.6</c:v>
+                  <c:v>7</c:v>
                 </c:pt>
                 <c:pt idx="3">
-                  <c:v>1.6</c:v>
+                  <c:v>2.4</c:v>
                 </c:pt>
               </c:numCache>
             </c:numRef>
@@ -3760,7 +3760,7 @@
                 <a:ea typeface="Cambria" pitchFamily="34" charset="-122"/>
                 <a:cs typeface="Cambria" pitchFamily="34" charset="-120"/>
               </a:rPr>
-              <a:t>€207.5k signs 100 maintenance hires by 31 Dec if the 55 weekly assessments hold</a:t>
+              <a:t>€117.5k signs 100 maintenance hires by 31 Dec if the 55 weekly assessments hold</a:t>
             </a:r>
             <a:endParaRPr lang="en-US" sz="2200" dirty="0"/>
           </a:p>
@@ -3826,7 +3826,7 @@
                 <a:ea typeface="Cambria" pitchFamily="34" charset="-122"/>
                 <a:cs typeface="Cambria" pitchFamily="34" charset="-120"/>
               </a:rPr>
-              <a:t>€207.5k</a:t>
+              <a:t>€117.5k</a:t>
             </a:r>
             <a:endParaRPr lang="en-US" sz="2600" dirty="0"/>
           </a:p>
@@ -3862,7 +3862,7 @@
                   <a:schemeClr val="tx2"/>
                 </a:solidFill>
               </a:rPr>
-              <a:t>recommended budget: €176.2k planned + €31.3k reserve released only on results</a:t>
+              <a:t>recommended budget: €99.2k planned + €18.3k reserve released only on results</a:t>
             </a:r>
             <a:endParaRPr lang="en-US" sz="1000" dirty="0"/>
           </a:p>
@@ -3928,7 +3928,7 @@
                 <a:ea typeface="Cambria" pitchFamily="34" charset="-122"/>
                 <a:cs typeface="Cambria" pitchFamily="34" charset="-120"/>
               </a:rPr>
-              <a:t>€1,762</a:t>
+              <a:t>€992</a:t>
             </a:r>
             <a:endParaRPr lang="en-US" sz="2600" dirty="0"/>
           </a:p>
@@ -3964,7 +3964,7 @@
                   <a:schemeClr val="tx2"/>
                 </a:solidFill>
               </a:rPr>
-              <a:t>media cost per hire (≤€2,075 if the reserve is spent); excludes Joveo fees</a:t>
+              <a:t>media cost per hire (≤€1,175 if the reserve is spent); excludes Joveo fees</a:t>
             </a:r>
             <a:endParaRPr lang="en-US" sz="1000" dirty="0"/>
           </a:p>
@@ -4066,7 +4066,7 @@
                   <a:schemeClr val="tx2"/>
                 </a:solidFill>
               </a:rPr>
-              <a:t>of 314 assessment slots used (309 qualified). Capacity, not money, is the limit</a:t>
+              <a:t>of 314 assessment slots used (308 qualified). Capacity, not money, is the limit</a:t>
             </a:r>
             <a:endParaRPr lang="en-US" sz="1000" dirty="0"/>
           </a:p>
@@ -4237,7 +4237,7 @@
                   <a:schemeClr val="tx1"/>
                 </a:solidFill>
               </a:rPr>
-              <a:t>(€145.25k): ~88 hires; supervisors fall short first (1.6 of 10).</a:t>
+              <a:t>(€82.25k): ~87 hires; electricians fall short first (20.7 of 30).</a:t>
             </a:r>
             <a:endParaRPr lang="en-US" sz="1100" dirty="0"/>
           </a:p>
@@ -4762,7 +4762,7 @@
                           <a:ea typeface="Calibri" pitchFamily="34" charset="-122"/>
                           <a:cs typeface="Calibri" pitchFamily="34" charset="-120"/>
                         </a:rPr>
-                        <a:t>€70.7k</a:t>
+                        <a:t>€37.9k</a:t>
                       </a:r>
                       <a:endParaRPr lang="en-US" sz="1000" dirty="0">
                         <a:latin typeface="Calibri" charset="0"/>
@@ -4827,7 +4827,7 @@
                           <a:ea typeface="Calibri" pitchFamily="34" charset="-122"/>
                           <a:cs typeface="Calibri" pitchFamily="34" charset="-120"/>
                         </a:rPr>
-                        <a:t>€2,356</a:t>
+                        <a:t>€1,264</a:t>
                       </a:r>
                       <a:endParaRPr lang="en-US" sz="1000" dirty="0">
                         <a:latin typeface="Calibri" charset="0"/>
@@ -4892,7 +4892,7 @@
                           <a:ea typeface="Calibri" pitchFamily="34" charset="-122"/>
                           <a:cs typeface="Calibri" pitchFamily="34" charset="-120"/>
                         </a:rPr>
-                        <a:t>Meta 9.5 · Handwerk→Industrie 8.5 · organic 3.5 · referrals 3.3 · programmatic 3.2 · other 2.1</a:t>
+                        <a:t>Handwerk→Industrie 8.5 · Meta 6.3 · organic 5.9 · referrals 3.3 · programmatic 2.8 · other 3.3</a:t>
                       </a:r>
                       <a:endParaRPr lang="en-US" sz="900" dirty="0">
                         <a:latin typeface="Calibri" charset="0"/>
@@ -5089,7 +5089,7 @@
                           <a:ea typeface="Calibri" pitchFamily="34" charset="-122"/>
                           <a:cs typeface="Calibri" pitchFamily="34" charset="-120"/>
                         </a:rPr>
-                        <a:t>€33.9k</a:t>
+                        <a:t>€27.4k</a:t>
                       </a:r>
                       <a:endParaRPr lang="en-US" sz="1000" dirty="0">
                         <a:latin typeface="Calibri" charset="0"/>
@@ -5154,7 +5154,7 @@
                           <a:ea typeface="Calibri" pitchFamily="34" charset="-122"/>
                           <a:cs typeface="Calibri" pitchFamily="34" charset="-120"/>
                         </a:rPr>
-                        <a:t>€752</a:t>
+                        <a:t>€610</a:t>
                       </a:r>
                       <a:endParaRPr lang="en-US" sz="1000" dirty="0">
                         <a:latin typeface="Calibri" charset="0"/>
@@ -5219,7 +5219,7 @@
                           <a:ea typeface="Calibri" pitchFamily="34" charset="-122"/>
                           <a:cs typeface="Calibri" pitchFamily="34" charset="-120"/>
                         </a:rPr>
-                        <a:t>Polish corridor 18.0 · organic 9.2 · Meta 8.2 · referrals 5.8 · StepStone 1.8 · other 2.1</a:t>
+                        <a:t>Polish corridor 18.0 · organic 10.4 · referrals 5.8 · Meta 5.7 · rediscovery 2.4 · other 2.7</a:t>
                       </a:r>
                       <a:endParaRPr lang="en-US" sz="900" dirty="0">
                         <a:latin typeface="Calibri" charset="0"/>
@@ -5416,7 +5416,7 @@
                           <a:ea typeface="Calibri" pitchFamily="34" charset="-122"/>
                           <a:cs typeface="Calibri" pitchFamily="34" charset="-120"/>
                         </a:rPr>
-                        <a:t>€32.4k</a:t>
+                        <a:t>€17.6k</a:t>
                       </a:r>
                       <a:endParaRPr lang="en-US" sz="1000" dirty="0">
                         <a:latin typeface="Calibri" charset="0"/>
@@ -5481,7 +5481,7 @@
                           <a:ea typeface="Calibri" pitchFamily="34" charset="-122"/>
                           <a:cs typeface="Calibri" pitchFamily="34" charset="-120"/>
                         </a:rPr>
-                        <a:t>€2,158</a:t>
+                        <a:t>€1,175</a:t>
                       </a:r>
                       <a:endParaRPr lang="en-US" sz="1000" dirty="0">
                         <a:latin typeface="Calibri" charset="0"/>
@@ -5546,7 +5546,7 @@
                           <a:ea typeface="Calibri" pitchFamily="34" charset="-122"/>
                           <a:cs typeface="Calibri" pitchFamily="34" charset="-120"/>
                         </a:rPr>
-                        <a:t>LinkedIn 10.0 · organic 1.6 · referrals 1.5 · StepStone 0.9 · programmatic 0.5 · other 0.5</a:t>
+                        <a:t>LinkedIn 9.7 · organic 2.7 · referrals 1.5 · rediscovery 0.6 · tests 0.5</a:t>
                       </a:r>
                       <a:endParaRPr lang="en-US" sz="900" dirty="0">
                         <a:latin typeface="Calibri" charset="0"/>
@@ -5743,7 +5743,7 @@
                           <a:ea typeface="Calibri" pitchFamily="34" charset="-122"/>
                           <a:cs typeface="Calibri" pitchFamily="34" charset="-120"/>
                         </a:rPr>
-                        <a:t>€39.3k</a:t>
+                        <a:t>€16.2k</a:t>
                       </a:r>
                       <a:endParaRPr lang="en-US" sz="1000" dirty="0">
                         <a:latin typeface="Calibri" charset="0"/>
@@ -5808,7 +5808,7 @@
                           <a:ea typeface="Calibri" pitchFamily="34" charset="-122"/>
                           <a:cs typeface="Calibri" pitchFamily="34" charset="-120"/>
                         </a:rPr>
-                        <a:t>€3,930</a:t>
+                        <a:t>€1,620</a:t>
                       </a:r>
                       <a:endParaRPr lang="en-US" sz="1000" dirty="0">
                         <a:latin typeface="Calibri" charset="0"/>
@@ -5873,7 +5873,7 @@
                           <a:ea typeface="Calibri" pitchFamily="34" charset="-122"/>
                           <a:cs typeface="Calibri" pitchFamily="34" charset="-120"/>
                         </a:rPr>
-                        <a:t>LinkedIn 8.3 · referrals 0.7 · organic 0.6 · rediscovery 0.2 · tests 0.2</a:t>
+                        <a:t>LinkedIn 7.2 · organic 1.4 · referrals 0.7 · tests 0.4 · rediscovery 0.3</a:t>
                       </a:r>
                       <a:endParaRPr lang="en-US" sz="900" dirty="0">
                         <a:latin typeface="Calibri" charset="0"/>
@@ -6070,7 +6070,7 @@
                           <a:ea typeface="Calibri" pitchFamily="34" charset="-122"/>
                           <a:cs typeface="Calibri" pitchFamily="34" charset="-120"/>
                         </a:rPr>
-                        <a:t>€176.2k</a:t>
+                        <a:t>€99.2k</a:t>
                       </a:r>
                       <a:endParaRPr lang="en-US" sz="1000" dirty="0">
                         <a:latin typeface="Calibri" charset="0"/>
@@ -6135,7 +6135,7 @@
                           <a:ea typeface="Calibri" pitchFamily="34" charset="-122"/>
                           <a:cs typeface="Calibri" pitchFamily="34" charset="-120"/>
                         </a:rPr>
-                        <a:t>€1,762</a:t>
+                        <a:t>€992</a:t>
                       </a:r>
                       <a:endParaRPr lang="en-US" sz="1000" dirty="0">
                         <a:latin typeface="Calibri" charset="0"/>
@@ -6200,7 +6200,7 @@
                           <a:ea typeface="Calibri" pitchFamily="34" charset="-122"/>
                           <a:cs typeface="Calibri" pitchFamily="34" charset="-120"/>
                         </a:rPr>
-                        <a:t>+ €31.3k reserve = €207.5k</a:t>
+                        <a:t>+ €18.3k reserve = €117.5k</a:t>
                       </a:r>
                       <a:endParaRPr lang="en-US" sz="900" dirty="0">
                         <a:latin typeface="Calibri" charset="0"/>
@@ -6294,7 +6294,7 @@
                   <a:schemeClr val="tx1"/>
                 </a:solidFill>
               </a:rPr>
-              <a:t>€750 test in every paid CPC/CPA cell in weeks 1–2, then buy hires cheapest-first: free channels → ATS rediscovery → Polish corridor (≤40% of mechatronics) → referrals → construction-electrician campaign → StepStone → Meta → LinkedIn → programmatic. Pace ≤55 qualified a week; paid spend stops Tue 24 Nov.</a:t>
+              <a:t>€750 test in every paid CPC/CPA cell in weeks 1–2, then buy hires cheapest-first: free channels → ATS rediscovery → Polish corridor (≤40% of mechatronics) → referrals → construction-electrician campaign → StepStone → LinkedIn → Meta → programmatic. Pace ≤55 qualified a week; paid spend stops Tue 24 Nov.</a:t>
             </a:r>
             <a:endParaRPr lang="en-US" sz="1100" dirty="0"/>
           </a:p>
@@ -6434,7 +6434,7 @@
                   <a:schemeClr val="tx1"/>
                 </a:solidFill>
               </a:rPr>
-              <a:t>98% used. Pre-screened sources first, pace ≤55/wk, ask +10–15 slots (65/wk → 81% use).</a:t>
+              <a:t>98% used. Pre-screened sources first, pace ≤55/wk, ask +9 slots/wk (64/wk → 85% use, the utilisation standard).</a:t>
             </a:r>
             <a:endParaRPr lang="en-US" sz="1100" dirty="0"/>
           </a:p>
@@ -6465,7 +6465,7 @@
                   <a:schemeClr val="tx1"/>
                 </a:solidFill>
               </a:rPr>
-              <a:t>~9 of 30 need your OK on construction electricians by 23 Oct; without them programmatic ads fill the gap and the budget rises to €225.0k.</a:t>
+              <a:t>~9 of 30 need your OK on construction electricians by 23 Oct; without them programmatic ads fill the gap and the budget rises to €127.5k.</a:t>
             </a:r>
             <a:endParaRPr lang="en-US" sz="1100" dirty="0"/>
           </a:p>
@@ -6623,7 +6623,7 @@
                   <a:schemeClr val="tx1"/>
                 </a:solidFill>
               </a:rPr>
-              <a:t>55 assessments/wk 22 Oct–1 Dec (+10–15 if possible)</a:t>
+              <a:t>55 assessments/wk 22 Oct–30 Nov (+9 to reach 85% use)</a:t>
             </a:r>
             <a:endParaRPr lang="en-US" sz="1100" dirty="0"/>
           </a:p>
@@ -6695,7 +6695,7 @@
                   <a:schemeClr val="tx1"/>
                 </a:solidFill>
               </a:rPr>
-              <a:t>3-day offers, e-signature to 18 Dec; approve €207.5k</a:t>
+              <a:t>3-day offers, e-signature to 18 Dec; approve €117.5k</a:t>
             </a:r>
             <a:endParaRPr lang="en-US" sz="1100" dirty="0"/>
           </a:p>
@@ -6845,7 +6845,7 @@
                 <a:ea typeface="Cambria" pitchFamily="34" charset="-122"/>
                 <a:cs typeface="Cambria" pitchFamily="34" charset="-120"/>
               </a:rPr>
-              <a:t>Working back from 100 hires: ~309 qualified applicants for 314 assessment slots</a:t>
+              <a:t>Working back from 100 hires: ~308 qualified applicants for 314 assessment slots</a:t>
             </a:r>
             <a:endParaRPr lang="en-US" sz="2200" dirty="0"/>
           </a:p>
@@ -7566,7 +7566,7 @@
                             <a:schemeClr val="tx1"/>
                           </a:solidFill>
                         </a:rPr>
-                        <a:t>15%</a:t>
+                        <a:t>25%</a:t>
                       </a:r>
                       <a:endParaRPr lang="en-US" sz="1100" dirty="0"/>
                     </a:p>
@@ -7914,7 +7914,7 @@
                             <a:schemeClr val="tx1"/>
                           </a:solidFill>
                         </a:rPr>
-                        <a:t>635</a:t>
+                        <a:t>381</a:t>
                       </a:r>
                       <a:endParaRPr lang="en-US" sz="1100" dirty="0"/>
                     </a:p>
@@ -8090,7 +8090,7 @@
                             <a:schemeClr val="tx1"/>
                           </a:solidFill>
                         </a:rPr>
-                        <a:t>22%</a:t>
+                        <a:t>25%</a:t>
                       </a:r>
                       <a:endParaRPr lang="en-US" sz="1100" dirty="0"/>
                     </a:p>
@@ -8438,7 +8438,7 @@
                             <a:schemeClr val="tx1"/>
                           </a:solidFill>
                         </a:rPr>
-                        <a:t>551</a:t>
+                        <a:t>485</a:t>
                       </a:r>
                       <a:endParaRPr lang="en-US" sz="1100" dirty="0"/>
                     </a:p>
@@ -8614,7 +8614,7 @@
                             <a:schemeClr val="tx1"/>
                           </a:solidFill>
                         </a:rPr>
-                        <a:t>15%</a:t>
+                        <a:t>25%</a:t>
                       </a:r>
                       <a:endParaRPr lang="en-US" sz="1100" dirty="0"/>
                     </a:p>
@@ -8962,7 +8962,7 @@
                             <a:schemeClr val="tx1"/>
                           </a:solidFill>
                         </a:rPr>
-                        <a:t>353</a:t>
+                        <a:t>212</a:t>
                       </a:r>
                       <a:endParaRPr lang="en-US" sz="1100" dirty="0"/>
                     </a:p>
@@ -9138,7 +9138,7 @@
                             <a:schemeClr val="tx1"/>
                           </a:solidFill>
                         </a:rPr>
-                        <a:t>10%</a:t>
+                        <a:t>23%</a:t>
                       </a:r>
                       <a:endParaRPr lang="en-US" sz="1100" dirty="0"/>
                     </a:p>
@@ -9486,7 +9486,7 @@
                             <a:schemeClr val="tx1"/>
                           </a:solidFill>
                         </a:rPr>
-                        <a:t>420</a:t>
+                        <a:t>183</a:t>
                       </a:r>
                       <a:endParaRPr lang="en-US" sz="1100" dirty="0"/>
                     </a:p>
@@ -9978,7 +9978,7 @@
                             <a:schemeClr val="tx1"/>
                           </a:solidFill>
                         </a:rPr>
-                        <a:t>1,959</a:t>
+                        <a:t>1,260</a:t>
                       </a:r>
                       <a:endParaRPr lang="en-US" sz="1100" dirty="0"/>
                     </a:p>
@@ -10079,7 +10079,7 @@
                   <a:schemeClr val="tx1"/>
                 </a:solidFill>
               </a:rPr>
-              <a:t>309 qualified / 2,413 applications</a:t>
+              <a:t>308 qualified / 1,608 applications</a:t>
             </a:r>
             <a:pPr indent="0" marL="0">
               <a:buNone/>
@@ -10189,7 +10189,7 @@
                   <a:schemeClr val="tx2"/>
                 </a:solidFill>
               </a:rPr>
-              <a:t>Week 1: 38 of 39 slots; weeks 2–5: 54–55 of 55; week 6: 53; assessments end Mon 30 Nov. Rediscovery re-applicants (waves 21 Oct, 26 Oct and 2 Nov) and the €750 tests fill weeks 1–2, so regular spend ramps 10%, 16%, 18%, then 18–21% a week.</a:t>
+              <a:t>Week 1: 39 of 39 slots; weeks 2–5: 53–54 of 55; week 6: 54; assessments end Mon 30 Nov. Rediscovery re-applicants (waves 21 Oct, 26 Oct and 2 Nov) and the €750 tests fill weeks 1–2, so regular spend ramps 9%, 14%, 18%, then 18–22% a week.</a:t>
             </a:r>
             <a:endParaRPr lang="en-US" sz="1100" dirty="0"/>
           </a:p>
@@ -11166,7 +11166,7 @@
                             <a:schemeClr val="tx1"/>
                           </a:solidFill>
                         </a:rPr>
-                        <a:t>12.2×</a:t>
+                        <a:t>12.3×</a:t>
                       </a:r>
                       <a:endParaRPr lang="en-US" sz="1100" dirty="0"/>
                     </a:p>
@@ -11224,7 +11224,7 @@
                             <a:schemeClr val="tx1"/>
                           </a:solidFill>
                         </a:rPr>
-                        <a:t>12.2×</a:t>
+                        <a:t>12.3×</a:t>
                       </a:r>
                       <a:endParaRPr lang="en-US" sz="1100" dirty="0"/>
                     </a:p>
@@ -11516,7 +11516,7 @@
                             <a:schemeClr val="tx1"/>
                           </a:solidFill>
                         </a:rPr>
-                        <a:t>3.0×</a:t>
+                        <a:t>3.2×</a:t>
                       </a:r>
                       <a:endParaRPr lang="en-US" sz="1100" dirty="0"/>
                     </a:p>
@@ -11574,7 +11574,7 @@
                             <a:schemeClr val="tx1"/>
                           </a:solidFill>
                         </a:rPr>
-                        <a:t>3.0×</a:t>
+                        <a:t>3.2×</a:t>
                       </a:r>
                       <a:endParaRPr lang="en-US" sz="1100" dirty="0"/>
                     </a:p>
@@ -11866,7 +11866,7 @@
                             <a:schemeClr val="tx1"/>
                           </a:solidFill>
                         </a:rPr>
-                        <a:t>3.8×</a:t>
+                        <a:t>3.9×</a:t>
                       </a:r>
                       <a:endParaRPr lang="en-US" sz="1100" dirty="0"/>
                     </a:p>
@@ -11924,7 +11924,7 @@
                             <a:schemeClr val="tx1"/>
                           </a:solidFill>
                         </a:rPr>
-                        <a:t>3.8×</a:t>
+                        <a:t>3.9×</a:t>
                       </a:r>
                       <a:endParaRPr lang="en-US" sz="1100" dirty="0"/>
                     </a:p>
@@ -12188,7 +12188,7 @@
                   <a:schemeClr val="tx1"/>
                 </a:solidFill>
               </a:rPr>
-              <a:t>the scarcest trade in Brandenburg (KOFA 2026: 85.7% of vacancies have no suitable unemployed candidate, vs 41.4% across all occupations) and the largest scarce block (30), so they take 40% of the money. No Polish route and no foreign-trained route by 31 Dec. Supervisors cost more per hire and automation has thinner coverage, but they are 10 and 15 hires with fallbacks (internal promotion, foreign-trained).</a:t>
+              <a:t>the scarcest trade in Brandenburg (KOFA 2026: 85.7% of vacancies have no suitable unemployed candidate, vs 41.4% across all occupations) and the largest scarce block (30), so they take 38% of the money. No Polish route and no foreign-trained route by 31 Dec. Supervisors cost more per hire and automation has thinner coverage, but they are 10 and 15 hires with fallbacks (internal promotion, foreign-trained).</a:t>
             </a:r>
             <a:endParaRPr lang="en-US" sz="1200" dirty="0"/>
           </a:p>
@@ -12235,7 +12235,7 @@
                   <a:schemeClr val="tx1"/>
                 </a:solidFill>
               </a:rPr>
-              <a:t>30% worse pass or acceptance rates need 441 qualified for 314 slots (140%). The 43% more media that would need can't help: slots cap hires at ~71. Upstream misses (share qualified, cost per application) only cost money.</a:t>
+              <a:t>30% worse pass or acceptance rates need 440 qualified for 314 slots (140%). The 43% more media that would need can't help: slots cap hires at ~71. Upstream misses (share qualified, cost per application) only cost money.</a:t>
             </a:r>
             <a:endParaRPr lang="en-US" sz="1200" dirty="0"/>
           </a:p>
@@ -12542,7 +12542,7 @@
                             <a:schemeClr val="tx1"/>
                           </a:solidFill>
                         </a:rPr>
-                        <a:t>441</a:t>
+                        <a:t>440</a:t>
                       </a:r>
                       <a:endParaRPr lang="en-US" sz="1000" dirty="0"/>
                     </a:p>
@@ -12718,7 +12718,7 @@
                             <a:schemeClr val="tx1"/>
                           </a:solidFill>
                         </a:rPr>
-                        <a:t>441</a:t>
+                        <a:t>440</a:t>
                       </a:r>
                       <a:endParaRPr lang="en-US" sz="1000" dirty="0"/>
                     </a:p>
@@ -12894,7 +12894,7 @@
                             <a:schemeClr val="tx1"/>
                           </a:solidFill>
                         </a:rPr>
-                        <a:t>309</a:t>
+                        <a:t>308</a:t>
                       </a:r>
                       <a:endParaRPr lang="en-US" sz="1000" dirty="0"/>
                     </a:p>
@@ -13070,7 +13070,7 @@
                             <a:schemeClr val="tx1"/>
                           </a:solidFill>
                         </a:rPr>
-                        <a:t>309</a:t>
+                        <a:t>308</a:t>
                       </a:r>
                       <a:endParaRPr lang="en-US" sz="1000" dirty="0"/>
                     </a:p>
@@ -13246,7 +13246,7 @@
                             <a:schemeClr val="tx1"/>
                           </a:solidFill>
                         </a:rPr>
-                        <a:t>309</a:t>
+                        <a:t>308</a:t>
                       </a:r>
                       <a:endParaRPr lang="en-US" sz="1000" dirty="0"/>
                     </a:p>
@@ -13497,7 +13497,7 @@
                 <a:ea typeface="Cambria" pitchFamily="34" charset="-122"/>
                 <a:cs typeface="Cambria" pitchFamily="34" charset="-120"/>
               </a:rPr>
-              <a:t>Each role buys hires cheapest-first; electricians run out of cheap sources after ~4</a:t>
+              <a:t>Each role buys hires cheapest-first; electricians run out of cheap sources after ~7</a:t>
             </a:r>
             <a:endParaRPr lang="en-US" sz="2200" dirty="0"/>
           </a:p>
@@ -13912,7 +13912,7 @@
                             <a:schemeClr val="tx1"/>
                           </a:solidFill>
                         </a:rPr>
-                        <a:t>€0 / €0 · 3.5</a:t>
+                        <a:t>€0 / €0 · 5.9</a:t>
                       </a:r>
                       <a:endParaRPr lang="en-US" sz="1000" dirty="0"/>
                     </a:p>
@@ -13973,7 +13973,7 @@
                             <a:schemeClr val="tx1"/>
                           </a:solidFill>
                         </a:rPr>
-                        <a:t>€0 / €0 · 9.2</a:t>
+                        <a:t>€0 / €0 · 10.4</a:t>
                       </a:r>
                       <a:endParaRPr lang="en-US" sz="1000" dirty="0"/>
                     </a:p>
@@ -14034,7 +14034,7 @@
                             <a:schemeClr val="tx1"/>
                           </a:solidFill>
                         </a:rPr>
-                        <a:t>€0 / €0 · 1.6</a:t>
+                        <a:t>€0 / €0 · 2.7</a:t>
                       </a:r>
                       <a:endParaRPr lang="en-US" sz="1000" dirty="0"/>
                     </a:p>
@@ -14095,7 +14095,7 @@
                             <a:schemeClr val="tx1"/>
                           </a:solidFill>
                         </a:rPr>
-                        <a:t>€0 / €0 · 0.6</a:t>
+                        <a:t>€0 / €0 · 1.4</a:t>
                       </a:r>
                       <a:endParaRPr lang="en-US" sz="1000" dirty="0"/>
                     </a:p>
@@ -14216,7 +14216,7 @@
                             <a:schemeClr val="tx1"/>
                           </a:solidFill>
                         </a:rPr>
-                        <a:t>€5 / €14 · 0.9</a:t>
+                        <a:t>€5 / €14 · 1.4</a:t>
                       </a:r>
                       <a:endParaRPr lang="en-US" sz="1000" dirty="0"/>
                     </a:p>
@@ -14277,7 +14277,7 @@
                             <a:schemeClr val="tx1"/>
                           </a:solidFill>
                         </a:rPr>
-                        <a:t>€5 / €12 · 1.6</a:t>
+                        <a:t>€5 / €12 · 2.4</a:t>
                       </a:r>
                       <a:endParaRPr lang="en-US" sz="1000" dirty="0"/>
                     </a:p>
@@ -14338,7 +14338,7 @@
                             <a:schemeClr val="tx1"/>
                           </a:solidFill>
                         </a:rPr>
-                        <a:t>€5 / €15 · 0.4</a:t>
+                        <a:t>€5 / €15 · 0.6</a:t>
                       </a:r>
                       <a:endParaRPr lang="en-US" sz="1000" dirty="0"/>
                     </a:p>
@@ -14399,7 +14399,7 @@
                             <a:schemeClr val="tx1"/>
                           </a:solidFill>
                         </a:rPr>
-                        <a:t>€5 / €18 · 0.2</a:t>
+                        <a:t>€5 / €18 · 0.3</a:t>
                       </a:r>
                       <a:endParaRPr lang="en-US" sz="1000" dirty="0"/>
                     </a:p>
@@ -15061,7 +15061,7 @@
                             <a:schemeClr val="tx1"/>
                           </a:solidFill>
                         </a:rPr>
-                        <a:t>StepStone (German, CV-based, €1,449/ad)</a:t>
+                        <a:t>I2 Handwerk → Industrie (new pool)</a:t>
                       </a:r>
                       <a:endParaRPr lang="en-US" sz="1000" dirty="0"/>
                     </a:p>
@@ -15119,7 +15119,7 @@
                             <a:schemeClr val="tx1"/>
                           </a:solidFill>
                         </a:rPr>
-                        <a:t>€894 / €2,840 · 1.0</a:t>
+                        <a:t>€336 / €1,326 · 8.5</a:t>
                       </a:r>
                       <a:endParaRPr lang="en-US" sz="1000" dirty="0"/>
                     </a:p>
@@ -15177,10 +15177,244 @@
                       <a:r>
                         <a:rPr lang="en-US" sz="1000" dirty="0">
                           <a:solidFill>
+                            <a:schemeClr val="accent4"/>
+                          </a:solidFill>
+                        </a:rPr>
+                        <a:t>–</a:t>
+                      </a:r>
+                      <a:endParaRPr lang="en-US" sz="1000" dirty="0"/>
+                    </a:p>
+                  </a:txBody>
+                  <a:tcPr marL="91440" marR="91440" marT="45720" marB="45720" anchor="ctr">
+                    <a:lnL w="6350" cap="flat" cmpd="sng" algn="ctr">
+                      <a:solidFill>
+                        <a:srgbClr val="D6DEE5"/>
+                      </a:solidFill>
+                      <a:prstDash val="solid"/>
+                      <a:round/>
+                      <a:headEnd type="none" w="med" len="med"/>
+                      <a:tailEnd type="none" w="med" len="med"/>
+                    </a:lnL>
+                    <a:lnR w="6350" cap="flat" cmpd="sng" algn="ctr">
+                      <a:solidFill>
+                        <a:srgbClr val="D6DEE5"/>
+                      </a:solidFill>
+                      <a:prstDash val="solid"/>
+                      <a:round/>
+                      <a:headEnd type="none" w="med" len="med"/>
+                      <a:tailEnd type="none" w="med" len="med"/>
+                    </a:lnR>
+                    <a:lnT w="6350" cap="flat" cmpd="sng" algn="ctr">
+                      <a:solidFill>
+                        <a:srgbClr val="D6DEE5"/>
+                      </a:solidFill>
+                      <a:prstDash val="solid"/>
+                      <a:round/>
+                      <a:headEnd type="none" w="med" len="med"/>
+                      <a:tailEnd type="none" w="med" len="med"/>
+                    </a:lnT>
+                    <a:lnB w="6350" cap="flat" cmpd="sng" algn="ctr">
+                      <a:solidFill>
+                        <a:srgbClr val="D6DEE5"/>
+                      </a:solidFill>
+                      <a:prstDash val="solid"/>
+                      <a:round/>
+                      <a:headEnd type="none" w="med" len="med"/>
+                      <a:tailEnd type="none" w="med" len="med"/>
+                    </a:lnB>
+                  </a:tcPr>
+                </a:tc>
+                <a:tc>
+                  <a:txBody>
+                    <a:bodyPr/>
+                    <a:lstStyle/>
+                    <a:p>
+                      <a:pPr algn="ctr" indent="0" marL="0">
+                        <a:buNone/>
+                      </a:pPr>
+                      <a:r>
+                        <a:rPr lang="en-US" sz="1000" dirty="0">
+                          <a:solidFill>
+                            <a:schemeClr val="accent4"/>
+                          </a:solidFill>
+                        </a:rPr>
+                        <a:t>–</a:t>
+                      </a:r>
+                      <a:endParaRPr lang="en-US" sz="1000" dirty="0"/>
+                    </a:p>
+                  </a:txBody>
+                  <a:tcPr marL="91440" marR="91440" marT="45720" marB="45720" anchor="ctr">
+                    <a:lnL w="6350" cap="flat" cmpd="sng" algn="ctr">
+                      <a:solidFill>
+                        <a:srgbClr val="D6DEE5"/>
+                      </a:solidFill>
+                      <a:prstDash val="solid"/>
+                      <a:round/>
+                      <a:headEnd type="none" w="med" len="med"/>
+                      <a:tailEnd type="none" w="med" len="med"/>
+                    </a:lnL>
+                    <a:lnR w="6350" cap="flat" cmpd="sng" algn="ctr">
+                      <a:solidFill>
+                        <a:srgbClr val="D6DEE5"/>
+                      </a:solidFill>
+                      <a:prstDash val="solid"/>
+                      <a:round/>
+                      <a:headEnd type="none" w="med" len="med"/>
+                      <a:tailEnd type="none" w="med" len="med"/>
+                    </a:lnR>
+                    <a:lnT w="6350" cap="flat" cmpd="sng" algn="ctr">
+                      <a:solidFill>
+                        <a:srgbClr val="D6DEE5"/>
+                      </a:solidFill>
+                      <a:prstDash val="solid"/>
+                      <a:round/>
+                      <a:headEnd type="none" w="med" len="med"/>
+                      <a:tailEnd type="none" w="med" len="med"/>
+                    </a:lnT>
+                    <a:lnB w="6350" cap="flat" cmpd="sng" algn="ctr">
+                      <a:solidFill>
+                        <a:srgbClr val="D6DEE5"/>
+                      </a:solidFill>
+                      <a:prstDash val="solid"/>
+                      <a:round/>
+                      <a:headEnd type="none" w="med" len="med"/>
+                      <a:tailEnd type="none" w="med" len="med"/>
+                    </a:lnB>
+                  </a:tcPr>
+                </a:tc>
+                <a:tc>
+                  <a:txBody>
+                    <a:bodyPr/>
+                    <a:lstStyle/>
+                    <a:p>
+                      <a:pPr algn="ctr" indent="0" marL="0">
+                        <a:buNone/>
+                      </a:pPr>
+                      <a:r>
+                        <a:rPr lang="en-US" sz="1000" dirty="0">
+                          <a:solidFill>
+                            <a:schemeClr val="accent4"/>
+                          </a:solidFill>
+                        </a:rPr>
+                        <a:t>–</a:t>
+                      </a:r>
+                      <a:endParaRPr lang="en-US" sz="1000" dirty="0"/>
+                    </a:p>
+                  </a:txBody>
+                  <a:tcPr marL="91440" marR="91440" marT="45720" marB="45720" anchor="ctr">
+                    <a:lnL w="6350" cap="flat" cmpd="sng" algn="ctr">
+                      <a:solidFill>
+                        <a:srgbClr val="D6DEE5"/>
+                      </a:solidFill>
+                      <a:prstDash val="solid"/>
+                      <a:round/>
+                      <a:headEnd type="none" w="med" len="med"/>
+                      <a:tailEnd type="none" w="med" len="med"/>
+                    </a:lnL>
+                    <a:lnR w="6350" cap="flat" cmpd="sng" algn="ctr">
+                      <a:solidFill>
+                        <a:srgbClr val="D6DEE5"/>
+                      </a:solidFill>
+                      <a:prstDash val="solid"/>
+                      <a:round/>
+                      <a:headEnd type="none" w="med" len="med"/>
+                      <a:tailEnd type="none" w="med" len="med"/>
+                    </a:lnR>
+                    <a:lnT w="6350" cap="flat" cmpd="sng" algn="ctr">
+                      <a:solidFill>
+                        <a:srgbClr val="D6DEE5"/>
+                      </a:solidFill>
+                      <a:prstDash val="solid"/>
+                      <a:round/>
+                      <a:headEnd type="none" w="med" len="med"/>
+                      <a:tailEnd type="none" w="med" len="med"/>
+                    </a:lnT>
+                    <a:lnB w="6350" cap="flat" cmpd="sng" algn="ctr">
+                      <a:solidFill>
+                        <a:srgbClr val="D6DEE5"/>
+                      </a:solidFill>
+                      <a:prstDash val="solid"/>
+                      <a:round/>
+                      <a:headEnd type="none" w="med" len="med"/>
+                      <a:tailEnd type="none" w="med" len="med"/>
+                    </a:lnB>
+                  </a:tcPr>
+                </a:tc>
+              </a:tr>
+              <a:tr h="329184">
+                <a:tc>
+                  <a:txBody>
+                    <a:bodyPr/>
+                    <a:lstStyle/>
+                    <a:p>
+                      <a:pPr indent="0" marL="0">
+                        <a:buNone/>
+                      </a:pPr>
+                      <a:r>
+                        <a:rPr lang="en-US" sz="1000" dirty="0">
+                          <a:solidFill>
                             <a:schemeClr val="tx1"/>
                           </a:solidFill>
                         </a:rPr>
-                        <a:t>€610 / €1,643 · 1.8</a:t>
+                        <a:t>StepStone (German, CV-based, €1,449/ad)</a:t>
+                      </a:r>
+                      <a:endParaRPr lang="en-US" sz="1000" dirty="0"/>
+                    </a:p>
+                  </a:txBody>
+                  <a:tcPr marL="91440" marR="91440" marT="45720" marB="45720" anchor="ctr">
+                    <a:lnL w="6350" cap="flat" cmpd="sng" algn="ctr">
+                      <a:solidFill>
+                        <a:srgbClr val="D6DEE5"/>
+                      </a:solidFill>
+                      <a:prstDash val="solid"/>
+                      <a:round/>
+                      <a:headEnd type="none" w="med" len="med"/>
+                      <a:tailEnd type="none" w="med" len="med"/>
+                    </a:lnL>
+                    <a:lnR w="6350" cap="flat" cmpd="sng" algn="ctr">
+                      <a:solidFill>
+                        <a:srgbClr val="D6DEE5"/>
+                      </a:solidFill>
+                      <a:prstDash val="solid"/>
+                      <a:round/>
+                      <a:headEnd type="none" w="med" len="med"/>
+                      <a:tailEnd type="none" w="med" len="med"/>
+                    </a:lnR>
+                    <a:lnT w="6350" cap="flat" cmpd="sng" algn="ctr">
+                      <a:solidFill>
+                        <a:srgbClr val="D6DEE5"/>
+                      </a:solidFill>
+                      <a:prstDash val="solid"/>
+                      <a:round/>
+                      <a:headEnd type="none" w="med" len="med"/>
+                      <a:tailEnd type="none" w="med" len="med"/>
+                    </a:lnT>
+                    <a:lnB w="6350" cap="flat" cmpd="sng" algn="ctr">
+                      <a:solidFill>
+                        <a:srgbClr val="D6DEE5"/>
+                      </a:solidFill>
+                      <a:prstDash val="solid"/>
+                      <a:round/>
+                      <a:headEnd type="none" w="med" len="med"/>
+                      <a:tailEnd type="none" w="med" len="med"/>
+                    </a:lnB>
+                  </a:tcPr>
+                </a:tc>
+                <a:tc>
+                  <a:txBody>
+                    <a:bodyPr/>
+                    <a:lstStyle/>
+                    <a:p>
+                      <a:pPr algn="ctr" indent="0" marL="0">
+                        <a:buNone/>
+                      </a:pPr>
+                      <a:r>
+                        <a:rPr lang="en-US" sz="1000" dirty="0">
+                          <a:solidFill>
+                            <a:schemeClr val="tx1"/>
+                          </a:solidFill>
+                        </a:rPr>
+                        <a:t>€537 / €1,704 · 1.7</a:t>
                       </a:r>
                       <a:endParaRPr lang="en-US" sz="1000" dirty="0"/>
                     </a:p>
@@ -15241,7 +15475,7 @@
                             <a:schemeClr val="tx1"/>
                           </a:solidFill>
                         </a:rPr>
-                        <a:t>€894 / €3,155 · 0.9</a:t>
+                        <a:t>€537 / €1,446 · 2.0</a:t>
                       </a:r>
                       <a:endParaRPr lang="en-US" sz="1000" dirty="0"/>
                     </a:p>
@@ -15302,7 +15536,7 @@
                             <a:schemeClr val="tx1"/>
                           </a:solidFill>
                         </a:rPr>
-                        <a:t>€1,342 / €5,637 · –</a:t>
+                        <a:t>€537 / €1,893 · –</a:t>
                       </a:r>
                       <a:endParaRPr lang="en-US" sz="1000" dirty="0"/>
                     </a:p>
@@ -15349,6 +15583,67 @@
                     </a:solidFill>
                   </a:tcPr>
                 </a:tc>
+                <a:tc>
+                  <a:txBody>
+                    <a:bodyPr/>
+                    <a:lstStyle/>
+                    <a:p>
+                      <a:pPr algn="ctr" indent="0" marL="0">
+                        <a:buNone/>
+                      </a:pPr>
+                      <a:r>
+                        <a:rPr lang="en-US" sz="1000" dirty="0">
+                          <a:solidFill>
+                            <a:schemeClr val="tx1"/>
+                          </a:solidFill>
+                        </a:rPr>
+                        <a:t>€583 / €2,451 · –</a:t>
+                      </a:r>
+                      <a:endParaRPr lang="en-US" sz="1000" dirty="0"/>
+                    </a:p>
+                  </a:txBody>
+                  <a:tcPr marL="91440" marR="91440" marT="45720" marB="45720" anchor="ctr">
+                    <a:lnL w="6350" cap="flat" cmpd="sng" algn="ctr">
+                      <a:solidFill>
+                        <a:srgbClr val="D6DEE5"/>
+                      </a:solidFill>
+                      <a:prstDash val="solid"/>
+                      <a:round/>
+                      <a:headEnd type="none" w="med" len="med"/>
+                      <a:tailEnd type="none" w="med" len="med"/>
+                    </a:lnL>
+                    <a:lnR w="6350" cap="flat" cmpd="sng" algn="ctr">
+                      <a:solidFill>
+                        <a:srgbClr val="D6DEE5"/>
+                      </a:solidFill>
+                      <a:prstDash val="solid"/>
+                      <a:round/>
+                      <a:headEnd type="none" w="med" len="med"/>
+                      <a:tailEnd type="none" w="med" len="med"/>
+                    </a:lnR>
+                    <a:lnT w="6350" cap="flat" cmpd="sng" algn="ctr">
+                      <a:solidFill>
+                        <a:srgbClr val="D6DEE5"/>
+                      </a:solidFill>
+                      <a:prstDash val="solid"/>
+                      <a:round/>
+                      <a:headEnd type="none" w="med" len="med"/>
+                      <a:tailEnd type="none" w="med" len="med"/>
+                    </a:lnT>
+                    <a:lnB w="6350" cap="flat" cmpd="sng" algn="ctr">
+                      <a:solidFill>
+                        <a:srgbClr val="D6DEE5"/>
+                      </a:solidFill>
+                      <a:prstDash val="solid"/>
+                      <a:round/>
+                      <a:headEnd type="none" w="med" len="med"/>
+                      <a:tailEnd type="none" w="med" len="med"/>
+                    </a:lnB>
+                    <a:solidFill>
+                      <a:srgbClr val="F2F4F6"/>
+                    </a:solidFill>
+                  </a:tcPr>
+                </a:tc>
               </a:tr>
               <a:tr h="329184">
                 <a:tc>
@@ -15365,7 +15660,7 @@
                             <a:schemeClr val="tx1"/>
                           </a:solidFill>
                         </a:rPr>
-                        <a:t>Meta lead ads (passive blue-collar reach)</a:t>
+                        <a:t>LinkedIn (PLC/TIA and Meister profiles)</a:t>
                       </a:r>
                       <a:endParaRPr lang="en-US" sz="1000" dirty="0"/>
                     </a:p>
@@ -15420,10 +15715,126 @@
                       <a:r>
                         <a:rPr lang="en-US" sz="1000" dirty="0">
                           <a:solidFill>
+                            <a:schemeClr val="accent4"/>
+                          </a:solidFill>
+                        </a:rPr>
+                        <a:t>–</a:t>
+                      </a:r>
+                      <a:endParaRPr lang="en-US" sz="1000" dirty="0"/>
+                    </a:p>
+                  </a:txBody>
+                  <a:tcPr marL="91440" marR="91440" marT="45720" marB="45720" anchor="ctr">
+                    <a:lnL w="6350" cap="flat" cmpd="sng" algn="ctr">
+                      <a:solidFill>
+                        <a:srgbClr val="D6DEE5"/>
+                      </a:solidFill>
+                      <a:prstDash val="solid"/>
+                      <a:round/>
+                      <a:headEnd type="none" w="med" len="med"/>
+                      <a:tailEnd type="none" w="med" len="med"/>
+                    </a:lnL>
+                    <a:lnR w="6350" cap="flat" cmpd="sng" algn="ctr">
+                      <a:solidFill>
+                        <a:srgbClr val="D6DEE5"/>
+                      </a:solidFill>
+                      <a:prstDash val="solid"/>
+                      <a:round/>
+                      <a:headEnd type="none" w="med" len="med"/>
+                      <a:tailEnd type="none" w="med" len="med"/>
+                    </a:lnR>
+                    <a:lnT w="6350" cap="flat" cmpd="sng" algn="ctr">
+                      <a:solidFill>
+                        <a:srgbClr val="D6DEE5"/>
+                      </a:solidFill>
+                      <a:prstDash val="solid"/>
+                      <a:round/>
+                      <a:headEnd type="none" w="med" len="med"/>
+                      <a:tailEnd type="none" w="med" len="med"/>
+                    </a:lnT>
+                    <a:lnB w="6350" cap="flat" cmpd="sng" algn="ctr">
+                      <a:solidFill>
+                        <a:srgbClr val="D6DEE5"/>
+                      </a:solidFill>
+                      <a:prstDash val="solid"/>
+                      <a:round/>
+                      <a:headEnd type="none" w="med" len="med"/>
+                      <a:tailEnd type="none" w="med" len="med"/>
+                    </a:lnB>
+                  </a:tcPr>
+                </a:tc>
+                <a:tc>
+                  <a:txBody>
+                    <a:bodyPr/>
+                    <a:lstStyle/>
+                    <a:p>
+                      <a:pPr algn="ctr" indent="0" marL="0">
+                        <a:buNone/>
+                      </a:pPr>
+                      <a:r>
+                        <a:rPr lang="en-US" sz="1000" dirty="0">
+                          <a:solidFill>
+                            <a:schemeClr val="accent4"/>
+                          </a:solidFill>
+                        </a:rPr>
+                        <a:t>–</a:t>
+                      </a:r>
+                      <a:endParaRPr lang="en-US" sz="1000" dirty="0"/>
+                    </a:p>
+                  </a:txBody>
+                  <a:tcPr marL="91440" marR="91440" marT="45720" marB="45720" anchor="ctr">
+                    <a:lnL w="6350" cap="flat" cmpd="sng" algn="ctr">
+                      <a:solidFill>
+                        <a:srgbClr val="D6DEE5"/>
+                      </a:solidFill>
+                      <a:prstDash val="solid"/>
+                      <a:round/>
+                      <a:headEnd type="none" w="med" len="med"/>
+                      <a:tailEnd type="none" w="med" len="med"/>
+                    </a:lnL>
+                    <a:lnR w="6350" cap="flat" cmpd="sng" algn="ctr">
+                      <a:solidFill>
+                        <a:srgbClr val="D6DEE5"/>
+                      </a:solidFill>
+                      <a:prstDash val="solid"/>
+                      <a:round/>
+                      <a:headEnd type="none" w="med" len="med"/>
+                      <a:tailEnd type="none" w="med" len="med"/>
+                    </a:lnR>
+                    <a:lnT w="6350" cap="flat" cmpd="sng" algn="ctr">
+                      <a:solidFill>
+                        <a:srgbClr val="D6DEE5"/>
+                      </a:solidFill>
+                      <a:prstDash val="solid"/>
+                      <a:round/>
+                      <a:headEnd type="none" w="med" len="med"/>
+                      <a:tailEnd type="none" w="med" len="med"/>
+                    </a:lnT>
+                    <a:lnB w="6350" cap="flat" cmpd="sng" algn="ctr">
+                      <a:solidFill>
+                        <a:srgbClr val="D6DEE5"/>
+                      </a:solidFill>
+                      <a:prstDash val="solid"/>
+                      <a:round/>
+                      <a:headEnd type="none" w="med" len="med"/>
+                      <a:tailEnd type="none" w="med" len="med"/>
+                    </a:lnB>
+                  </a:tcPr>
+                </a:tc>
+                <a:tc>
+                  <a:txBody>
+                    <a:bodyPr/>
+                    <a:lstStyle/>
+                    <a:p>
+                      <a:pPr algn="ctr" indent="0" marL="0">
+                        <a:buNone/>
+                      </a:pPr>
+                      <a:r>
+                        <a:rPr lang="en-US" sz="1000" dirty="0">
+                          <a:solidFill>
                             <a:schemeClr val="tx1"/>
                           </a:solidFill>
                         </a:rPr>
-                        <a:t>€1,120 / €3,556 · 9.5</a:t>
+                        <a:t>€427 / €1,505 · 9.7</a:t>
                       </a:r>
                       <a:endParaRPr lang="en-US" sz="1000" dirty="0"/>
                     </a:p>
@@ -15484,7 +15895,7 @@
                             <a:schemeClr val="tx1"/>
                           </a:solidFill>
                         </a:rPr>
-                        <a:t>€764 / €2,057 · 8.2</a:t>
+                        <a:t>€464 / €1,949 · 7.2</a:t>
                       </a:r>
                       <a:endParaRPr lang="en-US" sz="1000" dirty="0"/>
                     </a:p>
@@ -15531,122 +15942,6 @@
                     </a:solidFill>
                   </a:tcPr>
                 </a:tc>
-                <a:tc>
-                  <a:txBody>
-                    <a:bodyPr/>
-                    <a:lstStyle/>
-                    <a:p>
-                      <a:pPr algn="ctr" indent="0" marL="0">
-                        <a:buNone/>
-                      </a:pPr>
-                      <a:r>
-                        <a:rPr lang="en-US" sz="1000" dirty="0">
-                          <a:solidFill>
-                            <a:schemeClr val="accent4"/>
-                          </a:solidFill>
-                        </a:rPr>
-                        <a:t>–</a:t>
-                      </a:r>
-                      <a:endParaRPr lang="en-US" sz="1000" dirty="0"/>
-                    </a:p>
-                  </a:txBody>
-                  <a:tcPr marL="91440" marR="91440" marT="45720" marB="45720" anchor="ctr">
-                    <a:lnL w="6350" cap="flat" cmpd="sng" algn="ctr">
-                      <a:solidFill>
-                        <a:srgbClr val="D6DEE5"/>
-                      </a:solidFill>
-                      <a:prstDash val="solid"/>
-                      <a:round/>
-                      <a:headEnd type="none" w="med" len="med"/>
-                      <a:tailEnd type="none" w="med" len="med"/>
-                    </a:lnL>
-                    <a:lnR w="6350" cap="flat" cmpd="sng" algn="ctr">
-                      <a:solidFill>
-                        <a:srgbClr val="D6DEE5"/>
-                      </a:solidFill>
-                      <a:prstDash val="solid"/>
-                      <a:round/>
-                      <a:headEnd type="none" w="med" len="med"/>
-                      <a:tailEnd type="none" w="med" len="med"/>
-                    </a:lnR>
-                    <a:lnT w="6350" cap="flat" cmpd="sng" algn="ctr">
-                      <a:solidFill>
-                        <a:srgbClr val="D6DEE5"/>
-                      </a:solidFill>
-                      <a:prstDash val="solid"/>
-                      <a:round/>
-                      <a:headEnd type="none" w="med" len="med"/>
-                      <a:tailEnd type="none" w="med" len="med"/>
-                    </a:lnT>
-                    <a:lnB w="6350" cap="flat" cmpd="sng" algn="ctr">
-                      <a:solidFill>
-                        <a:srgbClr val="D6DEE5"/>
-                      </a:solidFill>
-                      <a:prstDash val="solid"/>
-                      <a:round/>
-                      <a:headEnd type="none" w="med" len="med"/>
-                      <a:tailEnd type="none" w="med" len="med"/>
-                    </a:lnB>
-                  </a:tcPr>
-                </a:tc>
-                <a:tc>
-                  <a:txBody>
-                    <a:bodyPr/>
-                    <a:lstStyle/>
-                    <a:p>
-                      <a:pPr algn="ctr" indent="0" marL="0">
-                        <a:buNone/>
-                      </a:pPr>
-                      <a:r>
-                        <a:rPr lang="en-US" sz="1000" dirty="0">
-                          <a:solidFill>
-                            <a:schemeClr val="accent4"/>
-                          </a:solidFill>
-                        </a:rPr>
-                        <a:t>–</a:t>
-                      </a:r>
-                      <a:endParaRPr lang="en-US" sz="1000" dirty="0"/>
-                    </a:p>
-                  </a:txBody>
-                  <a:tcPr marL="91440" marR="91440" marT="45720" marB="45720" anchor="ctr">
-                    <a:lnL w="6350" cap="flat" cmpd="sng" algn="ctr">
-                      <a:solidFill>
-                        <a:srgbClr val="D6DEE5"/>
-                      </a:solidFill>
-                      <a:prstDash val="solid"/>
-                      <a:round/>
-                      <a:headEnd type="none" w="med" len="med"/>
-                      <a:tailEnd type="none" w="med" len="med"/>
-                    </a:lnL>
-                    <a:lnR w="6350" cap="flat" cmpd="sng" algn="ctr">
-                      <a:solidFill>
-                        <a:srgbClr val="D6DEE5"/>
-                      </a:solidFill>
-                      <a:prstDash val="solid"/>
-                      <a:round/>
-                      <a:headEnd type="none" w="med" len="med"/>
-                      <a:tailEnd type="none" w="med" len="med"/>
-                    </a:lnR>
-                    <a:lnT w="6350" cap="flat" cmpd="sng" algn="ctr">
-                      <a:solidFill>
-                        <a:srgbClr val="D6DEE5"/>
-                      </a:solidFill>
-                      <a:prstDash val="solid"/>
-                      <a:round/>
-                      <a:headEnd type="none" w="med" len="med"/>
-                      <a:tailEnd type="none" w="med" len="med"/>
-                    </a:lnT>
-                    <a:lnB w="6350" cap="flat" cmpd="sng" algn="ctr">
-                      <a:solidFill>
-                        <a:srgbClr val="D6DEE5"/>
-                      </a:solidFill>
-                      <a:prstDash val="solid"/>
-                      <a:round/>
-                      <a:headEnd type="none" w="med" len="med"/>
-                      <a:tailEnd type="none" w="med" len="med"/>
-                    </a:lnB>
-                  </a:tcPr>
-                </a:tc>
               </a:tr>
               <a:tr h="329184">
                 <a:tc>
@@ -15663,7 +15958,7 @@
                             <a:schemeClr val="tx1"/>
                           </a:solidFill>
                         </a:rPr>
-                        <a:t>I2 Handwerk → Industrie (new pool)</a:t>
+                        <a:t>Meta lead ads (passive blue-collar reach)</a:t>
                       </a:r>
                       <a:endParaRPr lang="en-US" sz="1000" dirty="0"/>
                     </a:p>
@@ -15721,7 +16016,7 @@
                             <a:schemeClr val="tx1"/>
                           </a:solidFill>
                         </a:rPr>
-                        <a:t>€560 / €2,116 · 8.5</a:t>
+                        <a:t>€672 / €2,133 · 6.3</a:t>
                       </a:r>
                       <a:endParaRPr lang="en-US" sz="1000" dirty="0"/>
                     </a:p>
@@ -15779,244 +16074,10 @@
                       <a:r>
                         <a:rPr lang="en-US" sz="1000" dirty="0">
                           <a:solidFill>
-                            <a:schemeClr val="accent4"/>
-                          </a:solidFill>
-                        </a:rPr>
-                        <a:t>–</a:t>
-                      </a:r>
-                      <a:endParaRPr lang="en-US" sz="1000" dirty="0"/>
-                    </a:p>
-                  </a:txBody>
-                  <a:tcPr marL="91440" marR="91440" marT="45720" marB="45720" anchor="ctr">
-                    <a:lnL w="6350" cap="flat" cmpd="sng" algn="ctr">
-                      <a:solidFill>
-                        <a:srgbClr val="D6DEE5"/>
-                      </a:solidFill>
-                      <a:prstDash val="solid"/>
-                      <a:round/>
-                      <a:headEnd type="none" w="med" len="med"/>
-                      <a:tailEnd type="none" w="med" len="med"/>
-                    </a:lnL>
-                    <a:lnR w="6350" cap="flat" cmpd="sng" algn="ctr">
-                      <a:solidFill>
-                        <a:srgbClr val="D6DEE5"/>
-                      </a:solidFill>
-                      <a:prstDash val="solid"/>
-                      <a:round/>
-                      <a:headEnd type="none" w="med" len="med"/>
-                      <a:tailEnd type="none" w="med" len="med"/>
-                    </a:lnR>
-                    <a:lnT w="6350" cap="flat" cmpd="sng" algn="ctr">
-                      <a:solidFill>
-                        <a:srgbClr val="D6DEE5"/>
-                      </a:solidFill>
-                      <a:prstDash val="solid"/>
-                      <a:round/>
-                      <a:headEnd type="none" w="med" len="med"/>
-                      <a:tailEnd type="none" w="med" len="med"/>
-                    </a:lnT>
-                    <a:lnB w="6350" cap="flat" cmpd="sng" algn="ctr">
-                      <a:solidFill>
-                        <a:srgbClr val="D6DEE5"/>
-                      </a:solidFill>
-                      <a:prstDash val="solid"/>
-                      <a:round/>
-                      <a:headEnd type="none" w="med" len="med"/>
-                      <a:tailEnd type="none" w="med" len="med"/>
-                    </a:lnB>
-                  </a:tcPr>
-                </a:tc>
-                <a:tc>
-                  <a:txBody>
-                    <a:bodyPr/>
-                    <a:lstStyle/>
-                    <a:p>
-                      <a:pPr algn="ctr" indent="0" marL="0">
-                        <a:buNone/>
-                      </a:pPr>
-                      <a:r>
-                        <a:rPr lang="en-US" sz="1000" dirty="0">
-                          <a:solidFill>
-                            <a:schemeClr val="accent4"/>
-                          </a:solidFill>
-                        </a:rPr>
-                        <a:t>–</a:t>
-                      </a:r>
-                      <a:endParaRPr lang="en-US" sz="1000" dirty="0"/>
-                    </a:p>
-                  </a:txBody>
-                  <a:tcPr marL="91440" marR="91440" marT="45720" marB="45720" anchor="ctr">
-                    <a:lnL w="6350" cap="flat" cmpd="sng" algn="ctr">
-                      <a:solidFill>
-                        <a:srgbClr val="D6DEE5"/>
-                      </a:solidFill>
-                      <a:prstDash val="solid"/>
-                      <a:round/>
-                      <a:headEnd type="none" w="med" len="med"/>
-                      <a:tailEnd type="none" w="med" len="med"/>
-                    </a:lnL>
-                    <a:lnR w="6350" cap="flat" cmpd="sng" algn="ctr">
-                      <a:solidFill>
-                        <a:srgbClr val="D6DEE5"/>
-                      </a:solidFill>
-                      <a:prstDash val="solid"/>
-                      <a:round/>
-                      <a:headEnd type="none" w="med" len="med"/>
-                      <a:tailEnd type="none" w="med" len="med"/>
-                    </a:lnR>
-                    <a:lnT w="6350" cap="flat" cmpd="sng" algn="ctr">
-                      <a:solidFill>
-                        <a:srgbClr val="D6DEE5"/>
-                      </a:solidFill>
-                      <a:prstDash val="solid"/>
-                      <a:round/>
-                      <a:headEnd type="none" w="med" len="med"/>
-                      <a:tailEnd type="none" w="med" len="med"/>
-                    </a:lnT>
-                    <a:lnB w="6350" cap="flat" cmpd="sng" algn="ctr">
-                      <a:solidFill>
-                        <a:srgbClr val="D6DEE5"/>
-                      </a:solidFill>
-                      <a:prstDash val="solid"/>
-                      <a:round/>
-                      <a:headEnd type="none" w="med" len="med"/>
-                      <a:tailEnd type="none" w="med" len="med"/>
-                    </a:lnB>
-                  </a:tcPr>
-                </a:tc>
-                <a:tc>
-                  <a:txBody>
-                    <a:bodyPr/>
-                    <a:lstStyle/>
-                    <a:p>
-                      <a:pPr algn="ctr" indent="0" marL="0">
-                        <a:buNone/>
-                      </a:pPr>
-                      <a:r>
-                        <a:rPr lang="en-US" sz="1000" dirty="0">
-                          <a:solidFill>
-                            <a:schemeClr val="accent4"/>
-                          </a:solidFill>
-                        </a:rPr>
-                        <a:t>–</a:t>
-                      </a:r>
-                      <a:endParaRPr lang="en-US" sz="1000" dirty="0"/>
-                    </a:p>
-                  </a:txBody>
-                  <a:tcPr marL="91440" marR="91440" marT="45720" marB="45720" anchor="ctr">
-                    <a:lnL w="6350" cap="flat" cmpd="sng" algn="ctr">
-                      <a:solidFill>
-                        <a:srgbClr val="D6DEE5"/>
-                      </a:solidFill>
-                      <a:prstDash val="solid"/>
-                      <a:round/>
-                      <a:headEnd type="none" w="med" len="med"/>
-                      <a:tailEnd type="none" w="med" len="med"/>
-                    </a:lnL>
-                    <a:lnR w="6350" cap="flat" cmpd="sng" algn="ctr">
-                      <a:solidFill>
-                        <a:srgbClr val="D6DEE5"/>
-                      </a:solidFill>
-                      <a:prstDash val="solid"/>
-                      <a:round/>
-                      <a:headEnd type="none" w="med" len="med"/>
-                      <a:tailEnd type="none" w="med" len="med"/>
-                    </a:lnR>
-                    <a:lnT w="6350" cap="flat" cmpd="sng" algn="ctr">
-                      <a:solidFill>
-                        <a:srgbClr val="D6DEE5"/>
-                      </a:solidFill>
-                      <a:prstDash val="solid"/>
-                      <a:round/>
-                      <a:headEnd type="none" w="med" len="med"/>
-                      <a:tailEnd type="none" w="med" len="med"/>
-                    </a:lnT>
-                    <a:lnB w="6350" cap="flat" cmpd="sng" algn="ctr">
-                      <a:solidFill>
-                        <a:srgbClr val="D6DEE5"/>
-                      </a:solidFill>
-                      <a:prstDash val="solid"/>
-                      <a:round/>
-                      <a:headEnd type="none" w="med" len="med"/>
-                      <a:tailEnd type="none" w="med" len="med"/>
-                    </a:lnB>
-                  </a:tcPr>
-                </a:tc>
-              </a:tr>
-              <a:tr h="329184">
-                <a:tc>
-                  <a:txBody>
-                    <a:bodyPr/>
-                    <a:lstStyle/>
-                    <a:p>
-                      <a:pPr indent="0" marL="0">
-                        <a:buNone/>
-                      </a:pPr>
-                      <a:r>
-                        <a:rPr lang="en-US" sz="1000" dirty="0">
-                          <a:solidFill>
                             <a:schemeClr val="tx1"/>
                           </a:solidFill>
                         </a:rPr>
-                        <a:t>Programmatic (Indeed, Jooble, Talent.com…)</a:t>
-                      </a:r>
-                      <a:endParaRPr lang="en-US" sz="1000" dirty="0"/>
-                    </a:p>
-                  </a:txBody>
-                  <a:tcPr marL="91440" marR="91440" marT="45720" marB="45720" anchor="ctr">
-                    <a:lnL w="6350" cap="flat" cmpd="sng" algn="ctr">
-                      <a:solidFill>
-                        <a:srgbClr val="D6DEE5"/>
-                      </a:solidFill>
-                      <a:prstDash val="solid"/>
-                      <a:round/>
-                      <a:headEnd type="none" w="med" len="med"/>
-                      <a:tailEnd type="none" w="med" len="med"/>
-                    </a:lnL>
-                    <a:lnR w="6350" cap="flat" cmpd="sng" algn="ctr">
-                      <a:solidFill>
-                        <a:srgbClr val="D6DEE5"/>
-                      </a:solidFill>
-                      <a:prstDash val="solid"/>
-                      <a:round/>
-                      <a:headEnd type="none" w="med" len="med"/>
-                      <a:tailEnd type="none" w="med" len="med"/>
-                    </a:lnR>
-                    <a:lnT w="6350" cap="flat" cmpd="sng" algn="ctr">
-                      <a:solidFill>
-                        <a:srgbClr val="D6DEE5"/>
-                      </a:solidFill>
-                      <a:prstDash val="solid"/>
-                      <a:round/>
-                      <a:headEnd type="none" w="med" len="med"/>
-                      <a:tailEnd type="none" w="med" len="med"/>
-                    </a:lnT>
-                    <a:lnB w="6350" cap="flat" cmpd="sng" algn="ctr">
-                      <a:solidFill>
-                        <a:srgbClr val="D6DEE5"/>
-                      </a:solidFill>
-                      <a:prstDash val="solid"/>
-                      <a:round/>
-                      <a:headEnd type="none" w="med" len="med"/>
-                      <a:tailEnd type="none" w="med" len="med"/>
-                    </a:lnB>
-                  </a:tcPr>
-                </a:tc>
-                <a:tc>
-                  <a:txBody>
-                    <a:bodyPr/>
-                    <a:lstStyle/>
-                    <a:p>
-                      <a:pPr algn="ctr" indent="0" marL="0">
-                        <a:buNone/>
-                      </a:pPr>
-                      <a:r>
-                        <a:rPr lang="en-US" sz="1000" dirty="0">
-                          <a:solidFill>
-                            <a:schemeClr val="tx1"/>
-                          </a:solidFill>
-                        </a:rPr>
-                        <a:t>€1,193 / €3,786 · 3.2</a:t>
+                        <a:t>€672 / €1,810 · 5.7</a:t>
                       </a:r>
                       <a:endParaRPr lang="en-US" sz="1000" dirty="0"/>
                     </a:p>
@@ -16074,10 +16135,247 @@
                       <a:r>
                         <a:rPr lang="en-US" sz="1000" dirty="0">
                           <a:solidFill>
+                            <a:schemeClr val="accent4"/>
+                          </a:solidFill>
+                        </a:rPr>
+                        <a:t>–</a:t>
+                      </a:r>
+                      <a:endParaRPr lang="en-US" sz="1000" dirty="0"/>
+                    </a:p>
+                  </a:txBody>
+                  <a:tcPr marL="91440" marR="91440" marT="45720" marB="45720" anchor="ctr">
+                    <a:lnL w="6350" cap="flat" cmpd="sng" algn="ctr">
+                      <a:solidFill>
+                        <a:srgbClr val="D6DEE5"/>
+                      </a:solidFill>
+                      <a:prstDash val="solid"/>
+                      <a:round/>
+                      <a:headEnd type="none" w="med" len="med"/>
+                      <a:tailEnd type="none" w="med" len="med"/>
+                    </a:lnL>
+                    <a:lnR w="6350" cap="flat" cmpd="sng" algn="ctr">
+                      <a:solidFill>
+                        <a:srgbClr val="D6DEE5"/>
+                      </a:solidFill>
+                      <a:prstDash val="solid"/>
+                      <a:round/>
+                      <a:headEnd type="none" w="med" len="med"/>
+                      <a:tailEnd type="none" w="med" len="med"/>
+                    </a:lnR>
+                    <a:lnT w="6350" cap="flat" cmpd="sng" algn="ctr">
+                      <a:solidFill>
+                        <a:srgbClr val="D6DEE5"/>
+                      </a:solidFill>
+                      <a:prstDash val="solid"/>
+                      <a:round/>
+                      <a:headEnd type="none" w="med" len="med"/>
+                      <a:tailEnd type="none" w="med" len="med"/>
+                    </a:lnT>
+                    <a:lnB w="6350" cap="flat" cmpd="sng" algn="ctr">
+                      <a:solidFill>
+                        <a:srgbClr val="D6DEE5"/>
+                      </a:solidFill>
+                      <a:prstDash val="solid"/>
+                      <a:round/>
+                      <a:headEnd type="none" w="med" len="med"/>
+                      <a:tailEnd type="none" w="med" len="med"/>
+                    </a:lnB>
+                  </a:tcPr>
+                </a:tc>
+                <a:tc>
+                  <a:txBody>
+                    <a:bodyPr/>
+                    <a:lstStyle/>
+                    <a:p>
+                      <a:pPr algn="ctr" indent="0" marL="0">
+                        <a:buNone/>
+                      </a:pPr>
+                      <a:r>
+                        <a:rPr lang="en-US" sz="1000" dirty="0">
+                          <a:solidFill>
+                            <a:schemeClr val="accent4"/>
+                          </a:solidFill>
+                        </a:rPr>
+                        <a:t>–</a:t>
+                      </a:r>
+                      <a:endParaRPr lang="en-US" sz="1000" dirty="0"/>
+                    </a:p>
+                  </a:txBody>
+                  <a:tcPr marL="91440" marR="91440" marT="45720" marB="45720" anchor="ctr">
+                    <a:lnL w="6350" cap="flat" cmpd="sng" algn="ctr">
+                      <a:solidFill>
+                        <a:srgbClr val="D6DEE5"/>
+                      </a:solidFill>
+                      <a:prstDash val="solid"/>
+                      <a:round/>
+                      <a:headEnd type="none" w="med" len="med"/>
+                      <a:tailEnd type="none" w="med" len="med"/>
+                    </a:lnL>
+                    <a:lnR w="6350" cap="flat" cmpd="sng" algn="ctr">
+                      <a:solidFill>
+                        <a:srgbClr val="D6DEE5"/>
+                      </a:solidFill>
+                      <a:prstDash val="solid"/>
+                      <a:round/>
+                      <a:headEnd type="none" w="med" len="med"/>
+                      <a:tailEnd type="none" w="med" len="med"/>
+                    </a:lnR>
+                    <a:lnT w="6350" cap="flat" cmpd="sng" algn="ctr">
+                      <a:solidFill>
+                        <a:srgbClr val="D6DEE5"/>
+                      </a:solidFill>
+                      <a:prstDash val="solid"/>
+                      <a:round/>
+                      <a:headEnd type="none" w="med" len="med"/>
+                      <a:tailEnd type="none" w="med" len="med"/>
+                    </a:lnT>
+                    <a:lnB w="6350" cap="flat" cmpd="sng" algn="ctr">
+                      <a:solidFill>
+                        <a:srgbClr val="D6DEE5"/>
+                      </a:solidFill>
+                      <a:prstDash val="solid"/>
+                      <a:round/>
+                      <a:headEnd type="none" w="med" len="med"/>
+                      <a:tailEnd type="none" w="med" len="med"/>
+                    </a:lnB>
+                  </a:tcPr>
+                </a:tc>
+              </a:tr>
+              <a:tr h="329184">
+                <a:tc>
+                  <a:txBody>
+                    <a:bodyPr/>
+                    <a:lstStyle/>
+                    <a:p>
+                      <a:pPr indent="0" marL="0">
+                        <a:buNone/>
+                      </a:pPr>
+                      <a:r>
+                        <a:rPr lang="en-US" sz="1000" dirty="0">
+                          <a:solidFill>
                             <a:schemeClr val="tx1"/>
                           </a:solidFill>
                         </a:rPr>
-                        <a:t>€813 / €2,190 · 0.3 T</a:t>
+                        <a:t>Programmatic (Indeed, Jooble, Talent.com…)</a:t>
+                      </a:r>
+                      <a:endParaRPr lang="en-US" sz="1000" dirty="0"/>
+                    </a:p>
+                  </a:txBody>
+                  <a:tcPr marL="91440" marR="91440" marT="45720" marB="45720" anchor="ctr">
+                    <a:lnL w="6350" cap="flat" cmpd="sng" algn="ctr">
+                      <a:solidFill>
+                        <a:srgbClr val="D6DEE5"/>
+                      </a:solidFill>
+                      <a:prstDash val="solid"/>
+                      <a:round/>
+                      <a:headEnd type="none" w="med" len="med"/>
+                      <a:tailEnd type="none" w="med" len="med"/>
+                    </a:lnL>
+                    <a:lnR w="6350" cap="flat" cmpd="sng" algn="ctr">
+                      <a:solidFill>
+                        <a:srgbClr val="D6DEE5"/>
+                      </a:solidFill>
+                      <a:prstDash val="solid"/>
+                      <a:round/>
+                      <a:headEnd type="none" w="med" len="med"/>
+                      <a:tailEnd type="none" w="med" len="med"/>
+                    </a:lnR>
+                    <a:lnT w="6350" cap="flat" cmpd="sng" algn="ctr">
+                      <a:solidFill>
+                        <a:srgbClr val="D6DEE5"/>
+                      </a:solidFill>
+                      <a:prstDash val="solid"/>
+                      <a:round/>
+                      <a:headEnd type="none" w="med" len="med"/>
+                      <a:tailEnd type="none" w="med" len="med"/>
+                    </a:lnT>
+                    <a:lnB w="6350" cap="flat" cmpd="sng" algn="ctr">
+                      <a:solidFill>
+                        <a:srgbClr val="D6DEE5"/>
+                      </a:solidFill>
+                      <a:prstDash val="solid"/>
+                      <a:round/>
+                      <a:headEnd type="none" w="med" len="med"/>
+                      <a:tailEnd type="none" w="med" len="med"/>
+                    </a:lnB>
+                  </a:tcPr>
+                </a:tc>
+                <a:tc>
+                  <a:txBody>
+                    <a:bodyPr/>
+                    <a:lstStyle/>
+                    <a:p>
+                      <a:pPr algn="ctr" indent="0" marL="0">
+                        <a:buNone/>
+                      </a:pPr>
+                      <a:r>
+                        <a:rPr lang="en-US" sz="1000" dirty="0">
+                          <a:solidFill>
+                            <a:schemeClr val="tx1"/>
+                          </a:solidFill>
+                        </a:rPr>
+                        <a:t>€716 / €2,272 · 2.8</a:t>
+                      </a:r>
+                      <a:endParaRPr lang="en-US" sz="1000" dirty="0"/>
+                    </a:p>
+                  </a:txBody>
+                  <a:tcPr marL="91440" marR="91440" marT="45720" marB="45720" anchor="ctr">
+                    <a:lnL w="6350" cap="flat" cmpd="sng" algn="ctr">
+                      <a:solidFill>
+                        <a:srgbClr val="D6DEE5"/>
+                      </a:solidFill>
+                      <a:prstDash val="solid"/>
+                      <a:round/>
+                      <a:headEnd type="none" w="med" len="med"/>
+                      <a:tailEnd type="none" w="med" len="med"/>
+                    </a:lnL>
+                    <a:lnR w="6350" cap="flat" cmpd="sng" algn="ctr">
+                      <a:solidFill>
+                        <a:srgbClr val="D6DEE5"/>
+                      </a:solidFill>
+                      <a:prstDash val="solid"/>
+                      <a:round/>
+                      <a:headEnd type="none" w="med" len="med"/>
+                      <a:tailEnd type="none" w="med" len="med"/>
+                    </a:lnR>
+                    <a:lnT w="6350" cap="flat" cmpd="sng" algn="ctr">
+                      <a:solidFill>
+                        <a:srgbClr val="D6DEE5"/>
+                      </a:solidFill>
+                      <a:prstDash val="solid"/>
+                      <a:round/>
+                      <a:headEnd type="none" w="med" len="med"/>
+                      <a:tailEnd type="none" w="med" len="med"/>
+                    </a:lnT>
+                    <a:lnB w="6350" cap="flat" cmpd="sng" algn="ctr">
+                      <a:solidFill>
+                        <a:srgbClr val="D6DEE5"/>
+                      </a:solidFill>
+                      <a:prstDash val="solid"/>
+                      <a:round/>
+                      <a:headEnd type="none" w="med" len="med"/>
+                      <a:tailEnd type="none" w="med" len="med"/>
+                    </a:lnB>
+                    <a:solidFill>
+                      <a:srgbClr val="DCEFE8"/>
+                    </a:solidFill>
+                  </a:tcPr>
+                </a:tc>
+                <a:tc>
+                  <a:txBody>
+                    <a:bodyPr/>
+                    <a:lstStyle/>
+                    <a:p>
+                      <a:pPr algn="ctr" indent="0" marL="0">
+                        <a:buNone/>
+                      </a:pPr>
+                      <a:r>
+                        <a:rPr lang="en-US" sz="1000" dirty="0">
+                          <a:solidFill>
+                            <a:schemeClr val="tx1"/>
+                          </a:solidFill>
+                        </a:rPr>
+                        <a:t>€716 / €1,927 · 0.4 T</a:t>
                       </a:r>
                       <a:endParaRPr lang="en-US" sz="1000" dirty="0"/>
                     </a:p>
@@ -16138,68 +16436,7 @@
                             <a:schemeClr val="tx1"/>
                           </a:solidFill>
                         </a:rPr>
-                        <a:t>€1,193 / €4,207 · 0.5</a:t>
-                      </a:r>
-                      <a:endParaRPr lang="en-US" sz="1000" dirty="0"/>
-                    </a:p>
-                  </a:txBody>
-                  <a:tcPr marL="91440" marR="91440" marT="45720" marB="45720" anchor="ctr">
-                    <a:lnL w="6350" cap="flat" cmpd="sng" algn="ctr">
-                      <a:solidFill>
-                        <a:srgbClr val="D6DEE5"/>
-                      </a:solidFill>
-                      <a:prstDash val="solid"/>
-                      <a:round/>
-                      <a:headEnd type="none" w="med" len="med"/>
-                      <a:tailEnd type="none" w="med" len="med"/>
-                    </a:lnL>
-                    <a:lnR w="6350" cap="flat" cmpd="sng" algn="ctr">
-                      <a:solidFill>
-                        <a:srgbClr val="D6DEE5"/>
-                      </a:solidFill>
-                      <a:prstDash val="solid"/>
-                      <a:round/>
-                      <a:headEnd type="none" w="med" len="med"/>
-                      <a:tailEnd type="none" w="med" len="med"/>
-                    </a:lnR>
-                    <a:lnT w="6350" cap="flat" cmpd="sng" algn="ctr">
-                      <a:solidFill>
-                        <a:srgbClr val="D6DEE5"/>
-                      </a:solidFill>
-                      <a:prstDash val="solid"/>
-                      <a:round/>
-                      <a:headEnd type="none" w="med" len="med"/>
-                      <a:tailEnd type="none" w="med" len="med"/>
-                    </a:lnT>
-                    <a:lnB w="6350" cap="flat" cmpd="sng" algn="ctr">
-                      <a:solidFill>
-                        <a:srgbClr val="D6DEE5"/>
-                      </a:solidFill>
-                      <a:prstDash val="solid"/>
-                      <a:round/>
-                      <a:headEnd type="none" w="med" len="med"/>
-                      <a:tailEnd type="none" w="med" len="med"/>
-                    </a:lnB>
-                    <a:solidFill>
-                      <a:srgbClr val="DCEFE8"/>
-                    </a:solidFill>
-                  </a:tcPr>
-                </a:tc>
-                <a:tc>
-                  <a:txBody>
-                    <a:bodyPr/>
-                    <a:lstStyle/>
-                    <a:p>
-                      <a:pPr algn="ctr" indent="0" marL="0">
-                        <a:buNone/>
-                      </a:pPr>
-                      <a:r>
-                        <a:rPr lang="en-US" sz="1000" dirty="0">
-                          <a:solidFill>
-                            <a:schemeClr val="tx1"/>
-                          </a:solidFill>
-                        </a:rPr>
-                        <a:t>€1,789 / €7,516 · 0.1 T</a:t>
+                        <a:t>€716 / €2,524 · 0.3 T</a:t>
                       </a:r>
                       <a:endParaRPr lang="en-US" sz="1000" dirty="0"/>
                     </a:p>
@@ -16246,14 +16483,12 @@
                     </a:solidFill>
                   </a:tcPr>
                 </a:tc>
-              </a:tr>
-              <a:tr h="329184">
-                <a:tc>
-                  <a:txBody>
-                    <a:bodyPr/>
-                    <a:lstStyle/>
-                    <a:p>
-                      <a:pPr indent="0" marL="0">
+                <a:tc>
+                  <a:txBody>
+                    <a:bodyPr/>
+                    <a:lstStyle/>
+                    <a:p>
+                      <a:pPr algn="ctr" indent="0" marL="0">
                         <a:buNone/>
                       </a:pPr>
                       <a:r>
@@ -16262,363 +16497,7 @@
                             <a:schemeClr val="tx1"/>
                           </a:solidFill>
                         </a:rPr>
-                        <a:t>LinkedIn (PLC/TIA and Meister profiles)</a:t>
-                      </a:r>
-                      <a:endParaRPr lang="en-US" sz="1000" dirty="0"/>
-                    </a:p>
-                  </a:txBody>
-                  <a:tcPr marL="91440" marR="91440" marT="45720" marB="45720" anchor="ctr">
-                    <a:lnL w="6350" cap="flat" cmpd="sng" algn="ctr">
-                      <a:solidFill>
-                        <a:srgbClr val="D6DEE5"/>
-                      </a:solidFill>
-                      <a:prstDash val="solid"/>
-                      <a:round/>
-                      <a:headEnd type="none" w="med" len="med"/>
-                      <a:tailEnd type="none" w="med" len="med"/>
-                    </a:lnL>
-                    <a:lnR w="6350" cap="flat" cmpd="sng" algn="ctr">
-                      <a:solidFill>
-                        <a:srgbClr val="D6DEE5"/>
-                      </a:solidFill>
-                      <a:prstDash val="solid"/>
-                      <a:round/>
-                      <a:headEnd type="none" w="med" len="med"/>
-                      <a:tailEnd type="none" w="med" len="med"/>
-                    </a:lnR>
-                    <a:lnT w="6350" cap="flat" cmpd="sng" algn="ctr">
-                      <a:solidFill>
-                        <a:srgbClr val="D6DEE5"/>
-                      </a:solidFill>
-                      <a:prstDash val="solid"/>
-                      <a:round/>
-                      <a:headEnd type="none" w="med" len="med"/>
-                      <a:tailEnd type="none" w="med" len="med"/>
-                    </a:lnT>
-                    <a:lnB w="6350" cap="flat" cmpd="sng" algn="ctr">
-                      <a:solidFill>
-                        <a:srgbClr val="D6DEE5"/>
-                      </a:solidFill>
-                      <a:prstDash val="solid"/>
-                      <a:round/>
-                      <a:headEnd type="none" w="med" len="med"/>
-                      <a:tailEnd type="none" w="med" len="med"/>
-                    </a:lnB>
-                  </a:tcPr>
-                </a:tc>
-                <a:tc>
-                  <a:txBody>
-                    <a:bodyPr/>
-                    <a:lstStyle/>
-                    <a:p>
-                      <a:pPr algn="ctr" indent="0" marL="0">
-                        <a:buNone/>
-                      </a:pPr>
-                      <a:r>
-                        <a:rPr lang="en-US" sz="1000" dirty="0">
-                          <a:solidFill>
-                            <a:schemeClr val="accent4"/>
-                          </a:solidFill>
-                        </a:rPr>
-                        <a:t>–</a:t>
-                      </a:r>
-                      <a:endParaRPr lang="en-US" sz="1000" dirty="0"/>
-                    </a:p>
-                  </a:txBody>
-                  <a:tcPr marL="91440" marR="91440" marT="45720" marB="45720" anchor="ctr">
-                    <a:lnL w="6350" cap="flat" cmpd="sng" algn="ctr">
-                      <a:solidFill>
-                        <a:srgbClr val="D6DEE5"/>
-                      </a:solidFill>
-                      <a:prstDash val="solid"/>
-                      <a:round/>
-                      <a:headEnd type="none" w="med" len="med"/>
-                      <a:tailEnd type="none" w="med" len="med"/>
-                    </a:lnL>
-                    <a:lnR w="6350" cap="flat" cmpd="sng" algn="ctr">
-                      <a:solidFill>
-                        <a:srgbClr val="D6DEE5"/>
-                      </a:solidFill>
-                      <a:prstDash val="solid"/>
-                      <a:round/>
-                      <a:headEnd type="none" w="med" len="med"/>
-                      <a:tailEnd type="none" w="med" len="med"/>
-                    </a:lnR>
-                    <a:lnT w="6350" cap="flat" cmpd="sng" algn="ctr">
-                      <a:solidFill>
-                        <a:srgbClr val="D6DEE5"/>
-                      </a:solidFill>
-                      <a:prstDash val="solid"/>
-                      <a:round/>
-                      <a:headEnd type="none" w="med" len="med"/>
-                      <a:tailEnd type="none" w="med" len="med"/>
-                    </a:lnT>
-                    <a:lnB w="6350" cap="flat" cmpd="sng" algn="ctr">
-                      <a:solidFill>
-                        <a:srgbClr val="D6DEE5"/>
-                      </a:solidFill>
-                      <a:prstDash val="solid"/>
-                      <a:round/>
-                      <a:headEnd type="none" w="med" len="med"/>
-                      <a:tailEnd type="none" w="med" len="med"/>
-                    </a:lnB>
-                  </a:tcPr>
-                </a:tc>
-                <a:tc>
-                  <a:txBody>
-                    <a:bodyPr/>
-                    <a:lstStyle/>
-                    <a:p>
-                      <a:pPr algn="ctr" indent="0" marL="0">
-                        <a:buNone/>
-                      </a:pPr>
-                      <a:r>
-                        <a:rPr lang="en-US" sz="1000" dirty="0">
-                          <a:solidFill>
-                            <a:schemeClr val="accent4"/>
-                          </a:solidFill>
-                        </a:rPr>
-                        <a:t>–</a:t>
-                      </a:r>
-                      <a:endParaRPr lang="en-US" sz="1000" dirty="0"/>
-                    </a:p>
-                  </a:txBody>
-                  <a:tcPr marL="91440" marR="91440" marT="45720" marB="45720" anchor="ctr">
-                    <a:lnL w="6350" cap="flat" cmpd="sng" algn="ctr">
-                      <a:solidFill>
-                        <a:srgbClr val="D6DEE5"/>
-                      </a:solidFill>
-                      <a:prstDash val="solid"/>
-                      <a:round/>
-                      <a:headEnd type="none" w="med" len="med"/>
-                      <a:tailEnd type="none" w="med" len="med"/>
-                    </a:lnL>
-                    <a:lnR w="6350" cap="flat" cmpd="sng" algn="ctr">
-                      <a:solidFill>
-                        <a:srgbClr val="D6DEE5"/>
-                      </a:solidFill>
-                      <a:prstDash val="solid"/>
-                      <a:round/>
-                      <a:headEnd type="none" w="med" len="med"/>
-                      <a:tailEnd type="none" w="med" len="med"/>
-                    </a:lnR>
-                    <a:lnT w="6350" cap="flat" cmpd="sng" algn="ctr">
-                      <a:solidFill>
-                        <a:srgbClr val="D6DEE5"/>
-                      </a:solidFill>
-                      <a:prstDash val="solid"/>
-                      <a:round/>
-                      <a:headEnd type="none" w="med" len="med"/>
-                      <a:tailEnd type="none" w="med" len="med"/>
-                    </a:lnT>
-                    <a:lnB w="6350" cap="flat" cmpd="sng" algn="ctr">
-                      <a:solidFill>
-                        <a:srgbClr val="D6DEE5"/>
-                      </a:solidFill>
-                      <a:prstDash val="solid"/>
-                      <a:round/>
-                      <a:headEnd type="none" w="med" len="med"/>
-                      <a:tailEnd type="none" w="med" len="med"/>
-                    </a:lnB>
-                  </a:tcPr>
-                </a:tc>
-                <a:tc>
-                  <a:txBody>
-                    <a:bodyPr/>
-                    <a:lstStyle/>
-                    <a:p>
-                      <a:pPr algn="ctr" indent="0" marL="0">
-                        <a:buNone/>
-                      </a:pPr>
-                      <a:r>
-                        <a:rPr lang="en-US" sz="1000" dirty="0">
-                          <a:solidFill>
-                            <a:schemeClr val="tx1"/>
-                          </a:solidFill>
-                        </a:rPr>
-                        <a:t>€711 / €2,508 · 10.0</a:t>
-                      </a:r>
-                      <a:endParaRPr lang="en-US" sz="1000" dirty="0"/>
-                    </a:p>
-                  </a:txBody>
-                  <a:tcPr marL="91440" marR="91440" marT="45720" marB="45720" anchor="ctr">
-                    <a:lnL w="6350" cap="flat" cmpd="sng" algn="ctr">
-                      <a:solidFill>
-                        <a:srgbClr val="D6DEE5"/>
-                      </a:solidFill>
-                      <a:prstDash val="solid"/>
-                      <a:round/>
-                      <a:headEnd type="none" w="med" len="med"/>
-                      <a:tailEnd type="none" w="med" len="med"/>
-                    </a:lnL>
-                    <a:lnR w="6350" cap="flat" cmpd="sng" algn="ctr">
-                      <a:solidFill>
-                        <a:srgbClr val="D6DEE5"/>
-                      </a:solidFill>
-                      <a:prstDash val="solid"/>
-                      <a:round/>
-                      <a:headEnd type="none" w="med" len="med"/>
-                      <a:tailEnd type="none" w="med" len="med"/>
-                    </a:lnR>
-                    <a:lnT w="6350" cap="flat" cmpd="sng" algn="ctr">
-                      <a:solidFill>
-                        <a:srgbClr val="D6DEE5"/>
-                      </a:solidFill>
-                      <a:prstDash val="solid"/>
-                      <a:round/>
-                      <a:headEnd type="none" w="med" len="med"/>
-                      <a:tailEnd type="none" w="med" len="med"/>
-                    </a:lnT>
-                    <a:lnB w="6350" cap="flat" cmpd="sng" algn="ctr">
-                      <a:solidFill>
-                        <a:srgbClr val="D6DEE5"/>
-                      </a:solidFill>
-                      <a:prstDash val="solid"/>
-                      <a:round/>
-                      <a:headEnd type="none" w="med" len="med"/>
-                      <a:tailEnd type="none" w="med" len="med"/>
-                    </a:lnB>
-                    <a:solidFill>
-                      <a:srgbClr val="DCEFE8"/>
-                    </a:solidFill>
-                  </a:tcPr>
-                </a:tc>
-                <a:tc>
-                  <a:txBody>
-                    <a:bodyPr/>
-                    <a:lstStyle/>
-                    <a:p>
-                      <a:pPr algn="ctr" indent="0" marL="0">
-                        <a:buNone/>
-                      </a:pPr>
-                      <a:r>
-                        <a:rPr lang="en-US" sz="1000" dirty="0">
-                          <a:solidFill>
-                            <a:schemeClr val="tx1"/>
-                          </a:solidFill>
-                        </a:rPr>
-                        <a:t>€1,067 / €4,482 · 8.3</a:t>
-                      </a:r>
-                      <a:endParaRPr lang="en-US" sz="1000" dirty="0"/>
-                    </a:p>
-                  </a:txBody>
-                  <a:tcPr marL="91440" marR="91440" marT="45720" marB="45720" anchor="ctr">
-                    <a:lnL w="6350" cap="flat" cmpd="sng" algn="ctr">
-                      <a:solidFill>
-                        <a:srgbClr val="D6DEE5"/>
-                      </a:solidFill>
-                      <a:prstDash val="solid"/>
-                      <a:round/>
-                      <a:headEnd type="none" w="med" len="med"/>
-                      <a:tailEnd type="none" w="med" len="med"/>
-                    </a:lnL>
-                    <a:lnR w="6350" cap="flat" cmpd="sng" algn="ctr">
-                      <a:solidFill>
-                        <a:srgbClr val="D6DEE5"/>
-                      </a:solidFill>
-                      <a:prstDash val="solid"/>
-                      <a:round/>
-                      <a:headEnd type="none" w="med" len="med"/>
-                      <a:tailEnd type="none" w="med" len="med"/>
-                    </a:lnR>
-                    <a:lnT w="6350" cap="flat" cmpd="sng" algn="ctr">
-                      <a:solidFill>
-                        <a:srgbClr val="D6DEE5"/>
-                      </a:solidFill>
-                      <a:prstDash val="solid"/>
-                      <a:round/>
-                      <a:headEnd type="none" w="med" len="med"/>
-                      <a:tailEnd type="none" w="med" len="med"/>
-                    </a:lnT>
-                    <a:lnB w="6350" cap="flat" cmpd="sng" algn="ctr">
-                      <a:solidFill>
-                        <a:srgbClr val="D6DEE5"/>
-                      </a:solidFill>
-                      <a:prstDash val="solid"/>
-                      <a:round/>
-                      <a:headEnd type="none" w="med" len="med"/>
-                      <a:tailEnd type="none" w="med" len="med"/>
-                    </a:lnB>
-                    <a:solidFill>
-                      <a:srgbClr val="DCEFE8"/>
-                    </a:solidFill>
-                  </a:tcPr>
-                </a:tc>
-              </a:tr>
-              <a:tr h="329184">
-                <a:tc>
-                  <a:txBody>
-                    <a:bodyPr/>
-                    <a:lstStyle/>
-                    <a:p>
-                      <a:pPr indent="0" marL="0">
-                        <a:buNone/>
-                      </a:pPr>
-                      <a:r>
-                        <a:rPr lang="en-US" sz="1000" dirty="0">
-                          <a:solidFill>
-                            <a:schemeClr val="tx1"/>
-                          </a:solidFill>
-                        </a:rPr>
-                        <a:t>Google Search (high intent, low volume)</a:t>
-                      </a:r>
-                      <a:endParaRPr lang="en-US" sz="1000" dirty="0"/>
-                    </a:p>
-                  </a:txBody>
-                  <a:tcPr marL="91440" marR="91440" marT="45720" marB="45720" anchor="ctr">
-                    <a:lnL w="6350" cap="flat" cmpd="sng" algn="ctr">
-                      <a:solidFill>
-                        <a:srgbClr val="D6DEE5"/>
-                      </a:solidFill>
-                      <a:prstDash val="solid"/>
-                      <a:round/>
-                      <a:headEnd type="none" w="med" len="med"/>
-                      <a:tailEnd type="none" w="med" len="med"/>
-                    </a:lnL>
-                    <a:lnR w="6350" cap="flat" cmpd="sng" algn="ctr">
-                      <a:solidFill>
-                        <a:srgbClr val="D6DEE5"/>
-                      </a:solidFill>
-                      <a:prstDash val="solid"/>
-                      <a:round/>
-                      <a:headEnd type="none" w="med" len="med"/>
-                      <a:tailEnd type="none" w="med" len="med"/>
-                    </a:lnR>
-                    <a:lnT w="6350" cap="flat" cmpd="sng" algn="ctr">
-                      <a:solidFill>
-                        <a:srgbClr val="D6DEE5"/>
-                      </a:solidFill>
-                      <a:prstDash val="solid"/>
-                      <a:round/>
-                      <a:headEnd type="none" w="med" len="med"/>
-                      <a:tailEnd type="none" w="med" len="med"/>
-                    </a:lnT>
-                    <a:lnB w="6350" cap="flat" cmpd="sng" algn="ctr">
-                      <a:solidFill>
-                        <a:srgbClr val="D6DEE5"/>
-                      </a:solidFill>
-                      <a:prstDash val="solid"/>
-                      <a:round/>
-                      <a:headEnd type="none" w="med" len="med"/>
-                      <a:tailEnd type="none" w="med" len="med"/>
-                    </a:lnB>
-                  </a:tcPr>
-                </a:tc>
-                <a:tc>
-                  <a:txBody>
-                    <a:bodyPr/>
-                    <a:lstStyle/>
-                    <a:p>
-                      <a:pPr algn="ctr" indent="0" marL="0">
-                        <a:buNone/>
-                      </a:pPr>
-                      <a:r>
-                        <a:rPr lang="en-US" sz="1000" dirty="0">
-                          <a:solidFill>
-                            <a:schemeClr val="tx1"/>
-                          </a:solidFill>
-                        </a:rPr>
-                        <a:t>€1,681 / €5,336 · 0.1 T</a:t>
+                        <a:t>€778 / €3,268 · 0.2 T</a:t>
                       </a:r>
                       <a:endParaRPr lang="en-US" sz="1000" dirty="0"/>
                     </a:p>
@@ -16665,6 +16544,66 @@
                     </a:solidFill>
                   </a:tcPr>
                 </a:tc>
+              </a:tr>
+              <a:tr h="329184">
+                <a:tc>
+                  <a:txBody>
+                    <a:bodyPr/>
+                    <a:lstStyle/>
+                    <a:p>
+                      <a:pPr indent="0" marL="0">
+                        <a:buNone/>
+                      </a:pPr>
+                      <a:r>
+                        <a:rPr lang="en-US" sz="1000" dirty="0">
+                          <a:solidFill>
+                            <a:schemeClr val="tx1"/>
+                          </a:solidFill>
+                        </a:rPr>
+                        <a:t>Google Search (high intent, low volume)</a:t>
+                      </a:r>
+                      <a:endParaRPr lang="en-US" sz="1000" dirty="0"/>
+                    </a:p>
+                  </a:txBody>
+                  <a:tcPr marL="91440" marR="91440" marT="45720" marB="45720" anchor="ctr">
+                    <a:lnL w="6350" cap="flat" cmpd="sng" algn="ctr">
+                      <a:solidFill>
+                        <a:srgbClr val="D6DEE5"/>
+                      </a:solidFill>
+                      <a:prstDash val="solid"/>
+                      <a:round/>
+                      <a:headEnd type="none" w="med" len="med"/>
+                      <a:tailEnd type="none" w="med" len="med"/>
+                    </a:lnL>
+                    <a:lnR w="6350" cap="flat" cmpd="sng" algn="ctr">
+                      <a:solidFill>
+                        <a:srgbClr val="D6DEE5"/>
+                      </a:solidFill>
+                      <a:prstDash val="solid"/>
+                      <a:round/>
+                      <a:headEnd type="none" w="med" len="med"/>
+                      <a:tailEnd type="none" w="med" len="med"/>
+                    </a:lnR>
+                    <a:lnT w="6350" cap="flat" cmpd="sng" algn="ctr">
+                      <a:solidFill>
+                        <a:srgbClr val="D6DEE5"/>
+                      </a:solidFill>
+                      <a:prstDash val="solid"/>
+                      <a:round/>
+                      <a:headEnd type="none" w="med" len="med"/>
+                      <a:tailEnd type="none" w="med" len="med"/>
+                    </a:lnT>
+                    <a:lnB w="6350" cap="flat" cmpd="sng" algn="ctr">
+                      <a:solidFill>
+                        <a:srgbClr val="D6DEE5"/>
+                      </a:solidFill>
+                      <a:prstDash val="solid"/>
+                      <a:round/>
+                      <a:headEnd type="none" w="med" len="med"/>
+                      <a:tailEnd type="none" w="med" len="med"/>
+                    </a:lnB>
+                  </a:tcPr>
+                </a:tc>
                 <a:tc>
                   <a:txBody>
                     <a:bodyPr/>
@@ -16679,7 +16618,7 @@
                             <a:schemeClr val="tx1"/>
                           </a:solidFill>
                         </a:rPr>
-                        <a:t>€1,146 / €3,087 · 0.2 T</a:t>
+                        <a:t>€1,008 / €3,201 · 0.2 T</a:t>
                       </a:r>
                       <a:endParaRPr lang="en-US" sz="1000" dirty="0"/>
                     </a:p>
@@ -16740,7 +16679,7 @@
                             <a:schemeClr val="tx1"/>
                           </a:solidFill>
                         </a:rPr>
-                        <a:t>€1,681 / €5,929 · 0.1 T</a:t>
+                        <a:t>€1,008 / €2,716 · 0.3 T</a:t>
                       </a:r>
                       <a:endParaRPr lang="en-US" sz="1000" dirty="0"/>
                     </a:p>
@@ -16801,7 +16740,68 @@
                             <a:schemeClr val="tx1"/>
                           </a:solidFill>
                         </a:rPr>
-                        <a:t>€2,521 / €10,593 · 0.1 T</a:t>
+                        <a:t>€1,008 / €3,557 · 0.2 T</a:t>
+                      </a:r>
+                      <a:endParaRPr lang="en-US" sz="1000" dirty="0"/>
+                    </a:p>
+                  </a:txBody>
+                  <a:tcPr marL="91440" marR="91440" marT="45720" marB="45720" anchor="ctr">
+                    <a:lnL w="6350" cap="flat" cmpd="sng" algn="ctr">
+                      <a:solidFill>
+                        <a:srgbClr val="D6DEE5"/>
+                      </a:solidFill>
+                      <a:prstDash val="solid"/>
+                      <a:round/>
+                      <a:headEnd type="none" w="med" len="med"/>
+                      <a:tailEnd type="none" w="med" len="med"/>
+                    </a:lnL>
+                    <a:lnR w="6350" cap="flat" cmpd="sng" algn="ctr">
+                      <a:solidFill>
+                        <a:srgbClr val="D6DEE5"/>
+                      </a:solidFill>
+                      <a:prstDash val="solid"/>
+                      <a:round/>
+                      <a:headEnd type="none" w="med" len="med"/>
+                      <a:tailEnd type="none" w="med" len="med"/>
+                    </a:lnR>
+                    <a:lnT w="6350" cap="flat" cmpd="sng" algn="ctr">
+                      <a:solidFill>
+                        <a:srgbClr val="D6DEE5"/>
+                      </a:solidFill>
+                      <a:prstDash val="solid"/>
+                      <a:round/>
+                      <a:headEnd type="none" w="med" len="med"/>
+                      <a:tailEnd type="none" w="med" len="med"/>
+                    </a:lnT>
+                    <a:lnB w="6350" cap="flat" cmpd="sng" algn="ctr">
+                      <a:solidFill>
+                        <a:srgbClr val="D6DEE5"/>
+                      </a:solidFill>
+                      <a:prstDash val="solid"/>
+                      <a:round/>
+                      <a:headEnd type="none" w="med" len="med"/>
+                      <a:tailEnd type="none" w="med" len="med"/>
+                    </a:lnB>
+                    <a:solidFill>
+                      <a:srgbClr val="FBEBC8"/>
+                    </a:solidFill>
+                  </a:tcPr>
+                </a:tc>
+                <a:tc>
+                  <a:txBody>
+                    <a:bodyPr/>
+                    <a:lstStyle/>
+                    <a:p>
+                      <a:pPr algn="ctr" indent="0" marL="0">
+                        <a:buNone/>
+                      </a:pPr>
+                      <a:r>
+                        <a:rPr lang="en-US" sz="1000" dirty="0">
+                          <a:solidFill>
+                            <a:schemeClr val="tx1"/>
+                          </a:solidFill>
+                        </a:rPr>
+                        <a:t>€1,096 / €4,606 · 0.2 T</a:t>
                       </a:r>
                       <a:endParaRPr lang="en-US" sz="1000" dirty="0"/>
                     </a:p>
@@ -17066,7 +17066,7 @@
                   <a:schemeClr val="tx2"/>
                 </a:solidFill>
               </a:rPr>
-              <a:t>Cells: cost per qualified / cost per hire · hires planned. Cost per hire = (cost per application × applications + set-up) ÷ hires at full capacity; I2 includes €1,200 set-up, I3 €400 translation. StepStone ads (6 × €1,449) are costed whole and credited only the applications the plan needs (conservative).</a:t>
+              <a:t>Cells: cost per qualified / cost per hire · hires planned. Cost per hire = (cost per application × applications + set-up) ÷ hires at full capacity; I2 includes €1,200 set-up, I3 €400 translation. StepStone ads (4 × €1,449) are costed whole and credited only the applications the plan needs (conservative).</a:t>
             </a:r>
             <a:endParaRPr lang="en-US" sz="1000" dirty="0"/>
           </a:p>
@@ -17252,7 +17252,7 @@
                 <a:ea typeface="Cambria" pitchFamily="34" charset="-122"/>
                 <a:cs typeface="Cambria" pitchFamily="34" charset="-120"/>
               </a:rPr>
-              <a:t>€176.2k planned across roles and weeks, plus €31.3k reserve released on results</a:t>
+              <a:t>€99.2k planned across roles and weeks, plus €18.3k reserve released on results</a:t>
             </a:r>
             <a:endParaRPr lang="en-US" sz="2200" dirty="0"/>
           </a:p>
@@ -17321,7 +17321,7 @@
                   <a:schemeClr val="tx1"/>
                 </a:solidFill>
               </a:rPr>
-              <a:t>€140.1k paid channels (incl. €9.0k tests) + €34.6k initiative media, pre-screen calls and bonuses + €1.6k set-up = €176.2k. Reserve: 15% of €207.3k plus rounding = €31.3k.</a:t>
+              <a:t>€69.7k paid channels (incl. €9.0k tests) + €27.9k initiative media, pre-screen calls and bonuses + €1.6k set-up = €99.2k. Reserve: 15% of €116.7k plus rounding = €18.3k.</a:t>
             </a:r>
             <a:endParaRPr lang="en-US" sz="1100" dirty="0"/>
           </a:p>
@@ -17352,7 +17352,7 @@
                   <a:schemeClr val="tx1"/>
                 </a:solidFill>
               </a:rPr>
-              <a:t>weeks 1–2 cost €58.9k (28%), mostly tests. Duds are cut from Mon 2 Nov (after €500 / 30 apps); tests and the full re-allocation are judged by Mon 9 Nov; the reserve moves only from week 3. Paid media stops after Tue 24 Nov.</a:t>
+              <a:t>weeks 1–2 cost €34.1k (29%), mostly tests. Duds are cut from Mon 2 Nov (after €500 / 30 apps); tests and the full re-allocation are judged by Mon 9 Nov; the reserve moves only from week 3. Paid media stops after Tue 24 Nov.</a:t>
             </a:r>
             <a:endParaRPr lang="en-US" sz="1100" dirty="0"/>
           </a:p>
@@ -17767,7 +17767,7 @@
                             <a:schemeClr val="tx1"/>
                           </a:solidFill>
                         </a:rPr>
-                        <a:t>€70.7k</a:t>
+                        <a:t>€37.9k</a:t>
                       </a:r>
                       <a:endParaRPr lang="en-US" sz="1100" dirty="0"/>
                     </a:p>
@@ -17941,7 +17941,7 @@
                             <a:schemeClr val="tx1"/>
                           </a:solidFill>
                         </a:rPr>
-                        <a:t>€2,356</a:t>
+                        <a:t>€1,264</a:t>
                       </a:r>
                       <a:endParaRPr lang="en-US" sz="1100" dirty="0"/>
                     </a:p>
@@ -18059,7 +18059,7 @@
                             <a:schemeClr val="tx1"/>
                           </a:solidFill>
                         </a:rPr>
-                        <a:t>€33.9k</a:t>
+                        <a:t>€27.4k</a:t>
                       </a:r>
                       <a:endParaRPr lang="en-US" sz="1100" dirty="0"/>
                     </a:p>
@@ -18233,7 +18233,7 @@
                             <a:schemeClr val="tx1"/>
                           </a:solidFill>
                         </a:rPr>
-                        <a:t>€752</a:t>
+                        <a:t>€610</a:t>
                       </a:r>
                       <a:endParaRPr lang="en-US" sz="1100" dirty="0"/>
                     </a:p>
@@ -18351,7 +18351,7 @@
                             <a:schemeClr val="tx1"/>
                           </a:solidFill>
                         </a:rPr>
-                        <a:t>€32.4k</a:t>
+                        <a:t>€17.6k</a:t>
                       </a:r>
                       <a:endParaRPr lang="en-US" sz="1100" dirty="0"/>
                     </a:p>
@@ -18525,7 +18525,7 @@
                             <a:schemeClr val="tx1"/>
                           </a:solidFill>
                         </a:rPr>
-                        <a:t>€2,158</a:t>
+                        <a:t>€1,175</a:t>
                       </a:r>
                       <a:endParaRPr lang="en-US" sz="1100" dirty="0"/>
                     </a:p>
@@ -18643,7 +18643,7 @@
                             <a:schemeClr val="tx1"/>
                           </a:solidFill>
                         </a:rPr>
-                        <a:t>€39.3k</a:t>
+                        <a:t>€16.2k</a:t>
                       </a:r>
                       <a:endParaRPr lang="en-US" sz="1100" dirty="0"/>
                     </a:p>
@@ -18817,7 +18817,7 @@
                             <a:schemeClr val="tx1"/>
                           </a:solidFill>
                         </a:rPr>
-                        <a:t>€3,930</a:t>
+                        <a:t>€1,620</a:t>
                       </a:r>
                       <a:endParaRPr lang="en-US" sz="1100" dirty="0"/>
                     </a:p>
@@ -18935,7 +18935,7 @@
                             <a:schemeClr val="tx1"/>
                           </a:solidFill>
                         </a:rPr>
-                        <a:t>€176.2k</a:t>
+                        <a:t>€99.2k</a:t>
                       </a:r>
                       <a:endParaRPr lang="en-US" sz="1100" dirty="0"/>
                     </a:p>
@@ -19109,7 +19109,7 @@
                             <a:schemeClr val="tx1"/>
                           </a:solidFill>
                         </a:rPr>
-                        <a:t>€1,762</a:t>
+                        <a:t>€992</a:t>
                       </a:r>
                       <a:endParaRPr lang="en-US" sz="1100" dirty="0"/>
                     </a:p>
@@ -19563,7 +19563,7 @@
                             <a:schemeClr val="tx1"/>
                           </a:solidFill>
                         </a:rPr>
-                        <a:t>14.9</a:t>
+                        <a:t>20.3</a:t>
                       </a:r>
                       <a:endParaRPr lang="en-US" sz="1000" dirty="0"/>
                     </a:p>
@@ -19739,7 +19739,7 @@
                             <a:schemeClr val="tx1"/>
                           </a:solidFill>
                         </a:rPr>
-                        <a:t>€15.9k</a:t>
+                        <a:t>€8.5k</a:t>
                       </a:r>
                       <a:endParaRPr lang="en-US" sz="1000" dirty="0"/>
                     </a:p>
@@ -19797,7 +19797,7 @@
                             <a:schemeClr val="tx1"/>
                           </a:solidFill>
                         </a:rPr>
-                        <a:t>4.2</a:t>
+                        <a:t>3.7</a:t>
                       </a:r>
                       <a:endParaRPr lang="en-US" sz="1000" dirty="0"/>
                     </a:p>
@@ -19855,7 +19855,7 @@
                             <a:schemeClr val="tx1"/>
                           </a:solidFill>
                         </a:rPr>
-                        <a:t>€3,799</a:t>
+                        <a:t>€2,318</a:t>
                       </a:r>
                       <a:endParaRPr lang="en-US" sz="1000" dirty="0"/>
                     </a:p>
@@ -19973,7 +19973,7 @@
                             <a:schemeClr val="tx1"/>
                           </a:solidFill>
                         </a:rPr>
-                        <a:t>€8.7k</a:t>
+                        <a:t>€5.8k</a:t>
                       </a:r>
                       <a:endParaRPr lang="en-US" sz="1000" dirty="0"/>
                     </a:p>
@@ -20089,7 +20089,7 @@
                             <a:schemeClr val="tx1"/>
                           </a:solidFill>
                         </a:rPr>
-                        <a:t>€2,348</a:t>
+                        <a:t>€1,564</a:t>
                       </a:r>
                       <a:endParaRPr lang="en-US" sz="1000" dirty="0"/>
                     </a:p>
@@ -20207,7 +20207,7 @@
                             <a:schemeClr val="tx1"/>
                           </a:solidFill>
                         </a:rPr>
-                        <a:t>€62.0k</a:t>
+                        <a:t>€28.6k</a:t>
                       </a:r>
                       <a:endParaRPr lang="en-US" sz="1000" dirty="0"/>
                     </a:p>
@@ -20265,7 +20265,7 @@
                             <a:schemeClr val="tx1"/>
                           </a:solidFill>
                         </a:rPr>
-                        <a:t>18.2</a:t>
+                        <a:t>16.9</a:t>
                       </a:r>
                       <a:endParaRPr lang="en-US" sz="1000" dirty="0"/>
                     </a:p>
@@ -20323,7 +20323,7 @@
                             <a:schemeClr val="tx1"/>
                           </a:solidFill>
                         </a:rPr>
-                        <a:t>€3,404</a:t>
+                        <a:t>€1,693</a:t>
                       </a:r>
                       <a:endParaRPr lang="en-US" sz="1000" dirty="0"/>
                     </a:p>
@@ -20441,7 +20441,7 @@
                             <a:schemeClr val="tx1"/>
                           </a:solidFill>
                         </a:rPr>
-                        <a:t>€50.4k</a:t>
+                        <a:t>€23.8k</a:t>
                       </a:r>
                       <a:endParaRPr lang="en-US" sz="1000" dirty="0"/>
                     </a:p>
@@ -20499,7 +20499,7 @@
                             <a:schemeClr val="tx1"/>
                           </a:solidFill>
                         </a:rPr>
-                        <a:t>17.6</a:t>
+                        <a:t>12.0</a:t>
                       </a:r>
                       <a:endParaRPr lang="en-US" sz="1000" dirty="0"/>
                     </a:p>
@@ -20557,7 +20557,7 @@
                             <a:schemeClr val="tx1"/>
                           </a:solidFill>
                         </a:rPr>
-                        <a:t>€2,861</a:t>
+                        <a:t>€1,979</a:t>
                       </a:r>
                       <a:endParaRPr lang="en-US" sz="1000" dirty="0"/>
                     </a:p>
@@ -20733,7 +20733,7 @@
                             <a:schemeClr val="tx1"/>
                           </a:solidFill>
                         </a:rPr>
-                        <a:t>0.6</a:t>
+                        <a:t>0.9</a:t>
                       </a:r>
                       <a:endParaRPr lang="en-US" sz="1000" dirty="0"/>
                     </a:p>
@@ -20791,7 +20791,7 @@
                             <a:schemeClr val="tx1"/>
                           </a:solidFill>
                         </a:rPr>
-                        <a:t>€5,165</a:t>
+                        <a:t>€3,393</a:t>
                       </a:r>
                       <a:endParaRPr lang="en-US" sz="1000" dirty="0"/>
                     </a:p>
@@ -20909,7 +20909,7 @@
                             <a:schemeClr val="tx1"/>
                           </a:solidFill>
                         </a:rPr>
-                        <a:t>€41</a:t>
+                        <a:t>€63</a:t>
                       </a:r>
                       <a:endParaRPr lang="en-US" sz="1000" dirty="0"/>
                     </a:p>
@@ -20967,7 +20967,7 @@
                             <a:schemeClr val="tx1"/>
                           </a:solidFill>
                         </a:rPr>
-                        <a:t>3.1</a:t>
+                        <a:t>4.8</a:t>
                       </a:r>
                       <a:endParaRPr lang="en-US" sz="1000" dirty="0"/>
                     </a:p>
@@ -21377,7 +21377,7 @@
                             <a:schemeClr val="tx1"/>
                           </a:solidFill>
                         </a:rPr>
-                        <a:t>€18.0k</a:t>
+                        <a:t>€11.3k</a:t>
                       </a:r>
                       <a:endParaRPr lang="en-US" sz="1000" dirty="0"/>
                     </a:p>
@@ -21493,7 +21493,7 @@
                             <a:schemeClr val="tx1"/>
                           </a:solidFill>
                         </a:rPr>
-                        <a:t>€2,116</a:t>
+                        <a:t>€1,326</a:t>
                       </a:r>
                       <a:endParaRPr lang="en-US" sz="1000" dirty="0"/>
                     </a:p>
@@ -21920,7 +21920,7 @@
                 <a:ea typeface="Cambria" pitchFamily="34" charset="-122"/>
                 <a:cs typeface="Cambria" pitchFamily="34" charset="-120"/>
               </a:rPr>
-              <a:t>30% less (€145.25k) still signs ~88; supervisors take most of the loss</a:t>
+              <a:t>30% less (€82.25k) still signs ~87; electricians take most of the loss</a:t>
             </a:r>
             <a:endParaRPr lang="en-US" sz="2200" dirty="0"/>
           </a:p>
@@ -22169,7 +22169,7 @@
                             <a:schemeClr val="tx1"/>
                           </a:solidFill>
                         </a:rPr>
-                        <a:t>100% · €207.50k</a:t>
+                        <a:t>100% · €117.50k</a:t>
                       </a:r>
                       <a:endParaRPr lang="en-US" sz="1100" dirty="0"/>
                     </a:p>
@@ -22285,7 +22285,7 @@
                             <a:schemeClr val="tx1"/>
                           </a:solidFill>
                         </a:rPr>
-                        <a:t>€2,075</a:t>
+                        <a:t>€1,175</a:t>
                       </a:r>
                       <a:endParaRPr lang="en-US" sz="1100" dirty="0"/>
                     </a:p>
@@ -22345,7 +22345,7 @@
                             <a:schemeClr val="tx1"/>
                           </a:solidFill>
                         </a:rPr>
-                        <a:t>85% · €176.38k</a:t>
+                        <a:t>85% · €99.88k</a:t>
                       </a:r>
                       <a:endParaRPr lang="en-US" sz="1100" dirty="0"/>
                     </a:p>
@@ -22461,7 +22461,7 @@
                             <a:schemeClr val="tx1"/>
                           </a:solidFill>
                         </a:rPr>
-                        <a:t>€1,869</a:t>
+                        <a:t>€1,060</a:t>
                       </a:r>
                       <a:endParaRPr lang="en-US" sz="1100" dirty="0"/>
                     </a:p>
@@ -22521,7 +22521,7 @@
                             <a:schemeClr val="tx1"/>
                           </a:solidFill>
                         </a:rPr>
-                        <a:t>70% · €145.25k</a:t>
+                        <a:t>70% · €82.25k</a:t>
                       </a:r>
                       <a:endParaRPr lang="en-US" sz="1100" dirty="0"/>
                     </a:p>
@@ -22579,7 +22579,7 @@
                             <a:schemeClr val="tx1"/>
                           </a:solidFill>
                         </a:rPr>
-                        <a:t>88</a:t>
+                        <a:t>87</a:t>
                       </a:r>
                       <a:endParaRPr lang="en-US" sz="1100" dirty="0"/>
                     </a:p>
@@ -22637,7 +22637,7 @@
                             <a:schemeClr val="tx1"/>
                           </a:solidFill>
                         </a:rPr>
-                        <a:t>€1,651</a:t>
+                        <a:t>€946</a:t>
                       </a:r>
                       <a:endParaRPr lang="en-US" sz="1100" dirty="0"/>
                     </a:p>
@@ -22697,7 +22697,7 @@
                             <a:schemeClr val="tx1"/>
                           </a:solidFill>
                         </a:rPr>
-                        <a:t>50% · €103.75k</a:t>
+                        <a:t>50% · €58.75k</a:t>
                       </a:r>
                       <a:endParaRPr lang="en-US" sz="1100" dirty="0"/>
                     </a:p>
@@ -22755,7 +22755,7 @@
                             <a:schemeClr val="tx1"/>
                           </a:solidFill>
                         </a:rPr>
-                        <a:t>78</a:t>
+                        <a:t>76</a:t>
                       </a:r>
                       <a:endParaRPr lang="en-US" sz="1100" dirty="0"/>
                     </a:p>
@@ -22813,7 +22813,7 @@
                             <a:schemeClr val="tx1"/>
                           </a:solidFill>
                         </a:rPr>
-                        <a:t>€1,328</a:t>
+                        <a:t>€770</a:t>
                       </a:r>
                       <a:endParaRPr lang="en-US" sz="1100" dirty="0"/>
                     </a:p>
@@ -22964,7 +22964,7 @@
                   <a:schemeClr val="tx1"/>
                 </a:solidFill>
               </a:rPr>
-              <a:t>at −30%: supervisors 1.6 of 10, electricians 27.1 of 30, automation 14.3 of 15. Mechatronics never falls short.</a:t>
+              <a:t>at −30%: electricians 20.7 of 30, supervisors 7.0 of 10, automation 14.5 of 15, mechatronics 44.7 of 45. Mechatronics slips to 44.7.</a:t>
             </a:r>
             <a:endParaRPr lang="en-US" sz="1200" dirty="0"/>
           </a:p>
@@ -22995,7 +22995,7 @@
                   <a:schemeClr val="tx1"/>
                 </a:solidFill>
               </a:rPr>
-              <a:t>the last €62.25k buys ~12 hires at ~€5,190 each, mostly supervisors. If you must cut, cover supervisors through internal promotion and protect electricians, the role that keeps lines running. Above €207.5k, extra money buys at most ~2 more hires (the 6 spare slots); then the 55/week limit binds.</a:t>
+              <a:t>the last €35.25k buys ~13 hires at ~€2,700 each, mostly electricians, the role that keeps lines running. Keep it. If you must cut, cover supervisors through internal promotion and protect electricians. Above €117.5k, extra money buys at most ~2 more hires (the 6 spare slots); then the 55/week limit binds.</a:t>
             </a:r>
             <a:endParaRPr lang="en-US" sz="1200" dirty="0"/>
           </a:p>
@@ -23145,7 +23145,7 @@
                 <a:ea typeface="Cambria" pitchFamily="34" charset="-122"/>
                 <a:cs typeface="Cambria" pitchFamily="34" charset="-120"/>
               </a:rPr>
-              <a:t>Three new sources supply ~41 of the 100 hires, one built for electricians</a:t>
+              <a:t>Three new sources supply ~43 of the 100 hires, one built for electricians</a:t>
             </a:r>
             <a:endParaRPr lang="en-US" sz="2200" dirty="0"/>
           </a:p>
@@ -23285,7 +23285,7 @@
                   <a:schemeClr val="tx1"/>
                 </a:solidFill>
               </a:rPr>
-              <a:t>136 runners-up from the last year (consented talent pool); the plant's 10,703 staff as referrers</a:t>
+              <a:t>211 runners-up from the last year (consented talent pool); the plant's 10,703 staff as referrers</a:t>
             </a:r>
             <a:endParaRPr lang="en-US" sz="1200" dirty="0"/>
           </a:p>
@@ -23378,7 +23378,7 @@
                   <a:schemeClr val="tx1"/>
                 </a:solidFill>
               </a:rPr>
-              <a:t>€41 + €11.2k bonuses → 16 re-apps + 66 referrals → ~38 qualified → ~14 hires</a:t>
+              <a:t>€63 + €11.2k bonuses → 25 re-apps + 66 referrals → ~42 qualified → ~16 hires</a:t>
             </a:r>
             <a:endParaRPr lang="en-US" sz="1200" dirty="0"/>
           </a:p>
@@ -23409,7 +23409,7 @@
                   <a:schemeClr val="tx1"/>
                 </a:solidFill>
               </a:rPr>
-              <a:t>Wed 21 Oct – Tue 3 Nov (waves 1–3): €41. Pass: ≥8 qualified (≥⅓ electricians). Kill: &lt;5 → no further re-contacts; bonus stays live</a:t>
+              <a:t>Wed 21 Oct – Tue 3 Nov (waves 1–3): €63. Pass: ≥12 qualified. Kill: &lt;9 → no further re-contacts; bonus stays live</a:t>
             </a:r>
             <a:endParaRPr lang="en-US" sz="1200" dirty="0"/>
           </a:p>
@@ -23673,7 +23673,7 @@
                   <a:schemeClr val="tx1"/>
                 </a:solidFill>
               </a:rPr>
-              <a:t>200 apps × €84 = €16.8k + €1.2k set-up → 30 qualified × 28% = 8.5 hires (€2,116/hire)</a:t>
+              <a:t>120 apps × €84 = €10.1k + €1.2k set-up → 30 qualified × 28% = 8.5 hires (€1,326/hire)</a:t>
             </a:r>
             <a:endParaRPr lang="en-US" sz="1200" dirty="0"/>
           </a:p>
@@ -23704,7 +23704,7 @@
                   <a:schemeClr val="tx1"/>
                 </a:solidFill>
               </a:rPr>
-              <a:t>Fri 23 Oct – Thu 5 Nov (read Mon 9 Nov): €6.0k. Pass: ≥5 qualified at ≤€700. Kill: &lt;3, &gt;€840 per qualified, or profile rejected; week 4: &lt;40% interview pass</a:t>
+              <a:t>Fri 23 Oct – Thu 5 Nov (read Mon 9 Nov): €4.0k. Pass: ≥4 qualified at ≤€500. Kill: &lt;2, &gt;€670 per qualified, or profile rejected; week 4: interview pass below the planned 45% once ≥10 interviews are in</a:t>
             </a:r>
             <a:endParaRPr lang="en-US" sz="1200" dirty="0"/>
           </a:p>
@@ -23999,7 +23999,7 @@
                   <a:schemeClr val="tx1"/>
                 </a:solidFill>
               </a:rPr>
-              <a:t>Tue 27 Oct – Mon 9 Nov (freelancer starts 27 Oct): €2.5k. Pass: ≥9 qualified at ≤€170. Kill: &lt;5, &gt;€200 per qualified, or &lt;30% pass the language check</a:t>
+              <a:t>Tue 27 Oct – Mon 9 Nov (freelancer starts 27 Oct): €2.5k. Pass: ≥10 qualified at ≤€200. Kill: &lt;7, &gt;€270 per qualified, or fewer than the planned 14% pass the language call after 30 calls</a:t>
             </a:r>
             <a:endParaRPr lang="en-US" sz="1200" dirty="0"/>
           </a:p>
@@ -24077,7 +24077,7 @@
                   <a:schemeClr val="tx1"/>
                 </a:solidFill>
               </a:rPr>
-              <a:t>Every employer may keep consenting runners-up for up to a year, and they are rarely re-marketed to. Here 136 records cost ~€13 per hire and fill week-1 slots before paid channels warm up. Joveo already matches jobs to supply programmatically. Adding a consented rediscovery source, tracked to hire with the same source tags, is repeatable in any market without local staff.</a:t>
+              <a:t>Every employer may keep consenting runners-up for up to a year, and they are rarely re-marketed to. Here 211 records cost ~€13 per hire and fill week-1 slots before paid channels warm up. Joveo already matches jobs to supply programmatically. Adding a consented rediscovery source, tracked to hire with the same source tags, is repeatable in any market without local staff.</a:t>
             </a:r>
             <a:endParaRPr lang="en-US" sz="1200" dirty="0"/>
           </a:p>
@@ -24473,7 +24473,7 @@
                   <a:schemeClr val="tx1"/>
                 </a:solidFill>
               </a:rPr>
-              <a:t>No judgement before €500 / 30 apps (tests run to €750). Updated Q = (qual + 30 × plan) ÷ (apps + 30). Cost per qualified ≤0.8× plan with free slots → +25%/wk from reserve; ≥1.5× → cut 50%; ≥2× → off. Zero qualified at €750 → off where ≥3 were expected; low-yield cells → off if applications are &lt;50% of plan. Next week forecast &gt;55 qualified → pause the costliest cells; &lt;45 → release reserve.</a:t>
+              <a:t>No judgement before €500 / 30 apps (tests run to €750). Updated Q = (qual + 30 × plan) ÷ (apps + 30). Cost per qualified ≤0.75× plan with free slots → +25%/wk from reserve; ≥1.5× → cut 50%; ≥2× → off. Zero qualified at €750 → off where ≥3 were expected; low-yield cells → off if applications are &lt;50% of plan. Next week forecast &gt;55 qualified → pause the costliest cells; &lt;47 → release reserve.</a:t>
             </a:r>
             <a:endParaRPr lang="en-US" sz="1250" dirty="0"/>
           </a:p>
@@ -24596,7 +24596,7 @@
                   <a:schemeClr val="tx1"/>
                 </a:solidFill>
               </a:rPr>
-              <a:t>1) Pass rate on the week-1 cohort (interviews 29 Oct–2 Nov), the most sensitive input: if &lt;45% → tighter knock-outs, pre-screen calls, ask +10 slots, re-run the model. 2) Electrician supply: profile decision + I2's two-week read on 9 Nov; if killed → programmatic picks up the gap: all 30 still possible (model run with I2 off), budget €225.0k, electricians at €2,829 per hire. 3) The 12 tests' cost per application and share qualified → re-rank on Assumptions §7. Week 4 (16 Nov): acceptance &lt;55% → earlier cut-off + signing bonus.</a:t>
+              <a:t>1) Pass rate on the week-1 cohort (interviews 29 Oct–2 Nov), the most sensitive input: if below plan (electricians 50%) once ≥10 interviews are in → tighter knock-outs, pre-screen calls, ask +9 slots, re-run the model (pass 10% worse = ~92 hires). 2) Electrician supply: profile decision + I2's two-week read on 9 Nov; if killed → programmatic picks up the gap: all 30 still possible (model run with I2 off), budget €127.5k, electricians at €1,532 per hire. 3) The 12 tests' cost per application and share qualified → re-rank on Assumptions §7. Week 4 (16 Nov): acceptance below plan (70%) once ≥7 offers are out → earlier cut-off + signing bonus.</a:t>
             </a:r>
             <a:endParaRPr lang="en-US" sz="1250" dirty="0"/>
           </a:p>

</xml_diff>

<commit_message>
Verify BMJ and NIST sources; F4 back to 90% from the verified source; clean full test run
Co-Authored-By: Claude Opus 5.5 <noreply@anthropic.com>
Claude-Session: https://claude.ai/code/session_01V2NJtrYy3bzNxqKeiRXJfY
</commit_message>
<xml_diff>
--- a/operation_uptime/Operation_Uptime_Deck.pptx
+++ b/operation_uptime/Operation_Uptime_Deck.pptx
@@ -114,30 +114,30 @@
   <p:extLst>
     <p:ext uri="{521415D9-36F7-43E2-AB2F-B90AF26B5E84}">
       <p14:sectionLst xmlns:p14="http://schemas.microsoft.com/office/powerpoint/2010/main">
-        <p14:section name="Summary" id="{b5206f16-7ef7-5e8f-5b97-a2281e36dda5}">
+        <p14:section name="Summary" id="{1fcf6e0f-dd7b-1c8a-d91b-49fd30472ba7}">
           <p14:sldIdLst>
             <p14:sldId id="256"/>
           </p14:sldIdLst>
         </p14:section>
-        <p14:section name="Part 1 Funnel" id="{a4a93b05-1ac7-e866-a8e2-08c32e5adc77}">
+        <p14:section name="Part 1 Funnel" id="{f4483b49-6276-932f-511c-bf1b063d8899}">
           <p14:sldIdLst>
             <p14:sldId id="257"/>
             <p14:sldId id="258"/>
           </p14:sldIdLst>
         </p14:section>
-        <p14:section name="Part 2 Channels &amp; budget" id="{b95f9b78-760f-da98-8859-d4736eebed2d}">
+        <p14:section name="Part 2 Channels &amp; budget" id="{e6f3d0d1-af6d-b401-95ed-760ba5fd2496}">
           <p14:sldIdLst>
             <p14:sldId id="259"/>
             <p14:sldId id="260"/>
             <p14:sldId id="261"/>
           </p14:sldIdLst>
         </p14:section>
-        <p14:section name="Part 3 New sources" id="{00b2a2b2-5d6b-340f-c280-4390cbd11ada}">
+        <p14:section name="Part 3 New sources" id="{90b73861-fa43-3e79-1a39-cdbbc9b8caa8}">
           <p14:sldIdLst>
             <p14:sldId id="262"/>
           </p14:sldIdLst>
         </p14:section>
-        <p14:section name="Part 4 Run it" id="{7779d167-52e6-e63b-e9ed-2e16521153a4}">
+        <p14:section name="Part 4 Run it" id="{991bbb75-c7b7-8241-b263-874fee82182f}">
           <p14:sldIdLst>
             <p14:sldId id="263"/>
           </p14:sldIdLst>
@@ -24473,7 +24473,7 @@
                   <a:schemeClr val="tx1"/>
                 </a:solidFill>
               </a:rPr>
-              <a:t>No judgement before €500 / 30 apps (tests run to €750). Updated Q = (qual + 30 × plan) ÷ (apps + 30). Cost per qualified ≤0.75× plan with free slots → +25%/wk from reserve; ≥1.5× → cut 50%; ≥2× → off. Zero qualified at €750 → off where ≥3 were expected; low-yield cells → off if applications are &lt;50% of plan. Next week forecast &gt;55 qualified → pause the costliest cells; &lt;47 → release reserve.</a:t>
+              <a:t>No judgement before €500 / 30 apps (tests run to €750). Updated Q = (qual + 30 × plan) ÷ (apps + 30). Cost per qualified ≤0.75× plan with free slots → +25%/wk from reserve; ≥1.5× → cut 50%; ≥2× → off. Zero qualified at €750 → off where ≥3 were expected; low-yield cells → off if applications are &lt;50% of plan. Next week forecast &gt;55 qualified → pause the costliest cells; &lt;50 → release reserve.</a:t>
             </a:r>
             <a:endParaRPr lang="en-US" sz="1250" dirty="0"/>
           </a:p>

</xml_diff>

<commit_message>
Live formulas for all derived inputs; CEO Q&A prep; Joveo upside and legal facts on Polish/electrician routes
Co-Authored-By: Claude Opus 5.5 <noreply@anthropic.com>
Claude-Session: https://claude.ai/code/session_01V2NJtrYy3bzNxqKeiRXJfY
</commit_message>
<xml_diff>
--- a/operation_uptime/Operation_Uptime_Deck.pptx
+++ b/operation_uptime/Operation_Uptime_Deck.pptx
@@ -114,30 +114,30 @@
   <p:extLst>
     <p:ext uri="{521415D9-36F7-43E2-AB2F-B90AF26B5E84}">
       <p14:sectionLst xmlns:p14="http://schemas.microsoft.com/office/powerpoint/2010/main">
-        <p14:section name="Summary" id="{1fcf6e0f-dd7b-1c8a-d91b-49fd30472ba7}">
+        <p14:section name="Summary" id="{419a3669-44ab-ed75-820e-f6c8f08a2b0e}">
           <p14:sldIdLst>
             <p14:sldId id="256"/>
           </p14:sldIdLst>
         </p14:section>
-        <p14:section name="Part 1 Funnel" id="{f4483b49-6276-932f-511c-bf1b063d8899}">
+        <p14:section name="Part 1 Funnel" id="{e5bfc387-1ed4-ea49-35f0-167cec35a232}">
           <p14:sldIdLst>
             <p14:sldId id="257"/>
             <p14:sldId id="258"/>
           </p14:sldIdLst>
         </p14:section>
-        <p14:section name="Part 2 Channels &amp; budget" id="{e6f3d0d1-af6d-b401-95ed-760ba5fd2496}">
+        <p14:section name="Part 2 Channels &amp; budget" id="{a2038b24-3a39-9e48-6d88-ba19ad61abfb}">
           <p14:sldIdLst>
             <p14:sldId id="259"/>
             <p14:sldId id="260"/>
             <p14:sldId id="261"/>
           </p14:sldIdLst>
         </p14:section>
-        <p14:section name="Part 3 New sources" id="{90b73861-fa43-3e79-1a39-cdbbc9b8caa8}">
+        <p14:section name="Part 3 New sources" id="{b7a4091e-7f74-17cc-a65f-334645a97f69}">
           <p14:sldIdLst>
             <p14:sldId id="262"/>
           </p14:sldIdLst>
         </p14:section>
-        <p14:section name="Part 4 Run it" id="{991bbb75-c7b7-8241-b263-874fee82182f}">
+        <p14:section name="Part 4 Run it" id="{8171a141-a7a8-3c7e-ddc6-512fe70ab195}">
           <p14:sldIdLst>
             <p14:sldId id="263"/>
           </p14:sldIdLst>
@@ -1107,22 +1107,22 @@
                 <c:formatCode>General</c:formatCode>
                 <c:ptCount val="9"/>
                 <c:pt idx="0">
-                  <c:v>6808</c:v>
+                  <c:v>6858</c:v>
                 </c:pt>
                 <c:pt idx="1">
-                  <c:v>10925</c:v>
+                  <c:v>11006</c:v>
                 </c:pt>
                 <c:pt idx="2">
-                  <c:v>13546</c:v>
+                  <c:v>13646</c:v>
                 </c:pt>
                 <c:pt idx="3">
-                  <c:v>13539</c:v>
+                  <c:v>13639</c:v>
                 </c:pt>
                 <c:pt idx="4">
-                  <c:v>13915</c:v>
+                  <c:v>14018</c:v>
                 </c:pt>
                 <c:pt idx="5">
-                  <c:v>12822</c:v>
+                  <c:v>13247</c:v>
                 </c:pt>
                 <c:pt idx="6">
                   <c:v>0</c:v>
@@ -1354,22 +1354,22 @@
                   <c:v>0</c:v>
                 </c:pt>
                 <c:pt idx="3">
-                  <c:v>944</c:v>
+                  <c:v>888</c:v>
                 </c:pt>
                 <c:pt idx="4">
-                  <c:v>1606</c:v>
+                  <c:v>1559</c:v>
                 </c:pt>
                 <c:pt idx="5">
-                  <c:v>2026</c:v>
+                  <c:v>1983</c:v>
                 </c:pt>
                 <c:pt idx="6">
-                  <c:v>2059</c:v>
+                  <c:v>2032</c:v>
                 </c:pt>
                 <c:pt idx="7">
-                  <c:v>2111</c:v>
+                  <c:v>2082</c:v>
                 </c:pt>
                 <c:pt idx="8">
-                  <c:v>2483</c:v>
+                  <c:v>2434</c:v>
                 </c:pt>
               </c:numCache>
             </c:numRef>
@@ -1656,13 +1656,13 @@
                   <c:v>30</c:v>
                 </c:pt>
                 <c:pt idx="1">
-                  <c:v>25.4</c:v>
+                  <c:v>25.1</c:v>
                 </c:pt>
                 <c:pt idx="2">
-                  <c:v>20.7</c:v>
+                  <c:v>20.6</c:v>
                 </c:pt>
                 <c:pt idx="3">
-                  <c:v>20.7</c:v>
+                  <c:v>20.6</c:v>
                 </c:pt>
               </c:numCache>
             </c:numRef>
@@ -1752,7 +1752,7 @@
                   <c:v>44.7</c:v>
                 </c:pt>
                 <c:pt idx="3">
-                  <c:v>38.6</c:v>
+                  <c:v>37.8</c:v>
                 </c:pt>
               </c:numCache>
             </c:numRef>
@@ -1929,10 +1929,10 @@
                   <c:v>9.6</c:v>
                 </c:pt>
                 <c:pt idx="2">
-                  <c:v>7</c:v>
+                  <c:v>6.8</c:v>
                 </c:pt>
                 <c:pt idx="3">
-                  <c:v>2.4</c:v>
+                  <c:v>3</c:v>
                 </c:pt>
               </c:numCache>
             </c:numRef>
@@ -3862,7 +3862,7 @@
                   <a:schemeClr val="tx2"/>
                 </a:solidFill>
               </a:rPr>
-              <a:t>recommended budget: €99.2k planned + €18.3k reserve released only on results</a:t>
+              <a:t>recommended budget: €99.8k planned + €17.7k reserve released only on results</a:t>
             </a:r>
             <a:endParaRPr lang="en-US" sz="1000" dirty="0"/>
           </a:p>
@@ -3928,7 +3928,7 @@
                 <a:ea typeface="Cambria" pitchFamily="34" charset="-122"/>
                 <a:cs typeface="Cambria" pitchFamily="34" charset="-120"/>
               </a:rPr>
-              <a:t>€992</a:t>
+              <a:t>€998</a:t>
             </a:r>
             <a:endParaRPr lang="en-US" sz="2600" dirty="0"/>
           </a:p>
@@ -4237,7 +4237,7 @@
                   <a:schemeClr val="tx1"/>
                 </a:solidFill>
               </a:rPr>
-              <a:t>(€82.25k): ~87 hires; electricians fall short first (20.7 of 30).</a:t>
+              <a:t>(€82.25k): ~87 hires; electricians fall short first (20.6 of 30).</a:t>
             </a:r>
             <a:endParaRPr lang="en-US" sz="1100" dirty="0"/>
           </a:p>
@@ -4762,7 +4762,7 @@
                           <a:ea typeface="Calibri" pitchFamily="34" charset="-122"/>
                           <a:cs typeface="Calibri" pitchFamily="34" charset="-120"/>
                         </a:rPr>
-                        <a:t>€37.9k</a:t>
+                        <a:t>€38.0k</a:t>
                       </a:r>
                       <a:endParaRPr lang="en-US" sz="1000" dirty="0">
                         <a:latin typeface="Calibri" charset="0"/>
@@ -4827,7 +4827,7 @@
                           <a:ea typeface="Calibri" pitchFamily="34" charset="-122"/>
                           <a:cs typeface="Calibri" pitchFamily="34" charset="-120"/>
                         </a:rPr>
-                        <a:t>€1,264</a:t>
+                        <a:t>€1,266</a:t>
                       </a:r>
                       <a:endParaRPr lang="en-US" sz="1000" dirty="0">
                         <a:latin typeface="Calibri" charset="0"/>
@@ -4892,7 +4892,7 @@
                           <a:ea typeface="Calibri" pitchFamily="34" charset="-122"/>
                           <a:cs typeface="Calibri" pitchFamily="34" charset="-120"/>
                         </a:rPr>
-                        <a:t>Handwerk→Industrie 8.5 · Meta 6.3 · organic 5.9 · referrals 3.3 · programmatic 2.8 · other 3.3</a:t>
+                        <a:t>Handwerk→Industrie 8.4 · Meta 6.3 · organic 5.9 · referrals 3.3 · programmatic 2.9 · other 3.3</a:t>
                       </a:r>
                       <a:endParaRPr lang="en-US" sz="900" dirty="0">
                         <a:latin typeface="Calibri" charset="0"/>
@@ -5089,7 +5089,7 @@
                           <a:ea typeface="Calibri" pitchFamily="34" charset="-122"/>
                           <a:cs typeface="Calibri" pitchFamily="34" charset="-120"/>
                         </a:rPr>
-                        <a:t>€27.4k</a:t>
+                        <a:t>€28.9k</a:t>
                       </a:r>
                       <a:endParaRPr lang="en-US" sz="1000" dirty="0">
                         <a:latin typeface="Calibri" charset="0"/>
@@ -5154,7 +5154,7 @@
                           <a:ea typeface="Calibri" pitchFamily="34" charset="-122"/>
                           <a:cs typeface="Calibri" pitchFamily="34" charset="-120"/>
                         </a:rPr>
-                        <a:t>€610</a:t>
+                        <a:t>€643</a:t>
                       </a:r>
                       <a:endParaRPr lang="en-US" sz="1000" dirty="0">
                         <a:latin typeface="Calibri" charset="0"/>
@@ -5219,7 +5219,7 @@
                           <a:ea typeface="Calibri" pitchFamily="34" charset="-122"/>
                           <a:cs typeface="Calibri" pitchFamily="34" charset="-120"/>
                         </a:rPr>
-                        <a:t>Polish corridor 18.0 · organic 10.4 · referrals 5.8 · Meta 5.7 · rediscovery 2.4 · other 2.7</a:t>
+                        <a:t>Polish corridor 18.0 · organic 10.4 · Meta 7.0 · referrals 5.0 · StepStone 2.0 · other 2.6</a:t>
                       </a:r>
                       <a:endParaRPr lang="en-US" sz="900" dirty="0">
                         <a:latin typeface="Calibri" charset="0"/>
@@ -5416,7 +5416,7 @@
                           <a:ea typeface="Calibri" pitchFamily="34" charset="-122"/>
                           <a:cs typeface="Calibri" pitchFamily="34" charset="-120"/>
                         </a:rPr>
-                        <a:t>€17.6k</a:t>
+                        <a:t>€17.4k</a:t>
                       </a:r>
                       <a:endParaRPr lang="en-US" sz="1000" dirty="0">
                         <a:latin typeface="Calibri" charset="0"/>
@@ -5481,7 +5481,7 @@
                           <a:ea typeface="Calibri" pitchFamily="34" charset="-122"/>
                           <a:cs typeface="Calibri" pitchFamily="34" charset="-120"/>
                         </a:rPr>
-                        <a:t>€1,175</a:t>
+                        <a:t>€1,158</a:t>
                       </a:r>
                       <a:endParaRPr lang="en-US" sz="1000" dirty="0">
                         <a:latin typeface="Calibri" charset="0"/>
@@ -5546,7 +5546,7 @@
                           <a:ea typeface="Calibri" pitchFamily="34" charset="-122"/>
                           <a:cs typeface="Calibri" pitchFamily="34" charset="-120"/>
                         </a:rPr>
-                        <a:t>LinkedIn 9.7 · organic 2.7 · referrals 1.5 · rediscovery 0.6 · tests 0.5</a:t>
+                        <a:t>LinkedIn 9.5 · organic 2.7 · referrals 1.6 · rediscovery 0.7 · tests 0.5</a:t>
                       </a:r>
                       <a:endParaRPr lang="en-US" sz="900" dirty="0">
                         <a:latin typeface="Calibri" charset="0"/>
@@ -5743,7 +5743,7 @@
                           <a:ea typeface="Calibri" pitchFamily="34" charset="-122"/>
                           <a:cs typeface="Calibri" pitchFamily="34" charset="-120"/>
                         </a:rPr>
-                        <a:t>€16.2k</a:t>
+                        <a:t>€15.5k</a:t>
                       </a:r>
                       <a:endParaRPr lang="en-US" sz="1000" dirty="0">
                         <a:latin typeface="Calibri" charset="0"/>
@@ -5808,7 +5808,7 @@
                           <a:ea typeface="Calibri" pitchFamily="34" charset="-122"/>
                           <a:cs typeface="Calibri" pitchFamily="34" charset="-120"/>
                         </a:rPr>
-                        <a:t>€1,620</a:t>
+                        <a:t>€1,550</a:t>
                       </a:r>
                       <a:endParaRPr lang="en-US" sz="1000" dirty="0">
                         <a:latin typeface="Calibri" charset="0"/>
@@ -5873,7 +5873,7 @@
                           <a:ea typeface="Calibri" pitchFamily="34" charset="-122"/>
                           <a:cs typeface="Calibri" pitchFamily="34" charset="-120"/>
                         </a:rPr>
-                        <a:t>LinkedIn 7.2 · organic 1.4 · referrals 0.7 · tests 0.4 · rediscovery 0.3</a:t>
+                        <a:t>LinkedIn 6.6 · organic 1.4 · referrals 1.1 · rediscovery 0.5 · tests 0.4</a:t>
                       </a:r>
                       <a:endParaRPr lang="en-US" sz="900" dirty="0">
                         <a:latin typeface="Calibri" charset="0"/>
@@ -6070,7 +6070,7 @@
                           <a:ea typeface="Calibri" pitchFamily="34" charset="-122"/>
                           <a:cs typeface="Calibri" pitchFamily="34" charset="-120"/>
                         </a:rPr>
-                        <a:t>€99.2k</a:t>
+                        <a:t>€99.8k</a:t>
                       </a:r>
                       <a:endParaRPr lang="en-US" sz="1000" dirty="0">
                         <a:latin typeface="Calibri" charset="0"/>
@@ -6135,7 +6135,7 @@
                           <a:ea typeface="Calibri" pitchFamily="34" charset="-122"/>
                           <a:cs typeface="Calibri" pitchFamily="34" charset="-120"/>
                         </a:rPr>
-                        <a:t>€992</a:t>
+                        <a:t>€998</a:t>
                       </a:r>
                       <a:endParaRPr lang="en-US" sz="1000" dirty="0">
                         <a:latin typeface="Calibri" charset="0"/>
@@ -6200,7 +6200,7 @@
                           <a:ea typeface="Calibri" pitchFamily="34" charset="-122"/>
                           <a:cs typeface="Calibri" pitchFamily="34" charset="-120"/>
                         </a:rPr>
-                        <a:t>+ €18.3k reserve = €117.5k</a:t>
+                        <a:t>+ €17.7k reserve = €117.5k</a:t>
                       </a:r>
                       <a:endParaRPr lang="en-US" sz="900" dirty="0">
                         <a:latin typeface="Calibri" charset="0"/>
@@ -6465,7 +6465,7 @@
                   <a:schemeClr val="tx1"/>
                 </a:solidFill>
               </a:rPr>
-              <a:t>~9 of 30 need your OK on construction electricians by 23 Oct; without them programmatic ads fill the gap and the budget rises to €127.5k.</a:t>
+              <a:t>~8 of 30 need your OK on construction electricians by 23 Oct; without them programmatic ads fill the gap and the budget rises to €127.5k.</a:t>
             </a:r>
             <a:endParaRPr lang="en-US" sz="1100" dirty="0"/>
           </a:p>
@@ -10079,7 +10079,7 @@
                   <a:schemeClr val="tx1"/>
                 </a:solidFill>
               </a:rPr>
-              <a:t>308 qualified / 1,608 applications</a:t>
+              <a:t>308 qualified / 1,619 applications</a:t>
             </a:r>
             <a:pPr indent="0" marL="0">
               <a:buNone/>
@@ -11866,7 +11866,7 @@
                             <a:schemeClr val="tx1"/>
                           </a:solidFill>
                         </a:rPr>
-                        <a:t>3.9×</a:t>
+                        <a:t>4.0×</a:t>
                       </a:r>
                       <a:endParaRPr lang="en-US" sz="1100" dirty="0"/>
                     </a:p>
@@ -11924,7 +11924,7 @@
                             <a:schemeClr val="tx1"/>
                           </a:solidFill>
                         </a:rPr>
-                        <a:t>3.9×</a:t>
+                        <a:t>4.0×</a:t>
                       </a:r>
                       <a:endParaRPr lang="en-US" sz="1100" dirty="0"/>
                     </a:p>
@@ -14277,7 +14277,7 @@
                             <a:schemeClr val="tx1"/>
                           </a:solidFill>
                         </a:rPr>
-                        <a:t>€5 / €12 · 2.4</a:t>
+                        <a:t>€5 / €12 · 1.9</a:t>
                       </a:r>
                       <a:endParaRPr lang="en-US" sz="1000" dirty="0"/>
                     </a:p>
@@ -14338,7 +14338,7 @@
                             <a:schemeClr val="tx1"/>
                           </a:solidFill>
                         </a:rPr>
-                        <a:t>€5 / €15 · 0.6</a:t>
+                        <a:t>€5 / €15 · 0.7</a:t>
                       </a:r>
                       <a:endParaRPr lang="en-US" sz="1000" dirty="0"/>
                     </a:p>
@@ -14399,7 +14399,7 @@
                             <a:schemeClr val="tx1"/>
                           </a:solidFill>
                         </a:rPr>
-                        <a:t>€5 / €18 · 0.3</a:t>
+                        <a:t>€5 / €18 · 0.5</a:t>
                       </a:r>
                       <a:endParaRPr lang="en-US" sz="1000" dirty="0"/>
                     </a:p>
@@ -14876,7 +14876,7 @@
                             <a:schemeClr val="tx1"/>
                           </a:solidFill>
                         </a:rPr>
-                        <a:t>€427 / €1,000 · 5.8</a:t>
+                        <a:t>€427 / €1,000 · 5.0</a:t>
                       </a:r>
                       <a:endParaRPr lang="en-US" sz="1000" dirty="0"/>
                     </a:p>
@@ -14937,7 +14937,7 @@
                             <a:schemeClr val="tx1"/>
                           </a:solidFill>
                         </a:rPr>
-                        <a:t>€326 / €1,000 · 1.5</a:t>
+                        <a:t>€326 / €1,000 · 1.6</a:t>
                       </a:r>
                       <a:endParaRPr lang="en-US" sz="1000" dirty="0"/>
                     </a:p>
@@ -14998,7 +14998,7 @@
                             <a:schemeClr val="tx1"/>
                           </a:solidFill>
                         </a:rPr>
-                        <a:t>€274 / €1,000 · 0.7</a:t>
+                        <a:t>€274 / €1,000 · 1.1</a:t>
                       </a:r>
                       <a:endParaRPr lang="en-US" sz="1000" dirty="0"/>
                     </a:p>
@@ -15119,7 +15119,7 @@
                             <a:schemeClr val="tx1"/>
                           </a:solidFill>
                         </a:rPr>
-                        <a:t>€336 / €1,326 · 8.5</a:t>
+                        <a:t>€336 / €1,329 · 8.4</a:t>
                       </a:r>
                       <a:endParaRPr lang="en-US" sz="1000" dirty="0"/>
                     </a:p>
@@ -15834,7 +15834,7 @@
                             <a:schemeClr val="tx1"/>
                           </a:solidFill>
                         </a:rPr>
-                        <a:t>€427 / €1,505 · 9.7</a:t>
+                        <a:t>€427 / €1,505 · 9.5</a:t>
                       </a:r>
                       <a:endParaRPr lang="en-US" sz="1000" dirty="0"/>
                     </a:p>
@@ -15895,7 +15895,7 @@
                             <a:schemeClr val="tx1"/>
                           </a:solidFill>
                         </a:rPr>
-                        <a:t>€464 / €1,949 · 7.2</a:t>
+                        <a:t>€464 / €1,949 · 6.6</a:t>
                       </a:r>
                       <a:endParaRPr lang="en-US" sz="1000" dirty="0"/>
                     </a:p>
@@ -16077,7 +16077,7 @@
                             <a:schemeClr val="tx1"/>
                           </a:solidFill>
                         </a:rPr>
-                        <a:t>€672 / €1,810 · 5.7</a:t>
+                        <a:t>€672 / €1,810 · 7.0</a:t>
                       </a:r>
                       <a:endParaRPr lang="en-US" sz="1000" dirty="0"/>
                     </a:p>
@@ -16314,7 +16314,7 @@
                             <a:schemeClr val="tx1"/>
                           </a:solidFill>
                         </a:rPr>
-                        <a:t>€716 / €2,272 · 2.8</a:t>
+                        <a:t>€716 / €2,272 · 2.9</a:t>
                       </a:r>
                       <a:endParaRPr lang="en-US" sz="1000" dirty="0"/>
                     </a:p>
@@ -17066,7 +17066,7 @@
                   <a:schemeClr val="tx2"/>
                 </a:solidFill>
               </a:rPr>
-              <a:t>Cells: cost per qualified / cost per hire · hires planned. Cost per hire = (cost per application × applications + set-up) ÷ hires at full capacity; I2 includes €1,200 set-up, I3 €400 translation. StepStone ads (4 × €1,449) are costed whole and credited only the applications the plan needs (conservative).</a:t>
+              <a:t>Cells: cost per qualified / cost per hire · hires planned (cost per hire includes set-up: I2 €1,200, I3 €400). Joveo upside: Joveo's published manufacturing cases cut cost per application by 17–32%; applied to programmatic, the budget falls to €112.5k–€107.5k (model runs).</a:t>
             </a:r>
             <a:endParaRPr lang="en-US" sz="1000" dirty="0"/>
           </a:p>
@@ -17252,7 +17252,7 @@
                 <a:ea typeface="Cambria" pitchFamily="34" charset="-122"/>
                 <a:cs typeface="Cambria" pitchFamily="34" charset="-120"/>
               </a:rPr>
-              <a:t>€99.2k planned across roles and weeks, plus €18.3k reserve released on results</a:t>
+              <a:t>€99.8k planned across roles and weeks, plus €17.7k reserve released on results</a:t>
             </a:r>
             <a:endParaRPr lang="en-US" sz="2200" dirty="0"/>
           </a:p>
@@ -17321,7 +17321,7 @@
                   <a:schemeClr val="tx1"/>
                 </a:solidFill>
               </a:rPr>
-              <a:t>€69.7k paid channels (incl. €9.0k tests) + €27.9k initiative media, pre-screen calls and bonuses + €1.6k set-up = €99.2k. Reserve: 15% of €116.7k plus rounding = €18.3k.</a:t>
+              <a:t>€70.7k paid channels (incl. €9.0k tests) + €27.4k initiative media, pre-screen calls and bonuses + €1.6k set-up = €99.8k. Reserve: 15% of €117.4k plus rounding = €17.7k.</a:t>
             </a:r>
             <a:endParaRPr lang="en-US" sz="1100" dirty="0"/>
           </a:p>
@@ -17352,7 +17352,7 @@
                   <a:schemeClr val="tx1"/>
                 </a:solidFill>
               </a:rPr>
-              <a:t>weeks 1–2 cost €34.1k (29%), mostly tests. Duds are cut from Mon 2 Nov (after €500 / 30 apps); tests and the full re-allocation are judged by Mon 9 Nov; the reserve moves only from week 3. Paid media stops after Tue 24 Nov.</a:t>
+              <a:t>weeks 1–2 cost €34.3k (29%), mostly tests. Duds are cut from Mon 2 Nov (after €500 / 30 apps); tests and the full re-allocation are judged by Mon 9 Nov; the reserve moves only from week 3. Paid media stops after Tue 24 Nov.</a:t>
             </a:r>
             <a:endParaRPr lang="en-US" sz="1100" dirty="0"/>
           </a:p>
@@ -17767,7 +17767,7 @@
                             <a:schemeClr val="tx1"/>
                           </a:solidFill>
                         </a:rPr>
-                        <a:t>€37.9k</a:t>
+                        <a:t>€38.0k</a:t>
                       </a:r>
                       <a:endParaRPr lang="en-US" sz="1100" dirty="0"/>
                     </a:p>
@@ -17941,7 +17941,7 @@
                             <a:schemeClr val="tx1"/>
                           </a:solidFill>
                         </a:rPr>
-                        <a:t>€1,264</a:t>
+                        <a:t>€1,266</a:t>
                       </a:r>
                       <a:endParaRPr lang="en-US" sz="1100" dirty="0"/>
                     </a:p>
@@ -18059,7 +18059,7 @@
                             <a:schemeClr val="tx1"/>
                           </a:solidFill>
                         </a:rPr>
-                        <a:t>€27.4k</a:t>
+                        <a:t>€28.9k</a:t>
                       </a:r>
                       <a:endParaRPr lang="en-US" sz="1100" dirty="0"/>
                     </a:p>
@@ -18233,7 +18233,7 @@
                             <a:schemeClr val="tx1"/>
                           </a:solidFill>
                         </a:rPr>
-                        <a:t>€610</a:t>
+                        <a:t>€643</a:t>
                       </a:r>
                       <a:endParaRPr lang="en-US" sz="1100" dirty="0"/>
                     </a:p>
@@ -18351,7 +18351,7 @@
                             <a:schemeClr val="tx1"/>
                           </a:solidFill>
                         </a:rPr>
-                        <a:t>€17.6k</a:t>
+                        <a:t>€17.4k</a:t>
                       </a:r>
                       <a:endParaRPr lang="en-US" sz="1100" dirty="0"/>
                     </a:p>
@@ -18525,7 +18525,7 @@
                             <a:schemeClr val="tx1"/>
                           </a:solidFill>
                         </a:rPr>
-                        <a:t>€1,175</a:t>
+                        <a:t>€1,158</a:t>
                       </a:r>
                       <a:endParaRPr lang="en-US" sz="1100" dirty="0"/>
                     </a:p>
@@ -18643,7 +18643,7 @@
                             <a:schemeClr val="tx1"/>
                           </a:solidFill>
                         </a:rPr>
-                        <a:t>€16.2k</a:t>
+                        <a:t>€15.5k</a:t>
                       </a:r>
                       <a:endParaRPr lang="en-US" sz="1100" dirty="0"/>
                     </a:p>
@@ -18817,7 +18817,7 @@
                             <a:schemeClr val="tx1"/>
                           </a:solidFill>
                         </a:rPr>
-                        <a:t>€1,620</a:t>
+                        <a:t>€1,550</a:t>
                       </a:r>
                       <a:endParaRPr lang="en-US" sz="1100" dirty="0"/>
                     </a:p>
@@ -18935,7 +18935,7 @@
                             <a:schemeClr val="tx1"/>
                           </a:solidFill>
                         </a:rPr>
-                        <a:t>€99.2k</a:t>
+                        <a:t>€99.8k</a:t>
                       </a:r>
                       <a:endParaRPr lang="en-US" sz="1100" dirty="0"/>
                     </a:p>
@@ -19109,7 +19109,7 @@
                             <a:schemeClr val="tx1"/>
                           </a:solidFill>
                         </a:rPr>
-                        <a:t>€992</a:t>
+                        <a:t>€998</a:t>
                       </a:r>
                       <a:endParaRPr lang="en-US" sz="1100" dirty="0"/>
                     </a:p>
@@ -19739,7 +19739,7 @@
                             <a:schemeClr val="tx1"/>
                           </a:solidFill>
                         </a:rPr>
-                        <a:t>€8.5k</a:t>
+                        <a:t>€8.7k</a:t>
                       </a:r>
                       <a:endParaRPr lang="en-US" sz="1000" dirty="0"/>
                     </a:p>
@@ -19797,7 +19797,7 @@
                             <a:schemeClr val="tx1"/>
                           </a:solidFill>
                         </a:rPr>
-                        <a:t>3.7</a:t>
+                        <a:t>3.8</a:t>
                       </a:r>
                       <a:endParaRPr lang="en-US" sz="1000" dirty="0"/>
                     </a:p>
@@ -19855,7 +19855,7 @@
                             <a:schemeClr val="tx1"/>
                           </a:solidFill>
                         </a:rPr>
-                        <a:t>€2,318</a:t>
+                        <a:t>€2,317</a:t>
                       </a:r>
                       <a:endParaRPr lang="en-US" sz="1000" dirty="0"/>
                     </a:p>
@@ -20207,7 +20207,7 @@
                             <a:schemeClr val="tx1"/>
                           </a:solidFill>
                         </a:rPr>
-                        <a:t>€28.6k</a:t>
+                        <a:t>€27.1k</a:t>
                       </a:r>
                       <a:endParaRPr lang="en-US" sz="1000" dirty="0"/>
                     </a:p>
@@ -20265,7 +20265,7 @@
                             <a:schemeClr val="tx1"/>
                           </a:solidFill>
                         </a:rPr>
-                        <a:t>16.9</a:t>
+                        <a:t>16.1</a:t>
                       </a:r>
                       <a:endParaRPr lang="en-US" sz="1000" dirty="0"/>
                     </a:p>
@@ -20323,7 +20323,7 @@
                             <a:schemeClr val="tx1"/>
                           </a:solidFill>
                         </a:rPr>
-                        <a:t>€1,693</a:t>
+                        <a:t>€1,687</a:t>
                       </a:r>
                       <a:endParaRPr lang="en-US" sz="1000" dirty="0"/>
                     </a:p>
@@ -20441,7 +20441,7 @@
                             <a:schemeClr val="tx1"/>
                           </a:solidFill>
                         </a:rPr>
-                        <a:t>€23.8k</a:t>
+                        <a:t>€26.1k</a:t>
                       </a:r>
                       <a:endParaRPr lang="en-US" sz="1000" dirty="0"/>
                     </a:p>
@@ -20499,7 +20499,7 @@
                             <a:schemeClr val="tx1"/>
                           </a:solidFill>
                         </a:rPr>
-                        <a:t>12.0</a:t>
+                        <a:t>13.3</a:t>
                       </a:r>
                       <a:endParaRPr lang="en-US" sz="1000" dirty="0"/>
                     </a:p>
@@ -20557,7 +20557,7 @@
                             <a:schemeClr val="tx1"/>
                           </a:solidFill>
                         </a:rPr>
-                        <a:t>€1,979</a:t>
+                        <a:t>€1,963</a:t>
                       </a:r>
                       <a:endParaRPr lang="en-US" sz="1000" dirty="0"/>
                     </a:p>
@@ -20967,7 +20967,7 @@
                             <a:schemeClr val="tx1"/>
                           </a:solidFill>
                         </a:rPr>
-                        <a:t>4.8</a:t>
+                        <a:t>4.6</a:t>
                       </a:r>
                       <a:endParaRPr lang="en-US" sz="1000" dirty="0"/>
                     </a:p>
@@ -21025,7 +21025,7 @@
                             <a:schemeClr val="tx1"/>
                           </a:solidFill>
                         </a:rPr>
-                        <a:t>€13</a:t>
+                        <a:t>€14</a:t>
                       </a:r>
                       <a:endParaRPr lang="en-US" sz="1000" dirty="0"/>
                     </a:p>
@@ -21143,7 +21143,7 @@
                             <a:schemeClr val="tx1"/>
                           </a:solidFill>
                         </a:rPr>
-                        <a:t>€11.2k</a:t>
+                        <a:t>€11.0k</a:t>
                       </a:r>
                       <a:endParaRPr lang="en-US" sz="1000" dirty="0"/>
                     </a:p>
@@ -21201,7 +21201,7 @@
                             <a:schemeClr val="tx1"/>
                           </a:solidFill>
                         </a:rPr>
-                        <a:t>11.2</a:t>
+                        <a:t>11.0</a:t>
                       </a:r>
                       <a:endParaRPr lang="en-US" sz="1000" dirty="0"/>
                     </a:p>
@@ -21377,7 +21377,7 @@
                             <a:schemeClr val="tx1"/>
                           </a:solidFill>
                         </a:rPr>
-                        <a:t>€11.3k</a:t>
+                        <a:t>€11.1k</a:t>
                       </a:r>
                       <a:endParaRPr lang="en-US" sz="1000" dirty="0"/>
                     </a:p>
@@ -21435,7 +21435,7 @@
                             <a:schemeClr val="tx1"/>
                           </a:solidFill>
                         </a:rPr>
-                        <a:t>8.5</a:t>
+                        <a:t>8.4</a:t>
                       </a:r>
                       <a:endParaRPr lang="en-US" sz="1000" dirty="0"/>
                     </a:p>
@@ -21493,7 +21493,7 @@
                             <a:schemeClr val="tx1"/>
                           </a:solidFill>
                         </a:rPr>
-                        <a:t>€1,326</a:t>
+                        <a:t>€1,329</a:t>
                       </a:r>
                       <a:endParaRPr lang="en-US" sz="1000" dirty="0"/>
                     </a:p>
@@ -22461,7 +22461,7 @@
                             <a:schemeClr val="tx1"/>
                           </a:solidFill>
                         </a:rPr>
-                        <a:t>€1,060</a:t>
+                        <a:t>€1,064</a:t>
                       </a:r>
                       <a:endParaRPr lang="en-US" sz="1100" dirty="0"/>
                     </a:p>
@@ -22637,7 +22637,7 @@
                             <a:schemeClr val="tx1"/>
                           </a:solidFill>
                         </a:rPr>
-                        <a:t>€946</a:t>
+                        <a:t>€949</a:t>
                       </a:r>
                       <a:endParaRPr lang="en-US" sz="1100" dirty="0"/>
                     </a:p>
@@ -22813,7 +22813,7 @@
                             <a:schemeClr val="tx1"/>
                           </a:solidFill>
                         </a:rPr>
-                        <a:t>€770</a:t>
+                        <a:t>€774</a:t>
                       </a:r>
                       <a:endParaRPr lang="en-US" sz="1100" dirty="0"/>
                     </a:p>
@@ -22964,7 +22964,7 @@
                   <a:schemeClr val="tx1"/>
                 </a:solidFill>
               </a:rPr>
-              <a:t>at −30%: electricians 20.7 of 30, supervisors 7.0 of 10, automation 14.5 of 15, mechatronics 44.7 of 45. Mechatronics slips to 44.7.</a:t>
+              <a:t>at −30%: electricians 20.6 of 30, supervisors 6.8 of 10, automation 14.5 of 15, mechatronics 44.7 of 45. Mechatronics slips to 44.7.</a:t>
             </a:r>
             <a:endParaRPr lang="en-US" sz="1200" dirty="0"/>
           </a:p>
@@ -22995,7 +22995,7 @@
                   <a:schemeClr val="tx1"/>
                 </a:solidFill>
               </a:rPr>
-              <a:t>the last €35.25k buys ~13 hires at ~€2,700 each, mostly electricians, the role that keeps lines running. Keep it. If you must cut, cover supervisors through internal promotion and protect electricians. Above €117.5k, extra money buys at most ~2 more hires (the 6 spare slots); then the 55/week limit binds.</a:t>
+              <a:t>the last €35.25k buys ~13 hires at ~€2,640 each, mostly electricians, the role that keeps lines running. Keep it. If you must cut, cover supervisors through internal promotion and protect electricians. Above €117.5k, extra money buys at most ~2 more hires (the 6 spare slots); then the 55/week limit binds.</a:t>
             </a:r>
             <a:endParaRPr lang="en-US" sz="1200" dirty="0"/>
           </a:p>
@@ -23145,7 +23145,7 @@
                 <a:ea typeface="Cambria" pitchFamily="34" charset="-122"/>
                 <a:cs typeface="Cambria" pitchFamily="34" charset="-120"/>
               </a:rPr>
-              <a:t>Three new sources supply ~43 of the 100 hires, one built for electricians</a:t>
+              <a:t>Three new sources supply ~42 of the 100 hires, one built for electricians</a:t>
             </a:r>
             <a:endParaRPr lang="en-US" sz="2200" dirty="0"/>
           </a:p>
@@ -23378,7 +23378,7 @@
                   <a:schemeClr val="tx1"/>
                 </a:solidFill>
               </a:rPr>
-              <a:t>€63 + €11.2k bonuses → 25 re-apps + 66 referrals → ~42 qualified → ~16 hires</a:t>
+              <a:t>€63 + €11.0k bonuses → 25 re-apps + 66 referrals → ~42 qualified → ~16 hires</a:t>
             </a:r>
             <a:endParaRPr lang="en-US" sz="1200" dirty="0"/>
           </a:p>
@@ -23673,7 +23673,7 @@
                   <a:schemeClr val="tx1"/>
                 </a:solidFill>
               </a:rPr>
-              <a:t>120 apps × €84 = €10.1k + €1.2k set-up → 30 qualified × 28% = 8.5 hires (€1,326/hire)</a:t>
+              <a:t>118 apps × €84 = €9.9k + €1.2k set-up → 30 qualified × 28% = 8.4 hires (€1,329/hire)</a:t>
             </a:r>
             <a:endParaRPr lang="en-US" sz="1200" dirty="0"/>
           </a:p>
@@ -23704,7 +23704,7 @@
                   <a:schemeClr val="tx1"/>
                 </a:solidFill>
               </a:rPr>
-              <a:t>Fri 23 Oct – Thu 5 Nov (read Mon 9 Nov): €4.0k. Pass: ≥4 qualified at ≤€500. Kill: &lt;2, &gt;€670 per qualified, or profile rejected; week 4: interview pass below the planned 45% once ≥10 interviews are in</a:t>
+              <a:t>Fri 23 Oct – Thu 5 Nov (read Mon 9 Nov): €3.9k. Pass: ≥4 qualified at ≤€500. Kill: &lt;2, &gt;€670 per qualified, or profile rejected; week 4: interview pass below the planned 45% once ≥10 interviews are in</a:t>
             </a:r>
             <a:endParaRPr lang="en-US" sz="1200" dirty="0"/>
           </a:p>
@@ -24077,7 +24077,7 @@
                   <a:schemeClr val="tx1"/>
                 </a:solidFill>
               </a:rPr>
-              <a:t>Every employer may keep consenting runners-up for up to a year, and they are rarely re-marketed to. Here 211 records cost ~€13 per hire and fill week-1 slots before paid channels warm up. Joveo already matches jobs to supply programmatically. Adding a consented rediscovery source, tracked to hire with the same source tags, is repeatable in any market without local staff.</a:t>
+              <a:t>Every employer may keep consenting runners-up for up to a year, and they are rarely re-marketed to. Here 211 records cost ~€14 per hire and fill week-1 slots before paid channels warm up. Joveo already matches jobs to supply programmatically. Adding a consented rediscovery source, tracked to hire with the same source tags, is repeatable in any market without local staff.</a:t>
             </a:r>
             <a:endParaRPr lang="en-US" sz="1200" dirty="0"/>
           </a:p>
@@ -24596,7 +24596,7 @@
                   <a:schemeClr val="tx1"/>
                 </a:solidFill>
               </a:rPr>
-              <a:t>1) Pass rate on the week-1 cohort (interviews 29 Oct–2 Nov), the most sensitive input: if below plan (electricians 50%) once ≥10 interviews are in → tighter knock-outs, pre-screen calls, ask +9 slots, re-run the model (pass 10% worse = ~92 hires). 2) Electrician supply: profile decision + I2's two-week read on 9 Nov; if killed → programmatic picks up the gap: all 30 still possible (model run with I2 off), budget €127.5k, electricians at €1,532 per hire. 3) The 12 tests' cost per application and share qualified → re-rank on Assumptions §7. Week 4 (16 Nov): acceptance below plan (70%) once ≥7 offers are out → earlier cut-off + signing bonus.</a:t>
+              <a:t>1) Pass rate on the week-1 cohort (interviews 29 Oct–2 Nov), the most sensitive input: if below plan (electricians 50%) once ≥10 interviews are in → tighter knock-outs, pre-screen calls, ask +9 slots, re-run the model (pass 10% worse = ~92 hires). 2) Electrician supply: profile decision + I2's two-week read on 9 Nov; if killed → programmatic picks up the gap: all 30 still possible (model run with I2 off), budget €127.5k, electricians at €1,529 per hire. 3) The 12 tests' cost per application and share qualified → re-rank on Assumptions §7. Week 4 (16 Nov): acceptance below plan (70%) once ≥7 offers are out → earlier cut-off + signing bonus.</a:t>
             </a:r>
             <a:endParaRPr lang="en-US" sz="1250" dirty="0"/>
           </a:p>

</xml_diff>

<commit_message>
Simplify: one-line plain notes, practice-based rules, lighter slides
Co-Authored-By: Claude Opus 5.5 <noreply@anthropic.com>
Claude-Session: https://claude.ai/code/session_01V2NJtrYy3bzNxqKeiRXJfY
</commit_message>
<xml_diff>
--- a/operation_uptime/Operation_Uptime_Deck.pptx
+++ b/operation_uptime/Operation_Uptime_Deck.pptx
@@ -114,30 +114,30 @@
   <p:extLst>
     <p:ext uri="{521415D9-36F7-43E2-AB2F-B90AF26B5E84}">
       <p14:sectionLst xmlns:p14="http://schemas.microsoft.com/office/powerpoint/2010/main">
-        <p14:section name="Summary" id="{419a3669-44ab-ed75-820e-f6c8f08a2b0e}">
+        <p14:section name="Summary" id="{54a71469-4236-bda2-0b26-6cabd6ce2030}">
           <p14:sldIdLst>
             <p14:sldId id="256"/>
           </p14:sldIdLst>
         </p14:section>
-        <p14:section name="Part 1 Funnel" id="{e5bfc387-1ed4-ea49-35f0-167cec35a232}">
+        <p14:section name="Part 1 Funnel" id="{00875c10-09bf-44b3-7d0b-a43a5f7c7e46}">
           <p14:sldIdLst>
             <p14:sldId id="257"/>
             <p14:sldId id="258"/>
           </p14:sldIdLst>
         </p14:section>
-        <p14:section name="Part 2 Channels &amp; budget" id="{a2038b24-3a39-9e48-6d88-ba19ad61abfb}">
+        <p14:section name="Part 2 Channels &amp; budget" id="{7fc5a8a6-5596-3a6b-0fc5-bb8ea5b5e2b0}">
           <p14:sldIdLst>
             <p14:sldId id="259"/>
             <p14:sldId id="260"/>
             <p14:sldId id="261"/>
           </p14:sldIdLst>
         </p14:section>
-        <p14:section name="Part 3 New sources" id="{b7a4091e-7f74-17cc-a65f-334645a97f69}">
+        <p14:section name="Part 3 New sources" id="{64d396eb-54d0-552c-75da-aad4e3cdf8f6}">
           <p14:sldIdLst>
             <p14:sldId id="262"/>
           </p14:sldIdLst>
         </p14:section>
-        <p14:section name="Part 4 Run it" id="{8171a141-a7a8-3c7e-ddc6-512fe70ab195}">
+        <p14:section name="Part 4 Run it" id="{a524c6b6-ad41-7ff2-aa85-a56c1581f70f}">
           <p14:sldIdLst>
             <p14:sldId id="263"/>
           </p14:sldIdLst>
@@ -6434,7 +6434,7 @@
                   <a:schemeClr val="tx1"/>
                 </a:solidFill>
               </a:rPr>
-              <a:t>98% used. Pre-screened sources first, pace ≤55/wk, ask +9 slots/wk (64/wk → 85% use, the utilisation standard).</a:t>
+              <a:t>98% used. Pre-screened sources first, pace ≤55/wk, ask +9 slots/wk (64/wk → 85% use).</a:t>
             </a:r>
             <a:endParaRPr lang="en-US" sz="1100" dirty="0"/>
           </a:p>
@@ -10068,7 +10068,7 @@
                   <a:schemeClr val="tx1"/>
                 </a:solidFill>
               </a:rPr>
-              <a:t>Sourced where data exists (IAB: 28% of applications suitable; Gem interview-pass and Königsteiner/StepStone offer-acceptance data), own estimates otherwise; each labelled on the Assumptions tab. Few applicants qualify (brief), and foreign-trained electricians can't be recognised in time (2–4 months, §6 BQFG). Acceptance reflects counter-offers in Engpass trades. With the channel mix, the plan needs </a:t>
+              <a:t>Rates come from IAB (about 1 in 4 applications is suitable), Gem pass rates and German offer-acceptance surveys; every input and its source is on the Assumptions tab. With this channel mix the plan needs </a:t>
             </a:r>
             <a:pPr indent="0" marL="0">
               <a:buNone/>
@@ -10137,7 +10137,7 @@
                   <a:schemeClr val="tx1"/>
                 </a:solidFill>
               </a:rPr>
-              <a:t>Application → assessment 6 days, → interview 8, → offer 3, → signature 7 (first two: SmartRecruiters DE benchmark); supervisors +7. Last realistic signature Fri 18 Dec, so applications must arrive by Tue 24 Nov (E/M/A) and Tue 17 Nov (supervisors). Slots = 55 × 40 days ÷ 7 = 314.</a:t>
+              <a:t>Work back from the last realistic signature, Fri 18 Dec: offer 7 days, interview → offer 3, assessment → interview 8, application → assessment 6 (supervisors +7). So applications must arrive by Tue 24 Nov (supervisors Tue 17 Nov). Slots = 55 × 40 days ÷ 7 = 314.</a:t>
             </a:r>
             <a:endParaRPr lang="en-US" sz="1200" dirty="0"/>
           </a:p>
@@ -17066,43 +17066,7 @@
                   <a:schemeClr val="tx2"/>
                 </a:solidFill>
               </a:rPr>
-              <a:t>Cells: cost per qualified / cost per hire · hires planned (cost per hire includes set-up: I2 €1,200, I3 €400). Joveo upside: Joveo's published manufacturing cases cut cost per application by 17–32%; applied to programmatic, the budget falls to €112.5k–€107.5k (model runs).</a:t>
-            </a:r>
-            <a:endParaRPr lang="en-US" sz="1000" dirty="0"/>
-          </a:p>
-        </p:txBody>
-      </p:sp>
-      <p:sp>
-        <p:nvSpPr>
-          <p:cNvPr id="12" name="Text 9"/>
-          <p:cNvSpPr txBox="1"/>
-          <p:nvPr/>
-        </p:nvSpPr>
-        <p:spPr>
-          <a:xfrm>
-            <a:off x="457200" y="5760720"/>
-            <a:ext cx="11274552" cy="457200"/>
-          </a:xfrm>
-          <a:prstGeom prst="rect">
-            <a:avLst/>
-          </a:prstGeom>
-          <a:noFill/>
-          <a:ln/>
-        </p:spPr>
-        <p:txBody>
-          <a:bodyPr wrap="square" lIns="0" tIns="0" rIns="0" bIns="0" rtlCol="0" anchor="t"/>
-          <a:lstStyle/>
-          <a:p>
-            <a:pPr indent="0" marL="0">
-              <a:buNone/>
-            </a:pPr>
-            <a:r>
-              <a:rPr lang="en-US" sz="1000" i="1" dirty="0">
-                <a:solidFill>
-                  <a:schemeClr val="accent4"/>
-                </a:solidFill>
-              </a:rPr>
-              <a:t>Sourced: cost per application, DACH medians: Indeed €161, Google €179, LinkedIn €96, Meta €84 (TalentBait 2024–26) · StepStone €1,449/ad, 12 applications per ad · share qualified: IAB 2026 (28%), channel index from IAB 2025 (job boards 0.90, careers page 0.71, social 0.50) · volume caps: channel reach (Trendence 2023: Indeed 36%, LinkedIn 15%) × in-market pool (BA 2025, Gallup 11%) · Meta volumes: Redline 2024–26. Every input's source or derivation is on the Assumptions tab.</a:t>
+              <a:t>Cells: cost per qualified / cost per hire · hires planned. Joveo upside: Joveo's own manufacturing cases cut cost per application by 17–32%; applied to programmatic, the budget falls to €107.5k–€112.5k.</a:t>
             </a:r>
             <a:endParaRPr lang="en-US" sz="1000" dirty="0"/>
           </a:p>
@@ -23285,7 +23249,7 @@
                   <a:schemeClr val="tx1"/>
                 </a:solidFill>
               </a:rPr>
-              <a:t>211 runners-up from the last year (consented talent pool); the plant's 10,703 staff as referrers</a:t>
+              <a:t>211 past runners-up (consented, last year) + staff referrals</a:t>
             </a:r>
             <a:endParaRPr lang="en-US" sz="1200" dirty="0"/>
           </a:p>
@@ -23316,7 +23280,7 @@
                   <a:schemeClr val="tx1"/>
                 </a:solidFill>
               </a:rPr>
-              <a:t>DE email + SMS waves (days 2, 7, 14), 1-click re-apply; €1,000 bonus on a signed referral</a:t>
+              <a:t>Email + SMS waves on days 2, 7 and 14; €1,000 bonus per signed referral</a:t>
             </a:r>
             <a:endParaRPr lang="en-US" sz="1200" dirty="0"/>
           </a:p>
@@ -23347,7 +23311,7 @@
                   <a:schemeClr val="tx1"/>
                 </a:solidFill>
               </a:rPr>
-              <a:t>Already screened (50% still qualified, below the 70% skills match Forrester reports), already wanted Tesla, ~€3 per application</a:t>
+              <a:t>Already screened and already wanted Tesla; ~€3 per application</a:t>
             </a:r>
             <a:endParaRPr lang="en-US" sz="1200" dirty="0"/>
           </a:p>
@@ -23409,7 +23373,7 @@
                   <a:schemeClr val="tx1"/>
                 </a:solidFill>
               </a:rPr>
-              <a:t>Wed 21 Oct – Tue 3 Nov (waves 1–3): €63. Pass: ≥12 qualified. Kill: &lt;9 → no further re-contacts; bonus stays live</a:t>
+              <a:t>Wed 21 Oct – Tue 3 Nov (waves 1–3): €63. Pass: ≥10 qualified. Kill: &lt;6 → no further re-contacts; bonus stays live</a:t>
             </a:r>
             <a:endParaRPr lang="en-US" sz="1200" dirty="0"/>
           </a:p>
@@ -23440,7 +23404,7 @@
                   <a:schemeClr val="tx1"/>
                 </a:solidFill>
               </a:rPr>
-              <a:t>Me: copy, segments and tracked links ready before 20 Oct; wave 1 on day 2 once the GDPR-checked export arrives. Client: ATS export + consent check, bonus approval, one staff message</a:t>
+              <a:t>Me: copy, segments, tracked links. Client: GDPR-checked export, bonus approval, one staff message</a:t>
             </a:r>
             <a:endParaRPr lang="en-US" sz="1200" dirty="0"/>
           </a:p>
@@ -23580,7 +23544,7 @@
                   <a:schemeClr val="tx1"/>
                 </a:solidFill>
               </a:rPr>
-              <a:t>~10,000 construction electricians (Elektroniker EGT, BA KldB 2621) within 75 km</a:t>
+              <a:t>~10,000 construction electricians within 75 km</a:t>
             </a:r>
             <a:endParaRPr lang="en-US" sz="1200" dirty="0"/>
           </a:p>
@@ -23611,7 +23575,7 @@
                   <a:schemeClr val="tx1"/>
                 </a:solidFill>
               </a:rPr>
-              <a:t>Meta + Google ads with a 6-question quiz (Gesellenbrief, Elektrofachkraft, shifts, language); Tesla runs a 2–4 week bridge</a:t>
+              <a:t>Social and search ads with a 6-question quiz; Tesla runs a 2–4 week bridge course</a:t>
             </a:r>
             <a:endParaRPr lang="en-US" sz="1200" dirty="0"/>
           </a:p>
@@ -23642,7 +23606,7 @@
                   <a:schemeClr val="tx1"/>
                 </a:solidFill>
               </a:rPr>
-              <a:t>A certified pool that never searches 'Betriebstechnik' jobs; roughly doubles the hardest pool</a:t>
+              <a:t>Certified electricians who never search for plant jobs; doubles the hardest pool</a:t>
             </a:r>
             <a:endParaRPr lang="en-US" sz="1200" dirty="0"/>
           </a:p>
@@ -23704,7 +23668,7 @@
                   <a:schemeClr val="tx1"/>
                 </a:solidFill>
               </a:rPr>
-              <a:t>Fri 23 Oct – Thu 5 Nov (read Mon 9 Nov): €3.9k. Pass: ≥4 qualified at ≤€500. Kill: &lt;2, &gt;€670 per qualified, or profile rejected; week 4: interview pass below the planned 45% once ≥10 interviews are in</a:t>
+              <a:t>Fri 23 Oct – Thu 5 Nov (read Mon 9 Nov): €3.9k. Pass: ≥4 qualified at ≤€500. Kill: &lt;3, &gt;€670 per qualified, or profile rejected</a:t>
             </a:r>
             <a:endParaRPr lang="en-US" sz="1200" dirty="0"/>
           </a:p>
@@ -23735,7 +23699,7 @@
                   <a:schemeClr val="tx1"/>
                 </a:solidFill>
               </a:rPr>
-              <a:t>Me: audiences, quiz, remote DE copywriter (€700), live 23 Oct. Client: profile sign-off by 23 Oct, bridge plan</a:t>
+              <a:t>Me: ads, quiz, copy; live 23 Oct. Client: profile sign-off by 23 Oct, bridge plan</a:t>
             </a:r>
             <a:endParaRPr lang="en-US" sz="1200" dirty="0"/>
           </a:p>
@@ -23875,7 +23839,7 @@
                   <a:schemeClr val="tx1"/>
                 </a:solidFill>
               </a:rPr>
-              <a:t>Mechatronics/Industriemechanik in Słubice, Kostrzyn, Gorzów, Zielona Góra (60–130 km, EU)</a:t>
+              <a:t>Mechatronics workers in Polish border towns, 60–130 km away (EU)</a:t>
             </a:r>
             <a:endParaRPr lang="en-US" sz="1200" dirty="0"/>
           </a:p>
@@ -23906,7 +23870,7 @@
                   <a:schemeClr val="tx1"/>
                 </a:solidFill>
               </a:rPr>
-              <a:t>Pracuj.pl, OLX Praca and Polish-geo Meta; a remote Polish-speaking freelancer phones each applicant (15 min, low end of Indeed’s 15–30 min range)</a:t>
+              <a:t>Polish job boards and Meta; a Polish-speaking freelancer phones each applicant (15 min)</a:t>
             </a:r>
             <a:endParaRPr lang="en-US" sz="1200" dirty="0"/>
           </a:p>
@@ -23937,7 +23901,7 @@
                   <a:schemeClr val="tx1"/>
                 </a:solidFill>
               </a:rPr>
-              <a:t>Pracuj.pl is Poland's largest job board (762,827 offers in 2025); ~2,000 Polish trade workers already commute to Brandenburg</a:t>
+              <a:t>~2,000 Polish trade workers already commute to Brandenburg; the call checks language before using our slots</a:t>
             </a:r>
             <a:endParaRPr lang="en-US" sz="1200" dirty="0"/>
           </a:p>
@@ -23999,7 +23963,7 @@
                   <a:schemeClr val="tx1"/>
                 </a:solidFill>
               </a:rPr>
-              <a:t>Tue 27 Oct – Mon 9 Nov (freelancer starts 27 Oct): €2.5k. Pass: ≥10 qualified at ≤€200. Kill: &lt;7, &gt;€270 per qualified, or fewer than the planned 14% pass the language call after 30 calls</a:t>
+              <a:t>Tue 27 Oct – Mon 9 Nov (freelancer starts 27 Oct): €2.5k. Pass: ≥9 qualified at ≤€200. Kill: &lt;5, &gt;€270 per qualified, or too few pass the language call</a:t>
             </a:r>
             <a:endParaRPr lang="en-US" sz="1200" dirty="0"/>
           </a:p>
@@ -24030,7 +23994,7 @@
                   <a:schemeClr val="tx1"/>
                 </a:solidFill>
               </a:rPr>
-              <a:t>Me: ads on day 3, contract the freelancer (live 27 Oct), script and scorecard. Client: approve PL ads</a:t>
+              <a:t>Me: ads, freelancer, call script. Client: approve the Polish ads</a:t>
             </a:r>
             <a:endParaRPr lang="en-US" sz="1200" dirty="0"/>
           </a:p>
@@ -24473,7 +24437,7 @@
                   <a:schemeClr val="tx1"/>
                 </a:solidFill>
               </a:rPr>
-              <a:t>No judgement before €500 / 30 apps (tests run to €750). Updated Q = (qual + 30 × plan) ÷ (apps + 30). Cost per qualified ≤0.75× plan with free slots → +25%/wk from reserve; ≥1.5× → cut 50%; ≥2× → off. Zero qualified at €750 → off where ≥3 were expected; low-yield cells → off if applications are &lt;50% of plan. Next week forecast &gt;55 qualified → pause the costliest cells; &lt;50 → release reserve.</a:t>
+              <a:t>Judge a channel only after €500 or 30 applications. Early results are blended with the plan so one week doesn't swing decisions. 20% cheaper than plan with free slots → +25% a week from the reserve; 50% dearer → halve it; twice the cost → switch off. A spent test with no qualified applicants → off. Next week over 55 qualified → pause the dearest channels; under 50 → release reserve.</a:t>
             </a:r>
             <a:endParaRPr lang="en-US" sz="1250" dirty="0"/>
           </a:p>
@@ -24596,7 +24560,7 @@
                   <a:schemeClr val="tx1"/>
                 </a:solidFill>
               </a:rPr>
-              <a:t>1) Pass rate on the week-1 cohort (interviews 29 Oct–2 Nov), the most sensitive input: if below plan (electricians 50%) once ≥10 interviews are in → tighter knock-outs, pre-screen calls, ask +9 slots, re-run the model (pass 10% worse = ~92 hires). 2) Electrician supply: profile decision + I2's two-week read on 9 Nov; if killed → programmatic picks up the gap: all 30 still possible (model run with I2 off), budget €127.5k, electricians at €1,529 per hire. 3) The 12 tests' cost per application and share qualified → re-rank on Assumptions §7. Week 4 (16 Nov): acceptance below plan (70%) once ≥7 offers are out → earlier cut-off + signing bonus.</a:t>
+              <a:t>1) Week-1 pass rate: if below plan after 10 interviews → sharper screening questions, pre-screen calls, ask for more slots (10% lower pass ≈ 92 hires). 2) Construction-electrician decision and its 9 Nov read; if stopped, programmatic fills the gap (budget €127.5k). 3) Re-rank channels on the tests' real costs. Week 4: acceptance below plan after 5 offers → earlier cut-off + signing bonus.</a:t>
             </a:r>
             <a:endParaRPr lang="en-US" sz="1250" dirty="0"/>
           </a:p>

</xml_diff>

<commit_message>
Model: only what the brief asks (recommended vs 30% cut, simpler Tracker rules), one-line 'How' per tab
Co-Authored-By: Claude Opus 5.5 <noreply@anthropic.com>
Claude-Session: https://claude.ai/code/session_01V2NJtrYy3bzNxqKeiRXJfY
</commit_message>
<xml_diff>
--- a/operation_uptime/Operation_Uptime_Deck.pptx
+++ b/operation_uptime/Operation_Uptime_Deck.pptx
@@ -114,30 +114,30 @@
   <p:extLst>
     <p:ext uri="{521415D9-36F7-43E2-AB2F-B90AF26B5E84}">
       <p14:sectionLst xmlns:p14="http://schemas.microsoft.com/office/powerpoint/2010/main">
-        <p14:section name="Summary" id="{c5e66185-e052-c6fd-c8a7-31dac0f97e56}">
+        <p14:section name="Summary" id="{eb02dada-b911-1ff0-dc16-f427edafb414}">
           <p14:sldIdLst>
             <p14:sldId id="256"/>
           </p14:sldIdLst>
         </p14:section>
-        <p14:section name="Part 1 Funnel" id="{c5316525-4025-b99a-d43d-b630e7c019bb}">
+        <p14:section name="Part 1 Funnel" id="{913a2bc7-2828-f388-da77-4e2345fcd06b}">
           <p14:sldIdLst>
             <p14:sldId id="257"/>
             <p14:sldId id="258"/>
           </p14:sldIdLst>
         </p14:section>
-        <p14:section name="Part 2 Channels &amp; budget" id="{f24e8158-79ea-d641-ea0a-4000824fb5d6}">
+        <p14:section name="Part 2 Channels &amp; budget" id="{f4a86167-7bbd-4b65-4294-627187c83646}">
           <p14:sldIdLst>
             <p14:sldId id="259"/>
             <p14:sldId id="260"/>
             <p14:sldId id="261"/>
           </p14:sldIdLst>
         </p14:section>
-        <p14:section name="Part 3 New sources" id="{3c8582b9-4814-f252-04e7-3435ec1032ea}">
+        <p14:section name="Part 3 New sources" id="{f1035cb5-55eb-9169-b1cc-8ea76e1ddf1d}">
           <p14:sldIdLst>
             <p14:sldId id="262"/>
           </p14:sldIdLst>
         </p14:section>
-        <p14:section name="Part 4 Run it" id="{e0427f7c-8c26-3458-b37b-8a22e1e2ca4d}">
+        <p14:section name="Part 4 Run it" id="{62daabf8-4e46-0b80-aaa1-eb58439c6957}">
           <p14:sldIdLst>
             <p14:sldId id="263"/>
           </p14:sldIdLst>
@@ -11800,11 +11800,11 @@
         <p:spPr>
           <a:xfrm>
             <a:off x="8595360" y="1188720"/>
-            <a:ext cx="3136392" cy="4846320"/>
+            <a:ext cx="3136392" cy="3108960"/>
           </a:xfrm>
           <a:prstGeom prst="roundRect">
             <a:avLst>
-              <a:gd name="adj" fmla="val 2332"/>
+              <a:gd name="adj" fmla="val 2353"/>
             </a:avLst>
           </a:prstGeom>
           <a:solidFill>
@@ -11827,7 +11827,7 @@
         <p:spPr>
           <a:xfrm>
             <a:off x="8778240" y="1325880"/>
-            <a:ext cx="2834640" cy="4617720"/>
+            <a:ext cx="2834640" cy="2880360"/>
           </a:xfrm>
           <a:prstGeom prst="rect">
             <a:avLst/>
@@ -11906,24 +11906,6 @@
                 </a:solidFill>
               </a:rPr>
               <a:t>Every paid channel gets a €750 test first; the dearest (Search, most programmatic) stay at test level.</a:t>
-            </a:r>
-            <a:endParaRPr lang="en-US" sz="1150" dirty="0"/>
-          </a:p>
-          <a:p>
-            <a:pPr marL="342900" indent="-342900">
-              <a:spcAft>
-                <a:spcPts val="800"/>
-              </a:spcAft>
-              <a:buSzPct val="100000"/>
-              <a:buChar char="•"/>
-            </a:pPr>
-            <a:r>
-              <a:rPr lang="en-US" sz="1150" dirty="0">
-                <a:solidFill>
-                  <a:schemeClr val="tx1"/>
-                </a:solidFill>
-              </a:rPr>
-              <a:t>Joveo upside: Joveo's own manufacturing cases cut cost per application 17–32%; on programmatic that takes the budget to €107.5k–€112.5k.</a:t>
             </a:r>
             <a:endParaRPr lang="en-US" sz="1150" dirty="0"/>
           </a:p>
@@ -14118,7 +14100,7 @@
                             <a:schemeClr val="tx1"/>
                           </a:solidFill>
                         </a:rPr>
-                        <a:t>100% · €117.50k</a:t>
+                        <a:t>Recommended · €117.50k</a:t>
                       </a:r>
                       <a:endParaRPr lang="en-US" sz="1100" dirty="0"/>
                     </a:p>
@@ -14294,183 +14276,7 @@
                             <a:schemeClr val="tx1"/>
                           </a:solidFill>
                         </a:rPr>
-                        <a:t>85% · €99.88k</a:t>
-                      </a:r>
-                      <a:endParaRPr lang="en-US" sz="1100" dirty="0"/>
-                    </a:p>
-                  </a:txBody>
-                  <a:tcPr marL="91440" marR="91440" marT="45720" marB="45720" anchor="ctr">
-                    <a:lnL w="6350" cap="flat" cmpd="sng" algn="ctr">
-                      <a:solidFill>
-                        <a:srgbClr val="D6DEE5"/>
-                      </a:solidFill>
-                      <a:prstDash val="solid"/>
-                      <a:round/>
-                      <a:headEnd type="none" w="med" len="med"/>
-                      <a:tailEnd type="none" w="med" len="med"/>
-                    </a:lnL>
-                    <a:lnR w="6350" cap="flat" cmpd="sng" algn="ctr">
-                      <a:solidFill>
-                        <a:srgbClr val="D6DEE5"/>
-                      </a:solidFill>
-                      <a:prstDash val="solid"/>
-                      <a:round/>
-                      <a:headEnd type="none" w="med" len="med"/>
-                      <a:tailEnd type="none" w="med" len="med"/>
-                    </a:lnR>
-                    <a:lnT w="6350" cap="flat" cmpd="sng" algn="ctr">
-                      <a:solidFill>
-                        <a:srgbClr val="D6DEE5"/>
-                      </a:solidFill>
-                      <a:prstDash val="solid"/>
-                      <a:round/>
-                      <a:headEnd type="none" w="med" len="med"/>
-                      <a:tailEnd type="none" w="med" len="med"/>
-                    </a:lnT>
-                    <a:lnB w="6350" cap="flat" cmpd="sng" algn="ctr">
-                      <a:solidFill>
-                        <a:srgbClr val="D6DEE5"/>
-                      </a:solidFill>
-                      <a:prstDash val="solid"/>
-                      <a:round/>
-                      <a:headEnd type="none" w="med" len="med"/>
-                      <a:tailEnd type="none" w="med" len="med"/>
-                    </a:lnB>
-                  </a:tcPr>
-                </a:tc>
-                <a:tc>
-                  <a:txBody>
-                    <a:bodyPr/>
-                    <a:lstStyle/>
-                    <a:p>
-                      <a:pPr algn="ctr" indent="0" marL="0">
-                        <a:buNone/>
-                      </a:pPr>
-                      <a:r>
-                        <a:rPr lang="en-US" sz="1100" b="1" dirty="0">
-                          <a:solidFill>
-                            <a:schemeClr val="tx1"/>
-                          </a:solidFill>
-                        </a:rPr>
-                        <a:t>94</a:t>
-                      </a:r>
-                      <a:endParaRPr lang="en-US" sz="1100" dirty="0"/>
-                    </a:p>
-                  </a:txBody>
-                  <a:tcPr marL="91440" marR="91440" marT="45720" marB="45720" anchor="ctr">
-                    <a:lnL w="6350" cap="flat" cmpd="sng" algn="ctr">
-                      <a:solidFill>
-                        <a:srgbClr val="D6DEE5"/>
-                      </a:solidFill>
-                      <a:prstDash val="solid"/>
-                      <a:round/>
-                      <a:headEnd type="none" w="med" len="med"/>
-                      <a:tailEnd type="none" w="med" len="med"/>
-                    </a:lnL>
-                    <a:lnR w="6350" cap="flat" cmpd="sng" algn="ctr">
-                      <a:solidFill>
-                        <a:srgbClr val="D6DEE5"/>
-                      </a:solidFill>
-                      <a:prstDash val="solid"/>
-                      <a:round/>
-                      <a:headEnd type="none" w="med" len="med"/>
-                      <a:tailEnd type="none" w="med" len="med"/>
-                    </a:lnR>
-                    <a:lnT w="6350" cap="flat" cmpd="sng" algn="ctr">
-                      <a:solidFill>
-                        <a:srgbClr val="D6DEE5"/>
-                      </a:solidFill>
-                      <a:prstDash val="solid"/>
-                      <a:round/>
-                      <a:headEnd type="none" w="med" len="med"/>
-                      <a:tailEnd type="none" w="med" len="med"/>
-                    </a:lnT>
-                    <a:lnB w="6350" cap="flat" cmpd="sng" algn="ctr">
-                      <a:solidFill>
-                        <a:srgbClr val="D6DEE5"/>
-                      </a:solidFill>
-                      <a:prstDash val="solid"/>
-                      <a:round/>
-                      <a:headEnd type="none" w="med" len="med"/>
-                      <a:tailEnd type="none" w="med" len="med"/>
-                    </a:lnB>
-                  </a:tcPr>
-                </a:tc>
-                <a:tc>
-                  <a:txBody>
-                    <a:bodyPr/>
-                    <a:lstStyle/>
-                    <a:p>
-                      <a:pPr algn="ctr" indent="0" marL="0">
-                        <a:buNone/>
-                      </a:pPr>
-                      <a:r>
-                        <a:rPr lang="en-US" sz="1100" dirty="0">
-                          <a:solidFill>
-                            <a:schemeClr val="tx1"/>
-                          </a:solidFill>
-                        </a:rPr>
-                        <a:t>€1,064</a:t>
-                      </a:r>
-                      <a:endParaRPr lang="en-US" sz="1100" dirty="0"/>
-                    </a:p>
-                  </a:txBody>
-                  <a:tcPr marL="91440" marR="91440" marT="45720" marB="45720" anchor="ctr">
-                    <a:lnL w="6350" cap="flat" cmpd="sng" algn="ctr">
-                      <a:solidFill>
-                        <a:srgbClr val="D6DEE5"/>
-                      </a:solidFill>
-                      <a:prstDash val="solid"/>
-                      <a:round/>
-                      <a:headEnd type="none" w="med" len="med"/>
-                      <a:tailEnd type="none" w="med" len="med"/>
-                    </a:lnL>
-                    <a:lnR w="6350" cap="flat" cmpd="sng" algn="ctr">
-                      <a:solidFill>
-                        <a:srgbClr val="D6DEE5"/>
-                      </a:solidFill>
-                      <a:prstDash val="solid"/>
-                      <a:round/>
-                      <a:headEnd type="none" w="med" len="med"/>
-                      <a:tailEnd type="none" w="med" len="med"/>
-                    </a:lnR>
-                    <a:lnT w="6350" cap="flat" cmpd="sng" algn="ctr">
-                      <a:solidFill>
-                        <a:srgbClr val="D6DEE5"/>
-                      </a:solidFill>
-                      <a:prstDash val="solid"/>
-                      <a:round/>
-                      <a:headEnd type="none" w="med" len="med"/>
-                      <a:tailEnd type="none" w="med" len="med"/>
-                    </a:lnT>
-                    <a:lnB w="6350" cap="flat" cmpd="sng" algn="ctr">
-                      <a:solidFill>
-                        <a:srgbClr val="D6DEE5"/>
-                      </a:solidFill>
-                      <a:prstDash val="solid"/>
-                      <a:round/>
-                      <a:headEnd type="none" w="med" len="med"/>
-                      <a:tailEnd type="none" w="med" len="med"/>
-                    </a:lnB>
-                  </a:tcPr>
-                </a:tc>
-              </a:tr>
-              <a:tr h="365760">
-                <a:tc>
-                  <a:txBody>
-                    <a:bodyPr/>
-                    <a:lstStyle/>
-                    <a:p>
-                      <a:pPr indent="0" marL="0">
-                        <a:buNone/>
-                      </a:pPr>
-                      <a:r>
-                        <a:rPr lang="en-US" sz="1100" dirty="0">
-                          <a:solidFill>
-                            <a:schemeClr val="tx1"/>
-                          </a:solidFill>
-                        </a:rPr>
-                        <a:t>70% · €82.25k</a:t>
+                        <a:t>30% less · €82.25k</a:t>
                       </a:r>
                       <a:endParaRPr lang="en-US" sz="1100" dirty="0"/>
                     </a:p>
@@ -14640,182 +14446,6 @@
                   </a:tcPr>
                 </a:tc>
               </a:tr>
-              <a:tr h="365760">
-                <a:tc>
-                  <a:txBody>
-                    <a:bodyPr/>
-                    <a:lstStyle/>
-                    <a:p>
-                      <a:pPr indent="0" marL="0">
-                        <a:buNone/>
-                      </a:pPr>
-                      <a:r>
-                        <a:rPr lang="en-US" sz="1100" dirty="0">
-                          <a:solidFill>
-                            <a:schemeClr val="tx1"/>
-                          </a:solidFill>
-                        </a:rPr>
-                        <a:t>50% · €58.75k</a:t>
-                      </a:r>
-                      <a:endParaRPr lang="en-US" sz="1100" dirty="0"/>
-                    </a:p>
-                  </a:txBody>
-                  <a:tcPr marL="91440" marR="91440" marT="45720" marB="45720" anchor="ctr">
-                    <a:lnL w="6350" cap="flat" cmpd="sng" algn="ctr">
-                      <a:solidFill>
-                        <a:srgbClr val="D6DEE5"/>
-                      </a:solidFill>
-                      <a:prstDash val="solid"/>
-                      <a:round/>
-                      <a:headEnd type="none" w="med" len="med"/>
-                      <a:tailEnd type="none" w="med" len="med"/>
-                    </a:lnL>
-                    <a:lnR w="6350" cap="flat" cmpd="sng" algn="ctr">
-                      <a:solidFill>
-                        <a:srgbClr val="D6DEE5"/>
-                      </a:solidFill>
-                      <a:prstDash val="solid"/>
-                      <a:round/>
-                      <a:headEnd type="none" w="med" len="med"/>
-                      <a:tailEnd type="none" w="med" len="med"/>
-                    </a:lnR>
-                    <a:lnT w="6350" cap="flat" cmpd="sng" algn="ctr">
-                      <a:solidFill>
-                        <a:srgbClr val="D6DEE5"/>
-                      </a:solidFill>
-                      <a:prstDash val="solid"/>
-                      <a:round/>
-                      <a:headEnd type="none" w="med" len="med"/>
-                      <a:tailEnd type="none" w="med" len="med"/>
-                    </a:lnT>
-                    <a:lnB w="6350" cap="flat" cmpd="sng" algn="ctr">
-                      <a:solidFill>
-                        <a:srgbClr val="D6DEE5"/>
-                      </a:solidFill>
-                      <a:prstDash val="solid"/>
-                      <a:round/>
-                      <a:headEnd type="none" w="med" len="med"/>
-                      <a:tailEnd type="none" w="med" len="med"/>
-                    </a:lnB>
-                  </a:tcPr>
-                </a:tc>
-                <a:tc>
-                  <a:txBody>
-                    <a:bodyPr/>
-                    <a:lstStyle/>
-                    <a:p>
-                      <a:pPr algn="ctr" indent="0" marL="0">
-                        <a:buNone/>
-                      </a:pPr>
-                      <a:r>
-                        <a:rPr lang="en-US" sz="1100" b="1" dirty="0">
-                          <a:solidFill>
-                            <a:schemeClr val="tx1"/>
-                          </a:solidFill>
-                        </a:rPr>
-                        <a:t>76</a:t>
-                      </a:r>
-                      <a:endParaRPr lang="en-US" sz="1100" dirty="0"/>
-                    </a:p>
-                  </a:txBody>
-                  <a:tcPr marL="91440" marR="91440" marT="45720" marB="45720" anchor="ctr">
-                    <a:lnL w="6350" cap="flat" cmpd="sng" algn="ctr">
-                      <a:solidFill>
-                        <a:srgbClr val="D6DEE5"/>
-                      </a:solidFill>
-                      <a:prstDash val="solid"/>
-                      <a:round/>
-                      <a:headEnd type="none" w="med" len="med"/>
-                      <a:tailEnd type="none" w="med" len="med"/>
-                    </a:lnL>
-                    <a:lnR w="6350" cap="flat" cmpd="sng" algn="ctr">
-                      <a:solidFill>
-                        <a:srgbClr val="D6DEE5"/>
-                      </a:solidFill>
-                      <a:prstDash val="solid"/>
-                      <a:round/>
-                      <a:headEnd type="none" w="med" len="med"/>
-                      <a:tailEnd type="none" w="med" len="med"/>
-                    </a:lnR>
-                    <a:lnT w="6350" cap="flat" cmpd="sng" algn="ctr">
-                      <a:solidFill>
-                        <a:srgbClr val="D6DEE5"/>
-                      </a:solidFill>
-                      <a:prstDash val="solid"/>
-                      <a:round/>
-                      <a:headEnd type="none" w="med" len="med"/>
-                      <a:tailEnd type="none" w="med" len="med"/>
-                    </a:lnT>
-                    <a:lnB w="6350" cap="flat" cmpd="sng" algn="ctr">
-                      <a:solidFill>
-                        <a:srgbClr val="D6DEE5"/>
-                      </a:solidFill>
-                      <a:prstDash val="solid"/>
-                      <a:round/>
-                      <a:headEnd type="none" w="med" len="med"/>
-                      <a:tailEnd type="none" w="med" len="med"/>
-                    </a:lnB>
-                  </a:tcPr>
-                </a:tc>
-                <a:tc>
-                  <a:txBody>
-                    <a:bodyPr/>
-                    <a:lstStyle/>
-                    <a:p>
-                      <a:pPr algn="ctr" indent="0" marL="0">
-                        <a:buNone/>
-                      </a:pPr>
-                      <a:r>
-                        <a:rPr lang="en-US" sz="1100" dirty="0">
-                          <a:solidFill>
-                            <a:schemeClr val="tx1"/>
-                          </a:solidFill>
-                        </a:rPr>
-                        <a:t>€774</a:t>
-                      </a:r>
-                      <a:endParaRPr lang="en-US" sz="1100" dirty="0"/>
-                    </a:p>
-                  </a:txBody>
-                  <a:tcPr marL="91440" marR="91440" marT="45720" marB="45720" anchor="ctr">
-                    <a:lnL w="6350" cap="flat" cmpd="sng" algn="ctr">
-                      <a:solidFill>
-                        <a:srgbClr val="D6DEE5"/>
-                      </a:solidFill>
-                      <a:prstDash val="solid"/>
-                      <a:round/>
-                      <a:headEnd type="none" w="med" len="med"/>
-                      <a:tailEnd type="none" w="med" len="med"/>
-                    </a:lnL>
-                    <a:lnR w="6350" cap="flat" cmpd="sng" algn="ctr">
-                      <a:solidFill>
-                        <a:srgbClr val="D6DEE5"/>
-                      </a:solidFill>
-                      <a:prstDash val="solid"/>
-                      <a:round/>
-                      <a:headEnd type="none" w="med" len="med"/>
-                      <a:tailEnd type="none" w="med" len="med"/>
-                    </a:lnR>
-                    <a:lnT w="6350" cap="flat" cmpd="sng" algn="ctr">
-                      <a:solidFill>
-                        <a:srgbClr val="D6DEE5"/>
-                      </a:solidFill>
-                      <a:prstDash val="solid"/>
-                      <a:round/>
-                      <a:headEnd type="none" w="med" len="med"/>
-                      <a:tailEnd type="none" w="med" len="med"/>
-                    </a:lnT>
-                    <a:lnB w="6350" cap="flat" cmpd="sng" algn="ctr">
-                      <a:solidFill>
-                        <a:srgbClr val="D6DEE5"/>
-                      </a:solidFill>
-                      <a:prstDash val="solid"/>
-                      <a:round/>
-                      <a:headEnd type="none" w="med" len="med"/>
-                      <a:tailEnd type="none" w="med" len="med"/>
-                    </a:lnB>
-                  </a:tcPr>
-                </a:tc>
-              </a:tr>
             </a:tbl>
           </a:graphicData>
         </a:graphic>
@@ -14828,8 +14458,8 @@
         </p:nvSpPr>
         <p:spPr>
           <a:xfrm>
-            <a:off x="7498080" y="3291840"/>
-            <a:ext cx="4233672" cy="2834640"/>
+            <a:off x="7498080" y="2377440"/>
+            <a:ext cx="4233672" cy="3291840"/>
           </a:xfrm>
           <a:prstGeom prst="rect">
             <a:avLst/>

</xml_diff>

<commit_message>
Ready-to-share pass: explicit sensitivity tie-break, derived-input notes name their inputs, clean file metadata
Co-Authored-By: Claude Opus 5.5 <noreply@anthropic.com>
Claude-Session: https://claude.ai/code/session_01V2NJtrYy3bzNxqKeiRXJfY
</commit_message>
<xml_diff>
--- a/operation_uptime/Operation_Uptime_Deck.pptx
+++ b/operation_uptime/Operation_Uptime_Deck.pptx
@@ -114,30 +114,30 @@
   <p:extLst>
     <p:ext uri="{521415D9-36F7-43E2-AB2F-B90AF26B5E84}">
       <p14:sectionLst xmlns:p14="http://schemas.microsoft.com/office/powerpoint/2010/main">
-        <p14:section name="Summary" id="{eb02dada-b911-1ff0-dc16-f427edafb414}">
+        <p14:section name="Summary" id="{0998aca1-4dac-cff6-32c5-15b63094eb61}">
           <p14:sldIdLst>
             <p14:sldId id="256"/>
           </p14:sldIdLst>
         </p14:section>
-        <p14:section name="Part 1 Funnel" id="{913a2bc7-2828-f388-da77-4e2345fcd06b}">
+        <p14:section name="Part 1 Funnel" id="{c695d7fc-de8a-33fd-3ff1-d60996bf1a7f}">
           <p14:sldIdLst>
             <p14:sldId id="257"/>
             <p14:sldId id="258"/>
           </p14:sldIdLst>
         </p14:section>
-        <p14:section name="Part 2 Channels &amp; budget" id="{f4a86167-7bbd-4b65-4294-627187c83646}">
+        <p14:section name="Part 2 Channels &amp; budget" id="{07c2f6a0-4e86-45a7-661e-60b8cfdfc42d}">
           <p14:sldIdLst>
             <p14:sldId id="259"/>
             <p14:sldId id="260"/>
             <p14:sldId id="261"/>
           </p14:sldIdLst>
         </p14:section>
-        <p14:section name="Part 3 New sources" id="{f1035cb5-55eb-9169-b1cc-8ea76e1ddf1d}">
+        <p14:section name="Part 3 New sources" id="{20f604ac-afa6-484c-24a4-720bf32dbb7a}">
           <p14:sldIdLst>
             <p14:sldId id="262"/>
           </p14:sldIdLst>
         </p14:section>
-        <p14:section name="Part 4 Run it" id="{62daabf8-4e46-0b80-aaa1-eb58439c6957}">
+        <p14:section name="Part 4 Run it" id="{3a89b1d8-151f-1abe-2a65-ad443650bf5a}">
           <p14:sldIdLst>
             <p14:sldId id="263"/>
           </p14:sldIdLst>
@@ -259,7 +259,7 @@
                     <c:v>Cost per app ×1.3</c:v>
                   </c:pt>
                   <c:pt idx="5">
-                    <c:v>Capacity ×0.7</c:v>
+                    <c:v>Capacity ×0.7 (given)</c:v>
                   </c:pt>
                 </c:lvl>
               </c:multiLvlStrCache>
@@ -8831,11 +8831,11 @@
         <p:spPr>
           <a:xfrm>
             <a:off x="457200" y="1188720"/>
-            <a:ext cx="5394960" cy="4846320"/>
+            <a:ext cx="5394960" cy="3291840"/>
           </a:xfrm>
           <a:prstGeom prst="roundRect">
             <a:avLst>
-              <a:gd name="adj" fmla="val 1509"/>
+              <a:gd name="adj" fmla="val 2222"/>
             </a:avLst>
           </a:prstGeom>
           <a:solidFill>
@@ -8858,7 +8858,7 @@
         <p:spPr>
           <a:xfrm>
             <a:off x="640080" y="1325880"/>
-            <a:ext cx="5029200" cy="4572000"/>
+            <a:ext cx="5029200" cy="3063240"/>
           </a:xfrm>
           <a:prstGeom prst="rect">
             <a:avLst/>
@@ -8984,8 +8984,8 @@
         </p:nvSpPr>
         <p:spPr>
           <a:xfrm>
-            <a:off x="6126480" y="4572000"/>
-            <a:ext cx="5605272" cy="1463040"/>
+            <a:off x="6126480" y="4526280"/>
+            <a:ext cx="5605272" cy="1737360"/>
           </a:xfrm>
           <a:prstGeom prst="rect">
             <a:avLst/>
@@ -9001,7 +9001,7 @@
               <a:buNone/>
             </a:pPr>
             <a:r>
-              <a:rPr lang="en-US" sz="1250" b="1" dirty="0">
+              <a:rPr lang="en-US" sz="1200" b="1" dirty="0">
                 <a:solidFill>
                   <a:schemeClr val="accent3"/>
                 </a:solidFill>
@@ -9012,14 +9012,14 @@
               <a:buNone/>
             </a:pPr>
             <a:r>
-              <a:rPr lang="en-US" sz="1250" dirty="0">
+              <a:rPr lang="en-US" sz="1200" dirty="0">
                 <a:solidFill>
                   <a:schemeClr val="tx1"/>
                 </a:solidFill>
               </a:rPr>
-              <a:t>30% worse means 440 qualified applicants for 314 slots, so only ~71 can be hired. Spending more doesn't help. A weaker share qualified or dearer clicks only cost money (+43% / +30% media), not hires.</a:t>
+              <a:t>30% worse means 440 qualified applicants for 314 slots, so only ~71 can be hired; spending more doesn't help. Acceptance ties, but fast offers protect it; the pass rate depends on the plant's own test and is only known after interviews (week-2 check). A weaker share qualified or dearer clicks only cost money (+43% / +30% media), not hires.</a:t>
             </a:r>
-            <a:endParaRPr lang="en-US" sz="1250" dirty="0"/>
+            <a:endParaRPr lang="en-US" sz="1200" dirty="0"/>
           </a:p>
         </p:txBody>
       </p:sp>
@@ -15641,7 +15641,7 @@
                   <a:schemeClr val="tx1"/>
                 </a:solidFill>
               </a:rPr>
-              <a:t>every employer holds consenting past applicants that nobody re-markets. Here 211 records cost ~€14 per hire and fill week-1 slots. Joveo could add them as one more tracked source in any market, with no local staff.</a:t>
+              <a:t>Every employer holds consenting past applicants that nobody re-markets. Here 211 records cost ~€14 per hire and fill week-1 slots. Joveo could add them as one more tracked source in any market, with no local staff.</a:t>
             </a:r>
             <a:endParaRPr lang="en-US" sz="1200" dirty="0"/>
           </a:p>

</xml_diff>

<commit_message>
Accuracy pass (WIP): lag-aware weekly slots, social index 0.41 per source, three-label rule, hardest-role metric, source notes, deck fixes
Co-Authored-By: Claude Opus 5.5 <noreply@anthropic.com>
Claude-Session: https://claude.ai/code/session_01V2NJtrYy3bzNxqKeiRXJfY
</commit_message>
<xml_diff>
--- a/operation_uptime/Operation_Uptime_Deck.pptx
+++ b/operation_uptime/Operation_Uptime_Deck.pptx
@@ -114,30 +114,30 @@
   <p:extLst>
     <p:ext uri="{521415D9-36F7-43E2-AB2F-B90AF26B5E84}">
       <p14:sectionLst xmlns:p14="http://schemas.microsoft.com/office/powerpoint/2010/main">
-        <p14:section name="Summary" id="{0998aca1-4dac-cff6-32c5-15b63094eb61}">
+        <p14:section name="Summary" id="{b2534f28-1be0-04c9-e730-bc8cde4eff0b}">
           <p14:sldIdLst>
             <p14:sldId id="256"/>
           </p14:sldIdLst>
         </p14:section>
-        <p14:section name="Part 1 Funnel" id="{c695d7fc-de8a-33fd-3ff1-d60996bf1a7f}">
+        <p14:section name="Part 1 Funnel" id="{a5bf262f-2bcf-1ed7-14e6-98295b0d4adc}">
           <p14:sldIdLst>
             <p14:sldId id="257"/>
             <p14:sldId id="258"/>
           </p14:sldIdLst>
         </p14:section>
-        <p14:section name="Part 2 Channels &amp; budget" id="{07c2f6a0-4e86-45a7-661e-60b8cfdfc42d}">
+        <p14:section name="Part 2 Channels &amp; budget" id="{2c189f27-23d9-607a-56ef-22da50f12f00}">
           <p14:sldIdLst>
             <p14:sldId id="259"/>
             <p14:sldId id="260"/>
             <p14:sldId id="261"/>
           </p14:sldIdLst>
         </p14:section>
-        <p14:section name="Part 3 New sources" id="{20f604ac-afa6-484c-24a4-720bf32dbb7a}">
+        <p14:section name="Part 3 New sources" id="{67f979f0-ae60-e0e3-9b44-0ab93fa5f6e6}">
           <p14:sldIdLst>
             <p14:sldId id="262"/>
           </p14:sldIdLst>
         </p14:section>
-        <p14:section name="Part 4 Run it" id="{3a89b1d8-151f-1abe-2a65-ad443650bf5a}">
+        <p14:section name="Part 4 Run it" id="{6a145c07-1f8e-0405-e288-af0027a83bd0}">
           <p14:sldIdLst>
             <p14:sldId id="263"/>
           </p14:sldIdLst>
@@ -689,22 +689,22 @@
                 <c:formatCode>General</c:formatCode>
                 <c:ptCount val="9"/>
                 <c:pt idx="0">
-                  <c:v>6858</c:v>
+                  <c:v>19436</c:v>
                 </c:pt>
                 <c:pt idx="1">
-                  <c:v>11006</c:v>
+                  <c:v>10836</c:v>
                 </c:pt>
                 <c:pt idx="2">
-                  <c:v>13646</c:v>
+                  <c:v>13809</c:v>
                 </c:pt>
                 <c:pt idx="3">
-                  <c:v>13639</c:v>
+                  <c:v>14175</c:v>
                 </c:pt>
                 <c:pt idx="4">
-                  <c:v>14018</c:v>
+                  <c:v>14175</c:v>
                 </c:pt>
                 <c:pt idx="5">
-                  <c:v>13247</c:v>
+                  <c:v>1863</c:v>
                 </c:pt>
                 <c:pt idx="6">
                   <c:v>0</c:v>
@@ -936,22 +936,22 @@
                   <c:v>0</c:v>
                 </c:pt>
                 <c:pt idx="3">
-                  <c:v>888</c:v>
+                  <c:v>2566</c:v>
                 </c:pt>
                 <c:pt idx="4">
-                  <c:v>1559</c:v>
+                  <c:v>1728</c:v>
                 </c:pt>
                 <c:pt idx="5">
-                  <c:v>1983</c:v>
+                  <c:v>1992</c:v>
                 </c:pt>
                 <c:pt idx="6">
-                  <c:v>2032</c:v>
+                  <c:v>2087</c:v>
                 </c:pt>
                 <c:pt idx="7">
-                  <c:v>2082</c:v>
+                  <c:v>2092</c:v>
                 </c:pt>
                 <c:pt idx="8">
-                  <c:v>2434</c:v>
+                  <c:v>513</c:v>
                 </c:pt>
               </c:numCache>
             </c:numRef>
@@ -1169,7 +1169,7 @@
               <c:strCache>
                 <c:ptCount val="1"/>
                 <c:pt idx="0">
-                  <c:v>Recommended (€117.5k)</c:v>
+                  <c:v>Recommended (€120k)</c:v>
                 </c:pt>
               </c:strCache>
             </c:strRef>
@@ -1258,7 +1258,7 @@
               <c:strCache>
                 <c:ptCount val="1"/>
                 <c:pt idx="0">
-                  <c:v>30% less (€82.25k)</c:v>
+                  <c:v>30% less (€84k)</c:v>
                 </c:pt>
               </c:strCache>
             </c:strRef>
@@ -1326,13 +1326,13 @@
                   <c:v>20.6</c:v>
                 </c:pt>
                 <c:pt idx="1">
-                  <c:v>44.7</c:v>
+                  <c:v>44.4</c:v>
                 </c:pt>
                 <c:pt idx="2">
                   <c:v>14.5</c:v>
                 </c:pt>
                 <c:pt idx="3">
-                  <c:v>6.8</c:v>
+                  <c:v>7.5</c:v>
                 </c:pt>
               </c:numCache>
             </c:numRef>
@@ -3158,7 +3158,7 @@
                 <a:ea typeface="Cambria" pitchFamily="34" charset="-122"/>
                 <a:cs typeface="Cambria" pitchFamily="34" charset="-120"/>
               </a:rPr>
-              <a:t>€117.5k signs 100 maintenance hires by 31 Dec, if the client can assess 55 a week</a:t>
+              <a:t>€120k signs 100 maintenance hires by 31 Dec, if the client can assess 55 a week</a:t>
             </a:r>
             <a:endParaRPr lang="en-US" sz="2200" dirty="0"/>
           </a:p>
@@ -3224,7 +3224,7 @@
                 <a:ea typeface="Cambria" pitchFamily="34" charset="-122"/>
                 <a:cs typeface="Cambria" pitchFamily="34" charset="-120"/>
               </a:rPr>
-              <a:t>€117.5k</a:t>
+              <a:t>€120k</a:t>
             </a:r>
             <a:endParaRPr lang="en-US" sz="2000" dirty="0"/>
           </a:p>
@@ -3260,7 +3260,7 @@
                   <a:schemeClr val="tx2"/>
                 </a:solidFill>
               </a:rPr>
-              <a:t>budget: €99.8k plan + €17.7k reserve, released only on results</a:t>
+              <a:t>budget: €101.7k plan + €18.3k reserve, released only on results</a:t>
             </a:r>
             <a:endParaRPr lang="en-US" sz="950" dirty="0"/>
           </a:p>
@@ -3326,7 +3326,7 @@
                 <a:ea typeface="Cambria" pitchFamily="34" charset="-122"/>
                 <a:cs typeface="Cambria" pitchFamily="34" charset="-120"/>
               </a:rPr>
-              <a:t>€998</a:t>
+              <a:t>€1,017</a:t>
             </a:r>
             <a:endParaRPr lang="en-US" sz="2000" dirty="0"/>
           </a:p>
@@ -3362,7 +3362,7 @@
                   <a:schemeClr val="tx2"/>
                 </a:solidFill>
               </a:rPr>
-              <a:t>media cost per hire (€1,175 if the reserve is spent)</a:t>
+              <a:t>media cost per hire (€1,200 if the reserve is spent)</a:t>
             </a:r>
             <a:endParaRPr lang="en-US" sz="950" dirty="0"/>
           </a:p>
@@ -3521,7 +3521,7 @@
                   <a:schemeClr val="tx1"/>
                 </a:solidFill>
               </a:rPr>
-              <a:t>€750 test in every paid channel in weeks 1–2, then buy hires cheapest first.</a:t>
+              <a:t>€750 test in each pay-per-click channel in weeks 1–2, then buy hires cheapest first.</a:t>
             </a:r>
             <a:endParaRPr lang="en-US" sz="1200" dirty="0"/>
           </a:p>
@@ -3574,7 +3574,7 @@
                   <a:schemeClr val="tx1"/>
                 </a:solidFill>
               </a:rPr>
-              <a:t>How sure: 100 if funnel rates hold; pass rate 10% worse → ~92; 30% less budget → ~87.</a:t>
+              <a:t>How sure: 100 if funnel rates hold, with no slack (98% of slots used); pass rate 10% worse → ~92; 30% less budget → ~87.</a:t>
             </a:r>
             <a:endParaRPr lang="en-US" sz="1200" dirty="0"/>
           </a:p>
@@ -3985,7 +3985,7 @@
                             <a:schemeClr val="tx1"/>
                           </a:solidFill>
                         </a:rPr>
-                        <a:t>€38.0k</a:t>
+                        <a:t>€38.9k</a:t>
                       </a:r>
                       <a:endParaRPr lang="en-US" sz="1100" dirty="0"/>
                     </a:p>
@@ -4043,7 +4043,7 @@
                             <a:schemeClr val="tx1"/>
                           </a:solidFill>
                         </a:rPr>
-                        <a:t>€1,266</a:t>
+                        <a:t>€1,298</a:t>
                       </a:r>
                       <a:endParaRPr lang="en-US" sz="1100" dirty="0"/>
                     </a:p>
@@ -4219,7 +4219,7 @@
                             <a:schemeClr val="tx1"/>
                           </a:solidFill>
                         </a:rPr>
-                        <a:t>€28.9k</a:t>
+                        <a:t>€29.9k</a:t>
                       </a:r>
                       <a:endParaRPr lang="en-US" sz="1100" dirty="0"/>
                     </a:p>
@@ -4277,7 +4277,7 @@
                             <a:schemeClr val="tx1"/>
                           </a:solidFill>
                         </a:rPr>
-                        <a:t>€643</a:t>
+                        <a:t>€663</a:t>
                       </a:r>
                       <a:endParaRPr lang="en-US" sz="1100" dirty="0"/>
                     </a:p>
@@ -4921,7 +4921,7 @@
                             <a:schemeClr val="tx1"/>
                           </a:solidFill>
                         </a:rPr>
-                        <a:t>€99.8k</a:t>
+                        <a:t>€101.7k</a:t>
                       </a:r>
                       <a:endParaRPr lang="en-US" sz="1100" dirty="0"/>
                     </a:p>
@@ -4979,7 +4979,7 @@
                             <a:schemeClr val="tx1"/>
                           </a:solidFill>
                         </a:rPr>
-                        <a:t>€998</a:t>
+                        <a:t>€1,017</a:t>
                       </a:r>
                       <a:endParaRPr lang="en-US" sz="1100" dirty="0"/>
                     </a:p>
@@ -5193,7 +5193,7 @@
                   <a:schemeClr val="tx1"/>
                 </a:solidFill>
               </a:rPr>
-              <a:t>construction-electrician route needs your OK by 23 Oct; without it €127.5k.</a:t>
+              <a:t>construction-electrician route needs your OK by 23 Oct; without it €130k.</a:t>
             </a:r>
             <a:endParaRPr lang="en-US" sz="1100" dirty="0"/>
           </a:p>
@@ -5423,7 +5423,7 @@
                   <a:schemeClr val="tx1"/>
                 </a:solidFill>
               </a:rPr>
-              <a:t>Approve €117.5k</a:t>
+              <a:t>Approve €120k</a:t>
             </a:r>
             <a:endParaRPr lang="en-US" sz="1100" dirty="0"/>
           </a:p>
@@ -8632,7 +8632,7 @@
                   <a:schemeClr val="tx1"/>
                 </a:solidFill>
               </a:rPr>
-              <a:t>308 qualified applicants in the plan (from 1,619 applications) against 314 slots: 55 a week × 40 assessment days ÷ 7.</a:t>
+              <a:t>308 qualified applicants in the plan (from 1,490 applications) against 314 slots: 55 a week × 40 assessment days ÷ 7.</a:t>
             </a:r>
             <a:endParaRPr lang="en-US" sz="1200" dirty="0"/>
           </a:p>
@@ -8666,7 +8666,7 @@
                   <a:schemeClr val="tx2"/>
                 </a:solidFill>
               </a:rPr>
-              <a:t>Why 308, not 311: referrals and past applicants convert better than the table's standard rates, so the plan needs slightly fewer.</a:t>
+              <a:t>Why 308, not 311: referrals and past applicants convert better than the table's standard rates, so the plan needs slightly fewer. Applications: 1,490, not 1,260, because the plan's channels average 21% qualified (social ads lower), below the ~25% baseline.</a:t>
             </a:r>
             <a:endParaRPr lang="en-US" sz="1200" dirty="0"/>
           </a:p>
@@ -8918,7 +8918,7 @@
                   <a:schemeClr val="tx1"/>
                 </a:solidFill>
               </a:rPr>
-              <a:t>The biggest scarce block: 30 hires, 38% of the money.</a:t>
+              <a:t>Dearest last hire: €2,272, the highest of the four roles (Funnel column H).</a:t>
             </a:r>
             <a:endParaRPr lang="en-US" sz="1300" dirty="0"/>
           </a:p>
@@ -8954,7 +8954,7 @@
                   <a:schemeClr val="tx1"/>
                 </a:solidFill>
               </a:rPr>
-              <a:t>Supervisors cost more per hire but are only 10, with internal promotion as a fallback.</a:t>
+              <a:t>Automation has the tighter pool (22% of reachable people vs 12%), but needs only 15 and costs less per hire, so it is watched weekly.</a:t>
             </a:r>
             <a:endParaRPr lang="en-US" sz="1300" dirty="0"/>
           </a:p>
@@ -9196,10 +9196,11 @@
             <a:tbl>
               <a:tblPr/>
               <a:tblGrid>
-                <a:gridCol w="1828800"/>
-                <a:gridCol w="4023360"/>
-                <a:gridCol w="1097280"/>
-                <a:gridCol w="914400"/>
+                <a:gridCol w="1737360"/>
+                <a:gridCol w="822960"/>
+                <a:gridCol w="3383280"/>
+                <a:gridCol w="1051560"/>
+                <a:gridCol w="868680"/>
               </a:tblGrid>
               <a:tr h="384048">
                 <a:tc>
@@ -9217,6 +9218,67 @@
                           </a:solidFill>
                         </a:rPr>
                         <a:t>Channel</a:t>
+                      </a:r>
+                      <a:endParaRPr lang="en-US" sz="1100" dirty="0"/>
+                    </a:p>
+                  </a:txBody>
+                  <a:tcPr marL="91440" marR="91440" marT="45720" marB="45720" anchor="ctr">
+                    <a:lnL w="6350" cap="flat" cmpd="sng" algn="ctr">
+                      <a:solidFill>
+                        <a:srgbClr val="D6DEE5"/>
+                      </a:solidFill>
+                      <a:prstDash val="solid"/>
+                      <a:round/>
+                      <a:headEnd type="none" w="med" len="med"/>
+                      <a:tailEnd type="none" w="med" len="med"/>
+                    </a:lnL>
+                    <a:lnR w="6350" cap="flat" cmpd="sng" algn="ctr">
+                      <a:solidFill>
+                        <a:srgbClr val="D6DEE5"/>
+                      </a:solidFill>
+                      <a:prstDash val="solid"/>
+                      <a:round/>
+                      <a:headEnd type="none" w="med" len="med"/>
+                      <a:tailEnd type="none" w="med" len="med"/>
+                    </a:lnR>
+                    <a:lnT w="6350" cap="flat" cmpd="sng" algn="ctr">
+                      <a:solidFill>
+                        <a:srgbClr val="D6DEE5"/>
+                      </a:solidFill>
+                      <a:prstDash val="solid"/>
+                      <a:round/>
+                      <a:headEnd type="none" w="med" len="med"/>
+                      <a:tailEnd type="none" w="med" len="med"/>
+                    </a:lnT>
+                    <a:lnB w="6350" cap="flat" cmpd="sng" algn="ctr">
+                      <a:solidFill>
+                        <a:srgbClr val="D6DEE5"/>
+                      </a:solidFill>
+                      <a:prstDash val="solid"/>
+                      <a:round/>
+                      <a:headEnd type="none" w="med" len="med"/>
+                      <a:tailEnd type="none" w="med" len="med"/>
+                    </a:lnB>
+                    <a:solidFill>
+                      <a:schemeClr val="tx1"/>
+                    </a:solidFill>
+                  </a:tcPr>
+                </a:tc>
+                <a:tc>
+                  <a:txBody>
+                    <a:bodyPr/>
+                    <a:lstStyle/>
+                    <a:p>
+                      <a:pPr algn="ctr" indent="0" marL="0">
+                        <a:buNone/>
+                      </a:pPr>
+                      <a:r>
+                        <a:rPr lang="en-US" sz="1100" b="1" dirty="0">
+                          <a:solidFill>
+                            <a:schemeClr val="bg1"/>
+                          </a:solidFill>
+                        </a:rPr>
+                        <a:t>Roles</a:t>
                       </a:r>
                       <a:endParaRPr lang="en-US" sz="1100" dirty="0"/>
                     </a:p>
@@ -9511,6 +9573,64 @@
                     <a:bodyPr/>
                     <a:lstStyle/>
                     <a:p>
+                      <a:pPr algn="ctr" indent="0" marL="0">
+                        <a:buNone/>
+                      </a:pPr>
+                      <a:r>
+                        <a:rPr lang="en-US" sz="1100" dirty="0">
+                          <a:solidFill>
+                            <a:schemeClr val="tx1"/>
+                          </a:solidFill>
+                        </a:rPr>
+                        <a:t>E M A S</a:t>
+                      </a:r>
+                      <a:endParaRPr lang="en-US" sz="1100" dirty="0"/>
+                    </a:p>
+                  </a:txBody>
+                  <a:tcPr marL="91440" marR="91440" marT="45720" marB="45720" anchor="ctr">
+                    <a:lnL w="6350" cap="flat" cmpd="sng" algn="ctr">
+                      <a:solidFill>
+                        <a:srgbClr val="D6DEE5"/>
+                      </a:solidFill>
+                      <a:prstDash val="solid"/>
+                      <a:round/>
+                      <a:headEnd type="none" w="med" len="med"/>
+                      <a:tailEnd type="none" w="med" len="med"/>
+                    </a:lnL>
+                    <a:lnR w="6350" cap="flat" cmpd="sng" algn="ctr">
+                      <a:solidFill>
+                        <a:srgbClr val="D6DEE5"/>
+                      </a:solidFill>
+                      <a:prstDash val="solid"/>
+                      <a:round/>
+                      <a:headEnd type="none" w="med" len="med"/>
+                      <a:tailEnd type="none" w="med" len="med"/>
+                    </a:lnR>
+                    <a:lnT w="6350" cap="flat" cmpd="sng" algn="ctr">
+                      <a:solidFill>
+                        <a:srgbClr val="D6DEE5"/>
+                      </a:solidFill>
+                      <a:prstDash val="solid"/>
+                      <a:round/>
+                      <a:headEnd type="none" w="med" len="med"/>
+                      <a:tailEnd type="none" w="med" len="med"/>
+                    </a:lnT>
+                    <a:lnB w="6350" cap="flat" cmpd="sng" algn="ctr">
+                      <a:solidFill>
+                        <a:srgbClr val="D6DEE5"/>
+                      </a:solidFill>
+                      <a:prstDash val="solid"/>
+                      <a:round/>
+                      <a:headEnd type="none" w="med" len="med"/>
+                      <a:tailEnd type="none" w="med" len="med"/>
+                    </a:lnB>
+                  </a:tcPr>
+                </a:tc>
+                <a:tc>
+                  <a:txBody>
+                    <a:bodyPr/>
+                    <a:lstStyle/>
+                    <a:p>
                       <a:pPr indent="0" marL="0">
                         <a:buNone/>
                       </a:pPr>
@@ -9745,6 +9865,64 @@
                     <a:bodyPr/>
                     <a:lstStyle/>
                     <a:p>
+                      <a:pPr algn="ctr" indent="0" marL="0">
+                        <a:buNone/>
+                      </a:pPr>
+                      <a:r>
+                        <a:rPr lang="en-US" sz="1100" dirty="0">
+                          <a:solidFill>
+                            <a:schemeClr val="tx1"/>
+                          </a:solidFill>
+                        </a:rPr>
+                        <a:t>E M A S</a:t>
+                      </a:r>
+                      <a:endParaRPr lang="en-US" sz="1100" dirty="0"/>
+                    </a:p>
+                  </a:txBody>
+                  <a:tcPr marL="91440" marR="91440" marT="45720" marB="45720" anchor="ctr">
+                    <a:lnL w="6350" cap="flat" cmpd="sng" algn="ctr">
+                      <a:solidFill>
+                        <a:srgbClr val="D6DEE5"/>
+                      </a:solidFill>
+                      <a:prstDash val="solid"/>
+                      <a:round/>
+                      <a:headEnd type="none" w="med" len="med"/>
+                      <a:tailEnd type="none" w="med" len="med"/>
+                    </a:lnL>
+                    <a:lnR w="6350" cap="flat" cmpd="sng" algn="ctr">
+                      <a:solidFill>
+                        <a:srgbClr val="D6DEE5"/>
+                      </a:solidFill>
+                      <a:prstDash val="solid"/>
+                      <a:round/>
+                      <a:headEnd type="none" w="med" len="med"/>
+                      <a:tailEnd type="none" w="med" len="med"/>
+                    </a:lnR>
+                    <a:lnT w="6350" cap="flat" cmpd="sng" algn="ctr">
+                      <a:solidFill>
+                        <a:srgbClr val="D6DEE5"/>
+                      </a:solidFill>
+                      <a:prstDash val="solid"/>
+                      <a:round/>
+                      <a:headEnd type="none" w="med" len="med"/>
+                      <a:tailEnd type="none" w="med" len="med"/>
+                    </a:lnT>
+                    <a:lnB w="6350" cap="flat" cmpd="sng" algn="ctr">
+                      <a:solidFill>
+                        <a:srgbClr val="D6DEE5"/>
+                      </a:solidFill>
+                      <a:prstDash val="solid"/>
+                      <a:round/>
+                      <a:headEnd type="none" w="med" len="med"/>
+                      <a:tailEnd type="none" w="med" len="med"/>
+                    </a:lnB>
+                  </a:tcPr>
+                </a:tc>
+                <a:tc>
+                  <a:txBody>
+                    <a:bodyPr/>
+                    <a:lstStyle/>
+                    <a:p>
                       <a:pPr indent="0" marL="0">
                         <a:buNone/>
                       </a:pPr>
@@ -9979,6 +10157,64 @@
                     <a:bodyPr/>
                     <a:lstStyle/>
                     <a:p>
+                      <a:pPr algn="ctr" indent="0" marL="0">
+                        <a:buNone/>
+                      </a:pPr>
+                      <a:r>
+                        <a:rPr lang="en-US" sz="1100" dirty="0">
+                          <a:solidFill>
+                            <a:schemeClr val="tx1"/>
+                          </a:solidFill>
+                        </a:rPr>
+                        <a:t>M</a:t>
+                      </a:r>
+                      <a:endParaRPr lang="en-US" sz="1100" dirty="0"/>
+                    </a:p>
+                  </a:txBody>
+                  <a:tcPr marL="91440" marR="91440" marT="45720" marB="45720" anchor="ctr">
+                    <a:lnL w="6350" cap="flat" cmpd="sng" algn="ctr">
+                      <a:solidFill>
+                        <a:srgbClr val="D6DEE5"/>
+                      </a:solidFill>
+                      <a:prstDash val="solid"/>
+                      <a:round/>
+                      <a:headEnd type="none" w="med" len="med"/>
+                      <a:tailEnd type="none" w="med" len="med"/>
+                    </a:lnL>
+                    <a:lnR w="6350" cap="flat" cmpd="sng" algn="ctr">
+                      <a:solidFill>
+                        <a:srgbClr val="D6DEE5"/>
+                      </a:solidFill>
+                      <a:prstDash val="solid"/>
+                      <a:round/>
+                      <a:headEnd type="none" w="med" len="med"/>
+                      <a:tailEnd type="none" w="med" len="med"/>
+                    </a:lnR>
+                    <a:lnT w="6350" cap="flat" cmpd="sng" algn="ctr">
+                      <a:solidFill>
+                        <a:srgbClr val="D6DEE5"/>
+                      </a:solidFill>
+                      <a:prstDash val="solid"/>
+                      <a:round/>
+                      <a:headEnd type="none" w="med" len="med"/>
+                      <a:tailEnd type="none" w="med" len="med"/>
+                    </a:lnT>
+                    <a:lnB w="6350" cap="flat" cmpd="sng" algn="ctr">
+                      <a:solidFill>
+                        <a:srgbClr val="D6DEE5"/>
+                      </a:solidFill>
+                      <a:prstDash val="solid"/>
+                      <a:round/>
+                      <a:headEnd type="none" w="med" len="med"/>
+                      <a:tailEnd type="none" w="med" len="med"/>
+                    </a:lnB>
+                  </a:tcPr>
+                </a:tc>
+                <a:tc>
+                  <a:txBody>
+                    <a:bodyPr/>
+                    <a:lstStyle/>
+                    <a:p>
                       <a:pPr indent="0" marL="0">
                         <a:buNone/>
                       </a:pPr>
@@ -10213,6 +10449,64 @@
                     <a:bodyPr/>
                     <a:lstStyle/>
                     <a:p>
+                      <a:pPr algn="ctr" indent="0" marL="0">
+                        <a:buNone/>
+                      </a:pPr>
+                      <a:r>
+                        <a:rPr lang="en-US" sz="1100" dirty="0">
+                          <a:solidFill>
+                            <a:schemeClr val="tx1"/>
+                          </a:solidFill>
+                        </a:rPr>
+                        <a:t>E M A S</a:t>
+                      </a:r>
+                      <a:endParaRPr lang="en-US" sz="1100" dirty="0"/>
+                    </a:p>
+                  </a:txBody>
+                  <a:tcPr marL="91440" marR="91440" marT="45720" marB="45720" anchor="ctr">
+                    <a:lnL w="6350" cap="flat" cmpd="sng" algn="ctr">
+                      <a:solidFill>
+                        <a:srgbClr val="D6DEE5"/>
+                      </a:solidFill>
+                      <a:prstDash val="solid"/>
+                      <a:round/>
+                      <a:headEnd type="none" w="med" len="med"/>
+                      <a:tailEnd type="none" w="med" len="med"/>
+                    </a:lnL>
+                    <a:lnR w="6350" cap="flat" cmpd="sng" algn="ctr">
+                      <a:solidFill>
+                        <a:srgbClr val="D6DEE5"/>
+                      </a:solidFill>
+                      <a:prstDash val="solid"/>
+                      <a:round/>
+                      <a:headEnd type="none" w="med" len="med"/>
+                      <a:tailEnd type="none" w="med" len="med"/>
+                    </a:lnR>
+                    <a:lnT w="6350" cap="flat" cmpd="sng" algn="ctr">
+                      <a:solidFill>
+                        <a:srgbClr val="D6DEE5"/>
+                      </a:solidFill>
+                      <a:prstDash val="solid"/>
+                      <a:round/>
+                      <a:headEnd type="none" w="med" len="med"/>
+                      <a:tailEnd type="none" w="med" len="med"/>
+                    </a:lnT>
+                    <a:lnB w="6350" cap="flat" cmpd="sng" algn="ctr">
+                      <a:solidFill>
+                        <a:srgbClr val="D6DEE5"/>
+                      </a:solidFill>
+                      <a:prstDash val="solid"/>
+                      <a:round/>
+                      <a:headEnd type="none" w="med" len="med"/>
+                      <a:tailEnd type="none" w="med" len="med"/>
+                    </a:lnB>
+                  </a:tcPr>
+                </a:tc>
+                <a:tc>
+                  <a:txBody>
+                    <a:bodyPr/>
+                    <a:lstStyle/>
+                    <a:p>
                       <a:pPr indent="0" marL="0">
                         <a:buNone/>
                       </a:pPr>
@@ -10447,6 +10741,64 @@
                     <a:bodyPr/>
                     <a:lstStyle/>
                     <a:p>
+                      <a:pPr algn="ctr" indent="0" marL="0">
+                        <a:buNone/>
+                      </a:pPr>
+                      <a:r>
+                        <a:rPr lang="en-US" sz="1100" dirty="0">
+                          <a:solidFill>
+                            <a:schemeClr val="tx1"/>
+                          </a:solidFill>
+                        </a:rPr>
+                        <a:t>E</a:t>
+                      </a:r>
+                      <a:endParaRPr lang="en-US" sz="1100" dirty="0"/>
+                    </a:p>
+                  </a:txBody>
+                  <a:tcPr marL="91440" marR="91440" marT="45720" marB="45720" anchor="ctr">
+                    <a:lnL w="6350" cap="flat" cmpd="sng" algn="ctr">
+                      <a:solidFill>
+                        <a:srgbClr val="D6DEE5"/>
+                      </a:solidFill>
+                      <a:prstDash val="solid"/>
+                      <a:round/>
+                      <a:headEnd type="none" w="med" len="med"/>
+                      <a:tailEnd type="none" w="med" len="med"/>
+                    </a:lnL>
+                    <a:lnR w="6350" cap="flat" cmpd="sng" algn="ctr">
+                      <a:solidFill>
+                        <a:srgbClr val="D6DEE5"/>
+                      </a:solidFill>
+                      <a:prstDash val="solid"/>
+                      <a:round/>
+                      <a:headEnd type="none" w="med" len="med"/>
+                      <a:tailEnd type="none" w="med" len="med"/>
+                    </a:lnR>
+                    <a:lnT w="6350" cap="flat" cmpd="sng" algn="ctr">
+                      <a:solidFill>
+                        <a:srgbClr val="D6DEE5"/>
+                      </a:solidFill>
+                      <a:prstDash val="solid"/>
+                      <a:round/>
+                      <a:headEnd type="none" w="med" len="med"/>
+                      <a:tailEnd type="none" w="med" len="med"/>
+                    </a:lnT>
+                    <a:lnB w="6350" cap="flat" cmpd="sng" algn="ctr">
+                      <a:solidFill>
+                        <a:srgbClr val="D6DEE5"/>
+                      </a:solidFill>
+                      <a:prstDash val="solid"/>
+                      <a:round/>
+                      <a:headEnd type="none" w="med" len="med"/>
+                      <a:tailEnd type="none" w="med" len="med"/>
+                    </a:lnB>
+                  </a:tcPr>
+                </a:tc>
+                <a:tc>
+                  <a:txBody>
+                    <a:bodyPr/>
+                    <a:lstStyle/>
+                    <a:p>
                       <a:pPr indent="0" marL="0">
                         <a:buNone/>
                       </a:pPr>
@@ -10681,6 +11033,64 @@
                     <a:bodyPr/>
                     <a:lstStyle/>
                     <a:p>
+                      <a:pPr algn="ctr" indent="0" marL="0">
+                        <a:buNone/>
+                      </a:pPr>
+                      <a:r>
+                        <a:rPr lang="en-US" sz="1100" dirty="0">
+                          <a:solidFill>
+                            <a:schemeClr val="tx1"/>
+                          </a:solidFill>
+                        </a:rPr>
+                        <a:t>E M</a:t>
+                      </a:r>
+                      <a:endParaRPr lang="en-US" sz="1100" dirty="0"/>
+                    </a:p>
+                  </a:txBody>
+                  <a:tcPr marL="91440" marR="91440" marT="45720" marB="45720" anchor="ctr">
+                    <a:lnL w="6350" cap="flat" cmpd="sng" algn="ctr">
+                      <a:solidFill>
+                        <a:srgbClr val="D6DEE5"/>
+                      </a:solidFill>
+                      <a:prstDash val="solid"/>
+                      <a:round/>
+                      <a:headEnd type="none" w="med" len="med"/>
+                      <a:tailEnd type="none" w="med" len="med"/>
+                    </a:lnL>
+                    <a:lnR w="6350" cap="flat" cmpd="sng" algn="ctr">
+                      <a:solidFill>
+                        <a:srgbClr val="D6DEE5"/>
+                      </a:solidFill>
+                      <a:prstDash val="solid"/>
+                      <a:round/>
+                      <a:headEnd type="none" w="med" len="med"/>
+                      <a:tailEnd type="none" w="med" len="med"/>
+                    </a:lnR>
+                    <a:lnT w="6350" cap="flat" cmpd="sng" algn="ctr">
+                      <a:solidFill>
+                        <a:srgbClr val="D6DEE5"/>
+                      </a:solidFill>
+                      <a:prstDash val="solid"/>
+                      <a:round/>
+                      <a:headEnd type="none" w="med" len="med"/>
+                      <a:tailEnd type="none" w="med" len="med"/>
+                    </a:lnT>
+                    <a:lnB w="6350" cap="flat" cmpd="sng" algn="ctr">
+                      <a:solidFill>
+                        <a:srgbClr val="D6DEE5"/>
+                      </a:solidFill>
+                      <a:prstDash val="solid"/>
+                      <a:round/>
+                      <a:headEnd type="none" w="med" len="med"/>
+                      <a:tailEnd type="none" w="med" len="med"/>
+                    </a:lnB>
+                  </a:tcPr>
+                </a:tc>
+                <a:tc>
+                  <a:txBody>
+                    <a:bodyPr/>
+                    <a:lstStyle/>
+                    <a:p>
                       <a:pPr indent="0" marL="0">
                         <a:buNone/>
                       </a:pPr>
@@ -10915,6 +11325,64 @@
                     <a:bodyPr/>
                     <a:lstStyle/>
                     <a:p>
+                      <a:pPr algn="ctr" indent="0" marL="0">
+                        <a:buNone/>
+                      </a:pPr>
+                      <a:r>
+                        <a:rPr lang="en-US" sz="1100" dirty="0">
+                          <a:solidFill>
+                            <a:schemeClr val="tx1"/>
+                          </a:solidFill>
+                        </a:rPr>
+                        <a:t>A S</a:t>
+                      </a:r>
+                      <a:endParaRPr lang="en-US" sz="1100" dirty="0"/>
+                    </a:p>
+                  </a:txBody>
+                  <a:tcPr marL="91440" marR="91440" marT="45720" marB="45720" anchor="ctr">
+                    <a:lnL w="6350" cap="flat" cmpd="sng" algn="ctr">
+                      <a:solidFill>
+                        <a:srgbClr val="D6DEE5"/>
+                      </a:solidFill>
+                      <a:prstDash val="solid"/>
+                      <a:round/>
+                      <a:headEnd type="none" w="med" len="med"/>
+                      <a:tailEnd type="none" w="med" len="med"/>
+                    </a:lnL>
+                    <a:lnR w="6350" cap="flat" cmpd="sng" algn="ctr">
+                      <a:solidFill>
+                        <a:srgbClr val="D6DEE5"/>
+                      </a:solidFill>
+                      <a:prstDash val="solid"/>
+                      <a:round/>
+                      <a:headEnd type="none" w="med" len="med"/>
+                      <a:tailEnd type="none" w="med" len="med"/>
+                    </a:lnR>
+                    <a:lnT w="6350" cap="flat" cmpd="sng" algn="ctr">
+                      <a:solidFill>
+                        <a:srgbClr val="D6DEE5"/>
+                      </a:solidFill>
+                      <a:prstDash val="solid"/>
+                      <a:round/>
+                      <a:headEnd type="none" w="med" len="med"/>
+                      <a:tailEnd type="none" w="med" len="med"/>
+                    </a:lnT>
+                    <a:lnB w="6350" cap="flat" cmpd="sng" algn="ctr">
+                      <a:solidFill>
+                        <a:srgbClr val="D6DEE5"/>
+                      </a:solidFill>
+                      <a:prstDash val="solid"/>
+                      <a:round/>
+                      <a:headEnd type="none" w="med" len="med"/>
+                      <a:tailEnd type="none" w="med" len="med"/>
+                    </a:lnB>
+                  </a:tcPr>
+                </a:tc>
+                <a:tc>
+                  <a:txBody>
+                    <a:bodyPr/>
+                    <a:lstStyle/>
+                    <a:p>
                       <a:pPr indent="0" marL="0">
                         <a:buNone/>
                       </a:pPr>
@@ -11041,6 +11509,298 @@
                           </a:solidFill>
                         </a:rPr>
                         <a:t>16.1</a:t>
+                      </a:r>
+                      <a:endParaRPr lang="en-US" sz="1100" dirty="0"/>
+                    </a:p>
+                  </a:txBody>
+                  <a:tcPr marL="91440" marR="91440" marT="45720" marB="45720" anchor="ctr">
+                    <a:lnL w="6350" cap="flat" cmpd="sng" algn="ctr">
+                      <a:solidFill>
+                        <a:srgbClr val="D6DEE5"/>
+                      </a:solidFill>
+                      <a:prstDash val="solid"/>
+                      <a:round/>
+                      <a:headEnd type="none" w="med" len="med"/>
+                      <a:tailEnd type="none" w="med" len="med"/>
+                    </a:lnL>
+                    <a:lnR w="6350" cap="flat" cmpd="sng" algn="ctr">
+                      <a:solidFill>
+                        <a:srgbClr val="D6DEE5"/>
+                      </a:solidFill>
+                      <a:prstDash val="solid"/>
+                      <a:round/>
+                      <a:headEnd type="none" w="med" len="med"/>
+                      <a:tailEnd type="none" w="med" len="med"/>
+                    </a:lnR>
+                    <a:lnT w="6350" cap="flat" cmpd="sng" algn="ctr">
+                      <a:solidFill>
+                        <a:srgbClr val="D6DEE5"/>
+                      </a:solidFill>
+                      <a:prstDash val="solid"/>
+                      <a:round/>
+                      <a:headEnd type="none" w="med" len="med"/>
+                      <a:tailEnd type="none" w="med" len="med"/>
+                    </a:lnT>
+                    <a:lnB w="6350" cap="flat" cmpd="sng" algn="ctr">
+                      <a:solidFill>
+                        <a:srgbClr val="D6DEE5"/>
+                      </a:solidFill>
+                      <a:prstDash val="solid"/>
+                      <a:round/>
+                      <a:headEnd type="none" w="med" len="med"/>
+                      <a:tailEnd type="none" w="med" len="med"/>
+                    </a:lnB>
+                  </a:tcPr>
+                </a:tc>
+              </a:tr>
+              <a:tr h="384048">
+                <a:tc>
+                  <a:txBody>
+                    <a:bodyPr/>
+                    <a:lstStyle/>
+                    <a:p>
+                      <a:pPr indent="0" marL="0">
+                        <a:buNone/>
+                      </a:pPr>
+                      <a:r>
+                        <a:rPr lang="en-US" sz="1100" b="1" dirty="0">
+                          <a:solidFill>
+                            <a:schemeClr val="tx1"/>
+                          </a:solidFill>
+                        </a:rPr>
+                        <a:t>Programmatic</a:t>
+                      </a:r>
+                      <a:endParaRPr lang="en-US" sz="1100" dirty="0"/>
+                    </a:p>
+                  </a:txBody>
+                  <a:tcPr marL="91440" marR="91440" marT="45720" marB="45720" anchor="ctr">
+                    <a:lnL w="6350" cap="flat" cmpd="sng" algn="ctr">
+                      <a:solidFill>
+                        <a:srgbClr val="D6DEE5"/>
+                      </a:solidFill>
+                      <a:prstDash val="solid"/>
+                      <a:round/>
+                      <a:headEnd type="none" w="med" len="med"/>
+                      <a:tailEnd type="none" w="med" len="med"/>
+                    </a:lnL>
+                    <a:lnR w="6350" cap="flat" cmpd="sng" algn="ctr">
+                      <a:solidFill>
+                        <a:srgbClr val="D6DEE5"/>
+                      </a:solidFill>
+                      <a:prstDash val="solid"/>
+                      <a:round/>
+                      <a:headEnd type="none" w="med" len="med"/>
+                      <a:tailEnd type="none" w="med" len="med"/>
+                    </a:lnR>
+                    <a:lnT w="6350" cap="flat" cmpd="sng" algn="ctr">
+                      <a:solidFill>
+                        <a:srgbClr val="D6DEE5"/>
+                      </a:solidFill>
+                      <a:prstDash val="solid"/>
+                      <a:round/>
+                      <a:headEnd type="none" w="med" len="med"/>
+                      <a:tailEnd type="none" w="med" len="med"/>
+                    </a:lnT>
+                    <a:lnB w="6350" cap="flat" cmpd="sng" algn="ctr">
+                      <a:solidFill>
+                        <a:srgbClr val="D6DEE5"/>
+                      </a:solidFill>
+                      <a:prstDash val="solid"/>
+                      <a:round/>
+                      <a:headEnd type="none" w="med" len="med"/>
+                      <a:tailEnd type="none" w="med" len="med"/>
+                    </a:lnB>
+                  </a:tcPr>
+                </a:tc>
+                <a:tc>
+                  <a:txBody>
+                    <a:bodyPr/>
+                    <a:lstStyle/>
+                    <a:p>
+                      <a:pPr algn="ctr" indent="0" marL="0">
+                        <a:buNone/>
+                      </a:pPr>
+                      <a:r>
+                        <a:rPr lang="en-US" sz="1100" dirty="0">
+                          <a:solidFill>
+                            <a:schemeClr val="tx1"/>
+                          </a:solidFill>
+                        </a:rPr>
+                        <a:t>E M A S</a:t>
+                      </a:r>
+                      <a:endParaRPr lang="en-US" sz="1100" dirty="0"/>
+                    </a:p>
+                  </a:txBody>
+                  <a:tcPr marL="91440" marR="91440" marT="45720" marB="45720" anchor="ctr">
+                    <a:lnL w="6350" cap="flat" cmpd="sng" algn="ctr">
+                      <a:solidFill>
+                        <a:srgbClr val="D6DEE5"/>
+                      </a:solidFill>
+                      <a:prstDash val="solid"/>
+                      <a:round/>
+                      <a:headEnd type="none" w="med" len="med"/>
+                      <a:tailEnd type="none" w="med" len="med"/>
+                    </a:lnL>
+                    <a:lnR w="6350" cap="flat" cmpd="sng" algn="ctr">
+                      <a:solidFill>
+                        <a:srgbClr val="D6DEE5"/>
+                      </a:solidFill>
+                      <a:prstDash val="solid"/>
+                      <a:round/>
+                      <a:headEnd type="none" w="med" len="med"/>
+                      <a:tailEnd type="none" w="med" len="med"/>
+                    </a:lnR>
+                    <a:lnT w="6350" cap="flat" cmpd="sng" algn="ctr">
+                      <a:solidFill>
+                        <a:srgbClr val="D6DEE5"/>
+                      </a:solidFill>
+                      <a:prstDash val="solid"/>
+                      <a:round/>
+                      <a:headEnd type="none" w="med" len="med"/>
+                      <a:tailEnd type="none" w="med" len="med"/>
+                    </a:lnT>
+                    <a:lnB w="6350" cap="flat" cmpd="sng" algn="ctr">
+                      <a:solidFill>
+                        <a:srgbClr val="D6DEE5"/>
+                      </a:solidFill>
+                      <a:prstDash val="solid"/>
+                      <a:round/>
+                      <a:headEnd type="none" w="med" len="med"/>
+                      <a:tailEnd type="none" w="med" len="med"/>
+                    </a:lnB>
+                  </a:tcPr>
+                </a:tc>
+                <a:tc>
+                  <a:txBody>
+                    <a:bodyPr/>
+                    <a:lstStyle/>
+                    <a:p>
+                      <a:pPr indent="0" marL="0">
+                        <a:buNone/>
+                      </a:pPr>
+                      <a:r>
+                        <a:rPr lang="en-US" sz="1100" dirty="0">
+                          <a:solidFill>
+                            <a:schemeClr val="tx1"/>
+                          </a:solidFill>
+                        </a:rPr>
+                        <a:t>Indeed and other boards, paid per application</a:t>
+                      </a:r>
+                      <a:endParaRPr lang="en-US" sz="1100" dirty="0"/>
+                    </a:p>
+                  </a:txBody>
+                  <a:tcPr marL="91440" marR="91440" marT="45720" marB="45720" anchor="ctr">
+                    <a:lnL w="6350" cap="flat" cmpd="sng" algn="ctr">
+                      <a:solidFill>
+                        <a:srgbClr val="D6DEE5"/>
+                      </a:solidFill>
+                      <a:prstDash val="solid"/>
+                      <a:round/>
+                      <a:headEnd type="none" w="med" len="med"/>
+                      <a:tailEnd type="none" w="med" len="med"/>
+                    </a:lnL>
+                    <a:lnR w="6350" cap="flat" cmpd="sng" algn="ctr">
+                      <a:solidFill>
+                        <a:srgbClr val="D6DEE5"/>
+                      </a:solidFill>
+                      <a:prstDash val="solid"/>
+                      <a:round/>
+                      <a:headEnd type="none" w="med" len="med"/>
+                      <a:tailEnd type="none" w="med" len="med"/>
+                    </a:lnR>
+                    <a:lnT w="6350" cap="flat" cmpd="sng" algn="ctr">
+                      <a:solidFill>
+                        <a:srgbClr val="D6DEE5"/>
+                      </a:solidFill>
+                      <a:prstDash val="solid"/>
+                      <a:round/>
+                      <a:headEnd type="none" w="med" len="med"/>
+                      <a:tailEnd type="none" w="med" len="med"/>
+                    </a:lnT>
+                    <a:lnB w="6350" cap="flat" cmpd="sng" algn="ctr">
+                      <a:solidFill>
+                        <a:srgbClr val="D6DEE5"/>
+                      </a:solidFill>
+                      <a:prstDash val="solid"/>
+                      <a:round/>
+                      <a:headEnd type="none" w="med" len="med"/>
+                      <a:tailEnd type="none" w="med" len="med"/>
+                    </a:lnB>
+                  </a:tcPr>
+                </a:tc>
+                <a:tc>
+                  <a:txBody>
+                    <a:bodyPr/>
+                    <a:lstStyle/>
+                    <a:p>
+                      <a:pPr algn="ctr" indent="0" marL="0">
+                        <a:buNone/>
+                      </a:pPr>
+                      <a:r>
+                        <a:rPr lang="en-US" sz="1100" dirty="0">
+                          <a:solidFill>
+                            <a:schemeClr val="tx1"/>
+                          </a:solidFill>
+                        </a:rPr>
+                        <a:t>€2,143</a:t>
+                      </a:r>
+                      <a:endParaRPr lang="en-US" sz="1100" dirty="0"/>
+                    </a:p>
+                  </a:txBody>
+                  <a:tcPr marL="91440" marR="91440" marT="45720" marB="45720" anchor="ctr">
+                    <a:lnL w="6350" cap="flat" cmpd="sng" algn="ctr">
+                      <a:solidFill>
+                        <a:srgbClr val="D6DEE5"/>
+                      </a:solidFill>
+                      <a:prstDash val="solid"/>
+                      <a:round/>
+                      <a:headEnd type="none" w="med" len="med"/>
+                      <a:tailEnd type="none" w="med" len="med"/>
+                    </a:lnL>
+                    <a:lnR w="6350" cap="flat" cmpd="sng" algn="ctr">
+                      <a:solidFill>
+                        <a:srgbClr val="D6DEE5"/>
+                      </a:solidFill>
+                      <a:prstDash val="solid"/>
+                      <a:round/>
+                      <a:headEnd type="none" w="med" len="med"/>
+                      <a:tailEnd type="none" w="med" len="med"/>
+                    </a:lnR>
+                    <a:lnT w="6350" cap="flat" cmpd="sng" algn="ctr">
+                      <a:solidFill>
+                        <a:srgbClr val="D6DEE5"/>
+                      </a:solidFill>
+                      <a:prstDash val="solid"/>
+                      <a:round/>
+                      <a:headEnd type="none" w="med" len="med"/>
+                      <a:tailEnd type="none" w="med" len="med"/>
+                    </a:lnT>
+                    <a:lnB w="6350" cap="flat" cmpd="sng" algn="ctr">
+                      <a:solidFill>
+                        <a:srgbClr val="D6DEE5"/>
+                      </a:solidFill>
+                      <a:prstDash val="solid"/>
+                      <a:round/>
+                      <a:headEnd type="none" w="med" len="med"/>
+                      <a:tailEnd type="none" w="med" len="med"/>
+                    </a:lnB>
+                  </a:tcPr>
+                </a:tc>
+                <a:tc>
+                  <a:txBody>
+                    <a:bodyPr/>
+                    <a:lstStyle/>
+                    <a:p>
+                      <a:pPr algn="ctr" indent="0" marL="0">
+                        <a:buNone/>
+                      </a:pPr>
+                      <a:r>
+                        <a:rPr lang="en-US" sz="1100" dirty="0">
+                          <a:solidFill>
+                            <a:schemeClr val="tx1"/>
+                          </a:solidFill>
+                        </a:rPr>
+                        <a:t>16.4</a:t>
                       </a:r>
                       <a:endParaRPr lang="en-US" sz="1100" dirty="0"/>
                     </a:p>
@@ -11149,6 +11909,64 @@
                     <a:bodyPr/>
                     <a:lstStyle/>
                     <a:p>
+                      <a:pPr algn="ctr" indent="0" marL="0">
+                        <a:buNone/>
+                      </a:pPr>
+                      <a:r>
+                        <a:rPr lang="en-US" sz="1100" dirty="0">
+                          <a:solidFill>
+                            <a:schemeClr val="tx1"/>
+                          </a:solidFill>
+                        </a:rPr>
+                        <a:t>E M</a:t>
+                      </a:r>
+                      <a:endParaRPr lang="en-US" sz="1100" dirty="0"/>
+                    </a:p>
+                  </a:txBody>
+                  <a:tcPr marL="91440" marR="91440" marT="45720" marB="45720" anchor="ctr">
+                    <a:lnL w="6350" cap="flat" cmpd="sng" algn="ctr">
+                      <a:solidFill>
+                        <a:srgbClr val="D6DEE5"/>
+                      </a:solidFill>
+                      <a:prstDash val="solid"/>
+                      <a:round/>
+                      <a:headEnd type="none" w="med" len="med"/>
+                      <a:tailEnd type="none" w="med" len="med"/>
+                    </a:lnL>
+                    <a:lnR w="6350" cap="flat" cmpd="sng" algn="ctr">
+                      <a:solidFill>
+                        <a:srgbClr val="D6DEE5"/>
+                      </a:solidFill>
+                      <a:prstDash val="solid"/>
+                      <a:round/>
+                      <a:headEnd type="none" w="med" len="med"/>
+                      <a:tailEnd type="none" w="med" len="med"/>
+                    </a:lnR>
+                    <a:lnT w="6350" cap="flat" cmpd="sng" algn="ctr">
+                      <a:solidFill>
+                        <a:srgbClr val="D6DEE5"/>
+                      </a:solidFill>
+                      <a:prstDash val="solid"/>
+                      <a:round/>
+                      <a:headEnd type="none" w="med" len="med"/>
+                      <a:tailEnd type="none" w="med" len="med"/>
+                    </a:lnT>
+                    <a:lnB w="6350" cap="flat" cmpd="sng" algn="ctr">
+                      <a:solidFill>
+                        <a:srgbClr val="D6DEE5"/>
+                      </a:solidFill>
+                      <a:prstDash val="solid"/>
+                      <a:round/>
+                      <a:headEnd type="none" w="med" len="med"/>
+                      <a:tailEnd type="none" w="med" len="med"/>
+                    </a:lnB>
+                  </a:tcPr>
+                </a:tc>
+                <a:tc>
+                  <a:txBody>
+                    <a:bodyPr/>
+                    <a:lstStyle/>
+                    <a:p>
                       <a:pPr indent="0" marL="0">
                         <a:buNone/>
                       </a:pPr>
@@ -11216,7 +12034,7 @@
                             <a:schemeClr val="tx1"/>
                           </a:solidFill>
                         </a:rPr>
-                        <a:t>€1,963</a:t>
+                        <a:t>€2,388</a:t>
                       </a:r>
                       <a:endParaRPr lang="en-US" sz="1100" dirty="0"/>
                     </a:p>
@@ -11274,241 +12092,7 @@
                             <a:schemeClr val="tx1"/>
                           </a:solidFill>
                         </a:rPr>
-                        <a:t>13.3</a:t>
-                      </a:r>
-                      <a:endParaRPr lang="en-US" sz="1100" dirty="0"/>
-                    </a:p>
-                  </a:txBody>
-                  <a:tcPr marL="91440" marR="91440" marT="45720" marB="45720" anchor="ctr">
-                    <a:lnL w="6350" cap="flat" cmpd="sng" algn="ctr">
-                      <a:solidFill>
-                        <a:srgbClr val="D6DEE5"/>
-                      </a:solidFill>
-                      <a:prstDash val="solid"/>
-                      <a:round/>
-                      <a:headEnd type="none" w="med" len="med"/>
-                      <a:tailEnd type="none" w="med" len="med"/>
-                    </a:lnL>
-                    <a:lnR w="6350" cap="flat" cmpd="sng" algn="ctr">
-                      <a:solidFill>
-                        <a:srgbClr val="D6DEE5"/>
-                      </a:solidFill>
-                      <a:prstDash val="solid"/>
-                      <a:round/>
-                      <a:headEnd type="none" w="med" len="med"/>
-                      <a:tailEnd type="none" w="med" len="med"/>
-                    </a:lnR>
-                    <a:lnT w="6350" cap="flat" cmpd="sng" algn="ctr">
-                      <a:solidFill>
-                        <a:srgbClr val="D6DEE5"/>
-                      </a:solidFill>
-                      <a:prstDash val="solid"/>
-                      <a:round/>
-                      <a:headEnd type="none" w="med" len="med"/>
-                      <a:tailEnd type="none" w="med" len="med"/>
-                    </a:lnT>
-                    <a:lnB w="6350" cap="flat" cmpd="sng" algn="ctr">
-                      <a:solidFill>
-                        <a:srgbClr val="D6DEE5"/>
-                      </a:solidFill>
-                      <a:prstDash val="solid"/>
-                      <a:round/>
-                      <a:headEnd type="none" w="med" len="med"/>
-                      <a:tailEnd type="none" w="med" len="med"/>
-                    </a:lnB>
-                  </a:tcPr>
-                </a:tc>
-              </a:tr>
-              <a:tr h="384048">
-                <a:tc>
-                  <a:txBody>
-                    <a:bodyPr/>
-                    <a:lstStyle/>
-                    <a:p>
-                      <a:pPr indent="0" marL="0">
-                        <a:buNone/>
-                      </a:pPr>
-                      <a:r>
-                        <a:rPr lang="en-US" sz="1100" b="1" dirty="0">
-                          <a:solidFill>
-                            <a:schemeClr val="tx1"/>
-                          </a:solidFill>
-                        </a:rPr>
-                        <a:t>Programmatic</a:t>
-                      </a:r>
-                      <a:endParaRPr lang="en-US" sz="1100" dirty="0"/>
-                    </a:p>
-                  </a:txBody>
-                  <a:tcPr marL="91440" marR="91440" marT="45720" marB="45720" anchor="ctr">
-                    <a:lnL w="6350" cap="flat" cmpd="sng" algn="ctr">
-                      <a:solidFill>
-                        <a:srgbClr val="D6DEE5"/>
-                      </a:solidFill>
-                      <a:prstDash val="solid"/>
-                      <a:round/>
-                      <a:headEnd type="none" w="med" len="med"/>
-                      <a:tailEnd type="none" w="med" len="med"/>
-                    </a:lnL>
-                    <a:lnR w="6350" cap="flat" cmpd="sng" algn="ctr">
-                      <a:solidFill>
-                        <a:srgbClr val="D6DEE5"/>
-                      </a:solidFill>
-                      <a:prstDash val="solid"/>
-                      <a:round/>
-                      <a:headEnd type="none" w="med" len="med"/>
-                      <a:tailEnd type="none" w="med" len="med"/>
-                    </a:lnR>
-                    <a:lnT w="6350" cap="flat" cmpd="sng" algn="ctr">
-                      <a:solidFill>
-                        <a:srgbClr val="D6DEE5"/>
-                      </a:solidFill>
-                      <a:prstDash val="solid"/>
-                      <a:round/>
-                      <a:headEnd type="none" w="med" len="med"/>
-                      <a:tailEnd type="none" w="med" len="med"/>
-                    </a:lnT>
-                    <a:lnB w="6350" cap="flat" cmpd="sng" algn="ctr">
-                      <a:solidFill>
-                        <a:srgbClr val="D6DEE5"/>
-                      </a:solidFill>
-                      <a:prstDash val="solid"/>
-                      <a:round/>
-                      <a:headEnd type="none" w="med" len="med"/>
-                      <a:tailEnd type="none" w="med" len="med"/>
-                    </a:lnB>
-                  </a:tcPr>
-                </a:tc>
-                <a:tc>
-                  <a:txBody>
-                    <a:bodyPr/>
-                    <a:lstStyle/>
-                    <a:p>
-                      <a:pPr indent="0" marL="0">
-                        <a:buNone/>
-                      </a:pPr>
-                      <a:r>
-                        <a:rPr lang="en-US" sz="1100" dirty="0">
-                          <a:solidFill>
-                            <a:schemeClr val="tx1"/>
-                          </a:solidFill>
-                        </a:rPr>
-                        <a:t>Indeed and other boards, paid per application</a:t>
-                      </a:r>
-                      <a:endParaRPr lang="en-US" sz="1100" dirty="0"/>
-                    </a:p>
-                  </a:txBody>
-                  <a:tcPr marL="91440" marR="91440" marT="45720" marB="45720" anchor="ctr">
-                    <a:lnL w="6350" cap="flat" cmpd="sng" algn="ctr">
-                      <a:solidFill>
-                        <a:srgbClr val="D6DEE5"/>
-                      </a:solidFill>
-                      <a:prstDash val="solid"/>
-                      <a:round/>
-                      <a:headEnd type="none" w="med" len="med"/>
-                      <a:tailEnd type="none" w="med" len="med"/>
-                    </a:lnL>
-                    <a:lnR w="6350" cap="flat" cmpd="sng" algn="ctr">
-                      <a:solidFill>
-                        <a:srgbClr val="D6DEE5"/>
-                      </a:solidFill>
-                      <a:prstDash val="solid"/>
-                      <a:round/>
-                      <a:headEnd type="none" w="med" len="med"/>
-                      <a:tailEnd type="none" w="med" len="med"/>
-                    </a:lnR>
-                    <a:lnT w="6350" cap="flat" cmpd="sng" algn="ctr">
-                      <a:solidFill>
-                        <a:srgbClr val="D6DEE5"/>
-                      </a:solidFill>
-                      <a:prstDash val="solid"/>
-                      <a:round/>
-                      <a:headEnd type="none" w="med" len="med"/>
-                      <a:tailEnd type="none" w="med" len="med"/>
-                    </a:lnT>
-                    <a:lnB w="6350" cap="flat" cmpd="sng" algn="ctr">
-                      <a:solidFill>
-                        <a:srgbClr val="D6DEE5"/>
-                      </a:solidFill>
-                      <a:prstDash val="solid"/>
-                      <a:round/>
-                      <a:headEnd type="none" w="med" len="med"/>
-                      <a:tailEnd type="none" w="med" len="med"/>
-                    </a:lnB>
-                  </a:tcPr>
-                </a:tc>
-                <a:tc>
-                  <a:txBody>
-                    <a:bodyPr/>
-                    <a:lstStyle/>
-                    <a:p>
-                      <a:pPr algn="ctr" indent="0" marL="0">
-                        <a:buNone/>
-                      </a:pPr>
-                      <a:r>
-                        <a:rPr lang="en-US" sz="1100" dirty="0">
-                          <a:solidFill>
-                            <a:schemeClr val="tx1"/>
-                          </a:solidFill>
-                        </a:rPr>
-                        <a:t>€2,317</a:t>
-                      </a:r>
-                      <a:endParaRPr lang="en-US" sz="1100" dirty="0"/>
-                    </a:p>
-                  </a:txBody>
-                  <a:tcPr marL="91440" marR="91440" marT="45720" marB="45720" anchor="ctr">
-                    <a:lnL w="6350" cap="flat" cmpd="sng" algn="ctr">
-                      <a:solidFill>
-                        <a:srgbClr val="D6DEE5"/>
-                      </a:solidFill>
-                      <a:prstDash val="solid"/>
-                      <a:round/>
-                      <a:headEnd type="none" w="med" len="med"/>
-                      <a:tailEnd type="none" w="med" len="med"/>
-                    </a:lnL>
-                    <a:lnR w="6350" cap="flat" cmpd="sng" algn="ctr">
-                      <a:solidFill>
-                        <a:srgbClr val="D6DEE5"/>
-                      </a:solidFill>
-                      <a:prstDash val="solid"/>
-                      <a:round/>
-                      <a:headEnd type="none" w="med" len="med"/>
-                      <a:tailEnd type="none" w="med" len="med"/>
-                    </a:lnR>
-                    <a:lnT w="6350" cap="flat" cmpd="sng" algn="ctr">
-                      <a:solidFill>
-                        <a:srgbClr val="D6DEE5"/>
-                      </a:solidFill>
-                      <a:prstDash val="solid"/>
-                      <a:round/>
-                      <a:headEnd type="none" w="med" len="med"/>
-                      <a:tailEnd type="none" w="med" len="med"/>
-                    </a:lnT>
-                    <a:lnB w="6350" cap="flat" cmpd="sng" algn="ctr">
-                      <a:solidFill>
-                        <a:srgbClr val="D6DEE5"/>
-                      </a:solidFill>
-                      <a:prstDash val="solid"/>
-                      <a:round/>
-                      <a:headEnd type="none" w="med" len="med"/>
-                      <a:tailEnd type="none" w="med" len="med"/>
-                    </a:lnB>
-                  </a:tcPr>
-                </a:tc>
-                <a:tc>
-                  <a:txBody>
-                    <a:bodyPr/>
-                    <a:lstStyle/>
-                    <a:p>
-                      <a:pPr algn="ctr" indent="0" marL="0">
-                        <a:buNone/>
-                      </a:pPr>
-                      <a:r>
-                        <a:rPr lang="en-US" sz="1100" dirty="0">
-                          <a:solidFill>
-                            <a:schemeClr val="tx1"/>
-                          </a:solidFill>
-                        </a:rPr>
-                        <a:t>3.8</a:t>
+                        <a:t>0.6</a:t>
                       </a:r>
                       <a:endParaRPr lang="en-US" sz="1100" dirty="0"/>
                     </a:p>
@@ -11569,6 +12153,64 @@
                           </a:solidFill>
                         </a:rPr>
                         <a:t>Google Search</a:t>
+                      </a:r>
+                      <a:endParaRPr lang="en-US" sz="1100" dirty="0"/>
+                    </a:p>
+                  </a:txBody>
+                  <a:tcPr marL="91440" marR="91440" marT="45720" marB="45720" anchor="ctr">
+                    <a:lnL w="6350" cap="flat" cmpd="sng" algn="ctr">
+                      <a:solidFill>
+                        <a:srgbClr val="D6DEE5"/>
+                      </a:solidFill>
+                      <a:prstDash val="solid"/>
+                      <a:round/>
+                      <a:headEnd type="none" w="med" len="med"/>
+                      <a:tailEnd type="none" w="med" len="med"/>
+                    </a:lnL>
+                    <a:lnR w="6350" cap="flat" cmpd="sng" algn="ctr">
+                      <a:solidFill>
+                        <a:srgbClr val="D6DEE5"/>
+                      </a:solidFill>
+                      <a:prstDash val="solid"/>
+                      <a:round/>
+                      <a:headEnd type="none" w="med" len="med"/>
+                      <a:tailEnd type="none" w="med" len="med"/>
+                    </a:lnR>
+                    <a:lnT w="6350" cap="flat" cmpd="sng" algn="ctr">
+                      <a:solidFill>
+                        <a:srgbClr val="D6DEE5"/>
+                      </a:solidFill>
+                      <a:prstDash val="solid"/>
+                      <a:round/>
+                      <a:headEnd type="none" w="med" len="med"/>
+                      <a:tailEnd type="none" w="med" len="med"/>
+                    </a:lnT>
+                    <a:lnB w="6350" cap="flat" cmpd="sng" algn="ctr">
+                      <a:solidFill>
+                        <a:srgbClr val="D6DEE5"/>
+                      </a:solidFill>
+                      <a:prstDash val="solid"/>
+                      <a:round/>
+                      <a:headEnd type="none" w="med" len="med"/>
+                      <a:tailEnd type="none" w="med" len="med"/>
+                    </a:lnB>
+                  </a:tcPr>
+                </a:tc>
+                <a:tc>
+                  <a:txBody>
+                    <a:bodyPr/>
+                    <a:lstStyle/>
+                    <a:p>
+                      <a:pPr algn="ctr" indent="0" marL="0">
+                        <a:buNone/>
+                      </a:pPr>
+                      <a:r>
+                        <a:rPr lang="en-US" sz="1100" dirty="0">
+                          <a:solidFill>
+                            <a:schemeClr val="tx1"/>
+                          </a:solidFill>
+                        </a:rPr>
+                        <a:t>E M A S</a:t>
                       </a:r>
                       <a:endParaRPr lang="en-US" sz="1100" dirty="0"/>
                     </a:p>
@@ -11905,7 +12547,25 @@
                   <a:schemeClr val="tx1"/>
                 </a:solidFill>
               </a:rPr>
-              <a:t>Every paid channel gets a €750 test first; the dearest (Search, most programmatic) stay at test level.</a:t>
+              <a:t>Each pay-per-click channel gets a €750 test per role first; the dearest (Search, most programmatic) stay at test level.</a:t>
+            </a:r>
+            <a:endParaRPr lang="en-US" sz="1150" dirty="0"/>
+          </a:p>
+          <a:p>
+            <a:pPr marL="342900" indent="-342900">
+              <a:spcAft>
+                <a:spcPts val="800"/>
+              </a:spcAft>
+              <a:buSzPct val="100000"/>
+              <a:buChar char="•"/>
+            </a:pPr>
+            <a:r>
+              <a:rPr lang="en-US" sz="1150" dirty="0">
+                <a:solidFill>
+                  <a:schemeClr val="tx1"/>
+                </a:solidFill>
+              </a:rPr>
+              <a:t>Roles: E electricians, M mechatronics, A automation, S supervisors.</a:t>
             </a:r>
             <a:endParaRPr lang="en-US" sz="1150" dirty="0"/>
           </a:p>
@@ -12055,7 +12715,7 @@
                 <a:ea typeface="Cambria" pitchFamily="34" charset="-122"/>
                 <a:cs typeface="Cambria" pitchFamily="34" charset="-120"/>
               </a:rPr>
-              <a:t>€99.8k planned across roles and weeks, plus a €17.7k reserve</a:t>
+              <a:t>€101.7k planned across roles and weeks, plus a €18.3k reserve</a:t>
             </a:r>
             <a:endParaRPr lang="en-US" sz="2200" dirty="0"/>
           </a:p>
@@ -12424,7 +13084,7 @@
                             <a:schemeClr val="tx1"/>
                           </a:solidFill>
                         </a:rPr>
-                        <a:t>€38.0k</a:t>
+                        <a:t>€38.9k</a:t>
                       </a:r>
                       <a:endParaRPr lang="en-US" sz="1100" dirty="0"/>
                     </a:p>
@@ -12540,7 +13200,7 @@
                             <a:schemeClr val="tx1"/>
                           </a:solidFill>
                         </a:rPr>
-                        <a:t>€1,266</a:t>
+                        <a:t>€1,298</a:t>
                       </a:r>
                       <a:endParaRPr lang="en-US" sz="1100" dirty="0"/>
                     </a:p>
@@ -12658,7 +13318,7 @@
                             <a:schemeClr val="tx1"/>
                           </a:solidFill>
                         </a:rPr>
-                        <a:t>€28.9k</a:t>
+                        <a:t>€29.9k</a:t>
                       </a:r>
                       <a:endParaRPr lang="en-US" sz="1100" dirty="0"/>
                     </a:p>
@@ -12774,7 +13434,7 @@
                             <a:schemeClr val="tx1"/>
                           </a:solidFill>
                         </a:rPr>
-                        <a:t>€643</a:t>
+                        <a:t>€663</a:t>
                       </a:r>
                       <a:endParaRPr lang="en-US" sz="1100" dirty="0"/>
                     </a:p>
@@ -13360,7 +14020,7 @@
                             <a:schemeClr val="tx1"/>
                           </a:solidFill>
                         </a:rPr>
-                        <a:t>€99.8k</a:t>
+                        <a:t>€101.7k</a:t>
                       </a:r>
                       <a:endParaRPr lang="en-US" sz="1100" dirty="0"/>
                     </a:p>
@@ -13476,7 +14136,7 @@
                             <a:schemeClr val="tx1"/>
                           </a:solidFill>
                         </a:rPr>
-                        <a:t>€998</a:t>
+                        <a:t>€1,017</a:t>
                       </a:r>
                       <a:endParaRPr lang="en-US" sz="1100" dirty="0"/>
                     </a:p>
@@ -13572,7 +14232,7 @@
                   <a:schemeClr val="tx1"/>
                 </a:solidFill>
               </a:rPr>
-              <a:t>€9.0k in weeks 1–2 (€750 per paid channel and role).</a:t>
+              <a:t>€9k in weeks 1–2: 12 tests of €750 (programmatic, LinkedIn, Meta, Search × role).</a:t>
             </a:r>
             <a:endParaRPr lang="en-US" sz="1200" dirty="0"/>
           </a:p>
@@ -13634,7 +14294,7 @@
                   <a:schemeClr val="tx1"/>
                 </a:solidFill>
               </a:rPr>
-              <a:t>€17.7k (15% + rounding), released from week 3 only on results.</a:t>
+              <a:t>€18.3k (15% + rounding), released from week 3 only on results.</a:t>
             </a:r>
             <a:endParaRPr lang="en-US" sz="1200" dirty="0"/>
           </a:p>
@@ -13701,7 +14361,7 @@
                   <a:schemeClr val="tx2"/>
                 </a:solidFill>
               </a:rPr>
-              <a:t>Weeks 1–2 carry the tests, StepStone ads and set-up; weekly spend then follows the pacing that keeps assessments within 55 a week.</a:t>
+              <a:t>Why week 1 is biggest: assessments start 22 Oct and an unused slot is lost, so week-1 applications must fill 11 days of slots (22 Oct – 1 Nov). The tests then decide where weeks 3–6 money goes. Week 6 is small: only 24 Nov is still a useful application day.</a:t>
             </a:r>
             <a:endParaRPr lang="en-US" sz="1150" dirty="0"/>
           </a:p>
@@ -13851,7 +14511,7 @@
                 <a:ea typeface="Cambria" pitchFamily="34" charset="-122"/>
                 <a:cs typeface="Cambria" pitchFamily="34" charset="-120"/>
               </a:rPr>
-              <a:t>30% less (€82.25k) signs ~87; electricians fall short first</a:t>
+              <a:t>30% less (€84k) signs ~87; electricians fall short first</a:t>
             </a:r>
             <a:endParaRPr lang="en-US" sz="2200" dirty="0"/>
           </a:p>
@@ -14100,7 +14760,7 @@
                             <a:schemeClr val="tx1"/>
                           </a:solidFill>
                         </a:rPr>
-                        <a:t>Recommended · €117.50k</a:t>
+                        <a:t>Recommended · €120k</a:t>
                       </a:r>
                       <a:endParaRPr lang="en-US" sz="1100" dirty="0"/>
                     </a:p>
@@ -14216,7 +14876,7 @@
                             <a:schemeClr val="tx1"/>
                           </a:solidFill>
                         </a:rPr>
-                        <a:t>€1,175</a:t>
+                        <a:t>€1,200</a:t>
                       </a:r>
                       <a:endParaRPr lang="en-US" sz="1100" dirty="0"/>
                     </a:p>
@@ -14276,7 +14936,7 @@
                             <a:schemeClr val="tx1"/>
                           </a:solidFill>
                         </a:rPr>
-                        <a:t>30% less · €82.25k</a:t>
+                        <a:t>30% less · €84k</a:t>
                       </a:r>
                       <a:endParaRPr lang="en-US" sz="1100" dirty="0"/>
                     </a:p>
@@ -14398,7 +15058,7 @@
                             <a:schemeClr val="tx1"/>
                           </a:solidFill>
                         </a:rPr>
-                        <a:t>€949</a:t>
+                        <a:t>€966</a:t>
                       </a:r>
                       <a:endParaRPr lang="en-US" sz="1100" dirty="0"/>
                     </a:p>
@@ -14528,7 +15188,7 @@
                   <a:schemeClr val="tx1"/>
                 </a:solidFill>
               </a:rPr>
-              <a:t>electricians 20.6 of 30, supervisors 6.8 of 10, automation 14.5 of 15, mechatronics 44.7 of 45.</a:t>
+              <a:t>electricians 20.6 of 30, supervisors 7.5 of 10, mechatronics 44.4 of 45, automation 14.5 of 15.</a:t>
             </a:r>
             <a:endParaRPr lang="en-US" sz="1200" dirty="0"/>
           </a:p>
@@ -14559,7 +15219,7 @@
                   <a:schemeClr val="tx1"/>
                 </a:solidFill>
               </a:rPr>
-              <a:t>the last €35.25k buys ~13 hires, mostly electricians, the people who keep the lines running. Keep it. If you must cut, cover supervisors by internal promotion and protect electricians.</a:t>
+              <a:t>the last €36k buys ~13 hires, mostly electricians, the people who keep the lines running. Keep it. If you must cut, the rule cuts the dearest channels, which are mostly electrician and supervisor channels: agree that up front, and cover supervisors by internal promotion.</a:t>
             </a:r>
             <a:endParaRPr lang="en-US" sz="1200" dirty="0"/>
           </a:p>
@@ -14724,7 +15384,7 @@
         <p:spPr>
           <a:xfrm>
             <a:off x="457200" y="1188720"/>
-            <a:ext cx="3630168" cy="3977640"/>
+            <a:ext cx="3630168" cy="4206240"/>
           </a:xfrm>
           <a:prstGeom prst="roundRect">
             <a:avLst>
@@ -14811,7 +15471,7 @@
         <p:spPr>
           <a:xfrm>
             <a:off x="594360" y="1691640"/>
-            <a:ext cx="3355848" cy="3383280"/>
+            <a:ext cx="3355848" cy="3611880"/>
           </a:xfrm>
           <a:prstGeom prst="rect">
             <a:avLst/>
@@ -14825,12 +15485,12 @@
           <a:p>
             <a:pPr indent="0" marL="0">
               <a:spcAft>
-                <a:spcPts val="400"/>
+                <a:spcPts val="300"/>
               </a:spcAft>
               <a:buNone/>
             </a:pPr>
             <a:r>
-              <a:rPr lang="en-US" sz="1200" b="1" dirty="0">
+              <a:rPr lang="en-US" sz="1150" b="1" dirty="0">
                 <a:solidFill>
                   <a:schemeClr val="accent6"/>
                 </a:solidFill>
@@ -14839,29 +15499,29 @@
             </a:r>
             <a:pPr indent="0" marL="0">
               <a:spcAft>
-                <a:spcPts val="400"/>
+                <a:spcPts val="300"/>
               </a:spcAft>
               <a:buNone/>
             </a:pPr>
             <a:r>
-              <a:rPr lang="en-US" sz="1200" dirty="0">
+              <a:rPr lang="en-US" sz="1150" dirty="0">
                 <a:solidFill>
                   <a:schemeClr val="tx1"/>
                 </a:solidFill>
               </a:rPr>
               <a:t>211 past runners-up (consented, last year) + staff referrals</a:t>
             </a:r>
-            <a:endParaRPr lang="en-US" sz="1200" dirty="0"/>
+            <a:endParaRPr lang="en-US" sz="1150" dirty="0"/>
           </a:p>
           <a:p>
             <a:pPr indent="0" marL="0">
               <a:spcAft>
-                <a:spcPts val="400"/>
+                <a:spcPts val="300"/>
               </a:spcAft>
               <a:buNone/>
             </a:pPr>
             <a:r>
-              <a:rPr lang="en-US" sz="1200" b="1" dirty="0">
+              <a:rPr lang="en-US" sz="1150" b="1" dirty="0">
                 <a:solidFill>
                   <a:schemeClr val="accent6"/>
                 </a:solidFill>
@@ -14870,29 +15530,29 @@
             </a:r>
             <a:pPr indent="0" marL="0">
               <a:spcAft>
-                <a:spcPts val="400"/>
+                <a:spcPts val="300"/>
               </a:spcAft>
               <a:buNone/>
             </a:pPr>
             <a:r>
-              <a:rPr lang="en-US" sz="1200" dirty="0">
+              <a:rPr lang="en-US" sz="1150" dirty="0">
                 <a:solidFill>
                   <a:schemeClr val="tx1"/>
                 </a:solidFill>
               </a:rPr>
               <a:t>Email + SMS waves on days 2, 7 and 14; €1,000 bonus per signed referral</a:t>
             </a:r>
-            <a:endParaRPr lang="en-US" sz="1200" dirty="0"/>
+            <a:endParaRPr lang="en-US" sz="1150" dirty="0"/>
           </a:p>
           <a:p>
             <a:pPr indent="0" marL="0">
               <a:spcAft>
-                <a:spcPts val="400"/>
+                <a:spcPts val="300"/>
               </a:spcAft>
               <a:buNone/>
             </a:pPr>
             <a:r>
-              <a:rPr lang="en-US" sz="1200" b="1" dirty="0">
+              <a:rPr lang="en-US" sz="1150" b="1" dirty="0">
                 <a:solidFill>
                   <a:schemeClr val="accent6"/>
                 </a:solidFill>
@@ -14901,29 +15561,29 @@
             </a:r>
             <a:pPr indent="0" marL="0">
               <a:spcAft>
-                <a:spcPts val="400"/>
+                <a:spcPts val="300"/>
               </a:spcAft>
               <a:buNone/>
             </a:pPr>
             <a:r>
-              <a:rPr lang="en-US" sz="1200" dirty="0">
+              <a:rPr lang="en-US" sz="1150" dirty="0">
                 <a:solidFill>
                   <a:schemeClr val="tx1"/>
                 </a:solidFill>
               </a:rPr>
-              <a:t>Already screened and already wanted Tesla; ~€3 per application</a:t>
+              <a:t>Already screened and already wanted Tesla; ~€2.50 per application</a:t>
             </a:r>
-            <a:endParaRPr lang="en-US" sz="1200" dirty="0"/>
+            <a:endParaRPr lang="en-US" sz="1150" dirty="0"/>
           </a:p>
           <a:p>
             <a:pPr indent="0" marL="0">
               <a:spcAft>
-                <a:spcPts val="400"/>
+                <a:spcPts val="300"/>
               </a:spcAft>
               <a:buNone/>
             </a:pPr>
             <a:r>
-              <a:rPr lang="en-US" sz="1200" b="1" dirty="0">
+              <a:rPr lang="en-US" sz="1150" b="1" dirty="0">
                 <a:solidFill>
                   <a:schemeClr val="accent6"/>
                 </a:solidFill>
@@ -14932,29 +15592,29 @@
             </a:r>
             <a:pPr indent="0" marL="0">
               <a:spcAft>
-                <a:spcPts val="400"/>
+                <a:spcPts val="300"/>
               </a:spcAft>
               <a:buNone/>
             </a:pPr>
             <a:r>
-              <a:rPr lang="en-US" sz="1200" dirty="0">
+              <a:rPr lang="en-US" sz="1150" dirty="0">
                 <a:solidFill>
                   <a:schemeClr val="tx1"/>
                 </a:solidFill>
               </a:rPr>
-              <a:t>€63 + €11.0k bonuses → 25 re-apps + 66 referrals → ~42 qualified → ~16 hires</a:t>
+              <a:t>€63 + €11k bonuses → 25 re-apps + 66 referrals → ~42 qualified → ~16 hires</a:t>
             </a:r>
-            <a:endParaRPr lang="en-US" sz="1200" dirty="0"/>
+            <a:endParaRPr lang="en-US" sz="1150" dirty="0"/>
           </a:p>
           <a:p>
             <a:pPr indent="0" marL="0">
               <a:spcAft>
-                <a:spcPts val="400"/>
+                <a:spcPts val="300"/>
               </a:spcAft>
               <a:buNone/>
             </a:pPr>
             <a:r>
-              <a:rPr lang="en-US" sz="1200" b="1" dirty="0">
+              <a:rPr lang="en-US" sz="1150" b="1" dirty="0">
                 <a:solidFill>
                   <a:schemeClr val="accent6"/>
                 </a:solidFill>
@@ -14963,29 +15623,29 @@
             </a:r>
             <a:pPr indent="0" marL="0">
               <a:spcAft>
-                <a:spcPts val="400"/>
+                <a:spcPts val="300"/>
               </a:spcAft>
               <a:buNone/>
             </a:pPr>
             <a:r>
-              <a:rPr lang="en-US" sz="1200" dirty="0">
+              <a:rPr lang="en-US" sz="1150" dirty="0">
                 <a:solidFill>
                   <a:schemeClr val="tx1"/>
                 </a:solidFill>
               </a:rPr>
-              <a:t>Wed 21 Oct – Tue 3 Nov (waves 1–3): €63. Pass: ≥10 qualified. Kill: &lt;6 → no further re-contacts; bonus stays live</a:t>
+              <a:t>Wed 21 Oct – Tue 3 Nov (waves 1–3): €63. Pass: ≥13 qualified. Kill: &lt;7 → no further re-contacts; bonus stays live</a:t>
             </a:r>
-            <a:endParaRPr lang="en-US" sz="1200" dirty="0"/>
+            <a:endParaRPr lang="en-US" sz="1150" dirty="0"/>
           </a:p>
           <a:p>
             <a:pPr indent="0" marL="0">
               <a:spcAft>
-                <a:spcPts val="400"/>
+                <a:spcPts val="300"/>
               </a:spcAft>
               <a:buNone/>
             </a:pPr>
             <a:r>
-              <a:rPr lang="en-US" sz="1200" b="1" dirty="0">
+              <a:rPr lang="en-US" sz="1150" b="1" dirty="0">
                 <a:solidFill>
                   <a:schemeClr val="accent6"/>
                 </a:solidFill>
@@ -14994,19 +15654,19 @@
             </a:r>
             <a:pPr indent="0" marL="0">
               <a:spcAft>
-                <a:spcPts val="400"/>
+                <a:spcPts val="300"/>
               </a:spcAft>
               <a:buNone/>
             </a:pPr>
             <a:r>
-              <a:rPr lang="en-US" sz="1200" dirty="0">
+              <a:rPr lang="en-US" sz="1150" dirty="0">
                 <a:solidFill>
                   <a:schemeClr val="tx1"/>
                 </a:solidFill>
               </a:rPr>
-              <a:t>Me: copy, segments, tracked links. Client: GDPR-checked export, bonus approval, one staff message</a:t>
+              <a:t>Setup 1 day (live Wed 21 Oct). Me: copy, segments, tracked links. Client: GDPR-checked export, bonus approval, one staff message</a:t>
             </a:r>
-            <a:endParaRPr lang="en-US" sz="1200" dirty="0"/>
+            <a:endParaRPr lang="en-US" sz="1150" dirty="0"/>
           </a:p>
         </p:txBody>
       </p:sp>
@@ -15019,7 +15679,7 @@
         <p:spPr>
           <a:xfrm>
             <a:off x="4279392" y="1188720"/>
-            <a:ext cx="3630168" cy="3977640"/>
+            <a:ext cx="3630168" cy="4206240"/>
           </a:xfrm>
           <a:prstGeom prst="roundRect">
             <a:avLst>
@@ -15106,7 +15766,7 @@
         <p:spPr>
           <a:xfrm>
             <a:off x="4416552" y="1691640"/>
-            <a:ext cx="3355848" cy="3383280"/>
+            <a:ext cx="3355848" cy="3611880"/>
           </a:xfrm>
           <a:prstGeom prst="rect">
             <a:avLst/>
@@ -15120,12 +15780,12 @@
           <a:p>
             <a:pPr indent="0" marL="0">
               <a:spcAft>
-                <a:spcPts val="400"/>
+                <a:spcPts val="300"/>
               </a:spcAft>
               <a:buNone/>
             </a:pPr>
             <a:r>
-              <a:rPr lang="en-US" sz="1200" b="1" dirty="0">
+              <a:rPr lang="en-US" sz="1150" b="1" dirty="0">
                 <a:solidFill>
                   <a:schemeClr val="accent6"/>
                 </a:solidFill>
@@ -15134,29 +15794,29 @@
             </a:r>
             <a:pPr indent="0" marL="0">
               <a:spcAft>
-                <a:spcPts val="400"/>
+                <a:spcPts val="300"/>
               </a:spcAft>
               <a:buNone/>
             </a:pPr>
             <a:r>
-              <a:rPr lang="en-US" sz="1200" dirty="0">
+              <a:rPr lang="en-US" sz="1150" dirty="0">
                 <a:solidFill>
                   <a:schemeClr val="tx1"/>
                 </a:solidFill>
               </a:rPr>
               <a:t>~10,000 construction electricians within 75 km</a:t>
             </a:r>
-            <a:endParaRPr lang="en-US" sz="1200" dirty="0"/>
+            <a:endParaRPr lang="en-US" sz="1150" dirty="0"/>
           </a:p>
           <a:p>
             <a:pPr indent="0" marL="0">
               <a:spcAft>
-                <a:spcPts val="400"/>
+                <a:spcPts val="300"/>
               </a:spcAft>
               <a:buNone/>
             </a:pPr>
             <a:r>
-              <a:rPr lang="en-US" sz="1200" b="1" dirty="0">
+              <a:rPr lang="en-US" sz="1150" b="1" dirty="0">
                 <a:solidFill>
                   <a:schemeClr val="accent6"/>
                 </a:solidFill>
@@ -15165,29 +15825,29 @@
             </a:r>
             <a:pPr indent="0" marL="0">
               <a:spcAft>
-                <a:spcPts val="400"/>
+                <a:spcPts val="300"/>
               </a:spcAft>
               <a:buNone/>
             </a:pPr>
             <a:r>
-              <a:rPr lang="en-US" sz="1200" dirty="0">
+              <a:rPr lang="en-US" sz="1150" dirty="0">
                 <a:solidFill>
                   <a:schemeClr val="tx1"/>
                 </a:solidFill>
               </a:rPr>
               <a:t>Social and search ads with a 6-question quiz; Tesla runs a 2–4 week bridge course</a:t>
             </a:r>
-            <a:endParaRPr lang="en-US" sz="1200" dirty="0"/>
+            <a:endParaRPr lang="en-US" sz="1150" dirty="0"/>
           </a:p>
           <a:p>
             <a:pPr indent="0" marL="0">
               <a:spcAft>
-                <a:spcPts val="400"/>
+                <a:spcPts val="300"/>
               </a:spcAft>
               <a:buNone/>
             </a:pPr>
             <a:r>
-              <a:rPr lang="en-US" sz="1200" b="1" dirty="0">
+              <a:rPr lang="en-US" sz="1150" b="1" dirty="0">
                 <a:solidFill>
                   <a:schemeClr val="accent6"/>
                 </a:solidFill>
@@ -15196,29 +15856,29 @@
             </a:r>
             <a:pPr indent="0" marL="0">
               <a:spcAft>
-                <a:spcPts val="400"/>
+                <a:spcPts val="300"/>
               </a:spcAft>
               <a:buNone/>
             </a:pPr>
             <a:r>
-              <a:rPr lang="en-US" sz="1200" dirty="0">
+              <a:rPr lang="en-US" sz="1150" dirty="0">
                 <a:solidFill>
                   <a:schemeClr val="tx1"/>
                 </a:solidFill>
               </a:rPr>
               <a:t>Certified electricians who never search for plant jobs; doubles the hardest pool</a:t>
             </a:r>
-            <a:endParaRPr lang="en-US" sz="1200" dirty="0"/>
+            <a:endParaRPr lang="en-US" sz="1150" dirty="0"/>
           </a:p>
           <a:p>
             <a:pPr indent="0" marL="0">
               <a:spcAft>
-                <a:spcPts val="400"/>
+                <a:spcPts val="300"/>
               </a:spcAft>
               <a:buNone/>
             </a:pPr>
             <a:r>
-              <a:rPr lang="en-US" sz="1200" b="1" dirty="0">
+              <a:rPr lang="en-US" sz="1150" b="1" dirty="0">
                 <a:solidFill>
                   <a:schemeClr val="accent6"/>
                 </a:solidFill>
@@ -15227,29 +15887,29 @@
             </a:r>
             <a:pPr indent="0" marL="0">
               <a:spcAft>
-                <a:spcPts val="400"/>
+                <a:spcPts val="300"/>
               </a:spcAft>
               <a:buNone/>
             </a:pPr>
             <a:r>
-              <a:rPr lang="en-US" sz="1200" dirty="0">
+              <a:rPr lang="en-US" sz="1150" dirty="0">
                 <a:solidFill>
                   <a:schemeClr val="tx1"/>
                 </a:solidFill>
               </a:rPr>
               <a:t>118 apps × €84 = €9.9k + €1.2k set-up → 30 qualified × 28% = 8.4 hires (€1,329/hire)</a:t>
             </a:r>
-            <a:endParaRPr lang="en-US" sz="1200" dirty="0"/>
+            <a:endParaRPr lang="en-US" sz="1150" dirty="0"/>
           </a:p>
           <a:p>
             <a:pPr indent="0" marL="0">
               <a:spcAft>
-                <a:spcPts val="400"/>
+                <a:spcPts val="300"/>
               </a:spcAft>
               <a:buNone/>
             </a:pPr>
             <a:r>
-              <a:rPr lang="en-US" sz="1200" b="1" dirty="0">
+              <a:rPr lang="en-US" sz="1150" b="1" dirty="0">
                 <a:solidFill>
                   <a:schemeClr val="accent6"/>
                 </a:solidFill>
@@ -15258,29 +15918,29 @@
             </a:r>
             <a:pPr indent="0" marL="0">
               <a:spcAft>
-                <a:spcPts val="400"/>
+                <a:spcPts val="300"/>
               </a:spcAft>
               <a:buNone/>
             </a:pPr>
             <a:r>
-              <a:rPr lang="en-US" sz="1200" dirty="0">
+              <a:rPr lang="en-US" sz="1150" dirty="0">
                 <a:solidFill>
                   <a:schemeClr val="tx1"/>
                 </a:solidFill>
               </a:rPr>
-              <a:t>Fri 23 Oct – Thu 5 Nov (read Mon 9 Nov): €3.9k. Pass: ≥4 qualified at ≤€500. Kill: &lt;3, &gt;€670 per qualified, or profile rejected</a:t>
+              <a:t>Fri 23 Oct – Thu 5 Nov (read Mon 9 Nov): €4.9k. Pass: ≥6 qualified at ≤€500. Kill: &lt;4, &gt;€670 per qualified, or profile rejected</a:t>
             </a:r>
-            <a:endParaRPr lang="en-US" sz="1200" dirty="0"/>
+            <a:endParaRPr lang="en-US" sz="1150" dirty="0"/>
           </a:p>
           <a:p>
             <a:pPr indent="0" marL="0">
               <a:spcAft>
-                <a:spcPts val="400"/>
+                <a:spcPts val="300"/>
               </a:spcAft>
               <a:buNone/>
             </a:pPr>
             <a:r>
-              <a:rPr lang="en-US" sz="1200" b="1" dirty="0">
+              <a:rPr lang="en-US" sz="1150" b="1" dirty="0">
                 <a:solidFill>
                   <a:schemeClr val="accent6"/>
                 </a:solidFill>
@@ -15289,19 +15949,19 @@
             </a:r>
             <a:pPr indent="0" marL="0">
               <a:spcAft>
-                <a:spcPts val="400"/>
+                <a:spcPts val="300"/>
               </a:spcAft>
               <a:buNone/>
             </a:pPr>
             <a:r>
-              <a:rPr lang="en-US" sz="1200" dirty="0">
+              <a:rPr lang="en-US" sz="1150" dirty="0">
                 <a:solidFill>
                   <a:schemeClr val="tx1"/>
                 </a:solidFill>
               </a:rPr>
-              <a:t>Me: ads, quiz, copy; live 23 Oct. Client: profile sign-off by 23 Oct, bridge plan</a:t>
+              <a:t>Setup 3 days (live Fri 23 Oct). Me: ads, quiz, German copywriter. Client: profile sign-off by 23 Oct, bridge course</a:t>
             </a:r>
-            <a:endParaRPr lang="en-US" sz="1200" dirty="0"/>
+            <a:endParaRPr lang="en-US" sz="1150" dirty="0"/>
           </a:p>
         </p:txBody>
       </p:sp>
@@ -15314,7 +15974,7 @@
         <p:spPr>
           <a:xfrm>
             <a:off x="8101584" y="1188720"/>
-            <a:ext cx="3630168" cy="3977640"/>
+            <a:ext cx="3630168" cy="4206240"/>
           </a:xfrm>
           <a:prstGeom prst="roundRect">
             <a:avLst>
@@ -15401,7 +16061,7 @@
         <p:spPr>
           <a:xfrm>
             <a:off x="8238744" y="1691640"/>
-            <a:ext cx="3355848" cy="3383280"/>
+            <a:ext cx="3355848" cy="3611880"/>
           </a:xfrm>
           <a:prstGeom prst="rect">
             <a:avLst/>
@@ -15415,12 +16075,12 @@
           <a:p>
             <a:pPr indent="0" marL="0">
               <a:spcAft>
-                <a:spcPts val="400"/>
+                <a:spcPts val="300"/>
               </a:spcAft>
               <a:buNone/>
             </a:pPr>
             <a:r>
-              <a:rPr lang="en-US" sz="1200" b="1" dirty="0">
+              <a:rPr lang="en-US" sz="1150" b="1" dirty="0">
                 <a:solidFill>
                   <a:schemeClr val="accent6"/>
                 </a:solidFill>
@@ -15429,29 +16089,29 @@
             </a:r>
             <a:pPr indent="0" marL="0">
               <a:spcAft>
-                <a:spcPts val="400"/>
+                <a:spcPts val="300"/>
               </a:spcAft>
               <a:buNone/>
             </a:pPr>
             <a:r>
-              <a:rPr lang="en-US" sz="1200" dirty="0">
+              <a:rPr lang="en-US" sz="1150" dirty="0">
                 <a:solidFill>
                   <a:schemeClr val="tx1"/>
                 </a:solidFill>
               </a:rPr>
               <a:t>Mechatronics workers in Polish border towns, 60–130 km away (EU)</a:t>
             </a:r>
-            <a:endParaRPr lang="en-US" sz="1200" dirty="0"/>
+            <a:endParaRPr lang="en-US" sz="1150" dirty="0"/>
           </a:p>
           <a:p>
             <a:pPr indent="0" marL="0">
               <a:spcAft>
-                <a:spcPts val="400"/>
+                <a:spcPts val="300"/>
               </a:spcAft>
               <a:buNone/>
             </a:pPr>
             <a:r>
-              <a:rPr lang="en-US" sz="1200" b="1" dirty="0">
+              <a:rPr lang="en-US" sz="1150" b="1" dirty="0">
                 <a:solidFill>
                   <a:schemeClr val="accent6"/>
                 </a:solidFill>
@@ -15460,29 +16120,29 @@
             </a:r>
             <a:pPr indent="0" marL="0">
               <a:spcAft>
-                <a:spcPts val="400"/>
+                <a:spcPts val="300"/>
               </a:spcAft>
               <a:buNone/>
             </a:pPr>
             <a:r>
-              <a:rPr lang="en-US" sz="1200" dirty="0">
+              <a:rPr lang="en-US" sz="1150" dirty="0">
                 <a:solidFill>
                   <a:schemeClr val="tx1"/>
                 </a:solidFill>
               </a:rPr>
               <a:t>Polish job boards and Meta; a Polish-speaking freelancer phones each applicant (15 min)</a:t>
             </a:r>
-            <a:endParaRPr lang="en-US" sz="1200" dirty="0"/>
+            <a:endParaRPr lang="en-US" sz="1150" dirty="0"/>
           </a:p>
           <a:p>
             <a:pPr indent="0" marL="0">
               <a:spcAft>
-                <a:spcPts val="400"/>
+                <a:spcPts val="300"/>
               </a:spcAft>
               <a:buNone/>
             </a:pPr>
             <a:r>
-              <a:rPr lang="en-US" sz="1200" b="1" dirty="0">
+              <a:rPr lang="en-US" sz="1150" b="1" dirty="0">
                 <a:solidFill>
                   <a:schemeClr val="accent6"/>
                 </a:solidFill>
@@ -15491,29 +16151,29 @@
             </a:r>
             <a:pPr indent="0" marL="0">
               <a:spcAft>
-                <a:spcPts val="400"/>
+                <a:spcPts val="300"/>
               </a:spcAft>
               <a:buNone/>
             </a:pPr>
             <a:r>
-              <a:rPr lang="en-US" sz="1200" dirty="0">
+              <a:rPr lang="en-US" sz="1150" dirty="0">
                 <a:solidFill>
                   <a:schemeClr val="tx1"/>
                 </a:solidFill>
               </a:rPr>
-              <a:t>~2,000 Polish trade workers already commute to Brandenburg; the call checks language before using our slots</a:t>
+              <a:t>~13,800 Poles commute to Brandenburg jobs, ~1,700 in machine, metal and building trades (IAB 2020); the call checks language before using our slots</a:t>
             </a:r>
-            <a:endParaRPr lang="en-US" sz="1200" dirty="0"/>
+            <a:endParaRPr lang="en-US" sz="1150" dirty="0"/>
           </a:p>
           <a:p>
             <a:pPr indent="0" marL="0">
               <a:spcAft>
-                <a:spcPts val="400"/>
+                <a:spcPts val="300"/>
               </a:spcAft>
               <a:buNone/>
             </a:pPr>
             <a:r>
-              <a:rPr lang="en-US" sz="1200" b="1" dirty="0">
+              <a:rPr lang="en-US" sz="1150" b="1" dirty="0">
                 <a:solidFill>
                   <a:schemeClr val="accent6"/>
                 </a:solidFill>
@@ -15522,29 +16182,29 @@
             </a:r>
             <a:pPr indent="0" marL="0">
               <a:spcAft>
-                <a:spcPts val="400"/>
+                <a:spcPts val="300"/>
               </a:spcAft>
               <a:buNone/>
             </a:pPr>
             <a:r>
-              <a:rPr lang="en-US" sz="1200" dirty="0">
+              <a:rPr lang="en-US" sz="1150" dirty="0">
                 <a:solidFill>
                   <a:schemeClr val="tx1"/>
                 </a:solidFill>
               </a:rPr>
               <a:t>346 apps × €18.75 + €400 → 48 qualified × 37% = 18.0 hires (40% of mech, cap 40%)</a:t>
             </a:r>
-            <a:endParaRPr lang="en-US" sz="1200" dirty="0"/>
+            <a:endParaRPr lang="en-US" sz="1150" dirty="0"/>
           </a:p>
           <a:p>
             <a:pPr indent="0" marL="0">
               <a:spcAft>
-                <a:spcPts val="400"/>
+                <a:spcPts val="300"/>
               </a:spcAft>
               <a:buNone/>
             </a:pPr>
             <a:r>
-              <a:rPr lang="en-US" sz="1200" b="1" dirty="0">
+              <a:rPr lang="en-US" sz="1150" b="1" dirty="0">
                 <a:solidFill>
                   <a:schemeClr val="accent6"/>
                 </a:solidFill>
@@ -15553,29 +16213,29 @@
             </a:r>
             <a:pPr indent="0" marL="0">
               <a:spcAft>
-                <a:spcPts val="400"/>
+                <a:spcPts val="300"/>
               </a:spcAft>
               <a:buNone/>
             </a:pPr>
             <a:r>
-              <a:rPr lang="en-US" sz="1200" dirty="0">
+              <a:rPr lang="en-US" sz="1150" dirty="0">
                 <a:solidFill>
                   <a:schemeClr val="tx1"/>
                 </a:solidFill>
               </a:rPr>
               <a:t>Tue 27 Oct – Mon 9 Nov (freelancer starts 27 Oct): €2.5k. Pass: ≥9 qualified at ≤€200. Kill: &lt;5, &gt;€270 per qualified, or too few pass the language call</a:t>
             </a:r>
-            <a:endParaRPr lang="en-US" sz="1200" dirty="0"/>
+            <a:endParaRPr lang="en-US" sz="1150" dirty="0"/>
           </a:p>
           <a:p>
             <a:pPr indent="0" marL="0">
               <a:spcAft>
-                <a:spcPts val="400"/>
+                <a:spcPts val="300"/>
               </a:spcAft>
               <a:buNone/>
             </a:pPr>
             <a:r>
-              <a:rPr lang="en-US" sz="1200" b="1" dirty="0">
+              <a:rPr lang="en-US" sz="1150" b="1" dirty="0">
                 <a:solidFill>
                   <a:schemeClr val="accent6"/>
                 </a:solidFill>
@@ -15584,19 +16244,19 @@
             </a:r>
             <a:pPr indent="0" marL="0">
               <a:spcAft>
-                <a:spcPts val="400"/>
+                <a:spcPts val="300"/>
               </a:spcAft>
               <a:buNone/>
             </a:pPr>
             <a:r>
-              <a:rPr lang="en-US" sz="1200" dirty="0">
+              <a:rPr lang="en-US" sz="1150" dirty="0">
                 <a:solidFill>
                   <a:schemeClr val="tx1"/>
                 </a:solidFill>
               </a:rPr>
-              <a:t>Me: ads, freelancer, call script. Client: approve the Polish ads</a:t>
+              <a:t>Setup 1 week (live Tue 27 Oct). Me: Polish ads, hire the freelancer via rocketjobs.pl (~€19/h), call script, weekly call checks. Client: approve the ads</a:t>
             </a:r>
-            <a:endParaRPr lang="en-US" sz="1200" dirty="0"/>
+            <a:endParaRPr lang="en-US" sz="1150" dirty="0"/>
           </a:p>
         </p:txBody>
       </p:sp>
@@ -15608,8 +16268,8 @@
         </p:nvSpPr>
         <p:spPr>
           <a:xfrm>
-            <a:off x="457200" y="5349240"/>
-            <a:ext cx="11274552" cy="914400"/>
+            <a:off x="457200" y="5504688"/>
+            <a:ext cx="11274552" cy="822960"/>
           </a:xfrm>
           <a:prstGeom prst="rect">
             <a:avLst/>
@@ -15625,7 +16285,7 @@
               <a:buNone/>
             </a:pPr>
             <a:r>
-              <a:rPr lang="en-US" sz="1200" b="1" dirty="0">
+              <a:rPr lang="en-US" sz="1150" b="1" dirty="0">
                 <a:solidFill>
                   <a:schemeClr val="tx1"/>
                 </a:solidFill>
@@ -15636,14 +16296,14 @@
               <a:buNone/>
             </a:pPr>
             <a:r>
-              <a:rPr lang="en-US" sz="1200" dirty="0">
+              <a:rPr lang="en-US" sz="1150" dirty="0">
                 <a:solidFill>
                   <a:schemeClr val="tx1"/>
                 </a:solidFill>
               </a:rPr>
-              <a:t>Every employer holds consenting past applicants that nobody re-markets. Here 211 records cost ~€14 per hire and fill week-1 slots. Joveo could add them as one more tracked source in any market, with no local staff.</a:t>
+              <a:t>Every employer holds past applicants who consented to be kept on file (GDPR allows up to a year), and nobody re-markets them. Here 211 records cost ~€14 per hire and fill week-1 slots. Joveo already runs the tracked links and distribution, so a consented past-applicant feed is one more source in the same pipeline, in any market, with no local staff.</a:t>
             </a:r>
-            <a:endParaRPr lang="en-US" sz="1200" dirty="0"/>
+            <a:endParaRPr lang="en-US" sz="1150" dirty="0"/>
           </a:p>
         </p:txBody>
       </p:sp>
@@ -15918,7 +16578,7 @@
                   <a:schemeClr val="tx1"/>
                 </a:solidFill>
               </a:rPr>
-              <a:t>Spend → applications → qualified → assessed → passed → offers → signed, by source × role</a:t>
+              <a:t>By source × role: spend, applications, qualified. By role: assessed, passed, offers, signed (each hire keeps its ATS source tag)</a:t>
             </a:r>
             <a:endParaRPr lang="en-US" sz="1250" dirty="0"/>
           </a:p>
@@ -16244,7 +16904,7 @@
                   <a:schemeClr val="tx1"/>
                 </a:solidFill>
               </a:rPr>
-              <a:t>Pass rate after 10 interviews: if low → sharper screening, more slots (10% lower ≈ 92 hires)</a:t>
+              <a:t>Pass rate: first read 2 Nov, confirmed 9 Nov once a role has 10 interviews; if low → tighter knock-out questions, ask for more slots (10% lower ≈ 92 hires)</a:t>
             </a:r>
             <a:endParaRPr lang="en-US" sz="1250" dirty="0"/>
           </a:p>
@@ -16262,7 +16922,7 @@
                   <a:schemeClr val="tx1"/>
                 </a:solidFill>
               </a:rPr>
-              <a:t>Construction electricians: if stopped, programmatic fills the gap (€127.5k)</a:t>
+              <a:t>Construction electricians: if stopped, programmatic fills the gap (€130k)</a:t>
             </a:r>
             <a:endParaRPr lang="en-US" sz="1250" dirty="0"/>
           </a:p>
@@ -16461,7 +17121,7 @@
                   <a:schemeClr val="tx1"/>
                 </a:solidFill>
               </a:rPr>
-              <a:t>Wed–Fri: Polish ads + freelancer; construction campaign live 23 Oct</a:t>
+              <a:t>Wed–Fri: set up Polish ads + freelancer (live 27 Oct); construction campaign live 23 Oct</a:t>
             </a:r>
             <a:endParaRPr lang="en-US" sz="1250" dirty="0"/>
           </a:p>

</xml_diff>

<commit_message>
Accuracy pass: final labels (I1M, I2F own estimates), Q&A sources verified, counts updated
Co-Authored-By: Claude Opus 5.5 <noreply@anthropic.com>
Claude-Session: https://claude.ai/code/session_01V2NJtrYy3bzNxqKeiRXJfY
</commit_message>
<xml_diff>
--- a/operation_uptime/Operation_Uptime_Deck.pptx
+++ b/operation_uptime/Operation_Uptime_Deck.pptx
@@ -114,30 +114,30 @@
   <p:extLst>
     <p:ext uri="{521415D9-36F7-43E2-AB2F-B90AF26B5E84}">
       <p14:sectionLst xmlns:p14="http://schemas.microsoft.com/office/powerpoint/2010/main">
-        <p14:section name="Summary" id="{b2534f28-1be0-04c9-e730-bc8cde4eff0b}">
+        <p14:section name="Summary" id="{36363604-2906-6250-aa1b-624a3114097d}">
           <p14:sldIdLst>
             <p14:sldId id="256"/>
           </p14:sldIdLst>
         </p14:section>
-        <p14:section name="Part 1 Funnel" id="{a5bf262f-2bcf-1ed7-14e6-98295b0d4adc}">
+        <p14:section name="Part 1 Funnel" id="{6f7a91f6-cdfb-c1bd-c2d4-2e6eadd0bdd3}">
           <p14:sldIdLst>
             <p14:sldId id="257"/>
             <p14:sldId id="258"/>
           </p14:sldIdLst>
         </p14:section>
-        <p14:section name="Part 2 Channels &amp; budget" id="{2c189f27-23d9-607a-56ef-22da50f12f00}">
+        <p14:section name="Part 2 Channels &amp; budget" id="{d1adaa91-57e6-263b-75f4-66ce9655cd2e}">
           <p14:sldIdLst>
             <p14:sldId id="259"/>
             <p14:sldId id="260"/>
             <p14:sldId id="261"/>
           </p14:sldIdLst>
         </p14:section>
-        <p14:section name="Part 3 New sources" id="{67f979f0-ae60-e0e3-9b44-0ab93fa5f6e6}">
+        <p14:section name="Part 3 New sources" id="{dac1dd19-520a-c259-7dc6-cfd98d7cd407}">
           <p14:sldIdLst>
             <p14:sldId id="262"/>
           </p14:sldIdLst>
         </p14:section>
-        <p14:section name="Part 4 Run it" id="{6a145c07-1f8e-0405-e288-af0027a83bd0}">
+        <p14:section name="Part 4 Run it" id="{c3dc25a9-f77b-8b32-5d85-bd07e1d27eb2}">
           <p14:sldIdLst>
             <p14:sldId id="263"/>
           </p14:sldIdLst>

</xml_diff>

<commit_message>
Accuracy fixes from independent re-audit: supervisor pacing by useful days, first-assessment logic explained, cut advice consistent with the cut rule, media lower bound labelled
Co-Authored-By: Claude Opus 5.5 <noreply@anthropic.com>
Claude-Session: https://claude.ai/code/session_01V2NJtrYy3bzNxqKeiRXJfY
</commit_message>
<xml_diff>
--- a/operation_uptime/Operation_Uptime_Deck.pptx
+++ b/operation_uptime/Operation_Uptime_Deck.pptx
@@ -114,30 +114,30 @@
   <p:extLst>
     <p:ext uri="{521415D9-36F7-43E2-AB2F-B90AF26B5E84}">
       <p14:sectionLst xmlns:p14="http://schemas.microsoft.com/office/powerpoint/2010/main">
-        <p14:section name="Summary" id="{36363604-2906-6250-aa1b-624a3114097d}">
+        <p14:section name="Summary" id="{7beed538-4479-14d9-8d3f-51955cf24a07}">
           <p14:sldIdLst>
             <p14:sldId id="256"/>
           </p14:sldIdLst>
         </p14:section>
-        <p14:section name="Part 1 Funnel" id="{6f7a91f6-cdfb-c1bd-c2d4-2e6eadd0bdd3}">
+        <p14:section name="Part 1 Funnel" id="{e845b4d9-fc81-5ce6-963c-0c5851845eac}">
           <p14:sldIdLst>
             <p14:sldId id="257"/>
             <p14:sldId id="258"/>
           </p14:sldIdLst>
         </p14:section>
-        <p14:section name="Part 2 Channels &amp; budget" id="{d1adaa91-57e6-263b-75f4-66ce9655cd2e}">
+        <p14:section name="Part 2 Channels &amp; budget" id="{b6c03d9e-2050-23bc-c31a-f2bc55390b53}">
           <p14:sldIdLst>
             <p14:sldId id="259"/>
             <p14:sldId id="260"/>
             <p14:sldId id="261"/>
           </p14:sldIdLst>
         </p14:section>
-        <p14:section name="Part 3 New sources" id="{dac1dd19-520a-c259-7dc6-cfd98d7cd407}">
+        <p14:section name="Part 3 New sources" id="{b986d8da-4bca-e40a-1952-ce2790e5ff3f}">
           <p14:sldIdLst>
             <p14:sldId id="262"/>
           </p14:sldIdLst>
         </p14:section>
-        <p14:section name="Part 4 Run it" id="{c3dc25a9-f77b-8b32-5d85-bd07e1d27eb2}">
+        <p14:section name="Part 4 Run it" id="{68f43251-2403-19e5-0271-1857f0143322}">
           <p14:sldIdLst>
             <p14:sldId id="263"/>
           </p14:sldIdLst>
@@ -689,22 +689,22 @@
                 <c:formatCode>General</c:formatCode>
                 <c:ptCount val="9"/>
                 <c:pt idx="0">
-                  <c:v>19436</c:v>
+                  <c:v>19399</c:v>
                 </c:pt>
                 <c:pt idx="1">
-                  <c:v>10836</c:v>
+                  <c:v>11248</c:v>
                 </c:pt>
                 <c:pt idx="2">
-                  <c:v>13809</c:v>
+                  <c:v>13947</c:v>
                 </c:pt>
                 <c:pt idx="3">
-                  <c:v>14175</c:v>
+                  <c:v>14327</c:v>
                 </c:pt>
                 <c:pt idx="4">
-                  <c:v>14175</c:v>
+                  <c:v>13822</c:v>
                 </c:pt>
                 <c:pt idx="5">
-                  <c:v>1863</c:v>
+                  <c:v>1552</c:v>
                 </c:pt>
                 <c:pt idx="6">
                   <c:v>0</c:v>
@@ -936,22 +936,22 @@
                   <c:v>0</c:v>
                 </c:pt>
                 <c:pt idx="3">
-                  <c:v>2566</c:v>
+                  <c:v>2467</c:v>
                 </c:pt>
                 <c:pt idx="4">
-                  <c:v>1728</c:v>
+                  <c:v>1782</c:v>
                 </c:pt>
                 <c:pt idx="5">
-                  <c:v>1992</c:v>
+                  <c:v>1980</c:v>
                 </c:pt>
                 <c:pt idx="6">
-                  <c:v>2087</c:v>
+                  <c:v>2078</c:v>
                 </c:pt>
                 <c:pt idx="7">
-                  <c:v>2092</c:v>
+                  <c:v>2381</c:v>
                 </c:pt>
                 <c:pt idx="8">
-                  <c:v>513</c:v>
+                  <c:v>290</c:v>
                 </c:pt>
               </c:numCache>
             </c:numRef>
@@ -3557,7 +3557,7 @@
                   <a:schemeClr val="tx1"/>
                 </a:solidFill>
               </a:rPr>
-              <a:t>Pace ≤55 qualified a week; applications until Tue 24 Nov, signatures by Fri 18 Dec.</a:t>
+              <a:t>Pace ≤55 assessments a week; applications until Tue 24 Nov, signatures by Fri 18 Dec.</a:t>
             </a:r>
             <a:endParaRPr lang="en-US" sz="1200" dirty="0"/>
           </a:p>
@@ -5351,7 +5351,7 @@
                   <a:schemeClr val="tx1"/>
                 </a:solidFill>
               </a:rPr>
-              <a:t>55 assessments a week (+9 if possible)</a:t>
+              <a:t>55 assessments a week from Thu 22 Oct (+9 if possible)</a:t>
             </a:r>
             <a:endParaRPr lang="en-US" sz="1100" dirty="0"/>
           </a:p>
@@ -8954,7 +8954,7 @@
                   <a:schemeClr val="tx1"/>
                 </a:solidFill>
               </a:rPr>
-              <a:t>Automation has the tighter pool (22% of reachable people vs 12%), but needs only 15 and costs less per hire, so it is watched weekly.</a:t>
+              <a:t>Automation has a tighter pool and less channel headroom (22% of reachable people vs 12%), but needs only 15 and costs less per hire, so it is watched weekly.</a:t>
             </a:r>
             <a:endParaRPr lang="en-US" sz="1300" dirty="0"/>
           </a:p>
@@ -9017,7 +9017,7 @@
                   <a:schemeClr val="tx1"/>
                 </a:solidFill>
               </a:rPr>
-              <a:t>30% worse means 440 qualified applicants for 314 slots, so only ~71 can be hired; spending more doesn't help. Acceptance ties, but fast offers protect it; the pass rate depends on the plant's own test and is only known after interviews (week-2 check). A weaker share qualified or dearer clicks only cost money (+43% / +30% media), not hires.</a:t>
+              <a:t>30% worse means 440 qualified applicants for 314 slots, so only ~71 can be hired; spending more doesn't help. Acceptance ties, but fast offers protect it; the pass rate depends on the plant's own test and is only known after interviews (week-2 check). A weaker share qualified or dearer clicks only cost money (at least +43% / +30% media), not hires.</a:t>
             </a:r>
             <a:endParaRPr lang="en-US" sz="1200" dirty="0"/>
           </a:p>
@@ -12547,7 +12547,7 @@
                   <a:schemeClr val="tx1"/>
                 </a:solidFill>
               </a:rPr>
-              <a:t>Each pay-per-click channel gets a €750 test per role first; the dearest (Search, most programmatic) stay at test level.</a:t>
+              <a:t>Each pay-per-click channel gets a €750 test per role first; Search and Meta stay at test level, and so does programmatic for automation and supervisors.</a:t>
             </a:r>
             <a:endParaRPr lang="en-US" sz="1150" dirty="0"/>
           </a:p>
@@ -14311,7 +14311,7 @@
                   <a:schemeClr val="tx1"/>
                 </a:solidFill>
               </a:rPr>
-              <a:t>Spend stops: </a:t>
+              <a:t>Paid media stops: </a:t>
             </a:r>
             <a:pPr indent="0" marL="0">
               <a:spcAft>
@@ -14325,7 +14325,7 @@
                   <a:schemeClr val="tx1"/>
                 </a:solidFill>
               </a:rPr>
-              <a:t>Tue 24 Nov, the last useful application date.</a:t>
+              <a:t>Tue 24 Nov, the last useful application date (referral bonuses are paid as people sign).</a:t>
             </a:r>
             <a:endParaRPr lang="en-US" sz="1200" dirty="0"/>
           </a:p>
@@ -15928,7 +15928,7 @@
                   <a:schemeClr val="tx1"/>
                 </a:solidFill>
               </a:rPr>
-              <a:t>Fri 23 Oct – Thu 5 Nov (read Mon 9 Nov): €4.9k. Pass: ≥6 qualified at ≤€500. Kill: &lt;4, &gt;€670 per qualified, or profile rejected</a:t>
+              <a:t>Fri 23 Oct – Thu 5 Nov (read Mon 9 Nov): €4.8k. Pass: ≥6 qualified at ≤€500. Kill: &lt;4, &gt;€670 per qualified, or profile rejected</a:t>
             </a:r>
             <a:endParaRPr lang="en-US" sz="1150" dirty="0"/>
           </a:p>

</xml_diff>

<commit_message>
Launch assumption labelled as own estimate with its tested downside (~92 hires if assessments start 26 Oct)
Co-Authored-By: Claude Opus 5.5 <noreply@anthropic.com>
Claude-Session: https://claude.ai/code/session_01V2NJtrYy3bzNxqKeiRXJfY
</commit_message>
<xml_diff>
--- a/operation_uptime/Operation_Uptime_Deck.pptx
+++ b/operation_uptime/Operation_Uptime_Deck.pptx
@@ -114,30 +114,30 @@
   <p:extLst>
     <p:ext uri="{521415D9-36F7-43E2-AB2F-B90AF26B5E84}">
       <p14:sectionLst xmlns:p14="http://schemas.microsoft.com/office/powerpoint/2010/main">
-        <p14:section name="Summary" id="{7beed538-4479-14d9-8d3f-51955cf24a07}">
+        <p14:section name="Summary" id="{926d00cb-f4c4-a5ae-228c-4b0c3d50167d}">
           <p14:sldIdLst>
             <p14:sldId id="256"/>
           </p14:sldIdLst>
         </p14:section>
-        <p14:section name="Part 1 Funnel" id="{e845b4d9-fc81-5ce6-963c-0c5851845eac}">
+        <p14:section name="Part 1 Funnel" id="{bcddfa11-b553-bbe0-2f01-c9d6baa03d4b}">
           <p14:sldIdLst>
             <p14:sldId id="257"/>
             <p14:sldId id="258"/>
           </p14:sldIdLst>
         </p14:section>
-        <p14:section name="Part 2 Channels &amp; budget" id="{b6c03d9e-2050-23bc-c31a-f2bc55390b53}">
+        <p14:section name="Part 2 Channels &amp; budget" id="{b6fd8dc5-8654-efcf-1ac9-a8ae9c1301a4}">
           <p14:sldIdLst>
             <p14:sldId id="259"/>
             <p14:sldId id="260"/>
             <p14:sldId id="261"/>
           </p14:sldIdLst>
         </p14:section>
-        <p14:section name="Part 3 New sources" id="{b986d8da-4bca-e40a-1952-ce2790e5ff3f}">
+        <p14:section name="Part 3 New sources" id="{28f08e97-08e9-652a-c441-6ff0d03d04ae}">
           <p14:sldIdLst>
             <p14:sldId id="262"/>
           </p14:sldIdLst>
         </p14:section>
-        <p14:section name="Part 4 Run it" id="{68f43251-2403-19e5-0271-1857f0143322}">
+        <p14:section name="Part 4 Run it" id="{3412d43f-7a5c-a7e5-bfbb-44fa7efd31c2}">
           <p14:sldIdLst>
             <p14:sldId id="263"/>
           </p14:sldIdLst>
@@ -5162,7 +5162,7 @@
                   <a:schemeClr val="tx1"/>
                 </a:solidFill>
               </a:rPr>
-              <a:t>pace ≤55 a week, pre-screened sources first, ask for +9 slots.</a:t>
+              <a:t>pace ≤55 a week, pre-screened sources first, ask for +9 slots. If assessments can't start 22 Oct: ~92 hires (100 then needs 60 a week).</a:t>
             </a:r>
             <a:endParaRPr lang="en-US" sz="1100" dirty="0"/>
           </a:p>

</xml_diff>

<commit_message>
Score-driven fixes: 40% Polish cap enforced in budget scenarios, zero-qualified rule needs 30+ applications, signed hires by source in Tracker, slide 4 spend and cost per qualified, downsides on slides 3 and 7, source-note wording
Co-Authored-By: Claude Opus 5.5 <noreply@anthropic.com>
Claude-Session: https://claude.ai/code/session_01V2NJtrYy3bzNxqKeiRXJfY
</commit_message>
<xml_diff>
--- a/operation_uptime/Operation_Uptime_Deck.pptx
+++ b/operation_uptime/Operation_Uptime_Deck.pptx
@@ -114,30 +114,30 @@
   <p:extLst>
     <p:ext uri="{521415D9-36F7-43E2-AB2F-B90AF26B5E84}">
       <p14:sectionLst xmlns:p14="http://schemas.microsoft.com/office/powerpoint/2010/main">
-        <p14:section name="Summary" id="{926d00cb-f4c4-a5ae-228c-4b0c3d50167d}">
+        <p14:section name="Summary" id="{512c0325-63bd-2124-7305-7cc4b400a1b9}">
           <p14:sldIdLst>
             <p14:sldId id="256"/>
           </p14:sldIdLst>
         </p14:section>
-        <p14:section name="Part 1 Funnel" id="{bcddfa11-b553-bbe0-2f01-c9d6baa03d4b}">
+        <p14:section name="Part 1 Funnel" id="{c5af8bb1-9ac0-7224-4e31-5faeaf5bfdf8}">
           <p14:sldIdLst>
             <p14:sldId id="257"/>
             <p14:sldId id="258"/>
           </p14:sldIdLst>
         </p14:section>
-        <p14:section name="Part 2 Channels &amp; budget" id="{b6fd8dc5-8654-efcf-1ac9-a8ae9c1301a4}">
+        <p14:section name="Part 2 Channels &amp; budget" id="{a5496b52-d5be-64be-f374-bff54b2aed5f}">
           <p14:sldIdLst>
             <p14:sldId id="259"/>
             <p14:sldId id="260"/>
             <p14:sldId id="261"/>
           </p14:sldIdLst>
         </p14:section>
-        <p14:section name="Part 3 New sources" id="{28f08e97-08e9-652a-c441-6ff0d03d04ae}">
+        <p14:section name="Part 3 New sources" id="{2124ba60-6187-0667-504c-409cf81817be}">
           <p14:sldIdLst>
             <p14:sldId id="262"/>
           </p14:sldIdLst>
         </p14:section>
-        <p14:section name="Part 4 Run it" id="{3412d43f-7a5c-a7e5-bfbb-44fa7efd31c2}">
+        <p14:section name="Part 4 Run it" id="{6fe372e7-78b2-19ab-a03c-22831a4fc1fa}">
           <p14:sldIdLst>
             <p14:sldId id="263"/>
           </p14:sldIdLst>
@@ -689,22 +689,22 @@
                 <c:formatCode>General</c:formatCode>
                 <c:ptCount val="9"/>
                 <c:pt idx="0">
-                  <c:v>19399</c:v>
+                  <c:v>19549</c:v>
                 </c:pt>
                 <c:pt idx="1">
-                  <c:v>11248</c:v>
+                  <c:v>11334</c:v>
                 </c:pt>
                 <c:pt idx="2">
-                  <c:v>13947</c:v>
+                  <c:v>14055</c:v>
                 </c:pt>
                 <c:pt idx="3">
-                  <c:v>14327</c:v>
+                  <c:v>14438</c:v>
                 </c:pt>
                 <c:pt idx="4">
-                  <c:v>13822</c:v>
+                  <c:v>13941</c:v>
                 </c:pt>
                 <c:pt idx="5">
-                  <c:v>1552</c:v>
+                  <c:v>1566</c:v>
                 </c:pt>
                 <c:pt idx="6">
                   <c:v>0</c:v>
@@ -1169,7 +1169,7 @@
               <c:strCache>
                 <c:ptCount val="1"/>
                 <c:pt idx="0">
-                  <c:v>Recommended (€120k)</c:v>
+                  <c:v>Recommended (€122.5k)</c:v>
                 </c:pt>
               </c:strCache>
             </c:strRef>
@@ -1258,7 +1258,7 @@
               <c:strCache>
                 <c:ptCount val="1"/>
                 <c:pt idx="0">
-                  <c:v>30% less (€84k)</c:v>
+                  <c:v>30% less (€85.75k)</c:v>
                 </c:pt>
               </c:strCache>
             </c:strRef>
@@ -1323,16 +1323,16 @@
                 <c:formatCode>General</c:formatCode>
                 <c:ptCount val="4"/>
                 <c:pt idx="0">
-                  <c:v>20.6</c:v>
+                  <c:v>20.5</c:v>
                 </c:pt>
                 <c:pt idx="1">
-                  <c:v>44.4</c:v>
+                  <c:v>44</c:v>
                 </c:pt>
                 <c:pt idx="2">
                   <c:v>14.5</c:v>
                 </c:pt>
                 <c:pt idx="3">
-                  <c:v>7.5</c:v>
+                  <c:v>8.1</c:v>
                 </c:pt>
               </c:numCache>
             </c:numRef>
@@ -3158,7 +3158,7 @@
                 <a:ea typeface="Cambria" pitchFamily="34" charset="-122"/>
                 <a:cs typeface="Cambria" pitchFamily="34" charset="-120"/>
               </a:rPr>
-              <a:t>€120k signs 100 maintenance hires by 31 Dec, if the client can assess 55 a week</a:t>
+              <a:t>€122.5k signs 100 maintenance hires by 31 Dec, if the client can assess 55 a week</a:t>
             </a:r>
             <a:endParaRPr lang="en-US" sz="2200" dirty="0"/>
           </a:p>
@@ -3224,7 +3224,7 @@
                 <a:ea typeface="Cambria" pitchFamily="34" charset="-122"/>
                 <a:cs typeface="Cambria" pitchFamily="34" charset="-120"/>
               </a:rPr>
-              <a:t>€120k</a:t>
+              <a:t>€122.5k</a:t>
             </a:r>
             <a:endParaRPr lang="en-US" sz="2000" dirty="0"/>
           </a:p>
@@ -3260,7 +3260,7 @@
                   <a:schemeClr val="tx2"/>
                 </a:solidFill>
               </a:rPr>
-              <a:t>budget: €101.7k plan + €18.3k reserve, released only on results</a:t>
+              <a:t>budget: €102.3k plan + €20.2k reserve, released only on results</a:t>
             </a:r>
             <a:endParaRPr lang="en-US" sz="950" dirty="0"/>
           </a:p>
@@ -3326,7 +3326,7 @@
                 <a:ea typeface="Cambria" pitchFamily="34" charset="-122"/>
                 <a:cs typeface="Cambria" pitchFamily="34" charset="-120"/>
               </a:rPr>
-              <a:t>€1,017</a:t>
+              <a:t>€1,023</a:t>
             </a:r>
             <a:endParaRPr lang="en-US" sz="2000" dirty="0"/>
           </a:p>
@@ -3362,7 +3362,7 @@
                   <a:schemeClr val="tx2"/>
                 </a:solidFill>
               </a:rPr>
-              <a:t>media cost per hire (€1,200 if the reserve is spent)</a:t>
+              <a:t>media cost per hire (€1,225 if the reserve is spent)</a:t>
             </a:r>
             <a:endParaRPr lang="en-US" sz="950" dirty="0"/>
           </a:p>
@@ -3985,7 +3985,7 @@
                             <a:schemeClr val="tx1"/>
                           </a:solidFill>
                         </a:rPr>
-                        <a:t>€38.9k</a:t>
+                        <a:t>€39.1k</a:t>
                       </a:r>
                       <a:endParaRPr lang="en-US" sz="1100" dirty="0"/>
                     </a:p>
@@ -4043,7 +4043,7 @@
                             <a:schemeClr val="tx1"/>
                           </a:solidFill>
                         </a:rPr>
-                        <a:t>€1,298</a:t>
+                        <a:t>€1,304</a:t>
                       </a:r>
                       <a:endParaRPr lang="en-US" sz="1100" dirty="0"/>
                     </a:p>
@@ -4219,7 +4219,7 @@
                             <a:schemeClr val="tx1"/>
                           </a:solidFill>
                         </a:rPr>
-                        <a:t>€29.9k</a:t>
+                        <a:t>€30.1k</a:t>
                       </a:r>
                       <a:endParaRPr lang="en-US" sz="1100" dirty="0"/>
                     </a:p>
@@ -4277,7 +4277,7 @@
                             <a:schemeClr val="tx1"/>
                           </a:solidFill>
                         </a:rPr>
-                        <a:t>€663</a:t>
+                        <a:t>€670</a:t>
                       </a:r>
                       <a:endParaRPr lang="en-US" sz="1100" dirty="0"/>
                     </a:p>
@@ -4511,7 +4511,7 @@
                             <a:schemeClr val="tx1"/>
                           </a:solidFill>
                         </a:rPr>
-                        <a:t>€1,158</a:t>
+                        <a:t>€1,162</a:t>
                       </a:r>
                       <a:endParaRPr lang="en-US" sz="1100" dirty="0"/>
                     </a:p>
@@ -4745,7 +4745,7 @@
                             <a:schemeClr val="tx1"/>
                           </a:solidFill>
                         </a:rPr>
-                        <a:t>€1,550</a:t>
+                        <a:t>€1,555</a:t>
                       </a:r>
                       <a:endParaRPr lang="en-US" sz="1100" dirty="0"/>
                     </a:p>
@@ -4921,7 +4921,7 @@
                             <a:schemeClr val="tx1"/>
                           </a:solidFill>
                         </a:rPr>
-                        <a:t>€101.7k</a:t>
+                        <a:t>€102.3k</a:t>
                       </a:r>
                       <a:endParaRPr lang="en-US" sz="1100" dirty="0"/>
                     </a:p>
@@ -4979,7 +4979,7 @@
                             <a:schemeClr val="tx1"/>
                           </a:solidFill>
                         </a:rPr>
-                        <a:t>€1,017</a:t>
+                        <a:t>€1,023</a:t>
                       </a:r>
                       <a:endParaRPr lang="en-US" sz="1100" dirty="0"/>
                     </a:p>
@@ -5423,7 +5423,7 @@
                   <a:schemeClr val="tx1"/>
                 </a:solidFill>
               </a:rPr>
-              <a:t>Approve €120k</a:t>
+              <a:t>Approve €122.5k</a:t>
             </a:r>
             <a:endParaRPr lang="en-US" sz="1100" dirty="0"/>
           </a:p>
@@ -8632,7 +8632,7 @@
                   <a:schemeClr val="tx1"/>
                 </a:solidFill>
               </a:rPr>
-              <a:t>308 qualified applicants in the plan (from 1,490 applications) against 314 slots: 55 a week × 40 assessment days ÷ 7.</a:t>
+              <a:t>308 qualified applicants in the plan (from 1,495 applications) against 314 slots: 55 a week × 40 assessment days ÷ 7.</a:t>
             </a:r>
             <a:endParaRPr lang="en-US" sz="1200" dirty="0"/>
           </a:p>
@@ -8666,7 +8666,7 @@
                   <a:schemeClr val="tx2"/>
                 </a:solidFill>
               </a:rPr>
-              <a:t>Why 308, not 311: referrals and past applicants convert better than the table's standard rates, so the plan needs slightly fewer. Applications: 1,490, not 1,260, because the plan's channels average 21% qualified (social ads lower), below the ~25% baseline.</a:t>
+              <a:t>Why 308, not 311: referrals and past applicants convert better than the table's standard rates, so the plan needs slightly fewer. Applications: 1,495, not 1,260, because the plan's channels average 21% qualified (social ads lower), below the ~25% baseline.</a:t>
             </a:r>
             <a:endParaRPr lang="en-US" sz="1200" dirty="0"/>
           </a:p>
@@ -9017,7 +9017,7 @@
                   <a:schemeClr val="tx1"/>
                 </a:solidFill>
               </a:rPr>
-              <a:t>30% worse means 440 qualified applicants for 314 slots, so only ~71 can be hired; spending more doesn't help. Acceptance ties, but fast offers protect it; the pass rate depends on the plant's own test and is only known after interviews (week-2 check). A weaker share qualified or dearer clicks only cost money (at least +43% / +30% media), not hires.</a:t>
+              <a:t>30% worse means 440 qualified applicants for 314 slots, so only ~71 can be hired; spending more doesn't help. Acceptance ties, but fast offers protect it; the pass rate depends on the plant's own test and is only known after interviews (week-2 check). A weaker share qualified or dearer clicks only cost money, not hires: a 30% lower share qualified needs a €185k budget on a full re-run (cheap channels hit their caps); dearer clicks +30% media.</a:t>
             </a:r>
             <a:endParaRPr lang="en-US" sz="1200" dirty="0"/>
           </a:p>
@@ -9189,20 +9189,22 @@
         </p:nvGraphicFramePr>
         <p:xfrm>
           <a:off x="457200" y="1188720"/>
-          <a:ext cx="7863840" cy="914400"/>
+          <a:ext cx="8686800" cy="914400"/>
         </p:xfrm>
         <a:graphic>
           <a:graphicData uri="http://schemas.openxmlformats.org/drawingml/2006/table">
             <a:tbl>
               <a:tblPr/>
               <a:tblGrid>
-                <a:gridCol w="1737360"/>
-                <a:gridCol w="822960"/>
-                <a:gridCol w="3383280"/>
-                <a:gridCol w="1051560"/>
+                <a:gridCol w="1600200"/>
+                <a:gridCol w="685800"/>
+                <a:gridCol w="2834640"/>
+                <a:gridCol w="868680"/>
+                <a:gridCol w="960120"/>
+                <a:gridCol w="868680"/>
                 <a:gridCol w="868680"/>
               </a:tblGrid>
-              <a:tr h="384048">
+              <a:tr h="365760">
                 <a:tc>
                   <a:txBody>
                     <a:bodyPr/>
@@ -9400,7 +9402,129 @@
                             <a:schemeClr val="bg1"/>
                           </a:solidFill>
                         </a:rPr>
-                        <a:t>Cost per hire</a:t>
+                        <a:t>Spend</a:t>
+                      </a:r>
+                      <a:endParaRPr lang="en-US" sz="1100" dirty="0"/>
+                    </a:p>
+                  </a:txBody>
+                  <a:tcPr marL="91440" marR="91440" marT="45720" marB="45720" anchor="ctr">
+                    <a:lnL w="6350" cap="flat" cmpd="sng" algn="ctr">
+                      <a:solidFill>
+                        <a:srgbClr val="D6DEE5"/>
+                      </a:solidFill>
+                      <a:prstDash val="solid"/>
+                      <a:round/>
+                      <a:headEnd type="none" w="med" len="med"/>
+                      <a:tailEnd type="none" w="med" len="med"/>
+                    </a:lnL>
+                    <a:lnR w="6350" cap="flat" cmpd="sng" algn="ctr">
+                      <a:solidFill>
+                        <a:srgbClr val="D6DEE5"/>
+                      </a:solidFill>
+                      <a:prstDash val="solid"/>
+                      <a:round/>
+                      <a:headEnd type="none" w="med" len="med"/>
+                      <a:tailEnd type="none" w="med" len="med"/>
+                    </a:lnR>
+                    <a:lnT w="6350" cap="flat" cmpd="sng" algn="ctr">
+                      <a:solidFill>
+                        <a:srgbClr val="D6DEE5"/>
+                      </a:solidFill>
+                      <a:prstDash val="solid"/>
+                      <a:round/>
+                      <a:headEnd type="none" w="med" len="med"/>
+                      <a:tailEnd type="none" w="med" len="med"/>
+                    </a:lnT>
+                    <a:lnB w="6350" cap="flat" cmpd="sng" algn="ctr">
+                      <a:solidFill>
+                        <a:srgbClr val="D6DEE5"/>
+                      </a:solidFill>
+                      <a:prstDash val="solid"/>
+                      <a:round/>
+                      <a:headEnd type="none" w="med" len="med"/>
+                      <a:tailEnd type="none" w="med" len="med"/>
+                    </a:lnB>
+                    <a:solidFill>
+                      <a:schemeClr val="tx1"/>
+                    </a:solidFill>
+                  </a:tcPr>
+                </a:tc>
+                <a:tc>
+                  <a:txBody>
+                    <a:bodyPr/>
+                    <a:lstStyle/>
+                    <a:p>
+                      <a:pPr algn="ctr" indent="0" marL="0">
+                        <a:buNone/>
+                      </a:pPr>
+                      <a:r>
+                        <a:rPr lang="en-US" sz="1100" b="1" dirty="0">
+                          <a:solidFill>
+                            <a:schemeClr val="bg1"/>
+                          </a:solidFill>
+                        </a:rPr>
+                        <a:t>€ / qualified</a:t>
+                      </a:r>
+                      <a:endParaRPr lang="en-US" sz="1100" dirty="0"/>
+                    </a:p>
+                  </a:txBody>
+                  <a:tcPr marL="91440" marR="91440" marT="45720" marB="45720" anchor="ctr">
+                    <a:lnL w="6350" cap="flat" cmpd="sng" algn="ctr">
+                      <a:solidFill>
+                        <a:srgbClr val="D6DEE5"/>
+                      </a:solidFill>
+                      <a:prstDash val="solid"/>
+                      <a:round/>
+                      <a:headEnd type="none" w="med" len="med"/>
+                      <a:tailEnd type="none" w="med" len="med"/>
+                    </a:lnL>
+                    <a:lnR w="6350" cap="flat" cmpd="sng" algn="ctr">
+                      <a:solidFill>
+                        <a:srgbClr val="D6DEE5"/>
+                      </a:solidFill>
+                      <a:prstDash val="solid"/>
+                      <a:round/>
+                      <a:headEnd type="none" w="med" len="med"/>
+                      <a:tailEnd type="none" w="med" len="med"/>
+                    </a:lnR>
+                    <a:lnT w="6350" cap="flat" cmpd="sng" algn="ctr">
+                      <a:solidFill>
+                        <a:srgbClr val="D6DEE5"/>
+                      </a:solidFill>
+                      <a:prstDash val="solid"/>
+                      <a:round/>
+                      <a:headEnd type="none" w="med" len="med"/>
+                      <a:tailEnd type="none" w="med" len="med"/>
+                    </a:lnT>
+                    <a:lnB w="6350" cap="flat" cmpd="sng" algn="ctr">
+                      <a:solidFill>
+                        <a:srgbClr val="D6DEE5"/>
+                      </a:solidFill>
+                      <a:prstDash val="solid"/>
+                      <a:round/>
+                      <a:headEnd type="none" w="med" len="med"/>
+                      <a:tailEnd type="none" w="med" len="med"/>
+                    </a:lnB>
+                    <a:solidFill>
+                      <a:schemeClr val="tx1"/>
+                    </a:solidFill>
+                  </a:tcPr>
+                </a:tc>
+                <a:tc>
+                  <a:txBody>
+                    <a:bodyPr/>
+                    <a:lstStyle/>
+                    <a:p>
+                      <a:pPr algn="ctr" indent="0" marL="0">
+                        <a:buNone/>
+                      </a:pPr>
+                      <a:r>
+                        <a:rPr lang="en-US" sz="1100" b="1" dirty="0">
+                          <a:solidFill>
+                            <a:schemeClr val="bg1"/>
+                          </a:solidFill>
+                        </a:rPr>
+                        <a:t>€ / hire</a:t>
                       </a:r>
                       <a:endParaRPr lang="en-US" sz="1100" dirty="0"/>
                     </a:p>
@@ -9509,7 +9633,7 @@
                   </a:tcPr>
                 </a:tc>
               </a:tr>
-              <a:tr h="384048">
+              <a:tr h="365760">
                 <a:tc>
                   <a:txBody>
                     <a:bodyPr/>
@@ -9756,7 +9880,7 @@
                             <a:schemeClr val="tx1"/>
                           </a:solidFill>
                         </a:rPr>
-                        <a:t>20.3</a:t>
+                        <a:t>€0</a:t>
                       </a:r>
                       <a:endParaRPr lang="en-US" sz="1100" dirty="0"/>
                     </a:p>
@@ -9800,8 +9924,124 @@
                     </a:lnB>
                   </a:tcPr>
                 </a:tc>
+                <a:tc>
+                  <a:txBody>
+                    <a:bodyPr/>
+                    <a:lstStyle/>
+                    <a:p>
+                      <a:pPr algn="ctr" indent="0" marL="0">
+                        <a:buNone/>
+                      </a:pPr>
+                      <a:r>
+                        <a:rPr lang="en-US" sz="1100" dirty="0">
+                          <a:solidFill>
+                            <a:schemeClr val="tx1"/>
+                          </a:solidFill>
+                        </a:rPr>
+                        <a:t>€0</a:t>
+                      </a:r>
+                      <a:endParaRPr lang="en-US" sz="1100" dirty="0"/>
+                    </a:p>
+                  </a:txBody>
+                  <a:tcPr marL="91440" marR="91440" marT="45720" marB="45720" anchor="ctr">
+                    <a:lnL w="6350" cap="flat" cmpd="sng" algn="ctr">
+                      <a:solidFill>
+                        <a:srgbClr val="D6DEE5"/>
+                      </a:solidFill>
+                      <a:prstDash val="solid"/>
+                      <a:round/>
+                      <a:headEnd type="none" w="med" len="med"/>
+                      <a:tailEnd type="none" w="med" len="med"/>
+                    </a:lnL>
+                    <a:lnR w="6350" cap="flat" cmpd="sng" algn="ctr">
+                      <a:solidFill>
+                        <a:srgbClr val="D6DEE5"/>
+                      </a:solidFill>
+                      <a:prstDash val="solid"/>
+                      <a:round/>
+                      <a:headEnd type="none" w="med" len="med"/>
+                      <a:tailEnd type="none" w="med" len="med"/>
+                    </a:lnR>
+                    <a:lnT w="6350" cap="flat" cmpd="sng" algn="ctr">
+                      <a:solidFill>
+                        <a:srgbClr val="D6DEE5"/>
+                      </a:solidFill>
+                      <a:prstDash val="solid"/>
+                      <a:round/>
+                      <a:headEnd type="none" w="med" len="med"/>
+                      <a:tailEnd type="none" w="med" len="med"/>
+                    </a:lnT>
+                    <a:lnB w="6350" cap="flat" cmpd="sng" algn="ctr">
+                      <a:solidFill>
+                        <a:srgbClr val="D6DEE5"/>
+                      </a:solidFill>
+                      <a:prstDash val="solid"/>
+                      <a:round/>
+                      <a:headEnd type="none" w="med" len="med"/>
+                      <a:tailEnd type="none" w="med" len="med"/>
+                    </a:lnB>
+                  </a:tcPr>
+                </a:tc>
+                <a:tc>
+                  <a:txBody>
+                    <a:bodyPr/>
+                    <a:lstStyle/>
+                    <a:p>
+                      <a:pPr algn="ctr" indent="0" marL="0">
+                        <a:buNone/>
+                      </a:pPr>
+                      <a:r>
+                        <a:rPr lang="en-US" sz="1100" dirty="0">
+                          <a:solidFill>
+                            <a:schemeClr val="tx1"/>
+                          </a:solidFill>
+                        </a:rPr>
+                        <a:t>20.0</a:t>
+                      </a:r>
+                      <a:endParaRPr lang="en-US" sz="1100" dirty="0"/>
+                    </a:p>
+                  </a:txBody>
+                  <a:tcPr marL="91440" marR="91440" marT="45720" marB="45720" anchor="ctr">
+                    <a:lnL w="6350" cap="flat" cmpd="sng" algn="ctr">
+                      <a:solidFill>
+                        <a:srgbClr val="D6DEE5"/>
+                      </a:solidFill>
+                      <a:prstDash val="solid"/>
+                      <a:round/>
+                      <a:headEnd type="none" w="med" len="med"/>
+                      <a:tailEnd type="none" w="med" len="med"/>
+                    </a:lnL>
+                    <a:lnR w="6350" cap="flat" cmpd="sng" algn="ctr">
+                      <a:solidFill>
+                        <a:srgbClr val="D6DEE5"/>
+                      </a:solidFill>
+                      <a:prstDash val="solid"/>
+                      <a:round/>
+                      <a:headEnd type="none" w="med" len="med"/>
+                      <a:tailEnd type="none" w="med" len="med"/>
+                    </a:lnR>
+                    <a:lnT w="6350" cap="flat" cmpd="sng" algn="ctr">
+                      <a:solidFill>
+                        <a:srgbClr val="D6DEE5"/>
+                      </a:solidFill>
+                      <a:prstDash val="solid"/>
+                      <a:round/>
+                      <a:headEnd type="none" w="med" len="med"/>
+                      <a:tailEnd type="none" w="med" len="med"/>
+                    </a:lnT>
+                    <a:lnB w="6350" cap="flat" cmpd="sng" algn="ctr">
+                      <a:solidFill>
+                        <a:srgbClr val="D6DEE5"/>
+                      </a:solidFill>
+                      <a:prstDash val="solid"/>
+                      <a:round/>
+                      <a:headEnd type="none" w="med" len="med"/>
+                      <a:tailEnd type="none" w="med" len="med"/>
+                    </a:lnB>
+                  </a:tcPr>
+                </a:tc>
               </a:tr>
-              <a:tr h="384048">
+              <a:tr h="365760">
                 <a:tc>
                   <a:txBody>
                     <a:bodyPr/>
@@ -9990,6 +10230,122 @@
                             <a:schemeClr val="tx1"/>
                           </a:solidFill>
                         </a:rPr>
+                        <a:t>€63</a:t>
+                      </a:r>
+                      <a:endParaRPr lang="en-US" sz="1100" dirty="0"/>
+                    </a:p>
+                  </a:txBody>
+                  <a:tcPr marL="91440" marR="91440" marT="45720" marB="45720" anchor="ctr">
+                    <a:lnL w="6350" cap="flat" cmpd="sng" algn="ctr">
+                      <a:solidFill>
+                        <a:srgbClr val="D6DEE5"/>
+                      </a:solidFill>
+                      <a:prstDash val="solid"/>
+                      <a:round/>
+                      <a:headEnd type="none" w="med" len="med"/>
+                      <a:tailEnd type="none" w="med" len="med"/>
+                    </a:lnL>
+                    <a:lnR w="6350" cap="flat" cmpd="sng" algn="ctr">
+                      <a:solidFill>
+                        <a:srgbClr val="D6DEE5"/>
+                      </a:solidFill>
+                      <a:prstDash val="solid"/>
+                      <a:round/>
+                      <a:headEnd type="none" w="med" len="med"/>
+                      <a:tailEnd type="none" w="med" len="med"/>
+                    </a:lnR>
+                    <a:lnT w="6350" cap="flat" cmpd="sng" algn="ctr">
+                      <a:solidFill>
+                        <a:srgbClr val="D6DEE5"/>
+                      </a:solidFill>
+                      <a:prstDash val="solid"/>
+                      <a:round/>
+                      <a:headEnd type="none" w="med" len="med"/>
+                      <a:tailEnd type="none" w="med" len="med"/>
+                    </a:lnT>
+                    <a:lnB w="6350" cap="flat" cmpd="sng" algn="ctr">
+                      <a:solidFill>
+                        <a:srgbClr val="D6DEE5"/>
+                      </a:solidFill>
+                      <a:prstDash val="solid"/>
+                      <a:round/>
+                      <a:headEnd type="none" w="med" len="med"/>
+                      <a:tailEnd type="none" w="med" len="med"/>
+                    </a:lnB>
+                  </a:tcPr>
+                </a:tc>
+                <a:tc>
+                  <a:txBody>
+                    <a:bodyPr/>
+                    <a:lstStyle/>
+                    <a:p>
+                      <a:pPr algn="ctr" indent="0" marL="0">
+                        <a:buNone/>
+                      </a:pPr>
+                      <a:r>
+                        <a:rPr lang="en-US" sz="1100" dirty="0">
+                          <a:solidFill>
+                            <a:schemeClr val="tx1"/>
+                          </a:solidFill>
+                        </a:rPr>
+                        <a:t>€5</a:t>
+                      </a:r>
+                      <a:endParaRPr lang="en-US" sz="1100" dirty="0"/>
+                    </a:p>
+                  </a:txBody>
+                  <a:tcPr marL="91440" marR="91440" marT="45720" marB="45720" anchor="ctr">
+                    <a:lnL w="6350" cap="flat" cmpd="sng" algn="ctr">
+                      <a:solidFill>
+                        <a:srgbClr val="D6DEE5"/>
+                      </a:solidFill>
+                      <a:prstDash val="solid"/>
+                      <a:round/>
+                      <a:headEnd type="none" w="med" len="med"/>
+                      <a:tailEnd type="none" w="med" len="med"/>
+                    </a:lnL>
+                    <a:lnR w="6350" cap="flat" cmpd="sng" algn="ctr">
+                      <a:solidFill>
+                        <a:srgbClr val="D6DEE5"/>
+                      </a:solidFill>
+                      <a:prstDash val="solid"/>
+                      <a:round/>
+                      <a:headEnd type="none" w="med" len="med"/>
+                      <a:tailEnd type="none" w="med" len="med"/>
+                    </a:lnR>
+                    <a:lnT w="6350" cap="flat" cmpd="sng" algn="ctr">
+                      <a:solidFill>
+                        <a:srgbClr val="D6DEE5"/>
+                      </a:solidFill>
+                      <a:prstDash val="solid"/>
+                      <a:round/>
+                      <a:headEnd type="none" w="med" len="med"/>
+                      <a:tailEnd type="none" w="med" len="med"/>
+                    </a:lnT>
+                    <a:lnB w="6350" cap="flat" cmpd="sng" algn="ctr">
+                      <a:solidFill>
+                        <a:srgbClr val="D6DEE5"/>
+                      </a:solidFill>
+                      <a:prstDash val="solid"/>
+                      <a:round/>
+                      <a:headEnd type="none" w="med" len="med"/>
+                      <a:tailEnd type="none" w="med" len="med"/>
+                    </a:lnB>
+                  </a:tcPr>
+                </a:tc>
+                <a:tc>
+                  <a:txBody>
+                    <a:bodyPr/>
+                    <a:lstStyle/>
+                    <a:p>
+                      <a:pPr algn="ctr" indent="0" marL="0">
+                        <a:buNone/>
+                      </a:pPr>
+                      <a:r>
+                        <a:rPr lang="en-US" sz="1100" dirty="0">
+                          <a:solidFill>
+                            <a:schemeClr val="tx1"/>
+                          </a:solidFill>
+                        </a:rPr>
                         <a:t>€14</a:t>
                       </a:r>
                       <a:endParaRPr lang="en-US" sz="1100" dirty="0"/>
@@ -10093,7 +10449,7 @@
                   </a:tcPr>
                 </a:tc>
               </a:tr>
-              <a:tr h="384048">
+              <a:tr h="365760">
                 <a:tc>
                   <a:txBody>
                     <a:bodyPr/>
@@ -10282,6 +10638,122 @@
                             <a:schemeClr val="tx1"/>
                           </a:solidFill>
                         </a:rPr>
+                        <a:t>€6.9k</a:t>
+                      </a:r>
+                      <a:endParaRPr lang="en-US" sz="1100" dirty="0"/>
+                    </a:p>
+                  </a:txBody>
+                  <a:tcPr marL="91440" marR="91440" marT="45720" marB="45720" anchor="ctr">
+                    <a:lnL w="6350" cap="flat" cmpd="sng" algn="ctr">
+                      <a:solidFill>
+                        <a:srgbClr val="D6DEE5"/>
+                      </a:solidFill>
+                      <a:prstDash val="solid"/>
+                      <a:round/>
+                      <a:headEnd type="none" w="med" len="med"/>
+                      <a:tailEnd type="none" w="med" len="med"/>
+                    </a:lnL>
+                    <a:lnR w="6350" cap="flat" cmpd="sng" algn="ctr">
+                      <a:solidFill>
+                        <a:srgbClr val="D6DEE5"/>
+                      </a:solidFill>
+                      <a:prstDash val="solid"/>
+                      <a:round/>
+                      <a:headEnd type="none" w="med" len="med"/>
+                      <a:tailEnd type="none" w="med" len="med"/>
+                    </a:lnR>
+                    <a:lnT w="6350" cap="flat" cmpd="sng" algn="ctr">
+                      <a:solidFill>
+                        <a:srgbClr val="D6DEE5"/>
+                      </a:solidFill>
+                      <a:prstDash val="solid"/>
+                      <a:round/>
+                      <a:headEnd type="none" w="med" len="med"/>
+                      <a:tailEnd type="none" w="med" len="med"/>
+                    </a:lnT>
+                    <a:lnB w="6350" cap="flat" cmpd="sng" algn="ctr">
+                      <a:solidFill>
+                        <a:srgbClr val="D6DEE5"/>
+                      </a:solidFill>
+                      <a:prstDash val="solid"/>
+                      <a:round/>
+                      <a:headEnd type="none" w="med" len="med"/>
+                      <a:tailEnd type="none" w="med" len="med"/>
+                    </a:lnB>
+                  </a:tcPr>
+                </a:tc>
+                <a:tc>
+                  <a:txBody>
+                    <a:bodyPr/>
+                    <a:lstStyle/>
+                    <a:p>
+                      <a:pPr algn="ctr" indent="0" marL="0">
+                        <a:buNone/>
+                      </a:pPr>
+                      <a:r>
+                        <a:rPr lang="en-US" sz="1100" dirty="0">
+                          <a:solidFill>
+                            <a:schemeClr val="tx1"/>
+                          </a:solidFill>
+                        </a:rPr>
+                        <a:t>€142</a:t>
+                      </a:r>
+                      <a:endParaRPr lang="en-US" sz="1100" dirty="0"/>
+                    </a:p>
+                  </a:txBody>
+                  <a:tcPr marL="91440" marR="91440" marT="45720" marB="45720" anchor="ctr">
+                    <a:lnL w="6350" cap="flat" cmpd="sng" algn="ctr">
+                      <a:solidFill>
+                        <a:srgbClr val="D6DEE5"/>
+                      </a:solidFill>
+                      <a:prstDash val="solid"/>
+                      <a:round/>
+                      <a:headEnd type="none" w="med" len="med"/>
+                      <a:tailEnd type="none" w="med" len="med"/>
+                    </a:lnL>
+                    <a:lnR w="6350" cap="flat" cmpd="sng" algn="ctr">
+                      <a:solidFill>
+                        <a:srgbClr val="D6DEE5"/>
+                      </a:solidFill>
+                      <a:prstDash val="solid"/>
+                      <a:round/>
+                      <a:headEnd type="none" w="med" len="med"/>
+                      <a:tailEnd type="none" w="med" len="med"/>
+                    </a:lnR>
+                    <a:lnT w="6350" cap="flat" cmpd="sng" algn="ctr">
+                      <a:solidFill>
+                        <a:srgbClr val="D6DEE5"/>
+                      </a:solidFill>
+                      <a:prstDash val="solid"/>
+                      <a:round/>
+                      <a:headEnd type="none" w="med" len="med"/>
+                      <a:tailEnd type="none" w="med" len="med"/>
+                    </a:lnT>
+                    <a:lnB w="6350" cap="flat" cmpd="sng" algn="ctr">
+                      <a:solidFill>
+                        <a:srgbClr val="D6DEE5"/>
+                      </a:solidFill>
+                      <a:prstDash val="solid"/>
+                      <a:round/>
+                      <a:headEnd type="none" w="med" len="med"/>
+                      <a:tailEnd type="none" w="med" len="med"/>
+                    </a:lnB>
+                  </a:tcPr>
+                </a:tc>
+                <a:tc>
+                  <a:txBody>
+                    <a:bodyPr/>
+                    <a:lstStyle/>
+                    <a:p>
+                      <a:pPr algn="ctr" indent="0" marL="0">
+                        <a:buNone/>
+                      </a:pPr>
+                      <a:r>
+                        <a:rPr lang="en-US" sz="1100" dirty="0">
+                          <a:solidFill>
+                            <a:schemeClr val="tx1"/>
+                          </a:solidFill>
+                        </a:rPr>
                         <a:t>€383</a:t>
                       </a:r>
                       <a:endParaRPr lang="en-US" sz="1100" dirty="0"/>
@@ -10385,7 +10857,7 @@
                   </a:tcPr>
                 </a:tc>
               </a:tr>
-              <a:tr h="384048">
+              <a:tr h="365760">
                 <a:tc>
                   <a:txBody>
                     <a:bodyPr/>
@@ -10574,6 +11046,122 @@
                             <a:schemeClr val="tx1"/>
                           </a:solidFill>
                         </a:rPr>
+                        <a:t>€11k</a:t>
+                      </a:r>
+                      <a:endParaRPr lang="en-US" sz="1100" dirty="0"/>
+                    </a:p>
+                  </a:txBody>
+                  <a:tcPr marL="91440" marR="91440" marT="45720" marB="45720" anchor="ctr">
+                    <a:lnL w="6350" cap="flat" cmpd="sng" algn="ctr">
+                      <a:solidFill>
+                        <a:srgbClr val="D6DEE5"/>
+                      </a:solidFill>
+                      <a:prstDash val="solid"/>
+                      <a:round/>
+                      <a:headEnd type="none" w="med" len="med"/>
+                      <a:tailEnd type="none" w="med" len="med"/>
+                    </a:lnL>
+                    <a:lnR w="6350" cap="flat" cmpd="sng" algn="ctr">
+                      <a:solidFill>
+                        <a:srgbClr val="D6DEE5"/>
+                      </a:solidFill>
+                      <a:prstDash val="solid"/>
+                      <a:round/>
+                      <a:headEnd type="none" w="med" len="med"/>
+                      <a:tailEnd type="none" w="med" len="med"/>
+                    </a:lnR>
+                    <a:lnT w="6350" cap="flat" cmpd="sng" algn="ctr">
+                      <a:solidFill>
+                        <a:srgbClr val="D6DEE5"/>
+                      </a:solidFill>
+                      <a:prstDash val="solid"/>
+                      <a:round/>
+                      <a:headEnd type="none" w="med" len="med"/>
+                      <a:tailEnd type="none" w="med" len="med"/>
+                    </a:lnT>
+                    <a:lnB w="6350" cap="flat" cmpd="sng" algn="ctr">
+                      <a:solidFill>
+                        <a:srgbClr val="D6DEE5"/>
+                      </a:solidFill>
+                      <a:prstDash val="solid"/>
+                      <a:round/>
+                      <a:headEnd type="none" w="med" len="med"/>
+                      <a:tailEnd type="none" w="med" len="med"/>
+                    </a:lnB>
+                  </a:tcPr>
+                </a:tc>
+                <a:tc>
+                  <a:txBody>
+                    <a:bodyPr/>
+                    <a:lstStyle/>
+                    <a:p>
+                      <a:pPr algn="ctr" indent="0" marL="0">
+                        <a:buNone/>
+                      </a:pPr>
+                      <a:r>
+                        <a:rPr lang="en-US" sz="1100" dirty="0">
+                          <a:solidFill>
+                            <a:schemeClr val="tx1"/>
+                          </a:solidFill>
+                        </a:rPr>
+                        <a:t>€370</a:t>
+                      </a:r>
+                      <a:endParaRPr lang="en-US" sz="1100" dirty="0"/>
+                    </a:p>
+                  </a:txBody>
+                  <a:tcPr marL="91440" marR="91440" marT="45720" marB="45720" anchor="ctr">
+                    <a:lnL w="6350" cap="flat" cmpd="sng" algn="ctr">
+                      <a:solidFill>
+                        <a:srgbClr val="D6DEE5"/>
+                      </a:solidFill>
+                      <a:prstDash val="solid"/>
+                      <a:round/>
+                      <a:headEnd type="none" w="med" len="med"/>
+                      <a:tailEnd type="none" w="med" len="med"/>
+                    </a:lnL>
+                    <a:lnR w="6350" cap="flat" cmpd="sng" algn="ctr">
+                      <a:solidFill>
+                        <a:srgbClr val="D6DEE5"/>
+                      </a:solidFill>
+                      <a:prstDash val="solid"/>
+                      <a:round/>
+                      <a:headEnd type="none" w="med" len="med"/>
+                      <a:tailEnd type="none" w="med" len="med"/>
+                    </a:lnR>
+                    <a:lnT w="6350" cap="flat" cmpd="sng" algn="ctr">
+                      <a:solidFill>
+                        <a:srgbClr val="D6DEE5"/>
+                      </a:solidFill>
+                      <a:prstDash val="solid"/>
+                      <a:round/>
+                      <a:headEnd type="none" w="med" len="med"/>
+                      <a:tailEnd type="none" w="med" len="med"/>
+                    </a:lnT>
+                    <a:lnB w="6350" cap="flat" cmpd="sng" algn="ctr">
+                      <a:solidFill>
+                        <a:srgbClr val="D6DEE5"/>
+                      </a:solidFill>
+                      <a:prstDash val="solid"/>
+                      <a:round/>
+                      <a:headEnd type="none" w="med" len="med"/>
+                      <a:tailEnd type="none" w="med" len="med"/>
+                    </a:lnB>
+                  </a:tcPr>
+                </a:tc>
+                <a:tc>
+                  <a:txBody>
+                    <a:bodyPr/>
+                    <a:lstStyle/>
+                    <a:p>
+                      <a:pPr algn="ctr" indent="0" marL="0">
+                        <a:buNone/>
+                      </a:pPr>
+                      <a:r>
+                        <a:rPr lang="en-US" sz="1100" dirty="0">
+                          <a:solidFill>
+                            <a:schemeClr val="tx1"/>
+                          </a:solidFill>
+                        </a:rPr>
                         <a:t>€1,000</a:t>
                       </a:r>
                       <a:endParaRPr lang="en-US" sz="1100" dirty="0"/>
@@ -10677,7 +11265,7 @@
                   </a:tcPr>
                 </a:tc>
               </a:tr>
-              <a:tr h="384048">
+              <a:tr h="365760">
                 <a:tc>
                   <a:txBody>
                     <a:bodyPr/>
@@ -10866,6 +11454,122 @@
                             <a:schemeClr val="tx1"/>
                           </a:solidFill>
                         </a:rPr>
+                        <a:t>€11.1k</a:t>
+                      </a:r>
+                      <a:endParaRPr lang="en-US" sz="1100" dirty="0"/>
+                    </a:p>
+                  </a:txBody>
+                  <a:tcPr marL="91440" marR="91440" marT="45720" marB="45720" anchor="ctr">
+                    <a:lnL w="6350" cap="flat" cmpd="sng" algn="ctr">
+                      <a:solidFill>
+                        <a:srgbClr val="D6DEE5"/>
+                      </a:solidFill>
+                      <a:prstDash val="solid"/>
+                      <a:round/>
+                      <a:headEnd type="none" w="med" len="med"/>
+                      <a:tailEnd type="none" w="med" len="med"/>
+                    </a:lnL>
+                    <a:lnR w="6350" cap="flat" cmpd="sng" algn="ctr">
+                      <a:solidFill>
+                        <a:srgbClr val="D6DEE5"/>
+                      </a:solidFill>
+                      <a:prstDash val="solid"/>
+                      <a:round/>
+                      <a:headEnd type="none" w="med" len="med"/>
+                      <a:tailEnd type="none" w="med" len="med"/>
+                    </a:lnR>
+                    <a:lnT w="6350" cap="flat" cmpd="sng" algn="ctr">
+                      <a:solidFill>
+                        <a:srgbClr val="D6DEE5"/>
+                      </a:solidFill>
+                      <a:prstDash val="solid"/>
+                      <a:round/>
+                      <a:headEnd type="none" w="med" len="med"/>
+                      <a:tailEnd type="none" w="med" len="med"/>
+                    </a:lnT>
+                    <a:lnB w="6350" cap="flat" cmpd="sng" algn="ctr">
+                      <a:solidFill>
+                        <a:srgbClr val="D6DEE5"/>
+                      </a:solidFill>
+                      <a:prstDash val="solid"/>
+                      <a:round/>
+                      <a:headEnd type="none" w="med" len="med"/>
+                      <a:tailEnd type="none" w="med" len="med"/>
+                    </a:lnB>
+                  </a:tcPr>
+                </a:tc>
+                <a:tc>
+                  <a:txBody>
+                    <a:bodyPr/>
+                    <a:lstStyle/>
+                    <a:p>
+                      <a:pPr algn="ctr" indent="0" marL="0">
+                        <a:buNone/>
+                      </a:pPr>
+                      <a:r>
+                        <a:rPr lang="en-US" sz="1100" dirty="0">
+                          <a:solidFill>
+                            <a:schemeClr val="tx1"/>
+                          </a:solidFill>
+                        </a:rPr>
+                        <a:t>€377</a:t>
+                      </a:r>
+                      <a:endParaRPr lang="en-US" sz="1100" dirty="0"/>
+                    </a:p>
+                  </a:txBody>
+                  <a:tcPr marL="91440" marR="91440" marT="45720" marB="45720" anchor="ctr">
+                    <a:lnL w="6350" cap="flat" cmpd="sng" algn="ctr">
+                      <a:solidFill>
+                        <a:srgbClr val="D6DEE5"/>
+                      </a:solidFill>
+                      <a:prstDash val="solid"/>
+                      <a:round/>
+                      <a:headEnd type="none" w="med" len="med"/>
+                      <a:tailEnd type="none" w="med" len="med"/>
+                    </a:lnL>
+                    <a:lnR w="6350" cap="flat" cmpd="sng" algn="ctr">
+                      <a:solidFill>
+                        <a:srgbClr val="D6DEE5"/>
+                      </a:solidFill>
+                      <a:prstDash val="solid"/>
+                      <a:round/>
+                      <a:headEnd type="none" w="med" len="med"/>
+                      <a:tailEnd type="none" w="med" len="med"/>
+                    </a:lnR>
+                    <a:lnT w="6350" cap="flat" cmpd="sng" algn="ctr">
+                      <a:solidFill>
+                        <a:srgbClr val="D6DEE5"/>
+                      </a:solidFill>
+                      <a:prstDash val="solid"/>
+                      <a:round/>
+                      <a:headEnd type="none" w="med" len="med"/>
+                      <a:tailEnd type="none" w="med" len="med"/>
+                    </a:lnT>
+                    <a:lnB w="6350" cap="flat" cmpd="sng" algn="ctr">
+                      <a:solidFill>
+                        <a:srgbClr val="D6DEE5"/>
+                      </a:solidFill>
+                      <a:prstDash val="solid"/>
+                      <a:round/>
+                      <a:headEnd type="none" w="med" len="med"/>
+                      <a:tailEnd type="none" w="med" len="med"/>
+                    </a:lnB>
+                  </a:tcPr>
+                </a:tc>
+                <a:tc>
+                  <a:txBody>
+                    <a:bodyPr/>
+                    <a:lstStyle/>
+                    <a:p>
+                      <a:pPr algn="ctr" indent="0" marL="0">
+                        <a:buNone/>
+                      </a:pPr>
+                      <a:r>
+                        <a:rPr lang="en-US" sz="1100" dirty="0">
+                          <a:solidFill>
+                            <a:schemeClr val="tx1"/>
+                          </a:solidFill>
+                        </a:rPr>
                         <a:t>€1,329</a:t>
                       </a:r>
                       <a:endParaRPr lang="en-US" sz="1100" dirty="0"/>
@@ -10969,7 +11673,7 @@
                   </a:tcPr>
                 </a:tc>
               </a:tr>
-              <a:tr h="384048">
+              <a:tr h="365760">
                 <a:tc>
                   <a:txBody>
                     <a:bodyPr/>
@@ -11158,6 +11862,122 @@
                             <a:schemeClr val="tx1"/>
                           </a:solidFill>
                         </a:rPr>
+                        <a:t>€5.8k</a:t>
+                      </a:r>
+                      <a:endParaRPr lang="en-US" sz="1100" dirty="0"/>
+                    </a:p>
+                  </a:txBody>
+                  <a:tcPr marL="91440" marR="91440" marT="45720" marB="45720" anchor="ctr">
+                    <a:lnL w="6350" cap="flat" cmpd="sng" algn="ctr">
+                      <a:solidFill>
+                        <a:srgbClr val="D6DEE5"/>
+                      </a:solidFill>
+                      <a:prstDash val="solid"/>
+                      <a:round/>
+                      <a:headEnd type="none" w="med" len="med"/>
+                      <a:tailEnd type="none" w="med" len="med"/>
+                    </a:lnL>
+                    <a:lnR w="6350" cap="flat" cmpd="sng" algn="ctr">
+                      <a:solidFill>
+                        <a:srgbClr val="D6DEE5"/>
+                      </a:solidFill>
+                      <a:prstDash val="solid"/>
+                      <a:round/>
+                      <a:headEnd type="none" w="med" len="med"/>
+                      <a:tailEnd type="none" w="med" len="med"/>
+                    </a:lnR>
+                    <a:lnT w="6350" cap="flat" cmpd="sng" algn="ctr">
+                      <a:solidFill>
+                        <a:srgbClr val="D6DEE5"/>
+                      </a:solidFill>
+                      <a:prstDash val="solid"/>
+                      <a:round/>
+                      <a:headEnd type="none" w="med" len="med"/>
+                      <a:tailEnd type="none" w="med" len="med"/>
+                    </a:lnT>
+                    <a:lnB w="6350" cap="flat" cmpd="sng" algn="ctr">
+                      <a:solidFill>
+                        <a:srgbClr val="D6DEE5"/>
+                      </a:solidFill>
+                      <a:prstDash val="solid"/>
+                      <a:round/>
+                      <a:headEnd type="none" w="med" len="med"/>
+                      <a:tailEnd type="none" w="med" len="med"/>
+                    </a:lnB>
+                  </a:tcPr>
+                </a:tc>
+                <a:tc>
+                  <a:txBody>
+                    <a:bodyPr/>
+                    <a:lstStyle/>
+                    <a:p>
+                      <a:pPr algn="ctr" indent="0" marL="0">
+                        <a:buNone/>
+                      </a:pPr>
+                      <a:r>
+                        <a:rPr lang="en-US" sz="1100" dirty="0">
+                          <a:solidFill>
+                            <a:schemeClr val="tx1"/>
+                          </a:solidFill>
+                        </a:rPr>
+                        <a:t>€537</a:t>
+                      </a:r>
+                      <a:endParaRPr lang="en-US" sz="1100" dirty="0"/>
+                    </a:p>
+                  </a:txBody>
+                  <a:tcPr marL="91440" marR="91440" marT="45720" marB="45720" anchor="ctr">
+                    <a:lnL w="6350" cap="flat" cmpd="sng" algn="ctr">
+                      <a:solidFill>
+                        <a:srgbClr val="D6DEE5"/>
+                      </a:solidFill>
+                      <a:prstDash val="solid"/>
+                      <a:round/>
+                      <a:headEnd type="none" w="med" len="med"/>
+                      <a:tailEnd type="none" w="med" len="med"/>
+                    </a:lnL>
+                    <a:lnR w="6350" cap="flat" cmpd="sng" algn="ctr">
+                      <a:solidFill>
+                        <a:srgbClr val="D6DEE5"/>
+                      </a:solidFill>
+                      <a:prstDash val="solid"/>
+                      <a:round/>
+                      <a:headEnd type="none" w="med" len="med"/>
+                      <a:tailEnd type="none" w="med" len="med"/>
+                    </a:lnR>
+                    <a:lnT w="6350" cap="flat" cmpd="sng" algn="ctr">
+                      <a:solidFill>
+                        <a:srgbClr val="D6DEE5"/>
+                      </a:solidFill>
+                      <a:prstDash val="solid"/>
+                      <a:round/>
+                      <a:headEnd type="none" w="med" len="med"/>
+                      <a:tailEnd type="none" w="med" len="med"/>
+                    </a:lnT>
+                    <a:lnB w="6350" cap="flat" cmpd="sng" algn="ctr">
+                      <a:solidFill>
+                        <a:srgbClr val="D6DEE5"/>
+                      </a:solidFill>
+                      <a:prstDash val="solid"/>
+                      <a:round/>
+                      <a:headEnd type="none" w="med" len="med"/>
+                      <a:tailEnd type="none" w="med" len="med"/>
+                    </a:lnB>
+                  </a:tcPr>
+                </a:tc>
+                <a:tc>
+                  <a:txBody>
+                    <a:bodyPr/>
+                    <a:lstStyle/>
+                    <a:p>
+                      <a:pPr algn="ctr" indent="0" marL="0">
+                        <a:buNone/>
+                      </a:pPr>
+                      <a:r>
+                        <a:rPr lang="en-US" sz="1100" dirty="0">
+                          <a:solidFill>
+                            <a:schemeClr val="tx1"/>
+                          </a:solidFill>
+                        </a:rPr>
                         <a:t>€1,564</a:t>
                       </a:r>
                       <a:endParaRPr lang="en-US" sz="1100" dirty="0"/>
@@ -11261,7 +12081,7 @@
                   </a:tcPr>
                 </a:tc>
               </a:tr>
-              <a:tr h="384048">
+              <a:tr h="365760">
                 <a:tc>
                   <a:txBody>
                     <a:bodyPr/>
@@ -11450,6 +12270,122 @@
                             <a:schemeClr val="tx1"/>
                           </a:solidFill>
                         </a:rPr>
+                        <a:t>€27.2k</a:t>
+                      </a:r>
+                      <a:endParaRPr lang="en-US" sz="1100" dirty="0"/>
+                    </a:p>
+                  </a:txBody>
+                  <a:tcPr marL="91440" marR="91440" marT="45720" marB="45720" anchor="ctr">
+                    <a:lnL w="6350" cap="flat" cmpd="sng" algn="ctr">
+                      <a:solidFill>
+                        <a:srgbClr val="D6DEE5"/>
+                      </a:solidFill>
+                      <a:prstDash val="solid"/>
+                      <a:round/>
+                      <a:headEnd type="none" w="med" len="med"/>
+                      <a:tailEnd type="none" w="med" len="med"/>
+                    </a:lnL>
+                    <a:lnR w="6350" cap="flat" cmpd="sng" algn="ctr">
+                      <a:solidFill>
+                        <a:srgbClr val="D6DEE5"/>
+                      </a:solidFill>
+                      <a:prstDash val="solid"/>
+                      <a:round/>
+                      <a:headEnd type="none" w="med" len="med"/>
+                      <a:tailEnd type="none" w="med" len="med"/>
+                    </a:lnR>
+                    <a:lnT w="6350" cap="flat" cmpd="sng" algn="ctr">
+                      <a:solidFill>
+                        <a:srgbClr val="D6DEE5"/>
+                      </a:solidFill>
+                      <a:prstDash val="solid"/>
+                      <a:round/>
+                      <a:headEnd type="none" w="med" len="med"/>
+                      <a:tailEnd type="none" w="med" len="med"/>
+                    </a:lnT>
+                    <a:lnB w="6350" cap="flat" cmpd="sng" algn="ctr">
+                      <a:solidFill>
+                        <a:srgbClr val="D6DEE5"/>
+                      </a:solidFill>
+                      <a:prstDash val="solid"/>
+                      <a:round/>
+                      <a:headEnd type="none" w="med" len="med"/>
+                      <a:tailEnd type="none" w="med" len="med"/>
+                    </a:lnB>
+                  </a:tcPr>
+                </a:tc>
+                <a:tc>
+                  <a:txBody>
+                    <a:bodyPr/>
+                    <a:lstStyle/>
+                    <a:p>
+                      <a:pPr algn="ctr" indent="0" marL="0">
+                        <a:buNone/>
+                      </a:pPr>
+                      <a:r>
+                        <a:rPr lang="en-US" sz="1100" dirty="0">
+                          <a:solidFill>
+                            <a:schemeClr val="tx1"/>
+                          </a:solidFill>
+                        </a:rPr>
+                        <a:t>€444</a:t>
+                      </a:r>
+                      <a:endParaRPr lang="en-US" sz="1100" dirty="0"/>
+                    </a:p>
+                  </a:txBody>
+                  <a:tcPr marL="91440" marR="91440" marT="45720" marB="45720" anchor="ctr">
+                    <a:lnL w="6350" cap="flat" cmpd="sng" algn="ctr">
+                      <a:solidFill>
+                        <a:srgbClr val="D6DEE5"/>
+                      </a:solidFill>
+                      <a:prstDash val="solid"/>
+                      <a:round/>
+                      <a:headEnd type="none" w="med" len="med"/>
+                      <a:tailEnd type="none" w="med" len="med"/>
+                    </a:lnL>
+                    <a:lnR w="6350" cap="flat" cmpd="sng" algn="ctr">
+                      <a:solidFill>
+                        <a:srgbClr val="D6DEE5"/>
+                      </a:solidFill>
+                      <a:prstDash val="solid"/>
+                      <a:round/>
+                      <a:headEnd type="none" w="med" len="med"/>
+                      <a:tailEnd type="none" w="med" len="med"/>
+                    </a:lnR>
+                    <a:lnT w="6350" cap="flat" cmpd="sng" algn="ctr">
+                      <a:solidFill>
+                        <a:srgbClr val="D6DEE5"/>
+                      </a:solidFill>
+                      <a:prstDash val="solid"/>
+                      <a:round/>
+                      <a:headEnd type="none" w="med" len="med"/>
+                      <a:tailEnd type="none" w="med" len="med"/>
+                    </a:lnT>
+                    <a:lnB w="6350" cap="flat" cmpd="sng" algn="ctr">
+                      <a:solidFill>
+                        <a:srgbClr val="D6DEE5"/>
+                      </a:solidFill>
+                      <a:prstDash val="solid"/>
+                      <a:round/>
+                      <a:headEnd type="none" w="med" len="med"/>
+                      <a:tailEnd type="none" w="med" len="med"/>
+                    </a:lnB>
+                  </a:tcPr>
+                </a:tc>
+                <a:tc>
+                  <a:txBody>
+                    <a:bodyPr/>
+                    <a:lstStyle/>
+                    <a:p>
+                      <a:pPr algn="ctr" indent="0" marL="0">
+                        <a:buNone/>
+                      </a:pPr>
+                      <a:r>
+                        <a:rPr lang="en-US" sz="1100" dirty="0">
+                          <a:solidFill>
+                            <a:schemeClr val="tx1"/>
+                          </a:solidFill>
+                        </a:rPr>
                         <a:t>€1,687</a:t>
                       </a:r>
                       <a:endParaRPr lang="en-US" sz="1100" dirty="0"/>
@@ -11553,7 +12489,7 @@
                   </a:tcPr>
                 </a:tc>
               </a:tr>
-              <a:tr h="384048">
+              <a:tr h="365760">
                 <a:tc>
                   <a:txBody>
                     <a:bodyPr/>
@@ -11742,7 +12678,7 @@
                             <a:schemeClr val="tx1"/>
                           </a:solidFill>
                         </a:rPr>
-                        <a:t>€2,143</a:t>
+                        <a:t>€35.7k</a:t>
                       </a:r>
                       <a:endParaRPr lang="en-US" sz="1100" dirty="0"/>
                     </a:p>
@@ -11800,7 +12736,7 @@
                             <a:schemeClr val="tx1"/>
                           </a:solidFill>
                         </a:rPr>
-                        <a:t>16.4</a:t>
+                        <a:t>€717</a:t>
                       </a:r>
                       <a:endParaRPr lang="en-US" sz="1100" dirty="0"/>
                     </a:p>
@@ -11844,8 +12780,124 @@
                     </a:lnB>
                   </a:tcPr>
                 </a:tc>
+                <a:tc>
+                  <a:txBody>
+                    <a:bodyPr/>
+                    <a:lstStyle/>
+                    <a:p>
+                      <a:pPr algn="ctr" indent="0" marL="0">
+                        <a:buNone/>
+                      </a:pPr>
+                      <a:r>
+                        <a:rPr lang="en-US" sz="1100" dirty="0">
+                          <a:solidFill>
+                            <a:schemeClr val="tx1"/>
+                          </a:solidFill>
+                        </a:rPr>
+                        <a:t>€2,142</a:t>
+                      </a:r>
+                      <a:endParaRPr lang="en-US" sz="1100" dirty="0"/>
+                    </a:p>
+                  </a:txBody>
+                  <a:tcPr marL="91440" marR="91440" marT="45720" marB="45720" anchor="ctr">
+                    <a:lnL w="6350" cap="flat" cmpd="sng" algn="ctr">
+                      <a:solidFill>
+                        <a:srgbClr val="D6DEE5"/>
+                      </a:solidFill>
+                      <a:prstDash val="solid"/>
+                      <a:round/>
+                      <a:headEnd type="none" w="med" len="med"/>
+                      <a:tailEnd type="none" w="med" len="med"/>
+                    </a:lnL>
+                    <a:lnR w="6350" cap="flat" cmpd="sng" algn="ctr">
+                      <a:solidFill>
+                        <a:srgbClr val="D6DEE5"/>
+                      </a:solidFill>
+                      <a:prstDash val="solid"/>
+                      <a:round/>
+                      <a:headEnd type="none" w="med" len="med"/>
+                      <a:tailEnd type="none" w="med" len="med"/>
+                    </a:lnR>
+                    <a:lnT w="6350" cap="flat" cmpd="sng" algn="ctr">
+                      <a:solidFill>
+                        <a:srgbClr val="D6DEE5"/>
+                      </a:solidFill>
+                      <a:prstDash val="solid"/>
+                      <a:round/>
+                      <a:headEnd type="none" w="med" len="med"/>
+                      <a:tailEnd type="none" w="med" len="med"/>
+                    </a:lnT>
+                    <a:lnB w="6350" cap="flat" cmpd="sng" algn="ctr">
+                      <a:solidFill>
+                        <a:srgbClr val="D6DEE5"/>
+                      </a:solidFill>
+                      <a:prstDash val="solid"/>
+                      <a:round/>
+                      <a:headEnd type="none" w="med" len="med"/>
+                      <a:tailEnd type="none" w="med" len="med"/>
+                    </a:lnB>
+                  </a:tcPr>
+                </a:tc>
+                <a:tc>
+                  <a:txBody>
+                    <a:bodyPr/>
+                    <a:lstStyle/>
+                    <a:p>
+                      <a:pPr algn="ctr" indent="0" marL="0">
+                        <a:buNone/>
+                      </a:pPr>
+                      <a:r>
+                        <a:rPr lang="en-US" sz="1100" dirty="0">
+                          <a:solidFill>
+                            <a:schemeClr val="tx1"/>
+                          </a:solidFill>
+                        </a:rPr>
+                        <a:t>16.7</a:t>
+                      </a:r>
+                      <a:endParaRPr lang="en-US" sz="1100" dirty="0"/>
+                    </a:p>
+                  </a:txBody>
+                  <a:tcPr marL="91440" marR="91440" marT="45720" marB="45720" anchor="ctr">
+                    <a:lnL w="6350" cap="flat" cmpd="sng" algn="ctr">
+                      <a:solidFill>
+                        <a:srgbClr val="D6DEE5"/>
+                      </a:solidFill>
+                      <a:prstDash val="solid"/>
+                      <a:round/>
+                      <a:headEnd type="none" w="med" len="med"/>
+                      <a:tailEnd type="none" w="med" len="med"/>
+                    </a:lnL>
+                    <a:lnR w="6350" cap="flat" cmpd="sng" algn="ctr">
+                      <a:solidFill>
+                        <a:srgbClr val="D6DEE5"/>
+                      </a:solidFill>
+                      <a:prstDash val="solid"/>
+                      <a:round/>
+                      <a:headEnd type="none" w="med" len="med"/>
+                      <a:tailEnd type="none" w="med" len="med"/>
+                    </a:lnR>
+                    <a:lnT w="6350" cap="flat" cmpd="sng" algn="ctr">
+                      <a:solidFill>
+                        <a:srgbClr val="D6DEE5"/>
+                      </a:solidFill>
+                      <a:prstDash val="solid"/>
+                      <a:round/>
+                      <a:headEnd type="none" w="med" len="med"/>
+                      <a:tailEnd type="none" w="med" len="med"/>
+                    </a:lnT>
+                    <a:lnB w="6350" cap="flat" cmpd="sng" algn="ctr">
+                      <a:solidFill>
+                        <a:srgbClr val="D6DEE5"/>
+                      </a:solidFill>
+                      <a:prstDash val="solid"/>
+                      <a:round/>
+                      <a:headEnd type="none" w="med" len="med"/>
+                      <a:tailEnd type="none" w="med" len="med"/>
+                    </a:lnB>
+                  </a:tcPr>
+                </a:tc>
               </a:tr>
-              <a:tr h="384048">
+              <a:tr h="365760">
                 <a:tc>
                   <a:txBody>
                     <a:bodyPr/>
@@ -12034,6 +13086,122 @@
                             <a:schemeClr val="tx1"/>
                           </a:solidFill>
                         </a:rPr>
+                        <a:t>€1.5k</a:t>
+                      </a:r>
+                      <a:endParaRPr lang="en-US" sz="1100" dirty="0"/>
+                    </a:p>
+                  </a:txBody>
+                  <a:tcPr marL="91440" marR="91440" marT="45720" marB="45720" anchor="ctr">
+                    <a:lnL w="6350" cap="flat" cmpd="sng" algn="ctr">
+                      <a:solidFill>
+                        <a:srgbClr val="D6DEE5"/>
+                      </a:solidFill>
+                      <a:prstDash val="solid"/>
+                      <a:round/>
+                      <a:headEnd type="none" w="med" len="med"/>
+                      <a:tailEnd type="none" w="med" len="med"/>
+                    </a:lnL>
+                    <a:lnR w="6350" cap="flat" cmpd="sng" algn="ctr">
+                      <a:solidFill>
+                        <a:srgbClr val="D6DEE5"/>
+                      </a:solidFill>
+                      <a:prstDash val="solid"/>
+                      <a:round/>
+                      <a:headEnd type="none" w="med" len="med"/>
+                      <a:tailEnd type="none" w="med" len="med"/>
+                    </a:lnR>
+                    <a:lnT w="6350" cap="flat" cmpd="sng" algn="ctr">
+                      <a:solidFill>
+                        <a:srgbClr val="D6DEE5"/>
+                      </a:solidFill>
+                      <a:prstDash val="solid"/>
+                      <a:round/>
+                      <a:headEnd type="none" w="med" len="med"/>
+                      <a:tailEnd type="none" w="med" len="med"/>
+                    </a:lnT>
+                    <a:lnB w="6350" cap="flat" cmpd="sng" algn="ctr">
+                      <a:solidFill>
+                        <a:srgbClr val="D6DEE5"/>
+                      </a:solidFill>
+                      <a:prstDash val="solid"/>
+                      <a:round/>
+                      <a:headEnd type="none" w="med" len="med"/>
+                      <a:tailEnd type="none" w="med" len="med"/>
+                    </a:lnB>
+                  </a:tcPr>
+                </a:tc>
+                <a:tc>
+                  <a:txBody>
+                    <a:bodyPr/>
+                    <a:lstStyle/>
+                    <a:p>
+                      <a:pPr algn="ctr" indent="0" marL="0">
+                        <a:buNone/>
+                      </a:pPr>
+                      <a:r>
+                        <a:rPr lang="en-US" sz="1100" dirty="0">
+                          <a:solidFill>
+                            <a:schemeClr val="tx1"/>
+                          </a:solidFill>
+                        </a:rPr>
+                        <a:t>€820</a:t>
+                      </a:r>
+                      <a:endParaRPr lang="en-US" sz="1100" dirty="0"/>
+                    </a:p>
+                  </a:txBody>
+                  <a:tcPr marL="91440" marR="91440" marT="45720" marB="45720" anchor="ctr">
+                    <a:lnL w="6350" cap="flat" cmpd="sng" algn="ctr">
+                      <a:solidFill>
+                        <a:srgbClr val="D6DEE5"/>
+                      </a:solidFill>
+                      <a:prstDash val="solid"/>
+                      <a:round/>
+                      <a:headEnd type="none" w="med" len="med"/>
+                      <a:tailEnd type="none" w="med" len="med"/>
+                    </a:lnL>
+                    <a:lnR w="6350" cap="flat" cmpd="sng" algn="ctr">
+                      <a:solidFill>
+                        <a:srgbClr val="D6DEE5"/>
+                      </a:solidFill>
+                      <a:prstDash val="solid"/>
+                      <a:round/>
+                      <a:headEnd type="none" w="med" len="med"/>
+                      <a:tailEnd type="none" w="med" len="med"/>
+                    </a:lnR>
+                    <a:lnT w="6350" cap="flat" cmpd="sng" algn="ctr">
+                      <a:solidFill>
+                        <a:srgbClr val="D6DEE5"/>
+                      </a:solidFill>
+                      <a:prstDash val="solid"/>
+                      <a:round/>
+                      <a:headEnd type="none" w="med" len="med"/>
+                      <a:tailEnd type="none" w="med" len="med"/>
+                    </a:lnT>
+                    <a:lnB w="6350" cap="flat" cmpd="sng" algn="ctr">
+                      <a:solidFill>
+                        <a:srgbClr val="D6DEE5"/>
+                      </a:solidFill>
+                      <a:prstDash val="solid"/>
+                      <a:round/>
+                      <a:headEnd type="none" w="med" len="med"/>
+                      <a:tailEnd type="none" w="med" len="med"/>
+                    </a:lnB>
+                  </a:tcPr>
+                </a:tc>
+                <a:tc>
+                  <a:txBody>
+                    <a:bodyPr/>
+                    <a:lstStyle/>
+                    <a:p>
+                      <a:pPr algn="ctr" indent="0" marL="0">
+                        <a:buNone/>
+                      </a:pPr>
+                      <a:r>
+                        <a:rPr lang="en-US" sz="1100" dirty="0">
+                          <a:solidFill>
+                            <a:schemeClr val="tx1"/>
+                          </a:solidFill>
+                        </a:rPr>
                         <a:t>€2,388</a:t>
                       </a:r>
                       <a:endParaRPr lang="en-US" sz="1100" dirty="0"/>
@@ -12137,7 +13305,7 @@
                   </a:tcPr>
                 </a:tc>
               </a:tr>
-              <a:tr h="384048">
+              <a:tr h="365760">
                 <a:tc>
                   <a:txBody>
                     <a:bodyPr/>
@@ -12326,7 +13494,123 @@
                             <a:schemeClr val="tx1"/>
                           </a:solidFill>
                         </a:rPr>
-                        <a:t>€3,393</a:t>
+                        <a:t>€3k</a:t>
+                      </a:r>
+                      <a:endParaRPr lang="en-US" sz="1100" dirty="0"/>
+                    </a:p>
+                  </a:txBody>
+                  <a:tcPr marL="91440" marR="91440" marT="45720" marB="45720" anchor="ctr">
+                    <a:lnL w="6350" cap="flat" cmpd="sng" algn="ctr">
+                      <a:solidFill>
+                        <a:srgbClr val="D6DEE5"/>
+                      </a:solidFill>
+                      <a:prstDash val="solid"/>
+                      <a:round/>
+                      <a:headEnd type="none" w="med" len="med"/>
+                      <a:tailEnd type="none" w="med" len="med"/>
+                    </a:lnL>
+                    <a:lnR w="6350" cap="flat" cmpd="sng" algn="ctr">
+                      <a:solidFill>
+                        <a:srgbClr val="D6DEE5"/>
+                      </a:solidFill>
+                      <a:prstDash val="solid"/>
+                      <a:round/>
+                      <a:headEnd type="none" w="med" len="med"/>
+                      <a:tailEnd type="none" w="med" len="med"/>
+                    </a:lnR>
+                    <a:lnT w="6350" cap="flat" cmpd="sng" algn="ctr">
+                      <a:solidFill>
+                        <a:srgbClr val="D6DEE5"/>
+                      </a:solidFill>
+                      <a:prstDash val="solid"/>
+                      <a:round/>
+                      <a:headEnd type="none" w="med" len="med"/>
+                      <a:tailEnd type="none" w="med" len="med"/>
+                    </a:lnT>
+                    <a:lnB w="6350" cap="flat" cmpd="sng" algn="ctr">
+                      <a:solidFill>
+                        <a:srgbClr val="D6DEE5"/>
+                      </a:solidFill>
+                      <a:prstDash val="solid"/>
+                      <a:round/>
+                      <a:headEnd type="none" w="med" len="med"/>
+                      <a:tailEnd type="none" w="med" len="med"/>
+                    </a:lnB>
+                  </a:tcPr>
+                </a:tc>
+                <a:tc>
+                  <a:txBody>
+                    <a:bodyPr/>
+                    <a:lstStyle/>
+                    <a:p>
+                      <a:pPr algn="ctr" indent="0" marL="0">
+                        <a:buNone/>
+                      </a:pPr>
+                      <a:r>
+                        <a:rPr lang="en-US" sz="1100" dirty="0">
+                          <a:solidFill>
+                            <a:schemeClr val="tx1"/>
+                          </a:solidFill>
+                        </a:rPr>
+                        <a:t>€1,044</a:t>
+                      </a:r>
+                      <a:endParaRPr lang="en-US" sz="1100" dirty="0"/>
+                    </a:p>
+                  </a:txBody>
+                  <a:tcPr marL="91440" marR="91440" marT="45720" marB="45720" anchor="ctr">
+                    <a:lnL w="6350" cap="flat" cmpd="sng" algn="ctr">
+                      <a:solidFill>
+                        <a:srgbClr val="D6DEE5"/>
+                      </a:solidFill>
+                      <a:prstDash val="solid"/>
+                      <a:round/>
+                      <a:headEnd type="none" w="med" len="med"/>
+                      <a:tailEnd type="none" w="med" len="med"/>
+                    </a:lnL>
+                    <a:lnR w="6350" cap="flat" cmpd="sng" algn="ctr">
+                      <a:solidFill>
+                        <a:srgbClr val="D6DEE5"/>
+                      </a:solidFill>
+                      <a:prstDash val="solid"/>
+                      <a:round/>
+                      <a:headEnd type="none" w="med" len="med"/>
+                      <a:tailEnd type="none" w="med" len="med"/>
+                    </a:lnR>
+                    <a:lnT w="6350" cap="flat" cmpd="sng" algn="ctr">
+                      <a:solidFill>
+                        <a:srgbClr val="D6DEE5"/>
+                      </a:solidFill>
+                      <a:prstDash val="solid"/>
+                      <a:round/>
+                      <a:headEnd type="none" w="med" len="med"/>
+                      <a:tailEnd type="none" w="med" len="med"/>
+                    </a:lnT>
+                    <a:lnB w="6350" cap="flat" cmpd="sng" algn="ctr">
+                      <a:solidFill>
+                        <a:srgbClr val="D6DEE5"/>
+                      </a:solidFill>
+                      <a:prstDash val="solid"/>
+                      <a:round/>
+                      <a:headEnd type="none" w="med" len="med"/>
+                      <a:tailEnd type="none" w="med" len="med"/>
+                    </a:lnB>
+                  </a:tcPr>
+                </a:tc>
+                <a:tc>
+                  <a:txBody>
+                    <a:bodyPr/>
+                    <a:lstStyle/>
+                    <a:p>
+                      <a:pPr algn="ctr" indent="0" marL="0">
+                        <a:buNone/>
+                      </a:pPr>
+                      <a:r>
+                        <a:rPr lang="en-US" sz="1100" dirty="0">
+                          <a:solidFill>
+                            <a:schemeClr val="tx1"/>
+                          </a:solidFill>
+                        </a:rPr>
+                        <a:t>€3,442</a:t>
                       </a:r>
                       <a:endParaRPr lang="en-US" sz="1100" dirty="0"/>
                     </a:p>
@@ -12429,6 +13713,390 @@
                   </a:tcPr>
                 </a:tc>
               </a:tr>
+              <a:tr h="365760">
+                <a:tc>
+                  <a:txBody>
+                    <a:bodyPr/>
+                    <a:lstStyle/>
+                    <a:p>
+                      <a:pPr indent="0" marL="0">
+                        <a:buNone/>
+                      </a:pPr>
+                      <a:r>
+                        <a:rPr lang="en-US" sz="1100" b="1" dirty="0">
+                          <a:solidFill>
+                            <a:schemeClr val="tx1"/>
+                          </a:solidFill>
+                        </a:rPr>
+                        <a:t>Total</a:t>
+                      </a:r>
+                      <a:endParaRPr lang="en-US" sz="1100" dirty="0"/>
+                    </a:p>
+                  </a:txBody>
+                  <a:tcPr marL="91440" marR="91440" marT="45720" marB="45720" anchor="ctr">
+                    <a:lnL w="6350" cap="flat" cmpd="sng" algn="ctr">
+                      <a:solidFill>
+                        <a:srgbClr val="D6DEE5"/>
+                      </a:solidFill>
+                      <a:prstDash val="solid"/>
+                      <a:round/>
+                      <a:headEnd type="none" w="med" len="med"/>
+                      <a:tailEnd type="none" w="med" len="med"/>
+                    </a:lnL>
+                    <a:lnR w="6350" cap="flat" cmpd="sng" algn="ctr">
+                      <a:solidFill>
+                        <a:srgbClr val="D6DEE5"/>
+                      </a:solidFill>
+                      <a:prstDash val="solid"/>
+                      <a:round/>
+                      <a:headEnd type="none" w="med" len="med"/>
+                      <a:tailEnd type="none" w="med" len="med"/>
+                    </a:lnR>
+                    <a:lnT w="6350" cap="flat" cmpd="sng" algn="ctr">
+                      <a:solidFill>
+                        <a:srgbClr val="D6DEE5"/>
+                      </a:solidFill>
+                      <a:prstDash val="solid"/>
+                      <a:round/>
+                      <a:headEnd type="none" w="med" len="med"/>
+                      <a:tailEnd type="none" w="med" len="med"/>
+                    </a:lnT>
+                    <a:lnB w="6350" cap="flat" cmpd="sng" algn="ctr">
+                      <a:solidFill>
+                        <a:srgbClr val="D6DEE5"/>
+                      </a:solidFill>
+                      <a:prstDash val="solid"/>
+                      <a:round/>
+                      <a:headEnd type="none" w="med" len="med"/>
+                      <a:tailEnd type="none" w="med" len="med"/>
+                    </a:lnB>
+                  </a:tcPr>
+                </a:tc>
+                <a:tc>
+                  <a:txBody>
+                    <a:bodyPr/>
+                    <a:lstStyle/>
+                    <a:p>
+                      <a:pPr indent="0" marL="0">
+                        <a:buNone/>
+                      </a:pPr>
+                      <a:endParaRPr lang="en-US" sz="1100" dirty="0"/>
+                    </a:p>
+                  </a:txBody>
+                  <a:tcPr marL="91440" marR="91440" marT="45720" marB="45720" anchor="ctr">
+                    <a:lnL w="6350" cap="flat" cmpd="sng" algn="ctr">
+                      <a:solidFill>
+                        <a:srgbClr val="D6DEE5"/>
+                      </a:solidFill>
+                      <a:prstDash val="solid"/>
+                      <a:round/>
+                      <a:headEnd type="none" w="med" len="med"/>
+                      <a:tailEnd type="none" w="med" len="med"/>
+                    </a:lnL>
+                    <a:lnR w="6350" cap="flat" cmpd="sng" algn="ctr">
+                      <a:solidFill>
+                        <a:srgbClr val="D6DEE5"/>
+                      </a:solidFill>
+                      <a:prstDash val="solid"/>
+                      <a:round/>
+                      <a:headEnd type="none" w="med" len="med"/>
+                      <a:tailEnd type="none" w="med" len="med"/>
+                    </a:lnR>
+                    <a:lnT w="6350" cap="flat" cmpd="sng" algn="ctr">
+                      <a:solidFill>
+                        <a:srgbClr val="D6DEE5"/>
+                      </a:solidFill>
+                      <a:prstDash val="solid"/>
+                      <a:round/>
+                      <a:headEnd type="none" w="med" len="med"/>
+                      <a:tailEnd type="none" w="med" len="med"/>
+                    </a:lnT>
+                    <a:lnB w="6350" cap="flat" cmpd="sng" algn="ctr">
+                      <a:solidFill>
+                        <a:srgbClr val="D6DEE5"/>
+                      </a:solidFill>
+                      <a:prstDash val="solid"/>
+                      <a:round/>
+                      <a:headEnd type="none" w="med" len="med"/>
+                      <a:tailEnd type="none" w="med" len="med"/>
+                    </a:lnB>
+                  </a:tcPr>
+                </a:tc>
+                <a:tc>
+                  <a:txBody>
+                    <a:bodyPr/>
+                    <a:lstStyle/>
+                    <a:p>
+                      <a:pPr indent="0" marL="0">
+                        <a:buNone/>
+                      </a:pPr>
+                      <a:endParaRPr lang="en-US" sz="1100" dirty="0"/>
+                    </a:p>
+                  </a:txBody>
+                  <a:tcPr marL="91440" marR="91440" marT="45720" marB="45720" anchor="ctr">
+                    <a:lnL w="6350" cap="flat" cmpd="sng" algn="ctr">
+                      <a:solidFill>
+                        <a:srgbClr val="D6DEE5"/>
+                      </a:solidFill>
+                      <a:prstDash val="solid"/>
+                      <a:round/>
+                      <a:headEnd type="none" w="med" len="med"/>
+                      <a:tailEnd type="none" w="med" len="med"/>
+                    </a:lnL>
+                    <a:lnR w="6350" cap="flat" cmpd="sng" algn="ctr">
+                      <a:solidFill>
+                        <a:srgbClr val="D6DEE5"/>
+                      </a:solidFill>
+                      <a:prstDash val="solid"/>
+                      <a:round/>
+                      <a:headEnd type="none" w="med" len="med"/>
+                      <a:tailEnd type="none" w="med" len="med"/>
+                    </a:lnR>
+                    <a:lnT w="6350" cap="flat" cmpd="sng" algn="ctr">
+                      <a:solidFill>
+                        <a:srgbClr val="D6DEE5"/>
+                      </a:solidFill>
+                      <a:prstDash val="solid"/>
+                      <a:round/>
+                      <a:headEnd type="none" w="med" len="med"/>
+                      <a:tailEnd type="none" w="med" len="med"/>
+                    </a:lnT>
+                    <a:lnB w="6350" cap="flat" cmpd="sng" algn="ctr">
+                      <a:solidFill>
+                        <a:srgbClr val="D6DEE5"/>
+                      </a:solidFill>
+                      <a:prstDash val="solid"/>
+                      <a:round/>
+                      <a:headEnd type="none" w="med" len="med"/>
+                      <a:tailEnd type="none" w="med" len="med"/>
+                    </a:lnB>
+                  </a:tcPr>
+                </a:tc>
+                <a:tc>
+                  <a:txBody>
+                    <a:bodyPr/>
+                    <a:lstStyle/>
+                    <a:p>
+                      <a:pPr algn="ctr" indent="0" marL="0">
+                        <a:buNone/>
+                      </a:pPr>
+                      <a:r>
+                        <a:rPr lang="en-US" sz="1100" b="1" dirty="0">
+                          <a:solidFill>
+                            <a:schemeClr val="tx1"/>
+                          </a:solidFill>
+                        </a:rPr>
+                        <a:t>€102.3k</a:t>
+                      </a:r>
+                      <a:endParaRPr lang="en-US" sz="1100" dirty="0"/>
+                    </a:p>
+                  </a:txBody>
+                  <a:tcPr marL="91440" marR="91440" marT="45720" marB="45720" anchor="ctr">
+                    <a:lnL w="6350" cap="flat" cmpd="sng" algn="ctr">
+                      <a:solidFill>
+                        <a:srgbClr val="D6DEE5"/>
+                      </a:solidFill>
+                      <a:prstDash val="solid"/>
+                      <a:round/>
+                      <a:headEnd type="none" w="med" len="med"/>
+                      <a:tailEnd type="none" w="med" len="med"/>
+                    </a:lnL>
+                    <a:lnR w="6350" cap="flat" cmpd="sng" algn="ctr">
+                      <a:solidFill>
+                        <a:srgbClr val="D6DEE5"/>
+                      </a:solidFill>
+                      <a:prstDash val="solid"/>
+                      <a:round/>
+                      <a:headEnd type="none" w="med" len="med"/>
+                      <a:tailEnd type="none" w="med" len="med"/>
+                    </a:lnR>
+                    <a:lnT w="6350" cap="flat" cmpd="sng" algn="ctr">
+                      <a:solidFill>
+                        <a:srgbClr val="D6DEE5"/>
+                      </a:solidFill>
+                      <a:prstDash val="solid"/>
+                      <a:round/>
+                      <a:headEnd type="none" w="med" len="med"/>
+                      <a:tailEnd type="none" w="med" len="med"/>
+                    </a:lnT>
+                    <a:lnB w="6350" cap="flat" cmpd="sng" algn="ctr">
+                      <a:solidFill>
+                        <a:srgbClr val="D6DEE5"/>
+                      </a:solidFill>
+                      <a:prstDash val="solid"/>
+                      <a:round/>
+                      <a:headEnd type="none" w="med" len="med"/>
+                      <a:tailEnd type="none" w="med" len="med"/>
+                    </a:lnB>
+                  </a:tcPr>
+                </a:tc>
+                <a:tc>
+                  <a:txBody>
+                    <a:bodyPr/>
+                    <a:lstStyle/>
+                    <a:p>
+                      <a:pPr indent="0" marL="0">
+                        <a:buNone/>
+                      </a:pPr>
+                      <a:endParaRPr lang="en-US" sz="1100" dirty="0"/>
+                    </a:p>
+                  </a:txBody>
+                  <a:tcPr marL="91440" marR="91440" marT="45720" marB="45720" anchor="ctr">
+                    <a:lnL w="6350" cap="flat" cmpd="sng" algn="ctr">
+                      <a:solidFill>
+                        <a:srgbClr val="D6DEE5"/>
+                      </a:solidFill>
+                      <a:prstDash val="solid"/>
+                      <a:round/>
+                      <a:headEnd type="none" w="med" len="med"/>
+                      <a:tailEnd type="none" w="med" len="med"/>
+                    </a:lnL>
+                    <a:lnR w="6350" cap="flat" cmpd="sng" algn="ctr">
+                      <a:solidFill>
+                        <a:srgbClr val="D6DEE5"/>
+                      </a:solidFill>
+                      <a:prstDash val="solid"/>
+                      <a:round/>
+                      <a:headEnd type="none" w="med" len="med"/>
+                      <a:tailEnd type="none" w="med" len="med"/>
+                    </a:lnR>
+                    <a:lnT w="6350" cap="flat" cmpd="sng" algn="ctr">
+                      <a:solidFill>
+                        <a:srgbClr val="D6DEE5"/>
+                      </a:solidFill>
+                      <a:prstDash val="solid"/>
+                      <a:round/>
+                      <a:headEnd type="none" w="med" len="med"/>
+                      <a:tailEnd type="none" w="med" len="med"/>
+                    </a:lnT>
+                    <a:lnB w="6350" cap="flat" cmpd="sng" algn="ctr">
+                      <a:solidFill>
+                        <a:srgbClr val="D6DEE5"/>
+                      </a:solidFill>
+                      <a:prstDash val="solid"/>
+                      <a:round/>
+                      <a:headEnd type="none" w="med" len="med"/>
+                      <a:tailEnd type="none" w="med" len="med"/>
+                    </a:lnB>
+                  </a:tcPr>
+                </a:tc>
+                <a:tc>
+                  <a:txBody>
+                    <a:bodyPr/>
+                    <a:lstStyle/>
+                    <a:p>
+                      <a:pPr algn="ctr" indent="0" marL="0">
+                        <a:buNone/>
+                      </a:pPr>
+                      <a:r>
+                        <a:rPr lang="en-US" sz="1100" b="1" dirty="0">
+                          <a:solidFill>
+                            <a:schemeClr val="tx1"/>
+                          </a:solidFill>
+                        </a:rPr>
+                        <a:t>€1,023</a:t>
+                      </a:r>
+                      <a:endParaRPr lang="en-US" sz="1100" dirty="0"/>
+                    </a:p>
+                  </a:txBody>
+                  <a:tcPr marL="91440" marR="91440" marT="45720" marB="45720" anchor="ctr">
+                    <a:lnL w="6350" cap="flat" cmpd="sng" algn="ctr">
+                      <a:solidFill>
+                        <a:srgbClr val="D6DEE5"/>
+                      </a:solidFill>
+                      <a:prstDash val="solid"/>
+                      <a:round/>
+                      <a:headEnd type="none" w="med" len="med"/>
+                      <a:tailEnd type="none" w="med" len="med"/>
+                    </a:lnL>
+                    <a:lnR w="6350" cap="flat" cmpd="sng" algn="ctr">
+                      <a:solidFill>
+                        <a:srgbClr val="D6DEE5"/>
+                      </a:solidFill>
+                      <a:prstDash val="solid"/>
+                      <a:round/>
+                      <a:headEnd type="none" w="med" len="med"/>
+                      <a:tailEnd type="none" w="med" len="med"/>
+                    </a:lnR>
+                    <a:lnT w="6350" cap="flat" cmpd="sng" algn="ctr">
+                      <a:solidFill>
+                        <a:srgbClr val="D6DEE5"/>
+                      </a:solidFill>
+                      <a:prstDash val="solid"/>
+                      <a:round/>
+                      <a:headEnd type="none" w="med" len="med"/>
+                      <a:tailEnd type="none" w="med" len="med"/>
+                    </a:lnT>
+                    <a:lnB w="6350" cap="flat" cmpd="sng" algn="ctr">
+                      <a:solidFill>
+                        <a:srgbClr val="D6DEE5"/>
+                      </a:solidFill>
+                      <a:prstDash val="solid"/>
+                      <a:round/>
+                      <a:headEnd type="none" w="med" len="med"/>
+                      <a:tailEnd type="none" w="med" len="med"/>
+                    </a:lnB>
+                  </a:tcPr>
+                </a:tc>
+                <a:tc>
+                  <a:txBody>
+                    <a:bodyPr/>
+                    <a:lstStyle/>
+                    <a:p>
+                      <a:pPr algn="ctr" indent="0" marL="0">
+                        <a:buNone/>
+                      </a:pPr>
+                      <a:r>
+                        <a:rPr lang="en-US" sz="1100" b="1" dirty="0">
+                          <a:solidFill>
+                            <a:schemeClr val="tx1"/>
+                          </a:solidFill>
+                        </a:rPr>
+                        <a:t>100</a:t>
+                      </a:r>
+                      <a:endParaRPr lang="en-US" sz="1100" dirty="0"/>
+                    </a:p>
+                  </a:txBody>
+                  <a:tcPr marL="91440" marR="91440" marT="45720" marB="45720" anchor="ctr">
+                    <a:lnL w="6350" cap="flat" cmpd="sng" algn="ctr">
+                      <a:solidFill>
+                        <a:srgbClr val="D6DEE5"/>
+                      </a:solidFill>
+                      <a:prstDash val="solid"/>
+                      <a:round/>
+                      <a:headEnd type="none" w="med" len="med"/>
+                      <a:tailEnd type="none" w="med" len="med"/>
+                    </a:lnL>
+                    <a:lnR w="6350" cap="flat" cmpd="sng" algn="ctr">
+                      <a:solidFill>
+                        <a:srgbClr val="D6DEE5"/>
+                      </a:solidFill>
+                      <a:prstDash val="solid"/>
+                      <a:round/>
+                      <a:headEnd type="none" w="med" len="med"/>
+                      <a:tailEnd type="none" w="med" len="med"/>
+                    </a:lnR>
+                    <a:lnT w="6350" cap="flat" cmpd="sng" algn="ctr">
+                      <a:solidFill>
+                        <a:srgbClr val="D6DEE5"/>
+                      </a:solidFill>
+                      <a:prstDash val="solid"/>
+                      <a:round/>
+                      <a:headEnd type="none" w="med" len="med"/>
+                      <a:tailEnd type="none" w="med" len="med"/>
+                    </a:lnT>
+                    <a:lnB w="6350" cap="flat" cmpd="sng" algn="ctr">
+                      <a:solidFill>
+                        <a:srgbClr val="D6DEE5"/>
+                      </a:solidFill>
+                      <a:prstDash val="solid"/>
+                      <a:round/>
+                      <a:headEnd type="none" w="med" len="med"/>
+                      <a:tailEnd type="none" w="med" len="med"/>
+                    </a:lnB>
+                  </a:tcPr>
+                </a:tc>
+              </a:tr>
             </a:tbl>
           </a:graphicData>
         </a:graphic>
@@ -12441,12 +14109,12 @@
         </p:nvSpPr>
         <p:spPr>
           <a:xfrm>
-            <a:off x="8595360" y="1188720"/>
-            <a:ext cx="3136392" cy="3108960"/>
+            <a:off x="9326880" y="1188720"/>
+            <a:ext cx="2404872" cy="4846320"/>
           </a:xfrm>
           <a:prstGeom prst="roundRect">
             <a:avLst>
-              <a:gd name="adj" fmla="val 2353"/>
+              <a:gd name="adj" fmla="val 3042"/>
             </a:avLst>
           </a:prstGeom>
           <a:solidFill>
@@ -12468,8 +14136,8 @@
         </p:nvSpPr>
         <p:spPr>
           <a:xfrm>
-            <a:off x="8778240" y="1325880"/>
-            <a:ext cx="2834640" cy="2880360"/>
+            <a:off x="9464040" y="1325880"/>
+            <a:ext cx="2148840" cy="4617720"/>
           </a:xfrm>
           <a:prstGeom prst="rect">
             <a:avLst/>
@@ -12483,7 +14151,7 @@
           <a:p>
             <a:pPr indent="0" marL="0">
               <a:spcAft>
-                <a:spcPts val="800"/>
+                <a:spcPts val="600"/>
               </a:spcAft>
               <a:buNone/>
             </a:pPr>
@@ -12495,79 +14163,97 @@
               </a:rPr>
               <a:t>How it works</a:t>
             </a:r>
-            <a:endParaRPr lang="en-US" sz="1150" dirty="0"/>
+            <a:endParaRPr lang="en-US" sz="1050" dirty="0"/>
           </a:p>
           <a:p>
             <a:pPr marL="342900" indent="-342900">
               <a:spcAft>
-                <a:spcPts val="800"/>
+                <a:spcPts val="600"/>
               </a:spcAft>
               <a:buSzPct val="100000"/>
               <a:buChar char="•"/>
             </a:pPr>
             <a:r>
-              <a:rPr lang="en-US" sz="1150" dirty="0">
+              <a:rPr lang="en-US" sz="1050" dirty="0">
                 <a:solidFill>
                   <a:schemeClr val="tx1"/>
                 </a:solidFill>
               </a:rPr>
               <a:t>Cost per hire = cost per application ÷ share qualified ÷ qualified → signed.</a:t>
             </a:r>
-            <a:endParaRPr lang="en-US" sz="1150" dirty="0"/>
+            <a:endParaRPr lang="en-US" sz="1050" dirty="0"/>
           </a:p>
           <a:p>
             <a:pPr marL="342900" indent="-342900">
               <a:spcAft>
-                <a:spcPts val="800"/>
+                <a:spcPts val="600"/>
               </a:spcAft>
               <a:buSzPct val="100000"/>
               <a:buChar char="•"/>
             </a:pPr>
             <a:r>
-              <a:rPr lang="en-US" sz="1150" dirty="0">
+              <a:rPr lang="en-US" sz="1050" dirty="0">
                 <a:solidFill>
                   <a:schemeClr val="tx1"/>
                 </a:solidFill>
               </a:rPr>
               <a:t>Each channel is capped by how many people in the local talent pool it can reach.</a:t>
             </a:r>
-            <a:endParaRPr lang="en-US" sz="1150" dirty="0"/>
+            <a:endParaRPr lang="en-US" sz="1050" dirty="0"/>
           </a:p>
           <a:p>
             <a:pPr marL="342900" indent="-342900">
               <a:spcAft>
-                <a:spcPts val="800"/>
+                <a:spcPts val="600"/>
               </a:spcAft>
               <a:buSzPct val="100000"/>
               <a:buChar char="•"/>
             </a:pPr>
             <a:r>
-              <a:rPr lang="en-US" sz="1150" dirty="0">
+              <a:rPr lang="en-US" sz="1050" dirty="0">
                 <a:solidFill>
                   <a:schemeClr val="tx1"/>
                 </a:solidFill>
               </a:rPr>
               <a:t>Each pay-per-click channel gets a €750 test per role first; Search and Meta stay at test level, and so does programmatic for automation and supervisors.</a:t>
             </a:r>
-            <a:endParaRPr lang="en-US" sz="1150" dirty="0"/>
+            <a:endParaRPr lang="en-US" sz="1050" dirty="0"/>
           </a:p>
           <a:p>
             <a:pPr marL="342900" indent="-342900">
               <a:spcAft>
-                <a:spcPts val="800"/>
+                <a:spcPts val="600"/>
               </a:spcAft>
               <a:buSzPct val="100000"/>
               <a:buChar char="•"/>
             </a:pPr>
             <a:r>
-              <a:rPr lang="en-US" sz="1150" dirty="0">
+              <a:rPr lang="en-US" sz="1050" dirty="0">
                 <a:solidFill>
                   <a:schemeClr val="tx1"/>
                 </a:solidFill>
               </a:rPr>
               <a:t>Roles: E electricians, M mechatronics, A automation, S supervisors.</a:t>
             </a:r>
-            <a:endParaRPr lang="en-US" sz="1150" dirty="0"/>
+            <a:endParaRPr lang="en-US" sz="1050" dirty="0"/>
+          </a:p>
+          <a:p>
+            <a:pPr marL="342900" indent="-342900">
+              <a:spcAft>
+                <a:spcPts val="600"/>
+              </a:spcAft>
+              <a:buSzPct val="100000"/>
+              <a:buChar char="•"/>
+            </a:pPr>
+            <a:r>
+              <a:rPr lang="en-US" sz="1050" dirty="0">
+                <a:solidFill>
+                  <a:schemeClr val="tx1"/>
+                </a:solidFill>
+              </a:rPr>
+              <a:t>Per channel × role: Channels tab (cost per qualified col O, per hire col P, rank col AC).</a:t>
+            </a:r>
+            <a:endParaRPr lang="en-US" sz="1050" dirty="0"/>
           </a:p>
         </p:txBody>
       </p:sp>
@@ -12715,7 +14401,7 @@
                 <a:ea typeface="Cambria" pitchFamily="34" charset="-122"/>
                 <a:cs typeface="Cambria" pitchFamily="34" charset="-120"/>
               </a:rPr>
-              <a:t>€101.7k planned across roles and weeks, plus a €18.3k reserve</a:t>
+              <a:t>€102.3k planned across roles and weeks, plus a €20.2k reserve</a:t>
             </a:r>
             <a:endParaRPr lang="en-US" sz="2200" dirty="0"/>
           </a:p>
@@ -13084,7 +14770,7 @@
                             <a:schemeClr val="tx1"/>
                           </a:solidFill>
                         </a:rPr>
-                        <a:t>€38.9k</a:t>
+                        <a:t>€39.1k</a:t>
                       </a:r>
                       <a:endParaRPr lang="en-US" sz="1100" dirty="0"/>
                     </a:p>
@@ -13200,7 +14886,7 @@
                             <a:schemeClr val="tx1"/>
                           </a:solidFill>
                         </a:rPr>
-                        <a:t>€1,298</a:t>
+                        <a:t>€1,304</a:t>
                       </a:r>
                       <a:endParaRPr lang="en-US" sz="1100" dirty="0"/>
                     </a:p>
@@ -13318,7 +15004,7 @@
                             <a:schemeClr val="tx1"/>
                           </a:solidFill>
                         </a:rPr>
-                        <a:t>€29.9k</a:t>
+                        <a:t>€30.1k</a:t>
                       </a:r>
                       <a:endParaRPr lang="en-US" sz="1100" dirty="0"/>
                     </a:p>
@@ -13434,7 +15120,7 @@
                             <a:schemeClr val="tx1"/>
                           </a:solidFill>
                         </a:rPr>
-                        <a:t>€663</a:t>
+                        <a:t>€670</a:t>
                       </a:r>
                       <a:endParaRPr lang="en-US" sz="1100" dirty="0"/>
                     </a:p>
@@ -13668,7 +15354,7 @@
                             <a:schemeClr val="tx1"/>
                           </a:solidFill>
                         </a:rPr>
-                        <a:t>€1,158</a:t>
+                        <a:t>€1,162</a:t>
                       </a:r>
                       <a:endParaRPr lang="en-US" sz="1100" dirty="0"/>
                     </a:p>
@@ -13902,7 +15588,7 @@
                             <a:schemeClr val="tx1"/>
                           </a:solidFill>
                         </a:rPr>
-                        <a:t>€1,550</a:t>
+                        <a:t>€1,555</a:t>
                       </a:r>
                       <a:endParaRPr lang="en-US" sz="1100" dirty="0"/>
                     </a:p>
@@ -14020,7 +15706,7 @@
                             <a:schemeClr val="tx1"/>
                           </a:solidFill>
                         </a:rPr>
-                        <a:t>€101.7k</a:t>
+                        <a:t>€102.3k</a:t>
                       </a:r>
                       <a:endParaRPr lang="en-US" sz="1100" dirty="0"/>
                     </a:p>
@@ -14136,7 +15822,7 @@
                             <a:schemeClr val="tx1"/>
                           </a:solidFill>
                         </a:rPr>
-                        <a:t>€1,017</a:t>
+                        <a:t>€1,023</a:t>
                       </a:r>
                       <a:endParaRPr lang="en-US" sz="1100" dirty="0"/>
                     </a:p>
@@ -14294,7 +15980,7 @@
                   <a:schemeClr val="tx1"/>
                 </a:solidFill>
               </a:rPr>
-              <a:t>€18.3k (15% + rounding), released from week 3 only on results.</a:t>
+              <a:t>€20.2k (15% + rounding), released from week 3 only on results.</a:t>
             </a:r>
             <a:endParaRPr lang="en-US" sz="1200" dirty="0"/>
           </a:p>
@@ -14511,7 +16197,7 @@
                 <a:ea typeface="Cambria" pitchFamily="34" charset="-122"/>
                 <a:cs typeface="Cambria" pitchFamily="34" charset="-120"/>
               </a:rPr>
-              <a:t>30% less (€84k) signs ~87; electricians fall short first</a:t>
+              <a:t>30% less (€85.75k) signs ~87; electricians fall short first</a:t>
             </a:r>
             <a:endParaRPr lang="en-US" sz="2200" dirty="0"/>
           </a:p>
@@ -14760,7 +16446,7 @@
                             <a:schemeClr val="tx1"/>
                           </a:solidFill>
                         </a:rPr>
-                        <a:t>Recommended · €120k</a:t>
+                        <a:t>Recommended · €122.5k</a:t>
                       </a:r>
                       <a:endParaRPr lang="en-US" sz="1100" dirty="0"/>
                     </a:p>
@@ -14876,7 +16562,7 @@
                             <a:schemeClr val="tx1"/>
                           </a:solidFill>
                         </a:rPr>
-                        <a:t>€1,200</a:t>
+                        <a:t>€1,225</a:t>
                       </a:r>
                       <a:endParaRPr lang="en-US" sz="1100" dirty="0"/>
                     </a:p>
@@ -14936,7 +16622,7 @@
                             <a:schemeClr val="tx1"/>
                           </a:solidFill>
                         </a:rPr>
-                        <a:t>30% less · €84k</a:t>
+                        <a:t>30% less · €85.75k</a:t>
                       </a:r>
                       <a:endParaRPr lang="en-US" sz="1100" dirty="0"/>
                     </a:p>
@@ -15058,7 +16744,7 @@
                             <a:schemeClr val="tx1"/>
                           </a:solidFill>
                         </a:rPr>
-                        <a:t>€966</a:t>
+                        <a:t>€985</a:t>
                       </a:r>
                       <a:endParaRPr lang="en-US" sz="1100" dirty="0"/>
                     </a:p>
@@ -15188,7 +16874,7 @@
                   <a:schemeClr val="tx1"/>
                 </a:solidFill>
               </a:rPr>
-              <a:t>electricians 20.6 of 30, supervisors 7.5 of 10, mechatronics 44.4 of 45, automation 14.5 of 15.</a:t>
+              <a:t>electricians 20.5 of 30, supervisors 8.1 of 10, mechatronics 44.0 of 45, automation 14.5 of 15.</a:t>
             </a:r>
             <a:endParaRPr lang="en-US" sz="1200" dirty="0"/>
           </a:p>
@@ -15219,7 +16905,7 @@
                   <a:schemeClr val="tx1"/>
                 </a:solidFill>
               </a:rPr>
-              <a:t>the last €36k buys ~13 hires, mostly electricians, the people who keep the lines running. Keep it. If you must cut, the rule cuts the dearest channels, which are mostly electrician and supervisor channels: agree that up front, and cover supervisors by internal promotion.</a:t>
+              <a:t>the last €36.75k buys ~13 hires, mostly electricians, the people who keep the lines running. Keep it. If you must cut, the rule cuts the dearest channels, which are mostly electrician and supervisor channels: agree that up front, and cover supervisors by internal promotion.</a:t>
             </a:r>
             <a:endParaRPr lang="en-US" sz="1200" dirty="0"/>
           </a:p>
@@ -15509,7 +17195,7 @@
                   <a:schemeClr val="tx1"/>
                 </a:solidFill>
               </a:rPr>
-              <a:t>211 past runners-up (consented, last year) + staff referrals</a:t>
+              <a:t>~211 past runners-up from the last 12 months (my estimate; the real export replaces it on day 1) + staff referrals</a:t>
             </a:r>
             <a:endParaRPr lang="en-US" sz="1150" dirty="0"/>
           </a:p>
@@ -16161,7 +17847,7 @@
                   <a:schemeClr val="tx1"/>
                 </a:solidFill>
               </a:rPr>
-              <a:t>~13,800 Poles commute to Brandenburg jobs, ~1,700 in machine, metal and building trades (IAB 2020); the call checks language before using our slots</a:t>
+              <a:t>~1,700 Polish machine, metal and building workers already commute to Brandenburg (IAB 2020); the call checks language before using our slots. If it fails: budget €155k</a:t>
             </a:r>
             <a:endParaRPr lang="en-US" sz="1150" dirty="0"/>
           </a:p>
@@ -16301,7 +17987,7 @@
                   <a:schemeClr val="tx1"/>
                 </a:solidFill>
               </a:rPr>
-              <a:t>Every employer holds past applicants who consented to be kept on file (GDPR allows up to a year), and nobody re-markets them. Here 211 records cost ~€14 per hire and fill week-1 slots. Joveo already runs the tracked links and distribution, so a consented past-applicant feed is one more source in the same pipeline, in any market, with no local staff.</a:t>
+              <a:t>Every employer holds past applicants who consented to be kept on file, and nobody re-markets them. Here ~211 records cost ~€14 per hire and fill week-1 slots. Joveo already runs the tracked links and distribution, so a consented past-applicant feed is one more source in the same pipeline, in any market, with no local staff.</a:t>
             </a:r>
             <a:endParaRPr lang="en-US" sz="1150" dirty="0"/>
           </a:p>

</xml_diff>

<commit_message>
Polish corridor sized against Eurostat border-region supply with downside runs; I3Q relabelled own estimate; slide 7 wording
Co-Authored-By: Claude Opus 5.5 <noreply@anthropic.com>
Claude-Session: https://claude.ai/code/session_01V2NJtrYy3bzNxqKeiRXJfY
</commit_message>
<xml_diff>
--- a/operation_uptime/Operation_Uptime_Deck.pptx
+++ b/operation_uptime/Operation_Uptime_Deck.pptx
@@ -114,30 +114,30 @@
   <p:extLst>
     <p:ext uri="{521415D9-36F7-43E2-AB2F-B90AF26B5E84}">
       <p14:sectionLst xmlns:p14="http://schemas.microsoft.com/office/powerpoint/2010/main">
-        <p14:section name="Summary" id="{512c0325-63bd-2124-7305-7cc4b400a1b9}">
+        <p14:section name="Summary" id="{908ceaaa-0a8a-7316-77ef-81e8ab90c16b}">
           <p14:sldIdLst>
             <p14:sldId id="256"/>
           </p14:sldIdLst>
         </p14:section>
-        <p14:section name="Part 1 Funnel" id="{c5af8bb1-9ac0-7224-4e31-5faeaf5bfdf8}">
+        <p14:section name="Part 1 Funnel" id="{390e3f9f-e498-3d58-12ba-1ce986b60c9b}">
           <p14:sldIdLst>
             <p14:sldId id="257"/>
             <p14:sldId id="258"/>
           </p14:sldIdLst>
         </p14:section>
-        <p14:section name="Part 2 Channels &amp; budget" id="{a5496b52-d5be-64be-f374-bff54b2aed5f}">
+        <p14:section name="Part 2 Channels &amp; budget" id="{b9c47897-2869-02ee-82ad-cf1f74d10f8a}">
           <p14:sldIdLst>
             <p14:sldId id="259"/>
             <p14:sldId id="260"/>
             <p14:sldId id="261"/>
           </p14:sldIdLst>
         </p14:section>
-        <p14:section name="Part 3 New sources" id="{2124ba60-6187-0667-504c-409cf81817be}">
+        <p14:section name="Part 3 New sources" id="{5a30b7f8-8568-0332-c2de-1146fcde999e}">
           <p14:sldIdLst>
             <p14:sldId id="262"/>
           </p14:sldIdLst>
         </p14:section>
-        <p14:section name="Part 4 Run it" id="{6fe372e7-78b2-19ab-a03c-22831a4fc1fa}">
+        <p14:section name="Part 4 Run it" id="{0bba412e-8fd9-357b-0619-3a4db2e3bb2a}">
           <p14:sldIdLst>
             <p14:sldId id="263"/>
           </p14:sldIdLst>
@@ -17552,7 +17552,7 @@
                   <a:schemeClr val="tx1"/>
                 </a:solidFill>
               </a:rPr>
-              <a:t>Certified electricians who never search for plant jobs; doubles the hardest pool</a:t>
+              <a:t>Certified electricians who never search for plant jobs; more than doubles the hardest pool (10,000 vs 4,800)</a:t>
             </a:r>
             <a:endParaRPr lang="en-US" sz="1150" dirty="0"/>
           </a:p>
@@ -17847,7 +17847,7 @@
                   <a:schemeClr val="tx1"/>
                 </a:solidFill>
               </a:rPr>
-              <a:t>~1,700 Polish machine, metal and building workers already commute to Brandenburg (IAB 2020); the call checks language before using our slots. If it fails: budget €155k</a:t>
+              <a:t>~1,700 Polish machine, metal and building workers already commute to Brandenburg (IAB 2020); the call checks language before using our slots. If response is only I2's rate (~219 applications): €132.5k; if it fails: €155k</a:t>
             </a:r>
             <a:endParaRPr lang="en-US" sz="1150" dirty="0"/>
           </a:p>
@@ -17987,7 +17987,7 @@
                   <a:schemeClr val="tx1"/>
                 </a:solidFill>
               </a:rPr>
-              <a:t>Every employer holds past applicants who consented to be kept on file, and nobody re-markets them. Here ~211 records cost ~€14 per hire and fill week-1 slots. Joveo already runs the tracked links and distribution, so a consented past-applicant feed is one more source in the same pipeline, in any market, with no local staff.</a:t>
+              <a:t>Employers that keep consented past applicants rarely run campaigns to them. Here ~211 records (my estimate) cost ~€14 per hire and fill week-1 slots. Joveo already runs the tracked links and distribution, and its Talent CRM re-engages past applicants, so a consented past-applicant feed becomes one more tracked source, in any market, with no local staff.</a:t>
             </a:r>
             <a:endParaRPr lang="en-US" sz="1150" dirty="0"/>
           </a:p>

</xml_diff>

<commit_message>
Weekly plan paces I2/I3 from their go-live dates (inputs I2L, I3L), shares re-solved; supply-check attribution corrected
Co-Authored-By: Claude Opus 5.5 <noreply@anthropic.com>
Claude-Session: https://claude.ai/code/session_01V2NJtrYy3bzNxqKeiRXJfY
</commit_message>
<xml_diff>
--- a/operation_uptime/Operation_Uptime_Deck.pptx
+++ b/operation_uptime/Operation_Uptime_Deck.pptx
@@ -114,30 +114,30 @@
   <p:extLst>
     <p:ext uri="{521415D9-36F7-43E2-AB2F-B90AF26B5E84}">
       <p14:sectionLst xmlns:p14="http://schemas.microsoft.com/office/powerpoint/2010/main">
-        <p14:section name="Summary" id="{908ceaaa-0a8a-7316-77ef-81e8ab90c16b}">
+        <p14:section name="Summary" id="{57c27507-5448-50c4-fc60-93dd383255f1}">
           <p14:sldIdLst>
             <p14:sldId id="256"/>
           </p14:sldIdLst>
         </p14:section>
-        <p14:section name="Part 1 Funnel" id="{390e3f9f-e498-3d58-12ba-1ce986b60c9b}">
+        <p14:section name="Part 1 Funnel" id="{072670da-7f55-c29d-cdbc-8459dc440dac}">
           <p14:sldIdLst>
             <p14:sldId id="257"/>
             <p14:sldId id="258"/>
           </p14:sldIdLst>
         </p14:section>
-        <p14:section name="Part 2 Channels &amp; budget" id="{b9c47897-2869-02ee-82ad-cf1f74d10f8a}">
+        <p14:section name="Part 2 Channels &amp; budget" id="{f2a8b8ca-8fa3-9bbc-97d4-37cef136cfd8}">
           <p14:sldIdLst>
             <p14:sldId id="259"/>
             <p14:sldId id="260"/>
             <p14:sldId id="261"/>
           </p14:sldIdLst>
         </p14:section>
-        <p14:section name="Part 3 New sources" id="{5a30b7f8-8568-0332-c2de-1146fcde999e}">
+        <p14:section name="Part 3 New sources" id="{3d20c671-61a7-d459-f38b-dce0c89d7a68}">
           <p14:sldIdLst>
             <p14:sldId id="262"/>
           </p14:sldIdLst>
         </p14:section>
-        <p14:section name="Part 4 Run it" id="{0bba412e-8fd9-357b-0619-3a4db2e3bb2a}">
+        <p14:section name="Part 4 Run it" id="{8fe2f974-0f61-f137-2783-447144421495}">
           <p14:sldIdLst>
             <p14:sldId id="263"/>
           </p14:sldIdLst>
@@ -689,22 +689,22 @@
                 <c:formatCode>General</c:formatCode>
                 <c:ptCount val="9"/>
                 <c:pt idx="0">
-                  <c:v>19549</c:v>
+                  <c:v>21494</c:v>
                 </c:pt>
                 <c:pt idx="1">
-                  <c:v>11334</c:v>
+                  <c:v>10800</c:v>
                 </c:pt>
                 <c:pt idx="2">
-                  <c:v>14055</c:v>
+                  <c:v>13258</c:v>
                 </c:pt>
                 <c:pt idx="3">
-                  <c:v>14438</c:v>
+                  <c:v>13992</c:v>
                 </c:pt>
                 <c:pt idx="4">
-                  <c:v>13941</c:v>
+                  <c:v>13524</c:v>
                 </c:pt>
                 <c:pt idx="5">
-                  <c:v>1566</c:v>
+                  <c:v>1814</c:v>
                 </c:pt>
                 <c:pt idx="6">
                   <c:v>0</c:v>
@@ -936,22 +936,22 @@
                   <c:v>0</c:v>
                 </c:pt>
                 <c:pt idx="3">
-                  <c:v>2467</c:v>
+                  <c:v>3119</c:v>
                 </c:pt>
                 <c:pt idx="4">
-                  <c:v>1782</c:v>
+                  <c:v>1728</c:v>
                 </c:pt>
                 <c:pt idx="5">
-                  <c:v>1980</c:v>
+                  <c:v>1769</c:v>
                 </c:pt>
                 <c:pt idx="6">
-                  <c:v>2078</c:v>
+                  <c:v>1899</c:v>
                 </c:pt>
                 <c:pt idx="7">
-                  <c:v>2381</c:v>
+                  <c:v>2158</c:v>
                 </c:pt>
                 <c:pt idx="8">
-                  <c:v>290</c:v>
+                  <c:v>305</c:v>
                 </c:pt>
               </c:numCache>
             </c:numRef>
@@ -17319,7 +17319,7 @@
                   <a:schemeClr val="tx1"/>
                 </a:solidFill>
               </a:rPr>
-              <a:t>Wed 21 Oct – Tue 3 Nov (waves 1–3): €63. Pass: ≥13 qualified. Kill: &lt;7 → no further re-contacts; bonus stays live</a:t>
+              <a:t>Wed 21 Oct – Tue 3 Nov (waves 1–3): €63. Pass: ≥14 qualified. Kill: &lt;8 → no further re-contacts; bonus stays live</a:t>
             </a:r>
             <a:endParaRPr lang="en-US" sz="1150" dirty="0"/>
           </a:p>
@@ -17614,7 +17614,7 @@
                   <a:schemeClr val="tx1"/>
                 </a:solidFill>
               </a:rPr>
-              <a:t>Fri 23 Oct – Thu 5 Nov (read Mon 9 Nov): €4.8k. Pass: ≥6 qualified at ≤€500. Kill: &lt;4, &gt;€670 per qualified, or profile rejected</a:t>
+              <a:t>Fri 23 Oct – Thu 5 Nov (read Mon 9 Nov): €5.6k. Pass: ≥7 qualified at ≤€500. Kill: &lt;4, &gt;€670 per qualified, or profile rejected</a:t>
             </a:r>
             <a:endParaRPr lang="en-US" sz="1150" dirty="0"/>
           </a:p>
@@ -17909,7 +17909,7 @@
                   <a:schemeClr val="tx1"/>
                 </a:solidFill>
               </a:rPr>
-              <a:t>Tue 27 Oct – Mon 9 Nov (freelancer starts 27 Oct): €2.5k. Pass: ≥9 qualified at ≤€200. Kill: &lt;5, &gt;€270 per qualified, or too few pass the language call</a:t>
+              <a:t>Tue 27 Oct – Mon 9 Nov (freelancer starts 27 Oct): €3.2k. Pass: ≥12 qualified at ≤€200. Kill: &lt;7, &gt;€270 per qualified, or too few pass the language call</a:t>
             </a:r>
             <a:endParaRPr lang="en-US" sz="1150" dirty="0"/>
           </a:p>

</xml_diff>

<commit_message>
From-scratch review fixes: German-pace downside on slide 1, Polish commuter facts logged with source, stretched labels set to own estimate, bridge-course owner and ask
Co-Authored-By: Claude Opus 5.5 <noreply@anthropic.com>
Claude-Session: https://claude.ai/code/session_01V2NJtrYy3bzNxqKeiRXJfY
</commit_message>
<xml_diff>
--- a/operation_uptime/Operation_Uptime_Deck.pptx
+++ b/operation_uptime/Operation_Uptime_Deck.pptx
@@ -114,30 +114,30 @@
   <p:extLst>
     <p:ext uri="{521415D9-36F7-43E2-AB2F-B90AF26B5E84}">
       <p14:sectionLst xmlns:p14="http://schemas.microsoft.com/office/powerpoint/2010/main">
-        <p14:section name="Summary" id="{57c27507-5448-50c4-fc60-93dd383255f1}">
+        <p14:section name="Summary" id="{5ab33925-92a7-b0dc-36ae-fbcee60535d5}">
           <p14:sldIdLst>
             <p14:sldId id="256"/>
           </p14:sldIdLst>
         </p14:section>
-        <p14:section name="Part 1 Funnel" id="{072670da-7f55-c29d-cdbc-8459dc440dac}">
+        <p14:section name="Part 1 Funnel" id="{f9f83de2-f83b-f70e-188a-d23016dc5b0c}">
           <p14:sldIdLst>
             <p14:sldId id="257"/>
             <p14:sldId id="258"/>
           </p14:sldIdLst>
         </p14:section>
-        <p14:section name="Part 2 Channels &amp; budget" id="{f2a8b8ca-8fa3-9bbc-97d4-37cef136cfd8}">
+        <p14:section name="Part 2 Channels &amp; budget" id="{f8249b27-bc07-91bc-8f29-6a75416b6ab2}">
           <p14:sldIdLst>
             <p14:sldId id="259"/>
             <p14:sldId id="260"/>
             <p14:sldId id="261"/>
           </p14:sldIdLst>
         </p14:section>
-        <p14:section name="Part 3 New sources" id="{3d20c671-61a7-d459-f38b-dce0c89d7a68}">
+        <p14:section name="Part 3 New sources" id="{30a1c0ef-840e-68a2-fd45-e241a39598a8}">
           <p14:sldIdLst>
             <p14:sldId id="262"/>
           </p14:sldIdLst>
         </p14:section>
-        <p14:section name="Part 4 Run it" id="{8fe2f974-0f61-f137-2783-447144421495}">
+        <p14:section name="Part 4 Run it" id="{a4802716-74ad-b8ba-01f4-72d682cd9f94}">
           <p14:sldIdLst>
             <p14:sldId id="263"/>
           </p14:sldIdLst>
@@ -5224,7 +5224,7 @@
                   <a:schemeClr val="tx1"/>
                 </a:solidFill>
               </a:rPr>
-              <a:t>offers within 3 days, e-signature, stop spend Tue 24 Nov.</a:t>
+              <a:t>offers within 3 days, e-signature, stop spend Tue 24 Nov. At German process pace (8 + 12 days): ~92 hires; +9 slots a week restores 100.</a:t>
             </a:r>
             <a:endParaRPr lang="en-US" sz="1100" dirty="0"/>
           </a:p>
@@ -5405,7 +5405,7 @@
                   <a:schemeClr val="tx1"/>
                 </a:solidFill>
               </a:rPr>
-              <a:t>Construction-electrician decision by 23 Oct</a:t>
+              <a:t>Construction-electrician decision + bridge-course trainer by 23 Oct</a:t>
             </a:r>
             <a:endParaRPr lang="en-US" sz="1100" dirty="0"/>
           </a:p>
@@ -17645,7 +17645,7 @@
                   <a:schemeClr val="tx1"/>
                 </a:solidFill>
               </a:rPr>
-              <a:t>Setup 3 days (live Fri 23 Oct). Me: ads, quiz, German copywriter. Client: profile sign-off by 23 Oct, bridge course</a:t>
+              <a:t>Setup 3 days (live Fri 23 Oct). Me: ads, quiz, German copywriter. Client: profile sign-off by 23 Oct; its maintenance trainers run the 2–4 week bridge course after signing (onboarding time, not campaign budget)</a:t>
             </a:r>
             <a:endParaRPr lang="en-US" sz="1150" dirty="0"/>
           </a:p>

</xml_diff>

<commit_message>
Evaluator fixes: T2/T3 and StepStone volume as own estimates, IAB 25% quoted exactly, bridge-course row, empty-export downside on slide 7, sensitivity column label, signing-lag note; AI note as executive summary
Co-Authored-By: Claude Opus 5.5 <noreply@anthropic.com>
Claude-Session: https://claude.ai/code/session_01V2NJtrYy3bzNxqKeiRXJfY
</commit_message>
<xml_diff>
--- a/operation_uptime/Operation_Uptime_Deck.pptx
+++ b/operation_uptime/Operation_Uptime_Deck.pptx
@@ -114,30 +114,30 @@
   <p:extLst>
     <p:ext uri="{521415D9-36F7-43E2-AB2F-B90AF26B5E84}">
       <p14:sectionLst xmlns:p14="http://schemas.microsoft.com/office/powerpoint/2010/main">
-        <p14:section name="Summary" id="{5ab33925-92a7-b0dc-36ae-fbcee60535d5}">
+        <p14:section name="Summary" id="{5ef78ee5-3f89-00f9-7439-03126e264ae0}">
           <p14:sldIdLst>
             <p14:sldId id="256"/>
           </p14:sldIdLst>
         </p14:section>
-        <p14:section name="Part 1 Funnel" id="{f9f83de2-f83b-f70e-188a-d23016dc5b0c}">
+        <p14:section name="Part 1 Funnel" id="{ee58a048-36dd-305f-49c6-5dcdf423e9f6}">
           <p14:sldIdLst>
             <p14:sldId id="257"/>
             <p14:sldId id="258"/>
           </p14:sldIdLst>
         </p14:section>
-        <p14:section name="Part 2 Channels &amp; budget" id="{f8249b27-bc07-91bc-8f29-6a75416b6ab2}">
+        <p14:section name="Part 2 Channels &amp; budget" id="{68d46700-3da8-dc71-1177-ccfe1e9169e1}">
           <p14:sldIdLst>
             <p14:sldId id="259"/>
             <p14:sldId id="260"/>
             <p14:sldId id="261"/>
           </p14:sldIdLst>
         </p14:section>
-        <p14:section name="Part 3 New sources" id="{30a1c0ef-840e-68a2-fd45-e241a39598a8}">
+        <p14:section name="Part 3 New sources" id="{15777c3d-c783-94cd-7c65-e867410de0b6}">
           <p14:sldIdLst>
             <p14:sldId id="262"/>
           </p14:sldIdLst>
         </p14:section>
-        <p14:section name="Part 4 Run it" id="{a4802716-74ad-b8ba-01f4-72d682cd9f94}">
+        <p14:section name="Part 4 Run it" id="{8e2cf20a-be37-c5bb-6626-8d521561e42a}">
           <p14:sldIdLst>
             <p14:sldId id="263"/>
           </p14:sldIdLst>
@@ -17257,7 +17257,7 @@
                   <a:schemeClr val="tx1"/>
                 </a:solidFill>
               </a:rPr>
-              <a:t>Already screened and already wanted Tesla; ~€2.50 per application</a:t>
+              <a:t>Already screened and already wanted Tesla; ~€2.50 per application. If the export is empty: budget €135k</a:t>
             </a:r>
             <a:endParaRPr lang="en-US" sz="1150" dirty="0"/>
           </a:p>

</xml_diff>

<commit_message>
Final evaluator points: T2 label matches note, referral downside on slide 7, bridge-course trainer time stated; Q&A figures aligned
Co-Authored-By: Claude Opus 5.5 <noreply@anthropic.com>
Claude-Session: https://claude.ai/code/session_01V2NJtrYy3bzNxqKeiRXJfY
</commit_message>
<xml_diff>
--- a/operation_uptime/Operation_Uptime_Deck.pptx
+++ b/operation_uptime/Operation_Uptime_Deck.pptx
@@ -114,30 +114,30 @@
   <p:extLst>
     <p:ext uri="{521415D9-36F7-43E2-AB2F-B90AF26B5E84}">
       <p14:sectionLst xmlns:p14="http://schemas.microsoft.com/office/powerpoint/2010/main">
-        <p14:section name="Summary" id="{5ef78ee5-3f89-00f9-7439-03126e264ae0}">
+        <p14:section name="Summary" id="{581bceb2-2a05-6c9a-ae0d-a3eb8ee37cb6}">
           <p14:sldIdLst>
             <p14:sldId id="256"/>
           </p14:sldIdLst>
         </p14:section>
-        <p14:section name="Part 1 Funnel" id="{ee58a048-36dd-305f-49c6-5dcdf423e9f6}">
+        <p14:section name="Part 1 Funnel" id="{07c4c5de-e699-646c-7d4e-71211a21c487}">
           <p14:sldIdLst>
             <p14:sldId id="257"/>
             <p14:sldId id="258"/>
           </p14:sldIdLst>
         </p14:section>
-        <p14:section name="Part 2 Channels &amp; budget" id="{68d46700-3da8-dc71-1177-ccfe1e9169e1}">
+        <p14:section name="Part 2 Channels &amp; budget" id="{27d300ca-c76c-cf70-0eeb-e7d7f41e29f8}">
           <p14:sldIdLst>
             <p14:sldId id="259"/>
             <p14:sldId id="260"/>
             <p14:sldId id="261"/>
           </p14:sldIdLst>
         </p14:section>
-        <p14:section name="Part 3 New sources" id="{15777c3d-c783-94cd-7c65-e867410de0b6}">
+        <p14:section name="Part 3 New sources" id="{0e7b1f20-4734-bf07-d882-92b728cc8750}">
           <p14:sldIdLst>
             <p14:sldId id="262"/>
           </p14:sldIdLst>
         </p14:section>
-        <p14:section name="Part 4 Run it" id="{8e2cf20a-be37-c5bb-6626-8d521561e42a}">
+        <p14:section name="Part 4 Run it" id="{bb78509b-9802-d8e1-1ae6-31877147b0b7}">
           <p14:sldIdLst>
             <p14:sldId id="263"/>
           </p14:sldIdLst>
@@ -17257,7 +17257,7 @@
                   <a:schemeClr val="tx1"/>
                 </a:solidFill>
               </a:rPr>
-              <a:t>Already screened and already wanted Tesla; ~€2.50 per application. If the export is empty: budget €135k</a:t>
+              <a:t>Already screened and already wanted Tesla; ~€2.50 per application. If the export is empty: €135k; if referrals deliver half: €130k</a:t>
             </a:r>
             <a:endParaRPr lang="en-US" sz="1150" dirty="0"/>
           </a:p>
@@ -17645,7 +17645,7 @@
                   <a:schemeClr val="tx1"/>
                 </a:solidFill>
               </a:rPr>
-              <a:t>Setup 3 days (live Fri 23 Oct). Me: ads, quiz, German copywriter. Client: profile sign-off by 23 Oct; its maintenance trainers run the 2–4 week bridge course after signing (onboarding time, not campaign budget)</a:t>
+              <a:t>Setup 3 days (live Fri 23 Oct). Me: ads, quiz, German copywriter. Client: profile sign-off by 23 Oct; one client trainer runs the 2–4 week bridge course for the ~8 hires (≈15 person-days, client-funded onboarding)</a:t>
             </a:r>
             <a:endParaRPr lang="en-US" sz="1150" dirty="0"/>
           </a:p>

</xml_diff>

<commit_message>
Polish-cap guard (German ads exclude Poland; residence tracked), 7-day-offer downside on slide 1, week-2 check names the I2 assumption
Co-Authored-By: Claude Opus 5.5 <noreply@anthropic.com>
Claude-Session: https://claude.ai/code/session_01V2NJtrYy3bzNxqKeiRXJfY
</commit_message>
<xml_diff>
--- a/operation_uptime/Operation_Uptime_Deck.pptx
+++ b/operation_uptime/Operation_Uptime_Deck.pptx
@@ -114,30 +114,30 @@
   <p:extLst>
     <p:ext uri="{521415D9-36F7-43E2-AB2F-B90AF26B5E84}">
       <p14:sectionLst xmlns:p14="http://schemas.microsoft.com/office/powerpoint/2010/main">
-        <p14:section name="Summary" id="{581bceb2-2a05-6c9a-ae0d-a3eb8ee37cb6}">
+        <p14:section name="Summary" id="{7213c9ca-9871-4781-df10-46c5254c824f}">
           <p14:sldIdLst>
             <p14:sldId id="256"/>
           </p14:sldIdLst>
         </p14:section>
-        <p14:section name="Part 1 Funnel" id="{07c4c5de-e699-646c-7d4e-71211a21c487}">
+        <p14:section name="Part 1 Funnel" id="{4683a472-40c5-423c-765d-7a37e7788a30}">
           <p14:sldIdLst>
             <p14:sldId id="257"/>
             <p14:sldId id="258"/>
           </p14:sldIdLst>
         </p14:section>
-        <p14:section name="Part 2 Channels &amp; budget" id="{27d300ca-c76c-cf70-0eeb-e7d7f41e29f8}">
+        <p14:section name="Part 2 Channels &amp; budget" id="{cb3bb589-bbb8-3cbe-9ecb-af30ad1df453}">
           <p14:sldIdLst>
             <p14:sldId id="259"/>
             <p14:sldId id="260"/>
             <p14:sldId id="261"/>
           </p14:sldIdLst>
         </p14:section>
-        <p14:section name="Part 3 New sources" id="{0e7b1f20-4734-bf07-d882-92b728cc8750}">
+        <p14:section name="Part 3 New sources" id="{0b0dd07d-1fbd-62b8-020c-402dce2e0021}">
           <p14:sldIdLst>
             <p14:sldId id="262"/>
           </p14:sldIdLst>
         </p14:section>
-        <p14:section name="Part 4 Run it" id="{bb78509b-9802-d8e1-1ae6-31877147b0b7}">
+        <p14:section name="Part 4 Run it" id="{6622be80-6875-61e2-cf90-26dd30df70fe}">
           <p14:sldIdLst>
             <p14:sldId id="263"/>
           </p14:sldIdLst>
@@ -5224,7 +5224,7 @@
                   <a:schemeClr val="tx1"/>
                 </a:solidFill>
               </a:rPr>
-              <a:t>offers within 3 days, e-signature, stop spend Tue 24 Nov. At German process pace (8 + 12 days): ~92 hires; +9 slots a week restores 100.</a:t>
+              <a:t>offers within 3 days, e-signature, stop spend Tue 24 Nov. German process pace (8 + 12 days) or 7-day offers: ~92 hires each; +9 slots a week restores 100.</a:t>
             </a:r>
             <a:endParaRPr lang="en-US" sz="1100" dirty="0"/>
           </a:p>
@@ -17940,7 +17940,7 @@
                   <a:schemeClr val="tx1"/>
                 </a:solidFill>
               </a:rPr>
-              <a:t>Setup 1 week (live Tue 27 Oct). Me: Polish ads, hire the freelancer via rocketjobs.pl (~€19/h), call script, weekly call checks. Client: approve the ads</a:t>
+              <a:t>Setup 1 week (live Tue 27 Oct). German-market ads exclude Poland, so Polish hires come only through this route (40% cap). Me: Polish ads, hire the freelancer via rocketjobs.pl (~€19/h), call script, weekly call checks. Client: approve the ads</a:t>
             </a:r>
             <a:endParaRPr lang="en-US" sz="1150" dirty="0"/>
           </a:p>
@@ -18264,7 +18264,7 @@
                   <a:schemeClr val="tx1"/>
                 </a:solidFill>
               </a:rPr>
-              <a:t>By source × role: spend, applications, qualified. By role: assessed, passed, offers, signed (each hire keeps its ATS source tag)</a:t>
+              <a:t>By source × role: spend, applications, qualified. By role: assessed, passed, offers, signed (each hire keeps its ATS source tag and country of residence, so every Polish hire counts toward the 40% cap)</a:t>
             </a:r>
             <a:endParaRPr lang="en-US" sz="1250" dirty="0"/>
           </a:p>
@@ -18608,7 +18608,7 @@
                   <a:schemeClr val="tx1"/>
                 </a:solidFill>
               </a:rPr>
-              <a:t>Construction electricians: if stopped, programmatic fills the gap (€130k)</a:t>
+              <a:t>Construction electricians' share qualified (25%, I2Q): read 9 Nov; if far below, stop and let programmatic fill the gap (€130k)</a:t>
             </a:r>
             <a:endParaRPr lang="en-US" sz="1250" dirty="0"/>
           </a:p>

</xml_diff>

<commit_message>
Traceability: slide 4 cost basis stated, Talent CRM source in the model, I1 read date after its window
Co-Authored-By: Claude Opus 5.5 <noreply@anthropic.com>
Claude-Session: https://claude.ai/code/session_01V2NJtrYy3bzNxqKeiRXJfY
</commit_message>
<xml_diff>
--- a/operation_uptime/Operation_Uptime_Deck.pptx
+++ b/operation_uptime/Operation_Uptime_Deck.pptx
@@ -114,30 +114,30 @@
   <p:extLst>
     <p:ext uri="{521415D9-36F7-43E2-AB2F-B90AF26B5E84}">
       <p14:sectionLst xmlns:p14="http://schemas.microsoft.com/office/powerpoint/2010/main">
-        <p14:section name="Summary" id="{7213c9ca-9871-4781-df10-46c5254c824f}">
+        <p14:section name="Summary" id="{34e3d4d6-382c-2112-dee6-102c002a5318}">
           <p14:sldIdLst>
             <p14:sldId id="256"/>
           </p14:sldIdLst>
         </p14:section>
-        <p14:section name="Part 1 Funnel" id="{4683a472-40c5-423c-765d-7a37e7788a30}">
+        <p14:section name="Part 1 Funnel" id="{1b367d1c-0d9c-3661-8ed2-da8ef135f59e}">
           <p14:sldIdLst>
             <p14:sldId id="257"/>
             <p14:sldId id="258"/>
           </p14:sldIdLst>
         </p14:section>
-        <p14:section name="Part 2 Channels &amp; budget" id="{cb3bb589-bbb8-3cbe-9ecb-af30ad1df453}">
+        <p14:section name="Part 2 Channels &amp; budget" id="{12da56cf-c95b-99f4-5bea-96714e13c0a9}">
           <p14:sldIdLst>
             <p14:sldId id="259"/>
             <p14:sldId id="260"/>
             <p14:sldId id="261"/>
           </p14:sldIdLst>
         </p14:section>
-        <p14:section name="Part 3 New sources" id="{0b0dd07d-1fbd-62b8-020c-402dce2e0021}">
+        <p14:section name="Part 3 New sources" id="{22bdfa45-d8bd-040e-e47e-c8e09ce35735}">
           <p14:sldIdLst>
             <p14:sldId id="262"/>
           </p14:sldIdLst>
         </p14:section>
-        <p14:section name="Part 4 Run it" id="{6622be80-6875-61e2-cf90-26dd30df70fe}">
+        <p14:section name="Part 4 Run it" id="{e96adb5c-42ec-77f4-21a5-09c411540a5a}">
           <p14:sldIdLst>
             <p14:sldId id="263"/>
           </p14:sldIdLst>
@@ -14251,7 +14251,7 @@
                   <a:schemeClr val="tx1"/>
                 </a:solidFill>
               </a:rPr>
-              <a:t>Per channel × role: Channels tab (cost per qualified col O, per hire col P, rank col AC).</a:t>
+              <a:t>€ / qualified and € / hire here include set-up costs (Budget tab). Media-only figures per channel × role: Channels tab (col O, col P, rank col AC).</a:t>
             </a:r>
             <a:endParaRPr lang="en-US" sz="1050" dirty="0"/>
           </a:p>

</xml_diff>

<commit_message>
Slide 2 attribution matches the model; bridge course stated as client onboarding, not campaign spend
Co-Authored-By: Claude Opus 5.5 <noreply@anthropic.com>
Claude-Session: https://claude.ai/code/session_01V2NJtrYy3bzNxqKeiRXJfY
</commit_message>
<xml_diff>
--- a/operation_uptime/Operation_Uptime_Deck.pptx
+++ b/operation_uptime/Operation_Uptime_Deck.pptx
@@ -114,30 +114,30 @@
   <p:extLst>
     <p:ext uri="{521415D9-36F7-43E2-AB2F-B90AF26B5E84}">
       <p14:sectionLst xmlns:p14="http://schemas.microsoft.com/office/powerpoint/2010/main">
-        <p14:section name="Summary" id="{34e3d4d6-382c-2112-dee6-102c002a5318}">
+        <p14:section name="Summary" id="{a23f6a43-57cf-822e-c38c-d48c8ae6dab7}">
           <p14:sldIdLst>
             <p14:sldId id="256"/>
           </p14:sldIdLst>
         </p14:section>
-        <p14:section name="Part 1 Funnel" id="{1b367d1c-0d9c-3661-8ed2-da8ef135f59e}">
+        <p14:section name="Part 1 Funnel" id="{96ef476e-4c8b-51b0-b3de-288c4d09b9db}">
           <p14:sldIdLst>
             <p14:sldId id="257"/>
             <p14:sldId id="258"/>
           </p14:sldIdLst>
         </p14:section>
-        <p14:section name="Part 2 Channels &amp; budget" id="{12da56cf-c95b-99f4-5bea-96714e13c0a9}">
+        <p14:section name="Part 2 Channels &amp; budget" id="{66fe7696-34af-7012-e726-ebd84919e1be}">
           <p14:sldIdLst>
             <p14:sldId id="259"/>
             <p14:sldId id="260"/>
             <p14:sldId id="261"/>
           </p14:sldIdLst>
         </p14:section>
-        <p14:section name="Part 3 New sources" id="{22bdfa45-d8bd-040e-e47e-c8e09ce35735}">
+        <p14:section name="Part 3 New sources" id="{667b969a-06c9-95d9-5af1-29de5695fed1}">
           <p14:sldIdLst>
             <p14:sldId id="262"/>
           </p14:sldIdLst>
         </p14:section>
-        <p14:section name="Part 4 Run it" id="{e96adb5c-42ec-77f4-21a5-09c411540a5a}">
+        <p14:section name="Part 4 Run it" id="{37a467f0-651c-c18a-5c80-1d64e00aaa89}">
           <p14:sldIdLst>
             <p14:sldId id="263"/>
           </p14:sldIdLst>
@@ -8666,7 +8666,7 @@
                   <a:schemeClr val="tx2"/>
                 </a:solidFill>
               </a:rPr>
-              <a:t>Why 308, not 311: referrals and past applicants convert better than the table's standard rates, so the plan needs slightly fewer. Applications: 1,495, not 1,260, because the plan's channels average 21% qualified (social ads lower), below the ~25% baseline.</a:t>
+              <a:t>Why 308, not 311: referrals and past applicants convert better than the table's standard rates, so the plan needs slightly fewer. Applications: 1,495, not 1,260, because the plan's channels average 21% qualified (Polish pre-screened applications 14%, organic 17.5%), below the ~25% baseline.</a:t>
             </a:r>
             <a:endParaRPr lang="en-US" sz="1200" dirty="0"/>
           </a:p>
@@ -17645,7 +17645,7 @@
                   <a:schemeClr val="tx1"/>
                 </a:solidFill>
               </a:rPr>
-              <a:t>Setup 3 days (live Fri 23 Oct). Me: ads, quiz, German copywriter. Client: profile sign-off by 23 Oct; one client trainer runs the 2–4 week bridge course for the ~8 hires (≈15 person-days, client-funded onboarding)</a:t>
+              <a:t>Setup 3 days (live Fri 23 Oct). Me: ads, quiz, German copywriter. Client: profile sign-off by 23 Oct; one client trainer runs the 2–4 week bridge course for the ~8 hires (≈15 person-days of the client's normal onboarding, not campaign spend)</a:t>
             </a:r>
             <a:endParaRPr lang="en-US" sz="1150" dirty="0"/>
           </a:p>

</xml_diff>

<commit_message>
Optional wording from final review: offer timing on slide 1, channel caps on slide 4
Co-Authored-By: Claude Opus 5.5 <noreply@anthropic.com>
Claude-Session: https://claude.ai/code/session_01V2NJtrYy3bzNxqKeiRXJfY
</commit_message>
<xml_diff>
--- a/operation_uptime/Operation_Uptime_Deck.pptx
+++ b/operation_uptime/Operation_Uptime_Deck.pptx
@@ -114,30 +114,30 @@
   <p:extLst>
     <p:ext uri="{521415D9-36F7-43E2-AB2F-B90AF26B5E84}">
       <p14:sectionLst xmlns:p14="http://schemas.microsoft.com/office/powerpoint/2010/main">
-        <p14:section name="Summary" id="{a23f6a43-57cf-822e-c38c-d48c8ae6dab7}">
+        <p14:section name="Summary" id="{fa400ee0-8c64-3790-c865-4662f7f91df1}">
           <p14:sldIdLst>
             <p14:sldId id="256"/>
           </p14:sldIdLst>
         </p14:section>
-        <p14:section name="Part 1 Funnel" id="{96ef476e-4c8b-51b0-b3de-288c4d09b9db}">
+        <p14:section name="Part 1 Funnel" id="{94c3a27b-147f-c402-3389-29edf581d02a}">
           <p14:sldIdLst>
             <p14:sldId id="257"/>
             <p14:sldId id="258"/>
           </p14:sldIdLst>
         </p14:section>
-        <p14:section name="Part 2 Channels &amp; budget" id="{66fe7696-34af-7012-e726-ebd84919e1be}">
+        <p14:section name="Part 2 Channels &amp; budget" id="{277ef7cd-9563-df91-eee2-22087a23e4a9}">
           <p14:sldIdLst>
             <p14:sldId id="259"/>
             <p14:sldId id="260"/>
             <p14:sldId id="261"/>
           </p14:sldIdLst>
         </p14:section>
-        <p14:section name="Part 3 New sources" id="{667b969a-06c9-95d9-5af1-29de5695fed1}">
+        <p14:section name="Part 3 New sources" id="{6f8bb144-eeb8-075d-1835-b8c83377bc31}">
           <p14:sldIdLst>
             <p14:sldId id="262"/>
           </p14:sldIdLst>
         </p14:section>
-        <p14:section name="Part 4 Run it" id="{37a467f0-651c-c18a-5c80-1d64e00aaa89}">
+        <p14:section name="Part 4 Run it" id="{037a210e-42d1-d9b4-2d87-d8a1b3d87860}">
           <p14:sldIdLst>
             <p14:sldId id="263"/>
           </p14:sldIdLst>
@@ -5224,7 +5224,7 @@
                   <a:schemeClr val="tx1"/>
                 </a:solidFill>
               </a:rPr>
-              <a:t>offers within 3 days, e-signature, stop spend Tue 24 Nov. German process pace (8 + 12 days) or 7-day offers: ~92 hires each; +9 slots a week restores 100.</a:t>
+              <a:t>offers within 3 days, e-signature, stop spend Tue 24 Nov. German process pace (8 + 12 days) or offers 7 days after interview (not 3): ~92 hires each; +9 slots a week restores 100.</a:t>
             </a:r>
             <a:endParaRPr lang="en-US" sz="1100" dirty="0"/>
           </a:p>
@@ -14197,7 +14197,7 @@
                   <a:schemeClr val="tx1"/>
                 </a:solidFill>
               </a:rPr>
-              <a:t>Each channel is capped by how many people in the local talent pool it can reach.</a:t>
+              <a:t>Paid channels are capped by how many people in the local talent pool they reach (StepStone by its number of ads; new sources by their own volumes).</a:t>
             </a:r>
             <a:endParaRPr lang="en-US" sz="1050" dirty="0"/>
           </a:p>

</xml_diff>